<commit_message>
Align A1 poster statistics with the t-test/ANOVA thesis
Remove Holm-adjusted p values from the poster tables and text, rebuild
the ANOVA and paired-comparison tables from TTEST_ANOVA_60Q.json, and
re-export the PPTX, SVG and print PDF with matching poster checks and
manifest hashes.

Co-Authored-By: Claude Opus 5.5 <noreply@anthropic.com>
</commit_message>
<xml_diff>
--- a/FINALDOCS/POSTER/FINAL/M_RAG_A1_FINAL_EDITABLE.pptx
+++ b/FINALDOCS/POSTER/FINAL/M_RAG_A1_FINAL_EDITABLE.pptx
@@ -2,13 +2,13 @@
 <file path=ppt/presentation.xml><?xml version="1.0" encoding="utf-8"?>
 <p:presentation xmlns:p="http://schemas.openxmlformats.org/presentationml/2006/main">
   <p:sldMasterIdLst>
-    <p:sldMasterId xmlns:r="http://schemas.openxmlformats.org/officeDocument/2006/relationships" id="2147483648" r:id="Rf6cc408cd4424066"/>
+    <p:sldMasterId xmlns:r="http://schemas.openxmlformats.org/officeDocument/2006/relationships" id="2147483648" r:id="R5417218fc1ae4ba1"/>
   </p:sldMasterIdLst>
   <p:notesMasterIdLst>
-    <p:notesMasterId xmlns:r="http://schemas.openxmlformats.org/officeDocument/2006/relationships" r:id="Rbc1939e328104470"/>
+    <p:notesMasterId xmlns:r="http://schemas.openxmlformats.org/officeDocument/2006/relationships" r:id="R49f02fc842f04598"/>
   </p:notesMasterIdLst>
   <p:sldIdLst>
-    <p:sldId xmlns:r="http://schemas.openxmlformats.org/officeDocument/2006/relationships" id="256" r:id="R7c84f456f7774943"/>
+    <p:sldId xmlns:r="http://schemas.openxmlformats.org/officeDocument/2006/relationships" id="256" r:id="Reae5f24be768419a"/>
   </p:sldIdLst>
   <p:sldSz cx="21384000" cy="30276000"/>
   <p:notesSz cx="6858000" cy="9144000"/>
@@ -442,7 +442,7 @@
           <a:lstStyle xmlns:a="http://schemas.openxmlformats.org/drawingml/2006/main"/>
           <a:p xmlns:a="http://schemas.openxmlformats.org/drawingml/2006/main">
             <a:r>
-              <a:t>Research sources and full statistics: FINALDOCS/DATA/FACTORIAL_STATISTICS_60Q.json; FINALDOCS/MANUSCRIPT/GRADUATION_REPORT_TRANSFER_KO_60Q.md. The exploratory analysis uses query-level repeated measures and Holm-adjusted hypothesis families. Editable tables follow explicit data-type alignment. Reference [4] https://ojs.aaai.org/index.php/AAAI/article/view/40417; [8] https://doi.org/10.1145/3331184.3331317 is conceptual ranking background, not the implemented CEDR architecture. [M1] https://huggingface.co/K-intelligence/Midm-2.0-Base-Instruct; [M2] https://huggingface.co/cross-encoder/ms-marco-MiniLM-L6-v2. The English case evidence is a contiguous saved context excerpt (PDF p.9), reference evidence is on PDF p.20. References follow manuscript numbering.</a:t>
+              <a:t>Research sources and full statistics: FINALDOCS/DATA/TTEST_ANOVA_60Q.json; FINALDOCS/MANUSCRIPT/GRADUATION_REPORT_TRANSFER_KO_60Q.md. The exploratory analysis uses query-level paired t-tests and repeated-measures ANOVA with two-sided alpha 0.05 and no multiplicity adjustment. Editable tables follow explicit data-type alignment. Reference [4] https://ojs.aaai.org/index.php/AAAI/article/view/40417; [8] https://doi.org/10.1145/3331184.3331317 is conceptual ranking background, not the implemented CEDR architecture. [M1] https://huggingface.co/K-intelligence/Midm-2.0-Base-Instruct; [M2] https://huggingface.co/cross-encoder/ms-marco-MiniLM-L6-v2. The English case evidence is a contiguous saved context excerpt (PDF p.9), reference evidence is on PDF p.20. References follow manuscript numbering.</a:t>
             </a:r>
           </a:p>
         </p:txBody>
@@ -489,7 +489,7 @@
           <p:cNvPr id="3" name="Title">
             <a:extLst xmlns:a="http://schemas.openxmlformats.org/drawingml/2006/main">
               <a:ext uri="{FF2B5EF4-FFF2-40B4-BE49-F238E27FC236}">
-                <a16:creationId xmlns:a16="http://schemas.microsoft.com/office/drawing/2014/main" id="{18C2D189-7F74-4993-8549-C9919680D29E}"/>
+                <a16:creationId xmlns:a16="http://schemas.microsoft.com/office/drawing/2014/main" id="{707AB210-BD38-4486-97DB-EA36056D05B3}"/>
               </a:ext>
             </a:extLst>
           </p:cNvPr>
@@ -718,7 +718,7 @@
           <p:cNvPr id="2" name="Subtitle">
             <a:extLst xmlns:a="http://schemas.openxmlformats.org/drawingml/2006/main">
               <a:ext uri="{FF2B5EF4-FFF2-40B4-BE49-F238E27FC236}">
-                <a16:creationId xmlns:a16="http://schemas.microsoft.com/office/drawing/2014/main" id="{95258C7D-128B-4FB5-9036-1B1FA2C5D61A}"/>
+                <a16:creationId xmlns:a16="http://schemas.microsoft.com/office/drawing/2014/main" id="{812D2440-1B0F-4561-8FF5-5C56FF7FABBE}"/>
               </a:ext>
             </a:extLst>
           </p:cNvPr>
@@ -964,7 +964,7 @@
           <p:cNvPr id="2" name="Section title">
             <a:extLst xmlns:a="http://schemas.openxmlformats.org/drawingml/2006/main">
               <a:ext uri="{FF2B5EF4-FFF2-40B4-BE49-F238E27FC236}">
-                <a16:creationId xmlns:a16="http://schemas.microsoft.com/office/drawing/2014/main" id="{3664E239-E601-43E3-A7E1-4889C93DD8C0}"/>
+                <a16:creationId xmlns:a16="http://schemas.microsoft.com/office/drawing/2014/main" id="{8CB89280-5C8C-45A9-8BD8-A6F9CC1EE3DC}"/>
               </a:ext>
             </a:extLst>
           </p:cNvPr>
@@ -1210,7 +1210,7 @@
           <p:cNvPr id="3" name="Title">
             <a:extLst xmlns:a="http://schemas.openxmlformats.org/drawingml/2006/main">
               <a:ext uri="{FF2B5EF4-FFF2-40B4-BE49-F238E27FC236}">
-                <a16:creationId xmlns:a16="http://schemas.microsoft.com/office/drawing/2014/main" id="{2D40143D-9B87-4255-9D7A-9C933C582688}"/>
+                <a16:creationId xmlns:a16="http://schemas.microsoft.com/office/drawing/2014/main" id="{088BABFC-DA41-4346-8F53-202C7A4AA4F6}"/>
               </a:ext>
             </a:extLst>
           </p:cNvPr>
@@ -1439,7 +1439,7 @@
           <p:cNvPr id="2" name="Body">
             <a:extLst xmlns:a="http://schemas.openxmlformats.org/drawingml/2006/main">
               <a:ext uri="{FF2B5EF4-FFF2-40B4-BE49-F238E27FC236}">
-                <a16:creationId xmlns:a16="http://schemas.microsoft.com/office/drawing/2014/main" id="{BF3B3B9A-7488-49EE-AE4A-2B44892DA9B8}"/>
+                <a16:creationId xmlns:a16="http://schemas.microsoft.com/office/drawing/2014/main" id="{02A25B0B-B3B5-4736-8FA4-621DB9F0DC31}"/>
               </a:ext>
             </a:extLst>
           </p:cNvPr>
@@ -1685,7 +1685,7 @@
           <p:cNvPr id="4" name="Title">
             <a:extLst xmlns:a="http://schemas.openxmlformats.org/drawingml/2006/main">
               <a:ext uri="{FF2B5EF4-FFF2-40B4-BE49-F238E27FC236}">
-                <a16:creationId xmlns:a16="http://schemas.microsoft.com/office/drawing/2014/main" id="{64E8CCEA-31BC-4362-8B39-988B09536E5B}"/>
+                <a16:creationId xmlns:a16="http://schemas.microsoft.com/office/drawing/2014/main" id="{9B8AB8E3-6DB0-4918-BF61-4EE2258585C8}"/>
               </a:ext>
             </a:extLst>
           </p:cNvPr>
@@ -1914,7 +1914,7 @@
           <p:cNvPr id="2" name="Left column">
             <a:extLst xmlns:a="http://schemas.openxmlformats.org/drawingml/2006/main">
               <a:ext uri="{FF2B5EF4-FFF2-40B4-BE49-F238E27FC236}">
-                <a16:creationId xmlns:a16="http://schemas.microsoft.com/office/drawing/2014/main" id="{06CE0F29-D3E0-4093-AAE3-33BF360204DC}"/>
+                <a16:creationId xmlns:a16="http://schemas.microsoft.com/office/drawing/2014/main" id="{D7344E96-722C-48AA-A9B8-94E74EF9848E}"/>
               </a:ext>
             </a:extLst>
           </p:cNvPr>
@@ -2143,7 +2143,7 @@
           <p:cNvPr id="3" name="Right column">
             <a:extLst xmlns:a="http://schemas.openxmlformats.org/drawingml/2006/main">
               <a:ext uri="{FF2B5EF4-FFF2-40B4-BE49-F238E27FC236}">
-                <a16:creationId xmlns:a16="http://schemas.microsoft.com/office/drawing/2014/main" id="{D1BC5D0E-465F-4CE6-B2F6-C66255A1358F}"/>
+                <a16:creationId xmlns:a16="http://schemas.microsoft.com/office/drawing/2014/main" id="{47A5DC7E-84C6-494C-A226-4FE6972448AE}"/>
               </a:ext>
             </a:extLst>
           </p:cNvPr>
@@ -2389,7 +2389,7 @@
           <p:cNvPr id="3" name="Title">
             <a:extLst xmlns:a="http://schemas.openxmlformats.org/drawingml/2006/main">
               <a:ext uri="{FF2B5EF4-FFF2-40B4-BE49-F238E27FC236}">
-                <a16:creationId xmlns:a16="http://schemas.microsoft.com/office/drawing/2014/main" id="{2972B973-4DFE-416E-A383-E21E24C4F17B}"/>
+                <a16:creationId xmlns:a16="http://schemas.microsoft.com/office/drawing/2014/main" id="{541C9FAC-A4C6-470B-8229-354C7B702F2D}"/>
               </a:ext>
             </a:extLst>
           </p:cNvPr>
@@ -2618,7 +2618,7 @@
           <p:cNvPr id="2" name="Left column">
             <a:extLst xmlns:a="http://schemas.openxmlformats.org/drawingml/2006/main">
               <a:ext uri="{FF2B5EF4-FFF2-40B4-BE49-F238E27FC236}">
-                <a16:creationId xmlns:a16="http://schemas.microsoft.com/office/drawing/2014/main" id="{29FA1E36-CF00-45A7-9EE2-17BE27F488F5}"/>
+                <a16:creationId xmlns:a16="http://schemas.microsoft.com/office/drawing/2014/main" id="{BC7E0CD2-48B2-4422-BEB5-3277059A74F7}"/>
               </a:ext>
             </a:extLst>
           </p:cNvPr>
@@ -2885,12 +2885,12 @@
   </p:cSld>
   <p:clrMap bg1="lt1" tx1="dk1" bg2="lt2" tx2="dk2" accent1="accent1" accent2="accent2" accent3="accent3" accent4="accent4" accent5="accent5" accent6="accent6" hlink="hlink" folHlink="folHlink"/>
   <p:sldLayoutIdLst>
-    <p:sldLayoutId xmlns:r="http://schemas.openxmlformats.org/officeDocument/2006/relationships" id="2147483649" r:id="R95710aeefba64c27"/>
-    <p:sldLayoutId xmlns:r="http://schemas.openxmlformats.org/officeDocument/2006/relationships" id="2147483650" r:id="Rf712e709639e4f80"/>
-    <p:sldLayoutId xmlns:r="http://schemas.openxmlformats.org/officeDocument/2006/relationships" id="2147483651" r:id="R29734f7a68a84798"/>
-    <p:sldLayoutId xmlns:r="http://schemas.openxmlformats.org/officeDocument/2006/relationships" id="2147483652" r:id="R9d52fba0e0bf461a"/>
-    <p:sldLayoutId xmlns:r="http://schemas.openxmlformats.org/officeDocument/2006/relationships" id="2147483653" r:id="Ra2ed83a587e6470f"/>
-    <p:sldLayoutId xmlns:r="http://schemas.openxmlformats.org/officeDocument/2006/relationships" id="2147483654" r:id="Rd555bde63c2d4c94"/>
+    <p:sldLayoutId xmlns:r="http://schemas.openxmlformats.org/officeDocument/2006/relationships" id="2147483649" r:id="Rb40d50c614da453e"/>
+    <p:sldLayoutId xmlns:r="http://schemas.openxmlformats.org/officeDocument/2006/relationships" id="2147483650" r:id="R2b5172b4502b42a9"/>
+    <p:sldLayoutId xmlns:r="http://schemas.openxmlformats.org/officeDocument/2006/relationships" id="2147483651" r:id="R676a8a6a8303435f"/>
+    <p:sldLayoutId xmlns:r="http://schemas.openxmlformats.org/officeDocument/2006/relationships" id="2147483652" r:id="Rd814fbdf71cc4864"/>
+    <p:sldLayoutId xmlns:r="http://schemas.openxmlformats.org/officeDocument/2006/relationships" id="2147483653" r:id="R2854fdb348ce412c"/>
+    <p:sldLayoutId xmlns:r="http://schemas.openxmlformats.org/officeDocument/2006/relationships" id="2147483654" r:id="R88345d678e79417a"/>
   </p:sldLayoutIdLst>
   <p:txStyles>
     <p:titleStyle>
@@ -3441,7 +3441,7 @@
           <p:cNvPr id="76" name="">
             <a:extLst xmlns:a="http://schemas.openxmlformats.org/drawingml/2006/main">
               <a:ext uri="{FF2B5EF4-FFF2-40B4-BE49-F238E27FC236}">
-                <a16:creationId xmlns:a16="http://schemas.microsoft.com/office/drawing/2014/main" id="{307F14FD-D820-4A32-B6F8-DA81B5E23C26}"/>
+                <a16:creationId xmlns:a16="http://schemas.microsoft.com/office/drawing/2014/main" id="{B124FBB7-B6C3-4104-A94E-7B3E70932BD9}"/>
               </a:ext>
             </a:extLst>
           </p:cNvPr>
@@ -3472,7 +3472,7 @@
           <p:cNvPr id="2" name="한국어 질의로 영어 학술·기술 문서를 검색하는">
             <a:extLst xmlns:a="http://schemas.openxmlformats.org/drawingml/2006/main">
               <a:ext uri="{FF2B5EF4-FFF2-40B4-BE49-F238E27FC236}">
-                <a16:creationId xmlns:a16="http://schemas.microsoft.com/office/drawing/2014/main" id="{20D8F3DB-04B5-49AD-92E5-BB7609AF52EF}"/>
+                <a16:creationId xmlns:a16="http://schemas.microsoft.com/office/drawing/2014/main" id="{C4A155D7-595D-4D8B-8658-CBCEFA4C0B57}"/>
               </a:ext>
             </a:extLst>
           </p:cNvPr>
@@ -3602,7 +3602,6 @@
           </a:lstStyle>
           <a:p xmlns:a="http://schemas.openxmlformats.org/drawingml/2006/main">
             <a:pPr algn="ctr">
-              <a:buNone/>
               <a:defRPr sz="5200" b="0">
                 <a:solidFill>
                   <a:srgbClr val="FFFFFF"/>
@@ -3631,7 +3630,7 @@
           <p:cNvPr id="3" name="RAG에서의 HyDE·CAD·SCD 조합 실험">
             <a:extLst xmlns:a="http://schemas.openxmlformats.org/drawingml/2006/main">
               <a:ext uri="{FF2B5EF4-FFF2-40B4-BE49-F238E27FC236}">
-                <a16:creationId xmlns:a16="http://schemas.microsoft.com/office/drawing/2014/main" id="{7083EE00-123C-4EA6-959F-B4FBDE8FAF6F}"/>
+                <a16:creationId xmlns:a16="http://schemas.microsoft.com/office/drawing/2014/main" id="{61FCBC9A-DB55-46F5-B594-3413370C521E}"/>
               </a:ext>
             </a:extLst>
           </p:cNvPr>
@@ -3761,7 +3760,6 @@
           </a:lstStyle>
           <a:p xmlns:a="http://schemas.openxmlformats.org/drawingml/2006/main">
             <a:pPr algn="ctr">
-              <a:buNone/>
               <a:defRPr sz="5200" b="0">
                 <a:solidFill>
                   <a:srgbClr val="FFFFFF"/>
@@ -3790,7 +3788,7 @@
           <p:cNvPr id="4" name="문종건 · 동국대학교 WISE캠퍼스 컴퓨터공학과 · 지도교수 김진석 · 2026.10.15">
             <a:extLst xmlns:a="http://schemas.openxmlformats.org/drawingml/2006/main">
               <a:ext uri="{FF2B5EF4-FFF2-40B4-BE49-F238E27FC236}">
-                <a16:creationId xmlns:a16="http://schemas.microsoft.com/office/drawing/2014/main" id="{DB4F0942-9BA0-4154-8754-85691FA8E5E3}"/>
+                <a16:creationId xmlns:a16="http://schemas.microsoft.com/office/drawing/2014/main" id="{C8071267-0157-4238-AFF5-9A1C36ED35AA}"/>
               </a:ext>
             </a:extLst>
           </p:cNvPr>
@@ -3920,7 +3918,6 @@
           </a:lstStyle>
           <a:p xmlns:a="http://schemas.openxmlformats.org/drawingml/2006/main">
             <a:pPr algn="ctr">
-              <a:buNone/>
               <a:defRPr sz="2000" b="0">
                 <a:solidFill>
                   <a:srgbClr val="FFFFFF"/>
@@ -3949,7 +3946,7 @@
           <p:cNvPr id="5" name="">
             <a:extLst xmlns:a="http://schemas.openxmlformats.org/drawingml/2006/main">
               <a:ext uri="{FF2B5EF4-FFF2-40B4-BE49-F238E27FC236}">
-                <a16:creationId xmlns:a16="http://schemas.microsoft.com/office/drawing/2014/main" id="{5FBEE7C2-81E1-458E-BA69-A6A743423CDC}"/>
+                <a16:creationId xmlns:a16="http://schemas.microsoft.com/office/drawing/2014/main" id="{082CA7EC-C4E0-43F4-BD91-C095BB74736F}"/>
               </a:ext>
             </a:extLst>
           </p:cNvPr>
@@ -3980,7 +3977,7 @@
           <p:cNvPr id="6" name="01 연구 배경과 목적">
             <a:extLst xmlns:a="http://schemas.openxmlformats.org/drawingml/2006/main">
               <a:ext uri="{FF2B5EF4-FFF2-40B4-BE49-F238E27FC236}">
-                <a16:creationId xmlns:a16="http://schemas.microsoft.com/office/drawing/2014/main" id="{45E9146F-86D4-47FE-A6C7-F8E25AA605F7}"/>
+                <a16:creationId xmlns:a16="http://schemas.microsoft.com/office/drawing/2014/main" id="{8D949CEF-55A8-4FDD-8B6B-28C4630F12D3}"/>
               </a:ext>
             </a:extLst>
           </p:cNvPr>
@@ -4110,7 +4107,6 @@
           </a:lstStyle>
           <a:p xmlns:a="http://schemas.openxmlformats.org/drawingml/2006/main">
             <a:pPr algn="l">
-              <a:buNone/>
               <a:defRPr sz="2400" b="0">
                 <a:solidFill>
                   <a:srgbClr val="FFFFFF"/>
@@ -4139,7 +4135,7 @@
           <p:cNvPr id="7" name="검색 증강 생성(Retrieval-Augmented Generation, RAG)은 관련 문서 구간을 검색하고 그 텍">
             <a:extLst xmlns:a="http://schemas.openxmlformats.org/drawingml/2006/main">
               <a:ext uri="{FF2B5EF4-FFF2-40B4-BE49-F238E27FC236}">
-                <a16:creationId xmlns:a16="http://schemas.microsoft.com/office/drawing/2014/main" id="{07AF80D9-A184-4AFC-92E9-410FC0349FD2}"/>
+                <a16:creationId xmlns:a16="http://schemas.microsoft.com/office/drawing/2014/main" id="{F944E483-B7D7-4898-B573-13EF8871D6BD}"/>
               </a:ext>
             </a:extLst>
           </p:cNvPr>
@@ -4269,7 +4265,6 @@
           </a:lstStyle>
           <a:p xmlns:a="http://schemas.openxmlformats.org/drawingml/2006/main">
             <a:pPr algn="l">
-              <a:buNone/>
               <a:defRPr sz="1800" b="0">
                 <a:solidFill>
                   <a:srgbClr val="24324A"/>
@@ -4293,7 +4288,6 @@
           </a:p>
           <a:p xmlns:a="http://schemas.openxmlformats.org/drawingml/2006/main">
             <a:pPr algn="l">
-              <a:buNone/>
               <a:defRPr sz="1800" b="0">
                 <a:solidFill>
                   <a:srgbClr val="24324A"/>
@@ -4322,7 +4316,7 @@
           <p:cNvPr id="8" name="HyDE: 가상 문서 임베딩(Hypothetical Document Embeddings) 가상 문서 검색 입력 구성[">
             <a:extLst xmlns:a="http://schemas.openxmlformats.org/drawingml/2006/main">
               <a:ext uri="{FF2B5EF4-FFF2-40B4-BE49-F238E27FC236}">
-                <a16:creationId xmlns:a16="http://schemas.microsoft.com/office/drawing/2014/main" id="{BA0DDB7B-38EF-4C53-8B35-4597DAA72049}"/>
+                <a16:creationId xmlns:a16="http://schemas.microsoft.com/office/drawing/2014/main" id="{CC390CE8-B618-40EF-92AE-9EB9F1A862AF}"/>
               </a:ext>
             </a:extLst>
           </p:cNvPr>
@@ -4452,7 +4446,6 @@
           </a:lstStyle>
           <a:p xmlns:a="http://schemas.openxmlformats.org/drawingml/2006/main">
             <a:pPr algn="l">
-              <a:buNone/>
               <a:defRPr sz="1800" b="0">
                 <a:solidFill>
                   <a:srgbClr val="24324A"/>
@@ -4476,7 +4469,6 @@
           </a:p>
           <a:p xmlns:a="http://schemas.openxmlformats.org/drawingml/2006/main">
             <a:pPr algn="l">
-              <a:buNone/>
               <a:defRPr sz="1800" b="0">
                 <a:solidFill>
                   <a:srgbClr val="24324A"/>
@@ -4500,7 +4492,6 @@
           </a:p>
           <a:p xmlns:a="http://schemas.openxmlformats.org/drawingml/2006/main">
             <a:pPr algn="l">
-              <a:buNone/>
               <a:defRPr sz="1800" b="0">
                 <a:solidFill>
                   <a:srgbClr val="24324A"/>
@@ -4524,7 +4515,6 @@
           </a:p>
           <a:p xmlns:a="http://schemas.openxmlformats.org/drawingml/2006/main">
             <a:pPr algn="l">
-              <a:buNone/>
               <a:defRPr sz="1800" b="0">
                 <a:solidFill>
                   <a:srgbClr val="24324A"/>
@@ -4548,7 +4538,6 @@
           </a:p>
           <a:p xmlns:a="http://schemas.openxmlformats.org/drawingml/2006/main">
             <a:pPr algn="l">
-              <a:buNone/>
               <a:defRPr sz="1800" b="0">
                 <a:solidFill>
                   <a:srgbClr val="24324A"/>
@@ -4572,7 +4561,6 @@
           </a:p>
           <a:p xmlns:a="http://schemas.openxmlformats.org/drawingml/2006/main">
             <a:pPr algn="l">
-              <a:buNone/>
               <a:defRPr sz="1800" b="0">
                 <a:solidFill>
                   <a:srgbClr val="24324A"/>
@@ -4598,10 +4586,10 @@
       </p:sp>
       <p:sp>
         <p:nvSpPr>
-          <p:cNvPr id="9" name="HyDE는 한국어 등 다국어 검색에서 평가되었다[2]. 본 연구는 한국어 질의–영어 근거의 표현·출력 언어 문제를 동">
+          <p:cNvPr id="9" name="HyDE는 한국어 등 다국어 검색에서 평가되었다[2]. 한국어 질의–영어 문서 환경에서 HyDE·CAD·SCD의 개별">
             <a:extLst xmlns:a="http://schemas.openxmlformats.org/drawingml/2006/main">
               <a:ext uri="{FF2B5EF4-FFF2-40B4-BE49-F238E27FC236}">
-                <a16:creationId xmlns:a16="http://schemas.microsoft.com/office/drawing/2014/main" id="{368ECF16-7A80-4F5D-8924-03128D4B6E30}"/>
+                <a16:creationId xmlns:a16="http://schemas.microsoft.com/office/drawing/2014/main" id="{7441512C-2F2D-4293-8A03-34A66CCD8C12}"/>
               </a:ext>
             </a:extLst>
           </p:cNvPr>
@@ -4731,7 +4719,6 @@
           </a:lstStyle>
           <a:p xmlns:a="http://schemas.openxmlformats.org/drawingml/2006/main">
             <a:pPr algn="l">
-              <a:buNone/>
               <a:defRPr sz="1800" b="1">
                 <a:solidFill>
                   <a:srgbClr val="24324A"/>
@@ -4755,7 +4742,6 @@
           </a:p>
           <a:p xmlns:a="http://schemas.openxmlformats.org/drawingml/2006/main">
             <a:pPr algn="l">
-              <a:buNone/>
               <a:defRPr sz="1800" b="1">
                 <a:solidFill>
                   <a:srgbClr val="24324A"/>
@@ -4779,7 +4765,6 @@
           </a:p>
           <a:p xmlns:a="http://schemas.openxmlformats.org/drawingml/2006/main">
             <a:pPr algn="l">
-              <a:buNone/>
               <a:defRPr sz="1800" b="1">
                 <a:solidFill>
                   <a:srgbClr val="24324A"/>
@@ -4808,7 +4793,7 @@
           <p:cNvPr id="10" name="">
             <a:extLst xmlns:a="http://schemas.openxmlformats.org/drawingml/2006/main">
               <a:ext uri="{FF2B5EF4-FFF2-40B4-BE49-F238E27FC236}">
-                <a16:creationId xmlns:a16="http://schemas.microsoft.com/office/drawing/2014/main" id="{C0816FCC-E820-408B-B85F-75E0A8E0F39F}"/>
+                <a16:creationId xmlns:a16="http://schemas.microsoft.com/office/drawing/2014/main" id="{AB18E6E9-6112-4C1C-BCA0-E7489CDAC183}"/>
               </a:ext>
             </a:extLst>
           </p:cNvPr>
@@ -4839,7 +4824,7 @@
           <p:cNvPr id="11" name="02 Paper-RAG 구조와 기법 적용 위치">
             <a:extLst xmlns:a="http://schemas.openxmlformats.org/drawingml/2006/main">
               <a:ext uri="{FF2B5EF4-FFF2-40B4-BE49-F238E27FC236}">
-                <a16:creationId xmlns:a16="http://schemas.microsoft.com/office/drawing/2014/main" id="{ABA491DE-CB5C-4A36-8F7E-0D6058C65509}"/>
+                <a16:creationId xmlns:a16="http://schemas.microsoft.com/office/drawing/2014/main" id="{438DC46B-263F-4FD4-9624-5D3338F4A549}"/>
               </a:ext>
             </a:extLst>
           </p:cNvPr>
@@ -4969,7 +4954,6 @@
           </a:lstStyle>
           <a:p xmlns:a="http://schemas.openxmlformats.org/drawingml/2006/main">
             <a:pPr algn="l">
-              <a:buNone/>
               <a:defRPr sz="2400" b="0">
                 <a:solidFill>
                   <a:srgbClr val="FFFFFF"/>
@@ -4995,10 +4979,10 @@
       </p:sp>
       <p:sp>
         <p:nvSpPr>
-          <p:cNvPr id="12" name="Paper-RAG는 본 연구의 고정 검색·생성 파이프라인이다.">
+          <p:cNvPr id="12" name="Paper-RAG는 실험에 사용한 고정 검색·생성 파이프라인이다.">
             <a:extLst xmlns:a="http://schemas.openxmlformats.org/drawingml/2006/main">
               <a:ext uri="{FF2B5EF4-FFF2-40B4-BE49-F238E27FC236}">
-                <a16:creationId xmlns:a16="http://schemas.microsoft.com/office/drawing/2014/main" id="{171987F4-43DE-4CA8-95DC-56A870D7326B}"/>
+                <a16:creationId xmlns:a16="http://schemas.microsoft.com/office/drawing/2014/main" id="{2F6CF8C0-9341-455F-A856-DB9A1C1CEE00}"/>
               </a:ext>
             </a:extLst>
           </p:cNvPr>
@@ -5128,7 +5112,6 @@
           </a:lstStyle>
           <a:p xmlns:a="http://schemas.openxmlformats.org/drawingml/2006/main">
             <a:pPr algn="l">
-              <a:buNone/>
               <a:defRPr sz="1800" b="0">
                 <a:solidFill>
                   <a:srgbClr val="24324A"/>
@@ -5157,7 +5140,7 @@
           <p:cNvPr id="13" name="">
             <a:extLst xmlns:a="http://schemas.openxmlformats.org/drawingml/2006/main">
               <a:ext uri="{FF2B5EF4-FFF2-40B4-BE49-F238E27FC236}">
-                <a16:creationId xmlns:a16="http://schemas.microsoft.com/office/drawing/2014/main" id="{D66388B6-9D9A-4493-BD65-8BF7C53BFDCF}"/>
+                <a16:creationId xmlns:a16="http://schemas.microsoft.com/office/drawing/2014/main" id="{09865E6C-21E1-4A73-A751-A2E6DDC42935}"/>
               </a:ext>
             </a:extLst>
           </p:cNvPr>
@@ -5190,7 +5173,7 @@
           <p:cNvPr id="14" name="한국어 질의 HyDE OFF: 원질의 HyDE ON: 영어 번역·가상 문서">
             <a:extLst xmlns:a="http://schemas.openxmlformats.org/drawingml/2006/main">
               <a:ext uri="{FF2B5EF4-FFF2-40B4-BE49-F238E27FC236}">
-                <a16:creationId xmlns:a16="http://schemas.microsoft.com/office/drawing/2014/main" id="{010504EF-242A-472A-AB90-567F4F6F27E5}"/>
+                <a16:creationId xmlns:a16="http://schemas.microsoft.com/office/drawing/2014/main" id="{F55DA3B3-354C-4EC8-9ABA-F2D601C96B30}"/>
               </a:ext>
             </a:extLst>
           </p:cNvPr>
@@ -5320,7 +5303,6 @@
           </a:lstStyle>
           <a:p xmlns:a="http://schemas.openxmlformats.org/drawingml/2006/main">
             <a:pPr algn="ctr">
-              <a:buNone/>
               <a:defRPr sz="1800" b="0">
                 <a:solidFill>
                   <a:srgbClr val="24324A"/>
@@ -5344,7 +5326,6 @@
           </a:p>
           <a:p xmlns:a="http://schemas.openxmlformats.org/drawingml/2006/main">
             <a:pPr algn="ctr">
-              <a:buNone/>
               <a:defRPr sz="1800" b="0">
                 <a:solidFill>
                   <a:srgbClr val="24324A"/>
@@ -5368,7 +5349,6 @@
           </a:p>
           <a:p xmlns:a="http://schemas.openxmlformats.org/drawingml/2006/main">
             <a:pPr algn="ctr">
-              <a:buNone/>
               <a:defRPr sz="1800" b="0">
                 <a:solidFill>
                   <a:srgbClr val="24324A"/>
@@ -5397,7 +5377,7 @@
           <p:cNvPr id="15" name="">
             <a:extLst xmlns:a="http://schemas.openxmlformats.org/drawingml/2006/main">
               <a:ext uri="{FF2B5EF4-FFF2-40B4-BE49-F238E27FC236}">
-                <a16:creationId xmlns:a16="http://schemas.microsoft.com/office/drawing/2014/main" id="{57B6A6DD-5D7B-4624-B5D9-9814D3FDF5DC}"/>
+                <a16:creationId xmlns:a16="http://schemas.microsoft.com/office/drawing/2014/main" id="{504C5182-1A93-4388-9B51-6982EB3B193E}"/>
               </a:ext>
             </a:extLst>
           </p:cNvPr>
@@ -5430,7 +5410,7 @@
           <p:cNvPr id="16" name="BM25 희소 검색[6] 한국어 원질의 사용">
             <a:extLst xmlns:a="http://schemas.openxmlformats.org/drawingml/2006/main">
               <a:ext uri="{FF2B5EF4-FFF2-40B4-BE49-F238E27FC236}">
-                <a16:creationId xmlns:a16="http://schemas.microsoft.com/office/drawing/2014/main" id="{ABBF49ED-CC33-4BF0-93EB-8C2A749C6AA5}"/>
+                <a16:creationId xmlns:a16="http://schemas.microsoft.com/office/drawing/2014/main" id="{D0DDEE65-E1A3-4BAD-844D-D57FBF0C4B3B}"/>
               </a:ext>
             </a:extLst>
           </p:cNvPr>
@@ -5560,7 +5540,6 @@
           </a:lstStyle>
           <a:p xmlns:a="http://schemas.openxmlformats.org/drawingml/2006/main">
             <a:pPr algn="ctr">
-              <a:buNone/>
               <a:defRPr sz="1800" b="0">
                 <a:solidFill>
                   <a:srgbClr val="24324A"/>
@@ -5584,7 +5563,6 @@
           </a:p>
           <a:p xmlns:a="http://schemas.openxmlformats.org/drawingml/2006/main">
             <a:pPr algn="ctr">
-              <a:buNone/>
               <a:defRPr sz="1800" b="0">
                 <a:solidFill>
                   <a:srgbClr val="24324A"/>
@@ -5613,7 +5591,7 @@
           <p:cNvPr id="17" name="">
             <a:extLst xmlns:a="http://schemas.openxmlformats.org/drawingml/2006/main">
               <a:ext uri="{FF2B5EF4-FFF2-40B4-BE49-F238E27FC236}">
-                <a16:creationId xmlns:a16="http://schemas.microsoft.com/office/drawing/2014/main" id="{14662856-405F-4C79-AB51-BDE3444C7CC6}"/>
+                <a16:creationId xmlns:a16="http://schemas.microsoft.com/office/drawing/2014/main" id="{D8D0A2E9-78F0-455D-BDDA-A947524DC343}"/>
               </a:ext>
             </a:extLst>
           </p:cNvPr>
@@ -5646,7 +5624,7 @@
           <p:cNvPr id="18" name="BGE-M3 밀집 검색[5]">
             <a:extLst xmlns:a="http://schemas.openxmlformats.org/drawingml/2006/main">
               <a:ext uri="{FF2B5EF4-FFF2-40B4-BE49-F238E27FC236}">
-                <a16:creationId xmlns:a16="http://schemas.microsoft.com/office/drawing/2014/main" id="{090FAF09-340A-4C07-BB4A-1F3E51851FFC}"/>
+                <a16:creationId xmlns:a16="http://schemas.microsoft.com/office/drawing/2014/main" id="{CA787A4A-1279-4BEF-AF99-57ED132FAEF5}"/>
               </a:ext>
             </a:extLst>
           </p:cNvPr>
@@ -5776,7 +5754,6 @@
           </a:lstStyle>
           <a:p xmlns:a="http://schemas.openxmlformats.org/drawingml/2006/main">
             <a:pPr algn="ctr">
-              <a:buNone/>
               <a:defRPr sz="1800" b="0">
                 <a:solidFill>
                   <a:srgbClr val="24324A"/>
@@ -5805,7 +5782,7 @@
           <p:cNvPr id="19" name="">
             <a:extLst xmlns:a="http://schemas.openxmlformats.org/drawingml/2006/main">
               <a:ext uri="{FF2B5EF4-FFF2-40B4-BE49-F238E27FC236}">
-                <a16:creationId xmlns:a16="http://schemas.microsoft.com/office/drawing/2014/main" id="{4B72F661-9B82-4B60-9557-46582FF7446B}"/>
+                <a16:creationId xmlns:a16="http://schemas.microsoft.com/office/drawing/2014/main" id="{CC366CB8-05E1-40E5-B4F5-D1B28B23F601}"/>
               </a:ext>
             </a:extLst>
           </p:cNvPr>
@@ -5838,7 +5815,7 @@
           <p:cNvPr id="20" name="가중 RRF[7] 0.6 / 0.4, k=60">
             <a:extLst xmlns:a="http://schemas.openxmlformats.org/drawingml/2006/main">
               <a:ext uri="{FF2B5EF4-FFF2-40B4-BE49-F238E27FC236}">
-                <a16:creationId xmlns:a16="http://schemas.microsoft.com/office/drawing/2014/main" id="{424BE6AF-0C1B-422C-AB8F-8A55C4999F6F}"/>
+                <a16:creationId xmlns:a16="http://schemas.microsoft.com/office/drawing/2014/main" id="{422344FA-B291-462F-B4A4-62F19C965A77}"/>
               </a:ext>
             </a:extLst>
           </p:cNvPr>
@@ -5968,7 +5945,6 @@
           </a:lstStyle>
           <a:p xmlns:a="http://schemas.openxmlformats.org/drawingml/2006/main">
             <a:pPr algn="ctr">
-              <a:buNone/>
               <a:defRPr sz="1800" b="0">
                 <a:solidFill>
                   <a:srgbClr val="24324A"/>
@@ -5992,7 +5968,6 @@
           </a:p>
           <a:p xmlns:a="http://schemas.openxmlformats.org/drawingml/2006/main">
             <a:pPr algn="ctr">
-              <a:buNone/>
               <a:defRPr sz="1800" b="0">
                 <a:solidFill>
                   <a:srgbClr val="24324A"/>
@@ -6021,7 +5996,7 @@
           <p:cNvPr id="21" name="">
             <a:extLst xmlns:a="http://schemas.openxmlformats.org/drawingml/2006/main">
               <a:ext uri="{FF2B5EF4-FFF2-40B4-BE49-F238E27FC236}">
-                <a16:creationId xmlns:a16="http://schemas.microsoft.com/office/drawing/2014/main" id="{C43A4057-0FCA-4D44-8226-15A94E1E42AD}"/>
+                <a16:creationId xmlns:a16="http://schemas.microsoft.com/office/drawing/2014/main" id="{F36FD694-979E-466F-A8AB-384F6A419CF5}"/>
               </a:ext>
             </a:extLst>
           </p:cNvPr>
@@ -6053,7 +6028,7 @@
           <p:cNvPr id="22" name="">
             <a:extLst xmlns:a="http://schemas.openxmlformats.org/drawingml/2006/main">
               <a:ext uri="{FF2B5EF4-FFF2-40B4-BE49-F238E27FC236}">
-                <a16:creationId xmlns:a16="http://schemas.microsoft.com/office/drawing/2014/main" id="{C90C8D40-5ACD-4ED8-AA51-D7DB4C79396D}"/>
+                <a16:creationId xmlns:a16="http://schemas.microsoft.com/office/drawing/2014/main" id="{E56784AF-6584-4DD1-AF92-D8DA6EE0A735}"/>
               </a:ext>
             </a:extLst>
           </p:cNvPr>
@@ -6085,7 +6060,7 @@
           <p:cNvPr id="23" name="">
             <a:extLst xmlns:a="http://schemas.openxmlformats.org/drawingml/2006/main">
               <a:ext uri="{FF2B5EF4-FFF2-40B4-BE49-F238E27FC236}">
-                <a16:creationId xmlns:a16="http://schemas.microsoft.com/office/drawing/2014/main" id="{8E0C67CE-FD28-49D8-B3AB-212E79663A08}"/>
+                <a16:creationId xmlns:a16="http://schemas.microsoft.com/office/drawing/2014/main" id="{5A85AD56-5C88-4164-A04C-2F19223412A4}"/>
               </a:ext>
             </a:extLst>
           </p:cNvPr>
@@ -6117,7 +6092,7 @@
           <p:cNvPr id="24" name="">
             <a:extLst xmlns:a="http://schemas.openxmlformats.org/drawingml/2006/main">
               <a:ext uri="{FF2B5EF4-FFF2-40B4-BE49-F238E27FC236}">
-                <a16:creationId xmlns:a16="http://schemas.microsoft.com/office/drawing/2014/main" id="{0339FDC4-49A8-4CA2-86C8-87BF00790BEB}"/>
+                <a16:creationId xmlns:a16="http://schemas.microsoft.com/office/drawing/2014/main" id="{46AB8170-94B5-4794-8576-54B098E8FD9B}"/>
               </a:ext>
             </a:extLst>
           </p:cNvPr>
@@ -6150,7 +6125,7 @@
           <p:cNvPr id="25" name="원질의·구간 쌍 CrossEncoder 재정렬[8][M2] 상위 5개 구간 선택·문맥 길이 관리">
             <a:extLst xmlns:a="http://schemas.openxmlformats.org/drawingml/2006/main">
               <a:ext uri="{FF2B5EF4-FFF2-40B4-BE49-F238E27FC236}">
-                <a16:creationId xmlns:a16="http://schemas.microsoft.com/office/drawing/2014/main" id="{1B13E56A-471A-4ECA-901B-39F9B367FA1D}"/>
+                <a16:creationId xmlns:a16="http://schemas.microsoft.com/office/drawing/2014/main" id="{9609FE25-57BA-43D1-89E6-3ADA9DA6D14B}"/>
               </a:ext>
             </a:extLst>
           </p:cNvPr>
@@ -6280,7 +6255,6 @@
           </a:lstStyle>
           <a:p xmlns:a="http://schemas.openxmlformats.org/drawingml/2006/main">
             <a:pPr algn="ctr">
-              <a:buNone/>
               <a:defRPr sz="1800" b="0">
                 <a:solidFill>
                   <a:srgbClr val="24324A"/>
@@ -6304,7 +6278,6 @@
           </a:p>
           <a:p xmlns:a="http://schemas.openxmlformats.org/drawingml/2006/main">
             <a:pPr algn="ctr">
-              <a:buNone/>
               <a:defRPr sz="1800" b="0">
                 <a:solidFill>
                   <a:srgbClr val="24324A"/>
@@ -6333,7 +6306,7 @@
           <p:cNvPr id="26" name="">
             <a:extLst xmlns:a="http://schemas.openxmlformats.org/drawingml/2006/main">
               <a:ext uri="{FF2B5EF4-FFF2-40B4-BE49-F238E27FC236}">
-                <a16:creationId xmlns:a16="http://schemas.microsoft.com/office/drawing/2014/main" id="{718F5B70-120D-43B0-9037-555C0C128F6F}"/>
+                <a16:creationId xmlns:a16="http://schemas.microsoft.com/office/drawing/2014/main" id="{EA25553B-72A8-424E-9D61-9A5DAC7C675E}"/>
               </a:ext>
             </a:extLst>
           </p:cNvPr>
@@ -6366,7 +6339,7 @@
           <p:cNvPr id="27" name="Mi:dm 2.0 Base Instruct[M1] CAD 로짓 결합 후 SCD 언어별 조정, 최종 답변 생성">
             <a:extLst xmlns:a="http://schemas.openxmlformats.org/drawingml/2006/main">
               <a:ext uri="{FF2B5EF4-FFF2-40B4-BE49-F238E27FC236}">
-                <a16:creationId xmlns:a16="http://schemas.microsoft.com/office/drawing/2014/main" id="{068F3D05-F039-4813-B53D-A0EEBD92A59A}"/>
+                <a16:creationId xmlns:a16="http://schemas.microsoft.com/office/drawing/2014/main" id="{518D69AC-0FBA-40C5-AB18-EADFA7303051}"/>
               </a:ext>
             </a:extLst>
           </p:cNvPr>
@@ -6496,7 +6469,6 @@
           </a:lstStyle>
           <a:p xmlns:a="http://schemas.openxmlformats.org/drawingml/2006/main">
             <a:pPr algn="ctr">
-              <a:buNone/>
               <a:defRPr sz="1800" b="0">
                 <a:solidFill>
                   <a:srgbClr val="24324A"/>
@@ -6520,7 +6492,6 @@
           </a:p>
           <a:p xmlns:a="http://schemas.openxmlformats.org/drawingml/2006/main">
             <a:pPr algn="ctr">
-              <a:buNone/>
               <a:defRPr sz="1800" b="0">
                 <a:solidFill>
                   <a:srgbClr val="24324A"/>
@@ -6549,7 +6520,7 @@
           <p:cNvPr id="28" name="">
             <a:extLst xmlns:a="http://schemas.openxmlformats.org/drawingml/2006/main">
               <a:ext uri="{FF2B5EF4-FFF2-40B4-BE49-F238E27FC236}">
-                <a16:creationId xmlns:a16="http://schemas.microsoft.com/office/drawing/2014/main" id="{546EBC49-52FF-4767-8D8B-0B1D3E759A29}"/>
+                <a16:creationId xmlns:a16="http://schemas.microsoft.com/office/drawing/2014/main" id="{01517BC2-6B58-4ADD-8AC2-666C5CB6D320}"/>
               </a:ext>
             </a:extLst>
           </p:cNvPr>
@@ -6581,7 +6552,7 @@
           <p:cNvPr id="29" name="">
             <a:extLst xmlns:a="http://schemas.openxmlformats.org/drawingml/2006/main">
               <a:ext uri="{FF2B5EF4-FFF2-40B4-BE49-F238E27FC236}">
-                <a16:creationId xmlns:a16="http://schemas.microsoft.com/office/drawing/2014/main" id="{961EA1D3-7005-48E9-86A8-71B377B1C10E}"/>
+                <a16:creationId xmlns:a16="http://schemas.microsoft.com/office/drawing/2014/main" id="{28721863-CA08-469C-96BC-485DE2265EF8}"/>
               </a:ext>
             </a:extLst>
           </p:cNvPr>
@@ -6613,7 +6584,7 @@
           <p:cNvPr id="30" name="">
             <a:extLst xmlns:a="http://schemas.openxmlformats.org/drawingml/2006/main">
               <a:ext uri="{FF2B5EF4-FFF2-40B4-BE49-F238E27FC236}">
-                <a16:creationId xmlns:a16="http://schemas.microsoft.com/office/drawing/2014/main" id="{BB8F461A-7AF8-41AD-BE4F-52D92103DA94}"/>
+                <a16:creationId xmlns:a16="http://schemas.microsoft.com/office/drawing/2014/main" id="{210B2802-B92D-4E74-AC9C-3D43C44E4F84}"/>
               </a:ext>
             </a:extLst>
           </p:cNvPr>
@@ -6644,7 +6615,7 @@
           <p:cNvPr id="31" name="03 3요인 완전요인 실험 설계">
             <a:extLst xmlns:a="http://schemas.openxmlformats.org/drawingml/2006/main">
               <a:ext uri="{FF2B5EF4-FFF2-40B4-BE49-F238E27FC236}">
-                <a16:creationId xmlns:a16="http://schemas.microsoft.com/office/drawing/2014/main" id="{06A8580A-BE3F-4FF1-A6B8-D43FFF35A2C2}"/>
+                <a16:creationId xmlns:a16="http://schemas.microsoft.com/office/drawing/2014/main" id="{78A3373B-0A9D-4529-8EF6-3AC3C96D63BD}"/>
               </a:ext>
             </a:extLst>
           </p:cNvPr>
@@ -6774,7 +6745,6 @@
           </a:lstStyle>
           <a:p xmlns:a="http://schemas.openxmlformats.org/drawingml/2006/main">
             <a:pPr algn="l">
-              <a:buNone/>
               <a:defRPr sz="2400" b="0">
                 <a:solidFill>
                   <a:srgbClr val="FFFFFF"/>
@@ -6803,7 +6773,7 @@
           <p:cNvPr id="32" name="H=HyDE, C=CAD, S=SCD   0=미적용, 1=적용">
             <a:extLst xmlns:a="http://schemas.openxmlformats.org/drawingml/2006/main">
               <a:ext uri="{FF2B5EF4-FFF2-40B4-BE49-F238E27FC236}">
-                <a16:creationId xmlns:a16="http://schemas.microsoft.com/office/drawing/2014/main" id="{6E658457-7906-4B22-A95B-B56CDF2A9AB1}"/>
+                <a16:creationId xmlns:a16="http://schemas.microsoft.com/office/drawing/2014/main" id="{D1D5D367-CA52-4DA3-AA01-5984FFC8B102}"/>
               </a:ext>
             </a:extLst>
           </p:cNvPr>
@@ -6933,7 +6903,6 @@
           </a:lstStyle>
           <a:p xmlns:a="http://schemas.openxmlformats.org/drawingml/2006/main">
             <a:pPr algn="l">
-              <a:buNone/>
               <a:defRPr sz="1800" b="0">
                 <a:solidFill>
                   <a:srgbClr val="24324A"/>
@@ -6962,7 +6931,7 @@
           <p:cNvPr id="33" name="">
             <a:extLst xmlns:a="http://schemas.openxmlformats.org/drawingml/2006/main">
               <a:ext uri="{FF2B5EF4-FFF2-40B4-BE49-F238E27FC236}">
-                <a16:creationId xmlns:a16="http://schemas.microsoft.com/office/drawing/2014/main" id="{827ADEC0-AA42-41F6-97FA-F99E4014E9E7}"/>
+                <a16:creationId xmlns:a16="http://schemas.microsoft.com/office/drawing/2014/main" id="{C3BC8A11-3B74-4240-9922-1C2A6D735EFC}"/>
               </a:ext>
             </a:extLst>
           </p:cNvPr>
@@ -6991,9 +6960,7 @@
                     </a:bodyPr>
                     <a:lstStyle/>
                     <a:p>
-                      <a:pPr algn="ctr">
-                        <a:buNone/>
-                      </a:pPr>
+                      <a:pPr algn="ctr"/>
                       <a:r>
                         <a:rPr sz="1800" b="1">
                           <a:solidFill>
@@ -7044,9 +7011,7 @@
                     </a:bodyPr>
                     <a:lstStyle/>
                     <a:p>
-                      <a:pPr algn="ctr">
-                        <a:buNone/>
-                      </a:pPr>
+                      <a:pPr algn="ctr"/>
                       <a:r>
                         <a:rPr sz="1800" b="1">
                           <a:solidFill>
@@ -7091,9 +7056,7 @@
                     </a:bodyPr>
                     <a:lstStyle/>
                     <a:p>
-                      <a:pPr algn="ctr">
-                        <a:buNone/>
-                      </a:pPr>
+                      <a:pPr algn="ctr"/>
                       <a:r>
                         <a:rPr sz="1800" b="1">
                           <a:solidFill>
@@ -7138,9 +7101,7 @@
                     </a:bodyPr>
                     <a:lstStyle/>
                     <a:p>
-                      <a:pPr algn="ctr">
-                        <a:buNone/>
-                      </a:pPr>
+                      <a:pPr algn="ctr"/>
                       <a:r>
                         <a:rPr sz="1800" b="1">
                           <a:solidFill>
@@ -7187,9 +7148,7 @@
                     </a:bodyPr>
                     <a:lstStyle/>
                     <a:p>
-                      <a:pPr algn="ctr">
-                        <a:buNone/>
-                      </a:pPr>
+                      <a:pPr algn="ctr"/>
                       <a:r>
                         <a:rPr sz="1800" b="0">
                           <a:solidFill>
@@ -7234,9 +7193,7 @@
                     </a:bodyPr>
                     <a:lstStyle/>
                     <a:p>
-                      <a:pPr algn="ctr">
-                        <a:buNone/>
-                      </a:pPr>
+                      <a:pPr algn="ctr"/>
                       <a:r>
                         <a:rPr sz="1800" b="0">
                           <a:solidFill>
@@ -7275,9 +7232,7 @@
                     </a:bodyPr>
                     <a:lstStyle/>
                     <a:p>
-                      <a:pPr algn="ctr">
-                        <a:buNone/>
-                      </a:pPr>
+                      <a:pPr algn="ctr"/>
                       <a:r>
                         <a:rPr sz="1800" b="0">
                           <a:solidFill>
@@ -7316,9 +7271,7 @@
                     </a:bodyPr>
                     <a:lstStyle/>
                     <a:p>
-                      <a:pPr algn="ctr">
-                        <a:buNone/>
-                      </a:pPr>
+                      <a:pPr algn="ctr"/>
                       <a:r>
                         <a:rPr sz="1800" b="0">
                           <a:solidFill>
@@ -7359,9 +7312,7 @@
                     </a:bodyPr>
                     <a:lstStyle/>
                     <a:p>
-                      <a:pPr algn="ctr">
-                        <a:buNone/>
-                      </a:pPr>
+                      <a:pPr algn="ctr"/>
                       <a:r>
                         <a:rPr sz="1800" b="0">
                           <a:solidFill>
@@ -7406,9 +7357,7 @@
                     </a:bodyPr>
                     <a:lstStyle/>
                     <a:p>
-                      <a:pPr algn="ctr">
-                        <a:buNone/>
-                      </a:pPr>
+                      <a:pPr algn="ctr"/>
                       <a:r>
                         <a:rPr sz="1800" b="0">
                           <a:solidFill>
@@ -7447,9 +7396,7 @@
                     </a:bodyPr>
                     <a:lstStyle/>
                     <a:p>
-                      <a:pPr algn="ctr">
-                        <a:buNone/>
-                      </a:pPr>
+                      <a:pPr algn="ctr"/>
                       <a:r>
                         <a:rPr sz="1800" b="0">
                           <a:solidFill>
@@ -7488,9 +7435,7 @@
                     </a:bodyPr>
                     <a:lstStyle/>
                     <a:p>
-                      <a:pPr algn="ctr">
-                        <a:buNone/>
-                      </a:pPr>
+                      <a:pPr algn="ctr"/>
                       <a:r>
                         <a:rPr sz="1800" b="0">
                           <a:solidFill>
@@ -7531,9 +7476,7 @@
                     </a:bodyPr>
                     <a:lstStyle/>
                     <a:p>
-                      <a:pPr algn="ctr">
-                        <a:buNone/>
-                      </a:pPr>
+                      <a:pPr algn="ctr"/>
                       <a:r>
                         <a:rPr sz="1800" b="0">
                           <a:solidFill>
@@ -7578,9 +7521,7 @@
                     </a:bodyPr>
                     <a:lstStyle/>
                     <a:p>
-                      <a:pPr algn="ctr">
-                        <a:buNone/>
-                      </a:pPr>
+                      <a:pPr algn="ctr"/>
                       <a:r>
                         <a:rPr sz="1800" b="0">
                           <a:solidFill>
@@ -7619,9 +7560,7 @@
                     </a:bodyPr>
                     <a:lstStyle/>
                     <a:p>
-                      <a:pPr algn="ctr">
-                        <a:buNone/>
-                      </a:pPr>
+                      <a:pPr algn="ctr"/>
                       <a:r>
                         <a:rPr sz="1800" b="0">
                           <a:solidFill>
@@ -7660,9 +7599,7 @@
                     </a:bodyPr>
                     <a:lstStyle/>
                     <a:p>
-                      <a:pPr algn="ctr">
-                        <a:buNone/>
-                      </a:pPr>
+                      <a:pPr algn="ctr"/>
                       <a:r>
                         <a:rPr sz="1800" b="0">
                           <a:solidFill>
@@ -7703,9 +7640,7 @@
                     </a:bodyPr>
                     <a:lstStyle/>
                     <a:p>
-                      <a:pPr algn="ctr">
-                        <a:buNone/>
-                      </a:pPr>
+                      <a:pPr algn="ctr"/>
                       <a:r>
                         <a:rPr sz="1800" b="0">
                           <a:solidFill>
@@ -7750,9 +7685,7 @@
                     </a:bodyPr>
                     <a:lstStyle/>
                     <a:p>
-                      <a:pPr algn="ctr">
-                        <a:buNone/>
-                      </a:pPr>
+                      <a:pPr algn="ctr"/>
                       <a:r>
                         <a:rPr sz="1800" b="0">
                           <a:solidFill>
@@ -7791,9 +7724,7 @@
                     </a:bodyPr>
                     <a:lstStyle/>
                     <a:p>
-                      <a:pPr algn="ctr">
-                        <a:buNone/>
-                      </a:pPr>
+                      <a:pPr algn="ctr"/>
                       <a:r>
                         <a:rPr sz="1800" b="0">
                           <a:solidFill>
@@ -7832,9 +7763,7 @@
                     </a:bodyPr>
                     <a:lstStyle/>
                     <a:p>
-                      <a:pPr algn="ctr">
-                        <a:buNone/>
-                      </a:pPr>
+                      <a:pPr algn="ctr"/>
                       <a:r>
                         <a:rPr sz="1800" b="0">
                           <a:solidFill>
@@ -7875,9 +7804,7 @@
                     </a:bodyPr>
                     <a:lstStyle/>
                     <a:p>
-                      <a:pPr algn="ctr">
-                        <a:buNone/>
-                      </a:pPr>
+                      <a:pPr algn="ctr"/>
                       <a:r>
                         <a:rPr sz="1800" b="0">
                           <a:solidFill>
@@ -7922,9 +7849,7 @@
                     </a:bodyPr>
                     <a:lstStyle/>
                     <a:p>
-                      <a:pPr algn="ctr">
-                        <a:buNone/>
-                      </a:pPr>
+                      <a:pPr algn="ctr"/>
                       <a:r>
                         <a:rPr sz="1800" b="0">
                           <a:solidFill>
@@ -7963,9 +7888,7 @@
                     </a:bodyPr>
                     <a:lstStyle/>
                     <a:p>
-                      <a:pPr algn="ctr">
-                        <a:buNone/>
-                      </a:pPr>
+                      <a:pPr algn="ctr"/>
                       <a:r>
                         <a:rPr sz="1800" b="0">
                           <a:solidFill>
@@ -8004,9 +7927,7 @@
                     </a:bodyPr>
                     <a:lstStyle/>
                     <a:p>
-                      <a:pPr algn="ctr">
-                        <a:buNone/>
-                      </a:pPr>
+                      <a:pPr algn="ctr"/>
                       <a:r>
                         <a:rPr sz="1800" b="0">
                           <a:solidFill>
@@ -8047,9 +7968,7 @@
                     </a:bodyPr>
                     <a:lstStyle/>
                     <a:p>
-                      <a:pPr algn="ctr">
-                        <a:buNone/>
-                      </a:pPr>
+                      <a:pPr algn="ctr"/>
                       <a:r>
                         <a:rPr sz="1800" b="0">
                           <a:solidFill>
@@ -8094,9 +8013,7 @@
                     </a:bodyPr>
                     <a:lstStyle/>
                     <a:p>
-                      <a:pPr algn="ctr">
-                        <a:buNone/>
-                      </a:pPr>
+                      <a:pPr algn="ctr"/>
                       <a:r>
                         <a:rPr sz="1800" b="0">
                           <a:solidFill>
@@ -8135,9 +8052,7 @@
                     </a:bodyPr>
                     <a:lstStyle/>
                     <a:p>
-                      <a:pPr algn="ctr">
-                        <a:buNone/>
-                      </a:pPr>
+                      <a:pPr algn="ctr"/>
                       <a:r>
                         <a:rPr sz="1800" b="0">
                           <a:solidFill>
@@ -8176,9 +8091,7 @@
                     </a:bodyPr>
                     <a:lstStyle/>
                     <a:p>
-                      <a:pPr algn="ctr">
-                        <a:buNone/>
-                      </a:pPr>
+                      <a:pPr algn="ctr"/>
                       <a:r>
                         <a:rPr sz="1800" b="0">
                           <a:solidFill>
@@ -8219,9 +8132,7 @@
                     </a:bodyPr>
                     <a:lstStyle/>
                     <a:p>
-                      <a:pPr algn="ctr">
-                        <a:buNone/>
-                      </a:pPr>
+                      <a:pPr algn="ctr"/>
                       <a:r>
                         <a:rPr sz="1800" b="0">
                           <a:solidFill>
@@ -8266,9 +8177,7 @@
                     </a:bodyPr>
                     <a:lstStyle/>
                     <a:p>
-                      <a:pPr algn="ctr">
-                        <a:buNone/>
-                      </a:pPr>
+                      <a:pPr algn="ctr"/>
                       <a:r>
                         <a:rPr sz="1800" b="0">
                           <a:solidFill>
@@ -8307,9 +8216,7 @@
                     </a:bodyPr>
                     <a:lstStyle/>
                     <a:p>
-                      <a:pPr algn="ctr">
-                        <a:buNone/>
-                      </a:pPr>
+                      <a:pPr algn="ctr"/>
                       <a:r>
                         <a:rPr sz="1800" b="0">
                           <a:solidFill>
@@ -8348,9 +8255,7 @@
                     </a:bodyPr>
                     <a:lstStyle/>
                     <a:p>
-                      <a:pPr algn="ctr">
-                        <a:buNone/>
-                      </a:pPr>
+                      <a:pPr algn="ctr"/>
                       <a:r>
                         <a:rPr sz="1800" b="0">
                           <a:solidFill>
@@ -8391,9 +8296,7 @@
                     </a:bodyPr>
                     <a:lstStyle/>
                     <a:p>
-                      <a:pPr algn="ctr">
-                        <a:buNone/>
-                      </a:pPr>
+                      <a:pPr algn="ctr"/>
                       <a:r>
                         <a:rPr sz="1800" b="0">
                           <a:solidFill>
@@ -8438,9 +8341,7 @@
                     </a:bodyPr>
                     <a:lstStyle/>
                     <a:p>
-                      <a:pPr algn="ctr">
-                        <a:buNone/>
-                      </a:pPr>
+                      <a:pPr algn="ctr"/>
                       <a:r>
                         <a:rPr sz="1800" b="0">
                           <a:solidFill>
@@ -8479,9 +8380,7 @@
                     </a:bodyPr>
                     <a:lstStyle/>
                     <a:p>
-                      <a:pPr algn="ctr">
-                        <a:buNone/>
-                      </a:pPr>
+                      <a:pPr algn="ctr"/>
                       <a:r>
                         <a:rPr sz="1800" b="0">
                           <a:solidFill>
@@ -8520,9 +8419,7 @@
                     </a:bodyPr>
                     <a:lstStyle/>
                     <a:p>
-                      <a:pPr algn="ctr">
-                        <a:buNone/>
-                      </a:pPr>
+                      <a:pPr algn="ctr"/>
                       <a:r>
                         <a:rPr sz="1800" b="0">
                           <a:solidFill>
@@ -8564,7 +8461,7 @@
           <p:cNvPr id="34" name="같은 질의 60개 × 8조건 반복측정 = 480개 생성 기록">
             <a:extLst xmlns:a="http://schemas.openxmlformats.org/drawingml/2006/main">
               <a:ext uri="{FF2B5EF4-FFF2-40B4-BE49-F238E27FC236}">
-                <a16:creationId xmlns:a16="http://schemas.microsoft.com/office/drawing/2014/main" id="{C13B4DE2-291F-4C28-806E-AD2A80E1CB53}"/>
+                <a16:creationId xmlns:a16="http://schemas.microsoft.com/office/drawing/2014/main" id="{078D1A9C-A262-4CDA-8905-D8DE88F863AD}"/>
               </a:ext>
             </a:extLst>
           </p:cNvPr>
@@ -8694,7 +8591,6 @@
           </a:lstStyle>
           <a:p xmlns:a="http://schemas.openxmlformats.org/drawingml/2006/main">
             <a:pPr algn="l">
-              <a:buNone/>
               <a:defRPr sz="1800" b="1">
                 <a:solidFill>
                   <a:srgbClr val="24324A"/>
@@ -8723,7 +8619,7 @@
           <p:cNvPr id="35" name="생성 512토큰, CAD α=0.5, SCD α=1.1·β=0.9·Tstart=5">
             <a:extLst xmlns:a="http://schemas.openxmlformats.org/drawingml/2006/main">
               <a:ext uri="{FF2B5EF4-FFF2-40B4-BE49-F238E27FC236}">
-                <a16:creationId xmlns:a16="http://schemas.microsoft.com/office/drawing/2014/main" id="{2B114CEE-7C1B-4DC7-9A97-476832105F41}"/>
+                <a16:creationId xmlns:a16="http://schemas.microsoft.com/office/drawing/2014/main" id="{E4A45FB3-1DB6-4774-9F72-C3F409182A83}"/>
               </a:ext>
             </a:extLst>
           </p:cNvPr>
@@ -8853,7 +8749,6 @@
           </a:lstStyle>
           <a:p xmlns:a="http://schemas.openxmlformats.org/drawingml/2006/main">
             <a:pPr algn="l">
-              <a:buNone/>
               <a:defRPr sz="1800" b="0">
                 <a:solidFill>
                   <a:srgbClr val="24324A"/>
@@ -8882,7 +8777,7 @@
           <p:cNvPr id="36" name="문서 요약을 15개 내용 단위로 나누어 질의를 작성하고, 총 60개 질의의 원문 페이지·정답 근거·답변 가능성을 확인">
             <a:extLst xmlns:a="http://schemas.openxmlformats.org/drawingml/2006/main">
               <a:ext uri="{FF2B5EF4-FFF2-40B4-BE49-F238E27FC236}">
-                <a16:creationId xmlns:a16="http://schemas.microsoft.com/office/drawing/2014/main" id="{1DB54CE9-20A9-49EC-8861-A0764339B16A}"/>
+                <a16:creationId xmlns:a16="http://schemas.microsoft.com/office/drawing/2014/main" id="{6DDA1723-3294-441D-83EB-9842CA8A28C9}"/>
               </a:ext>
             </a:extLst>
           </p:cNvPr>
@@ -9012,7 +8907,6 @@
           </a:lstStyle>
           <a:p xmlns:a="http://schemas.openxmlformats.org/drawingml/2006/main">
             <a:pPr algn="l">
-              <a:buNone/>
               <a:defRPr sz="1800" b="0">
                 <a:solidFill>
                   <a:srgbClr val="24324A"/>
@@ -9036,7 +8930,6 @@
           </a:p>
           <a:p xmlns:a="http://schemas.openxmlformats.org/drawingml/2006/main">
             <a:pPr algn="l">
-              <a:buNone/>
               <a:defRPr sz="1800" b="0">
                 <a:solidFill>
                   <a:srgbClr val="24324A"/>
@@ -9065,7 +8958,7 @@
           <p:cNvPr id="37" name="">
             <a:extLst xmlns:a="http://schemas.openxmlformats.org/drawingml/2006/main">
               <a:ext uri="{FF2B5EF4-FFF2-40B4-BE49-F238E27FC236}">
-                <a16:creationId xmlns:a16="http://schemas.microsoft.com/office/drawing/2014/main" id="{F62927B6-D60F-4201-B1B1-A68BB0300485}"/>
+                <a16:creationId xmlns:a16="http://schemas.microsoft.com/office/drawing/2014/main" id="{98BEAC82-B3FD-45C4-A0DA-C894B67D1ECA}"/>
               </a:ext>
             </a:extLst>
           </p:cNvPr>
@@ -9096,7 +8989,7 @@
           <p:cNvPr id="38" name="04 평가 지표 및 실험·통계 방법">
             <a:extLst xmlns:a="http://schemas.openxmlformats.org/drawingml/2006/main">
               <a:ext uri="{FF2B5EF4-FFF2-40B4-BE49-F238E27FC236}">
-                <a16:creationId xmlns:a16="http://schemas.microsoft.com/office/drawing/2014/main" id="{A9489E70-B301-48F2-B35A-F97337A797C9}"/>
+                <a16:creationId xmlns:a16="http://schemas.microsoft.com/office/drawing/2014/main" id="{1C2AC397-8D8E-4B7F-B11B-1C24458AF243}"/>
               </a:ext>
             </a:extLst>
           </p:cNvPr>
@@ -9226,7 +9119,6 @@
           </a:lstStyle>
           <a:p xmlns:a="http://schemas.openxmlformats.org/drawingml/2006/main">
             <a:pPr algn="l">
-              <a:buNone/>
               <a:defRPr sz="2400" b="0">
                 <a:solidFill>
                   <a:srgbClr val="FFFFFF"/>
@@ -9255,7 +9147,7 @@
           <p:cNvPr id="39" name="근거 충실도: 높을수록 검색 근거가 지지하는 답변 주장 비율이 크다. 답변 관련성: 높을수록 답변 기반 질문과 원질문">
             <a:extLst xmlns:a="http://schemas.openxmlformats.org/drawingml/2006/main">
               <a:ext uri="{FF2B5EF4-FFF2-40B4-BE49-F238E27FC236}">
-                <a16:creationId xmlns:a16="http://schemas.microsoft.com/office/drawing/2014/main" id="{8B9D0C8B-DE50-4B90-A878-60AFEB0DD8DA}"/>
+                <a16:creationId xmlns:a16="http://schemas.microsoft.com/office/drawing/2014/main" id="{5DA0CC21-F217-49D5-AE74-163C9AFD4D8D}"/>
               </a:ext>
             </a:extLst>
           </p:cNvPr>
@@ -9385,7 +9277,6 @@
           </a:lstStyle>
           <a:p xmlns:a="http://schemas.openxmlformats.org/drawingml/2006/main">
             <a:pPr algn="l">
-              <a:buNone/>
               <a:defRPr sz="1800" b="0">
                 <a:solidFill>
                   <a:srgbClr val="24324A"/>
@@ -9409,7 +9300,6 @@
           </a:p>
           <a:p xmlns:a="http://schemas.openxmlformats.org/drawingml/2006/main">
             <a:pPr algn="l">
-              <a:buNone/>
               <a:defRPr sz="1800" b="0">
                 <a:solidFill>
                   <a:srgbClr val="24324A"/>
@@ -9433,7 +9323,6 @@
           </a:p>
           <a:p xmlns:a="http://schemas.openxmlformats.org/drawingml/2006/main">
             <a:pPr algn="l">
-              <a:buNone/>
               <a:defRPr sz="1800" b="0">
                 <a:solidFill>
                   <a:srgbClr val="24324A"/>
@@ -9457,7 +9346,6 @@
           </a:p>
           <a:p xmlns:a="http://schemas.openxmlformats.org/drawingml/2006/main">
             <a:pPr algn="l">
-              <a:buNone/>
               <a:defRPr sz="1800" b="0">
                 <a:solidFill>
                   <a:srgbClr val="24324A"/>
@@ -9481,7 +9369,6 @@
           </a:p>
           <a:p xmlns:a="http://schemas.openxmlformats.org/drawingml/2006/main">
             <a:pPr algn="l">
-              <a:buNone/>
               <a:defRPr sz="1800" b="0">
                 <a:solidFill>
                   <a:srgbClr val="24324A"/>
@@ -9510,7 +9397,7 @@
           <p:cNvPr id="40" name="품질 관측값은 0~1이다. 관련성 +0.080은 ON−OFF 평균 차이 0.080점이다. SD는 질의별 분포의 표본표">
             <a:extLst xmlns:a="http://schemas.openxmlformats.org/drawingml/2006/main">
               <a:ext uri="{FF2B5EF4-FFF2-40B4-BE49-F238E27FC236}">
-                <a16:creationId xmlns:a16="http://schemas.microsoft.com/office/drawing/2014/main" id="{5C49F3F4-C621-4158-AA78-3690915A584D}"/>
+                <a16:creationId xmlns:a16="http://schemas.microsoft.com/office/drawing/2014/main" id="{C2E699DF-B4FA-48E9-971C-781E7B4B17C1}"/>
               </a:ext>
             </a:extLst>
           </p:cNvPr>
@@ -9640,7 +9527,6 @@
           </a:lstStyle>
           <a:p xmlns:a="http://schemas.openxmlformats.org/drawingml/2006/main">
             <a:pPr algn="l">
-              <a:buNone/>
               <a:defRPr sz="1800" b="0">
                 <a:solidFill>
                   <a:srgbClr val="24324A"/>
@@ -9664,7 +9550,6 @@
           </a:p>
           <a:p xmlns:a="http://schemas.openxmlformats.org/drawingml/2006/main">
             <a:pPr algn="l">
-              <a:buNone/>
               <a:defRPr sz="1800" b="0">
                 <a:solidFill>
                   <a:srgbClr val="24324A"/>
@@ -9688,7 +9573,6 @@
           </a:p>
           <a:p xmlns:a="http://schemas.openxmlformats.org/drawingml/2006/main">
             <a:pPr algn="l">
-              <a:buNone/>
               <a:defRPr sz="1800" b="0">
                 <a:solidFill>
                   <a:srgbClr val="24324A"/>
@@ -9717,7 +9601,7 @@
           <p:cNvPr id="41" name="평가 예시  ext_raptor_011, H0C0S0">
             <a:extLst xmlns:a="http://schemas.openxmlformats.org/drawingml/2006/main">
               <a:ext uri="{FF2B5EF4-FFF2-40B4-BE49-F238E27FC236}">
-                <a16:creationId xmlns:a16="http://schemas.microsoft.com/office/drawing/2014/main" id="{B0B826B3-3EF0-469E-B156-76B43250CC9C}"/>
+                <a16:creationId xmlns:a16="http://schemas.microsoft.com/office/drawing/2014/main" id="{E83DCFB9-23AE-4599-9D91-9CE6CD537763}"/>
               </a:ext>
             </a:extLst>
           </p:cNvPr>
@@ -9847,7 +9731,6 @@
           </a:lstStyle>
           <a:p xmlns:a="http://schemas.openxmlformats.org/drawingml/2006/main">
             <a:pPr algn="l">
-              <a:buNone/>
               <a:defRPr sz="1800" b="1">
                 <a:solidFill>
                   <a:srgbClr val="24324A"/>
@@ -9876,7 +9759,7 @@
           <p:cNvPr id="42" name="질문: Cinderella 사례의 정성 분석에서 RAPTOR의 tree-based retrieval이 DPR보다 주제">
             <a:extLst xmlns:a="http://schemas.openxmlformats.org/drawingml/2006/main">
               <a:ext uri="{FF2B5EF4-FFF2-40B4-BE49-F238E27FC236}">
-                <a16:creationId xmlns:a16="http://schemas.microsoft.com/office/drawing/2014/main" id="{87904639-62A9-4614-B066-40665DEA3566}"/>
+                <a16:creationId xmlns:a16="http://schemas.microsoft.com/office/drawing/2014/main" id="{8E532899-727A-4EAA-A060-E244AD849D8C}"/>
               </a:ext>
             </a:extLst>
           </p:cNvPr>
@@ -10006,7 +9889,6 @@
           </a:lstStyle>
           <a:p xmlns:a="http://schemas.openxmlformats.org/drawingml/2006/main">
             <a:pPr algn="l">
-              <a:buNone/>
               <a:defRPr sz="1800" b="0">
                 <a:solidFill>
                   <a:srgbClr val="24324A"/>
@@ -10030,7 +9912,6 @@
           </a:p>
           <a:p xmlns:a="http://schemas.openxmlformats.org/drawingml/2006/main">
             <a:pPr algn="l">
-              <a:buNone/>
               <a:defRPr sz="1800" b="0">
                 <a:solidFill>
                   <a:srgbClr val="24324A"/>
@@ -10059,7 +9940,7 @@
           <p:cNvPr id="43" name="검색 근거(PDF p.9): “By providing both the original text and higher-l">
             <a:extLst xmlns:a="http://schemas.openxmlformats.org/drawingml/2006/main">
               <a:ext uri="{FF2B5EF4-FFF2-40B4-BE49-F238E27FC236}">
-                <a16:creationId xmlns:a16="http://schemas.microsoft.com/office/drawing/2014/main" id="{3B679EB7-B7DC-4A60-A8B9-BA2E9FE038C2}"/>
+                <a16:creationId xmlns:a16="http://schemas.microsoft.com/office/drawing/2014/main" id="{E8B24F52-820F-438E-B9E2-E46199A906DB}"/>
               </a:ext>
             </a:extLst>
           </p:cNvPr>
@@ -10189,7 +10070,6 @@
           </a:lstStyle>
           <a:p xmlns:a="http://schemas.openxmlformats.org/drawingml/2006/main">
             <a:pPr algn="l">
-              <a:buNone/>
               <a:defRPr sz="1800" b="0">
                 <a:solidFill>
                   <a:srgbClr val="24324A"/>
@@ -10213,7 +10093,6 @@
           </a:p>
           <a:p xmlns:a="http://schemas.openxmlformats.org/drawingml/2006/main">
             <a:pPr algn="l">
-              <a:buNone/>
               <a:defRPr sz="1800" b="0">
                 <a:solidFill>
                   <a:srgbClr val="24324A"/>
@@ -10237,7 +10116,6 @@
           </a:p>
           <a:p xmlns:a="http://schemas.openxmlformats.org/drawingml/2006/main">
             <a:pPr algn="l">
-              <a:buNone/>
               <a:defRPr sz="1800" b="0">
                 <a:solidFill>
                   <a:srgbClr val="24324A"/>
@@ -10266,7 +10144,7 @@
           <p:cNvPr id="44" name="참조 답변 요지(PDF p.20): RAPTOR는 이야기의 주요 부분을, DPR은 이야기의 좁은 일부를 자세히 검색한">
             <a:extLst xmlns:a="http://schemas.openxmlformats.org/drawingml/2006/main">
               <a:ext uri="{FF2B5EF4-FFF2-40B4-BE49-F238E27FC236}">
-                <a16:creationId xmlns:a16="http://schemas.microsoft.com/office/drawing/2014/main" id="{DE0059C3-9038-4D15-AD7D-772E14CF57A8}"/>
+                <a16:creationId xmlns:a16="http://schemas.microsoft.com/office/drawing/2014/main" id="{5D70A1C8-A9DF-4E2F-B51C-31D407D194C7}"/>
               </a:ext>
             </a:extLst>
           </p:cNvPr>
@@ -10396,7 +10274,6 @@
           </a:lstStyle>
           <a:p xmlns:a="http://schemas.openxmlformats.org/drawingml/2006/main">
             <a:pPr algn="l">
-              <a:buNone/>
               <a:defRPr sz="1800" b="0">
                 <a:solidFill>
                   <a:srgbClr val="24324A"/>
@@ -10420,7 +10297,6 @@
           </a:p>
           <a:p xmlns:a="http://schemas.openxmlformats.org/drawingml/2006/main">
             <a:pPr algn="l">
-              <a:buNone/>
               <a:defRPr sz="1800" b="0">
                 <a:solidFill>
                   <a:srgbClr val="24324A"/>
@@ -10449,7 +10325,7 @@
           <p:cNvPr id="45" name="생성 답변 발췌: “질문의 요구사항에 따라 서로 다른 층위(layer)에서 노드를 선택할 수 있습니다.”">
             <a:extLst xmlns:a="http://schemas.openxmlformats.org/drawingml/2006/main">
               <a:ext uri="{FF2B5EF4-FFF2-40B4-BE49-F238E27FC236}">
-                <a16:creationId xmlns:a16="http://schemas.microsoft.com/office/drawing/2014/main" id="{9D73BECE-FD4F-491D-8ED6-DB58D43259BC}"/>
+                <a16:creationId xmlns:a16="http://schemas.microsoft.com/office/drawing/2014/main" id="{9C2C350A-3287-4938-9960-625A1AF9AC38}"/>
               </a:ext>
             </a:extLst>
           </p:cNvPr>
@@ -10579,7 +10455,6 @@
           </a:lstStyle>
           <a:p xmlns:a="http://schemas.openxmlformats.org/drawingml/2006/main">
             <a:pPr algn="l">
-              <a:buNone/>
               <a:defRPr sz="1800" b="0">
                 <a:solidFill>
                   <a:srgbClr val="24324A"/>
@@ -10603,7 +10478,6 @@
           </a:p>
           <a:p xmlns:a="http://schemas.openxmlformats.org/drawingml/2006/main">
             <a:pPr algn="l">
-              <a:buNone/>
               <a:defRPr sz="1800" b="0">
                 <a:solidFill>
                   <a:srgbClr val="24324A"/>
@@ -10632,7 +10506,7 @@
           <p:cNvPr id="46" name="충실도 1.000: 추출된 답변 주장을 검색 문맥이 모두 지지 관련성 0.937: 답변 기반 질문과 원질문의 평균 의">
             <a:extLst xmlns:a="http://schemas.openxmlformats.org/drawingml/2006/main">
               <a:ext uri="{FF2B5EF4-FFF2-40B4-BE49-F238E27FC236}">
-                <a16:creationId xmlns:a16="http://schemas.microsoft.com/office/drawing/2014/main" id="{10339883-484F-49D8-A7C8-F8777F63B8EF}"/>
+                <a16:creationId xmlns:a16="http://schemas.microsoft.com/office/drawing/2014/main" id="{492D705E-5CD0-4326-BF36-68E776982E4F}"/>
               </a:ext>
             </a:extLst>
           </p:cNvPr>
@@ -10762,7 +10636,6 @@
           </a:lstStyle>
           <a:p xmlns:a="http://schemas.openxmlformats.org/drawingml/2006/main">
             <a:pPr algn="l">
-              <a:buNone/>
               <a:defRPr sz="1800" b="0">
                 <a:solidFill>
                   <a:srgbClr val="24324A"/>
@@ -10786,7 +10659,6 @@
           </a:p>
           <a:p xmlns:a="http://schemas.openxmlformats.org/drawingml/2006/main">
             <a:pPr algn="l">
-              <a:buNone/>
               <a:defRPr sz="1800" b="0">
                 <a:solidFill>
                   <a:srgbClr val="24324A"/>
@@ -10815,7 +10687,7 @@
           <p:cNvPr id="47" name="평가: RAGAS 0.2.15[10]·gpt-4o·BGE-M3, 저장 답변 평가 S0 영어 / S1 한국어 번역 평가">
             <a:extLst xmlns:a="http://schemas.openxmlformats.org/drawingml/2006/main">
               <a:ext uri="{FF2B5EF4-FFF2-40B4-BE49-F238E27FC236}">
-                <a16:creationId xmlns:a16="http://schemas.microsoft.com/office/drawing/2014/main" id="{4C2F2814-28BF-4FAD-8E2F-938D04745754}"/>
+                <a16:creationId xmlns:a16="http://schemas.microsoft.com/office/drawing/2014/main" id="{C0CEBE01-FE8E-4ACB-A7DC-76BC2674A26F}"/>
               </a:ext>
             </a:extLst>
           </p:cNvPr>
@@ -10945,7 +10817,6 @@
           </a:lstStyle>
           <a:p xmlns:a="http://schemas.openxmlformats.org/drawingml/2006/main">
             <a:pPr algn="l">
-              <a:buNone/>
               <a:defRPr sz="1800" b="0">
                 <a:solidFill>
                   <a:srgbClr val="24324A"/>
@@ -10969,7 +10840,6 @@
           </a:p>
           <a:p xmlns:a="http://schemas.openxmlformats.org/drawingml/2006/main">
             <a:pPr algn="l">
-              <a:buNone/>
               <a:defRPr sz="1800" b="0">
                 <a:solidFill>
                   <a:srgbClr val="24324A"/>
@@ -10995,10 +10865,10 @@
       </p:sp>
       <p:sp>
         <p:nvSpPr>
-          <p:cNvPr id="48" name="반복측정 분산분석(ANOVA)·대응 t-검정·Holm, α=0.05 품질 S별 H×C / 문자·시간 H×C×S, SC">
+          <p:cNvPr id="48" name="반복측정 분산분석(ANOVA)·대응 t-검정, 양측 α=0.05 품질 S별 H×C / 문자·시간 H×C×S, SCD ">
             <a:extLst xmlns:a="http://schemas.openxmlformats.org/drawingml/2006/main">
               <a:ext uri="{FF2B5EF4-FFF2-40B4-BE49-F238E27FC236}">
-                <a16:creationId xmlns:a16="http://schemas.microsoft.com/office/drawing/2014/main" id="{734BF438-2E7D-4C31-86A6-7FCDA4E898BC}"/>
+                <a16:creationId xmlns:a16="http://schemas.microsoft.com/office/drawing/2014/main" id="{4779FA00-3925-420C-A2E6-5F22BD27451D}"/>
               </a:ext>
             </a:extLst>
           </p:cNvPr>
@@ -11128,7 +10998,6 @@
           </a:lstStyle>
           <a:p xmlns:a="http://schemas.openxmlformats.org/drawingml/2006/main">
             <a:pPr algn="l">
-              <a:buNone/>
               <a:defRPr sz="1800" b="1">
                 <a:solidFill>
                   <a:srgbClr val="24324A"/>
@@ -11147,12 +11016,11 @@
                 <a:ea typeface="Malgun Gothic"/>
                 <a:cs typeface="Malgun Gothic"/>
               </a:rPr>
-              <a:t>반복측정 분산분석(ANOVA)·대응 t-검정·Holm, α=0.05</a:t>
+              <a:t>반복측정 분산분석(ANOVA)·대응 t-검정, 양측 α=0.05</a:t>
             </a:r>
           </a:p>
           <a:p xmlns:a="http://schemas.openxmlformats.org/drawingml/2006/main">
             <a:pPr algn="l">
-              <a:buNone/>
               <a:defRPr sz="1800" b="1">
                 <a:solidFill>
                   <a:srgbClr val="24324A"/>
@@ -11181,7 +11049,7 @@
           <p:cNvPr id="49" name="">
             <a:extLst xmlns:a="http://schemas.openxmlformats.org/drawingml/2006/main">
               <a:ext uri="{FF2B5EF4-FFF2-40B4-BE49-F238E27FC236}">
-                <a16:creationId xmlns:a16="http://schemas.microsoft.com/office/drawing/2014/main" id="{E4F4DA52-820D-49E7-B186-4E0A7462F275}"/>
+                <a16:creationId xmlns:a16="http://schemas.microsoft.com/office/drawing/2014/main" id="{C0DECB3A-6188-4E31-BD60-0B3F9566883B}"/>
               </a:ext>
             </a:extLst>
           </p:cNvPr>
@@ -11212,7 +11080,7 @@
           <p:cNvPr id="50" name="05 조합별 결과와 통계 검정">
             <a:extLst xmlns:a="http://schemas.openxmlformats.org/drawingml/2006/main">
               <a:ext uri="{FF2B5EF4-FFF2-40B4-BE49-F238E27FC236}">
-                <a16:creationId xmlns:a16="http://schemas.microsoft.com/office/drawing/2014/main" id="{C76AF8FD-FE50-4762-BE8A-5D7CBBD1C539}"/>
+                <a16:creationId xmlns:a16="http://schemas.microsoft.com/office/drawing/2014/main" id="{10E30CC0-BFAE-4E54-B4F7-8FEA81626F19}"/>
               </a:ext>
             </a:extLst>
           </p:cNvPr>
@@ -11342,7 +11210,6 @@
           </a:lstStyle>
           <a:p xmlns:a="http://schemas.openxmlformats.org/drawingml/2006/main">
             <a:pPr algn="l">
-              <a:buNone/>
               <a:defRPr sz="2400" b="0">
                 <a:solidFill>
                   <a:srgbClr val="FFFFFF"/>
@@ -11371,7 +11238,7 @@
           <p:cNvPr id="51" name="HyDE·CAD·SCD 8조합의 품질·한국어 비율·시간 평균(SD)">
             <a:extLst xmlns:a="http://schemas.openxmlformats.org/drawingml/2006/main">
               <a:ext uri="{FF2B5EF4-FFF2-40B4-BE49-F238E27FC236}">
-                <a16:creationId xmlns:a16="http://schemas.microsoft.com/office/drawing/2014/main" id="{CB9973BD-C0E3-46E0-BB5C-726B7151E099}"/>
+                <a16:creationId xmlns:a16="http://schemas.microsoft.com/office/drawing/2014/main" id="{655E4F36-D737-408F-9826-78E163897E75}"/>
               </a:ext>
             </a:extLst>
           </p:cNvPr>
@@ -11501,7 +11368,6 @@
           </a:lstStyle>
           <a:p xmlns:a="http://schemas.openxmlformats.org/drawingml/2006/main">
             <a:pPr algn="l">
-              <a:buNone/>
               <a:defRPr sz="1800" b="1">
                 <a:solidFill>
                   <a:srgbClr val="24324A"/>
@@ -11530,7 +11396,7 @@
           <p:cNvPr id="52" name="">
             <a:extLst xmlns:a="http://schemas.openxmlformats.org/drawingml/2006/main">
               <a:ext uri="{FF2B5EF4-FFF2-40B4-BE49-F238E27FC236}">
-                <a16:creationId xmlns:a16="http://schemas.microsoft.com/office/drawing/2014/main" id="{5E562212-B51C-472A-92F9-3520A6B1D575}"/>
+                <a16:creationId xmlns:a16="http://schemas.microsoft.com/office/drawing/2014/main" id="{DAD4AA4A-2792-42EE-A0DE-B53ABDFF1205}"/>
               </a:ext>
             </a:extLst>
           </p:cNvPr>
@@ -11562,9 +11428,7 @@
                     </a:bodyPr>
                     <a:lstStyle/>
                     <a:p>
-                      <a:pPr algn="ctr">
-                        <a:buNone/>
-                      </a:pPr>
+                      <a:pPr algn="ctr"/>
                       <a:r>
                         <a:rPr sz="1800" b="1">
                           <a:solidFill>
@@ -11615,9 +11479,7 @@
                     </a:bodyPr>
                     <a:lstStyle/>
                     <a:p>
-                      <a:pPr algn="ctr">
-                        <a:buNone/>
-                      </a:pPr>
+                      <a:pPr algn="ctr"/>
                       <a:r>
                         <a:rPr sz="1800" b="1">
                           <a:solidFill>
@@ -11631,9 +11493,7 @@
                       </a:r>
                     </a:p>
                     <a:p>
-                      <a:pPr algn="ctr">
-                        <a:buNone/>
-                      </a:pPr>
+                      <a:pPr algn="ctr"/>
                       <a:r>
                         <a:rPr sz="1800" b="1">
                           <a:solidFill>
@@ -11678,9 +11538,7 @@
                     </a:bodyPr>
                     <a:lstStyle/>
                     <a:p>
-                      <a:pPr algn="ctr">
-                        <a:buNone/>
-                      </a:pPr>
+                      <a:pPr algn="ctr"/>
                       <a:r>
                         <a:rPr sz="1800" b="1">
                           <a:solidFill>
@@ -11694,9 +11552,7 @@
                       </a:r>
                     </a:p>
                     <a:p>
-                      <a:pPr algn="ctr">
-                        <a:buNone/>
-                      </a:pPr>
+                      <a:pPr algn="ctr"/>
                       <a:r>
                         <a:rPr sz="1800" b="1">
                           <a:solidFill>
@@ -11741,9 +11597,7 @@
                     </a:bodyPr>
                     <a:lstStyle/>
                     <a:p>
-                      <a:pPr algn="ctr">
-                        <a:buNone/>
-                      </a:pPr>
+                      <a:pPr algn="ctr"/>
                       <a:r>
                         <a:rPr sz="1800" b="1">
                           <a:solidFill>
@@ -11757,9 +11611,7 @@
                       </a:r>
                     </a:p>
                     <a:p>
-                      <a:pPr algn="ctr">
-                        <a:buNone/>
-                      </a:pPr>
+                      <a:pPr algn="ctr"/>
                       <a:r>
                         <a:rPr sz="1800" b="1">
                           <a:solidFill>
@@ -11804,9 +11656,7 @@
                     </a:bodyPr>
                     <a:lstStyle/>
                     <a:p>
-                      <a:pPr algn="ctr">
-                        <a:buNone/>
-                      </a:pPr>
+                      <a:pPr algn="ctr"/>
                       <a:r>
                         <a:rPr sz="1800" b="1">
                           <a:solidFill>
@@ -11820,9 +11670,7 @@
                       </a:r>
                     </a:p>
                     <a:p>
-                      <a:pPr algn="ctr">
-                        <a:buNone/>
-                      </a:pPr>
+                      <a:pPr algn="ctr"/>
                       <a:r>
                         <a:rPr sz="1800" b="1">
                           <a:solidFill>
@@ -11867,9 +11715,7 @@
                     </a:bodyPr>
                     <a:lstStyle/>
                     <a:p>
-                      <a:pPr algn="ctr">
-                        <a:buNone/>
-                      </a:pPr>
+                      <a:pPr algn="ctr"/>
                       <a:r>
                         <a:rPr sz="1800" b="1">
                           <a:solidFill>
@@ -11883,9 +11729,7 @@
                       </a:r>
                     </a:p>
                     <a:p>
-                      <a:pPr algn="ctr">
-                        <a:buNone/>
-                      </a:pPr>
+                      <a:pPr algn="ctr"/>
                       <a:r>
                         <a:rPr sz="1800" b="1">
                           <a:solidFill>
@@ -11930,9 +11774,7 @@
                     </a:bodyPr>
                     <a:lstStyle/>
                     <a:p>
-                      <a:pPr algn="ctr">
-                        <a:buNone/>
-                      </a:pPr>
+                      <a:pPr algn="ctr"/>
                       <a:r>
                         <a:rPr sz="1800" b="1">
                           <a:solidFill>
@@ -11946,9 +11788,7 @@
                       </a:r>
                     </a:p>
                     <a:p>
-                      <a:pPr algn="ctr">
-                        <a:buNone/>
-                      </a:pPr>
+                      <a:pPr algn="ctr"/>
                       <a:r>
                         <a:rPr sz="1800" b="1">
                           <a:solidFill>
@@ -11995,9 +11835,7 @@
                     </a:bodyPr>
                     <a:lstStyle/>
                     <a:p>
-                      <a:pPr algn="ctr">
-                        <a:buNone/>
-                      </a:pPr>
+                      <a:pPr algn="ctr"/>
                       <a:r>
                         <a:rPr sz="1800" b="0">
                           <a:solidFill>
@@ -12042,9 +11880,7 @@
                     </a:bodyPr>
                     <a:lstStyle/>
                     <a:p>
-                      <a:pPr algn="r">
-                        <a:buNone/>
-                      </a:pPr>
+                      <a:pPr algn="r"/>
                       <a:r>
                         <a:rPr sz="1800" b="0">
                           <a:solidFill>
@@ -12058,9 +11894,7 @@
                       </a:r>
                     </a:p>
                     <a:p>
-                      <a:pPr algn="r">
-                        <a:buNone/>
-                      </a:pPr>
+                      <a:pPr algn="r"/>
                       <a:r>
                         <a:rPr sz="1800" b="0">
                           <a:solidFill>
@@ -12099,9 +11933,7 @@
                     </a:bodyPr>
                     <a:lstStyle/>
                     <a:p>
-                      <a:pPr algn="r">
-                        <a:buNone/>
-                      </a:pPr>
+                      <a:pPr algn="r"/>
                       <a:r>
                         <a:rPr sz="1800" b="0">
                           <a:solidFill>
@@ -12115,9 +11947,7 @@
                       </a:r>
                     </a:p>
                     <a:p>
-                      <a:pPr algn="r">
-                        <a:buNone/>
-                      </a:pPr>
+                      <a:pPr algn="r"/>
                       <a:r>
                         <a:rPr sz="1800" b="0">
                           <a:solidFill>
@@ -12156,9 +11986,7 @@
                     </a:bodyPr>
                     <a:lstStyle/>
                     <a:p>
-                      <a:pPr algn="r">
-                        <a:buNone/>
-                      </a:pPr>
+                      <a:pPr algn="r"/>
                       <a:r>
                         <a:rPr sz="1800" b="0">
                           <a:solidFill>
@@ -12172,9 +12000,7 @@
                       </a:r>
                     </a:p>
                     <a:p>
-                      <a:pPr algn="r">
-                        <a:buNone/>
-                      </a:pPr>
+                      <a:pPr algn="r"/>
                       <a:r>
                         <a:rPr sz="1800" b="0">
                           <a:solidFill>
@@ -12213,9 +12039,7 @@
                     </a:bodyPr>
                     <a:lstStyle/>
                     <a:p>
-                      <a:pPr algn="r">
-                        <a:buNone/>
-                      </a:pPr>
+                      <a:pPr algn="r"/>
                       <a:r>
                         <a:rPr sz="1800" b="0">
                           <a:solidFill>
@@ -12229,9 +12053,7 @@
                       </a:r>
                     </a:p>
                     <a:p>
-                      <a:pPr algn="r">
-                        <a:buNone/>
-                      </a:pPr>
+                      <a:pPr algn="r"/>
                       <a:r>
                         <a:rPr sz="1800" b="0">
                           <a:solidFill>
@@ -12270,9 +12092,7 @@
                     </a:bodyPr>
                     <a:lstStyle/>
                     <a:p>
-                      <a:pPr algn="r">
-                        <a:buNone/>
-                      </a:pPr>
+                      <a:pPr algn="r"/>
                       <a:r>
                         <a:rPr sz="1800" b="0">
                           <a:solidFill>
@@ -12286,9 +12106,7 @@
                       </a:r>
                     </a:p>
                     <a:p>
-                      <a:pPr algn="r">
-                        <a:buNone/>
-                      </a:pPr>
+                      <a:pPr algn="r"/>
                       <a:r>
                         <a:rPr sz="1800" b="0">
                           <a:solidFill>
@@ -12327,9 +12145,7 @@
                     </a:bodyPr>
                     <a:lstStyle/>
                     <a:p>
-                      <a:pPr algn="r">
-                        <a:buNone/>
-                      </a:pPr>
+                      <a:pPr algn="r"/>
                       <a:r>
                         <a:rPr sz="1800" b="0">
                           <a:solidFill>
@@ -12343,9 +12159,7 @@
                       </a:r>
                     </a:p>
                     <a:p>
-                      <a:pPr algn="r">
-                        <a:buNone/>
-                      </a:pPr>
+                      <a:pPr algn="r"/>
                       <a:r>
                         <a:rPr sz="1800" b="0">
                           <a:solidFill>
@@ -12386,9 +12200,7 @@
                     </a:bodyPr>
                     <a:lstStyle/>
                     <a:p>
-                      <a:pPr algn="ctr">
-                        <a:buNone/>
-                      </a:pPr>
+                      <a:pPr algn="ctr"/>
                       <a:r>
                         <a:rPr sz="1800" b="0">
                           <a:solidFill>
@@ -12433,9 +12245,7 @@
                     </a:bodyPr>
                     <a:lstStyle/>
                     <a:p>
-                      <a:pPr algn="r">
-                        <a:buNone/>
-                      </a:pPr>
+                      <a:pPr algn="r"/>
                       <a:r>
                         <a:rPr sz="1800" b="0">
                           <a:solidFill>
@@ -12449,9 +12259,7 @@
                       </a:r>
                     </a:p>
                     <a:p>
-                      <a:pPr algn="r">
-                        <a:buNone/>
-                      </a:pPr>
+                      <a:pPr algn="r"/>
                       <a:r>
                         <a:rPr sz="1800" b="0">
                           <a:solidFill>
@@ -12490,9 +12298,7 @@
                     </a:bodyPr>
                     <a:lstStyle/>
                     <a:p>
-                      <a:pPr algn="r">
-                        <a:buNone/>
-                      </a:pPr>
+                      <a:pPr algn="r"/>
                       <a:r>
                         <a:rPr sz="1800" b="0">
                           <a:solidFill>
@@ -12506,9 +12312,7 @@
                       </a:r>
                     </a:p>
                     <a:p>
-                      <a:pPr algn="r">
-                        <a:buNone/>
-                      </a:pPr>
+                      <a:pPr algn="r"/>
                       <a:r>
                         <a:rPr sz="1800" b="0">
                           <a:solidFill>
@@ -12547,9 +12351,7 @@
                     </a:bodyPr>
                     <a:lstStyle/>
                     <a:p>
-                      <a:pPr algn="r">
-                        <a:buNone/>
-                      </a:pPr>
+                      <a:pPr algn="r"/>
                       <a:r>
                         <a:rPr sz="1800" b="0">
                           <a:solidFill>
@@ -12563,9 +12365,7 @@
                       </a:r>
                     </a:p>
                     <a:p>
-                      <a:pPr algn="r">
-                        <a:buNone/>
-                      </a:pPr>
+                      <a:pPr algn="r"/>
                       <a:r>
                         <a:rPr sz="1800" b="0">
                           <a:solidFill>
@@ -12604,9 +12404,7 @@
                     </a:bodyPr>
                     <a:lstStyle/>
                     <a:p>
-                      <a:pPr algn="r">
-                        <a:buNone/>
-                      </a:pPr>
+                      <a:pPr algn="r"/>
                       <a:r>
                         <a:rPr sz="1800" b="0">
                           <a:solidFill>
@@ -12620,9 +12418,7 @@
                       </a:r>
                     </a:p>
                     <a:p>
-                      <a:pPr algn="r">
-                        <a:buNone/>
-                      </a:pPr>
+                      <a:pPr algn="r"/>
                       <a:r>
                         <a:rPr sz="1800" b="0">
                           <a:solidFill>
@@ -12661,9 +12457,7 @@
                     </a:bodyPr>
                     <a:lstStyle/>
                     <a:p>
-                      <a:pPr algn="r">
-                        <a:buNone/>
-                      </a:pPr>
+                      <a:pPr algn="r"/>
                       <a:r>
                         <a:rPr sz="1800" b="0">
                           <a:solidFill>
@@ -12677,9 +12471,7 @@
                       </a:r>
                     </a:p>
                     <a:p>
-                      <a:pPr algn="r">
-                        <a:buNone/>
-                      </a:pPr>
+                      <a:pPr algn="r"/>
                       <a:r>
                         <a:rPr sz="1800" b="0">
                           <a:solidFill>
@@ -12718,9 +12510,7 @@
                     </a:bodyPr>
                     <a:lstStyle/>
                     <a:p>
-                      <a:pPr algn="r">
-                        <a:buNone/>
-                      </a:pPr>
+                      <a:pPr algn="r"/>
                       <a:r>
                         <a:rPr sz="1800" b="0">
                           <a:solidFill>
@@ -12734,9 +12524,7 @@
                       </a:r>
                     </a:p>
                     <a:p>
-                      <a:pPr algn="r">
-                        <a:buNone/>
-                      </a:pPr>
+                      <a:pPr algn="r"/>
                       <a:r>
                         <a:rPr sz="1800" b="0">
                           <a:solidFill>
@@ -12777,9 +12565,7 @@
                     </a:bodyPr>
                     <a:lstStyle/>
                     <a:p>
-                      <a:pPr algn="ctr">
-                        <a:buNone/>
-                      </a:pPr>
+                      <a:pPr algn="ctr"/>
                       <a:r>
                         <a:rPr sz="1800" b="0">
                           <a:solidFill>
@@ -12824,9 +12610,7 @@
                     </a:bodyPr>
                     <a:lstStyle/>
                     <a:p>
-                      <a:pPr algn="r">
-                        <a:buNone/>
-                      </a:pPr>
+                      <a:pPr algn="r"/>
                       <a:r>
                         <a:rPr sz="1800" b="0">
                           <a:solidFill>
@@ -12840,9 +12624,7 @@
                       </a:r>
                     </a:p>
                     <a:p>
-                      <a:pPr algn="r">
-                        <a:buNone/>
-                      </a:pPr>
+                      <a:pPr algn="r"/>
                       <a:r>
                         <a:rPr sz="1800" b="0">
                           <a:solidFill>
@@ -12881,9 +12663,7 @@
                     </a:bodyPr>
                     <a:lstStyle/>
                     <a:p>
-                      <a:pPr algn="r">
-                        <a:buNone/>
-                      </a:pPr>
+                      <a:pPr algn="r"/>
                       <a:r>
                         <a:rPr sz="1800" b="0">
                           <a:solidFill>
@@ -12897,9 +12677,7 @@
                       </a:r>
                     </a:p>
                     <a:p>
-                      <a:pPr algn="r">
-                        <a:buNone/>
-                      </a:pPr>
+                      <a:pPr algn="r"/>
                       <a:r>
                         <a:rPr sz="1800" b="0">
                           <a:solidFill>
@@ -12938,9 +12716,7 @@
                     </a:bodyPr>
                     <a:lstStyle/>
                     <a:p>
-                      <a:pPr algn="r">
-                        <a:buNone/>
-                      </a:pPr>
+                      <a:pPr algn="r"/>
                       <a:r>
                         <a:rPr sz="1800" b="0">
                           <a:solidFill>
@@ -12954,9 +12730,7 @@
                       </a:r>
                     </a:p>
                     <a:p>
-                      <a:pPr algn="r">
-                        <a:buNone/>
-                      </a:pPr>
+                      <a:pPr algn="r"/>
                       <a:r>
                         <a:rPr sz="1800" b="0">
                           <a:solidFill>
@@ -12995,9 +12769,7 @@
                     </a:bodyPr>
                     <a:lstStyle/>
                     <a:p>
-                      <a:pPr algn="r">
-                        <a:buNone/>
-                      </a:pPr>
+                      <a:pPr algn="r"/>
                       <a:r>
                         <a:rPr sz="1800" b="0">
                           <a:solidFill>
@@ -13011,9 +12783,7 @@
                       </a:r>
                     </a:p>
                     <a:p>
-                      <a:pPr algn="r">
-                        <a:buNone/>
-                      </a:pPr>
+                      <a:pPr algn="r"/>
                       <a:r>
                         <a:rPr sz="1800" b="0">
                           <a:solidFill>
@@ -13052,9 +12822,7 @@
                     </a:bodyPr>
                     <a:lstStyle/>
                     <a:p>
-                      <a:pPr algn="r">
-                        <a:buNone/>
-                      </a:pPr>
+                      <a:pPr algn="r"/>
                       <a:r>
                         <a:rPr sz="1800" b="0">
                           <a:solidFill>
@@ -13068,9 +12836,7 @@
                       </a:r>
                     </a:p>
                     <a:p>
-                      <a:pPr algn="r">
-                        <a:buNone/>
-                      </a:pPr>
+                      <a:pPr algn="r"/>
                       <a:r>
                         <a:rPr sz="1800" b="0">
                           <a:solidFill>
@@ -13109,9 +12875,7 @@
                     </a:bodyPr>
                     <a:lstStyle/>
                     <a:p>
-                      <a:pPr algn="r">
-                        <a:buNone/>
-                      </a:pPr>
+                      <a:pPr algn="r"/>
                       <a:r>
                         <a:rPr sz="1800" b="0">
                           <a:solidFill>
@@ -13125,9 +12889,7 @@
                       </a:r>
                     </a:p>
                     <a:p>
-                      <a:pPr algn="r">
-                        <a:buNone/>
-                      </a:pPr>
+                      <a:pPr algn="r"/>
                       <a:r>
                         <a:rPr sz="1800" b="0">
                           <a:solidFill>
@@ -13168,9 +12930,7 @@
                     </a:bodyPr>
                     <a:lstStyle/>
                     <a:p>
-                      <a:pPr algn="ctr">
-                        <a:buNone/>
-                      </a:pPr>
+                      <a:pPr algn="ctr"/>
                       <a:r>
                         <a:rPr sz="1800" b="0">
                           <a:solidFill>
@@ -13215,9 +12975,7 @@
                     </a:bodyPr>
                     <a:lstStyle/>
                     <a:p>
-                      <a:pPr algn="r">
-                        <a:buNone/>
-                      </a:pPr>
+                      <a:pPr algn="r"/>
                       <a:r>
                         <a:rPr sz="1800" b="0">
                           <a:solidFill>
@@ -13231,9 +12989,7 @@
                       </a:r>
                     </a:p>
                     <a:p>
-                      <a:pPr algn="r">
-                        <a:buNone/>
-                      </a:pPr>
+                      <a:pPr algn="r"/>
                       <a:r>
                         <a:rPr sz="1800" b="0">
                           <a:solidFill>
@@ -13272,9 +13028,7 @@
                     </a:bodyPr>
                     <a:lstStyle/>
                     <a:p>
-                      <a:pPr algn="r">
-                        <a:buNone/>
-                      </a:pPr>
+                      <a:pPr algn="r"/>
                       <a:r>
                         <a:rPr sz="1800" b="0">
                           <a:solidFill>
@@ -13288,9 +13042,7 @@
                       </a:r>
                     </a:p>
                     <a:p>
-                      <a:pPr algn="r">
-                        <a:buNone/>
-                      </a:pPr>
+                      <a:pPr algn="r"/>
                       <a:r>
                         <a:rPr sz="1800" b="0">
                           <a:solidFill>
@@ -13329,9 +13081,7 @@
                     </a:bodyPr>
                     <a:lstStyle/>
                     <a:p>
-                      <a:pPr algn="r">
-                        <a:buNone/>
-                      </a:pPr>
+                      <a:pPr algn="r"/>
                       <a:r>
                         <a:rPr sz="1800" b="0">
                           <a:solidFill>
@@ -13345,9 +13095,7 @@
                       </a:r>
                     </a:p>
                     <a:p>
-                      <a:pPr algn="r">
-                        <a:buNone/>
-                      </a:pPr>
+                      <a:pPr algn="r"/>
                       <a:r>
                         <a:rPr sz="1800" b="0">
                           <a:solidFill>
@@ -13386,9 +13134,7 @@
                     </a:bodyPr>
                     <a:lstStyle/>
                     <a:p>
-                      <a:pPr algn="r">
-                        <a:buNone/>
-                      </a:pPr>
+                      <a:pPr algn="r"/>
                       <a:r>
                         <a:rPr sz="1800" b="0">
                           <a:solidFill>
@@ -13402,9 +13148,7 @@
                       </a:r>
                     </a:p>
                     <a:p>
-                      <a:pPr algn="r">
-                        <a:buNone/>
-                      </a:pPr>
+                      <a:pPr algn="r"/>
                       <a:r>
                         <a:rPr sz="1800" b="0">
                           <a:solidFill>
@@ -13443,9 +13187,7 @@
                     </a:bodyPr>
                     <a:lstStyle/>
                     <a:p>
-                      <a:pPr algn="r">
-                        <a:buNone/>
-                      </a:pPr>
+                      <a:pPr algn="r"/>
                       <a:r>
                         <a:rPr sz="1800" b="0">
                           <a:solidFill>
@@ -13459,9 +13201,7 @@
                       </a:r>
                     </a:p>
                     <a:p>
-                      <a:pPr algn="r">
-                        <a:buNone/>
-                      </a:pPr>
+                      <a:pPr algn="r"/>
                       <a:r>
                         <a:rPr sz="1800" b="0">
                           <a:solidFill>
@@ -13500,9 +13240,7 @@
                     </a:bodyPr>
                     <a:lstStyle/>
                     <a:p>
-                      <a:pPr algn="r">
-                        <a:buNone/>
-                      </a:pPr>
+                      <a:pPr algn="r"/>
                       <a:r>
                         <a:rPr sz="1800" b="0">
                           <a:solidFill>
@@ -13516,9 +13254,7 @@
                       </a:r>
                     </a:p>
                     <a:p>
-                      <a:pPr algn="r">
-                        <a:buNone/>
-                      </a:pPr>
+                      <a:pPr algn="r"/>
                       <a:r>
                         <a:rPr sz="1800" b="0">
                           <a:solidFill>
@@ -13559,9 +13295,7 @@
                     </a:bodyPr>
                     <a:lstStyle/>
                     <a:p>
-                      <a:pPr algn="ctr">
-                        <a:buNone/>
-                      </a:pPr>
+                      <a:pPr algn="ctr"/>
                       <a:r>
                         <a:rPr sz="1800" b="0">
                           <a:solidFill>
@@ -13606,9 +13340,7 @@
                     </a:bodyPr>
                     <a:lstStyle/>
                     <a:p>
-                      <a:pPr algn="r">
-                        <a:buNone/>
-                      </a:pPr>
+                      <a:pPr algn="r"/>
                       <a:r>
                         <a:rPr sz="1800" b="0">
                           <a:solidFill>
@@ -13622,9 +13354,7 @@
                       </a:r>
                     </a:p>
                     <a:p>
-                      <a:pPr algn="r">
-                        <a:buNone/>
-                      </a:pPr>
+                      <a:pPr algn="r"/>
                       <a:r>
                         <a:rPr sz="1800" b="0">
                           <a:solidFill>
@@ -13663,9 +13393,7 @@
                     </a:bodyPr>
                     <a:lstStyle/>
                     <a:p>
-                      <a:pPr algn="r">
-                        <a:buNone/>
-                      </a:pPr>
+                      <a:pPr algn="r"/>
                       <a:r>
                         <a:rPr sz="1800" b="0">
                           <a:solidFill>
@@ -13679,9 +13407,7 @@
                       </a:r>
                     </a:p>
                     <a:p>
-                      <a:pPr algn="r">
-                        <a:buNone/>
-                      </a:pPr>
+                      <a:pPr algn="r"/>
                       <a:r>
                         <a:rPr sz="1800" b="0">
                           <a:solidFill>
@@ -13720,9 +13446,7 @@
                     </a:bodyPr>
                     <a:lstStyle/>
                     <a:p>
-                      <a:pPr algn="r">
-                        <a:buNone/>
-                      </a:pPr>
+                      <a:pPr algn="r"/>
                       <a:r>
                         <a:rPr sz="1800" b="0">
                           <a:solidFill>
@@ -13736,9 +13460,7 @@
                       </a:r>
                     </a:p>
                     <a:p>
-                      <a:pPr algn="r">
-                        <a:buNone/>
-                      </a:pPr>
+                      <a:pPr algn="r"/>
                       <a:r>
                         <a:rPr sz="1800" b="0">
                           <a:solidFill>
@@ -13777,9 +13499,7 @@
                     </a:bodyPr>
                     <a:lstStyle/>
                     <a:p>
-                      <a:pPr algn="r">
-                        <a:buNone/>
-                      </a:pPr>
+                      <a:pPr algn="r"/>
                       <a:r>
                         <a:rPr sz="1800" b="0">
                           <a:solidFill>
@@ -13793,9 +13513,7 @@
                       </a:r>
                     </a:p>
                     <a:p>
-                      <a:pPr algn="r">
-                        <a:buNone/>
-                      </a:pPr>
+                      <a:pPr algn="r"/>
                       <a:r>
                         <a:rPr sz="1800" b="0">
                           <a:solidFill>
@@ -13834,9 +13552,7 @@
                     </a:bodyPr>
                     <a:lstStyle/>
                     <a:p>
-                      <a:pPr algn="r">
-                        <a:buNone/>
-                      </a:pPr>
+                      <a:pPr algn="r"/>
                       <a:r>
                         <a:rPr sz="1800" b="0">
                           <a:solidFill>
@@ -13850,9 +13566,7 @@
                       </a:r>
                     </a:p>
                     <a:p>
-                      <a:pPr algn="r">
-                        <a:buNone/>
-                      </a:pPr>
+                      <a:pPr algn="r"/>
                       <a:r>
                         <a:rPr sz="1800" b="0">
                           <a:solidFill>
@@ -13891,9 +13605,7 @@
                     </a:bodyPr>
                     <a:lstStyle/>
                     <a:p>
-                      <a:pPr algn="r">
-                        <a:buNone/>
-                      </a:pPr>
+                      <a:pPr algn="r"/>
                       <a:r>
                         <a:rPr sz="1800" b="0">
                           <a:solidFill>
@@ -13907,9 +13619,7 @@
                       </a:r>
                     </a:p>
                     <a:p>
-                      <a:pPr algn="r">
-                        <a:buNone/>
-                      </a:pPr>
+                      <a:pPr algn="r"/>
                       <a:r>
                         <a:rPr sz="1800" b="0">
                           <a:solidFill>
@@ -13950,9 +13660,7 @@
                     </a:bodyPr>
                     <a:lstStyle/>
                     <a:p>
-                      <a:pPr algn="ctr">
-                        <a:buNone/>
-                      </a:pPr>
+                      <a:pPr algn="ctr"/>
                       <a:r>
                         <a:rPr sz="1800" b="0">
                           <a:solidFill>
@@ -13997,9 +13705,7 @@
                     </a:bodyPr>
                     <a:lstStyle/>
                     <a:p>
-                      <a:pPr algn="r">
-                        <a:buNone/>
-                      </a:pPr>
+                      <a:pPr algn="r"/>
                       <a:r>
                         <a:rPr sz="1800" b="0">
                           <a:solidFill>
@@ -14013,9 +13719,7 @@
                       </a:r>
                     </a:p>
                     <a:p>
-                      <a:pPr algn="r">
-                        <a:buNone/>
-                      </a:pPr>
+                      <a:pPr algn="r"/>
                       <a:r>
                         <a:rPr sz="1800" b="0">
                           <a:solidFill>
@@ -14054,9 +13758,7 @@
                     </a:bodyPr>
                     <a:lstStyle/>
                     <a:p>
-                      <a:pPr algn="r">
-                        <a:buNone/>
-                      </a:pPr>
+                      <a:pPr algn="r"/>
                       <a:r>
                         <a:rPr sz="1800" b="0">
                           <a:solidFill>
@@ -14070,9 +13772,7 @@
                       </a:r>
                     </a:p>
                     <a:p>
-                      <a:pPr algn="r">
-                        <a:buNone/>
-                      </a:pPr>
+                      <a:pPr algn="r"/>
                       <a:r>
                         <a:rPr sz="1800" b="0">
                           <a:solidFill>
@@ -14111,9 +13811,7 @@
                     </a:bodyPr>
                     <a:lstStyle/>
                     <a:p>
-                      <a:pPr algn="r">
-                        <a:buNone/>
-                      </a:pPr>
+                      <a:pPr algn="r"/>
                       <a:r>
                         <a:rPr sz="1800" b="0">
                           <a:solidFill>
@@ -14127,9 +13825,7 @@
                       </a:r>
                     </a:p>
                     <a:p>
-                      <a:pPr algn="r">
-                        <a:buNone/>
-                      </a:pPr>
+                      <a:pPr algn="r"/>
                       <a:r>
                         <a:rPr sz="1800" b="0">
                           <a:solidFill>
@@ -14168,9 +13864,7 @@
                     </a:bodyPr>
                     <a:lstStyle/>
                     <a:p>
-                      <a:pPr algn="r">
-                        <a:buNone/>
-                      </a:pPr>
+                      <a:pPr algn="r"/>
                       <a:r>
                         <a:rPr sz="1800" b="0">
                           <a:solidFill>
@@ -14184,9 +13878,7 @@
                       </a:r>
                     </a:p>
                     <a:p>
-                      <a:pPr algn="r">
-                        <a:buNone/>
-                      </a:pPr>
+                      <a:pPr algn="r"/>
                       <a:r>
                         <a:rPr sz="1800" b="0">
                           <a:solidFill>
@@ -14225,9 +13917,7 @@
                     </a:bodyPr>
                     <a:lstStyle/>
                     <a:p>
-                      <a:pPr algn="r">
-                        <a:buNone/>
-                      </a:pPr>
+                      <a:pPr algn="r"/>
                       <a:r>
                         <a:rPr sz="1800" b="0">
                           <a:solidFill>
@@ -14241,9 +13931,7 @@
                       </a:r>
                     </a:p>
                     <a:p>
-                      <a:pPr algn="r">
-                        <a:buNone/>
-                      </a:pPr>
+                      <a:pPr algn="r"/>
                       <a:r>
                         <a:rPr sz="1800" b="0">
                           <a:solidFill>
@@ -14282,9 +13970,7 @@
                     </a:bodyPr>
                     <a:lstStyle/>
                     <a:p>
-                      <a:pPr algn="r">
-                        <a:buNone/>
-                      </a:pPr>
+                      <a:pPr algn="r"/>
                       <a:r>
                         <a:rPr sz="1800" b="0">
                           <a:solidFill>
@@ -14298,9 +13984,7 @@
                       </a:r>
                     </a:p>
                     <a:p>
-                      <a:pPr algn="r">
-                        <a:buNone/>
-                      </a:pPr>
+                      <a:pPr algn="r"/>
                       <a:r>
                         <a:rPr sz="1800" b="0">
                           <a:solidFill>
@@ -14341,9 +14025,7 @@
                     </a:bodyPr>
                     <a:lstStyle/>
                     <a:p>
-                      <a:pPr algn="ctr">
-                        <a:buNone/>
-                      </a:pPr>
+                      <a:pPr algn="ctr"/>
                       <a:r>
                         <a:rPr sz="1800" b="0">
                           <a:solidFill>
@@ -14388,9 +14070,7 @@
                     </a:bodyPr>
                     <a:lstStyle/>
                     <a:p>
-                      <a:pPr algn="r">
-                        <a:buNone/>
-                      </a:pPr>
+                      <a:pPr algn="r"/>
                       <a:r>
                         <a:rPr sz="1800" b="0">
                           <a:solidFill>
@@ -14404,9 +14084,7 @@
                       </a:r>
                     </a:p>
                     <a:p>
-                      <a:pPr algn="r">
-                        <a:buNone/>
-                      </a:pPr>
+                      <a:pPr algn="r"/>
                       <a:r>
                         <a:rPr sz="1800" b="0">
                           <a:solidFill>
@@ -14445,9 +14123,7 @@
                     </a:bodyPr>
                     <a:lstStyle/>
                     <a:p>
-                      <a:pPr algn="r">
-                        <a:buNone/>
-                      </a:pPr>
+                      <a:pPr algn="r"/>
                       <a:r>
                         <a:rPr sz="1800" b="0">
                           <a:solidFill>
@@ -14461,9 +14137,7 @@
                       </a:r>
                     </a:p>
                     <a:p>
-                      <a:pPr algn="r">
-                        <a:buNone/>
-                      </a:pPr>
+                      <a:pPr algn="r"/>
                       <a:r>
                         <a:rPr sz="1800" b="0">
                           <a:solidFill>
@@ -14502,9 +14176,7 @@
                     </a:bodyPr>
                     <a:lstStyle/>
                     <a:p>
-                      <a:pPr algn="r">
-                        <a:buNone/>
-                      </a:pPr>
+                      <a:pPr algn="r"/>
                       <a:r>
                         <a:rPr sz="1800" b="0">
                           <a:solidFill>
@@ -14518,9 +14190,7 @@
                       </a:r>
                     </a:p>
                     <a:p>
-                      <a:pPr algn="r">
-                        <a:buNone/>
-                      </a:pPr>
+                      <a:pPr algn="r"/>
                       <a:r>
                         <a:rPr sz="1800" b="0">
                           <a:solidFill>
@@ -14559,9 +14229,7 @@
                     </a:bodyPr>
                     <a:lstStyle/>
                     <a:p>
-                      <a:pPr algn="r">
-                        <a:buNone/>
-                      </a:pPr>
+                      <a:pPr algn="r"/>
                       <a:r>
                         <a:rPr sz="1800" b="0">
                           <a:solidFill>
@@ -14575,9 +14243,7 @@
                       </a:r>
                     </a:p>
                     <a:p>
-                      <a:pPr algn="r">
-                        <a:buNone/>
-                      </a:pPr>
+                      <a:pPr algn="r"/>
                       <a:r>
                         <a:rPr sz="1800" b="0">
                           <a:solidFill>
@@ -14616,9 +14282,7 @@
                     </a:bodyPr>
                     <a:lstStyle/>
                     <a:p>
-                      <a:pPr algn="r">
-                        <a:buNone/>
-                      </a:pPr>
+                      <a:pPr algn="r"/>
                       <a:r>
                         <a:rPr sz="1800" b="0">
                           <a:solidFill>
@@ -14632,9 +14296,7 @@
                       </a:r>
                     </a:p>
                     <a:p>
-                      <a:pPr algn="r">
-                        <a:buNone/>
-                      </a:pPr>
+                      <a:pPr algn="r"/>
                       <a:r>
                         <a:rPr sz="1800" b="0">
                           <a:solidFill>
@@ -14673,9 +14335,7 @@
                     </a:bodyPr>
                     <a:lstStyle/>
                     <a:p>
-                      <a:pPr algn="r">
-                        <a:buNone/>
-                      </a:pPr>
+                      <a:pPr algn="r"/>
                       <a:r>
                         <a:rPr sz="1800" b="0">
                           <a:solidFill>
@@ -14689,9 +14349,7 @@
                       </a:r>
                     </a:p>
                     <a:p>
-                      <a:pPr algn="r">
-                        <a:buNone/>
-                      </a:pPr>
+                      <a:pPr algn="r"/>
                       <a:r>
                         <a:rPr sz="1800" b="0">
                           <a:solidFill>
@@ -14732,9 +14390,7 @@
                     </a:bodyPr>
                     <a:lstStyle/>
                     <a:p>
-                      <a:pPr algn="ctr">
-                        <a:buNone/>
-                      </a:pPr>
+                      <a:pPr algn="ctr"/>
                       <a:r>
                         <a:rPr sz="1800" b="0">
                           <a:solidFill>
@@ -14779,9 +14435,7 @@
                     </a:bodyPr>
                     <a:lstStyle/>
                     <a:p>
-                      <a:pPr algn="r">
-                        <a:buNone/>
-                      </a:pPr>
+                      <a:pPr algn="r"/>
                       <a:r>
                         <a:rPr sz="1800" b="0">
                           <a:solidFill>
@@ -14795,9 +14449,7 @@
                       </a:r>
                     </a:p>
                     <a:p>
-                      <a:pPr algn="r">
-                        <a:buNone/>
-                      </a:pPr>
+                      <a:pPr algn="r"/>
                       <a:r>
                         <a:rPr sz="1800" b="0">
                           <a:solidFill>
@@ -14836,9 +14488,7 @@
                     </a:bodyPr>
                     <a:lstStyle/>
                     <a:p>
-                      <a:pPr algn="r">
-                        <a:buNone/>
-                      </a:pPr>
+                      <a:pPr algn="r"/>
                       <a:r>
                         <a:rPr sz="1800" b="0">
                           <a:solidFill>
@@ -14852,9 +14502,7 @@
                       </a:r>
                     </a:p>
                     <a:p>
-                      <a:pPr algn="r">
-                        <a:buNone/>
-                      </a:pPr>
+                      <a:pPr algn="r"/>
                       <a:r>
                         <a:rPr sz="1800" b="0">
                           <a:solidFill>
@@ -14893,9 +14541,7 @@
                     </a:bodyPr>
                     <a:lstStyle/>
                     <a:p>
-                      <a:pPr algn="r">
-                        <a:buNone/>
-                      </a:pPr>
+                      <a:pPr algn="r"/>
                       <a:r>
                         <a:rPr sz="1800" b="0">
                           <a:solidFill>
@@ -14909,9 +14555,7 @@
                       </a:r>
                     </a:p>
                     <a:p>
-                      <a:pPr algn="r">
-                        <a:buNone/>
-                      </a:pPr>
+                      <a:pPr algn="r"/>
                       <a:r>
                         <a:rPr sz="1800" b="0">
                           <a:solidFill>
@@ -14950,9 +14594,7 @@
                     </a:bodyPr>
                     <a:lstStyle/>
                     <a:p>
-                      <a:pPr algn="r">
-                        <a:buNone/>
-                      </a:pPr>
+                      <a:pPr algn="r"/>
                       <a:r>
                         <a:rPr sz="1800" b="0">
                           <a:solidFill>
@@ -14966,9 +14608,7 @@
                       </a:r>
                     </a:p>
                     <a:p>
-                      <a:pPr algn="r">
-                        <a:buNone/>
-                      </a:pPr>
+                      <a:pPr algn="r"/>
                       <a:r>
                         <a:rPr sz="1800" b="0">
                           <a:solidFill>
@@ -15007,9 +14647,7 @@
                     </a:bodyPr>
                     <a:lstStyle/>
                     <a:p>
-                      <a:pPr algn="r">
-                        <a:buNone/>
-                      </a:pPr>
+                      <a:pPr algn="r"/>
                       <a:r>
                         <a:rPr sz="1800" b="0">
                           <a:solidFill>
@@ -15023,9 +14661,7 @@
                       </a:r>
                     </a:p>
                     <a:p>
-                      <a:pPr algn="r">
-                        <a:buNone/>
-                      </a:pPr>
+                      <a:pPr algn="r"/>
                       <a:r>
                         <a:rPr sz="1800" b="0">
                           <a:solidFill>
@@ -15064,9 +14700,7 @@
                     </a:bodyPr>
                     <a:lstStyle/>
                     <a:p>
-                      <a:pPr algn="r">
-                        <a:buNone/>
-                      </a:pPr>
+                      <a:pPr algn="r"/>
                       <a:r>
                         <a:rPr sz="1800" b="0">
                           <a:solidFill>
@@ -15080,9 +14714,7 @@
                       </a:r>
                     </a:p>
                     <a:p>
-                      <a:pPr algn="r">
-                        <a:buNone/>
-                      </a:pPr>
+                      <a:pPr algn="r"/>
                       <a:r>
                         <a:rPr sz="1800" b="0">
                           <a:solidFill>
@@ -15124,7 +14756,7 @@
           <p:cNvPr id="53" name="">
             <a:extLst xmlns:a="http://schemas.openxmlformats.org/drawingml/2006/main">
               <a:ext uri="{FF2B5EF4-FFF2-40B4-BE49-F238E27FC236}">
-                <a16:creationId xmlns:a16="http://schemas.microsoft.com/office/drawing/2014/main" id="{C52C554D-C602-410A-8371-34F0B5FB4AE1}"/>
+                <a16:creationId xmlns:a16="http://schemas.microsoft.com/office/drawing/2014/main" id="{A7B2EBAA-010F-4F67-83E3-9FE8736C1110}"/>
               </a:ext>
             </a:extLst>
           </p:cNvPr>
@@ -15155,7 +14787,7 @@
           <p:cNvPr id="54" name="S0: 영어 평가 문맥 / S1: 한국어 번역 평가 문맥 충실도 H0C1S0 n=58, H0C0S1 n=57, 나머지">
             <a:extLst xmlns:a="http://schemas.openxmlformats.org/drawingml/2006/main">
               <a:ext uri="{FF2B5EF4-FFF2-40B4-BE49-F238E27FC236}">
-                <a16:creationId xmlns:a16="http://schemas.microsoft.com/office/drawing/2014/main" id="{7BE12E8B-7593-4B72-B74F-B80C1C612C4F}"/>
+                <a16:creationId xmlns:a16="http://schemas.microsoft.com/office/drawing/2014/main" id="{2FE0393A-2664-4404-87A4-A694170D9EE1}"/>
               </a:ext>
             </a:extLst>
           </p:cNvPr>
@@ -15285,7 +14917,6 @@
           </a:lstStyle>
           <a:p xmlns:a="http://schemas.openxmlformats.org/drawingml/2006/main">
             <a:pPr algn="l">
-              <a:buNone/>
               <a:defRPr sz="1800" b="0">
                 <a:solidFill>
                   <a:srgbClr val="24324A"/>
@@ -15309,7 +14940,6 @@
           </a:p>
           <a:p xmlns:a="http://schemas.openxmlformats.org/drawingml/2006/main">
             <a:pPr algn="l">
-              <a:buNone/>
               <a:defRPr sz="1800" b="0">
                 <a:solidFill>
                   <a:srgbClr val="24324A"/>
@@ -15333,7 +14963,6 @@
           </a:p>
           <a:p xmlns:a="http://schemas.openxmlformats.org/drawingml/2006/main">
             <a:pPr algn="l">
-              <a:buNone/>
               <a:defRPr sz="1800" b="0">
                 <a:solidFill>
                   <a:srgbClr val="24324A"/>
@@ -15362,7 +14991,7 @@
           <p:cNvPr id="55" name="3요인 반복측정 ANOVA  ·  각 효과 df=(1,59)">
             <a:extLst xmlns:a="http://schemas.openxmlformats.org/drawingml/2006/main">
               <a:ext uri="{FF2B5EF4-FFF2-40B4-BE49-F238E27FC236}">
-                <a16:creationId xmlns:a16="http://schemas.microsoft.com/office/drawing/2014/main" id="{5EC029FB-D198-4410-BF48-B4883A842D6A}"/>
+                <a16:creationId xmlns:a16="http://schemas.microsoft.com/office/drawing/2014/main" id="{3E7DB54C-853A-4AA0-A9B5-B7EE4AE0C88D}"/>
               </a:ext>
             </a:extLst>
           </p:cNvPr>
@@ -15492,7 +15121,6 @@
           </a:lstStyle>
           <a:p xmlns:a="http://schemas.openxmlformats.org/drawingml/2006/main">
             <a:pPr algn="l">
-              <a:buNone/>
               <a:defRPr sz="1800" b="1">
                 <a:solidFill>
                   <a:srgbClr val="24324A"/>
@@ -15521,7 +15149,7 @@
           <p:cNvPr id="56" name="">
             <a:extLst xmlns:a="http://schemas.openxmlformats.org/drawingml/2006/main">
               <a:ext uri="{FF2B5EF4-FFF2-40B4-BE49-F238E27FC236}">
-                <a16:creationId xmlns:a16="http://schemas.microsoft.com/office/drawing/2014/main" id="{01E93656-F1C1-486B-9527-17888CB09419}"/>
+                <a16:creationId xmlns:a16="http://schemas.microsoft.com/office/drawing/2014/main" id="{D2BDEE2A-C865-4BF3-A1F2-454795AB3EF0}"/>
               </a:ext>
             </a:extLst>
           </p:cNvPr>
@@ -15551,9 +15179,7 @@
                     </a:bodyPr>
                     <a:lstStyle/>
                     <a:p>
-                      <a:pPr algn="ctr">
-                        <a:buNone/>
-                      </a:pPr>
+                      <a:pPr algn="ctr"/>
                       <a:r>
                         <a:rPr sz="1800" b="1">
                           <a:solidFill>
@@ -15604,9 +15230,7 @@
                     </a:bodyPr>
                     <a:lstStyle/>
                     <a:p>
-                      <a:pPr algn="ctr">
-                        <a:buNone/>
-                      </a:pPr>
+                      <a:pPr algn="ctr"/>
                       <a:r>
                         <a:rPr sz="1800" b="1">
                           <a:solidFill>
@@ -15620,9 +15244,7 @@
                       </a:r>
                     </a:p>
                     <a:p>
-                      <a:pPr algn="ctr">
-                        <a:buNone/>
-                      </a:pPr>
+                      <a:pPr algn="ctr"/>
                       <a:r>
                         <a:rPr sz="1800" b="1">
                           <a:solidFill>
@@ -15667,9 +15289,7 @@
                     </a:bodyPr>
                     <a:lstStyle/>
                     <a:p>
-                      <a:pPr algn="ctr">
-                        <a:buNone/>
-                      </a:pPr>
+                      <a:pPr algn="ctr"/>
                       <a:r>
                         <a:rPr sz="1800" b="1">
                           <a:solidFill>
@@ -15679,7 +15299,7 @@
                           <a:ea typeface="Malgun Gothic"/>
                           <a:cs typeface="Malgun Gothic"/>
                         </a:rPr>
-                        <a:t>보정 p</a:t>
+                        <a:t>p</a:t>
                       </a:r>
                     </a:p>
                   </a:txBody>
@@ -15714,9 +15334,7 @@
                     </a:bodyPr>
                     <a:lstStyle/>
                     <a:p>
-                      <a:pPr algn="ctr">
-                        <a:buNone/>
-                      </a:pPr>
+                      <a:pPr algn="ctr"/>
                       <a:r>
                         <a:rPr sz="1800" b="1">
                           <a:solidFill>
@@ -15730,9 +15348,7 @@
                       </a:r>
                     </a:p>
                     <a:p>
-                      <a:pPr algn="ctr">
-                        <a:buNone/>
-                      </a:pPr>
+                      <a:pPr algn="ctr"/>
                       <a:r>
                         <a:rPr sz="1800" b="1">
                           <a:solidFill>
@@ -15777,9 +15393,7 @@
                     </a:bodyPr>
                     <a:lstStyle/>
                     <a:p>
-                      <a:pPr algn="ctr">
-                        <a:buNone/>
-                      </a:pPr>
+                      <a:pPr algn="ctr"/>
                       <a:r>
                         <a:rPr sz="1800" b="1">
                           <a:solidFill>
@@ -15789,7 +15403,7 @@
                           <a:ea typeface="Malgun Gothic"/>
                           <a:cs typeface="Malgun Gothic"/>
                         </a:rPr>
-                        <a:t>보정 p</a:t>
+                        <a:t>p</a:t>
                       </a:r>
                     </a:p>
                   </a:txBody>
@@ -15826,9 +15440,7 @@
                     </a:bodyPr>
                     <a:lstStyle/>
                     <a:p>
-                      <a:pPr algn="ctr">
-                        <a:buNone/>
-                      </a:pPr>
+                      <a:pPr algn="ctr"/>
                       <a:r>
                         <a:rPr sz="1800" b="0">
                           <a:solidFill>
@@ -15873,9 +15485,7 @@
                     </a:bodyPr>
                     <a:lstStyle/>
                     <a:p>
-                      <a:pPr algn="r">
-                        <a:buNone/>
-                      </a:pPr>
+                      <a:pPr algn="r"/>
                       <a:r>
                         <a:rPr sz="1800" b="0">
                           <a:solidFill>
@@ -15914,9 +15524,7 @@
                     </a:bodyPr>
                     <a:lstStyle/>
                     <a:p>
-                      <a:pPr algn="r">
-                        <a:buNone/>
-                      </a:pPr>
+                      <a:pPr algn="r"/>
                       <a:r>
                         <a:rPr sz="1800" b="0">
                           <a:solidFill>
@@ -15926,7 +15534,7 @@
                           <a:ea typeface="Malgun Gothic"/>
                           <a:cs typeface="Malgun Gothic"/>
                         </a:rPr>
-                        <a:t>0.370</a:t>
+                        <a:t>0.093</a:t>
                       </a:r>
                     </a:p>
                   </a:txBody>
@@ -15955,9 +15563,7 @@
                     </a:bodyPr>
                     <a:lstStyle/>
                     <a:p>
-                      <a:pPr algn="r">
-                        <a:buNone/>
-                      </a:pPr>
+                      <a:pPr algn="r"/>
                       <a:r>
                         <a:rPr sz="1800" b="0">
                           <a:solidFill>
@@ -15996,9 +15602,7 @@
                     </a:bodyPr>
                     <a:lstStyle/>
                     <a:p>
-                      <a:pPr algn="r">
-                        <a:buNone/>
-                      </a:pPr>
+                      <a:pPr algn="r"/>
                       <a:r>
                         <a:rPr sz="1800" b="0">
                           <a:solidFill>
@@ -16039,9 +15643,7 @@
                     </a:bodyPr>
                     <a:lstStyle/>
                     <a:p>
-                      <a:pPr algn="ctr">
-                        <a:buNone/>
-                      </a:pPr>
+                      <a:pPr algn="ctr"/>
                       <a:r>
                         <a:rPr sz="1800" b="0">
                           <a:solidFill>
@@ -16086,9 +15688,7 @@
                     </a:bodyPr>
                     <a:lstStyle/>
                     <a:p>
-                      <a:pPr algn="r">
-                        <a:buNone/>
-                      </a:pPr>
+                      <a:pPr algn="r"/>
                       <a:r>
                         <a:rPr sz="1800" b="0">
                           <a:solidFill>
@@ -16127,9 +15727,7 @@
                     </a:bodyPr>
                     <a:lstStyle/>
                     <a:p>
-                      <a:pPr algn="r">
-                        <a:buNone/>
-                      </a:pPr>
+                      <a:pPr algn="r"/>
                       <a:r>
                         <a:rPr sz="1800" b="0">
                           <a:solidFill>
@@ -16139,7 +15737,7 @@
                           <a:ea typeface="Malgun Gothic"/>
                           <a:cs typeface="Malgun Gothic"/>
                         </a:rPr>
-                        <a:t>0.358</a:t>
+                        <a:t>0.072</a:t>
                       </a:r>
                     </a:p>
                   </a:txBody>
@@ -16168,9 +15766,7 @@
                     </a:bodyPr>
                     <a:lstStyle/>
                     <a:p>
-                      <a:pPr algn="r">
-                        <a:buNone/>
-                      </a:pPr>
+                      <a:pPr algn="r"/>
                       <a:r>
                         <a:rPr sz="1800" b="0">
                           <a:solidFill>
@@ -16209,9 +15805,7 @@
                     </a:bodyPr>
                     <a:lstStyle/>
                     <a:p>
-                      <a:pPr algn="r">
-                        <a:buNone/>
-                      </a:pPr>
+                      <a:pPr algn="r"/>
                       <a:r>
                         <a:rPr sz="1800" b="0">
                           <a:solidFill>
@@ -16252,9 +15846,7 @@
                     </a:bodyPr>
                     <a:lstStyle/>
                     <a:p>
-                      <a:pPr algn="ctr">
-                        <a:buNone/>
-                      </a:pPr>
+                      <a:pPr algn="ctr"/>
                       <a:r>
                         <a:rPr sz="1800" b="0">
                           <a:solidFill>
@@ -16299,9 +15891,7 @@
                     </a:bodyPr>
                     <a:lstStyle/>
                     <a:p>
-                      <a:pPr algn="r">
-                        <a:buNone/>
-                      </a:pPr>
+                      <a:pPr algn="r"/>
                       <a:r>
                         <a:rPr sz="1800" b="0">
                           <a:solidFill>
@@ -16340,9 +15930,7 @@
                     </a:bodyPr>
                     <a:lstStyle/>
                     <a:p>
-                      <a:pPr algn="r">
-                        <a:buNone/>
-                      </a:pPr>
+                      <a:pPr algn="r"/>
                       <a:r>
                         <a:rPr sz="1800" b="0">
                           <a:solidFill>
@@ -16381,9 +15969,7 @@
                     </a:bodyPr>
                     <a:lstStyle/>
                     <a:p>
-                      <a:pPr algn="r">
-                        <a:buNone/>
-                      </a:pPr>
+                      <a:pPr algn="r"/>
                       <a:r>
                         <a:rPr sz="1800" b="0">
                           <a:solidFill>
@@ -16422,9 +16008,7 @@
                     </a:bodyPr>
                     <a:lstStyle/>
                     <a:p>
-                      <a:pPr algn="r">
-                        <a:buNone/>
-                      </a:pPr>
+                      <a:pPr algn="r"/>
                       <a:r>
                         <a:rPr sz="1800" b="0">
                           <a:solidFill>
@@ -16434,7 +16018,7 @@
                           <a:ea typeface="Malgun Gothic"/>
                           <a:cs typeface="Malgun Gothic"/>
                         </a:rPr>
-                        <a:t>0.066</a:t>
+                        <a:t>0.016</a:t>
                       </a:r>
                     </a:p>
                   </a:txBody>
@@ -16465,9 +16049,7 @@
                     </a:bodyPr>
                     <a:lstStyle/>
                     <a:p>
-                      <a:pPr algn="ctr">
-                        <a:buNone/>
-                      </a:pPr>
+                      <a:pPr algn="ctr"/>
                       <a:r>
                         <a:rPr sz="1800" b="0">
                           <a:solidFill>
@@ -16512,9 +16094,7 @@
                     </a:bodyPr>
                     <a:lstStyle/>
                     <a:p>
-                      <a:pPr algn="r">
-                        <a:buNone/>
-                      </a:pPr>
+                      <a:pPr algn="r"/>
                       <a:r>
                         <a:rPr sz="1800" b="0">
                           <a:solidFill>
@@ -16553,9 +16133,7 @@
                     </a:bodyPr>
                     <a:lstStyle/>
                     <a:p>
-                      <a:pPr algn="r">
-                        <a:buNone/>
-                      </a:pPr>
+                      <a:pPr algn="r"/>
                       <a:r>
                         <a:rPr sz="1800" b="0">
                           <a:solidFill>
@@ -16565,7 +16143,7 @@
                           <a:ea typeface="Malgun Gothic"/>
                           <a:cs typeface="Malgun Gothic"/>
                         </a:rPr>
-                        <a:t>0.239</a:t>
+                        <a:t>0.040</a:t>
                       </a:r>
                     </a:p>
                   </a:txBody>
@@ -16594,9 +16172,7 @@
                     </a:bodyPr>
                     <a:lstStyle/>
                     <a:p>
-                      <a:pPr algn="r">
-                        <a:buNone/>
-                      </a:pPr>
+                      <a:pPr algn="r"/>
                       <a:r>
                         <a:rPr sz="1800" b="0">
                           <a:solidFill>
@@ -16635,9 +16211,7 @@
                     </a:bodyPr>
                     <a:lstStyle/>
                     <a:p>
-                      <a:pPr algn="r">
-                        <a:buNone/>
-                      </a:pPr>
+                      <a:pPr algn="r"/>
                       <a:r>
                         <a:rPr sz="1800" b="0">
                           <a:solidFill>
@@ -16647,7 +16221,7 @@
                           <a:ea typeface="Malgun Gothic"/>
                           <a:cs typeface="Malgun Gothic"/>
                         </a:rPr>
-                        <a:t>0.414</a:t>
+                        <a:t>0.138</a:t>
                       </a:r>
                     </a:p>
                   </a:txBody>
@@ -16678,9 +16252,7 @@
                     </a:bodyPr>
                     <a:lstStyle/>
                     <a:p>
-                      <a:pPr algn="ctr">
-                        <a:buNone/>
-                      </a:pPr>
+                      <a:pPr algn="ctr"/>
                       <a:r>
                         <a:rPr sz="1800" b="0">
                           <a:solidFill>
@@ -16725,9 +16297,7 @@
                     </a:bodyPr>
                     <a:lstStyle/>
                     <a:p>
-                      <a:pPr algn="r">
-                        <a:buNone/>
-                      </a:pPr>
+                      <a:pPr algn="r"/>
                       <a:r>
                         <a:rPr sz="1800" b="0">
                           <a:solidFill>
@@ -16766,9 +16336,7 @@
                     </a:bodyPr>
                     <a:lstStyle/>
                     <a:p>
-                      <a:pPr algn="r">
-                        <a:buNone/>
-                      </a:pPr>
+                      <a:pPr algn="r"/>
                       <a:r>
                         <a:rPr sz="1800" b="0">
                           <a:solidFill>
@@ -16778,7 +16346,7 @@
                           <a:ea typeface="Malgun Gothic"/>
                           <a:cs typeface="Malgun Gothic"/>
                         </a:rPr>
-                        <a:t>0.940</a:t>
+                        <a:t>0.384</a:t>
                       </a:r>
                     </a:p>
                   </a:txBody>
@@ -16807,9 +16375,7 @@
                     </a:bodyPr>
                     <a:lstStyle/>
                     <a:p>
-                      <a:pPr algn="r">
-                        <a:buNone/>
-                      </a:pPr>
+                      <a:pPr algn="r"/>
                       <a:r>
                         <a:rPr sz="1800" b="0">
                           <a:solidFill>
@@ -16848,9 +16414,7 @@
                     </a:bodyPr>
                     <a:lstStyle/>
                     <a:p>
-                      <a:pPr algn="r">
-                        <a:buNone/>
-                      </a:pPr>
+                      <a:pPr algn="r"/>
                       <a:r>
                         <a:rPr sz="1800" b="0">
                           <a:solidFill>
@@ -16860,7 +16424,7 @@
                           <a:ea typeface="Malgun Gothic"/>
                           <a:cs typeface="Malgun Gothic"/>
                         </a:rPr>
-                        <a:t>0.976</a:t>
+                        <a:t>0.529</a:t>
                       </a:r>
                     </a:p>
                   </a:txBody>
@@ -16891,9 +16455,7 @@
                     </a:bodyPr>
                     <a:lstStyle/>
                     <a:p>
-                      <a:pPr algn="ctr">
-                        <a:buNone/>
-                      </a:pPr>
+                      <a:pPr algn="ctr"/>
                       <a:r>
                         <a:rPr sz="1800" b="0">
                           <a:solidFill>
@@ -16938,9 +16500,7 @@
                     </a:bodyPr>
                     <a:lstStyle/>
                     <a:p>
-                      <a:pPr algn="r">
-                        <a:buNone/>
-                      </a:pPr>
+                      <a:pPr algn="r"/>
                       <a:r>
                         <a:rPr sz="1800" b="0">
                           <a:solidFill>
@@ -16979,9 +16539,7 @@
                     </a:bodyPr>
                     <a:lstStyle/>
                     <a:p>
-                      <a:pPr algn="r">
-                        <a:buNone/>
-                      </a:pPr>
+                      <a:pPr algn="r"/>
                       <a:r>
                         <a:rPr sz="1800" b="0">
                           <a:solidFill>
@@ -16991,7 +16549,7 @@
                           <a:ea typeface="Malgun Gothic"/>
                           <a:cs typeface="Malgun Gothic"/>
                         </a:rPr>
-                        <a:t>0.940</a:t>
+                        <a:t>0.939</a:t>
                       </a:r>
                     </a:p>
                   </a:txBody>
@@ -17020,9 +16578,7 @@
                     </a:bodyPr>
                     <a:lstStyle/>
                     <a:p>
-                      <a:pPr algn="r">
-                        <a:buNone/>
-                      </a:pPr>
+                      <a:pPr algn="r"/>
                       <a:r>
                         <a:rPr sz="1800" b="0">
                           <a:solidFill>
@@ -17061,9 +16617,7 @@
                     </a:bodyPr>
                     <a:lstStyle/>
                     <a:p>
-                      <a:pPr algn="r">
-                        <a:buNone/>
-                      </a:pPr>
+                      <a:pPr algn="r"/>
                       <a:r>
                         <a:rPr sz="1800" b="0">
                           <a:solidFill>
@@ -17073,7 +16627,7 @@
                           <a:ea typeface="Malgun Gothic"/>
                           <a:cs typeface="Malgun Gothic"/>
                         </a:rPr>
-                        <a:t>0.005</a:t>
+                        <a:t>&lt;0.001</a:t>
                       </a:r>
                     </a:p>
                   </a:txBody>
@@ -17104,9 +16658,7 @@
                     </a:bodyPr>
                     <a:lstStyle/>
                     <a:p>
-                      <a:pPr algn="ctr">
-                        <a:buNone/>
-                      </a:pPr>
+                      <a:pPr algn="ctr"/>
                       <a:r>
                         <a:rPr sz="1800" b="0">
                           <a:solidFill>
@@ -17151,9 +16703,7 @@
                     </a:bodyPr>
                     <a:lstStyle/>
                     <a:p>
-                      <a:pPr algn="r">
-                        <a:buNone/>
-                      </a:pPr>
+                      <a:pPr algn="r"/>
                       <a:r>
                         <a:rPr sz="1800" b="0">
                           <a:solidFill>
@@ -17192,9 +16742,7 @@
                     </a:bodyPr>
                     <a:lstStyle/>
                     <a:p>
-                      <a:pPr algn="r">
-                        <a:buNone/>
-                      </a:pPr>
+                      <a:pPr algn="r"/>
                       <a:r>
                         <a:rPr sz="1800" b="0">
                           <a:solidFill>
@@ -17204,7 +16752,7 @@
                           <a:ea typeface="Malgun Gothic"/>
                           <a:cs typeface="Malgun Gothic"/>
                         </a:rPr>
-                        <a:t>0.940</a:t>
+                        <a:t>0.313</a:t>
                       </a:r>
                     </a:p>
                   </a:txBody>
@@ -17233,9 +16781,7 @@
                     </a:bodyPr>
                     <a:lstStyle/>
                     <a:p>
-                      <a:pPr algn="r">
-                        <a:buNone/>
-                      </a:pPr>
+                      <a:pPr algn="r"/>
                       <a:r>
                         <a:rPr sz="1800" b="0">
                           <a:solidFill>
@@ -17274,9 +16820,7 @@
                     </a:bodyPr>
                     <a:lstStyle/>
                     <a:p>
-                      <a:pPr algn="r">
-                        <a:buNone/>
-                      </a:pPr>
+                      <a:pPr algn="r"/>
                       <a:r>
                         <a:rPr sz="1800" b="0">
                           <a:solidFill>
@@ -17286,7 +16830,7 @@
                           <a:ea typeface="Malgun Gothic"/>
                           <a:cs typeface="Malgun Gothic"/>
                         </a:rPr>
-                        <a:t>0.976</a:t>
+                        <a:t>0.488</a:t>
                       </a:r>
                     </a:p>
                   </a:txBody>
@@ -17315,10 +16859,10 @@
       </p:graphicFrame>
       <p:sp>
         <p:nvSpPr>
-          <p:cNvPr id="57" name="문자 비율·시간은 각각 7검정에 Holm 보정. RAGAS H×C 검정은 평가 문맥 언어별로 수행했으며, 전체 24검">
+          <p:cNvPr id="57" name="p&lt;0.05: 한국어 비율 S·H×C / 실행 시간 H·C·S·C×S RAGAS H×C 검정은 평가 문맥 언어별로 수">
             <a:extLst xmlns:a="http://schemas.openxmlformats.org/drawingml/2006/main">
               <a:ext uri="{FF2B5EF4-FFF2-40B4-BE49-F238E27FC236}">
-                <a16:creationId xmlns:a16="http://schemas.microsoft.com/office/drawing/2014/main" id="{87B3D930-A71A-4ECE-A779-BD685224615C}"/>
+                <a16:creationId xmlns:a16="http://schemas.microsoft.com/office/drawing/2014/main" id="{94213441-4F82-48A8-9945-97196A39167F}"/>
               </a:ext>
             </a:extLst>
           </p:cNvPr>
@@ -17448,7 +16992,6 @@
           </a:lstStyle>
           <a:p xmlns:a="http://schemas.openxmlformats.org/drawingml/2006/main">
             <a:pPr algn="l">
-              <a:buNone/>
               <a:defRPr sz="1800" b="0">
                 <a:solidFill>
                   <a:srgbClr val="24324A"/>
@@ -17467,12 +17010,11 @@
                 <a:ea typeface="Malgun Gothic"/>
                 <a:cs typeface="Malgun Gothic"/>
               </a:rPr>
-              <a:t>문자 비율·시간은 각각 7검정에 Holm 보정.</a:t>
+              <a:t>p&lt;0.05: 한국어 비율 S·H×C / 실행 시간 H·C·S·C×S</a:t>
             </a:r>
           </a:p>
           <a:p xmlns:a="http://schemas.openxmlformats.org/drawingml/2006/main">
             <a:pPr algn="l">
-              <a:buNone/>
               <a:defRPr sz="1800" b="0">
                 <a:solidFill>
                   <a:srgbClr val="24324A"/>
@@ -17496,7 +17038,6 @@
           </a:p>
           <a:p xmlns:a="http://schemas.openxmlformats.org/drawingml/2006/main">
             <a:pPr algn="l">
-              <a:buNone/>
               <a:defRPr sz="1800" b="0">
                 <a:solidFill>
                   <a:srgbClr val="24324A"/>
@@ -17515,7 +17056,7 @@
                 <a:ea typeface="Malgun Gothic"/>
                 <a:cs typeface="Malgun Gothic"/>
               </a:rPr>
-              <a:t>전체 24검정의 Holm 보정 p는 모두 0.05 이상이었다.</a:t>
+              <a:t>품질 4지표 24검정의 p는 모두 0.05 이상이었다.</a:t>
             </a:r>
           </a:p>
         </p:txBody>
@@ -17525,7 +17066,7 @@
           <p:cNvPr id="58" name="기법별 대응 비교  ·  질의별 평균 차이, 양측 검정">
             <a:extLst xmlns:a="http://schemas.openxmlformats.org/drawingml/2006/main">
               <a:ext uri="{FF2B5EF4-FFF2-40B4-BE49-F238E27FC236}">
-                <a16:creationId xmlns:a16="http://schemas.microsoft.com/office/drawing/2014/main" id="{A6092A1F-E72C-4692-AE2C-D75D0A410C8C}"/>
+                <a16:creationId xmlns:a16="http://schemas.microsoft.com/office/drawing/2014/main" id="{A83A5B6B-9286-4C33-94B3-40C5A7056F10}"/>
               </a:ext>
             </a:extLst>
           </p:cNvPr>
@@ -17655,7 +17196,6 @@
           </a:lstStyle>
           <a:p xmlns:a="http://schemas.openxmlformats.org/drawingml/2006/main">
             <a:pPr algn="l">
-              <a:buNone/>
               <a:defRPr sz="1800" b="1">
                 <a:solidFill>
                   <a:srgbClr val="24324A"/>
@@ -17684,7 +17224,7 @@
           <p:cNvPr id="59" name="">
             <a:extLst xmlns:a="http://schemas.openxmlformats.org/drawingml/2006/main">
               <a:ext uri="{FF2B5EF4-FFF2-40B4-BE49-F238E27FC236}">
-                <a16:creationId xmlns:a16="http://schemas.microsoft.com/office/drawing/2014/main" id="{5B8A7DEB-9875-4EF4-9179-2CB8A1141FC7}"/>
+                <a16:creationId xmlns:a16="http://schemas.microsoft.com/office/drawing/2014/main" id="{4CA91D7B-4B10-4E60-95A1-D8BD85064931}"/>
               </a:ext>
             </a:extLst>
           </p:cNvPr>
@@ -17714,9 +17254,7 @@
                     </a:bodyPr>
                     <a:lstStyle/>
                     <a:p>
-                      <a:pPr algn="ctr">
-                        <a:buNone/>
-                      </a:pPr>
+                      <a:pPr algn="ctr"/>
                       <a:r>
                         <a:rPr sz="1800" b="1">
                           <a:solidFill>
@@ -17767,9 +17305,7 @@
                     </a:bodyPr>
                     <a:lstStyle/>
                     <a:p>
-                      <a:pPr algn="ctr">
-                        <a:buNone/>
-                      </a:pPr>
+                      <a:pPr algn="ctr"/>
                       <a:r>
                         <a:rPr sz="1800" b="1">
                           <a:solidFill>
@@ -17783,9 +17319,7 @@
                       </a:r>
                     </a:p>
                     <a:p>
-                      <a:pPr algn="ctr">
-                        <a:buNone/>
-                      </a:pPr>
+                      <a:pPr algn="ctr"/>
                       <a:r>
                         <a:rPr sz="1800" b="1">
                           <a:solidFill>
@@ -17830,9 +17364,7 @@
                     </a:bodyPr>
                     <a:lstStyle/>
                     <a:p>
-                      <a:pPr algn="ctr">
-                        <a:buNone/>
-                      </a:pPr>
+                      <a:pPr algn="ctr"/>
                       <a:r>
                         <a:rPr sz="1800" b="1">
                           <a:solidFill>
@@ -17877,25 +17409,7 @@
                     </a:bodyPr>
                     <a:lstStyle/>
                     <a:p>
-                      <a:pPr algn="ctr">
-                        <a:buNone/>
-                      </a:pPr>
-                      <a:r>
-                        <a:rPr sz="1800" b="1">
-                          <a:solidFill>
-                            <a:srgbClr val="24324A"/>
-                          </a:solidFill>
-                          <a:latin typeface="Malgun Gothic"/>
-                          <a:ea typeface="Malgun Gothic"/>
-                          <a:cs typeface="Malgun Gothic"/>
-                        </a:rPr>
-                        <a:t>보정 전</a:t>
-                      </a:r>
-                    </a:p>
-                    <a:p>
-                      <a:pPr algn="ctr">
-                        <a:buNone/>
-                      </a:pPr>
+                      <a:pPr algn="ctr"/>
                       <a:r>
                         <a:rPr sz="1800" b="1">
                           <a:solidFill>
@@ -17940,9 +17454,7 @@
                     </a:bodyPr>
                     <a:lstStyle/>
                     <a:p>
-                      <a:pPr algn="ctr">
-                        <a:buNone/>
-                      </a:pPr>
+                      <a:pPr algn="ctr"/>
                       <a:r>
                         <a:rPr sz="1800" b="1">
                           <a:solidFill>
@@ -17952,23 +17464,7 @@
                           <a:ea typeface="Malgun Gothic"/>
                           <a:cs typeface="Malgun Gothic"/>
                         </a:rPr>
-                        <a:t>보정 후</a:t>
-                      </a:r>
-                    </a:p>
-                    <a:p>
-                      <a:pPr algn="ctr">
-                        <a:buNone/>
-                      </a:pPr>
-                      <a:r>
-                        <a:rPr sz="1800" b="1">
-                          <a:solidFill>
-                            <a:srgbClr val="24324A"/>
-                          </a:solidFill>
-                          <a:latin typeface="Malgun Gothic"/>
-                          <a:ea typeface="Malgun Gothic"/>
-                          <a:cs typeface="Malgun Gothic"/>
-                        </a:rPr>
-                        <a:t>p</a:t>
+                        <a:t>dz</a:t>
                       </a:r>
                     </a:p>
                   </a:txBody>
@@ -18005,9 +17501,7 @@
                     </a:bodyPr>
                     <a:lstStyle/>
                     <a:p>
-                      <a:pPr algn="l">
-                        <a:buNone/>
-                      </a:pPr>
+                      <a:pPr algn="l"/>
                       <a:r>
                         <a:rPr sz="1800" b="0">
                           <a:solidFill>
@@ -18021,9 +17515,7 @@
                       </a:r>
                     </a:p>
                     <a:p>
-                      <a:pPr algn="l">
-                        <a:buNone/>
-                      </a:pPr>
+                      <a:pPr algn="l"/>
                       <a:r>
                         <a:rPr sz="1800" b="0">
                           <a:solidFill>
@@ -18068,9 +17560,7 @@
                     </a:bodyPr>
                     <a:lstStyle/>
                     <a:p>
-                      <a:pPr algn="r">
-                        <a:buNone/>
-                      </a:pPr>
+                      <a:pPr algn="r"/>
                       <a:r>
                         <a:rPr sz="1800" b="0">
                           <a:solidFill>
@@ -18084,9 +17574,7 @@
                       </a:r>
                     </a:p>
                     <a:p>
-                      <a:pPr algn="r">
-                        <a:buNone/>
-                      </a:pPr>
+                      <a:pPr algn="r"/>
                       <a:r>
                         <a:rPr sz="1800" b="0">
                           <a:solidFill>
@@ -18125,9 +17613,7 @@
                     </a:bodyPr>
                     <a:lstStyle/>
                     <a:p>
-                      <a:pPr algn="r">
-                        <a:buNone/>
-                      </a:pPr>
+                      <a:pPr algn="r"/>
                       <a:r>
                         <a:rPr sz="1800" b="0">
                           <a:solidFill>
@@ -18141,9 +17627,7 @@
                       </a:r>
                     </a:p>
                     <a:p>
-                      <a:pPr algn="r">
-                        <a:buNone/>
-                      </a:pPr>
+                      <a:pPr algn="r"/>
                       <a:r>
                         <a:rPr sz="1800" b="0">
                           <a:solidFill>
@@ -18182,9 +17666,7 @@
                     </a:bodyPr>
                     <a:lstStyle/>
                     <a:p>
-                      <a:pPr algn="r">
-                        <a:buNone/>
-                      </a:pPr>
+                      <a:pPr algn="r"/>
                       <a:r>
                         <a:rPr sz="1800" b="0">
                           <a:solidFill>
@@ -18223,9 +17705,7 @@
                     </a:bodyPr>
                     <a:lstStyle/>
                     <a:p>
-                      <a:pPr algn="r">
-                        <a:buNone/>
-                      </a:pPr>
+                      <a:pPr algn="r"/>
                       <a:r>
                         <a:rPr sz="1800" b="0">
                           <a:solidFill>
@@ -18235,7 +17715,7 @@
                           <a:ea typeface="Malgun Gothic"/>
                           <a:cs typeface="Malgun Gothic"/>
                         </a:rPr>
-                        <a:t>0.117</a:t>
+                        <a:t>0.289</a:t>
                       </a:r>
                     </a:p>
                   </a:txBody>
@@ -18266,9 +17746,7 @@
                     </a:bodyPr>
                     <a:lstStyle/>
                     <a:p>
-                      <a:pPr algn="l">
-                        <a:buNone/>
-                      </a:pPr>
+                      <a:pPr algn="l"/>
                       <a:r>
                         <a:rPr sz="1800" b="0">
                           <a:solidFill>
@@ -18282,9 +17760,7 @@
                       </a:r>
                     </a:p>
                     <a:p>
-                      <a:pPr algn="l">
-                        <a:buNone/>
-                      </a:pPr>
+                      <a:pPr algn="l"/>
                       <a:r>
                         <a:rPr sz="1800" b="0">
                           <a:solidFill>
@@ -18329,9 +17805,7 @@
                     </a:bodyPr>
                     <a:lstStyle/>
                     <a:p>
-                      <a:pPr algn="r">
-                        <a:buNone/>
-                      </a:pPr>
+                      <a:pPr algn="r"/>
                       <a:r>
                         <a:rPr sz="1800" b="0">
                           <a:solidFill>
@@ -18345,9 +17819,7 @@
                       </a:r>
                     </a:p>
                     <a:p>
-                      <a:pPr algn="r">
-                        <a:buNone/>
-                      </a:pPr>
+                      <a:pPr algn="r"/>
                       <a:r>
                         <a:rPr sz="1800" b="0">
                           <a:solidFill>
@@ -18386,9 +17858,7 @@
                     </a:bodyPr>
                     <a:lstStyle/>
                     <a:p>
-                      <a:pPr algn="r">
-                        <a:buNone/>
-                      </a:pPr>
+                      <a:pPr algn="r"/>
                       <a:r>
                         <a:rPr sz="1800" b="0">
                           <a:solidFill>
@@ -18402,9 +17872,7 @@
                       </a:r>
                     </a:p>
                     <a:p>
-                      <a:pPr algn="r">
-                        <a:buNone/>
-                      </a:pPr>
+                      <a:pPr algn="r"/>
                       <a:r>
                         <a:rPr sz="1800" b="0">
                           <a:solidFill>
@@ -18443,9 +17911,7 @@
                     </a:bodyPr>
                     <a:lstStyle/>
                     <a:p>
-                      <a:pPr algn="r">
-                        <a:buNone/>
-                      </a:pPr>
+                      <a:pPr algn="r"/>
                       <a:r>
                         <a:rPr sz="1800" b="0">
                           <a:solidFill>
@@ -18484,9 +17950,7 @@
                     </a:bodyPr>
                     <a:lstStyle/>
                     <a:p>
-                      <a:pPr algn="r">
-                        <a:buNone/>
-                      </a:pPr>
+                      <a:pPr algn="r"/>
                       <a:r>
                         <a:rPr sz="1800" b="0">
                           <a:solidFill>
@@ -18496,7 +17960,7 @@
                           <a:ea typeface="Malgun Gothic"/>
                           <a:cs typeface="Malgun Gothic"/>
                         </a:rPr>
-                        <a:t>1.000</a:t>
+                        <a:t>0.113</a:t>
                       </a:r>
                     </a:p>
                   </a:txBody>
@@ -18527,9 +17991,7 @@
                     </a:bodyPr>
                     <a:lstStyle/>
                     <a:p>
-                      <a:pPr algn="l">
-                        <a:buNone/>
-                      </a:pPr>
+                      <a:pPr algn="l"/>
                       <a:r>
                         <a:rPr sz="1800" b="0">
                           <a:solidFill>
@@ -18543,9 +18005,7 @@
                       </a:r>
                     </a:p>
                     <a:p>
-                      <a:pPr algn="l">
-                        <a:buNone/>
-                      </a:pPr>
+                      <a:pPr algn="l"/>
                       <a:r>
                         <a:rPr sz="1800" b="0">
                           <a:solidFill>
@@ -18590,9 +18050,7 @@
                     </a:bodyPr>
                     <a:lstStyle/>
                     <a:p>
-                      <a:pPr algn="r">
-                        <a:buNone/>
-                      </a:pPr>
+                      <a:pPr algn="r"/>
                       <a:r>
                         <a:rPr sz="1800" b="0">
                           <a:solidFill>
@@ -18606,9 +18064,7 @@
                       </a:r>
                     </a:p>
                     <a:p>
-                      <a:pPr algn="r">
-                        <a:buNone/>
-                      </a:pPr>
+                      <a:pPr algn="r"/>
                       <a:r>
                         <a:rPr sz="1800" b="0">
                           <a:solidFill>
@@ -18647,9 +18103,7 @@
                     </a:bodyPr>
                     <a:lstStyle/>
                     <a:p>
-                      <a:pPr algn="r">
-                        <a:buNone/>
-                      </a:pPr>
+                      <a:pPr algn="r"/>
                       <a:r>
                         <a:rPr sz="1800" b="0">
                           <a:solidFill>
@@ -18663,9 +18117,7 @@
                       </a:r>
                     </a:p>
                     <a:p>
-                      <a:pPr algn="r">
-                        <a:buNone/>
-                      </a:pPr>
+                      <a:pPr algn="r"/>
                       <a:r>
                         <a:rPr sz="1800" b="0">
                           <a:solidFill>
@@ -18704,9 +18156,7 @@
                     </a:bodyPr>
                     <a:lstStyle/>
                     <a:p>
-                      <a:pPr algn="r">
-                        <a:buNone/>
-                      </a:pPr>
+                      <a:pPr algn="r"/>
                       <a:r>
                         <a:rPr sz="1800" b="0">
                           <a:solidFill>
@@ -18745,9 +18195,7 @@
                     </a:bodyPr>
                     <a:lstStyle/>
                     <a:p>
-                      <a:pPr algn="r">
-                        <a:buNone/>
-                      </a:pPr>
+                      <a:pPr algn="r"/>
                       <a:r>
                         <a:rPr sz="1800" b="0">
                           <a:solidFill>
@@ -18757,7 +18205,7 @@
                           <a:ea typeface="Malgun Gothic"/>
                           <a:cs typeface="Malgun Gothic"/>
                         </a:rPr>
-                        <a:t>&lt;0.001</a:t>
+                        <a:t>1.801</a:t>
                       </a:r>
                     </a:p>
                   </a:txBody>
@@ -18786,10 +18234,10 @@
       </p:graphicFrame>
       <p:sp>
         <p:nvSpPr>
-          <p:cNvPr id="60" name="HyDE: C0S0, CAD: H0S0, SCD: H0의 CAD 상태 평균 보정: HyDE·CAD 각 4지표, SCD">
+          <p:cNvPr id="60" name="HyDE: C0S0, CAD: H0S0, SCD: H0의 CAD 상태 평균 p: 다중비교 보정 없는 양측 p, dz:">
             <a:extLst xmlns:a="http://schemas.openxmlformats.org/drawingml/2006/main">
               <a:ext uri="{FF2B5EF4-FFF2-40B4-BE49-F238E27FC236}">
-                <a16:creationId xmlns:a16="http://schemas.microsoft.com/office/drawing/2014/main" id="{C735DB22-B016-4190-B8C8-4B18C57289F7}"/>
+                <a16:creationId xmlns:a16="http://schemas.microsoft.com/office/drawing/2014/main" id="{0360F373-C7A8-4BAB-9CBF-9DA230CC9A38}"/>
               </a:ext>
             </a:extLst>
           </p:cNvPr>
@@ -18919,7 +18367,6 @@
           </a:lstStyle>
           <a:p xmlns:a="http://schemas.openxmlformats.org/drawingml/2006/main">
             <a:pPr algn="l">
-              <a:buNone/>
               <a:defRPr sz="1800" b="0">
                 <a:solidFill>
                   <a:srgbClr val="24324A"/>
@@ -18943,7 +18390,6 @@
           </a:p>
           <a:p xmlns:a="http://schemas.openxmlformats.org/drawingml/2006/main">
             <a:pPr algn="l">
-              <a:buNone/>
               <a:defRPr sz="1800" b="0">
                 <a:solidFill>
                   <a:srgbClr val="24324A"/>
@@ -18962,12 +18408,11 @@
                 <a:ea typeface="Malgun Gothic"/>
                 <a:cs typeface="Malgun Gothic"/>
               </a:rPr>
-              <a:t>보정: HyDE·CAD 각 4지표, SCD 주·전체 비교 2검정</a:t>
+              <a:t>p: 다중비교 보정 없는 양측 p, dz: 차이 평균/차이 SD</a:t>
             </a:r>
           </a:p>
           <a:p xmlns:a="http://schemas.openxmlformats.org/drawingml/2006/main">
             <a:pPr algn="l">
-              <a:buNone/>
               <a:defRPr sz="1800" b="0">
                 <a:solidFill>
                   <a:srgbClr val="24324A"/>
@@ -18991,7 +18436,6 @@
           </a:p>
           <a:p xmlns:a="http://schemas.openxmlformats.org/drawingml/2006/main">
             <a:pPr algn="l">
-              <a:buNone/>
               <a:defRPr sz="1800" b="0">
                 <a:solidFill>
                   <a:srgbClr val="24324A"/>
@@ -19020,7 +18464,7 @@
           <p:cNvPr id="61" name="">
             <a:extLst xmlns:a="http://schemas.openxmlformats.org/drawingml/2006/main">
               <a:ext uri="{FF2B5EF4-FFF2-40B4-BE49-F238E27FC236}">
-                <a16:creationId xmlns:a16="http://schemas.microsoft.com/office/drawing/2014/main" id="{36ED8F9F-DEAE-422A-AB18-47EFDC8F2F48}"/>
+                <a16:creationId xmlns:a16="http://schemas.microsoft.com/office/drawing/2014/main" id="{24CF6432-AA43-4634-93A7-26B2FEE8C8F6}"/>
               </a:ext>
             </a:extLst>
           </p:cNvPr>
@@ -19051,7 +18495,7 @@
           <p:cNvPr id="62" name="06 결과 해석">
             <a:extLst xmlns:a="http://schemas.openxmlformats.org/drawingml/2006/main">
               <a:ext uri="{FF2B5EF4-FFF2-40B4-BE49-F238E27FC236}">
-                <a16:creationId xmlns:a16="http://schemas.microsoft.com/office/drawing/2014/main" id="{9A3ACB9E-52AB-41C7-93FE-D17725FD7DCC}"/>
+                <a16:creationId xmlns:a16="http://schemas.microsoft.com/office/drawing/2014/main" id="{5C583980-A700-4E57-BBE1-4E0148BA7B3F}"/>
               </a:ext>
             </a:extLst>
           </p:cNvPr>
@@ -19181,7 +18625,6 @@
           </a:lstStyle>
           <a:p xmlns:a="http://schemas.openxmlformats.org/drawingml/2006/main">
             <a:pPr algn="l">
-              <a:buNone/>
               <a:defRPr sz="2400" b="0">
                 <a:solidFill>
                   <a:srgbClr val="FFFFFF"/>
@@ -19207,10 +18650,10 @@
       </p:sp>
       <p:sp>
         <p:nvSpPr>
-          <p:cNvPr id="63" name="HyDE의 양의 관련성 차이는 다중비교 보정 결과와 함께 해석한다. CAD는 질의별 충실도 변동과 추가 실행 시간을 ">
+          <p:cNvPr id="63" name="HyDE 관련성은 평균 +0.080점, t(59)=2.236, p=0.029였다. CAD 충실도는 평균 +0.029점">
             <a:extLst xmlns:a="http://schemas.openxmlformats.org/drawingml/2006/main">
               <a:ext uri="{FF2B5EF4-FFF2-40B4-BE49-F238E27FC236}">
-                <a16:creationId xmlns:a16="http://schemas.microsoft.com/office/drawing/2014/main" id="{3064354D-CF8D-4207-8EC6-6DB2D62CBF15}"/>
+                <a16:creationId xmlns:a16="http://schemas.microsoft.com/office/drawing/2014/main" id="{A598518B-D54E-4E6C-93BA-5EE623CBF783}"/>
               </a:ext>
             </a:extLst>
           </p:cNvPr>
@@ -19340,7 +18783,6 @@
           </a:lstStyle>
           <a:p xmlns:a="http://schemas.openxmlformats.org/drawingml/2006/main">
             <a:pPr algn="l">
-              <a:buNone/>
               <a:defRPr sz="1800" b="0">
                 <a:solidFill>
                   <a:srgbClr val="24324A"/>
@@ -19359,12 +18801,11 @@
                 <a:ea typeface="Malgun Gothic"/>
                 <a:cs typeface="Malgun Gothic"/>
               </a:rPr>
-              <a:t>HyDE 관련성은 평균 +0.080점, Holm 보정 p=0.117이었다.</a:t>
+              <a:t>HyDE 관련성은 평균 +0.080점, t(59)=2.236, p=0.029였다.</a:t>
             </a:r>
           </a:p>
           <a:p xmlns:a="http://schemas.openxmlformats.org/drawingml/2006/main">
             <a:pPr algn="l">
-              <a:buNone/>
               <a:defRPr sz="1800" b="0">
                 <a:solidFill>
                   <a:srgbClr val="24324A"/>
@@ -19383,12 +18824,11 @@
                 <a:ea typeface="Malgun Gothic"/>
                 <a:cs typeface="Malgun Gothic"/>
               </a:rPr>
-              <a:t>CAD 충실도는 평균 +0.029점이며 질의별 증감이 달랐다.</a:t>
+              <a:t>CAD 충실도는 평균 +0.029점, t(57)=0.862, p=0.393이었다.</a:t>
             </a:r>
           </a:p>
           <a:p xmlns:a="http://schemas.openxmlformats.org/drawingml/2006/main">
             <a:pPr algn="l">
-              <a:buNone/>
               <a:defRPr sz="1800" b="0">
                 <a:solidFill>
                   <a:srgbClr val="24324A"/>
@@ -19407,12 +18847,11 @@
                 <a:ea typeface="Malgun Gothic"/>
                 <a:cs typeface="Malgun Gothic"/>
               </a:rPr>
-              <a:t>SCD 주 비교의 한국어 문자 비율은 평균 21.822%p 높았다.</a:t>
+              <a:t>SCD 주 비교의 한국어 비율은 21.822%p 높았다(p&lt;0.001).</a:t>
             </a:r>
           </a:p>
           <a:p xmlns:a="http://schemas.openxmlformats.org/drawingml/2006/main">
             <a:pPr algn="l">
-              <a:buNone/>
               <a:defRPr sz="1800" b="0">
                 <a:solidFill>
                   <a:srgbClr val="24324A"/>
@@ -19441,7 +18880,7 @@
           <p:cNvPr id="64" name="">
             <a:extLst xmlns:a="http://schemas.openxmlformats.org/drawingml/2006/main">
               <a:ext uri="{FF2B5EF4-FFF2-40B4-BE49-F238E27FC236}">
-                <a16:creationId xmlns:a16="http://schemas.microsoft.com/office/drawing/2014/main" id="{335E4EE7-3A51-44EC-843E-3029AFF737CF}"/>
+                <a16:creationId xmlns:a16="http://schemas.microsoft.com/office/drawing/2014/main" id="{AEBE0219-1508-4E0C-89F7-49A2A74338CC}"/>
               </a:ext>
             </a:extLst>
           </p:cNvPr>
@@ -19472,7 +18911,7 @@
           <p:cNvPr id="65" name="07 결론">
             <a:extLst xmlns:a="http://schemas.openxmlformats.org/drawingml/2006/main">
               <a:ext uri="{FF2B5EF4-FFF2-40B4-BE49-F238E27FC236}">
-                <a16:creationId xmlns:a16="http://schemas.microsoft.com/office/drawing/2014/main" id="{3E89197A-0FFF-4F28-8AB4-FD0E50C31BF7}"/>
+                <a16:creationId xmlns:a16="http://schemas.microsoft.com/office/drawing/2014/main" id="{486B674A-61D8-4562-A6BB-5C45DFE1621E}"/>
               </a:ext>
             </a:extLst>
           </p:cNvPr>
@@ -19602,7 +19041,6 @@
           </a:lstStyle>
           <a:p xmlns:a="http://schemas.openxmlformats.org/drawingml/2006/main">
             <a:pPr algn="l">
-              <a:buNone/>
               <a:defRPr sz="2400" b="0">
                 <a:solidFill>
                   <a:srgbClr val="FFFFFF"/>
@@ -19628,10 +19066,10 @@
       </p:sp>
       <p:sp>
         <p:nvSpPr>
-          <p:cNvPr id="66" name="답변 품질은 평균 대응 차이와 보정 검정 결과로 판단한다. 한국어 사용 비중을 높이는 목적에는 SCD 결과를 참고한다">
+          <p:cNvPr id="66" name="HyDE는 C0S0에서 관련성을 높였고, CAD 충실도 차이는 유의하지 않았다. SCD는 같은 영어 근거에서 한국어 ">
             <a:extLst xmlns:a="http://schemas.openxmlformats.org/drawingml/2006/main">
               <a:ext uri="{FF2B5EF4-FFF2-40B4-BE49-F238E27FC236}">
-                <a16:creationId xmlns:a16="http://schemas.microsoft.com/office/drawing/2014/main" id="{AE010BAB-C317-447B-A51E-97D1FA975761}"/>
+                <a16:creationId xmlns:a16="http://schemas.microsoft.com/office/drawing/2014/main" id="{A6CFB91C-90C0-4EBF-92CC-5DFD802DF078}"/>
               </a:ext>
             </a:extLst>
           </p:cNvPr>
@@ -19761,7 +19199,6 @@
           </a:lstStyle>
           <a:p xmlns:a="http://schemas.openxmlformats.org/drawingml/2006/main">
             <a:pPr algn="l">
-              <a:buNone/>
               <a:defRPr sz="1800" b="0">
                 <a:solidFill>
                   <a:srgbClr val="24324A"/>
@@ -19780,12 +19217,11 @@
                 <a:ea typeface="Malgun Gothic"/>
                 <a:cs typeface="Malgun Gothic"/>
               </a:rPr>
-              <a:t>HyDE 관련성과 CAD 충실도는 Holm 보정 후 유의하지 않았다.</a:t>
+              <a:t>HyDE는 C0S0에서 관련성을 높였고, CAD 충실도 차이는 유의하지 않았다.</a:t>
             </a:r>
           </a:p>
           <a:p xmlns:a="http://schemas.openxmlformats.org/drawingml/2006/main">
             <a:pPr algn="l">
-              <a:buNone/>
               <a:defRPr sz="1800" b="0">
                 <a:solidFill>
                   <a:srgbClr val="24324A"/>
@@ -19809,7 +19245,6 @@
           </a:p>
           <a:p xmlns:a="http://schemas.openxmlformats.org/drawingml/2006/main">
             <a:pPr algn="l">
-              <a:buNone/>
               <a:defRPr sz="1800" b="0">
                 <a:solidFill>
                   <a:srgbClr val="24324A"/>
@@ -19833,7 +19268,6 @@
           </a:p>
           <a:p xmlns:a="http://schemas.openxmlformats.org/drawingml/2006/main">
             <a:pPr algn="l">
-              <a:buNone/>
               <a:defRPr sz="1800" b="0">
                 <a:solidFill>
                   <a:srgbClr val="24324A"/>
@@ -19857,7 +19291,6 @@
           </a:p>
           <a:p xmlns:a="http://schemas.openxmlformats.org/drawingml/2006/main">
             <a:pPr algn="l">
-              <a:buNone/>
               <a:defRPr sz="1800" b="0">
                 <a:solidFill>
                   <a:srgbClr val="24324A"/>
@@ -19886,7 +19319,7 @@
           <p:cNvPr id="67" name="">
             <a:extLst xmlns:a="http://schemas.openxmlformats.org/drawingml/2006/main">
               <a:ext uri="{FF2B5EF4-FFF2-40B4-BE49-F238E27FC236}">
-                <a16:creationId xmlns:a16="http://schemas.microsoft.com/office/drawing/2014/main" id="{EA928F77-F2EF-42C7-8912-E723DC9F84AB}"/>
+                <a16:creationId xmlns:a16="http://schemas.microsoft.com/office/drawing/2014/main" id="{BF9547DB-F8F2-4FAB-A13A-60CFC8E078CF}"/>
               </a:ext>
             </a:extLst>
           </p:cNvPr>
@@ -19917,7 +19350,7 @@
           <p:cNvPr id="68" name="08 주요 참고문헌">
             <a:extLst xmlns:a="http://schemas.openxmlformats.org/drawingml/2006/main">
               <a:ext uri="{FF2B5EF4-FFF2-40B4-BE49-F238E27FC236}">
-                <a16:creationId xmlns:a16="http://schemas.microsoft.com/office/drawing/2014/main" id="{397120A7-6652-4A46-B1DB-C62B417681E0}"/>
+                <a16:creationId xmlns:a16="http://schemas.microsoft.com/office/drawing/2014/main" id="{8E21C8BA-10A1-40E1-9AA9-6C82383CFB63}"/>
               </a:ext>
             </a:extLst>
           </p:cNvPr>
@@ -20047,7 +19480,6 @@
           </a:lstStyle>
           <a:p xmlns:a="http://schemas.openxmlformats.org/drawingml/2006/main">
             <a:pPr algn="l">
-              <a:buNone/>
               <a:defRPr sz="2400" b="0">
                 <a:solidFill>
                   <a:srgbClr val="FFFFFF"/>
@@ -20076,7 +19508,7 @@
           <p:cNvPr id="69" name="[1] Lewis et al. RAG. NeurIPS, 2020. [2] Gao et al. HyDE. ACL, 20">
             <a:extLst xmlns:a="http://schemas.openxmlformats.org/drawingml/2006/main">
               <a:ext uri="{FF2B5EF4-FFF2-40B4-BE49-F238E27FC236}">
-                <a16:creationId xmlns:a16="http://schemas.microsoft.com/office/drawing/2014/main" id="{63179EAE-09ED-447D-A0C7-72C8A7116635}"/>
+                <a16:creationId xmlns:a16="http://schemas.microsoft.com/office/drawing/2014/main" id="{9027F5CF-D9A8-40BC-AD80-2B5D08A5BF72}"/>
               </a:ext>
             </a:extLst>
           </p:cNvPr>
@@ -20206,7 +19638,6 @@
           </a:lstStyle>
           <a:p xmlns:a="http://schemas.openxmlformats.org/drawingml/2006/main">
             <a:pPr algn="l">
-              <a:buNone/>
               <a:defRPr sz="1600" b="0">
                 <a:solidFill>
                   <a:srgbClr val="24324A"/>
@@ -20230,7 +19661,6 @@
           </a:p>
           <a:p xmlns:a="http://schemas.openxmlformats.org/drawingml/2006/main">
             <a:pPr algn="l">
-              <a:buNone/>
               <a:defRPr sz="1600" b="0">
                 <a:solidFill>
                   <a:srgbClr val="24324A"/>
@@ -20254,7 +19684,6 @@
           </a:p>
           <a:p xmlns:a="http://schemas.openxmlformats.org/drawingml/2006/main">
             <a:pPr algn="l">
-              <a:buNone/>
               <a:defRPr sz="1600" b="0">
                 <a:solidFill>
                   <a:srgbClr val="24324A"/>
@@ -20283,7 +19712,7 @@
           <p:cNvPr id="70" name="[4] Li et al. Language Drift and SCD. AAAI, 2026. [5] Chen et al.">
             <a:extLst xmlns:a="http://schemas.openxmlformats.org/drawingml/2006/main">
               <a:ext uri="{FF2B5EF4-FFF2-40B4-BE49-F238E27FC236}">
-                <a16:creationId xmlns:a16="http://schemas.microsoft.com/office/drawing/2014/main" id="{E5E7E863-54BB-4C29-BCFA-80F5EE009DAD}"/>
+                <a16:creationId xmlns:a16="http://schemas.microsoft.com/office/drawing/2014/main" id="{BDE32D7C-C746-43C7-A10B-1D4ED4A0E095}"/>
               </a:ext>
             </a:extLst>
           </p:cNvPr>
@@ -20413,7 +19842,6 @@
           </a:lstStyle>
           <a:p xmlns:a="http://schemas.openxmlformats.org/drawingml/2006/main">
             <a:pPr algn="l">
-              <a:buNone/>
               <a:defRPr sz="1600" b="0">
                 <a:solidFill>
                   <a:srgbClr val="24324A"/>
@@ -20437,7 +19865,6 @@
           </a:p>
           <a:p xmlns:a="http://schemas.openxmlformats.org/drawingml/2006/main">
             <a:pPr algn="l">
-              <a:buNone/>
               <a:defRPr sz="1600" b="0">
                 <a:solidFill>
                   <a:srgbClr val="24324A"/>
@@ -20461,7 +19888,6 @@
           </a:p>
           <a:p xmlns:a="http://schemas.openxmlformats.org/drawingml/2006/main">
             <a:pPr algn="l">
-              <a:buNone/>
               <a:defRPr sz="1600" b="0">
                 <a:solidFill>
                   <a:srgbClr val="24324A"/>
@@ -20490,7 +19916,7 @@
           <p:cNvPr id="71" name="[6] Robertson et al. Okapi at TREC-3. NIST, 1995. [7] Cormack et ">
             <a:extLst xmlns:a="http://schemas.openxmlformats.org/drawingml/2006/main">
               <a:ext uri="{FF2B5EF4-FFF2-40B4-BE49-F238E27FC236}">
-                <a16:creationId xmlns:a16="http://schemas.microsoft.com/office/drawing/2014/main" id="{22D781C6-63DB-4A76-836E-7616E1BB7FB1}"/>
+                <a16:creationId xmlns:a16="http://schemas.microsoft.com/office/drawing/2014/main" id="{967E668E-7DDD-43D5-8531-7598CDF90764}"/>
               </a:ext>
             </a:extLst>
           </p:cNvPr>
@@ -20620,7 +20046,6 @@
           </a:lstStyle>
           <a:p xmlns:a="http://schemas.openxmlformats.org/drawingml/2006/main">
             <a:pPr algn="l">
-              <a:buNone/>
               <a:defRPr sz="1600" b="0">
                 <a:solidFill>
                   <a:srgbClr val="24324A"/>
@@ -20644,7 +20069,6 @@
           </a:p>
           <a:p xmlns:a="http://schemas.openxmlformats.org/drawingml/2006/main">
             <a:pPr algn="l">
-              <a:buNone/>
               <a:defRPr sz="1600" b="0">
                 <a:solidFill>
                   <a:srgbClr val="24324A"/>
@@ -20673,7 +20097,7 @@
           <p:cNvPr id="72" name="[8] MacAvaney et al. CEDR. SIGIR, 2019. 공식 모델  [M1] KT Mi:dm 2.0 ">
             <a:extLst xmlns:a="http://schemas.openxmlformats.org/drawingml/2006/main">
               <a:ext uri="{FF2B5EF4-FFF2-40B4-BE49-F238E27FC236}">
-                <a16:creationId xmlns:a16="http://schemas.microsoft.com/office/drawing/2014/main" id="{23856CA5-4F76-4A97-BCC1-7FFD4E9DFFAE}"/>
+                <a16:creationId xmlns:a16="http://schemas.microsoft.com/office/drawing/2014/main" id="{CDDB70DA-6C87-4FA4-92AB-9773A9A6BBF0}"/>
               </a:ext>
             </a:extLst>
           </p:cNvPr>
@@ -20803,7 +20227,6 @@
           </a:lstStyle>
           <a:p xmlns:a="http://schemas.openxmlformats.org/drawingml/2006/main">
             <a:pPr algn="l">
-              <a:buNone/>
               <a:defRPr sz="1600" b="0">
                 <a:solidFill>
                   <a:srgbClr val="24324A"/>
@@ -20827,7 +20250,6 @@
           </a:p>
           <a:p xmlns:a="http://schemas.openxmlformats.org/drawingml/2006/main">
             <a:pPr algn="l">
-              <a:buNone/>
               <a:defRPr sz="1600" b="0">
                 <a:solidFill>
                   <a:srgbClr val="24324A"/>
@@ -20853,10 +20275,10 @@
       </p:sp>
       <p:sp>
         <p:nvSpPr>
-          <p:cNvPr id="73" name="학술 22편·모델·자료 출처: 동봉 POSTER_REFERENCES_FULL.md · 통계·결측·민감도 분석: 동봉 ">
+          <p:cNvPr id="73" name="학술 22편·모델·자료 출처: FINALDOCS/VALIDATION/REFERENCES.md · 통계·민감도: 동봉 ">
             <a:extLst xmlns:a="http://schemas.openxmlformats.org/drawingml/2006/main">
               <a:ext uri="{FF2B5EF4-FFF2-40B4-BE49-F238E27FC236}">
-                <a16:creationId xmlns:a16="http://schemas.microsoft.com/office/drawing/2014/main" id="{A5E2237D-D31E-44E0-8008-6AA4979CDF7D}"/>
+                <a16:creationId xmlns:a16="http://schemas.microsoft.com/office/drawing/2014/main" id="{4317AC15-8CA5-4059-B48C-A4346EA72ECA}"/>
               </a:ext>
             </a:extLst>
           </p:cNvPr>
@@ -20986,7 +20408,6 @@
           </a:lstStyle>
           <a:p xmlns:a="http://schemas.openxmlformats.org/drawingml/2006/main">
             <a:pPr algn="l">
-              <a:buNone/>
               <a:defRPr sz="1600" b="0">
                 <a:solidFill>
                   <a:srgbClr val="24324A"/>
@@ -21015,7 +20436,7 @@
           <p:cNvPr id="74" name="영어 문서 4종 · 질의 60개 · 생성 모델 1종 · 질의별 반복측정">
             <a:extLst xmlns:a="http://schemas.openxmlformats.org/drawingml/2006/main">
               <a:ext uri="{FF2B5EF4-FFF2-40B4-BE49-F238E27FC236}">
-                <a16:creationId xmlns:a16="http://schemas.microsoft.com/office/drawing/2014/main" id="{14C402B1-41B4-4B19-BCF5-8CC97C5F7CBB}"/>
+                <a16:creationId xmlns:a16="http://schemas.microsoft.com/office/drawing/2014/main" id="{A4DEB587-C8F4-45DF-8AB7-C17238C39793}"/>
               </a:ext>
             </a:extLst>
           </p:cNvPr>
@@ -21145,7 +20566,6 @@
           </a:lstStyle>
           <a:p xmlns:a="http://schemas.openxmlformats.org/drawingml/2006/main">
             <a:pPr algn="l">
-              <a:buNone/>
               <a:defRPr sz="1400" b="0">
                 <a:solidFill>
                   <a:srgbClr val="695184"/>
@@ -21174,7 +20594,7 @@
           <p:cNvPr id="75" name="A1 594 × 841 mm">
             <a:extLst xmlns:a="http://schemas.openxmlformats.org/drawingml/2006/main">
               <a:ext uri="{FF2B5EF4-FFF2-40B4-BE49-F238E27FC236}">
-                <a16:creationId xmlns:a16="http://schemas.microsoft.com/office/drawing/2014/main" id="{054E15FE-62B2-4307-9CD2-8E5084005506}"/>
+                <a16:creationId xmlns:a16="http://schemas.microsoft.com/office/drawing/2014/main" id="{8495BF88-5658-434D-95EA-28B434C210D7}"/>
               </a:ext>
             </a:extLst>
           </p:cNvPr>
@@ -21304,7 +20724,6 @@
           </a:lstStyle>
           <a:p xmlns:a="http://schemas.openxmlformats.org/drawingml/2006/main">
             <a:pPr algn="r">
-              <a:buNone/>
               <a:defRPr sz="1050" b="0">
                 <a:solidFill>
                   <a:srgbClr val="695184"/>
@@ -21331,7 +20750,7 @@
     </p:spTree>
     <p:extLst>
       <p:ext uri="{BB962C8B-B14F-4D97-AF65-F5344CB8AC3E}">
-        <p14:creationId xmlns:p14="http://schemas.microsoft.com/office/powerpoint/2010/main" val="1012599631"/>
+        <p14:creationId xmlns:p14="http://schemas.microsoft.com/office/powerpoint/2010/main" val="2087134093"/>
       </p:ext>
     </p:extLst>
   </p:cSld>

</xml_diff>

<commit_message>
Align thesis recommendations with tested conditions and fix poster runtime ratio
- 6.3: replace the SCD+HyDE recommendation with the C0S0 (+0.080, p=0.029)
  and exploratory C0S1 (+0.072, p=0.114) HyDE comparisons
- 6.2/5.7/5.8: state CAD and HyDE results as measured differences, drop the
  redundant RQ1 scope sentence, distinguish string vs. content difference
- Replace ON/OFF phrasing with 적용/미적용; soften causal claim in 3.1 and
  the CAD lineage claim in 2.7; describe appendix B-4 as a selected case
- Poster: CAD runtime as 3.1x (SCD off) / 2.7x (SCD on); wording cleanup
- Regenerate HWPX/PDF (51 pages, positions unchanged) and refresh manifests

Co-Authored-By: Claude Opus 5.5 <noreply@anthropic.com>
</commit_message>
<xml_diff>
--- a/FINALDOCS/POSTER/FINAL/M_RAG_A1_FINAL_EDITABLE.pptx
+++ b/FINALDOCS/POSTER/FINAL/M_RAG_A1_FINAL_EDITABLE.pptx
@@ -2,13 +2,13 @@
 <file path=ppt/presentation.xml><?xml version="1.0" encoding="utf-8"?>
 <p:presentation xmlns:p="http://schemas.openxmlformats.org/presentationml/2006/main">
   <p:sldMasterIdLst>
-    <p:sldMasterId xmlns:r="http://schemas.openxmlformats.org/officeDocument/2006/relationships" id="2147483648" r:id="R5417218fc1ae4ba1"/>
+    <p:sldMasterId xmlns:r="http://schemas.openxmlformats.org/officeDocument/2006/relationships" id="2147483648" r:id="R3b11d35200044fea"/>
   </p:sldMasterIdLst>
   <p:notesMasterIdLst>
-    <p:notesMasterId xmlns:r="http://schemas.openxmlformats.org/officeDocument/2006/relationships" r:id="R49f02fc842f04598"/>
+    <p:notesMasterId xmlns:r="http://schemas.openxmlformats.org/officeDocument/2006/relationships" r:id="R4949fc67fcff473a"/>
   </p:notesMasterIdLst>
   <p:sldIdLst>
-    <p:sldId xmlns:r="http://schemas.openxmlformats.org/officeDocument/2006/relationships" id="256" r:id="Reae5f24be768419a"/>
+    <p:sldId xmlns:r="http://schemas.openxmlformats.org/officeDocument/2006/relationships" id="256" r:id="Re562c2222906468f"/>
   </p:sldIdLst>
   <p:sldSz cx="21384000" cy="30276000"/>
   <p:notesSz cx="6858000" cy="9144000"/>
@@ -489,7 +489,7 @@
           <p:cNvPr id="3" name="Title">
             <a:extLst xmlns:a="http://schemas.openxmlformats.org/drawingml/2006/main">
               <a:ext uri="{FF2B5EF4-FFF2-40B4-BE49-F238E27FC236}">
-                <a16:creationId xmlns:a16="http://schemas.microsoft.com/office/drawing/2014/main" id="{707AB210-BD38-4486-97DB-EA36056D05B3}"/>
+                <a16:creationId xmlns:a16="http://schemas.microsoft.com/office/drawing/2014/main" id="{3AA86962-2AB5-423F-9184-841619492E28}"/>
               </a:ext>
             </a:extLst>
           </p:cNvPr>
@@ -718,7 +718,7 @@
           <p:cNvPr id="2" name="Subtitle">
             <a:extLst xmlns:a="http://schemas.openxmlformats.org/drawingml/2006/main">
               <a:ext uri="{FF2B5EF4-FFF2-40B4-BE49-F238E27FC236}">
-                <a16:creationId xmlns:a16="http://schemas.microsoft.com/office/drawing/2014/main" id="{812D2440-1B0F-4561-8FF5-5C56FF7FABBE}"/>
+                <a16:creationId xmlns:a16="http://schemas.microsoft.com/office/drawing/2014/main" id="{813FB6E7-6EF6-42BD-A34D-414BC2206906}"/>
               </a:ext>
             </a:extLst>
           </p:cNvPr>
@@ -964,7 +964,7 @@
           <p:cNvPr id="2" name="Section title">
             <a:extLst xmlns:a="http://schemas.openxmlformats.org/drawingml/2006/main">
               <a:ext uri="{FF2B5EF4-FFF2-40B4-BE49-F238E27FC236}">
-                <a16:creationId xmlns:a16="http://schemas.microsoft.com/office/drawing/2014/main" id="{8CB89280-5C8C-45A9-8BD8-A6F9CC1EE3DC}"/>
+                <a16:creationId xmlns:a16="http://schemas.microsoft.com/office/drawing/2014/main" id="{7C3B6948-9802-42E4-891A-2FDF91DB9D23}"/>
               </a:ext>
             </a:extLst>
           </p:cNvPr>
@@ -1210,7 +1210,7 @@
           <p:cNvPr id="3" name="Title">
             <a:extLst xmlns:a="http://schemas.openxmlformats.org/drawingml/2006/main">
               <a:ext uri="{FF2B5EF4-FFF2-40B4-BE49-F238E27FC236}">
-                <a16:creationId xmlns:a16="http://schemas.microsoft.com/office/drawing/2014/main" id="{088BABFC-DA41-4346-8F53-202C7A4AA4F6}"/>
+                <a16:creationId xmlns:a16="http://schemas.microsoft.com/office/drawing/2014/main" id="{613578F9-ADE6-4FE3-80B0-DEAB4999D3C7}"/>
               </a:ext>
             </a:extLst>
           </p:cNvPr>
@@ -1439,7 +1439,7 @@
           <p:cNvPr id="2" name="Body">
             <a:extLst xmlns:a="http://schemas.openxmlformats.org/drawingml/2006/main">
               <a:ext uri="{FF2B5EF4-FFF2-40B4-BE49-F238E27FC236}">
-                <a16:creationId xmlns:a16="http://schemas.microsoft.com/office/drawing/2014/main" id="{02A25B0B-B3B5-4736-8FA4-621DB9F0DC31}"/>
+                <a16:creationId xmlns:a16="http://schemas.microsoft.com/office/drawing/2014/main" id="{182CC6BC-3C4E-41DB-B691-BA7509FA687F}"/>
               </a:ext>
             </a:extLst>
           </p:cNvPr>
@@ -1685,7 +1685,7 @@
           <p:cNvPr id="4" name="Title">
             <a:extLst xmlns:a="http://schemas.openxmlformats.org/drawingml/2006/main">
               <a:ext uri="{FF2B5EF4-FFF2-40B4-BE49-F238E27FC236}">
-                <a16:creationId xmlns:a16="http://schemas.microsoft.com/office/drawing/2014/main" id="{9B8AB8E3-6DB0-4918-BF61-4EE2258585C8}"/>
+                <a16:creationId xmlns:a16="http://schemas.microsoft.com/office/drawing/2014/main" id="{E2A24762-7A6B-4A7B-A25E-B784FBBE4A2D}"/>
               </a:ext>
             </a:extLst>
           </p:cNvPr>
@@ -1914,7 +1914,7 @@
           <p:cNvPr id="2" name="Left column">
             <a:extLst xmlns:a="http://schemas.openxmlformats.org/drawingml/2006/main">
               <a:ext uri="{FF2B5EF4-FFF2-40B4-BE49-F238E27FC236}">
-                <a16:creationId xmlns:a16="http://schemas.microsoft.com/office/drawing/2014/main" id="{D7344E96-722C-48AA-A9B8-94E74EF9848E}"/>
+                <a16:creationId xmlns:a16="http://schemas.microsoft.com/office/drawing/2014/main" id="{B4C97ECD-3ECE-4C3B-B162-E85B6B5C5D50}"/>
               </a:ext>
             </a:extLst>
           </p:cNvPr>
@@ -2143,7 +2143,7 @@
           <p:cNvPr id="3" name="Right column">
             <a:extLst xmlns:a="http://schemas.openxmlformats.org/drawingml/2006/main">
               <a:ext uri="{FF2B5EF4-FFF2-40B4-BE49-F238E27FC236}">
-                <a16:creationId xmlns:a16="http://schemas.microsoft.com/office/drawing/2014/main" id="{47A5DC7E-84C6-494C-A226-4FE6972448AE}"/>
+                <a16:creationId xmlns:a16="http://schemas.microsoft.com/office/drawing/2014/main" id="{8D55F3E0-22BF-4E1B-AA61-83819AA920D5}"/>
               </a:ext>
             </a:extLst>
           </p:cNvPr>
@@ -2389,7 +2389,7 @@
           <p:cNvPr id="3" name="Title">
             <a:extLst xmlns:a="http://schemas.openxmlformats.org/drawingml/2006/main">
               <a:ext uri="{FF2B5EF4-FFF2-40B4-BE49-F238E27FC236}">
-                <a16:creationId xmlns:a16="http://schemas.microsoft.com/office/drawing/2014/main" id="{541C9FAC-A4C6-470B-8229-354C7B702F2D}"/>
+                <a16:creationId xmlns:a16="http://schemas.microsoft.com/office/drawing/2014/main" id="{E350ABDD-06B5-4000-B9F1-A7ABB4687E4B}"/>
               </a:ext>
             </a:extLst>
           </p:cNvPr>
@@ -2618,7 +2618,7 @@
           <p:cNvPr id="2" name="Left column">
             <a:extLst xmlns:a="http://schemas.openxmlformats.org/drawingml/2006/main">
               <a:ext uri="{FF2B5EF4-FFF2-40B4-BE49-F238E27FC236}">
-                <a16:creationId xmlns:a16="http://schemas.microsoft.com/office/drawing/2014/main" id="{BC7E0CD2-48B2-4422-BEB5-3277059A74F7}"/>
+                <a16:creationId xmlns:a16="http://schemas.microsoft.com/office/drawing/2014/main" id="{499283E6-2D31-4BF4-985F-57FBEFF928C6}"/>
               </a:ext>
             </a:extLst>
           </p:cNvPr>
@@ -2885,12 +2885,12 @@
   </p:cSld>
   <p:clrMap bg1="lt1" tx1="dk1" bg2="lt2" tx2="dk2" accent1="accent1" accent2="accent2" accent3="accent3" accent4="accent4" accent5="accent5" accent6="accent6" hlink="hlink" folHlink="folHlink"/>
   <p:sldLayoutIdLst>
-    <p:sldLayoutId xmlns:r="http://schemas.openxmlformats.org/officeDocument/2006/relationships" id="2147483649" r:id="Rb40d50c614da453e"/>
-    <p:sldLayoutId xmlns:r="http://schemas.openxmlformats.org/officeDocument/2006/relationships" id="2147483650" r:id="R2b5172b4502b42a9"/>
-    <p:sldLayoutId xmlns:r="http://schemas.openxmlformats.org/officeDocument/2006/relationships" id="2147483651" r:id="R676a8a6a8303435f"/>
-    <p:sldLayoutId xmlns:r="http://schemas.openxmlformats.org/officeDocument/2006/relationships" id="2147483652" r:id="Rd814fbdf71cc4864"/>
-    <p:sldLayoutId xmlns:r="http://schemas.openxmlformats.org/officeDocument/2006/relationships" id="2147483653" r:id="R2854fdb348ce412c"/>
-    <p:sldLayoutId xmlns:r="http://schemas.openxmlformats.org/officeDocument/2006/relationships" id="2147483654" r:id="R88345d678e79417a"/>
+    <p:sldLayoutId xmlns:r="http://schemas.openxmlformats.org/officeDocument/2006/relationships" id="2147483649" r:id="R795ce3ad7e394fb8"/>
+    <p:sldLayoutId xmlns:r="http://schemas.openxmlformats.org/officeDocument/2006/relationships" id="2147483650" r:id="R0b81810b648a49ad"/>
+    <p:sldLayoutId xmlns:r="http://schemas.openxmlformats.org/officeDocument/2006/relationships" id="2147483651" r:id="Rf696abf199374e04"/>
+    <p:sldLayoutId xmlns:r="http://schemas.openxmlformats.org/officeDocument/2006/relationships" id="2147483652" r:id="R3c9cb9491df94465"/>
+    <p:sldLayoutId xmlns:r="http://schemas.openxmlformats.org/officeDocument/2006/relationships" id="2147483653" r:id="Rbe4c6c5906ea4ead"/>
+    <p:sldLayoutId xmlns:r="http://schemas.openxmlformats.org/officeDocument/2006/relationships" id="2147483654" r:id="Rd5cb04c378844181"/>
   </p:sldLayoutIdLst>
   <p:txStyles>
     <p:titleStyle>
@@ -3441,7 +3441,7 @@
           <p:cNvPr id="76" name="">
             <a:extLst xmlns:a="http://schemas.openxmlformats.org/drawingml/2006/main">
               <a:ext uri="{FF2B5EF4-FFF2-40B4-BE49-F238E27FC236}">
-                <a16:creationId xmlns:a16="http://schemas.microsoft.com/office/drawing/2014/main" id="{B124FBB7-B6C3-4104-A94E-7B3E70932BD9}"/>
+                <a16:creationId xmlns:a16="http://schemas.microsoft.com/office/drawing/2014/main" id="{88C73751-82B4-443F-8071-6FB12B2BCB52}"/>
               </a:ext>
             </a:extLst>
           </p:cNvPr>
@@ -3472,7 +3472,7 @@
           <p:cNvPr id="2" name="한국어 질의로 영어 학술·기술 문서를 검색하는">
             <a:extLst xmlns:a="http://schemas.openxmlformats.org/drawingml/2006/main">
               <a:ext uri="{FF2B5EF4-FFF2-40B4-BE49-F238E27FC236}">
-                <a16:creationId xmlns:a16="http://schemas.microsoft.com/office/drawing/2014/main" id="{C4A155D7-595D-4D8B-8658-CBCEFA4C0B57}"/>
+                <a16:creationId xmlns:a16="http://schemas.microsoft.com/office/drawing/2014/main" id="{6915451A-423C-4826-9AEA-E7B12F3C45ED}"/>
               </a:ext>
             </a:extLst>
           </p:cNvPr>
@@ -3630,7 +3630,7 @@
           <p:cNvPr id="3" name="RAG에서의 HyDE·CAD·SCD 조합 실험">
             <a:extLst xmlns:a="http://schemas.openxmlformats.org/drawingml/2006/main">
               <a:ext uri="{FF2B5EF4-FFF2-40B4-BE49-F238E27FC236}">
-                <a16:creationId xmlns:a16="http://schemas.microsoft.com/office/drawing/2014/main" id="{61FCBC9A-DB55-46F5-B594-3413370C521E}"/>
+                <a16:creationId xmlns:a16="http://schemas.microsoft.com/office/drawing/2014/main" id="{AFB0096C-AD71-40B5-963D-8015F5AF9EFC}"/>
               </a:ext>
             </a:extLst>
           </p:cNvPr>
@@ -3788,7 +3788,7 @@
           <p:cNvPr id="4" name="문종건 · 동국대학교 WISE캠퍼스 컴퓨터공학과 · 지도교수 김진석 · 2026.10.15">
             <a:extLst xmlns:a="http://schemas.openxmlformats.org/drawingml/2006/main">
               <a:ext uri="{FF2B5EF4-FFF2-40B4-BE49-F238E27FC236}">
-                <a16:creationId xmlns:a16="http://schemas.microsoft.com/office/drawing/2014/main" id="{C8071267-0157-4238-AFF5-9A1C36ED35AA}"/>
+                <a16:creationId xmlns:a16="http://schemas.microsoft.com/office/drawing/2014/main" id="{4A94F85B-9C0D-42F4-8D3C-C46E7E3983D3}"/>
               </a:ext>
             </a:extLst>
           </p:cNvPr>
@@ -3946,7 +3946,7 @@
           <p:cNvPr id="5" name="">
             <a:extLst xmlns:a="http://schemas.openxmlformats.org/drawingml/2006/main">
               <a:ext uri="{FF2B5EF4-FFF2-40B4-BE49-F238E27FC236}">
-                <a16:creationId xmlns:a16="http://schemas.microsoft.com/office/drawing/2014/main" id="{082CA7EC-C4E0-43F4-BD91-C095BB74736F}"/>
+                <a16:creationId xmlns:a16="http://schemas.microsoft.com/office/drawing/2014/main" id="{0C6933EA-D2D1-41BA-8850-498B856C8D19}"/>
               </a:ext>
             </a:extLst>
           </p:cNvPr>
@@ -3977,7 +3977,7 @@
           <p:cNvPr id="6" name="01 연구 배경과 목적">
             <a:extLst xmlns:a="http://schemas.openxmlformats.org/drawingml/2006/main">
               <a:ext uri="{FF2B5EF4-FFF2-40B4-BE49-F238E27FC236}">
-                <a16:creationId xmlns:a16="http://schemas.microsoft.com/office/drawing/2014/main" id="{8D949CEF-55A8-4FDD-8B6B-28C4630F12D3}"/>
+                <a16:creationId xmlns:a16="http://schemas.microsoft.com/office/drawing/2014/main" id="{EB239701-7E97-41A0-BFB6-15D9D22685BC}"/>
               </a:ext>
             </a:extLst>
           </p:cNvPr>
@@ -4135,7 +4135,7 @@
           <p:cNvPr id="7" name="검색 증강 생성(Retrieval-Augmented Generation, RAG)은 관련 문서 구간을 검색하고 그 텍">
             <a:extLst xmlns:a="http://schemas.openxmlformats.org/drawingml/2006/main">
               <a:ext uri="{FF2B5EF4-FFF2-40B4-BE49-F238E27FC236}">
-                <a16:creationId xmlns:a16="http://schemas.microsoft.com/office/drawing/2014/main" id="{F944E483-B7D7-4898-B573-13EF8871D6BD}"/>
+                <a16:creationId xmlns:a16="http://schemas.microsoft.com/office/drawing/2014/main" id="{76735A99-0280-408C-A5EE-FDF2B836BB14}"/>
               </a:ext>
             </a:extLst>
           </p:cNvPr>
@@ -4316,7 +4316,7 @@
           <p:cNvPr id="8" name="HyDE: 가상 문서 임베딩(Hypothetical Document Embeddings) 가상 문서 검색 입력 구성[">
             <a:extLst xmlns:a="http://schemas.openxmlformats.org/drawingml/2006/main">
               <a:ext uri="{FF2B5EF4-FFF2-40B4-BE49-F238E27FC236}">
-                <a16:creationId xmlns:a16="http://schemas.microsoft.com/office/drawing/2014/main" id="{CC390CE8-B618-40EF-92AE-9EB9F1A862AF}"/>
+                <a16:creationId xmlns:a16="http://schemas.microsoft.com/office/drawing/2014/main" id="{264F7FE3-C1FC-4E6E-9445-0AB9A6668735}"/>
               </a:ext>
             </a:extLst>
           </p:cNvPr>
@@ -4586,10 +4586,10 @@
       </p:sp>
       <p:sp>
         <p:nvSpPr>
-          <p:cNvPr id="9" name="HyDE는 한국어 등 다국어 검색에서 평가되었다[2]. 한국어 질의–영어 문서 환경에서 HyDE·CAD·SCD의 개별">
+          <p:cNvPr id="9" name="HyDE는 한국어를 포함한 다국어 검색에서 평가되었다[2]. 한국어 질의–영어 문서 환경에서 HyDE·CAD·SCD의">
             <a:extLst xmlns:a="http://schemas.openxmlformats.org/drawingml/2006/main">
               <a:ext uri="{FF2B5EF4-FFF2-40B4-BE49-F238E27FC236}">
-                <a16:creationId xmlns:a16="http://schemas.microsoft.com/office/drawing/2014/main" id="{7441512C-2F2D-4293-8A03-34A66CCD8C12}"/>
+                <a16:creationId xmlns:a16="http://schemas.microsoft.com/office/drawing/2014/main" id="{EEE91773-F2A8-46BC-9F66-52F03F8BB5E2}"/>
               </a:ext>
             </a:extLst>
           </p:cNvPr>
@@ -4737,7 +4737,7 @@
                 <a:ea typeface="Malgun Gothic"/>
                 <a:cs typeface="Malgun Gothic"/>
               </a:rPr>
-              <a:t>HyDE는 한국어 등 다국어 검색에서 평가되었다[2].</a:t>
+              <a:t>HyDE는 한국어를 포함한 다국어 검색에서 평가되었다[2].</a:t>
             </a:r>
           </a:p>
           <a:p xmlns:a="http://schemas.openxmlformats.org/drawingml/2006/main">
@@ -4793,7 +4793,7 @@
           <p:cNvPr id="10" name="">
             <a:extLst xmlns:a="http://schemas.openxmlformats.org/drawingml/2006/main">
               <a:ext uri="{FF2B5EF4-FFF2-40B4-BE49-F238E27FC236}">
-                <a16:creationId xmlns:a16="http://schemas.microsoft.com/office/drawing/2014/main" id="{AB18E6E9-6112-4C1C-BCA0-E7489CDAC183}"/>
+                <a16:creationId xmlns:a16="http://schemas.microsoft.com/office/drawing/2014/main" id="{53DD512A-CA2D-4291-BB17-BC7D04DEF152}"/>
               </a:ext>
             </a:extLst>
           </p:cNvPr>
@@ -4824,7 +4824,7 @@
           <p:cNvPr id="11" name="02 Paper-RAG 구조와 기법 적용 위치">
             <a:extLst xmlns:a="http://schemas.openxmlformats.org/drawingml/2006/main">
               <a:ext uri="{FF2B5EF4-FFF2-40B4-BE49-F238E27FC236}">
-                <a16:creationId xmlns:a16="http://schemas.microsoft.com/office/drawing/2014/main" id="{438DC46B-263F-4FD4-9624-5D3338F4A549}"/>
+                <a16:creationId xmlns:a16="http://schemas.microsoft.com/office/drawing/2014/main" id="{70563DA3-6481-4079-82B2-1AC4167FD0F3}"/>
               </a:ext>
             </a:extLst>
           </p:cNvPr>
@@ -4982,7 +4982,7 @@
           <p:cNvPr id="12" name="Paper-RAG는 실험에 사용한 고정 검색·생성 파이프라인이다.">
             <a:extLst xmlns:a="http://schemas.openxmlformats.org/drawingml/2006/main">
               <a:ext uri="{FF2B5EF4-FFF2-40B4-BE49-F238E27FC236}">
-                <a16:creationId xmlns:a16="http://schemas.microsoft.com/office/drawing/2014/main" id="{2F6CF8C0-9341-455F-A856-DB9A1C1CEE00}"/>
+                <a16:creationId xmlns:a16="http://schemas.microsoft.com/office/drawing/2014/main" id="{A49FFED5-FCDF-426E-9C5A-1595DA814960}"/>
               </a:ext>
             </a:extLst>
           </p:cNvPr>
@@ -5140,7 +5140,7 @@
           <p:cNvPr id="13" name="">
             <a:extLst xmlns:a="http://schemas.openxmlformats.org/drawingml/2006/main">
               <a:ext uri="{FF2B5EF4-FFF2-40B4-BE49-F238E27FC236}">
-                <a16:creationId xmlns:a16="http://schemas.microsoft.com/office/drawing/2014/main" id="{09865E6C-21E1-4A73-A751-A2E6DDC42935}"/>
+                <a16:creationId xmlns:a16="http://schemas.microsoft.com/office/drawing/2014/main" id="{2B0329C8-30E4-47CB-8A82-D021831C9316}"/>
               </a:ext>
             </a:extLst>
           </p:cNvPr>
@@ -5173,7 +5173,7 @@
           <p:cNvPr id="14" name="한국어 질의 HyDE OFF: 원질의 HyDE ON: 영어 번역·가상 문서">
             <a:extLst xmlns:a="http://schemas.openxmlformats.org/drawingml/2006/main">
               <a:ext uri="{FF2B5EF4-FFF2-40B4-BE49-F238E27FC236}">
-                <a16:creationId xmlns:a16="http://schemas.microsoft.com/office/drawing/2014/main" id="{F55DA3B3-354C-4EC8-9ABA-F2D601C96B30}"/>
+                <a16:creationId xmlns:a16="http://schemas.microsoft.com/office/drawing/2014/main" id="{D0FA7350-3DF6-4C07-A792-00D91A4235A3}"/>
               </a:ext>
             </a:extLst>
           </p:cNvPr>
@@ -5377,7 +5377,7 @@
           <p:cNvPr id="15" name="">
             <a:extLst xmlns:a="http://schemas.openxmlformats.org/drawingml/2006/main">
               <a:ext uri="{FF2B5EF4-FFF2-40B4-BE49-F238E27FC236}">
-                <a16:creationId xmlns:a16="http://schemas.microsoft.com/office/drawing/2014/main" id="{504C5182-1A93-4388-9B51-6982EB3B193E}"/>
+                <a16:creationId xmlns:a16="http://schemas.microsoft.com/office/drawing/2014/main" id="{30AB55E9-E3F7-4106-9237-44C7C992A795}"/>
               </a:ext>
             </a:extLst>
           </p:cNvPr>
@@ -5410,7 +5410,7 @@
           <p:cNvPr id="16" name="BM25 희소 검색[6] 한국어 원질의 사용">
             <a:extLst xmlns:a="http://schemas.openxmlformats.org/drawingml/2006/main">
               <a:ext uri="{FF2B5EF4-FFF2-40B4-BE49-F238E27FC236}">
-                <a16:creationId xmlns:a16="http://schemas.microsoft.com/office/drawing/2014/main" id="{D0DDEE65-E1A3-4BAD-844D-D57FBF0C4B3B}"/>
+                <a16:creationId xmlns:a16="http://schemas.microsoft.com/office/drawing/2014/main" id="{22210D0C-A786-42DA-9311-386002A3CCE2}"/>
               </a:ext>
             </a:extLst>
           </p:cNvPr>
@@ -5591,7 +5591,7 @@
           <p:cNvPr id="17" name="">
             <a:extLst xmlns:a="http://schemas.openxmlformats.org/drawingml/2006/main">
               <a:ext uri="{FF2B5EF4-FFF2-40B4-BE49-F238E27FC236}">
-                <a16:creationId xmlns:a16="http://schemas.microsoft.com/office/drawing/2014/main" id="{D8D0A2E9-78F0-455D-BDDA-A947524DC343}"/>
+                <a16:creationId xmlns:a16="http://schemas.microsoft.com/office/drawing/2014/main" id="{BFA2BE0E-B09F-4C6F-8C71-61D5146D83D0}"/>
               </a:ext>
             </a:extLst>
           </p:cNvPr>
@@ -5624,7 +5624,7 @@
           <p:cNvPr id="18" name="BGE-M3 밀집 검색[5]">
             <a:extLst xmlns:a="http://schemas.openxmlformats.org/drawingml/2006/main">
               <a:ext uri="{FF2B5EF4-FFF2-40B4-BE49-F238E27FC236}">
-                <a16:creationId xmlns:a16="http://schemas.microsoft.com/office/drawing/2014/main" id="{CA787A4A-1279-4BEF-AF99-57ED132FAEF5}"/>
+                <a16:creationId xmlns:a16="http://schemas.microsoft.com/office/drawing/2014/main" id="{1270A6B1-1A25-43F6-A994-A4D2A4F1B766}"/>
               </a:ext>
             </a:extLst>
           </p:cNvPr>
@@ -5782,7 +5782,7 @@
           <p:cNvPr id="19" name="">
             <a:extLst xmlns:a="http://schemas.openxmlformats.org/drawingml/2006/main">
               <a:ext uri="{FF2B5EF4-FFF2-40B4-BE49-F238E27FC236}">
-                <a16:creationId xmlns:a16="http://schemas.microsoft.com/office/drawing/2014/main" id="{CC366CB8-05E1-40E5-B4F5-D1B28B23F601}"/>
+                <a16:creationId xmlns:a16="http://schemas.microsoft.com/office/drawing/2014/main" id="{ADE26CB3-643A-40DB-99A3-568E03727E57}"/>
               </a:ext>
             </a:extLst>
           </p:cNvPr>
@@ -5815,7 +5815,7 @@
           <p:cNvPr id="20" name="가중 RRF[7] 0.6 / 0.4, k=60">
             <a:extLst xmlns:a="http://schemas.openxmlformats.org/drawingml/2006/main">
               <a:ext uri="{FF2B5EF4-FFF2-40B4-BE49-F238E27FC236}">
-                <a16:creationId xmlns:a16="http://schemas.microsoft.com/office/drawing/2014/main" id="{422344FA-B291-462F-B4A4-62F19C965A77}"/>
+                <a16:creationId xmlns:a16="http://schemas.microsoft.com/office/drawing/2014/main" id="{5FE4BAF2-8425-45B5-930F-CCDB66245ED3}"/>
               </a:ext>
             </a:extLst>
           </p:cNvPr>
@@ -5996,7 +5996,7 @@
           <p:cNvPr id="21" name="">
             <a:extLst xmlns:a="http://schemas.openxmlformats.org/drawingml/2006/main">
               <a:ext uri="{FF2B5EF4-FFF2-40B4-BE49-F238E27FC236}">
-                <a16:creationId xmlns:a16="http://schemas.microsoft.com/office/drawing/2014/main" id="{F36FD694-979E-466F-A8AB-384F6A419CF5}"/>
+                <a16:creationId xmlns:a16="http://schemas.microsoft.com/office/drawing/2014/main" id="{F4114495-9911-43C1-8D10-29C3F435FF1C}"/>
               </a:ext>
             </a:extLst>
           </p:cNvPr>
@@ -6028,7 +6028,7 @@
           <p:cNvPr id="22" name="">
             <a:extLst xmlns:a="http://schemas.openxmlformats.org/drawingml/2006/main">
               <a:ext uri="{FF2B5EF4-FFF2-40B4-BE49-F238E27FC236}">
-                <a16:creationId xmlns:a16="http://schemas.microsoft.com/office/drawing/2014/main" id="{E56784AF-6584-4DD1-AF92-D8DA6EE0A735}"/>
+                <a16:creationId xmlns:a16="http://schemas.microsoft.com/office/drawing/2014/main" id="{8592AE65-097C-49D9-B3A9-A909775F771B}"/>
               </a:ext>
             </a:extLst>
           </p:cNvPr>
@@ -6060,7 +6060,7 @@
           <p:cNvPr id="23" name="">
             <a:extLst xmlns:a="http://schemas.openxmlformats.org/drawingml/2006/main">
               <a:ext uri="{FF2B5EF4-FFF2-40B4-BE49-F238E27FC236}">
-                <a16:creationId xmlns:a16="http://schemas.microsoft.com/office/drawing/2014/main" id="{5A85AD56-5C88-4164-A04C-2F19223412A4}"/>
+                <a16:creationId xmlns:a16="http://schemas.microsoft.com/office/drawing/2014/main" id="{637554CB-F632-4498-B350-93130DE07E53}"/>
               </a:ext>
             </a:extLst>
           </p:cNvPr>
@@ -6092,7 +6092,7 @@
           <p:cNvPr id="24" name="">
             <a:extLst xmlns:a="http://schemas.openxmlformats.org/drawingml/2006/main">
               <a:ext uri="{FF2B5EF4-FFF2-40B4-BE49-F238E27FC236}">
-                <a16:creationId xmlns:a16="http://schemas.microsoft.com/office/drawing/2014/main" id="{46AB8170-94B5-4794-8576-54B098E8FD9B}"/>
+                <a16:creationId xmlns:a16="http://schemas.microsoft.com/office/drawing/2014/main" id="{979EA324-C1B2-4649-8C34-753A713EBC8D}"/>
               </a:ext>
             </a:extLst>
           </p:cNvPr>
@@ -6122,10 +6122,10 @@
       </p:sp>
       <p:sp>
         <p:nvSpPr>
-          <p:cNvPr id="25" name="원질의·구간 쌍 CrossEncoder 재정렬[8][M2] 상위 5개 구간 선택·문맥 길이 관리">
+          <p:cNvPr id="25" name="원질의·구간 쌍 CrossEncoder 재정렬[8][M2] 상위 5개 구간 선택·입력 길이 관리">
             <a:extLst xmlns:a="http://schemas.openxmlformats.org/drawingml/2006/main">
               <a:ext uri="{FF2B5EF4-FFF2-40B4-BE49-F238E27FC236}">
-                <a16:creationId xmlns:a16="http://schemas.microsoft.com/office/drawing/2014/main" id="{9609FE25-57BA-43D1-89E6-3ADA9DA6D14B}"/>
+                <a16:creationId xmlns:a16="http://schemas.microsoft.com/office/drawing/2014/main" id="{25CC13DA-564B-47AE-89E2-AC22A18B9C06}"/>
               </a:ext>
             </a:extLst>
           </p:cNvPr>
@@ -6296,7 +6296,7 @@
                 <a:ea typeface="Malgun Gothic"/>
                 <a:cs typeface="Malgun Gothic"/>
               </a:rPr>
-              <a:t>상위 5개 구간 선택·문맥 길이 관리</a:t>
+              <a:t>상위 5개 구간 선택·입력 길이 관리</a:t>
             </a:r>
           </a:p>
         </p:txBody>
@@ -6306,7 +6306,7 @@
           <p:cNvPr id="26" name="">
             <a:extLst xmlns:a="http://schemas.openxmlformats.org/drawingml/2006/main">
               <a:ext uri="{FF2B5EF4-FFF2-40B4-BE49-F238E27FC236}">
-                <a16:creationId xmlns:a16="http://schemas.microsoft.com/office/drawing/2014/main" id="{EA25553B-72A8-424E-9D61-9A5DAC7C675E}"/>
+                <a16:creationId xmlns:a16="http://schemas.microsoft.com/office/drawing/2014/main" id="{D01E416E-7B92-451D-B666-13E59680B6E4}"/>
               </a:ext>
             </a:extLst>
           </p:cNvPr>
@@ -6339,7 +6339,7 @@
           <p:cNvPr id="27" name="Mi:dm 2.0 Base Instruct[M1] CAD 로짓 결합 후 SCD 언어별 조정, 최종 답변 생성">
             <a:extLst xmlns:a="http://schemas.openxmlformats.org/drawingml/2006/main">
               <a:ext uri="{FF2B5EF4-FFF2-40B4-BE49-F238E27FC236}">
-                <a16:creationId xmlns:a16="http://schemas.microsoft.com/office/drawing/2014/main" id="{518D69AC-0FBA-40C5-AB18-EADFA7303051}"/>
+                <a16:creationId xmlns:a16="http://schemas.microsoft.com/office/drawing/2014/main" id="{82D33F64-92E1-4669-8729-C1F040716127}"/>
               </a:ext>
             </a:extLst>
           </p:cNvPr>
@@ -6520,7 +6520,7 @@
           <p:cNvPr id="28" name="">
             <a:extLst xmlns:a="http://schemas.openxmlformats.org/drawingml/2006/main">
               <a:ext uri="{FF2B5EF4-FFF2-40B4-BE49-F238E27FC236}">
-                <a16:creationId xmlns:a16="http://schemas.microsoft.com/office/drawing/2014/main" id="{01517BC2-6B58-4ADD-8AC2-666C5CB6D320}"/>
+                <a16:creationId xmlns:a16="http://schemas.microsoft.com/office/drawing/2014/main" id="{F9FE418E-2F41-4A46-8A3F-E5F8AFA8F0E3}"/>
               </a:ext>
             </a:extLst>
           </p:cNvPr>
@@ -6552,7 +6552,7 @@
           <p:cNvPr id="29" name="">
             <a:extLst xmlns:a="http://schemas.openxmlformats.org/drawingml/2006/main">
               <a:ext uri="{FF2B5EF4-FFF2-40B4-BE49-F238E27FC236}">
-                <a16:creationId xmlns:a16="http://schemas.microsoft.com/office/drawing/2014/main" id="{28721863-CA08-469C-96BC-485DE2265EF8}"/>
+                <a16:creationId xmlns:a16="http://schemas.microsoft.com/office/drawing/2014/main" id="{A0B7D102-7142-4745-B2F3-5861AF5A6AD0}"/>
               </a:ext>
             </a:extLst>
           </p:cNvPr>
@@ -6584,7 +6584,7 @@
           <p:cNvPr id="30" name="">
             <a:extLst xmlns:a="http://schemas.openxmlformats.org/drawingml/2006/main">
               <a:ext uri="{FF2B5EF4-FFF2-40B4-BE49-F238E27FC236}">
-                <a16:creationId xmlns:a16="http://schemas.microsoft.com/office/drawing/2014/main" id="{210B2802-B92D-4E74-AC9C-3D43C44E4F84}"/>
+                <a16:creationId xmlns:a16="http://schemas.microsoft.com/office/drawing/2014/main" id="{07CB35E2-A813-44BF-890D-9B3C02238C1D}"/>
               </a:ext>
             </a:extLst>
           </p:cNvPr>
@@ -6615,7 +6615,7 @@
           <p:cNvPr id="31" name="03 3요인 완전요인 실험 설계">
             <a:extLst xmlns:a="http://schemas.openxmlformats.org/drawingml/2006/main">
               <a:ext uri="{FF2B5EF4-FFF2-40B4-BE49-F238E27FC236}">
-                <a16:creationId xmlns:a16="http://schemas.microsoft.com/office/drawing/2014/main" id="{78A3373B-0A9D-4529-8EF6-3AC3C96D63BD}"/>
+                <a16:creationId xmlns:a16="http://schemas.microsoft.com/office/drawing/2014/main" id="{0D8CA60C-18D4-4689-B927-38A94448A0B9}"/>
               </a:ext>
             </a:extLst>
           </p:cNvPr>
@@ -6773,7 +6773,7 @@
           <p:cNvPr id="32" name="H=HyDE, C=CAD, S=SCD   0=미적용, 1=적용">
             <a:extLst xmlns:a="http://schemas.openxmlformats.org/drawingml/2006/main">
               <a:ext uri="{FF2B5EF4-FFF2-40B4-BE49-F238E27FC236}">
-                <a16:creationId xmlns:a16="http://schemas.microsoft.com/office/drawing/2014/main" id="{D1D5D367-CA52-4DA3-AA01-5984FFC8B102}"/>
+                <a16:creationId xmlns:a16="http://schemas.microsoft.com/office/drawing/2014/main" id="{6B96E66F-F899-485C-ACBD-371F77DD727A}"/>
               </a:ext>
             </a:extLst>
           </p:cNvPr>
@@ -6931,7 +6931,7 @@
           <p:cNvPr id="33" name="">
             <a:extLst xmlns:a="http://schemas.openxmlformats.org/drawingml/2006/main">
               <a:ext uri="{FF2B5EF4-FFF2-40B4-BE49-F238E27FC236}">
-                <a16:creationId xmlns:a16="http://schemas.microsoft.com/office/drawing/2014/main" id="{C3BC8A11-3B74-4240-9922-1C2A6D735EFC}"/>
+                <a16:creationId xmlns:a16="http://schemas.microsoft.com/office/drawing/2014/main" id="{810D0D89-E0E5-486B-885C-C70AB4A728ED}"/>
               </a:ext>
             </a:extLst>
           </p:cNvPr>
@@ -8461,7 +8461,7 @@
           <p:cNvPr id="34" name="같은 질의 60개 × 8조건 반복측정 = 480개 생성 기록">
             <a:extLst xmlns:a="http://schemas.openxmlformats.org/drawingml/2006/main">
               <a:ext uri="{FF2B5EF4-FFF2-40B4-BE49-F238E27FC236}">
-                <a16:creationId xmlns:a16="http://schemas.microsoft.com/office/drawing/2014/main" id="{078D1A9C-A262-4CDA-8905-D8DE88F863AD}"/>
+                <a16:creationId xmlns:a16="http://schemas.microsoft.com/office/drawing/2014/main" id="{BECD48E8-8D7A-4887-9200-F8763108EA15}"/>
               </a:ext>
             </a:extLst>
           </p:cNvPr>
@@ -8619,7 +8619,7 @@
           <p:cNvPr id="35" name="생성 512토큰, CAD α=0.5, SCD α=1.1·β=0.9·Tstart=5">
             <a:extLst xmlns:a="http://schemas.openxmlformats.org/drawingml/2006/main">
               <a:ext uri="{FF2B5EF4-FFF2-40B4-BE49-F238E27FC236}">
-                <a16:creationId xmlns:a16="http://schemas.microsoft.com/office/drawing/2014/main" id="{E4A45FB3-1DB6-4774-9F72-C3F409182A83}"/>
+                <a16:creationId xmlns:a16="http://schemas.microsoft.com/office/drawing/2014/main" id="{7AF80AF9-8150-449F-9AB0-3D3BBCCA6313}"/>
               </a:ext>
             </a:extLst>
           </p:cNvPr>
@@ -8777,7 +8777,7 @@
           <p:cNvPr id="36" name="문서 요약을 15개 내용 단위로 나누어 질의를 작성하고, 총 60개 질의의 원문 페이지·정답 근거·답변 가능성을 확인">
             <a:extLst xmlns:a="http://schemas.openxmlformats.org/drawingml/2006/main">
               <a:ext uri="{FF2B5EF4-FFF2-40B4-BE49-F238E27FC236}">
-                <a16:creationId xmlns:a16="http://schemas.microsoft.com/office/drawing/2014/main" id="{6DDA1723-3294-441D-83EB-9842CA8A28C9}"/>
+                <a16:creationId xmlns:a16="http://schemas.microsoft.com/office/drawing/2014/main" id="{9DE22CE4-2591-4B6F-930E-8AE0E06FC3EE}"/>
               </a:ext>
             </a:extLst>
           </p:cNvPr>
@@ -8958,7 +8958,7 @@
           <p:cNvPr id="37" name="">
             <a:extLst xmlns:a="http://schemas.openxmlformats.org/drawingml/2006/main">
               <a:ext uri="{FF2B5EF4-FFF2-40B4-BE49-F238E27FC236}">
-                <a16:creationId xmlns:a16="http://schemas.microsoft.com/office/drawing/2014/main" id="{98BEAC82-B3FD-45C4-A0DA-C894B67D1ECA}"/>
+                <a16:creationId xmlns:a16="http://schemas.microsoft.com/office/drawing/2014/main" id="{BB7D6B8B-BC7B-4F32-BA88-CF986D56E9B0}"/>
               </a:ext>
             </a:extLst>
           </p:cNvPr>
@@ -8989,7 +8989,7 @@
           <p:cNvPr id="38" name="04 평가 지표 및 실험·통계 방법">
             <a:extLst xmlns:a="http://schemas.openxmlformats.org/drawingml/2006/main">
               <a:ext uri="{FF2B5EF4-FFF2-40B4-BE49-F238E27FC236}">
-                <a16:creationId xmlns:a16="http://schemas.microsoft.com/office/drawing/2014/main" id="{1C2AC397-8D8E-4B7F-B11B-1C24458AF243}"/>
+                <a16:creationId xmlns:a16="http://schemas.microsoft.com/office/drawing/2014/main" id="{1EFF305F-73A6-4621-9119-01D3B2F76CBE}"/>
               </a:ext>
             </a:extLst>
           </p:cNvPr>
@@ -9147,7 +9147,7 @@
           <p:cNvPr id="39" name="근거 충실도: 높을수록 검색 근거가 지지하는 답변 주장 비율이 크다. 답변 관련성: 높을수록 답변 기반 질문과 원질문">
             <a:extLst xmlns:a="http://schemas.openxmlformats.org/drawingml/2006/main">
               <a:ext uri="{FF2B5EF4-FFF2-40B4-BE49-F238E27FC236}">
-                <a16:creationId xmlns:a16="http://schemas.microsoft.com/office/drawing/2014/main" id="{5DA0CC21-F217-49D5-AE74-163C9AFD4D8D}"/>
+                <a16:creationId xmlns:a16="http://schemas.microsoft.com/office/drawing/2014/main" id="{FD0807A8-1646-437A-9DE4-245C02141654}"/>
               </a:ext>
             </a:extLst>
           </p:cNvPr>
@@ -9397,7 +9397,7 @@
           <p:cNvPr id="40" name="품질 관측값은 0~1이다. 관련성 +0.080은 ON−OFF 평균 차이 0.080점이다. SD는 질의별 분포의 표본표">
             <a:extLst xmlns:a="http://schemas.openxmlformats.org/drawingml/2006/main">
               <a:ext uri="{FF2B5EF4-FFF2-40B4-BE49-F238E27FC236}">
-                <a16:creationId xmlns:a16="http://schemas.microsoft.com/office/drawing/2014/main" id="{C2E699DF-B4FA-48E9-971C-781E7B4B17C1}"/>
+                <a16:creationId xmlns:a16="http://schemas.microsoft.com/office/drawing/2014/main" id="{7F4D7193-6242-48E4-B011-335BA633D070}"/>
               </a:ext>
             </a:extLst>
           </p:cNvPr>
@@ -9601,7 +9601,7 @@
           <p:cNvPr id="41" name="평가 예시  ext_raptor_011, H0C0S0">
             <a:extLst xmlns:a="http://schemas.openxmlformats.org/drawingml/2006/main">
               <a:ext uri="{FF2B5EF4-FFF2-40B4-BE49-F238E27FC236}">
-                <a16:creationId xmlns:a16="http://schemas.microsoft.com/office/drawing/2014/main" id="{E83DCFB9-23AE-4599-9D91-9CE6CD537763}"/>
+                <a16:creationId xmlns:a16="http://schemas.microsoft.com/office/drawing/2014/main" id="{C3412673-FF58-4B98-BDD5-3CBD33AAA2B1}"/>
               </a:ext>
             </a:extLst>
           </p:cNvPr>
@@ -9759,7 +9759,7 @@
           <p:cNvPr id="42" name="질문: Cinderella 사례의 정성 분석에서 RAPTOR의 tree-based retrieval이 DPR보다 주제">
             <a:extLst xmlns:a="http://schemas.openxmlformats.org/drawingml/2006/main">
               <a:ext uri="{FF2B5EF4-FFF2-40B4-BE49-F238E27FC236}">
-                <a16:creationId xmlns:a16="http://schemas.microsoft.com/office/drawing/2014/main" id="{8E532899-727A-4EAA-A060-E244AD849D8C}"/>
+                <a16:creationId xmlns:a16="http://schemas.microsoft.com/office/drawing/2014/main" id="{DEE45DEB-C207-4D3A-800A-9765715FE6CF}"/>
               </a:ext>
             </a:extLst>
           </p:cNvPr>
@@ -9940,7 +9940,7 @@
           <p:cNvPr id="43" name="검색 근거(PDF p.9): “By providing both the original text and higher-l">
             <a:extLst xmlns:a="http://schemas.openxmlformats.org/drawingml/2006/main">
               <a:ext uri="{FF2B5EF4-FFF2-40B4-BE49-F238E27FC236}">
-                <a16:creationId xmlns:a16="http://schemas.microsoft.com/office/drawing/2014/main" id="{E8B24F52-820F-438E-B9E2-E46199A906DB}"/>
+                <a16:creationId xmlns:a16="http://schemas.microsoft.com/office/drawing/2014/main" id="{39282E8E-0A93-46D3-B4DA-20F99524F491}"/>
               </a:ext>
             </a:extLst>
           </p:cNvPr>
@@ -10144,7 +10144,7 @@
           <p:cNvPr id="44" name="참조 답변 요지(PDF p.20): RAPTOR는 이야기의 주요 부분을, DPR은 이야기의 좁은 일부를 자세히 검색한">
             <a:extLst xmlns:a="http://schemas.openxmlformats.org/drawingml/2006/main">
               <a:ext uri="{FF2B5EF4-FFF2-40B4-BE49-F238E27FC236}">
-                <a16:creationId xmlns:a16="http://schemas.microsoft.com/office/drawing/2014/main" id="{5D70A1C8-A9DF-4E2F-B51C-31D407D194C7}"/>
+                <a16:creationId xmlns:a16="http://schemas.microsoft.com/office/drawing/2014/main" id="{0DC59136-55D7-4F06-9243-1C356041EBF9}"/>
               </a:ext>
             </a:extLst>
           </p:cNvPr>
@@ -10325,7 +10325,7 @@
           <p:cNvPr id="45" name="생성 답변 발췌: “질문의 요구사항에 따라 서로 다른 층위(layer)에서 노드를 선택할 수 있습니다.”">
             <a:extLst xmlns:a="http://schemas.openxmlformats.org/drawingml/2006/main">
               <a:ext uri="{FF2B5EF4-FFF2-40B4-BE49-F238E27FC236}">
-                <a16:creationId xmlns:a16="http://schemas.microsoft.com/office/drawing/2014/main" id="{9C2C350A-3287-4938-9960-625A1AF9AC38}"/>
+                <a16:creationId xmlns:a16="http://schemas.microsoft.com/office/drawing/2014/main" id="{0122C19A-96E0-4A2D-8EB6-9A5FC2D7D46F}"/>
               </a:ext>
             </a:extLst>
           </p:cNvPr>
@@ -10503,10 +10503,10 @@
       </p:sp>
       <p:sp>
         <p:nvSpPr>
-          <p:cNvPr id="46" name="충실도 1.000: 추출된 답변 주장을 검색 문맥이 모두 지지 관련성 0.937: 답변 기반 질문과 원질문의 평균 의">
+          <p:cNvPr id="46" name="충실도 1.000: 추출된 답변 주장을 검색 결과가 모두 지지 관련성 0.937: 답변 기반 질문과 원질문의 평균 의">
             <a:extLst xmlns:a="http://schemas.openxmlformats.org/drawingml/2006/main">
               <a:ext uri="{FF2B5EF4-FFF2-40B4-BE49-F238E27FC236}">
-                <a16:creationId xmlns:a16="http://schemas.microsoft.com/office/drawing/2014/main" id="{492D705E-5CD0-4326-BF36-68E776982E4F}"/>
+                <a16:creationId xmlns:a16="http://schemas.microsoft.com/office/drawing/2014/main" id="{0F0031D5-188C-400B-8DF3-C56BCB1C79F7}"/>
               </a:ext>
             </a:extLst>
           </p:cNvPr>
@@ -10654,7 +10654,7 @@
                 <a:ea typeface="Malgun Gothic"/>
                 <a:cs typeface="Malgun Gothic"/>
               </a:rPr>
-              <a:t>충실도 1.000: 추출된 답변 주장을 검색 문맥이 모두 지지</a:t>
+              <a:t>충실도 1.000: 추출된 답변 주장을 검색 결과가 모두 지지</a:t>
             </a:r>
           </a:p>
           <a:p xmlns:a="http://schemas.openxmlformats.org/drawingml/2006/main">
@@ -10684,10 +10684,10 @@
       </p:sp>
       <p:sp>
         <p:nvSpPr>
-          <p:cNvPr id="47" name="평가: RAGAS 0.2.15[10]·gpt-4o·BGE-M3, 저장 답변 평가 S0 영어 / S1 한국어 번역 평가">
+          <p:cNvPr id="47" name="평가: RAGAS 0.2.15[10]·gpt-4o·BGE-M3, 저장 답변 평가 평가 언어: S0 영어 / S1 한국">
             <a:extLst xmlns:a="http://schemas.openxmlformats.org/drawingml/2006/main">
               <a:ext uri="{FF2B5EF4-FFF2-40B4-BE49-F238E27FC236}">
-                <a16:creationId xmlns:a16="http://schemas.microsoft.com/office/drawing/2014/main" id="{C0CEBE01-FE8E-4ACB-A7DC-76BC2674A26F}"/>
+                <a16:creationId xmlns:a16="http://schemas.microsoft.com/office/drawing/2014/main" id="{11853166-0F27-42FA-8B71-7177C1D3BB98}"/>
               </a:ext>
             </a:extLst>
           </p:cNvPr>
@@ -10858,7 +10858,7 @@
                 <a:ea typeface="Malgun Gothic"/>
                 <a:cs typeface="Malgun Gothic"/>
               </a:rPr>
-              <a:t>S0 영어 / S1 한국어 번역 평가 문맥, 모든 생성 문맥은 영어</a:t>
+              <a:t>평가 언어: S0 영어 / S1 한국어 번역, 생성 입력은 모두 영어</a:t>
             </a:r>
           </a:p>
         </p:txBody>
@@ -10868,7 +10868,7 @@
           <p:cNvPr id="48" name="반복측정 분산분석(ANOVA)·대응 t-검정, 양측 α=0.05 품질 S별 H×C / 문자·시간 H×C×S, SCD ">
             <a:extLst xmlns:a="http://schemas.openxmlformats.org/drawingml/2006/main">
               <a:ext uri="{FF2B5EF4-FFF2-40B4-BE49-F238E27FC236}">
-                <a16:creationId xmlns:a16="http://schemas.microsoft.com/office/drawing/2014/main" id="{4779FA00-3925-420C-A2E6-5F22BD27451D}"/>
+                <a16:creationId xmlns:a16="http://schemas.microsoft.com/office/drawing/2014/main" id="{2C6E7E6B-0306-4EA9-822E-C4C88550DCCB}"/>
               </a:ext>
             </a:extLst>
           </p:cNvPr>
@@ -11049,7 +11049,7 @@
           <p:cNvPr id="49" name="">
             <a:extLst xmlns:a="http://schemas.openxmlformats.org/drawingml/2006/main">
               <a:ext uri="{FF2B5EF4-FFF2-40B4-BE49-F238E27FC236}">
-                <a16:creationId xmlns:a16="http://schemas.microsoft.com/office/drawing/2014/main" id="{C0DECB3A-6188-4E31-BD60-0B3F9566883B}"/>
+                <a16:creationId xmlns:a16="http://schemas.microsoft.com/office/drawing/2014/main" id="{FD264E1F-B597-4562-BC61-32470FDE4F2A}"/>
               </a:ext>
             </a:extLst>
           </p:cNvPr>
@@ -11080,7 +11080,7 @@
           <p:cNvPr id="50" name="05 조합별 결과와 통계 검정">
             <a:extLst xmlns:a="http://schemas.openxmlformats.org/drawingml/2006/main">
               <a:ext uri="{FF2B5EF4-FFF2-40B4-BE49-F238E27FC236}">
-                <a16:creationId xmlns:a16="http://schemas.microsoft.com/office/drawing/2014/main" id="{10E30CC0-BFAE-4E54-B4F7-8FEA81626F19}"/>
+                <a16:creationId xmlns:a16="http://schemas.microsoft.com/office/drawing/2014/main" id="{95678E53-9946-4562-A735-54D6DA885E15}"/>
               </a:ext>
             </a:extLst>
           </p:cNvPr>
@@ -11238,7 +11238,7 @@
           <p:cNvPr id="51" name="HyDE·CAD·SCD 8조합의 품질·한국어 비율·시간 평균(SD)">
             <a:extLst xmlns:a="http://schemas.openxmlformats.org/drawingml/2006/main">
               <a:ext uri="{FF2B5EF4-FFF2-40B4-BE49-F238E27FC236}">
-                <a16:creationId xmlns:a16="http://schemas.microsoft.com/office/drawing/2014/main" id="{655E4F36-D737-408F-9826-78E163897E75}"/>
+                <a16:creationId xmlns:a16="http://schemas.microsoft.com/office/drawing/2014/main" id="{0F99F741-6688-41A4-8823-BC4FFF749F26}"/>
               </a:ext>
             </a:extLst>
           </p:cNvPr>
@@ -11396,7 +11396,7 @@
           <p:cNvPr id="52" name="">
             <a:extLst xmlns:a="http://schemas.openxmlformats.org/drawingml/2006/main">
               <a:ext uri="{FF2B5EF4-FFF2-40B4-BE49-F238E27FC236}">
-                <a16:creationId xmlns:a16="http://schemas.microsoft.com/office/drawing/2014/main" id="{DAD4AA4A-2792-42EE-A0DE-B53ABDFF1205}"/>
+                <a16:creationId xmlns:a16="http://schemas.microsoft.com/office/drawing/2014/main" id="{907F3F6A-CA6B-4B42-9F65-A64A2DFC4A2A}"/>
               </a:ext>
             </a:extLst>
           </p:cNvPr>
@@ -14756,7 +14756,7 @@
           <p:cNvPr id="53" name="">
             <a:extLst xmlns:a="http://schemas.openxmlformats.org/drawingml/2006/main">
               <a:ext uri="{FF2B5EF4-FFF2-40B4-BE49-F238E27FC236}">
-                <a16:creationId xmlns:a16="http://schemas.microsoft.com/office/drawing/2014/main" id="{A7B2EBAA-010F-4F67-83E3-9FE8736C1110}"/>
+                <a16:creationId xmlns:a16="http://schemas.microsoft.com/office/drawing/2014/main" id="{50E735DA-2EE0-4406-9278-6C9407026C56}"/>
               </a:ext>
             </a:extLst>
           </p:cNvPr>
@@ -14784,10 +14784,10 @@
       </p:sp>
       <p:sp>
         <p:nvSpPr>
-          <p:cNvPr id="54" name="S0: 영어 평가 문맥 / S1: 한국어 번역 평가 문맥 충실도 H0C1S0 n=58, H0C0S1 n=57, 나머지">
+          <p:cNvPr id="54" name="S0: 영어로 평가 / S1: 한국어 번역으로 평가 충실도 H0C1S0 n=58, H0C0S1 n=57, 나머지 n=">
             <a:extLst xmlns:a="http://schemas.openxmlformats.org/drawingml/2006/main">
               <a:ext uri="{FF2B5EF4-FFF2-40B4-BE49-F238E27FC236}">
-                <a16:creationId xmlns:a16="http://schemas.microsoft.com/office/drawing/2014/main" id="{2FE0393A-2664-4404-87A4-A694170D9EE1}"/>
+                <a16:creationId xmlns:a16="http://schemas.microsoft.com/office/drawing/2014/main" id="{75046709-B8A9-4069-A223-55D1E6965471}"/>
               </a:ext>
             </a:extLst>
           </p:cNvPr>
@@ -14935,7 +14935,7 @@
                 <a:ea typeface="Malgun Gothic"/>
                 <a:cs typeface="Malgun Gothic"/>
               </a:rPr>
-              <a:t>S0: 영어 평가 문맥 / S1: 한국어 번역 평가 문맥</a:t>
+              <a:t>S0: 영어로 평가 / S1: 한국어 번역으로 평가</a:t>
             </a:r>
           </a:p>
           <a:p xmlns:a="http://schemas.openxmlformats.org/drawingml/2006/main">
@@ -14991,7 +14991,7 @@
           <p:cNvPr id="55" name="3요인 반복측정 ANOVA  ·  각 효과 df=(1,59)">
             <a:extLst xmlns:a="http://schemas.openxmlformats.org/drawingml/2006/main">
               <a:ext uri="{FF2B5EF4-FFF2-40B4-BE49-F238E27FC236}">
-                <a16:creationId xmlns:a16="http://schemas.microsoft.com/office/drawing/2014/main" id="{3E7DB54C-853A-4AA0-A9B5-B7EE4AE0C88D}"/>
+                <a16:creationId xmlns:a16="http://schemas.microsoft.com/office/drawing/2014/main" id="{3882FF16-E846-400D-9A81-05F42242403F}"/>
               </a:ext>
             </a:extLst>
           </p:cNvPr>
@@ -15149,7 +15149,7 @@
           <p:cNvPr id="56" name="">
             <a:extLst xmlns:a="http://schemas.openxmlformats.org/drawingml/2006/main">
               <a:ext uri="{FF2B5EF4-FFF2-40B4-BE49-F238E27FC236}">
-                <a16:creationId xmlns:a16="http://schemas.microsoft.com/office/drawing/2014/main" id="{D2BDEE2A-C865-4BF3-A1F2-454795AB3EF0}"/>
+                <a16:creationId xmlns:a16="http://schemas.microsoft.com/office/drawing/2014/main" id="{FBEFF174-3C7C-4C0E-A6AF-AD0B9E05ACA0}"/>
               </a:ext>
             </a:extLst>
           </p:cNvPr>
@@ -16859,10 +16859,10 @@
       </p:graphicFrame>
       <p:sp>
         <p:nvSpPr>
-          <p:cNvPr id="57" name="p&lt;0.05: 한국어 비율 S·H×C / 실행 시간 H·C·S·C×S RAGAS H×C 검정은 평가 문맥 언어별로 수">
+          <p:cNvPr id="57" name="p&lt;0.05: 한국어 비율 S·H×C / 실행 시간 H·C·S·C×S RAGAS H×C 검정은 평가 언어별로 수행했으">
             <a:extLst xmlns:a="http://schemas.openxmlformats.org/drawingml/2006/main">
               <a:ext uri="{FF2B5EF4-FFF2-40B4-BE49-F238E27FC236}">
-                <a16:creationId xmlns:a16="http://schemas.microsoft.com/office/drawing/2014/main" id="{94213441-4F82-48A8-9945-97196A39167F}"/>
+                <a16:creationId xmlns:a16="http://schemas.microsoft.com/office/drawing/2014/main" id="{B6008603-5833-4D74-AF42-AFDE4985F7D8}"/>
               </a:ext>
             </a:extLst>
           </p:cNvPr>
@@ -17033,7 +17033,7 @@
                 <a:ea typeface="Malgun Gothic"/>
                 <a:cs typeface="Malgun Gothic"/>
               </a:rPr>
-              <a:t>RAGAS H×C 검정은 평가 문맥 언어별로 수행했으며,</a:t>
+              <a:t>RAGAS H×C 검정은 평가 언어별로 수행했으며,</a:t>
             </a:r>
           </a:p>
           <a:p xmlns:a="http://schemas.openxmlformats.org/drawingml/2006/main">
@@ -17066,7 +17066,7 @@
           <p:cNvPr id="58" name="기법별 대응 비교  ·  질의별 평균 차이, 양측 검정">
             <a:extLst xmlns:a="http://schemas.openxmlformats.org/drawingml/2006/main">
               <a:ext uri="{FF2B5EF4-FFF2-40B4-BE49-F238E27FC236}">
-                <a16:creationId xmlns:a16="http://schemas.microsoft.com/office/drawing/2014/main" id="{A83A5B6B-9286-4C33-94B3-40C5A7056F10}"/>
+                <a16:creationId xmlns:a16="http://schemas.microsoft.com/office/drawing/2014/main" id="{E738EF54-CAFB-4DA8-B1B1-62B796968596}"/>
               </a:ext>
             </a:extLst>
           </p:cNvPr>
@@ -17224,7 +17224,7 @@
           <p:cNvPr id="59" name="">
             <a:extLst xmlns:a="http://schemas.openxmlformats.org/drawingml/2006/main">
               <a:ext uri="{FF2B5EF4-FFF2-40B4-BE49-F238E27FC236}">
-                <a16:creationId xmlns:a16="http://schemas.microsoft.com/office/drawing/2014/main" id="{4CA91D7B-4B10-4E60-95A1-D8BD85064931}"/>
+                <a16:creationId xmlns:a16="http://schemas.microsoft.com/office/drawing/2014/main" id="{C1FE5007-D33D-452F-B7E4-1159DE971303}"/>
               </a:ext>
             </a:extLst>
           </p:cNvPr>
@@ -18237,7 +18237,7 @@
           <p:cNvPr id="60" name="HyDE: C0S0, CAD: H0S0, SCD: H0의 CAD 상태 평균 p: 다중비교 보정 없는 양측 p, dz:">
             <a:extLst xmlns:a="http://schemas.openxmlformats.org/drawingml/2006/main">
               <a:ext uri="{FF2B5EF4-FFF2-40B4-BE49-F238E27FC236}">
-                <a16:creationId xmlns:a16="http://schemas.microsoft.com/office/drawing/2014/main" id="{0360F373-C7A8-4BAB-9CBF-9DA230CC9A38}"/>
+                <a16:creationId xmlns:a16="http://schemas.microsoft.com/office/drawing/2014/main" id="{FDC519F8-214C-4CE9-8A1E-FCFF5193EA6F}"/>
               </a:ext>
             </a:extLst>
           </p:cNvPr>
@@ -18464,7 +18464,7 @@
           <p:cNvPr id="61" name="">
             <a:extLst xmlns:a="http://schemas.openxmlformats.org/drawingml/2006/main">
               <a:ext uri="{FF2B5EF4-FFF2-40B4-BE49-F238E27FC236}">
-                <a16:creationId xmlns:a16="http://schemas.microsoft.com/office/drawing/2014/main" id="{24CF6432-AA43-4634-93A7-26B2FEE8C8F6}"/>
+                <a16:creationId xmlns:a16="http://schemas.microsoft.com/office/drawing/2014/main" id="{88A47597-C87D-49E1-B562-57E722E00F6B}"/>
               </a:ext>
             </a:extLst>
           </p:cNvPr>
@@ -18495,7 +18495,7 @@
           <p:cNvPr id="62" name="06 결과 해석">
             <a:extLst xmlns:a="http://schemas.openxmlformats.org/drawingml/2006/main">
               <a:ext uri="{FF2B5EF4-FFF2-40B4-BE49-F238E27FC236}">
-                <a16:creationId xmlns:a16="http://schemas.microsoft.com/office/drawing/2014/main" id="{5C583980-A700-4E57-BBE1-4E0148BA7B3F}"/>
+                <a16:creationId xmlns:a16="http://schemas.microsoft.com/office/drawing/2014/main" id="{F7C8BA24-D803-4068-9833-87ECD866E268}"/>
               </a:ext>
             </a:extLst>
           </p:cNvPr>
@@ -18653,7 +18653,7 @@
           <p:cNvPr id="63" name="HyDE 관련성은 평균 +0.080점, t(59)=2.236, p=0.029였다. CAD 충실도는 평균 +0.029점">
             <a:extLst xmlns:a="http://schemas.openxmlformats.org/drawingml/2006/main">
               <a:ext uri="{FF2B5EF4-FFF2-40B4-BE49-F238E27FC236}">
-                <a16:creationId xmlns:a16="http://schemas.microsoft.com/office/drawing/2014/main" id="{A598518B-D54E-4E6C-93BA-5EE623CBF783}"/>
+                <a16:creationId xmlns:a16="http://schemas.microsoft.com/office/drawing/2014/main" id="{6FD4FACA-8CCF-41E3-9547-9A10A217EB9D}"/>
               </a:ext>
             </a:extLst>
           </p:cNvPr>
@@ -18880,7 +18880,7 @@
           <p:cNvPr id="64" name="">
             <a:extLst xmlns:a="http://schemas.openxmlformats.org/drawingml/2006/main">
               <a:ext uri="{FF2B5EF4-FFF2-40B4-BE49-F238E27FC236}">
-                <a16:creationId xmlns:a16="http://schemas.microsoft.com/office/drawing/2014/main" id="{AEBE0219-1508-4E0C-89F7-49A2A74338CC}"/>
+                <a16:creationId xmlns:a16="http://schemas.microsoft.com/office/drawing/2014/main" id="{7DA0E778-FFE5-4E17-8764-81049E8D7078}"/>
               </a:ext>
             </a:extLst>
           </p:cNvPr>
@@ -18911,7 +18911,7 @@
           <p:cNvPr id="65" name="07 결론">
             <a:extLst xmlns:a="http://schemas.openxmlformats.org/drawingml/2006/main">
               <a:ext uri="{FF2B5EF4-FFF2-40B4-BE49-F238E27FC236}">
-                <a16:creationId xmlns:a16="http://schemas.microsoft.com/office/drawing/2014/main" id="{486B674A-61D8-4562-A6BB-5C45DFE1621E}"/>
+                <a16:creationId xmlns:a16="http://schemas.microsoft.com/office/drawing/2014/main" id="{BBA5CC2C-EA78-454B-9C85-4297DD269849}"/>
               </a:ext>
             </a:extLst>
           </p:cNvPr>
@@ -19066,10 +19066,10 @@
       </p:sp>
       <p:sp>
         <p:nvSpPr>
-          <p:cNvPr id="66" name="HyDE는 C0S0에서 관련성을 높였고, CAD 충실도 차이는 유의하지 않았다. SCD는 같은 영어 근거에서 한국어 ">
+          <p:cNvPr id="66" name="HyDE는 C0S0에서 관련성을 높였고(p=0.029), CAD 충실도 차이는 p=0.393이었다. SCD는 같은 영">
             <a:extLst xmlns:a="http://schemas.openxmlformats.org/drawingml/2006/main">
               <a:ext uri="{FF2B5EF4-FFF2-40B4-BE49-F238E27FC236}">
-                <a16:creationId xmlns:a16="http://schemas.microsoft.com/office/drawing/2014/main" id="{A6CFB91C-90C0-4EBF-92CC-5DFD802DF078}"/>
+                <a16:creationId xmlns:a16="http://schemas.microsoft.com/office/drawing/2014/main" id="{FE250D17-B2D7-4429-9AA1-CDA727DCE868}"/>
               </a:ext>
             </a:extLst>
           </p:cNvPr>
@@ -19217,7 +19217,7 @@
                 <a:ea typeface="Malgun Gothic"/>
                 <a:cs typeface="Malgun Gothic"/>
               </a:rPr>
-              <a:t>HyDE는 C0S0에서 관련성을 높였고, CAD 충실도 차이는 유의하지 않았다.</a:t>
+              <a:t>HyDE는 C0S0에서 관련성을 높였고(p=0.029), CAD 충실도 차이는 p=0.393이었다.</a:t>
             </a:r>
           </a:p>
           <a:p xmlns:a="http://schemas.openxmlformats.org/drawingml/2006/main">
@@ -19263,7 +19263,7 @@
                 <a:ea typeface="Malgun Gothic"/>
                 <a:cs typeface="Malgun Gothic"/>
               </a:rPr>
-              <a:t>CAD는 두 SCD 상태 모두 실행 시간이 늘었다.</a:t>
+              <a:t>CAD는 실행 시간을 SCD 미적용 3.1배, 적용 2.7배로 늘렸다.</a:t>
             </a:r>
           </a:p>
           <a:p xmlns:a="http://schemas.openxmlformats.org/drawingml/2006/main">
@@ -19319,7 +19319,7 @@
           <p:cNvPr id="67" name="">
             <a:extLst xmlns:a="http://schemas.openxmlformats.org/drawingml/2006/main">
               <a:ext uri="{FF2B5EF4-FFF2-40B4-BE49-F238E27FC236}">
-                <a16:creationId xmlns:a16="http://schemas.microsoft.com/office/drawing/2014/main" id="{BF9547DB-F8F2-4FAB-A13A-60CFC8E078CF}"/>
+                <a16:creationId xmlns:a16="http://schemas.microsoft.com/office/drawing/2014/main" id="{615B71FC-A346-4231-AF8D-A0CB757FFA38}"/>
               </a:ext>
             </a:extLst>
           </p:cNvPr>
@@ -19350,7 +19350,7 @@
           <p:cNvPr id="68" name="08 주요 참고문헌">
             <a:extLst xmlns:a="http://schemas.openxmlformats.org/drawingml/2006/main">
               <a:ext uri="{FF2B5EF4-FFF2-40B4-BE49-F238E27FC236}">
-                <a16:creationId xmlns:a16="http://schemas.microsoft.com/office/drawing/2014/main" id="{8E21C8BA-10A1-40E1-9AA9-6C82383CFB63}"/>
+                <a16:creationId xmlns:a16="http://schemas.microsoft.com/office/drawing/2014/main" id="{73C8002D-0CF4-4E30-AAC4-5FCDD9F3AE6E}"/>
               </a:ext>
             </a:extLst>
           </p:cNvPr>
@@ -19508,7 +19508,7 @@
           <p:cNvPr id="69" name="[1] Lewis et al. RAG. NeurIPS, 2020. [2] Gao et al. HyDE. ACL, 20">
             <a:extLst xmlns:a="http://schemas.openxmlformats.org/drawingml/2006/main">
               <a:ext uri="{FF2B5EF4-FFF2-40B4-BE49-F238E27FC236}">
-                <a16:creationId xmlns:a16="http://schemas.microsoft.com/office/drawing/2014/main" id="{9027F5CF-D9A8-40BC-AD80-2B5D08A5BF72}"/>
+                <a16:creationId xmlns:a16="http://schemas.microsoft.com/office/drawing/2014/main" id="{41E7049E-11D6-4A1F-BE20-646651CCEE37}"/>
               </a:ext>
             </a:extLst>
           </p:cNvPr>
@@ -19712,7 +19712,7 @@
           <p:cNvPr id="70" name="[4] Li et al. Language Drift and SCD. AAAI, 2026. [5] Chen et al.">
             <a:extLst xmlns:a="http://schemas.openxmlformats.org/drawingml/2006/main">
               <a:ext uri="{FF2B5EF4-FFF2-40B4-BE49-F238E27FC236}">
-                <a16:creationId xmlns:a16="http://schemas.microsoft.com/office/drawing/2014/main" id="{BDE32D7C-C746-43C7-A10B-1D4ED4A0E095}"/>
+                <a16:creationId xmlns:a16="http://schemas.microsoft.com/office/drawing/2014/main" id="{2896C016-835C-4B43-8751-EF7457D37FFB}"/>
               </a:ext>
             </a:extLst>
           </p:cNvPr>
@@ -19916,7 +19916,7 @@
           <p:cNvPr id="71" name="[6] Robertson et al. Okapi at TREC-3. NIST, 1995. [7] Cormack et ">
             <a:extLst xmlns:a="http://schemas.openxmlformats.org/drawingml/2006/main">
               <a:ext uri="{FF2B5EF4-FFF2-40B4-BE49-F238E27FC236}">
-                <a16:creationId xmlns:a16="http://schemas.microsoft.com/office/drawing/2014/main" id="{967E668E-7DDD-43D5-8531-7598CDF90764}"/>
+                <a16:creationId xmlns:a16="http://schemas.microsoft.com/office/drawing/2014/main" id="{683BF456-9D45-4BAC-9121-73490765EBD6}"/>
               </a:ext>
             </a:extLst>
           </p:cNvPr>
@@ -20097,7 +20097,7 @@
           <p:cNvPr id="72" name="[8] MacAvaney et al. CEDR. SIGIR, 2019. 공식 모델  [M1] KT Mi:dm 2.0 ">
             <a:extLst xmlns:a="http://schemas.openxmlformats.org/drawingml/2006/main">
               <a:ext uri="{FF2B5EF4-FFF2-40B4-BE49-F238E27FC236}">
-                <a16:creationId xmlns:a16="http://schemas.microsoft.com/office/drawing/2014/main" id="{CDDB70DA-6C87-4FA4-92AB-9773A9A6BBF0}"/>
+                <a16:creationId xmlns:a16="http://schemas.microsoft.com/office/drawing/2014/main" id="{655632E7-3B6A-41E8-8507-B51A203634B6}"/>
               </a:ext>
             </a:extLst>
           </p:cNvPr>
@@ -20275,10 +20275,10 @@
       </p:sp>
       <p:sp>
         <p:nvSpPr>
-          <p:cNvPr id="73" name="학술 22편·모델·자료 출처: FINALDOCS/VALIDATION/REFERENCES.md · 통계·민감도: 동봉 ">
+          <p:cNvPr id="73" name="전체 참고문헌 22편과 모델·자료 출처는 논문의 참고문헌에 수록">
             <a:extLst xmlns:a="http://schemas.openxmlformats.org/drawingml/2006/main">
               <a:ext uri="{FF2B5EF4-FFF2-40B4-BE49-F238E27FC236}">
-                <a16:creationId xmlns:a16="http://schemas.microsoft.com/office/drawing/2014/main" id="{4317AC15-8CA5-4059-B48C-A4346EA72ECA}"/>
+                <a16:creationId xmlns:a16="http://schemas.microsoft.com/office/drawing/2014/main" id="{E4E79B22-ABD6-442D-BE31-552D3F2694A1}"/>
               </a:ext>
             </a:extLst>
           </p:cNvPr>
@@ -20426,7 +20426,7 @@
                 <a:ea typeface="Malgun Gothic"/>
                 <a:cs typeface="Malgun Gothic"/>
               </a:rPr>
-              <a:t>학술 22편·모델·자료 출처: FINALDOCS/VALIDATION/REFERENCES.md · 통계·민감도: 동봉 상세표</a:t>
+              <a:t>전체 참고문헌 22편과 모델·자료 출처는 논문의 참고문헌에 수록</a:t>
             </a:r>
           </a:p>
         </p:txBody>
@@ -20436,7 +20436,7 @@
           <p:cNvPr id="74" name="영어 문서 4종 · 질의 60개 · 생성 모델 1종 · 질의별 반복측정">
             <a:extLst xmlns:a="http://schemas.openxmlformats.org/drawingml/2006/main">
               <a:ext uri="{FF2B5EF4-FFF2-40B4-BE49-F238E27FC236}">
-                <a16:creationId xmlns:a16="http://schemas.microsoft.com/office/drawing/2014/main" id="{A4DEB587-C8F4-45DF-8AB7-C17238C39793}"/>
+                <a16:creationId xmlns:a16="http://schemas.microsoft.com/office/drawing/2014/main" id="{E1AF734D-69B7-48D0-B1F4-ABEFB0216D42}"/>
               </a:ext>
             </a:extLst>
           </p:cNvPr>
@@ -20594,7 +20594,7 @@
           <p:cNvPr id="75" name="A1 594 × 841 mm">
             <a:extLst xmlns:a="http://schemas.openxmlformats.org/drawingml/2006/main">
               <a:ext uri="{FF2B5EF4-FFF2-40B4-BE49-F238E27FC236}">
-                <a16:creationId xmlns:a16="http://schemas.microsoft.com/office/drawing/2014/main" id="{8495BF88-5658-434D-95EA-28B434C210D7}"/>
+                <a16:creationId xmlns:a16="http://schemas.microsoft.com/office/drawing/2014/main" id="{13CEBAD9-9D63-45DD-AB62-1A79BE0DE151}"/>
               </a:ext>
             </a:extLst>
           </p:cNvPr>
@@ -20750,7 +20750,7 @@
     </p:spTree>
     <p:extLst>
       <p:ext uri="{BB962C8B-B14F-4D97-AF65-F5344CB8AC3E}">
-        <p14:creationId xmlns:p14="http://schemas.microsoft.com/office/powerpoint/2010/main" val="2087134093"/>
+        <p14:creationId xmlns:p14="http://schemas.microsoft.com/office/powerpoint/2010/main" val="1613744321"/>
       </p:ext>
     </p:extLst>
   </p:cSld>

</xml_diff>

<commit_message>
Polish thesis and poster prose after a full sentence-level reread
- 5.8: restore the comparison order so "이 비교" refers to the base
  condition; place the exploratory SCD-on HyDE result after it
- 5.6 RQ2: state the CAD faithfulness change as a mean difference
- Remove repeated counts/SD ratios across 5.6 and 5.8, merge duplicated
  sentences in 5.8 and appendix B-4, fix the 5.4 Type I error sentence
- 6.2: describe the significance instead of restating 6.1 numbers
- Poster: round 21.822%p and runtime deltas, spell out the methods line
- Regenerate HWPX/PDF (51 pages, positions unchanged), refresh manifests

Co-Authored-By: Claude Opus 5.5 <noreply@anthropic.com>
</commit_message>
<xml_diff>
--- a/FINALDOCS/POSTER/FINAL/M_RAG_A1_FINAL_EDITABLE.pptx
+++ b/FINALDOCS/POSTER/FINAL/M_RAG_A1_FINAL_EDITABLE.pptx
@@ -2,13 +2,13 @@
 <file path=ppt/presentation.xml><?xml version="1.0" encoding="utf-8"?>
 <p:presentation xmlns:p="http://schemas.openxmlformats.org/presentationml/2006/main">
   <p:sldMasterIdLst>
-    <p:sldMasterId xmlns:r="http://schemas.openxmlformats.org/officeDocument/2006/relationships" id="2147483648" r:id="R3b11d35200044fea"/>
+    <p:sldMasterId xmlns:r="http://schemas.openxmlformats.org/officeDocument/2006/relationships" id="2147483648" r:id="R6235bf1f6f664c81"/>
   </p:sldMasterIdLst>
   <p:notesMasterIdLst>
-    <p:notesMasterId xmlns:r="http://schemas.openxmlformats.org/officeDocument/2006/relationships" r:id="R4949fc67fcff473a"/>
+    <p:notesMasterId xmlns:r="http://schemas.openxmlformats.org/officeDocument/2006/relationships" r:id="Rdd3939f53baa400d"/>
   </p:notesMasterIdLst>
   <p:sldIdLst>
-    <p:sldId xmlns:r="http://schemas.openxmlformats.org/officeDocument/2006/relationships" id="256" r:id="Re562c2222906468f"/>
+    <p:sldId xmlns:r="http://schemas.openxmlformats.org/officeDocument/2006/relationships" id="256" r:id="Re375367e10cc407b"/>
   </p:sldIdLst>
   <p:sldSz cx="21384000" cy="30276000"/>
   <p:notesSz cx="6858000" cy="9144000"/>
@@ -489,7 +489,7 @@
           <p:cNvPr id="3" name="Title">
             <a:extLst xmlns:a="http://schemas.openxmlformats.org/drawingml/2006/main">
               <a:ext uri="{FF2B5EF4-FFF2-40B4-BE49-F238E27FC236}">
-                <a16:creationId xmlns:a16="http://schemas.microsoft.com/office/drawing/2014/main" id="{3AA86962-2AB5-423F-9184-841619492E28}"/>
+                <a16:creationId xmlns:a16="http://schemas.microsoft.com/office/drawing/2014/main" id="{07C0BAFA-B223-4E60-99AC-127FBC0D8590}"/>
               </a:ext>
             </a:extLst>
           </p:cNvPr>
@@ -718,7 +718,7 @@
           <p:cNvPr id="2" name="Subtitle">
             <a:extLst xmlns:a="http://schemas.openxmlformats.org/drawingml/2006/main">
               <a:ext uri="{FF2B5EF4-FFF2-40B4-BE49-F238E27FC236}">
-                <a16:creationId xmlns:a16="http://schemas.microsoft.com/office/drawing/2014/main" id="{813FB6E7-6EF6-42BD-A34D-414BC2206906}"/>
+                <a16:creationId xmlns:a16="http://schemas.microsoft.com/office/drawing/2014/main" id="{31722EE8-B848-4B0B-9468-5D6C68178045}"/>
               </a:ext>
             </a:extLst>
           </p:cNvPr>
@@ -964,7 +964,7 @@
           <p:cNvPr id="2" name="Section title">
             <a:extLst xmlns:a="http://schemas.openxmlformats.org/drawingml/2006/main">
               <a:ext uri="{FF2B5EF4-FFF2-40B4-BE49-F238E27FC236}">
-                <a16:creationId xmlns:a16="http://schemas.microsoft.com/office/drawing/2014/main" id="{7C3B6948-9802-42E4-891A-2FDF91DB9D23}"/>
+                <a16:creationId xmlns:a16="http://schemas.microsoft.com/office/drawing/2014/main" id="{E65C68E4-B19B-414A-999E-423151292715}"/>
               </a:ext>
             </a:extLst>
           </p:cNvPr>
@@ -1210,7 +1210,7 @@
           <p:cNvPr id="3" name="Title">
             <a:extLst xmlns:a="http://schemas.openxmlformats.org/drawingml/2006/main">
               <a:ext uri="{FF2B5EF4-FFF2-40B4-BE49-F238E27FC236}">
-                <a16:creationId xmlns:a16="http://schemas.microsoft.com/office/drawing/2014/main" id="{613578F9-ADE6-4FE3-80B0-DEAB4999D3C7}"/>
+                <a16:creationId xmlns:a16="http://schemas.microsoft.com/office/drawing/2014/main" id="{6F31241B-A97F-4299-A9AC-F0157EAABDED}"/>
               </a:ext>
             </a:extLst>
           </p:cNvPr>
@@ -1439,7 +1439,7 @@
           <p:cNvPr id="2" name="Body">
             <a:extLst xmlns:a="http://schemas.openxmlformats.org/drawingml/2006/main">
               <a:ext uri="{FF2B5EF4-FFF2-40B4-BE49-F238E27FC236}">
-                <a16:creationId xmlns:a16="http://schemas.microsoft.com/office/drawing/2014/main" id="{182CC6BC-3C4E-41DB-B691-BA7509FA687F}"/>
+                <a16:creationId xmlns:a16="http://schemas.microsoft.com/office/drawing/2014/main" id="{2E4E7E5E-1A2C-42E0-93CF-71AEC85BCC1B}"/>
               </a:ext>
             </a:extLst>
           </p:cNvPr>
@@ -1685,7 +1685,7 @@
           <p:cNvPr id="4" name="Title">
             <a:extLst xmlns:a="http://schemas.openxmlformats.org/drawingml/2006/main">
               <a:ext uri="{FF2B5EF4-FFF2-40B4-BE49-F238E27FC236}">
-                <a16:creationId xmlns:a16="http://schemas.microsoft.com/office/drawing/2014/main" id="{E2A24762-7A6B-4A7B-A25E-B784FBBE4A2D}"/>
+                <a16:creationId xmlns:a16="http://schemas.microsoft.com/office/drawing/2014/main" id="{5D5D812A-FDAF-4B24-9C9D-FB29B3C0FB07}"/>
               </a:ext>
             </a:extLst>
           </p:cNvPr>
@@ -1914,7 +1914,7 @@
           <p:cNvPr id="2" name="Left column">
             <a:extLst xmlns:a="http://schemas.openxmlformats.org/drawingml/2006/main">
               <a:ext uri="{FF2B5EF4-FFF2-40B4-BE49-F238E27FC236}">
-                <a16:creationId xmlns:a16="http://schemas.microsoft.com/office/drawing/2014/main" id="{B4C97ECD-3ECE-4C3B-B162-E85B6B5C5D50}"/>
+                <a16:creationId xmlns:a16="http://schemas.microsoft.com/office/drawing/2014/main" id="{F5D9849A-6575-4645-8D61-27673A9280F3}"/>
               </a:ext>
             </a:extLst>
           </p:cNvPr>
@@ -2143,7 +2143,7 @@
           <p:cNvPr id="3" name="Right column">
             <a:extLst xmlns:a="http://schemas.openxmlformats.org/drawingml/2006/main">
               <a:ext uri="{FF2B5EF4-FFF2-40B4-BE49-F238E27FC236}">
-                <a16:creationId xmlns:a16="http://schemas.microsoft.com/office/drawing/2014/main" id="{8D55F3E0-22BF-4E1B-AA61-83819AA920D5}"/>
+                <a16:creationId xmlns:a16="http://schemas.microsoft.com/office/drawing/2014/main" id="{5CFD4B5D-6546-4CF6-8A2B-7B1C789071A2}"/>
               </a:ext>
             </a:extLst>
           </p:cNvPr>
@@ -2389,7 +2389,7 @@
           <p:cNvPr id="3" name="Title">
             <a:extLst xmlns:a="http://schemas.openxmlformats.org/drawingml/2006/main">
               <a:ext uri="{FF2B5EF4-FFF2-40B4-BE49-F238E27FC236}">
-                <a16:creationId xmlns:a16="http://schemas.microsoft.com/office/drawing/2014/main" id="{E350ABDD-06B5-4000-B9F1-A7ABB4687E4B}"/>
+                <a16:creationId xmlns:a16="http://schemas.microsoft.com/office/drawing/2014/main" id="{5497BE03-BD2D-4F5F-8AA9-2FBA4F1FEDA7}"/>
               </a:ext>
             </a:extLst>
           </p:cNvPr>
@@ -2618,7 +2618,7 @@
           <p:cNvPr id="2" name="Left column">
             <a:extLst xmlns:a="http://schemas.openxmlformats.org/drawingml/2006/main">
               <a:ext uri="{FF2B5EF4-FFF2-40B4-BE49-F238E27FC236}">
-                <a16:creationId xmlns:a16="http://schemas.microsoft.com/office/drawing/2014/main" id="{499283E6-2D31-4BF4-985F-57FBEFF928C6}"/>
+                <a16:creationId xmlns:a16="http://schemas.microsoft.com/office/drawing/2014/main" id="{A2718882-54BE-4AE2-BBCF-118386EB170C}"/>
               </a:ext>
             </a:extLst>
           </p:cNvPr>
@@ -2885,12 +2885,12 @@
   </p:cSld>
   <p:clrMap bg1="lt1" tx1="dk1" bg2="lt2" tx2="dk2" accent1="accent1" accent2="accent2" accent3="accent3" accent4="accent4" accent5="accent5" accent6="accent6" hlink="hlink" folHlink="folHlink"/>
   <p:sldLayoutIdLst>
-    <p:sldLayoutId xmlns:r="http://schemas.openxmlformats.org/officeDocument/2006/relationships" id="2147483649" r:id="R795ce3ad7e394fb8"/>
-    <p:sldLayoutId xmlns:r="http://schemas.openxmlformats.org/officeDocument/2006/relationships" id="2147483650" r:id="R0b81810b648a49ad"/>
-    <p:sldLayoutId xmlns:r="http://schemas.openxmlformats.org/officeDocument/2006/relationships" id="2147483651" r:id="Rf696abf199374e04"/>
-    <p:sldLayoutId xmlns:r="http://schemas.openxmlformats.org/officeDocument/2006/relationships" id="2147483652" r:id="R3c9cb9491df94465"/>
-    <p:sldLayoutId xmlns:r="http://schemas.openxmlformats.org/officeDocument/2006/relationships" id="2147483653" r:id="Rbe4c6c5906ea4ead"/>
-    <p:sldLayoutId xmlns:r="http://schemas.openxmlformats.org/officeDocument/2006/relationships" id="2147483654" r:id="Rd5cb04c378844181"/>
+    <p:sldLayoutId xmlns:r="http://schemas.openxmlformats.org/officeDocument/2006/relationships" id="2147483649" r:id="R13ad1610903c456d"/>
+    <p:sldLayoutId xmlns:r="http://schemas.openxmlformats.org/officeDocument/2006/relationships" id="2147483650" r:id="Raa47b83c4b44442f"/>
+    <p:sldLayoutId xmlns:r="http://schemas.openxmlformats.org/officeDocument/2006/relationships" id="2147483651" r:id="Rd864ad15c57047f7"/>
+    <p:sldLayoutId xmlns:r="http://schemas.openxmlformats.org/officeDocument/2006/relationships" id="2147483652" r:id="R9d61913635c24bf8"/>
+    <p:sldLayoutId xmlns:r="http://schemas.openxmlformats.org/officeDocument/2006/relationships" id="2147483653" r:id="Rd70f9866964b4fb1"/>
+    <p:sldLayoutId xmlns:r="http://schemas.openxmlformats.org/officeDocument/2006/relationships" id="2147483654" r:id="R5547191a3a99437b"/>
   </p:sldLayoutIdLst>
   <p:txStyles>
     <p:titleStyle>
@@ -3441,7 +3441,7 @@
           <p:cNvPr id="76" name="">
             <a:extLst xmlns:a="http://schemas.openxmlformats.org/drawingml/2006/main">
               <a:ext uri="{FF2B5EF4-FFF2-40B4-BE49-F238E27FC236}">
-                <a16:creationId xmlns:a16="http://schemas.microsoft.com/office/drawing/2014/main" id="{88C73751-82B4-443F-8071-6FB12B2BCB52}"/>
+                <a16:creationId xmlns:a16="http://schemas.microsoft.com/office/drawing/2014/main" id="{E588A753-C5A7-4FB4-92AF-E8386BB8A7B6}"/>
               </a:ext>
             </a:extLst>
           </p:cNvPr>
@@ -3472,7 +3472,7 @@
           <p:cNvPr id="2" name="한국어 질의로 영어 학술·기술 문서를 검색하는">
             <a:extLst xmlns:a="http://schemas.openxmlformats.org/drawingml/2006/main">
               <a:ext uri="{FF2B5EF4-FFF2-40B4-BE49-F238E27FC236}">
-                <a16:creationId xmlns:a16="http://schemas.microsoft.com/office/drawing/2014/main" id="{6915451A-423C-4826-9AEA-E7B12F3C45ED}"/>
+                <a16:creationId xmlns:a16="http://schemas.microsoft.com/office/drawing/2014/main" id="{98D35406-EEF0-4CD4-9D0D-F9C774496311}"/>
               </a:ext>
             </a:extLst>
           </p:cNvPr>
@@ -3630,7 +3630,7 @@
           <p:cNvPr id="3" name="RAG에서의 HyDE·CAD·SCD 조합 실험">
             <a:extLst xmlns:a="http://schemas.openxmlformats.org/drawingml/2006/main">
               <a:ext uri="{FF2B5EF4-FFF2-40B4-BE49-F238E27FC236}">
-                <a16:creationId xmlns:a16="http://schemas.microsoft.com/office/drawing/2014/main" id="{AFB0096C-AD71-40B5-963D-8015F5AF9EFC}"/>
+                <a16:creationId xmlns:a16="http://schemas.microsoft.com/office/drawing/2014/main" id="{E408D2E7-5DC9-4E7B-A58D-61B1A75077A7}"/>
               </a:ext>
             </a:extLst>
           </p:cNvPr>
@@ -3788,7 +3788,7 @@
           <p:cNvPr id="4" name="문종건 · 동국대학교 WISE캠퍼스 컴퓨터공학과 · 지도교수 김진석 · 2026.10.15">
             <a:extLst xmlns:a="http://schemas.openxmlformats.org/drawingml/2006/main">
               <a:ext uri="{FF2B5EF4-FFF2-40B4-BE49-F238E27FC236}">
-                <a16:creationId xmlns:a16="http://schemas.microsoft.com/office/drawing/2014/main" id="{4A94F85B-9C0D-42F4-8D3C-C46E7E3983D3}"/>
+                <a16:creationId xmlns:a16="http://schemas.microsoft.com/office/drawing/2014/main" id="{33A74FED-624E-49DA-A8CD-D4E3025E1FAF}"/>
               </a:ext>
             </a:extLst>
           </p:cNvPr>
@@ -3946,7 +3946,7 @@
           <p:cNvPr id="5" name="">
             <a:extLst xmlns:a="http://schemas.openxmlformats.org/drawingml/2006/main">
               <a:ext uri="{FF2B5EF4-FFF2-40B4-BE49-F238E27FC236}">
-                <a16:creationId xmlns:a16="http://schemas.microsoft.com/office/drawing/2014/main" id="{0C6933EA-D2D1-41BA-8850-498B856C8D19}"/>
+                <a16:creationId xmlns:a16="http://schemas.microsoft.com/office/drawing/2014/main" id="{9D4DF89C-E278-440C-8963-49FB8E9EBD60}"/>
               </a:ext>
             </a:extLst>
           </p:cNvPr>
@@ -3977,7 +3977,7 @@
           <p:cNvPr id="6" name="01 연구 배경과 목적">
             <a:extLst xmlns:a="http://schemas.openxmlformats.org/drawingml/2006/main">
               <a:ext uri="{FF2B5EF4-FFF2-40B4-BE49-F238E27FC236}">
-                <a16:creationId xmlns:a16="http://schemas.microsoft.com/office/drawing/2014/main" id="{EB239701-7E97-41A0-BFB6-15D9D22685BC}"/>
+                <a16:creationId xmlns:a16="http://schemas.microsoft.com/office/drawing/2014/main" id="{BFF15FD1-5AE2-4B54-8FCD-DA7CD889F507}"/>
               </a:ext>
             </a:extLst>
           </p:cNvPr>
@@ -4135,7 +4135,7 @@
           <p:cNvPr id="7" name="검색 증강 생성(Retrieval-Augmented Generation, RAG)은 관련 문서 구간을 검색하고 그 텍">
             <a:extLst xmlns:a="http://schemas.openxmlformats.org/drawingml/2006/main">
               <a:ext uri="{FF2B5EF4-FFF2-40B4-BE49-F238E27FC236}">
-                <a16:creationId xmlns:a16="http://schemas.microsoft.com/office/drawing/2014/main" id="{76735A99-0280-408C-A5EE-FDF2B836BB14}"/>
+                <a16:creationId xmlns:a16="http://schemas.microsoft.com/office/drawing/2014/main" id="{A7CB3FE7-97E8-4D81-8342-D368E706BD61}"/>
               </a:ext>
             </a:extLst>
           </p:cNvPr>
@@ -4316,7 +4316,7 @@
           <p:cNvPr id="8" name="HyDE: 가상 문서 임베딩(Hypothetical Document Embeddings) 가상 문서 검색 입력 구성[">
             <a:extLst xmlns:a="http://schemas.openxmlformats.org/drawingml/2006/main">
               <a:ext uri="{FF2B5EF4-FFF2-40B4-BE49-F238E27FC236}">
-                <a16:creationId xmlns:a16="http://schemas.microsoft.com/office/drawing/2014/main" id="{264F7FE3-C1FC-4E6E-9445-0AB9A6668735}"/>
+                <a16:creationId xmlns:a16="http://schemas.microsoft.com/office/drawing/2014/main" id="{EC806C2C-1E27-4650-85F5-021605D0D260}"/>
               </a:ext>
             </a:extLst>
           </p:cNvPr>
@@ -4589,7 +4589,7 @@
           <p:cNvPr id="9" name="HyDE는 한국어를 포함한 다국어 검색에서 평가되었다[2]. 한국어 질의–영어 문서 환경에서 HyDE·CAD·SCD의">
             <a:extLst xmlns:a="http://schemas.openxmlformats.org/drawingml/2006/main">
               <a:ext uri="{FF2B5EF4-FFF2-40B4-BE49-F238E27FC236}">
-                <a16:creationId xmlns:a16="http://schemas.microsoft.com/office/drawing/2014/main" id="{EEE91773-F2A8-46BC-9F66-52F03F8BB5E2}"/>
+                <a16:creationId xmlns:a16="http://schemas.microsoft.com/office/drawing/2014/main" id="{702D493F-86F8-410D-8E8B-CB765BC158AE}"/>
               </a:ext>
             </a:extLst>
           </p:cNvPr>
@@ -4793,7 +4793,7 @@
           <p:cNvPr id="10" name="">
             <a:extLst xmlns:a="http://schemas.openxmlformats.org/drawingml/2006/main">
               <a:ext uri="{FF2B5EF4-FFF2-40B4-BE49-F238E27FC236}">
-                <a16:creationId xmlns:a16="http://schemas.microsoft.com/office/drawing/2014/main" id="{53DD512A-CA2D-4291-BB17-BC7D04DEF152}"/>
+                <a16:creationId xmlns:a16="http://schemas.microsoft.com/office/drawing/2014/main" id="{7DAAC475-77ED-4736-800A-8861726B01CE}"/>
               </a:ext>
             </a:extLst>
           </p:cNvPr>
@@ -4824,7 +4824,7 @@
           <p:cNvPr id="11" name="02 Paper-RAG 구조와 기법 적용 위치">
             <a:extLst xmlns:a="http://schemas.openxmlformats.org/drawingml/2006/main">
               <a:ext uri="{FF2B5EF4-FFF2-40B4-BE49-F238E27FC236}">
-                <a16:creationId xmlns:a16="http://schemas.microsoft.com/office/drawing/2014/main" id="{70563DA3-6481-4079-82B2-1AC4167FD0F3}"/>
+                <a16:creationId xmlns:a16="http://schemas.microsoft.com/office/drawing/2014/main" id="{E3BD0098-3652-4F43-8EA0-33F0BD15F5AB}"/>
               </a:ext>
             </a:extLst>
           </p:cNvPr>
@@ -4982,7 +4982,7 @@
           <p:cNvPr id="12" name="Paper-RAG는 실험에 사용한 고정 검색·생성 파이프라인이다.">
             <a:extLst xmlns:a="http://schemas.openxmlformats.org/drawingml/2006/main">
               <a:ext uri="{FF2B5EF4-FFF2-40B4-BE49-F238E27FC236}">
-                <a16:creationId xmlns:a16="http://schemas.microsoft.com/office/drawing/2014/main" id="{A49FFED5-FCDF-426E-9C5A-1595DA814960}"/>
+                <a16:creationId xmlns:a16="http://schemas.microsoft.com/office/drawing/2014/main" id="{65790FA7-706C-4CCD-9B50-B6AFFD43CEBA}"/>
               </a:ext>
             </a:extLst>
           </p:cNvPr>
@@ -5140,7 +5140,7 @@
           <p:cNvPr id="13" name="">
             <a:extLst xmlns:a="http://schemas.openxmlformats.org/drawingml/2006/main">
               <a:ext uri="{FF2B5EF4-FFF2-40B4-BE49-F238E27FC236}">
-                <a16:creationId xmlns:a16="http://schemas.microsoft.com/office/drawing/2014/main" id="{2B0329C8-30E4-47CB-8A82-D021831C9316}"/>
+                <a16:creationId xmlns:a16="http://schemas.microsoft.com/office/drawing/2014/main" id="{493D2AE8-1B79-4888-8F4C-99CAD857174F}"/>
               </a:ext>
             </a:extLst>
           </p:cNvPr>
@@ -5173,7 +5173,7 @@
           <p:cNvPr id="14" name="한국어 질의 HyDE OFF: 원질의 HyDE ON: 영어 번역·가상 문서">
             <a:extLst xmlns:a="http://schemas.openxmlformats.org/drawingml/2006/main">
               <a:ext uri="{FF2B5EF4-FFF2-40B4-BE49-F238E27FC236}">
-                <a16:creationId xmlns:a16="http://schemas.microsoft.com/office/drawing/2014/main" id="{D0FA7350-3DF6-4C07-A792-00D91A4235A3}"/>
+                <a16:creationId xmlns:a16="http://schemas.microsoft.com/office/drawing/2014/main" id="{3654D477-6733-454A-B7F7-C181647B48FD}"/>
               </a:ext>
             </a:extLst>
           </p:cNvPr>
@@ -5377,7 +5377,7 @@
           <p:cNvPr id="15" name="">
             <a:extLst xmlns:a="http://schemas.openxmlformats.org/drawingml/2006/main">
               <a:ext uri="{FF2B5EF4-FFF2-40B4-BE49-F238E27FC236}">
-                <a16:creationId xmlns:a16="http://schemas.microsoft.com/office/drawing/2014/main" id="{30AB55E9-E3F7-4106-9237-44C7C992A795}"/>
+                <a16:creationId xmlns:a16="http://schemas.microsoft.com/office/drawing/2014/main" id="{227747A0-E20C-4769-9D02-CF7A7DBCAA70}"/>
               </a:ext>
             </a:extLst>
           </p:cNvPr>
@@ -5410,7 +5410,7 @@
           <p:cNvPr id="16" name="BM25 희소 검색[6] 한국어 원질의 사용">
             <a:extLst xmlns:a="http://schemas.openxmlformats.org/drawingml/2006/main">
               <a:ext uri="{FF2B5EF4-FFF2-40B4-BE49-F238E27FC236}">
-                <a16:creationId xmlns:a16="http://schemas.microsoft.com/office/drawing/2014/main" id="{22210D0C-A786-42DA-9311-386002A3CCE2}"/>
+                <a16:creationId xmlns:a16="http://schemas.microsoft.com/office/drawing/2014/main" id="{ACDFC118-C032-478F-AD46-18EC7D77D91C}"/>
               </a:ext>
             </a:extLst>
           </p:cNvPr>
@@ -5591,7 +5591,7 @@
           <p:cNvPr id="17" name="">
             <a:extLst xmlns:a="http://schemas.openxmlformats.org/drawingml/2006/main">
               <a:ext uri="{FF2B5EF4-FFF2-40B4-BE49-F238E27FC236}">
-                <a16:creationId xmlns:a16="http://schemas.microsoft.com/office/drawing/2014/main" id="{BFA2BE0E-B09F-4C6F-8C71-61D5146D83D0}"/>
+                <a16:creationId xmlns:a16="http://schemas.microsoft.com/office/drawing/2014/main" id="{C774C2BD-B9B7-49EF-88CB-B5F38ED7BCA4}"/>
               </a:ext>
             </a:extLst>
           </p:cNvPr>
@@ -5624,7 +5624,7 @@
           <p:cNvPr id="18" name="BGE-M3 밀집 검색[5]">
             <a:extLst xmlns:a="http://schemas.openxmlformats.org/drawingml/2006/main">
               <a:ext uri="{FF2B5EF4-FFF2-40B4-BE49-F238E27FC236}">
-                <a16:creationId xmlns:a16="http://schemas.microsoft.com/office/drawing/2014/main" id="{1270A6B1-1A25-43F6-A994-A4D2A4F1B766}"/>
+                <a16:creationId xmlns:a16="http://schemas.microsoft.com/office/drawing/2014/main" id="{19EE5B8B-6472-465C-BD69-6E4EF3AF93A5}"/>
               </a:ext>
             </a:extLst>
           </p:cNvPr>
@@ -5782,7 +5782,7 @@
           <p:cNvPr id="19" name="">
             <a:extLst xmlns:a="http://schemas.openxmlformats.org/drawingml/2006/main">
               <a:ext uri="{FF2B5EF4-FFF2-40B4-BE49-F238E27FC236}">
-                <a16:creationId xmlns:a16="http://schemas.microsoft.com/office/drawing/2014/main" id="{ADE26CB3-643A-40DB-99A3-568E03727E57}"/>
+                <a16:creationId xmlns:a16="http://schemas.microsoft.com/office/drawing/2014/main" id="{3FD039B9-CFAE-4DBA-AC09-EA5D171D50C3}"/>
               </a:ext>
             </a:extLst>
           </p:cNvPr>
@@ -5815,7 +5815,7 @@
           <p:cNvPr id="20" name="가중 RRF[7] 0.6 / 0.4, k=60">
             <a:extLst xmlns:a="http://schemas.openxmlformats.org/drawingml/2006/main">
               <a:ext uri="{FF2B5EF4-FFF2-40B4-BE49-F238E27FC236}">
-                <a16:creationId xmlns:a16="http://schemas.microsoft.com/office/drawing/2014/main" id="{5FE4BAF2-8425-45B5-930F-CCDB66245ED3}"/>
+                <a16:creationId xmlns:a16="http://schemas.microsoft.com/office/drawing/2014/main" id="{F99617E2-4428-4175-A3F3-E0A3B2F9CDC9}"/>
               </a:ext>
             </a:extLst>
           </p:cNvPr>
@@ -5996,7 +5996,7 @@
           <p:cNvPr id="21" name="">
             <a:extLst xmlns:a="http://schemas.openxmlformats.org/drawingml/2006/main">
               <a:ext uri="{FF2B5EF4-FFF2-40B4-BE49-F238E27FC236}">
-                <a16:creationId xmlns:a16="http://schemas.microsoft.com/office/drawing/2014/main" id="{F4114495-9911-43C1-8D10-29C3F435FF1C}"/>
+                <a16:creationId xmlns:a16="http://schemas.microsoft.com/office/drawing/2014/main" id="{F2B7DFCE-5098-4056-B08C-A24DCDFCF6F6}"/>
               </a:ext>
             </a:extLst>
           </p:cNvPr>
@@ -6028,7 +6028,7 @@
           <p:cNvPr id="22" name="">
             <a:extLst xmlns:a="http://schemas.openxmlformats.org/drawingml/2006/main">
               <a:ext uri="{FF2B5EF4-FFF2-40B4-BE49-F238E27FC236}">
-                <a16:creationId xmlns:a16="http://schemas.microsoft.com/office/drawing/2014/main" id="{8592AE65-097C-49D9-B3A9-A909775F771B}"/>
+                <a16:creationId xmlns:a16="http://schemas.microsoft.com/office/drawing/2014/main" id="{72BA4699-CED3-4379-81D6-5C05350B7BA8}"/>
               </a:ext>
             </a:extLst>
           </p:cNvPr>
@@ -6060,7 +6060,7 @@
           <p:cNvPr id="23" name="">
             <a:extLst xmlns:a="http://schemas.openxmlformats.org/drawingml/2006/main">
               <a:ext uri="{FF2B5EF4-FFF2-40B4-BE49-F238E27FC236}">
-                <a16:creationId xmlns:a16="http://schemas.microsoft.com/office/drawing/2014/main" id="{637554CB-F632-4498-B350-93130DE07E53}"/>
+                <a16:creationId xmlns:a16="http://schemas.microsoft.com/office/drawing/2014/main" id="{84232A8F-9529-4010-8844-E0F6C238C2C8}"/>
               </a:ext>
             </a:extLst>
           </p:cNvPr>
@@ -6092,7 +6092,7 @@
           <p:cNvPr id="24" name="">
             <a:extLst xmlns:a="http://schemas.openxmlformats.org/drawingml/2006/main">
               <a:ext uri="{FF2B5EF4-FFF2-40B4-BE49-F238E27FC236}">
-                <a16:creationId xmlns:a16="http://schemas.microsoft.com/office/drawing/2014/main" id="{979EA324-C1B2-4649-8C34-753A713EBC8D}"/>
+                <a16:creationId xmlns:a16="http://schemas.microsoft.com/office/drawing/2014/main" id="{78048D26-F3E7-42D7-A017-56D562298958}"/>
               </a:ext>
             </a:extLst>
           </p:cNvPr>
@@ -6125,7 +6125,7 @@
           <p:cNvPr id="25" name="원질의·구간 쌍 CrossEncoder 재정렬[8][M2] 상위 5개 구간 선택·입력 길이 관리">
             <a:extLst xmlns:a="http://schemas.openxmlformats.org/drawingml/2006/main">
               <a:ext uri="{FF2B5EF4-FFF2-40B4-BE49-F238E27FC236}">
-                <a16:creationId xmlns:a16="http://schemas.microsoft.com/office/drawing/2014/main" id="{25CC13DA-564B-47AE-89E2-AC22A18B9C06}"/>
+                <a16:creationId xmlns:a16="http://schemas.microsoft.com/office/drawing/2014/main" id="{8EA43AF2-B64A-4825-9209-54524E873BC6}"/>
               </a:ext>
             </a:extLst>
           </p:cNvPr>
@@ -6306,7 +6306,7 @@
           <p:cNvPr id="26" name="">
             <a:extLst xmlns:a="http://schemas.openxmlformats.org/drawingml/2006/main">
               <a:ext uri="{FF2B5EF4-FFF2-40B4-BE49-F238E27FC236}">
-                <a16:creationId xmlns:a16="http://schemas.microsoft.com/office/drawing/2014/main" id="{D01E416E-7B92-451D-B666-13E59680B6E4}"/>
+                <a16:creationId xmlns:a16="http://schemas.microsoft.com/office/drawing/2014/main" id="{2666C21F-B1C2-495D-99E4-DEE4712767ED}"/>
               </a:ext>
             </a:extLst>
           </p:cNvPr>
@@ -6339,7 +6339,7 @@
           <p:cNvPr id="27" name="Mi:dm 2.0 Base Instruct[M1] CAD 로짓 결합 후 SCD 언어별 조정, 최종 답변 생성">
             <a:extLst xmlns:a="http://schemas.openxmlformats.org/drawingml/2006/main">
               <a:ext uri="{FF2B5EF4-FFF2-40B4-BE49-F238E27FC236}">
-                <a16:creationId xmlns:a16="http://schemas.microsoft.com/office/drawing/2014/main" id="{82D33F64-92E1-4669-8729-C1F040716127}"/>
+                <a16:creationId xmlns:a16="http://schemas.microsoft.com/office/drawing/2014/main" id="{D2C6A544-5047-4101-9718-9B4665AB6650}"/>
               </a:ext>
             </a:extLst>
           </p:cNvPr>
@@ -6520,7 +6520,7 @@
           <p:cNvPr id="28" name="">
             <a:extLst xmlns:a="http://schemas.openxmlformats.org/drawingml/2006/main">
               <a:ext uri="{FF2B5EF4-FFF2-40B4-BE49-F238E27FC236}">
-                <a16:creationId xmlns:a16="http://schemas.microsoft.com/office/drawing/2014/main" id="{F9FE418E-2F41-4A46-8A3F-E5F8AFA8F0E3}"/>
+                <a16:creationId xmlns:a16="http://schemas.microsoft.com/office/drawing/2014/main" id="{49AA8C1C-2718-487D-AEAC-C0F7205B48E6}"/>
               </a:ext>
             </a:extLst>
           </p:cNvPr>
@@ -6552,7 +6552,7 @@
           <p:cNvPr id="29" name="">
             <a:extLst xmlns:a="http://schemas.openxmlformats.org/drawingml/2006/main">
               <a:ext uri="{FF2B5EF4-FFF2-40B4-BE49-F238E27FC236}">
-                <a16:creationId xmlns:a16="http://schemas.microsoft.com/office/drawing/2014/main" id="{A0B7D102-7142-4745-B2F3-5861AF5A6AD0}"/>
+                <a16:creationId xmlns:a16="http://schemas.microsoft.com/office/drawing/2014/main" id="{5FE2221B-1614-44C7-A556-F8899D09CE55}"/>
               </a:ext>
             </a:extLst>
           </p:cNvPr>
@@ -6584,7 +6584,7 @@
           <p:cNvPr id="30" name="">
             <a:extLst xmlns:a="http://schemas.openxmlformats.org/drawingml/2006/main">
               <a:ext uri="{FF2B5EF4-FFF2-40B4-BE49-F238E27FC236}">
-                <a16:creationId xmlns:a16="http://schemas.microsoft.com/office/drawing/2014/main" id="{07CB35E2-A813-44BF-890D-9B3C02238C1D}"/>
+                <a16:creationId xmlns:a16="http://schemas.microsoft.com/office/drawing/2014/main" id="{8FF530EC-E47E-4AA1-BCA2-8125DD7D15C8}"/>
               </a:ext>
             </a:extLst>
           </p:cNvPr>
@@ -6615,7 +6615,7 @@
           <p:cNvPr id="31" name="03 3요인 완전요인 실험 설계">
             <a:extLst xmlns:a="http://schemas.openxmlformats.org/drawingml/2006/main">
               <a:ext uri="{FF2B5EF4-FFF2-40B4-BE49-F238E27FC236}">
-                <a16:creationId xmlns:a16="http://schemas.microsoft.com/office/drawing/2014/main" id="{0D8CA60C-18D4-4689-B927-38A94448A0B9}"/>
+                <a16:creationId xmlns:a16="http://schemas.microsoft.com/office/drawing/2014/main" id="{A69E3D3F-0F58-40D0-9834-C475E82D57E2}"/>
               </a:ext>
             </a:extLst>
           </p:cNvPr>
@@ -6773,7 +6773,7 @@
           <p:cNvPr id="32" name="H=HyDE, C=CAD, S=SCD   0=미적용, 1=적용">
             <a:extLst xmlns:a="http://schemas.openxmlformats.org/drawingml/2006/main">
               <a:ext uri="{FF2B5EF4-FFF2-40B4-BE49-F238E27FC236}">
-                <a16:creationId xmlns:a16="http://schemas.microsoft.com/office/drawing/2014/main" id="{6B96E66F-F899-485C-ACBD-371F77DD727A}"/>
+                <a16:creationId xmlns:a16="http://schemas.microsoft.com/office/drawing/2014/main" id="{71871DC1-BCB9-401D-9EAE-4465591893B3}"/>
               </a:ext>
             </a:extLst>
           </p:cNvPr>
@@ -6931,7 +6931,7 @@
           <p:cNvPr id="33" name="">
             <a:extLst xmlns:a="http://schemas.openxmlformats.org/drawingml/2006/main">
               <a:ext uri="{FF2B5EF4-FFF2-40B4-BE49-F238E27FC236}">
-                <a16:creationId xmlns:a16="http://schemas.microsoft.com/office/drawing/2014/main" id="{810D0D89-E0E5-486B-885C-C70AB4A728ED}"/>
+                <a16:creationId xmlns:a16="http://schemas.microsoft.com/office/drawing/2014/main" id="{8AD321E6-9B75-47AF-AF04-C2D002046E83}"/>
               </a:ext>
             </a:extLst>
           </p:cNvPr>
@@ -8461,7 +8461,7 @@
           <p:cNvPr id="34" name="같은 질의 60개 × 8조건 반복측정 = 480개 생성 기록">
             <a:extLst xmlns:a="http://schemas.openxmlformats.org/drawingml/2006/main">
               <a:ext uri="{FF2B5EF4-FFF2-40B4-BE49-F238E27FC236}">
-                <a16:creationId xmlns:a16="http://schemas.microsoft.com/office/drawing/2014/main" id="{BECD48E8-8D7A-4887-9200-F8763108EA15}"/>
+                <a16:creationId xmlns:a16="http://schemas.microsoft.com/office/drawing/2014/main" id="{116B4C4D-F43E-4030-BF53-304C1D03D96D}"/>
               </a:ext>
             </a:extLst>
           </p:cNvPr>
@@ -8619,7 +8619,7 @@
           <p:cNvPr id="35" name="생성 512토큰, CAD α=0.5, SCD α=1.1·β=0.9·Tstart=5">
             <a:extLst xmlns:a="http://schemas.openxmlformats.org/drawingml/2006/main">
               <a:ext uri="{FF2B5EF4-FFF2-40B4-BE49-F238E27FC236}">
-                <a16:creationId xmlns:a16="http://schemas.microsoft.com/office/drawing/2014/main" id="{7AF80AF9-8150-449F-9AB0-3D3BBCCA6313}"/>
+                <a16:creationId xmlns:a16="http://schemas.microsoft.com/office/drawing/2014/main" id="{31036749-CA9D-41BB-8831-0CDC2316E009}"/>
               </a:ext>
             </a:extLst>
           </p:cNvPr>
@@ -8777,7 +8777,7 @@
           <p:cNvPr id="36" name="문서 요약을 15개 내용 단위로 나누어 질의를 작성하고, 총 60개 질의의 원문 페이지·정답 근거·답변 가능성을 확인">
             <a:extLst xmlns:a="http://schemas.openxmlformats.org/drawingml/2006/main">
               <a:ext uri="{FF2B5EF4-FFF2-40B4-BE49-F238E27FC236}">
-                <a16:creationId xmlns:a16="http://schemas.microsoft.com/office/drawing/2014/main" id="{9DE22CE4-2591-4B6F-930E-8AE0E06FC3EE}"/>
+                <a16:creationId xmlns:a16="http://schemas.microsoft.com/office/drawing/2014/main" id="{E2A9BD50-6725-4102-A775-2019F889C72F}"/>
               </a:ext>
             </a:extLst>
           </p:cNvPr>
@@ -8958,7 +8958,7 @@
           <p:cNvPr id="37" name="">
             <a:extLst xmlns:a="http://schemas.openxmlformats.org/drawingml/2006/main">
               <a:ext uri="{FF2B5EF4-FFF2-40B4-BE49-F238E27FC236}">
-                <a16:creationId xmlns:a16="http://schemas.microsoft.com/office/drawing/2014/main" id="{BB7D6B8B-BC7B-4F32-BA88-CF986D56E9B0}"/>
+                <a16:creationId xmlns:a16="http://schemas.microsoft.com/office/drawing/2014/main" id="{C0303BCD-161F-4E51-9E8E-2C63C2D4017A}"/>
               </a:ext>
             </a:extLst>
           </p:cNvPr>
@@ -8989,7 +8989,7 @@
           <p:cNvPr id="38" name="04 평가 지표 및 실험·통계 방법">
             <a:extLst xmlns:a="http://schemas.openxmlformats.org/drawingml/2006/main">
               <a:ext uri="{FF2B5EF4-FFF2-40B4-BE49-F238E27FC236}">
-                <a16:creationId xmlns:a16="http://schemas.microsoft.com/office/drawing/2014/main" id="{1EFF305F-73A6-4621-9119-01D3B2F76CBE}"/>
+                <a16:creationId xmlns:a16="http://schemas.microsoft.com/office/drawing/2014/main" id="{E4C8F15C-80C5-4B90-9D18-F64AD1EDAA8C}"/>
               </a:ext>
             </a:extLst>
           </p:cNvPr>
@@ -9147,7 +9147,7 @@
           <p:cNvPr id="39" name="근거 충실도: 높을수록 검색 근거가 지지하는 답변 주장 비율이 크다. 답변 관련성: 높을수록 답변 기반 질문과 원질문">
             <a:extLst xmlns:a="http://schemas.openxmlformats.org/drawingml/2006/main">
               <a:ext uri="{FF2B5EF4-FFF2-40B4-BE49-F238E27FC236}">
-                <a16:creationId xmlns:a16="http://schemas.microsoft.com/office/drawing/2014/main" id="{FD0807A8-1646-437A-9DE4-245C02141654}"/>
+                <a16:creationId xmlns:a16="http://schemas.microsoft.com/office/drawing/2014/main" id="{34D4FEBF-3FAE-466A-90E0-F2D762690C7E}"/>
               </a:ext>
             </a:extLst>
           </p:cNvPr>
@@ -9397,7 +9397,7 @@
           <p:cNvPr id="40" name="품질 관측값은 0~1이다. 관련성 +0.080은 ON−OFF 평균 차이 0.080점이다. SD는 질의별 분포의 표본표">
             <a:extLst xmlns:a="http://schemas.openxmlformats.org/drawingml/2006/main">
               <a:ext uri="{FF2B5EF4-FFF2-40B4-BE49-F238E27FC236}">
-                <a16:creationId xmlns:a16="http://schemas.microsoft.com/office/drawing/2014/main" id="{7F4D7193-6242-48E4-B011-335BA633D070}"/>
+                <a16:creationId xmlns:a16="http://schemas.microsoft.com/office/drawing/2014/main" id="{88C0CADF-57BA-4362-A5A5-D47FC13ACD39}"/>
               </a:ext>
             </a:extLst>
           </p:cNvPr>
@@ -9601,7 +9601,7 @@
           <p:cNvPr id="41" name="평가 예시  ext_raptor_011, H0C0S0">
             <a:extLst xmlns:a="http://schemas.openxmlformats.org/drawingml/2006/main">
               <a:ext uri="{FF2B5EF4-FFF2-40B4-BE49-F238E27FC236}">
-                <a16:creationId xmlns:a16="http://schemas.microsoft.com/office/drawing/2014/main" id="{C3412673-FF58-4B98-BDD5-3CBD33AAA2B1}"/>
+                <a16:creationId xmlns:a16="http://schemas.microsoft.com/office/drawing/2014/main" id="{E37F1A37-A672-4B83-AEB7-C8CA70C6E8AC}"/>
               </a:ext>
             </a:extLst>
           </p:cNvPr>
@@ -9759,7 +9759,7 @@
           <p:cNvPr id="42" name="질문: Cinderella 사례의 정성 분석에서 RAPTOR의 tree-based retrieval이 DPR보다 주제">
             <a:extLst xmlns:a="http://schemas.openxmlformats.org/drawingml/2006/main">
               <a:ext uri="{FF2B5EF4-FFF2-40B4-BE49-F238E27FC236}">
-                <a16:creationId xmlns:a16="http://schemas.microsoft.com/office/drawing/2014/main" id="{DEE45DEB-C207-4D3A-800A-9765715FE6CF}"/>
+                <a16:creationId xmlns:a16="http://schemas.microsoft.com/office/drawing/2014/main" id="{DC3499A3-42C3-4F21-A0E8-20049CE17FB6}"/>
               </a:ext>
             </a:extLst>
           </p:cNvPr>
@@ -9940,7 +9940,7 @@
           <p:cNvPr id="43" name="검색 근거(PDF p.9): “By providing both the original text and higher-l">
             <a:extLst xmlns:a="http://schemas.openxmlformats.org/drawingml/2006/main">
               <a:ext uri="{FF2B5EF4-FFF2-40B4-BE49-F238E27FC236}">
-                <a16:creationId xmlns:a16="http://schemas.microsoft.com/office/drawing/2014/main" id="{39282E8E-0A93-46D3-B4DA-20F99524F491}"/>
+                <a16:creationId xmlns:a16="http://schemas.microsoft.com/office/drawing/2014/main" id="{C3ADAF69-E5B3-449E-A7FD-5356507FA591}"/>
               </a:ext>
             </a:extLst>
           </p:cNvPr>
@@ -10144,7 +10144,7 @@
           <p:cNvPr id="44" name="참조 답변 요지(PDF p.20): RAPTOR는 이야기의 주요 부분을, DPR은 이야기의 좁은 일부를 자세히 검색한">
             <a:extLst xmlns:a="http://schemas.openxmlformats.org/drawingml/2006/main">
               <a:ext uri="{FF2B5EF4-FFF2-40B4-BE49-F238E27FC236}">
-                <a16:creationId xmlns:a16="http://schemas.microsoft.com/office/drawing/2014/main" id="{0DC59136-55D7-4F06-9243-1C356041EBF9}"/>
+                <a16:creationId xmlns:a16="http://schemas.microsoft.com/office/drawing/2014/main" id="{9C0E3B67-A5CE-45EC-8464-516C9CBB59C8}"/>
               </a:ext>
             </a:extLst>
           </p:cNvPr>
@@ -10325,7 +10325,7 @@
           <p:cNvPr id="45" name="생성 답변 발췌: “질문의 요구사항에 따라 서로 다른 층위(layer)에서 노드를 선택할 수 있습니다.”">
             <a:extLst xmlns:a="http://schemas.openxmlformats.org/drawingml/2006/main">
               <a:ext uri="{FF2B5EF4-FFF2-40B4-BE49-F238E27FC236}">
-                <a16:creationId xmlns:a16="http://schemas.microsoft.com/office/drawing/2014/main" id="{0122C19A-96E0-4A2D-8EB6-9A5FC2D7D46F}"/>
+                <a16:creationId xmlns:a16="http://schemas.microsoft.com/office/drawing/2014/main" id="{A623D024-5FFC-45AF-95E6-B29CC4D9C109}"/>
               </a:ext>
             </a:extLst>
           </p:cNvPr>
@@ -10506,7 +10506,7 @@
           <p:cNvPr id="46" name="충실도 1.000: 추출된 답변 주장을 검색 결과가 모두 지지 관련성 0.937: 답변 기반 질문과 원질문의 평균 의">
             <a:extLst xmlns:a="http://schemas.openxmlformats.org/drawingml/2006/main">
               <a:ext uri="{FF2B5EF4-FFF2-40B4-BE49-F238E27FC236}">
-                <a16:creationId xmlns:a16="http://schemas.microsoft.com/office/drawing/2014/main" id="{0F0031D5-188C-400B-8DF3-C56BCB1C79F7}"/>
+                <a16:creationId xmlns:a16="http://schemas.microsoft.com/office/drawing/2014/main" id="{9A302188-48D6-4F4F-BCFF-73D34CA44E60}"/>
               </a:ext>
             </a:extLst>
           </p:cNvPr>
@@ -10687,7 +10687,7 @@
           <p:cNvPr id="47" name="평가: RAGAS 0.2.15[10]·gpt-4o·BGE-M3, 저장 답변 평가 평가 언어: S0 영어 / S1 한국">
             <a:extLst xmlns:a="http://schemas.openxmlformats.org/drawingml/2006/main">
               <a:ext uri="{FF2B5EF4-FFF2-40B4-BE49-F238E27FC236}">
-                <a16:creationId xmlns:a16="http://schemas.microsoft.com/office/drawing/2014/main" id="{11853166-0F27-42FA-8B71-7177C1D3BB98}"/>
+                <a16:creationId xmlns:a16="http://schemas.microsoft.com/office/drawing/2014/main" id="{0B8F4923-F7F9-43DE-8B49-D3938F05BFDC}"/>
               </a:ext>
             </a:extLst>
           </p:cNvPr>
@@ -10865,10 +10865,10 @@
       </p:sp>
       <p:sp>
         <p:nvSpPr>
-          <p:cNvPr id="48" name="반복측정 분산분석(ANOVA)·대응 t-검정, 양측 α=0.05 품질 S별 H×C / 문자·시간 H×C×S, SCD ">
+          <p:cNvPr id="48" name="반복측정 분산분석(ANOVA)·대응 t-검정, 양측 α=0.05 품질: SCD 상태별 H×C / 한국어 비율·시간: ">
             <a:extLst xmlns:a="http://schemas.openxmlformats.org/drawingml/2006/main">
               <a:ext uri="{FF2B5EF4-FFF2-40B4-BE49-F238E27FC236}">
-                <a16:creationId xmlns:a16="http://schemas.microsoft.com/office/drawing/2014/main" id="{2C6E7E6B-0306-4EA9-822E-C4C88550DCCB}"/>
+                <a16:creationId xmlns:a16="http://schemas.microsoft.com/office/drawing/2014/main" id="{EB0B9160-DBEB-4086-AF5F-982005DCCA1C}"/>
               </a:ext>
             </a:extLst>
           </p:cNvPr>
@@ -11039,7 +11039,7 @@
                 <a:ea typeface="Malgun Gothic"/>
                 <a:cs typeface="Malgun Gothic"/>
               </a:rPr>
-              <a:t>품질 S별 H×C / 문자·시간 H×C×S, SCD 120·240쌍→질의60</a:t>
+              <a:t>품질: SCD 상태별 H×C / 한국어 비율·시간: H×C×S, SCD 대응쌍은 질의별 평균(n=60)</a:t>
             </a:r>
           </a:p>
         </p:txBody>
@@ -11049,7 +11049,7 @@
           <p:cNvPr id="49" name="">
             <a:extLst xmlns:a="http://schemas.openxmlformats.org/drawingml/2006/main">
               <a:ext uri="{FF2B5EF4-FFF2-40B4-BE49-F238E27FC236}">
-                <a16:creationId xmlns:a16="http://schemas.microsoft.com/office/drawing/2014/main" id="{FD264E1F-B597-4562-BC61-32470FDE4F2A}"/>
+                <a16:creationId xmlns:a16="http://schemas.microsoft.com/office/drawing/2014/main" id="{20C34AB8-5FB9-44BC-8D41-E5CE950F9FA3}"/>
               </a:ext>
             </a:extLst>
           </p:cNvPr>
@@ -11080,7 +11080,7 @@
           <p:cNvPr id="50" name="05 조합별 결과와 통계 검정">
             <a:extLst xmlns:a="http://schemas.openxmlformats.org/drawingml/2006/main">
               <a:ext uri="{FF2B5EF4-FFF2-40B4-BE49-F238E27FC236}">
-                <a16:creationId xmlns:a16="http://schemas.microsoft.com/office/drawing/2014/main" id="{95678E53-9946-4562-A735-54D6DA885E15}"/>
+                <a16:creationId xmlns:a16="http://schemas.microsoft.com/office/drawing/2014/main" id="{B8026820-DC64-4CAE-846B-BBD1C4EB45AD}"/>
               </a:ext>
             </a:extLst>
           </p:cNvPr>
@@ -11238,7 +11238,7 @@
           <p:cNvPr id="51" name="HyDE·CAD·SCD 8조합의 품질·한국어 비율·시간 평균(SD)">
             <a:extLst xmlns:a="http://schemas.openxmlformats.org/drawingml/2006/main">
               <a:ext uri="{FF2B5EF4-FFF2-40B4-BE49-F238E27FC236}">
-                <a16:creationId xmlns:a16="http://schemas.microsoft.com/office/drawing/2014/main" id="{0F99F741-6688-41A4-8823-BC4FFF749F26}"/>
+                <a16:creationId xmlns:a16="http://schemas.microsoft.com/office/drawing/2014/main" id="{C8442F1B-C298-43B8-974A-C33CA8E52BCB}"/>
               </a:ext>
             </a:extLst>
           </p:cNvPr>
@@ -11396,7 +11396,7 @@
           <p:cNvPr id="52" name="">
             <a:extLst xmlns:a="http://schemas.openxmlformats.org/drawingml/2006/main">
               <a:ext uri="{FF2B5EF4-FFF2-40B4-BE49-F238E27FC236}">
-                <a16:creationId xmlns:a16="http://schemas.microsoft.com/office/drawing/2014/main" id="{907F3F6A-CA6B-4B42-9F65-A64A2DFC4A2A}"/>
+                <a16:creationId xmlns:a16="http://schemas.microsoft.com/office/drawing/2014/main" id="{81BFE966-BC00-4A78-B095-B71984F5A4EB}"/>
               </a:ext>
             </a:extLst>
           </p:cNvPr>
@@ -14756,7 +14756,7 @@
           <p:cNvPr id="53" name="">
             <a:extLst xmlns:a="http://schemas.openxmlformats.org/drawingml/2006/main">
               <a:ext uri="{FF2B5EF4-FFF2-40B4-BE49-F238E27FC236}">
-                <a16:creationId xmlns:a16="http://schemas.microsoft.com/office/drawing/2014/main" id="{50E735DA-2EE0-4406-9278-6C9407026C56}"/>
+                <a16:creationId xmlns:a16="http://schemas.microsoft.com/office/drawing/2014/main" id="{EEE5D3F3-A0F6-4031-BFA9-423A029CF023}"/>
               </a:ext>
             </a:extLst>
           </p:cNvPr>
@@ -14787,7 +14787,7 @@
           <p:cNvPr id="54" name="S0: 영어로 평가 / S1: 한국어 번역으로 평가 충실도 H0C1S0 n=58, H0C0S1 n=57, 나머지 n=">
             <a:extLst xmlns:a="http://schemas.openxmlformats.org/drawingml/2006/main">
               <a:ext uri="{FF2B5EF4-FFF2-40B4-BE49-F238E27FC236}">
-                <a16:creationId xmlns:a16="http://schemas.microsoft.com/office/drawing/2014/main" id="{75046709-B8A9-4069-A223-55D1E6965471}"/>
+                <a16:creationId xmlns:a16="http://schemas.microsoft.com/office/drawing/2014/main" id="{295E0488-BDFD-4C11-B933-812D2285EFAC}"/>
               </a:ext>
             </a:extLst>
           </p:cNvPr>
@@ -14991,7 +14991,7 @@
           <p:cNvPr id="55" name="3요인 반복측정 ANOVA  ·  각 효과 df=(1,59)">
             <a:extLst xmlns:a="http://schemas.openxmlformats.org/drawingml/2006/main">
               <a:ext uri="{FF2B5EF4-FFF2-40B4-BE49-F238E27FC236}">
-                <a16:creationId xmlns:a16="http://schemas.microsoft.com/office/drawing/2014/main" id="{3882FF16-E846-400D-9A81-05F42242403F}"/>
+                <a16:creationId xmlns:a16="http://schemas.microsoft.com/office/drawing/2014/main" id="{40531829-FA42-40F2-ABFC-4704220EC752}"/>
               </a:ext>
             </a:extLst>
           </p:cNvPr>
@@ -15149,7 +15149,7 @@
           <p:cNvPr id="56" name="">
             <a:extLst xmlns:a="http://schemas.openxmlformats.org/drawingml/2006/main">
               <a:ext uri="{FF2B5EF4-FFF2-40B4-BE49-F238E27FC236}">
-                <a16:creationId xmlns:a16="http://schemas.microsoft.com/office/drawing/2014/main" id="{FBEFF174-3C7C-4C0E-A6AF-AD0B9E05ACA0}"/>
+                <a16:creationId xmlns:a16="http://schemas.microsoft.com/office/drawing/2014/main" id="{393AD65B-8613-4291-8BAE-D64014BEB2C3}"/>
               </a:ext>
             </a:extLst>
           </p:cNvPr>
@@ -16862,7 +16862,7 @@
           <p:cNvPr id="57" name="p&lt;0.05: 한국어 비율 S·H×C / 실행 시간 H·C·S·C×S RAGAS H×C 검정은 평가 언어별로 수행했으">
             <a:extLst xmlns:a="http://schemas.openxmlformats.org/drawingml/2006/main">
               <a:ext uri="{FF2B5EF4-FFF2-40B4-BE49-F238E27FC236}">
-                <a16:creationId xmlns:a16="http://schemas.microsoft.com/office/drawing/2014/main" id="{B6008603-5833-4D74-AF42-AFDE4985F7D8}"/>
+                <a16:creationId xmlns:a16="http://schemas.microsoft.com/office/drawing/2014/main" id="{8D43E5C8-53AE-46BC-8AC2-0CAB42FBFE59}"/>
               </a:ext>
             </a:extLst>
           </p:cNvPr>
@@ -17066,7 +17066,7 @@
           <p:cNvPr id="58" name="기법별 대응 비교  ·  질의별 평균 차이, 양측 검정">
             <a:extLst xmlns:a="http://schemas.openxmlformats.org/drawingml/2006/main">
               <a:ext uri="{FF2B5EF4-FFF2-40B4-BE49-F238E27FC236}">
-                <a16:creationId xmlns:a16="http://schemas.microsoft.com/office/drawing/2014/main" id="{E738EF54-CAFB-4DA8-B1B1-62B796968596}"/>
+                <a16:creationId xmlns:a16="http://schemas.microsoft.com/office/drawing/2014/main" id="{1CBB8F47-5559-4E64-A827-F5A96B999554}"/>
               </a:ext>
             </a:extLst>
           </p:cNvPr>
@@ -17224,7 +17224,7 @@
           <p:cNvPr id="59" name="">
             <a:extLst xmlns:a="http://schemas.openxmlformats.org/drawingml/2006/main">
               <a:ext uri="{FF2B5EF4-FFF2-40B4-BE49-F238E27FC236}">
-                <a16:creationId xmlns:a16="http://schemas.microsoft.com/office/drawing/2014/main" id="{C1FE5007-D33D-452F-B7E4-1159DE971303}"/>
+                <a16:creationId xmlns:a16="http://schemas.microsoft.com/office/drawing/2014/main" id="{205563F7-B5A4-434B-8C44-4B92B7814EC4}"/>
               </a:ext>
             </a:extLst>
           </p:cNvPr>
@@ -18237,7 +18237,7 @@
           <p:cNvPr id="60" name="HyDE: C0S0, CAD: H0S0, SCD: H0의 CAD 상태 평균 p: 다중비교 보정 없는 양측 p, dz:">
             <a:extLst xmlns:a="http://schemas.openxmlformats.org/drawingml/2006/main">
               <a:ext uri="{FF2B5EF4-FFF2-40B4-BE49-F238E27FC236}">
-                <a16:creationId xmlns:a16="http://schemas.microsoft.com/office/drawing/2014/main" id="{FDC519F8-214C-4CE9-8A1E-FCFF5193EA6F}"/>
+                <a16:creationId xmlns:a16="http://schemas.microsoft.com/office/drawing/2014/main" id="{C0816845-668B-41BA-BDBE-562C26C50FEC}"/>
               </a:ext>
             </a:extLst>
           </p:cNvPr>
@@ -18464,7 +18464,7 @@
           <p:cNvPr id="61" name="">
             <a:extLst xmlns:a="http://schemas.openxmlformats.org/drawingml/2006/main">
               <a:ext uri="{FF2B5EF4-FFF2-40B4-BE49-F238E27FC236}">
-                <a16:creationId xmlns:a16="http://schemas.microsoft.com/office/drawing/2014/main" id="{88A47597-C87D-49E1-B562-57E722E00F6B}"/>
+                <a16:creationId xmlns:a16="http://schemas.microsoft.com/office/drawing/2014/main" id="{016D7BE4-F789-46BA-AD29-2F59AB9C1732}"/>
               </a:ext>
             </a:extLst>
           </p:cNvPr>
@@ -18495,7 +18495,7 @@
           <p:cNvPr id="62" name="06 결과 해석">
             <a:extLst xmlns:a="http://schemas.openxmlformats.org/drawingml/2006/main">
               <a:ext uri="{FF2B5EF4-FFF2-40B4-BE49-F238E27FC236}">
-                <a16:creationId xmlns:a16="http://schemas.microsoft.com/office/drawing/2014/main" id="{F7C8BA24-D803-4068-9833-87ECD866E268}"/>
+                <a16:creationId xmlns:a16="http://schemas.microsoft.com/office/drawing/2014/main" id="{6F48715C-D631-4F96-9C90-6B0BF34481F5}"/>
               </a:ext>
             </a:extLst>
           </p:cNvPr>
@@ -18653,7 +18653,7 @@
           <p:cNvPr id="63" name="HyDE 관련성은 평균 +0.080점, t(59)=2.236, p=0.029였다. CAD 충실도는 평균 +0.029점">
             <a:extLst xmlns:a="http://schemas.openxmlformats.org/drawingml/2006/main">
               <a:ext uri="{FF2B5EF4-FFF2-40B4-BE49-F238E27FC236}">
-                <a16:creationId xmlns:a16="http://schemas.microsoft.com/office/drawing/2014/main" id="{6FD4FACA-8CCF-41E3-9547-9A10A217EB9D}"/>
+                <a16:creationId xmlns:a16="http://schemas.microsoft.com/office/drawing/2014/main" id="{3E3E3D95-84C1-4D2B-B648-631C8BDC05EE}"/>
               </a:ext>
             </a:extLst>
           </p:cNvPr>
@@ -18847,7 +18847,7 @@
                 <a:ea typeface="Malgun Gothic"/>
                 <a:cs typeface="Malgun Gothic"/>
               </a:rPr>
-              <a:t>SCD 주 비교의 한국어 비율은 21.822%p 높았다(p&lt;0.001).</a:t>
+              <a:t>SCD 주 비교의 한국어 비율은 21.8%p 높았다(p&lt;0.001).</a:t>
             </a:r>
           </a:p>
           <a:p xmlns:a="http://schemas.openxmlformats.org/drawingml/2006/main">
@@ -18870,7 +18870,7 @@
                 <a:ea typeface="Malgun Gothic"/>
                 <a:cs typeface="Malgun Gothic"/>
               </a:rPr>
-              <a:t>CAD 시간 증가: SCD OFF +46.583초 / ON +37.747초.</a:t>
+              <a:t>CAD 시간 증가: SCD OFF +46.6초 / ON +37.7초.</a:t>
             </a:r>
           </a:p>
         </p:txBody>
@@ -18880,7 +18880,7 @@
           <p:cNvPr id="64" name="">
             <a:extLst xmlns:a="http://schemas.openxmlformats.org/drawingml/2006/main">
               <a:ext uri="{FF2B5EF4-FFF2-40B4-BE49-F238E27FC236}">
-                <a16:creationId xmlns:a16="http://schemas.microsoft.com/office/drawing/2014/main" id="{7DA0E778-FFE5-4E17-8764-81049E8D7078}"/>
+                <a16:creationId xmlns:a16="http://schemas.microsoft.com/office/drawing/2014/main" id="{0DDFB009-280C-4D25-8BD8-EC906DF8121E}"/>
               </a:ext>
             </a:extLst>
           </p:cNvPr>
@@ -18911,7 +18911,7 @@
           <p:cNvPr id="65" name="07 결론">
             <a:extLst xmlns:a="http://schemas.openxmlformats.org/drawingml/2006/main">
               <a:ext uri="{FF2B5EF4-FFF2-40B4-BE49-F238E27FC236}">
-                <a16:creationId xmlns:a16="http://schemas.microsoft.com/office/drawing/2014/main" id="{BBA5CC2C-EA78-454B-9C85-4297DD269849}"/>
+                <a16:creationId xmlns:a16="http://schemas.microsoft.com/office/drawing/2014/main" id="{BEF4C6BB-82A6-46F7-B90D-D803172EA2E4}"/>
               </a:ext>
             </a:extLst>
           </p:cNvPr>
@@ -19069,7 +19069,7 @@
           <p:cNvPr id="66" name="HyDE는 C0S0에서 관련성을 높였고(p=0.029), CAD 충실도 차이는 p=0.393이었다. SCD는 같은 영">
             <a:extLst xmlns:a="http://schemas.openxmlformats.org/drawingml/2006/main">
               <a:ext uri="{FF2B5EF4-FFF2-40B4-BE49-F238E27FC236}">
-                <a16:creationId xmlns:a16="http://schemas.microsoft.com/office/drawing/2014/main" id="{FE250D17-B2D7-4429-9AA1-CDA727DCE868}"/>
+                <a16:creationId xmlns:a16="http://schemas.microsoft.com/office/drawing/2014/main" id="{86590124-E2D6-4D2C-BCE9-2DA0B098CE85}"/>
               </a:ext>
             </a:extLst>
           </p:cNvPr>
@@ -19319,7 +19319,7 @@
           <p:cNvPr id="67" name="">
             <a:extLst xmlns:a="http://schemas.openxmlformats.org/drawingml/2006/main">
               <a:ext uri="{FF2B5EF4-FFF2-40B4-BE49-F238E27FC236}">
-                <a16:creationId xmlns:a16="http://schemas.microsoft.com/office/drawing/2014/main" id="{615B71FC-A346-4231-AF8D-A0CB757FFA38}"/>
+                <a16:creationId xmlns:a16="http://schemas.microsoft.com/office/drawing/2014/main" id="{836ABA67-7A8C-4E2E-91E6-A3D6200818D8}"/>
               </a:ext>
             </a:extLst>
           </p:cNvPr>
@@ -19350,7 +19350,7 @@
           <p:cNvPr id="68" name="08 주요 참고문헌">
             <a:extLst xmlns:a="http://schemas.openxmlformats.org/drawingml/2006/main">
               <a:ext uri="{FF2B5EF4-FFF2-40B4-BE49-F238E27FC236}">
-                <a16:creationId xmlns:a16="http://schemas.microsoft.com/office/drawing/2014/main" id="{73C8002D-0CF4-4E30-AAC4-5FCDD9F3AE6E}"/>
+                <a16:creationId xmlns:a16="http://schemas.microsoft.com/office/drawing/2014/main" id="{4D6854E6-000C-459A-B5ED-65287A85E009}"/>
               </a:ext>
             </a:extLst>
           </p:cNvPr>
@@ -19508,7 +19508,7 @@
           <p:cNvPr id="69" name="[1] Lewis et al. RAG. NeurIPS, 2020. [2] Gao et al. HyDE. ACL, 20">
             <a:extLst xmlns:a="http://schemas.openxmlformats.org/drawingml/2006/main">
               <a:ext uri="{FF2B5EF4-FFF2-40B4-BE49-F238E27FC236}">
-                <a16:creationId xmlns:a16="http://schemas.microsoft.com/office/drawing/2014/main" id="{41E7049E-11D6-4A1F-BE20-646651CCEE37}"/>
+                <a16:creationId xmlns:a16="http://schemas.microsoft.com/office/drawing/2014/main" id="{825D5A2E-31B9-4494-A2A9-4E4FF8352A4F}"/>
               </a:ext>
             </a:extLst>
           </p:cNvPr>
@@ -19712,7 +19712,7 @@
           <p:cNvPr id="70" name="[4] Li et al. Language Drift and SCD. AAAI, 2026. [5] Chen et al.">
             <a:extLst xmlns:a="http://schemas.openxmlformats.org/drawingml/2006/main">
               <a:ext uri="{FF2B5EF4-FFF2-40B4-BE49-F238E27FC236}">
-                <a16:creationId xmlns:a16="http://schemas.microsoft.com/office/drawing/2014/main" id="{2896C016-835C-4B43-8751-EF7457D37FFB}"/>
+                <a16:creationId xmlns:a16="http://schemas.microsoft.com/office/drawing/2014/main" id="{DE9E04A5-62CE-4805-8CFA-37769019A343}"/>
               </a:ext>
             </a:extLst>
           </p:cNvPr>
@@ -19916,7 +19916,7 @@
           <p:cNvPr id="71" name="[6] Robertson et al. Okapi at TREC-3. NIST, 1995. [7] Cormack et ">
             <a:extLst xmlns:a="http://schemas.openxmlformats.org/drawingml/2006/main">
               <a:ext uri="{FF2B5EF4-FFF2-40B4-BE49-F238E27FC236}">
-                <a16:creationId xmlns:a16="http://schemas.microsoft.com/office/drawing/2014/main" id="{683BF456-9D45-4BAC-9121-73490765EBD6}"/>
+                <a16:creationId xmlns:a16="http://schemas.microsoft.com/office/drawing/2014/main" id="{78204908-7C94-46F5-ABDD-4B5AEE8C319D}"/>
               </a:ext>
             </a:extLst>
           </p:cNvPr>
@@ -20097,7 +20097,7 @@
           <p:cNvPr id="72" name="[8] MacAvaney et al. CEDR. SIGIR, 2019. 공식 모델  [M1] KT Mi:dm 2.0 ">
             <a:extLst xmlns:a="http://schemas.openxmlformats.org/drawingml/2006/main">
               <a:ext uri="{FF2B5EF4-FFF2-40B4-BE49-F238E27FC236}">
-                <a16:creationId xmlns:a16="http://schemas.microsoft.com/office/drawing/2014/main" id="{655632E7-3B6A-41E8-8507-B51A203634B6}"/>
+                <a16:creationId xmlns:a16="http://schemas.microsoft.com/office/drawing/2014/main" id="{A19F4303-8579-495D-AFDA-452DB00C7124}"/>
               </a:ext>
             </a:extLst>
           </p:cNvPr>
@@ -20278,7 +20278,7 @@
           <p:cNvPr id="73" name="전체 참고문헌 22편과 모델·자료 출처는 논문의 참고문헌에 수록">
             <a:extLst xmlns:a="http://schemas.openxmlformats.org/drawingml/2006/main">
               <a:ext uri="{FF2B5EF4-FFF2-40B4-BE49-F238E27FC236}">
-                <a16:creationId xmlns:a16="http://schemas.microsoft.com/office/drawing/2014/main" id="{E4E79B22-ABD6-442D-BE31-552D3F2694A1}"/>
+                <a16:creationId xmlns:a16="http://schemas.microsoft.com/office/drawing/2014/main" id="{C324540F-2DBC-4D8F-9B96-472E99434986}"/>
               </a:ext>
             </a:extLst>
           </p:cNvPr>
@@ -20436,7 +20436,7 @@
           <p:cNvPr id="74" name="영어 문서 4종 · 질의 60개 · 생성 모델 1종 · 질의별 반복측정">
             <a:extLst xmlns:a="http://schemas.openxmlformats.org/drawingml/2006/main">
               <a:ext uri="{FF2B5EF4-FFF2-40B4-BE49-F238E27FC236}">
-                <a16:creationId xmlns:a16="http://schemas.microsoft.com/office/drawing/2014/main" id="{E1AF734D-69B7-48D0-B1F4-ABEFB0216D42}"/>
+                <a16:creationId xmlns:a16="http://schemas.microsoft.com/office/drawing/2014/main" id="{D495E1C2-3AAE-4CF5-9BE2-746AF70B155E}"/>
               </a:ext>
             </a:extLst>
           </p:cNvPr>
@@ -20594,7 +20594,7 @@
           <p:cNvPr id="75" name="A1 594 × 841 mm">
             <a:extLst xmlns:a="http://schemas.openxmlformats.org/drawingml/2006/main">
               <a:ext uri="{FF2B5EF4-FFF2-40B4-BE49-F238E27FC236}">
-                <a16:creationId xmlns:a16="http://schemas.microsoft.com/office/drawing/2014/main" id="{13CEBAD9-9D63-45DD-AB62-1A79BE0DE151}"/>
+                <a16:creationId xmlns:a16="http://schemas.microsoft.com/office/drawing/2014/main" id="{7AD36D54-2D25-403B-9A86-DCF8076F882E}"/>
               </a:ext>
             </a:extLst>
           </p:cNvPr>
@@ -20750,7 +20750,7 @@
     </p:spTree>
     <p:extLst>
       <p:ext uri="{BB962C8B-B14F-4D97-AF65-F5344CB8AC3E}">
-        <p14:creationId xmlns:p14="http://schemas.microsoft.com/office/powerpoint/2010/main" val="1613744321"/>
+        <p14:creationId xmlns:p14="http://schemas.microsoft.com/office/powerpoint/2010/main" val="2047551306"/>
       </p:ext>
     </p:extLst>
   </p:cSld>

</xml_diff>

<commit_message>
Apply the independent prose review to the thesis and poster
- Thesis: fix effect verbs on non-significant results, reduce repeated
  "p값은 ~보다 컸다", state the multiple-comparison handling, add the
  C×S interaction to the RQ4 conclusion, fix cause/effect order and
  vague referents, add 3.1x/2.7x in 5.7, match the B-2 quoted question
  to appendix A, remove duplicated record-keeping descriptions, and
  rewrite 6.2 as the significance of the comparison
- Poster: rewrite 06/07, mark exploratory effects, add a problem
  statement to 01, unify terms with the thesis
- Page break before 5.9 (heading no longer stranded); regenerate
  HWPX/PDF (51 pages) and refresh manifests
- Add the independent review report

Co-Authored-By: Claude Opus 5.5 <noreply@anthropic.com>
</commit_message>
<xml_diff>
--- a/FINALDOCS/POSTER/FINAL/M_RAG_A1_FINAL_EDITABLE.pptx
+++ b/FINALDOCS/POSTER/FINAL/M_RAG_A1_FINAL_EDITABLE.pptx
@@ -2,13 +2,13 @@
 <file path=ppt/presentation.xml><?xml version="1.0" encoding="utf-8"?>
 <p:presentation xmlns:p="http://schemas.openxmlformats.org/presentationml/2006/main">
   <p:sldMasterIdLst>
-    <p:sldMasterId xmlns:r="http://schemas.openxmlformats.org/officeDocument/2006/relationships" id="2147483648" r:id="R6235bf1f6f664c81"/>
+    <p:sldMasterId xmlns:r="http://schemas.openxmlformats.org/officeDocument/2006/relationships" id="2147483648" r:id="R78afd8e3b6eb4d84"/>
   </p:sldMasterIdLst>
   <p:notesMasterIdLst>
-    <p:notesMasterId xmlns:r="http://schemas.openxmlformats.org/officeDocument/2006/relationships" r:id="Rdd3939f53baa400d"/>
+    <p:notesMasterId xmlns:r="http://schemas.openxmlformats.org/officeDocument/2006/relationships" r:id="R53f3c389fc704493"/>
   </p:notesMasterIdLst>
   <p:sldIdLst>
-    <p:sldId xmlns:r="http://schemas.openxmlformats.org/officeDocument/2006/relationships" id="256" r:id="Re375367e10cc407b"/>
+    <p:sldId xmlns:r="http://schemas.openxmlformats.org/officeDocument/2006/relationships" id="256" r:id="Rc702f5a0ec6c4574"/>
   </p:sldIdLst>
   <p:sldSz cx="21384000" cy="30276000"/>
   <p:notesSz cx="6858000" cy="9144000"/>
@@ -489,7 +489,7 @@
           <p:cNvPr id="3" name="Title">
             <a:extLst xmlns:a="http://schemas.openxmlformats.org/drawingml/2006/main">
               <a:ext uri="{FF2B5EF4-FFF2-40B4-BE49-F238E27FC236}">
-                <a16:creationId xmlns:a16="http://schemas.microsoft.com/office/drawing/2014/main" id="{07C0BAFA-B223-4E60-99AC-127FBC0D8590}"/>
+                <a16:creationId xmlns:a16="http://schemas.microsoft.com/office/drawing/2014/main" id="{2289664F-4BAD-455F-A843-FE758703F648}"/>
               </a:ext>
             </a:extLst>
           </p:cNvPr>
@@ -718,7 +718,7 @@
           <p:cNvPr id="2" name="Subtitle">
             <a:extLst xmlns:a="http://schemas.openxmlformats.org/drawingml/2006/main">
               <a:ext uri="{FF2B5EF4-FFF2-40B4-BE49-F238E27FC236}">
-                <a16:creationId xmlns:a16="http://schemas.microsoft.com/office/drawing/2014/main" id="{31722EE8-B848-4B0B-9468-5D6C68178045}"/>
+                <a16:creationId xmlns:a16="http://schemas.microsoft.com/office/drawing/2014/main" id="{6806BBF0-0EB0-4FA4-AD43-B7CB5FC00D4D}"/>
               </a:ext>
             </a:extLst>
           </p:cNvPr>
@@ -964,7 +964,7 @@
           <p:cNvPr id="2" name="Section title">
             <a:extLst xmlns:a="http://schemas.openxmlformats.org/drawingml/2006/main">
               <a:ext uri="{FF2B5EF4-FFF2-40B4-BE49-F238E27FC236}">
-                <a16:creationId xmlns:a16="http://schemas.microsoft.com/office/drawing/2014/main" id="{E65C68E4-B19B-414A-999E-423151292715}"/>
+                <a16:creationId xmlns:a16="http://schemas.microsoft.com/office/drawing/2014/main" id="{AA42F1BD-BB3A-45EA-BEF4-E97982B6E594}"/>
               </a:ext>
             </a:extLst>
           </p:cNvPr>
@@ -1210,7 +1210,7 @@
           <p:cNvPr id="3" name="Title">
             <a:extLst xmlns:a="http://schemas.openxmlformats.org/drawingml/2006/main">
               <a:ext uri="{FF2B5EF4-FFF2-40B4-BE49-F238E27FC236}">
-                <a16:creationId xmlns:a16="http://schemas.microsoft.com/office/drawing/2014/main" id="{6F31241B-A97F-4299-A9AC-F0157EAABDED}"/>
+                <a16:creationId xmlns:a16="http://schemas.microsoft.com/office/drawing/2014/main" id="{CFD9C104-D843-4298-BC0A-9262CD460E44}"/>
               </a:ext>
             </a:extLst>
           </p:cNvPr>
@@ -1439,7 +1439,7 @@
           <p:cNvPr id="2" name="Body">
             <a:extLst xmlns:a="http://schemas.openxmlformats.org/drawingml/2006/main">
               <a:ext uri="{FF2B5EF4-FFF2-40B4-BE49-F238E27FC236}">
-                <a16:creationId xmlns:a16="http://schemas.microsoft.com/office/drawing/2014/main" id="{2E4E7E5E-1A2C-42E0-93CF-71AEC85BCC1B}"/>
+                <a16:creationId xmlns:a16="http://schemas.microsoft.com/office/drawing/2014/main" id="{FC452112-BDC6-47DD-9B0E-F20F3C12DCD0}"/>
               </a:ext>
             </a:extLst>
           </p:cNvPr>
@@ -1685,7 +1685,7 @@
           <p:cNvPr id="4" name="Title">
             <a:extLst xmlns:a="http://schemas.openxmlformats.org/drawingml/2006/main">
               <a:ext uri="{FF2B5EF4-FFF2-40B4-BE49-F238E27FC236}">
-                <a16:creationId xmlns:a16="http://schemas.microsoft.com/office/drawing/2014/main" id="{5D5D812A-FDAF-4B24-9C9D-FB29B3C0FB07}"/>
+                <a16:creationId xmlns:a16="http://schemas.microsoft.com/office/drawing/2014/main" id="{DE7D7297-F64C-4758-B596-BED90235E8BC}"/>
               </a:ext>
             </a:extLst>
           </p:cNvPr>
@@ -1914,7 +1914,7 @@
           <p:cNvPr id="2" name="Left column">
             <a:extLst xmlns:a="http://schemas.openxmlformats.org/drawingml/2006/main">
               <a:ext uri="{FF2B5EF4-FFF2-40B4-BE49-F238E27FC236}">
-                <a16:creationId xmlns:a16="http://schemas.microsoft.com/office/drawing/2014/main" id="{F5D9849A-6575-4645-8D61-27673A9280F3}"/>
+                <a16:creationId xmlns:a16="http://schemas.microsoft.com/office/drawing/2014/main" id="{4F2C80AE-DFF1-4F27-9F1B-EC6749770F90}"/>
               </a:ext>
             </a:extLst>
           </p:cNvPr>
@@ -2143,7 +2143,7 @@
           <p:cNvPr id="3" name="Right column">
             <a:extLst xmlns:a="http://schemas.openxmlformats.org/drawingml/2006/main">
               <a:ext uri="{FF2B5EF4-FFF2-40B4-BE49-F238E27FC236}">
-                <a16:creationId xmlns:a16="http://schemas.microsoft.com/office/drawing/2014/main" id="{5CFD4B5D-6546-4CF6-8A2B-7B1C789071A2}"/>
+                <a16:creationId xmlns:a16="http://schemas.microsoft.com/office/drawing/2014/main" id="{AD4B81D9-AF12-44CA-9E56-164D7F24E64B}"/>
               </a:ext>
             </a:extLst>
           </p:cNvPr>
@@ -2389,7 +2389,7 @@
           <p:cNvPr id="3" name="Title">
             <a:extLst xmlns:a="http://schemas.openxmlformats.org/drawingml/2006/main">
               <a:ext uri="{FF2B5EF4-FFF2-40B4-BE49-F238E27FC236}">
-                <a16:creationId xmlns:a16="http://schemas.microsoft.com/office/drawing/2014/main" id="{5497BE03-BD2D-4F5F-8AA9-2FBA4F1FEDA7}"/>
+                <a16:creationId xmlns:a16="http://schemas.microsoft.com/office/drawing/2014/main" id="{ACB77181-AB22-4E4B-B333-D0272E4A1C6F}"/>
               </a:ext>
             </a:extLst>
           </p:cNvPr>
@@ -2618,7 +2618,7 @@
           <p:cNvPr id="2" name="Left column">
             <a:extLst xmlns:a="http://schemas.openxmlformats.org/drawingml/2006/main">
               <a:ext uri="{FF2B5EF4-FFF2-40B4-BE49-F238E27FC236}">
-                <a16:creationId xmlns:a16="http://schemas.microsoft.com/office/drawing/2014/main" id="{A2718882-54BE-4AE2-BBCF-118386EB170C}"/>
+                <a16:creationId xmlns:a16="http://schemas.microsoft.com/office/drawing/2014/main" id="{2DE6CFAD-8C85-43A2-968E-62AAB1A15F7E}"/>
               </a:ext>
             </a:extLst>
           </p:cNvPr>
@@ -2885,12 +2885,12 @@
   </p:cSld>
   <p:clrMap bg1="lt1" tx1="dk1" bg2="lt2" tx2="dk2" accent1="accent1" accent2="accent2" accent3="accent3" accent4="accent4" accent5="accent5" accent6="accent6" hlink="hlink" folHlink="folHlink"/>
   <p:sldLayoutIdLst>
-    <p:sldLayoutId xmlns:r="http://schemas.openxmlformats.org/officeDocument/2006/relationships" id="2147483649" r:id="R13ad1610903c456d"/>
-    <p:sldLayoutId xmlns:r="http://schemas.openxmlformats.org/officeDocument/2006/relationships" id="2147483650" r:id="Raa47b83c4b44442f"/>
-    <p:sldLayoutId xmlns:r="http://schemas.openxmlformats.org/officeDocument/2006/relationships" id="2147483651" r:id="Rd864ad15c57047f7"/>
-    <p:sldLayoutId xmlns:r="http://schemas.openxmlformats.org/officeDocument/2006/relationships" id="2147483652" r:id="R9d61913635c24bf8"/>
-    <p:sldLayoutId xmlns:r="http://schemas.openxmlformats.org/officeDocument/2006/relationships" id="2147483653" r:id="Rd70f9866964b4fb1"/>
-    <p:sldLayoutId xmlns:r="http://schemas.openxmlformats.org/officeDocument/2006/relationships" id="2147483654" r:id="R5547191a3a99437b"/>
+    <p:sldLayoutId xmlns:r="http://schemas.openxmlformats.org/officeDocument/2006/relationships" id="2147483649" r:id="R1f60f0ded9034f6b"/>
+    <p:sldLayoutId xmlns:r="http://schemas.openxmlformats.org/officeDocument/2006/relationships" id="2147483650" r:id="Rb54d3af20ef84be9"/>
+    <p:sldLayoutId xmlns:r="http://schemas.openxmlformats.org/officeDocument/2006/relationships" id="2147483651" r:id="R05087f3bbfb347a5"/>
+    <p:sldLayoutId xmlns:r="http://schemas.openxmlformats.org/officeDocument/2006/relationships" id="2147483652" r:id="Ra9f3dc87f8584bb7"/>
+    <p:sldLayoutId xmlns:r="http://schemas.openxmlformats.org/officeDocument/2006/relationships" id="2147483653" r:id="Rc9f11f8eca024695"/>
+    <p:sldLayoutId xmlns:r="http://schemas.openxmlformats.org/officeDocument/2006/relationships" id="2147483654" r:id="Rf5144ccf0c2f4f2a"/>
   </p:sldLayoutIdLst>
   <p:txStyles>
     <p:titleStyle>
@@ -3441,7 +3441,7 @@
           <p:cNvPr id="76" name="">
             <a:extLst xmlns:a="http://schemas.openxmlformats.org/drawingml/2006/main">
               <a:ext uri="{FF2B5EF4-FFF2-40B4-BE49-F238E27FC236}">
-                <a16:creationId xmlns:a16="http://schemas.microsoft.com/office/drawing/2014/main" id="{E588A753-C5A7-4FB4-92AF-E8386BB8A7B6}"/>
+                <a16:creationId xmlns:a16="http://schemas.microsoft.com/office/drawing/2014/main" id="{7DDBC1E5-11EC-4264-86F0-4D73BE6C60EE}"/>
               </a:ext>
             </a:extLst>
           </p:cNvPr>
@@ -3472,7 +3472,7 @@
           <p:cNvPr id="2" name="한국어 질의로 영어 학술·기술 문서를 검색하는">
             <a:extLst xmlns:a="http://schemas.openxmlformats.org/drawingml/2006/main">
               <a:ext uri="{FF2B5EF4-FFF2-40B4-BE49-F238E27FC236}">
-                <a16:creationId xmlns:a16="http://schemas.microsoft.com/office/drawing/2014/main" id="{98D35406-EEF0-4CD4-9D0D-F9C774496311}"/>
+                <a16:creationId xmlns:a16="http://schemas.microsoft.com/office/drawing/2014/main" id="{2CF6C21B-E085-4FBC-8B30-21AF6DC6BE00}"/>
               </a:ext>
             </a:extLst>
           </p:cNvPr>
@@ -3630,7 +3630,7 @@
           <p:cNvPr id="3" name="RAG에서의 HyDE·CAD·SCD 조합 실험">
             <a:extLst xmlns:a="http://schemas.openxmlformats.org/drawingml/2006/main">
               <a:ext uri="{FF2B5EF4-FFF2-40B4-BE49-F238E27FC236}">
-                <a16:creationId xmlns:a16="http://schemas.microsoft.com/office/drawing/2014/main" id="{E408D2E7-5DC9-4E7B-A58D-61B1A75077A7}"/>
+                <a16:creationId xmlns:a16="http://schemas.microsoft.com/office/drawing/2014/main" id="{8BBF0810-01B4-4D75-8ACB-8A99638F984C}"/>
               </a:ext>
             </a:extLst>
           </p:cNvPr>
@@ -3788,7 +3788,7 @@
           <p:cNvPr id="4" name="문종건 · 동국대학교 WISE캠퍼스 컴퓨터공학과 · 지도교수 김진석 · 2026.10.15">
             <a:extLst xmlns:a="http://schemas.openxmlformats.org/drawingml/2006/main">
               <a:ext uri="{FF2B5EF4-FFF2-40B4-BE49-F238E27FC236}">
-                <a16:creationId xmlns:a16="http://schemas.microsoft.com/office/drawing/2014/main" id="{33A74FED-624E-49DA-A8CD-D4E3025E1FAF}"/>
+                <a16:creationId xmlns:a16="http://schemas.microsoft.com/office/drawing/2014/main" id="{2313F6F6-C728-497B-889B-8CE8987F9CBC}"/>
               </a:ext>
             </a:extLst>
           </p:cNvPr>
@@ -3946,7 +3946,7 @@
           <p:cNvPr id="5" name="">
             <a:extLst xmlns:a="http://schemas.openxmlformats.org/drawingml/2006/main">
               <a:ext uri="{FF2B5EF4-FFF2-40B4-BE49-F238E27FC236}">
-                <a16:creationId xmlns:a16="http://schemas.microsoft.com/office/drawing/2014/main" id="{9D4DF89C-E278-440C-8963-49FB8E9EBD60}"/>
+                <a16:creationId xmlns:a16="http://schemas.microsoft.com/office/drawing/2014/main" id="{F23FD162-E6FE-45F4-A9CB-5EDCAE044FE1}"/>
               </a:ext>
             </a:extLst>
           </p:cNvPr>
@@ -3977,7 +3977,7 @@
           <p:cNvPr id="6" name="01 연구 배경과 목적">
             <a:extLst xmlns:a="http://schemas.openxmlformats.org/drawingml/2006/main">
               <a:ext uri="{FF2B5EF4-FFF2-40B4-BE49-F238E27FC236}">
-                <a16:creationId xmlns:a16="http://schemas.microsoft.com/office/drawing/2014/main" id="{BFF15FD1-5AE2-4B54-8FCD-DA7CD889F507}"/>
+                <a16:creationId xmlns:a16="http://schemas.microsoft.com/office/drawing/2014/main" id="{C2CAA2EF-A643-4DC9-8684-E5B981AAE592}"/>
               </a:ext>
             </a:extLst>
           </p:cNvPr>
@@ -4135,7 +4135,7 @@
           <p:cNvPr id="7" name="검색 증강 생성(Retrieval-Augmented Generation, RAG)은 관련 문서 구간을 검색하고 그 텍">
             <a:extLst xmlns:a="http://schemas.openxmlformats.org/drawingml/2006/main">
               <a:ext uri="{FF2B5EF4-FFF2-40B4-BE49-F238E27FC236}">
-                <a16:creationId xmlns:a16="http://schemas.microsoft.com/office/drawing/2014/main" id="{A7CB3FE7-97E8-4D81-8342-D368E706BD61}"/>
+                <a16:creationId xmlns:a16="http://schemas.microsoft.com/office/drawing/2014/main" id="{5F147FA8-2BDD-4566-AB38-91B67205580D}"/>
               </a:ext>
             </a:extLst>
           </p:cNvPr>
@@ -4316,7 +4316,7 @@
           <p:cNvPr id="8" name="HyDE: 가상 문서 임베딩(Hypothetical Document Embeddings) 가상 문서 검색 입력 구성[">
             <a:extLst xmlns:a="http://schemas.openxmlformats.org/drawingml/2006/main">
               <a:ext uri="{FF2B5EF4-FFF2-40B4-BE49-F238E27FC236}">
-                <a16:creationId xmlns:a16="http://schemas.microsoft.com/office/drawing/2014/main" id="{EC806C2C-1E27-4650-85F5-021605D0D260}"/>
+                <a16:creationId xmlns:a16="http://schemas.microsoft.com/office/drawing/2014/main" id="{A45F7719-E4B1-4D0E-9E1B-C09BE6212C7E}"/>
               </a:ext>
             </a:extLst>
           </p:cNvPr>
@@ -4586,10 +4586,10 @@
       </p:sp>
       <p:sp>
         <p:nvSpPr>
-          <p:cNvPr id="9" name="HyDE는 한국어를 포함한 다국어 검색에서 평가되었다[2]. 한국어 질의–영어 문서 환경에서 HyDE·CAD·SCD의">
+          <p:cNvPr id="9" name="한국어 질의–영어 문서 RAG는 검색 어휘 차이, 근거 반영, 영어 출력(언어 이탈)의 문제를 함께 겪는다. 세 기법">
             <a:extLst xmlns:a="http://schemas.openxmlformats.org/drawingml/2006/main">
               <a:ext uri="{FF2B5EF4-FFF2-40B4-BE49-F238E27FC236}">
-                <a16:creationId xmlns:a16="http://schemas.microsoft.com/office/drawing/2014/main" id="{702D493F-86F8-410D-8E8B-CB765BC158AE}"/>
+                <a16:creationId xmlns:a16="http://schemas.microsoft.com/office/drawing/2014/main" id="{EB97F40D-DBF6-42FC-9C01-A4BCF26C2E96}"/>
               </a:ext>
             </a:extLst>
           </p:cNvPr>
@@ -4737,7 +4737,7 @@
                 <a:ea typeface="Malgun Gothic"/>
                 <a:cs typeface="Malgun Gothic"/>
               </a:rPr>
-              <a:t>HyDE는 한국어를 포함한 다국어 검색에서 평가되었다[2].</a:t>
+              <a:t>한국어 질의–영어 문서 RAG는 검색 어휘 차이, 근거 반영,</a:t>
             </a:r>
           </a:p>
           <a:p xmlns:a="http://schemas.openxmlformats.org/drawingml/2006/main">
@@ -4760,7 +4760,7 @@
                 <a:ea typeface="Malgun Gothic"/>
                 <a:cs typeface="Malgun Gothic"/>
               </a:rPr>
-              <a:t>한국어 질의–영어 문서 환경에서 HyDE·CAD·SCD의</a:t>
+              <a:t>영어 출력(언어 이탈)의 문제를 함께 겪는다. 세 기법의</a:t>
             </a:r>
           </a:p>
           <a:p xmlns:a="http://schemas.openxmlformats.org/drawingml/2006/main">
@@ -4783,7 +4783,7 @@
                 <a:ea typeface="Malgun Gothic"/>
                 <a:cs typeface="Malgun Gothic"/>
               </a:rPr>
-              <a:t>개별 차이와 조합 효과를 같은 파이프라인에서 비교하였다.</a:t>
+              <a:t>단독 효과와 조합 효과를 같은 파이프라인에서 비교하였다.</a:t>
             </a:r>
           </a:p>
         </p:txBody>
@@ -4793,7 +4793,7 @@
           <p:cNvPr id="10" name="">
             <a:extLst xmlns:a="http://schemas.openxmlformats.org/drawingml/2006/main">
               <a:ext uri="{FF2B5EF4-FFF2-40B4-BE49-F238E27FC236}">
-                <a16:creationId xmlns:a16="http://schemas.microsoft.com/office/drawing/2014/main" id="{7DAAC475-77ED-4736-800A-8861726B01CE}"/>
+                <a16:creationId xmlns:a16="http://schemas.microsoft.com/office/drawing/2014/main" id="{A2CDC6DC-5954-4C46-A4EE-365ED29BE15E}"/>
               </a:ext>
             </a:extLst>
           </p:cNvPr>
@@ -4824,7 +4824,7 @@
           <p:cNvPr id="11" name="02 Paper-RAG 구조와 기법 적용 위치">
             <a:extLst xmlns:a="http://schemas.openxmlformats.org/drawingml/2006/main">
               <a:ext uri="{FF2B5EF4-FFF2-40B4-BE49-F238E27FC236}">
-                <a16:creationId xmlns:a16="http://schemas.microsoft.com/office/drawing/2014/main" id="{E3BD0098-3652-4F43-8EA0-33F0BD15F5AB}"/>
+                <a16:creationId xmlns:a16="http://schemas.microsoft.com/office/drawing/2014/main" id="{62C38AF6-1253-4D6A-AC7B-1307FF33F75D}"/>
               </a:ext>
             </a:extLst>
           </p:cNvPr>
@@ -4982,7 +4982,7 @@
           <p:cNvPr id="12" name="Paper-RAG는 실험에 사용한 고정 검색·생성 파이프라인이다.">
             <a:extLst xmlns:a="http://schemas.openxmlformats.org/drawingml/2006/main">
               <a:ext uri="{FF2B5EF4-FFF2-40B4-BE49-F238E27FC236}">
-                <a16:creationId xmlns:a16="http://schemas.microsoft.com/office/drawing/2014/main" id="{65790FA7-706C-4CCD-9B50-B6AFFD43CEBA}"/>
+                <a16:creationId xmlns:a16="http://schemas.microsoft.com/office/drawing/2014/main" id="{2946413C-2FBF-44EE-B3D8-2DA83DE7EE62}"/>
               </a:ext>
             </a:extLst>
           </p:cNvPr>
@@ -5140,7 +5140,7 @@
           <p:cNvPr id="13" name="">
             <a:extLst xmlns:a="http://schemas.openxmlformats.org/drawingml/2006/main">
               <a:ext uri="{FF2B5EF4-FFF2-40B4-BE49-F238E27FC236}">
-                <a16:creationId xmlns:a16="http://schemas.microsoft.com/office/drawing/2014/main" id="{493D2AE8-1B79-4888-8F4C-99CAD857174F}"/>
+                <a16:creationId xmlns:a16="http://schemas.microsoft.com/office/drawing/2014/main" id="{19B9C244-15B9-4843-9945-97BDAA6CF0C1}"/>
               </a:ext>
             </a:extLst>
           </p:cNvPr>
@@ -5173,7 +5173,7 @@
           <p:cNvPr id="14" name="한국어 질의 HyDE OFF: 원질의 HyDE ON: 영어 번역·가상 문서">
             <a:extLst xmlns:a="http://schemas.openxmlformats.org/drawingml/2006/main">
               <a:ext uri="{FF2B5EF4-FFF2-40B4-BE49-F238E27FC236}">
-                <a16:creationId xmlns:a16="http://schemas.microsoft.com/office/drawing/2014/main" id="{3654D477-6733-454A-B7F7-C181647B48FD}"/>
+                <a16:creationId xmlns:a16="http://schemas.microsoft.com/office/drawing/2014/main" id="{F622BCE3-CDE8-40A1-AC25-2AEC832302E1}"/>
               </a:ext>
             </a:extLst>
           </p:cNvPr>
@@ -5377,7 +5377,7 @@
           <p:cNvPr id="15" name="">
             <a:extLst xmlns:a="http://schemas.openxmlformats.org/drawingml/2006/main">
               <a:ext uri="{FF2B5EF4-FFF2-40B4-BE49-F238E27FC236}">
-                <a16:creationId xmlns:a16="http://schemas.microsoft.com/office/drawing/2014/main" id="{227747A0-E20C-4769-9D02-CF7A7DBCAA70}"/>
+                <a16:creationId xmlns:a16="http://schemas.microsoft.com/office/drawing/2014/main" id="{053DFD87-1233-4A3F-9594-BEC167988E3F}"/>
               </a:ext>
             </a:extLst>
           </p:cNvPr>
@@ -5410,7 +5410,7 @@
           <p:cNvPr id="16" name="BM25 희소 검색[6] 한국어 원질의 사용">
             <a:extLst xmlns:a="http://schemas.openxmlformats.org/drawingml/2006/main">
               <a:ext uri="{FF2B5EF4-FFF2-40B4-BE49-F238E27FC236}">
-                <a16:creationId xmlns:a16="http://schemas.microsoft.com/office/drawing/2014/main" id="{ACDFC118-C032-478F-AD46-18EC7D77D91C}"/>
+                <a16:creationId xmlns:a16="http://schemas.microsoft.com/office/drawing/2014/main" id="{ABBB11B8-CF77-48B6-96FF-90880EBACDA9}"/>
               </a:ext>
             </a:extLst>
           </p:cNvPr>
@@ -5591,7 +5591,7 @@
           <p:cNvPr id="17" name="">
             <a:extLst xmlns:a="http://schemas.openxmlformats.org/drawingml/2006/main">
               <a:ext uri="{FF2B5EF4-FFF2-40B4-BE49-F238E27FC236}">
-                <a16:creationId xmlns:a16="http://schemas.microsoft.com/office/drawing/2014/main" id="{C774C2BD-B9B7-49EF-88CB-B5F38ED7BCA4}"/>
+                <a16:creationId xmlns:a16="http://schemas.microsoft.com/office/drawing/2014/main" id="{0BFDC7CE-CCBF-4F05-B39D-4A43C8FF08CB}"/>
               </a:ext>
             </a:extLst>
           </p:cNvPr>
@@ -5624,7 +5624,7 @@
           <p:cNvPr id="18" name="BGE-M3 밀집 검색[5]">
             <a:extLst xmlns:a="http://schemas.openxmlformats.org/drawingml/2006/main">
               <a:ext uri="{FF2B5EF4-FFF2-40B4-BE49-F238E27FC236}">
-                <a16:creationId xmlns:a16="http://schemas.microsoft.com/office/drawing/2014/main" id="{19EE5B8B-6472-465C-BD69-6E4EF3AF93A5}"/>
+                <a16:creationId xmlns:a16="http://schemas.microsoft.com/office/drawing/2014/main" id="{BC311CD6-D28F-4F1D-908C-16A33A7E1928}"/>
               </a:ext>
             </a:extLst>
           </p:cNvPr>
@@ -5782,7 +5782,7 @@
           <p:cNvPr id="19" name="">
             <a:extLst xmlns:a="http://schemas.openxmlformats.org/drawingml/2006/main">
               <a:ext uri="{FF2B5EF4-FFF2-40B4-BE49-F238E27FC236}">
-                <a16:creationId xmlns:a16="http://schemas.microsoft.com/office/drawing/2014/main" id="{3FD039B9-CFAE-4DBA-AC09-EA5D171D50C3}"/>
+                <a16:creationId xmlns:a16="http://schemas.microsoft.com/office/drawing/2014/main" id="{C7223DBD-C1D5-463B-8F95-07D5239E345B}"/>
               </a:ext>
             </a:extLst>
           </p:cNvPr>
@@ -5815,7 +5815,7 @@
           <p:cNvPr id="20" name="가중 RRF[7] 0.6 / 0.4, k=60">
             <a:extLst xmlns:a="http://schemas.openxmlformats.org/drawingml/2006/main">
               <a:ext uri="{FF2B5EF4-FFF2-40B4-BE49-F238E27FC236}">
-                <a16:creationId xmlns:a16="http://schemas.microsoft.com/office/drawing/2014/main" id="{F99617E2-4428-4175-A3F3-E0A3B2F9CDC9}"/>
+                <a16:creationId xmlns:a16="http://schemas.microsoft.com/office/drawing/2014/main" id="{42E02A47-9235-410F-BC20-EBE6725FA5C7}"/>
               </a:ext>
             </a:extLst>
           </p:cNvPr>
@@ -5996,7 +5996,7 @@
           <p:cNvPr id="21" name="">
             <a:extLst xmlns:a="http://schemas.openxmlformats.org/drawingml/2006/main">
               <a:ext uri="{FF2B5EF4-FFF2-40B4-BE49-F238E27FC236}">
-                <a16:creationId xmlns:a16="http://schemas.microsoft.com/office/drawing/2014/main" id="{F2B7DFCE-5098-4056-B08C-A24DCDFCF6F6}"/>
+                <a16:creationId xmlns:a16="http://schemas.microsoft.com/office/drawing/2014/main" id="{8B8EBC5E-9FCC-476F-8D0A-DD4335116A84}"/>
               </a:ext>
             </a:extLst>
           </p:cNvPr>
@@ -6028,7 +6028,7 @@
           <p:cNvPr id="22" name="">
             <a:extLst xmlns:a="http://schemas.openxmlformats.org/drawingml/2006/main">
               <a:ext uri="{FF2B5EF4-FFF2-40B4-BE49-F238E27FC236}">
-                <a16:creationId xmlns:a16="http://schemas.microsoft.com/office/drawing/2014/main" id="{72BA4699-CED3-4379-81D6-5C05350B7BA8}"/>
+                <a16:creationId xmlns:a16="http://schemas.microsoft.com/office/drawing/2014/main" id="{3FD3FE97-E9E5-4DFD-8317-2CE1D8FFF96F}"/>
               </a:ext>
             </a:extLst>
           </p:cNvPr>
@@ -6060,7 +6060,7 @@
           <p:cNvPr id="23" name="">
             <a:extLst xmlns:a="http://schemas.openxmlformats.org/drawingml/2006/main">
               <a:ext uri="{FF2B5EF4-FFF2-40B4-BE49-F238E27FC236}">
-                <a16:creationId xmlns:a16="http://schemas.microsoft.com/office/drawing/2014/main" id="{84232A8F-9529-4010-8844-E0F6C238C2C8}"/>
+                <a16:creationId xmlns:a16="http://schemas.microsoft.com/office/drawing/2014/main" id="{FD7C67A9-3A28-4A2D-981B-70A9497B5CE3}"/>
               </a:ext>
             </a:extLst>
           </p:cNvPr>
@@ -6092,7 +6092,7 @@
           <p:cNvPr id="24" name="">
             <a:extLst xmlns:a="http://schemas.openxmlformats.org/drawingml/2006/main">
               <a:ext uri="{FF2B5EF4-FFF2-40B4-BE49-F238E27FC236}">
-                <a16:creationId xmlns:a16="http://schemas.microsoft.com/office/drawing/2014/main" id="{78048D26-F3E7-42D7-A017-56D562298958}"/>
+                <a16:creationId xmlns:a16="http://schemas.microsoft.com/office/drawing/2014/main" id="{A036E9F2-9F1D-4611-BFC3-41DE23A07634}"/>
               </a:ext>
             </a:extLst>
           </p:cNvPr>
@@ -6125,7 +6125,7 @@
           <p:cNvPr id="25" name="원질의·구간 쌍 CrossEncoder 재정렬[8][M2] 상위 5개 구간 선택·입력 길이 관리">
             <a:extLst xmlns:a="http://schemas.openxmlformats.org/drawingml/2006/main">
               <a:ext uri="{FF2B5EF4-FFF2-40B4-BE49-F238E27FC236}">
-                <a16:creationId xmlns:a16="http://schemas.microsoft.com/office/drawing/2014/main" id="{8EA43AF2-B64A-4825-9209-54524E873BC6}"/>
+                <a16:creationId xmlns:a16="http://schemas.microsoft.com/office/drawing/2014/main" id="{A0ED452E-C2A3-4CF9-B091-1CBC6DF62573}"/>
               </a:ext>
             </a:extLst>
           </p:cNvPr>
@@ -6306,7 +6306,7 @@
           <p:cNvPr id="26" name="">
             <a:extLst xmlns:a="http://schemas.openxmlformats.org/drawingml/2006/main">
               <a:ext uri="{FF2B5EF4-FFF2-40B4-BE49-F238E27FC236}">
-                <a16:creationId xmlns:a16="http://schemas.microsoft.com/office/drawing/2014/main" id="{2666C21F-B1C2-495D-99E4-DEE4712767ED}"/>
+                <a16:creationId xmlns:a16="http://schemas.microsoft.com/office/drawing/2014/main" id="{052BDE01-5338-4F1D-9563-CC39949503D2}"/>
               </a:ext>
             </a:extLst>
           </p:cNvPr>
@@ -6339,7 +6339,7 @@
           <p:cNvPr id="27" name="Mi:dm 2.0 Base Instruct[M1] CAD 로짓 결합 후 SCD 언어별 조정, 최종 답변 생성">
             <a:extLst xmlns:a="http://schemas.openxmlformats.org/drawingml/2006/main">
               <a:ext uri="{FF2B5EF4-FFF2-40B4-BE49-F238E27FC236}">
-                <a16:creationId xmlns:a16="http://schemas.microsoft.com/office/drawing/2014/main" id="{D2C6A544-5047-4101-9718-9B4665AB6650}"/>
+                <a16:creationId xmlns:a16="http://schemas.microsoft.com/office/drawing/2014/main" id="{BA8A9FC7-6D6C-41A5-8243-80100D13252E}"/>
               </a:ext>
             </a:extLst>
           </p:cNvPr>
@@ -6520,7 +6520,7 @@
           <p:cNvPr id="28" name="">
             <a:extLst xmlns:a="http://schemas.openxmlformats.org/drawingml/2006/main">
               <a:ext uri="{FF2B5EF4-FFF2-40B4-BE49-F238E27FC236}">
-                <a16:creationId xmlns:a16="http://schemas.microsoft.com/office/drawing/2014/main" id="{49AA8C1C-2718-487D-AEAC-C0F7205B48E6}"/>
+                <a16:creationId xmlns:a16="http://schemas.microsoft.com/office/drawing/2014/main" id="{14354F1F-4B89-4781-AC78-F19B65F36CB0}"/>
               </a:ext>
             </a:extLst>
           </p:cNvPr>
@@ -6552,7 +6552,7 @@
           <p:cNvPr id="29" name="">
             <a:extLst xmlns:a="http://schemas.openxmlformats.org/drawingml/2006/main">
               <a:ext uri="{FF2B5EF4-FFF2-40B4-BE49-F238E27FC236}">
-                <a16:creationId xmlns:a16="http://schemas.microsoft.com/office/drawing/2014/main" id="{5FE2221B-1614-44C7-A556-F8899D09CE55}"/>
+                <a16:creationId xmlns:a16="http://schemas.microsoft.com/office/drawing/2014/main" id="{7AC54586-7A9D-4D76-909D-1212D2BBC287}"/>
               </a:ext>
             </a:extLst>
           </p:cNvPr>
@@ -6584,7 +6584,7 @@
           <p:cNvPr id="30" name="">
             <a:extLst xmlns:a="http://schemas.openxmlformats.org/drawingml/2006/main">
               <a:ext uri="{FF2B5EF4-FFF2-40B4-BE49-F238E27FC236}">
-                <a16:creationId xmlns:a16="http://schemas.microsoft.com/office/drawing/2014/main" id="{8FF530EC-E47E-4AA1-BCA2-8125DD7D15C8}"/>
+                <a16:creationId xmlns:a16="http://schemas.microsoft.com/office/drawing/2014/main" id="{72222C0E-2B02-44C9-B807-5B6BE468252C}"/>
               </a:ext>
             </a:extLst>
           </p:cNvPr>
@@ -6615,7 +6615,7 @@
           <p:cNvPr id="31" name="03 3요인 완전요인 실험 설계">
             <a:extLst xmlns:a="http://schemas.openxmlformats.org/drawingml/2006/main">
               <a:ext uri="{FF2B5EF4-FFF2-40B4-BE49-F238E27FC236}">
-                <a16:creationId xmlns:a16="http://schemas.microsoft.com/office/drawing/2014/main" id="{A69E3D3F-0F58-40D0-9834-C475E82D57E2}"/>
+                <a16:creationId xmlns:a16="http://schemas.microsoft.com/office/drawing/2014/main" id="{94AE48EC-342C-4BA7-ADDB-A47541147896}"/>
               </a:ext>
             </a:extLst>
           </p:cNvPr>
@@ -6773,7 +6773,7 @@
           <p:cNvPr id="32" name="H=HyDE, C=CAD, S=SCD   0=미적용, 1=적용">
             <a:extLst xmlns:a="http://schemas.openxmlformats.org/drawingml/2006/main">
               <a:ext uri="{FF2B5EF4-FFF2-40B4-BE49-F238E27FC236}">
-                <a16:creationId xmlns:a16="http://schemas.microsoft.com/office/drawing/2014/main" id="{71871DC1-BCB9-401D-9EAE-4465591893B3}"/>
+                <a16:creationId xmlns:a16="http://schemas.microsoft.com/office/drawing/2014/main" id="{5EC852D3-B192-4764-9CA6-BEAA9E8068E9}"/>
               </a:ext>
             </a:extLst>
           </p:cNvPr>
@@ -6931,7 +6931,7 @@
           <p:cNvPr id="33" name="">
             <a:extLst xmlns:a="http://schemas.openxmlformats.org/drawingml/2006/main">
               <a:ext uri="{FF2B5EF4-FFF2-40B4-BE49-F238E27FC236}">
-                <a16:creationId xmlns:a16="http://schemas.microsoft.com/office/drawing/2014/main" id="{8AD321E6-9B75-47AF-AF04-C2D002046E83}"/>
+                <a16:creationId xmlns:a16="http://schemas.microsoft.com/office/drawing/2014/main" id="{4A773E95-A37F-41D7-8DDC-AB5530DE49B7}"/>
               </a:ext>
             </a:extLst>
           </p:cNvPr>
@@ -8461,7 +8461,7 @@
           <p:cNvPr id="34" name="같은 질의 60개 × 8조건 반복측정 = 480개 생성 기록">
             <a:extLst xmlns:a="http://schemas.openxmlformats.org/drawingml/2006/main">
               <a:ext uri="{FF2B5EF4-FFF2-40B4-BE49-F238E27FC236}">
-                <a16:creationId xmlns:a16="http://schemas.microsoft.com/office/drawing/2014/main" id="{116B4C4D-F43E-4030-BF53-304C1D03D96D}"/>
+                <a16:creationId xmlns:a16="http://schemas.microsoft.com/office/drawing/2014/main" id="{D4F54AAC-AA7C-4AA8-B9B5-055A817CF194}"/>
               </a:ext>
             </a:extLst>
           </p:cNvPr>
@@ -8619,7 +8619,7 @@
           <p:cNvPr id="35" name="생성 512토큰, CAD α=0.5, SCD α=1.1·β=0.9·Tstart=5">
             <a:extLst xmlns:a="http://schemas.openxmlformats.org/drawingml/2006/main">
               <a:ext uri="{FF2B5EF4-FFF2-40B4-BE49-F238E27FC236}">
-                <a16:creationId xmlns:a16="http://schemas.microsoft.com/office/drawing/2014/main" id="{31036749-CA9D-41BB-8831-0CDC2316E009}"/>
+                <a16:creationId xmlns:a16="http://schemas.microsoft.com/office/drawing/2014/main" id="{1F4A2435-F7C6-40F0-A5A3-6EC49D072E29}"/>
               </a:ext>
             </a:extLst>
           </p:cNvPr>
@@ -8774,10 +8774,10 @@
       </p:sp>
       <p:sp>
         <p:nvSpPr>
-          <p:cNvPr id="36" name="문서 요약을 15개 내용 단위로 나누어 질의를 작성하고, 총 60개 질의의 원문 페이지·정답 근거·답변 가능성을 확인">
+          <p:cNvPr id="36" name="문서마다 주요 내용을 15개 단위로 요약해 단위별 질의를 작성하고, 총 60개 질의의 원문 페이지·정답 근거·답변 가">
             <a:extLst xmlns:a="http://schemas.openxmlformats.org/drawingml/2006/main">
               <a:ext uri="{FF2B5EF4-FFF2-40B4-BE49-F238E27FC236}">
-                <a16:creationId xmlns:a16="http://schemas.microsoft.com/office/drawing/2014/main" id="{E2A9BD50-6725-4102-A775-2019F889C72F}"/>
+                <a16:creationId xmlns:a16="http://schemas.microsoft.com/office/drawing/2014/main" id="{C4F2748D-DCA3-4DAC-9007-CEEB1963C77A}"/>
               </a:ext>
             </a:extLst>
           </p:cNvPr>
@@ -8925,7 +8925,7 @@
                 <a:ea typeface="Malgun Gothic"/>
                 <a:cs typeface="Malgun Gothic"/>
               </a:rPr>
-              <a:t>문서 요약을 15개 내용 단위로 나누어 질의를 작성하고,</a:t>
+              <a:t>문서마다 주요 내용을 15개 단위로 요약해 단위별 질의를 작성하고,</a:t>
             </a:r>
           </a:p>
           <a:p xmlns:a="http://schemas.openxmlformats.org/drawingml/2006/main">
@@ -8958,7 +8958,7 @@
           <p:cNvPr id="37" name="">
             <a:extLst xmlns:a="http://schemas.openxmlformats.org/drawingml/2006/main">
               <a:ext uri="{FF2B5EF4-FFF2-40B4-BE49-F238E27FC236}">
-                <a16:creationId xmlns:a16="http://schemas.microsoft.com/office/drawing/2014/main" id="{C0303BCD-161F-4E51-9E8E-2C63C2D4017A}"/>
+                <a16:creationId xmlns:a16="http://schemas.microsoft.com/office/drawing/2014/main" id="{260B7A32-207C-4841-ABD0-2E7D29AE0DCF}"/>
               </a:ext>
             </a:extLst>
           </p:cNvPr>
@@ -8989,7 +8989,7 @@
           <p:cNvPr id="38" name="04 평가 지표 및 실험·통계 방법">
             <a:extLst xmlns:a="http://schemas.openxmlformats.org/drawingml/2006/main">
               <a:ext uri="{FF2B5EF4-FFF2-40B4-BE49-F238E27FC236}">
-                <a16:creationId xmlns:a16="http://schemas.microsoft.com/office/drawing/2014/main" id="{E4C8F15C-80C5-4B90-9D18-F64AD1EDAA8C}"/>
+                <a16:creationId xmlns:a16="http://schemas.microsoft.com/office/drawing/2014/main" id="{1BEFB309-50C9-4879-B124-470919C6FDAC}"/>
               </a:ext>
             </a:extLst>
           </p:cNvPr>
@@ -9144,10 +9144,10 @@
       </p:sp>
       <p:sp>
         <p:nvSpPr>
-          <p:cNvPr id="39" name="근거 충실도: 높을수록 검색 근거가 지지하는 답변 주장 비율이 크다. 답변 관련성: 높을수록 답변 기반 질문과 원질문">
+          <p:cNvPr id="39" name="근거 충실도: 높을수록 검색 결과가 뒷받침하는 답변 주장 비율이 크다. 답변 관련성: 높을수록 답변 기반 질문과 원질">
             <a:extLst xmlns:a="http://schemas.openxmlformats.org/drawingml/2006/main">
               <a:ext uri="{FF2B5EF4-FFF2-40B4-BE49-F238E27FC236}">
-                <a16:creationId xmlns:a16="http://schemas.microsoft.com/office/drawing/2014/main" id="{34D4FEBF-3FAE-466A-90E0-F2D762690C7E}"/>
+                <a16:creationId xmlns:a16="http://schemas.microsoft.com/office/drawing/2014/main" id="{E72B5B61-6ED9-4961-9089-E50F16E0BE15}"/>
               </a:ext>
             </a:extLst>
           </p:cNvPr>
@@ -9295,7 +9295,7 @@
                 <a:ea typeface="Malgun Gothic"/>
                 <a:cs typeface="Malgun Gothic"/>
               </a:rPr>
-              <a:t>근거 충실도: 높을수록 검색 근거가 지지하는 답변 주장 비율이 크다.</a:t>
+              <a:t>근거 충실도: 높을수록 검색 결과가 뒷받침하는 답변 주장 비율이 크다.</a:t>
             </a:r>
           </a:p>
           <a:p xmlns:a="http://schemas.openxmlformats.org/drawingml/2006/main">
@@ -9394,10 +9394,10 @@
       </p:sp>
       <p:sp>
         <p:nvSpPr>
-          <p:cNvPr id="40" name="품질 관측값은 0~1이다. 관련성 +0.080은 ON−OFF 평균 차이 0.080점이다. SD는 질의별 분포의 표본표">
+          <p:cNvPr id="40" name="품질 관측값은 0~1이다. 차이는 ON−OFF 평균 차이다. 한국어 비율 0.700은 70.0%, 차이 +0.218은">
             <a:extLst xmlns:a="http://schemas.openxmlformats.org/drawingml/2006/main">
               <a:ext uri="{FF2B5EF4-FFF2-40B4-BE49-F238E27FC236}">
-                <a16:creationId xmlns:a16="http://schemas.microsoft.com/office/drawing/2014/main" id="{88C0CADF-57BA-4362-A5A5-D47FC13ACD39}"/>
+                <a16:creationId xmlns:a16="http://schemas.microsoft.com/office/drawing/2014/main" id="{978329CF-3F40-4C48-AD4D-46276CB81490}"/>
               </a:ext>
             </a:extLst>
           </p:cNvPr>
@@ -9545,30 +9545,7 @@
                 <a:ea typeface="Malgun Gothic"/>
                 <a:cs typeface="Malgun Gothic"/>
               </a:rPr>
-              <a:t>품질 관측값은 0~1이다. 관련성 +0.080은 ON−OFF 평균 차이</a:t>
-            </a:r>
-          </a:p>
-          <a:p xmlns:a="http://schemas.openxmlformats.org/drawingml/2006/main">
-            <a:pPr algn="l">
-              <a:defRPr sz="1800" b="0">
-                <a:solidFill>
-                  <a:srgbClr val="24324A"/>
-                </a:solidFill>
-                <a:latin typeface="Malgun Gothic"/>
-                <a:ea typeface="Malgun Gothic"/>
-                <a:cs typeface="Malgun Gothic"/>
-              </a:defRPr>
-            </a:pPr>
-            <a:r>
-              <a:rPr sz="1800" b="0">
-                <a:solidFill>
-                  <a:srgbClr val="24324A"/>
-                </a:solidFill>
-                <a:latin typeface="Malgun Gothic"/>
-                <a:ea typeface="Malgun Gothic"/>
-                <a:cs typeface="Malgun Gothic"/>
-              </a:rPr>
-              <a:t>0.080점이다. SD는 질의별 분포의 표본표준편차다.</a:t>
+              <a:t>품질 관측값은 0~1이다. 차이는 ON−OFF 평균 차이다.</a:t>
             </a:r>
           </a:p>
           <a:p xmlns:a="http://schemas.openxmlformats.org/drawingml/2006/main">
@@ -9601,7 +9578,7 @@
           <p:cNvPr id="41" name="평가 예시  ext_raptor_011, H0C0S0">
             <a:extLst xmlns:a="http://schemas.openxmlformats.org/drawingml/2006/main">
               <a:ext uri="{FF2B5EF4-FFF2-40B4-BE49-F238E27FC236}">
-                <a16:creationId xmlns:a16="http://schemas.microsoft.com/office/drawing/2014/main" id="{E37F1A37-A672-4B83-AEB7-C8CA70C6E8AC}"/>
+                <a16:creationId xmlns:a16="http://schemas.microsoft.com/office/drawing/2014/main" id="{70F0298E-F1E8-4DE7-8BA6-DA9947DA23FE}"/>
               </a:ext>
             </a:extLst>
           </p:cNvPr>
@@ -9759,7 +9736,7 @@
           <p:cNvPr id="42" name="질문: Cinderella 사례의 정성 분석에서 RAPTOR의 tree-based retrieval이 DPR보다 주제">
             <a:extLst xmlns:a="http://schemas.openxmlformats.org/drawingml/2006/main">
               <a:ext uri="{FF2B5EF4-FFF2-40B4-BE49-F238E27FC236}">
-                <a16:creationId xmlns:a16="http://schemas.microsoft.com/office/drawing/2014/main" id="{DC3499A3-42C3-4F21-A0E8-20049CE17FB6}"/>
+                <a16:creationId xmlns:a16="http://schemas.microsoft.com/office/drawing/2014/main" id="{9BD9AA2A-426D-4049-92BF-EDF6FC27791E}"/>
               </a:ext>
             </a:extLst>
           </p:cNvPr>
@@ -9940,7 +9917,7 @@
           <p:cNvPr id="43" name="검색 근거(PDF p.9): “By providing both the original text and higher-l">
             <a:extLst xmlns:a="http://schemas.openxmlformats.org/drawingml/2006/main">
               <a:ext uri="{FF2B5EF4-FFF2-40B4-BE49-F238E27FC236}">
-                <a16:creationId xmlns:a16="http://schemas.microsoft.com/office/drawing/2014/main" id="{C3ADAF69-E5B3-449E-A7FD-5356507FA591}"/>
+                <a16:creationId xmlns:a16="http://schemas.microsoft.com/office/drawing/2014/main" id="{3CAB2510-DC34-47A4-84ED-982C9A1BE75D}"/>
               </a:ext>
             </a:extLst>
           </p:cNvPr>
@@ -10144,7 +10121,7 @@
           <p:cNvPr id="44" name="참조 답변 요지(PDF p.20): RAPTOR는 이야기의 주요 부분을, DPR은 이야기의 좁은 일부를 자세히 검색한">
             <a:extLst xmlns:a="http://schemas.openxmlformats.org/drawingml/2006/main">
               <a:ext uri="{FF2B5EF4-FFF2-40B4-BE49-F238E27FC236}">
-                <a16:creationId xmlns:a16="http://schemas.microsoft.com/office/drawing/2014/main" id="{9C0E3B67-A5CE-45EC-8464-516C9CBB59C8}"/>
+                <a16:creationId xmlns:a16="http://schemas.microsoft.com/office/drawing/2014/main" id="{0C264AC3-4781-4E1C-B119-BF5365E8F10D}"/>
               </a:ext>
             </a:extLst>
           </p:cNvPr>
@@ -10325,7 +10302,7 @@
           <p:cNvPr id="45" name="생성 답변 발췌: “질문의 요구사항에 따라 서로 다른 층위(layer)에서 노드를 선택할 수 있습니다.”">
             <a:extLst xmlns:a="http://schemas.openxmlformats.org/drawingml/2006/main">
               <a:ext uri="{FF2B5EF4-FFF2-40B4-BE49-F238E27FC236}">
-                <a16:creationId xmlns:a16="http://schemas.microsoft.com/office/drawing/2014/main" id="{A623D024-5FFC-45AF-95E6-B29CC4D9C109}"/>
+                <a16:creationId xmlns:a16="http://schemas.microsoft.com/office/drawing/2014/main" id="{C5270960-255F-481D-811B-69FC61A2DC0E}"/>
               </a:ext>
             </a:extLst>
           </p:cNvPr>
@@ -10506,7 +10483,7 @@
           <p:cNvPr id="46" name="충실도 1.000: 추출된 답변 주장을 검색 결과가 모두 지지 관련성 0.937: 답변 기반 질문과 원질문의 평균 의">
             <a:extLst xmlns:a="http://schemas.openxmlformats.org/drawingml/2006/main">
               <a:ext uri="{FF2B5EF4-FFF2-40B4-BE49-F238E27FC236}">
-                <a16:creationId xmlns:a16="http://schemas.microsoft.com/office/drawing/2014/main" id="{9A302188-48D6-4F4F-BCFF-73D34CA44E60}"/>
+                <a16:creationId xmlns:a16="http://schemas.microsoft.com/office/drawing/2014/main" id="{71F80C61-FDA2-4789-9E3B-DA0A9D988ABF}"/>
               </a:ext>
             </a:extLst>
           </p:cNvPr>
@@ -10687,7 +10664,7 @@
           <p:cNvPr id="47" name="평가: RAGAS 0.2.15[10]·gpt-4o·BGE-M3, 저장 답변 평가 평가 언어: S0 영어 / S1 한국">
             <a:extLst xmlns:a="http://schemas.openxmlformats.org/drawingml/2006/main">
               <a:ext uri="{FF2B5EF4-FFF2-40B4-BE49-F238E27FC236}">
-                <a16:creationId xmlns:a16="http://schemas.microsoft.com/office/drawing/2014/main" id="{0B8F4923-F7F9-43DE-8B49-D3938F05BFDC}"/>
+                <a16:creationId xmlns:a16="http://schemas.microsoft.com/office/drawing/2014/main" id="{B33B7512-F3AE-486E-9A70-327951CCBA2B}"/>
               </a:ext>
             </a:extLst>
           </p:cNvPr>
@@ -10868,7 +10845,7 @@
           <p:cNvPr id="48" name="반복측정 분산분석(ANOVA)·대응 t-검정, 양측 α=0.05 품질: SCD 상태별 H×C / 한국어 비율·시간: ">
             <a:extLst xmlns:a="http://schemas.openxmlformats.org/drawingml/2006/main">
               <a:ext uri="{FF2B5EF4-FFF2-40B4-BE49-F238E27FC236}">
-                <a16:creationId xmlns:a16="http://schemas.microsoft.com/office/drawing/2014/main" id="{EB0B9160-DBEB-4086-AF5F-982005DCCA1C}"/>
+                <a16:creationId xmlns:a16="http://schemas.microsoft.com/office/drawing/2014/main" id="{BDB5008C-77D3-4DB9-A45E-CC1D81C8AC41}"/>
               </a:ext>
             </a:extLst>
           </p:cNvPr>
@@ -11049,7 +11026,7 @@
           <p:cNvPr id="49" name="">
             <a:extLst xmlns:a="http://schemas.openxmlformats.org/drawingml/2006/main">
               <a:ext uri="{FF2B5EF4-FFF2-40B4-BE49-F238E27FC236}">
-                <a16:creationId xmlns:a16="http://schemas.microsoft.com/office/drawing/2014/main" id="{20C34AB8-5FB9-44BC-8D41-E5CE950F9FA3}"/>
+                <a16:creationId xmlns:a16="http://schemas.microsoft.com/office/drawing/2014/main" id="{1974C881-D403-4C6B-B4A3-0D8881F39C10}"/>
               </a:ext>
             </a:extLst>
           </p:cNvPr>
@@ -11080,7 +11057,7 @@
           <p:cNvPr id="50" name="05 조합별 결과와 통계 검정">
             <a:extLst xmlns:a="http://schemas.openxmlformats.org/drawingml/2006/main">
               <a:ext uri="{FF2B5EF4-FFF2-40B4-BE49-F238E27FC236}">
-                <a16:creationId xmlns:a16="http://schemas.microsoft.com/office/drawing/2014/main" id="{B8026820-DC64-4CAE-846B-BBD1C4EB45AD}"/>
+                <a16:creationId xmlns:a16="http://schemas.microsoft.com/office/drawing/2014/main" id="{95B6A686-9609-465C-8912-84C9284509A6}"/>
               </a:ext>
             </a:extLst>
           </p:cNvPr>
@@ -11238,7 +11215,7 @@
           <p:cNvPr id="51" name="HyDE·CAD·SCD 8조합의 품질·한국어 비율·시간 평균(SD)">
             <a:extLst xmlns:a="http://schemas.openxmlformats.org/drawingml/2006/main">
               <a:ext uri="{FF2B5EF4-FFF2-40B4-BE49-F238E27FC236}">
-                <a16:creationId xmlns:a16="http://schemas.microsoft.com/office/drawing/2014/main" id="{C8442F1B-C298-43B8-974A-C33CA8E52BCB}"/>
+                <a16:creationId xmlns:a16="http://schemas.microsoft.com/office/drawing/2014/main" id="{EA0DD159-F5DF-4613-80C8-6FFF91606DBA}"/>
               </a:ext>
             </a:extLst>
           </p:cNvPr>
@@ -11396,7 +11373,7 @@
           <p:cNvPr id="52" name="">
             <a:extLst xmlns:a="http://schemas.openxmlformats.org/drawingml/2006/main">
               <a:ext uri="{FF2B5EF4-FFF2-40B4-BE49-F238E27FC236}">
-                <a16:creationId xmlns:a16="http://schemas.microsoft.com/office/drawing/2014/main" id="{81BFE966-BC00-4A78-B095-B71984F5A4EB}"/>
+                <a16:creationId xmlns:a16="http://schemas.microsoft.com/office/drawing/2014/main" id="{6EE18D62-9C4C-4FD0-89A9-57CB2E134EB6}"/>
               </a:ext>
             </a:extLst>
           </p:cNvPr>
@@ -14756,7 +14733,7 @@
           <p:cNvPr id="53" name="">
             <a:extLst xmlns:a="http://schemas.openxmlformats.org/drawingml/2006/main">
               <a:ext uri="{FF2B5EF4-FFF2-40B4-BE49-F238E27FC236}">
-                <a16:creationId xmlns:a16="http://schemas.microsoft.com/office/drawing/2014/main" id="{EEE5D3F3-A0F6-4031-BFA9-423A029CF023}"/>
+                <a16:creationId xmlns:a16="http://schemas.microsoft.com/office/drawing/2014/main" id="{0785FE23-E967-47BF-8A00-A526ED56788B}"/>
               </a:ext>
             </a:extLst>
           </p:cNvPr>
@@ -14787,7 +14764,7 @@
           <p:cNvPr id="54" name="S0: 영어로 평가 / S1: 한국어 번역으로 평가 충실도 H0C1S0 n=58, H0C0S1 n=57, 나머지 n=">
             <a:extLst xmlns:a="http://schemas.openxmlformats.org/drawingml/2006/main">
               <a:ext uri="{FF2B5EF4-FFF2-40B4-BE49-F238E27FC236}">
-                <a16:creationId xmlns:a16="http://schemas.microsoft.com/office/drawing/2014/main" id="{295E0488-BDFD-4C11-B933-812D2285EFAC}"/>
+                <a16:creationId xmlns:a16="http://schemas.microsoft.com/office/drawing/2014/main" id="{819B5E03-2B43-4114-A3FF-9B3CF9AFE6FE}"/>
               </a:ext>
             </a:extLst>
           </p:cNvPr>
@@ -14981,7 +14958,7 @@
                 <a:ea typeface="Malgun Gothic"/>
                 <a:cs typeface="Malgun Gothic"/>
               </a:rPr>
-              <a:t>한국어 비율·시간(초)은 생성 기록에서 직접 계산</a:t>
+              <a:t>한국어 비율·시간(초)은 답변과 실행 시간에서 직접 계산</a:t>
             </a:r>
           </a:p>
         </p:txBody>
@@ -14991,7 +14968,7 @@
           <p:cNvPr id="55" name="3요인 반복측정 ANOVA  ·  각 효과 df=(1,59)">
             <a:extLst xmlns:a="http://schemas.openxmlformats.org/drawingml/2006/main">
               <a:ext uri="{FF2B5EF4-FFF2-40B4-BE49-F238E27FC236}">
-                <a16:creationId xmlns:a16="http://schemas.microsoft.com/office/drawing/2014/main" id="{40531829-FA42-40F2-ABFC-4704220EC752}"/>
+                <a16:creationId xmlns:a16="http://schemas.microsoft.com/office/drawing/2014/main" id="{8E0281FD-F93A-4A7F-BEE8-E2E954B41BDA}"/>
               </a:ext>
             </a:extLst>
           </p:cNvPr>
@@ -15149,7 +15126,7 @@
           <p:cNvPr id="56" name="">
             <a:extLst xmlns:a="http://schemas.openxmlformats.org/drawingml/2006/main">
               <a:ext uri="{FF2B5EF4-FFF2-40B4-BE49-F238E27FC236}">
-                <a16:creationId xmlns:a16="http://schemas.microsoft.com/office/drawing/2014/main" id="{393AD65B-8613-4291-8BAE-D64014BEB2C3}"/>
+                <a16:creationId xmlns:a16="http://schemas.microsoft.com/office/drawing/2014/main" id="{C473657E-1C4E-499D-AE6C-13E525359B5B}"/>
               </a:ext>
             </a:extLst>
           </p:cNvPr>
@@ -16859,10 +16836,10 @@
       </p:graphicFrame>
       <p:sp>
         <p:nvSpPr>
-          <p:cNvPr id="57" name="p&lt;0.05: 한국어 비율 S·H×C / 실행 시간 H·C·S·C×S RAGAS H×C 검정은 평가 언어별로 수행했으">
+          <p:cNvPr id="57" name="p&lt;0.05: 한국어 비율 S·H×C* / 실행 시간 H·C·S*·C×S (*유의수준 근처의 탐색적 결과) RAGAS">
             <a:extLst xmlns:a="http://schemas.openxmlformats.org/drawingml/2006/main">
               <a:ext uri="{FF2B5EF4-FFF2-40B4-BE49-F238E27FC236}">
-                <a16:creationId xmlns:a16="http://schemas.microsoft.com/office/drawing/2014/main" id="{8D43E5C8-53AE-46BC-8AC2-0CAB42FBFE59}"/>
+                <a16:creationId xmlns:a16="http://schemas.microsoft.com/office/drawing/2014/main" id="{C469F927-E94D-4D5C-99DD-6D6DE9271A04}"/>
               </a:ext>
             </a:extLst>
           </p:cNvPr>
@@ -17010,7 +16987,7 @@
                 <a:ea typeface="Malgun Gothic"/>
                 <a:cs typeface="Malgun Gothic"/>
               </a:rPr>
-              <a:t>p&lt;0.05: 한국어 비율 S·H×C / 실행 시간 H·C·S·C×S</a:t>
+              <a:t>p&lt;0.05: 한국어 비율 S·H×C* / 실행 시간 H·C·S*·C×S (*유의수준 근처의 탐색적 결과)</a:t>
             </a:r>
           </a:p>
           <a:p xmlns:a="http://schemas.openxmlformats.org/drawingml/2006/main">
@@ -17066,7 +17043,7 @@
           <p:cNvPr id="58" name="기법별 대응 비교  ·  질의별 평균 차이, 양측 검정">
             <a:extLst xmlns:a="http://schemas.openxmlformats.org/drawingml/2006/main">
               <a:ext uri="{FF2B5EF4-FFF2-40B4-BE49-F238E27FC236}">
-                <a16:creationId xmlns:a16="http://schemas.microsoft.com/office/drawing/2014/main" id="{1CBB8F47-5559-4E64-A827-F5A96B999554}"/>
+                <a16:creationId xmlns:a16="http://schemas.microsoft.com/office/drawing/2014/main" id="{59D98C1E-67BB-4DB0-B2F8-F458F43D239A}"/>
               </a:ext>
             </a:extLst>
           </p:cNvPr>
@@ -17224,7 +17201,7 @@
           <p:cNvPr id="59" name="">
             <a:extLst xmlns:a="http://schemas.openxmlformats.org/drawingml/2006/main">
               <a:ext uri="{FF2B5EF4-FFF2-40B4-BE49-F238E27FC236}">
-                <a16:creationId xmlns:a16="http://schemas.microsoft.com/office/drawing/2014/main" id="{205563F7-B5A4-434B-8C44-4B92B7814EC4}"/>
+                <a16:creationId xmlns:a16="http://schemas.microsoft.com/office/drawing/2014/main" id="{A214632D-95AD-4F5B-A7E1-55689EC16105}"/>
               </a:ext>
             </a:extLst>
           </p:cNvPr>
@@ -18237,7 +18214,7 @@
           <p:cNvPr id="60" name="HyDE: C0S0, CAD: H0S0, SCD: H0의 CAD 상태 평균 p: 다중비교 보정 없는 양측 p, dz:">
             <a:extLst xmlns:a="http://schemas.openxmlformats.org/drawingml/2006/main">
               <a:ext uri="{FF2B5EF4-FFF2-40B4-BE49-F238E27FC236}">
-                <a16:creationId xmlns:a16="http://schemas.microsoft.com/office/drawing/2014/main" id="{C0816845-668B-41BA-BDBE-562C26C50FEC}"/>
+                <a16:creationId xmlns:a16="http://schemas.microsoft.com/office/drawing/2014/main" id="{8213D86D-36C6-43AC-8A5A-8CE473BC1062}"/>
               </a:ext>
             </a:extLst>
           </p:cNvPr>
@@ -18249,7 +18226,7 @@
         <p:spPr>
           <a:xfrm xmlns:a="http://schemas.openxmlformats.org/drawingml/2006/main">
             <a:off x="10949175" y="21564600"/>
-            <a:ext cx="9729975" cy="1143000"/>
+            <a:ext cx="9729975" cy="857250"/>
           </a:xfrm>
           <a:prstGeom xmlns:a="http://schemas.openxmlformats.org/drawingml/2006/main" prst="rect">
             <a:avLst/>
@@ -18431,29 +18408,6 @@
                 <a:ea typeface="Malgun Gothic"/>
                 <a:cs typeface="Malgun Gothic"/>
               </a:rPr>
-              <a:t>SCD 차이 +0.218은 한글 비중 +21.8%p에 해당</a:t>
-            </a:r>
-          </a:p>
-          <a:p xmlns:a="http://schemas.openxmlformats.org/drawingml/2006/main">
-            <a:pPr algn="l">
-              <a:defRPr sz="1800" b="0">
-                <a:solidFill>
-                  <a:srgbClr val="24324A"/>
-                </a:solidFill>
-                <a:latin typeface="Malgun Gothic"/>
-                <a:ea typeface="Malgun Gothic"/>
-                <a:cs typeface="Malgun Gothic"/>
-              </a:defRPr>
-            </a:pPr>
-            <a:r>
-              <a:rPr sz="1800" b="0">
-                <a:solidFill>
-                  <a:srgbClr val="24324A"/>
-                </a:solidFill>
-                <a:latin typeface="Malgun Gothic"/>
-                <a:ea typeface="Malgun Gothic"/>
-                <a:cs typeface="Malgun Gothic"/>
-              </a:rPr>
               <a:t>평균표 SD는 점수의 산포, 대응표 SD는 ON−OFF 차이의 산포</a:t>
             </a:r>
           </a:p>
@@ -18464,7 +18418,7 @@
           <p:cNvPr id="61" name="">
             <a:extLst xmlns:a="http://schemas.openxmlformats.org/drawingml/2006/main">
               <a:ext uri="{FF2B5EF4-FFF2-40B4-BE49-F238E27FC236}">
-                <a16:creationId xmlns:a16="http://schemas.microsoft.com/office/drawing/2014/main" id="{016D7BE4-F789-46BA-AD29-2F59AB9C1732}"/>
+                <a16:creationId xmlns:a16="http://schemas.microsoft.com/office/drawing/2014/main" id="{178A86DF-D64B-4ACF-A40F-B761E7FC4CBE}"/>
               </a:ext>
             </a:extLst>
           </p:cNvPr>
@@ -18475,7 +18429,7 @@
         </p:nvSpPr>
         <p:spPr>
           <a:xfrm xmlns:a="http://schemas.openxmlformats.org/drawingml/2006/main">
-            <a:off x="10949175" y="22812375"/>
+            <a:off x="10949175" y="22526625"/>
             <a:ext cx="9729975" cy="438150"/>
           </a:xfrm>
           <a:prstGeom xmlns:a="http://schemas.openxmlformats.org/drawingml/2006/main" prst="rect">
@@ -18495,7 +18449,7 @@
           <p:cNvPr id="62" name="06 결과 해석">
             <a:extLst xmlns:a="http://schemas.openxmlformats.org/drawingml/2006/main">
               <a:ext uri="{FF2B5EF4-FFF2-40B4-BE49-F238E27FC236}">
-                <a16:creationId xmlns:a16="http://schemas.microsoft.com/office/drawing/2014/main" id="{6F48715C-D631-4F96-9C90-6B0BF34481F5}"/>
+                <a16:creationId xmlns:a16="http://schemas.microsoft.com/office/drawing/2014/main" id="{EB7F33E0-937C-455E-B3B4-99C1ABF60FF2}"/>
               </a:ext>
             </a:extLst>
           </p:cNvPr>
@@ -18506,7 +18460,7 @@
         </p:nvSpPr>
         <p:spPr>
           <a:xfrm xmlns:a="http://schemas.openxmlformats.org/drawingml/2006/main">
-            <a:off x="11044425" y="22840950"/>
+            <a:off x="11044425" y="22555200"/>
             <a:ext cx="9539475" cy="381000"/>
           </a:xfrm>
           <a:prstGeom xmlns:a="http://schemas.openxmlformats.org/drawingml/2006/main" prst="rect">
@@ -18650,10 +18604,10 @@
       </p:sp>
       <p:sp>
         <p:nvSpPr>
-          <p:cNvPr id="63" name="HyDE 관련성은 평균 +0.080점, t(59)=2.236, p=0.029였다. CAD 충실도는 평균 +0.029점">
+          <p:cNvPr id="63" name="HyDE: 기본 조건에서 관련성이 유의하게 높았고(p=0.029), SCD 적용 조건의 추가 비교에서는 p=0.114">
             <a:extLst xmlns:a="http://schemas.openxmlformats.org/drawingml/2006/main">
               <a:ext uri="{FF2B5EF4-FFF2-40B4-BE49-F238E27FC236}">
-                <a16:creationId xmlns:a16="http://schemas.microsoft.com/office/drawing/2014/main" id="{3E3E3D95-84C1-4D2B-B648-631C8BDC05EE}"/>
+                <a16:creationId xmlns:a16="http://schemas.microsoft.com/office/drawing/2014/main" id="{3251FDC8-A947-417F-8BEA-38BAD53D0BCC}"/>
               </a:ext>
             </a:extLst>
           </p:cNvPr>
@@ -18664,8 +18618,8 @@
         </p:nvSpPr>
         <p:spPr>
           <a:xfrm xmlns:a="http://schemas.openxmlformats.org/drawingml/2006/main">
-            <a:off x="10949175" y="23336250"/>
-            <a:ext cx="9729975" cy="1219200"/>
+            <a:off x="10949175" y="23050500"/>
+            <a:ext cx="9729975" cy="1428750"/>
           </a:xfrm>
           <a:prstGeom xmlns:a="http://schemas.openxmlformats.org/drawingml/2006/main" prst="rect">
             <a:avLst/>
@@ -18801,7 +18755,7 @@
                 <a:ea typeface="Malgun Gothic"/>
                 <a:cs typeface="Malgun Gothic"/>
               </a:rPr>
-              <a:t>HyDE 관련성은 평균 +0.080점, t(59)=2.236, p=0.029였다.</a:t>
+              <a:t>HyDE: 기본 조건에서 관련성이 유의하게 높았고(p=0.029),</a:t>
             </a:r>
           </a:p>
           <a:p xmlns:a="http://schemas.openxmlformats.org/drawingml/2006/main">
@@ -18824,7 +18778,7 @@
                 <a:ea typeface="Malgun Gothic"/>
                 <a:cs typeface="Malgun Gothic"/>
               </a:rPr>
-              <a:t>CAD 충실도는 평균 +0.029점, t(57)=0.862, p=0.393이었다.</a:t>
+              <a:t>SCD 적용 조건의 추가 비교에서는 p=0.114였다.</a:t>
             </a:r>
           </a:p>
           <a:p xmlns:a="http://schemas.openxmlformats.org/drawingml/2006/main">
@@ -18847,7 +18801,7 @@
                 <a:ea typeface="Malgun Gothic"/>
                 <a:cs typeface="Malgun Gothic"/>
               </a:rPr>
-              <a:t>SCD 주 비교의 한국어 비율은 21.8%p 높았다(p&lt;0.001).</a:t>
+              <a:t>CAD: 충실도 차이는 작았고(p=0.393), 실행 시간은 약 2.9배였다.</a:t>
             </a:r>
           </a:p>
           <a:p xmlns:a="http://schemas.openxmlformats.org/drawingml/2006/main">
@@ -18870,7 +18824,30 @@
                 <a:ea typeface="Malgun Gothic"/>
                 <a:cs typeface="Malgun Gothic"/>
               </a:rPr>
-              <a:t>CAD 시간 증가: SCD OFF +46.6초 / ON +37.7초.</a:t>
+              <a:t>SCD: 네 조합 모두에서 한국어 문자 비율이 높았고, CAD와 함께</a:t>
+            </a:r>
+          </a:p>
+          <a:p xmlns:a="http://schemas.openxmlformats.org/drawingml/2006/main">
+            <a:pPr algn="l">
+              <a:defRPr sz="1800" b="0">
+                <a:solidFill>
+                  <a:srgbClr val="24324A"/>
+                </a:solidFill>
+                <a:latin typeface="Malgun Gothic"/>
+                <a:ea typeface="Malgun Gothic"/>
+                <a:cs typeface="Malgun Gothic"/>
+              </a:defRPr>
+            </a:pPr>
+            <a:r>
+              <a:rPr sz="1800" b="0">
+                <a:solidFill>
+                  <a:srgbClr val="24324A"/>
+                </a:solidFill>
+                <a:latin typeface="Malgun Gothic"/>
+                <a:ea typeface="Malgun Gothic"/>
+                <a:cs typeface="Malgun Gothic"/>
+              </a:rPr>
+              <a:t>쓰면 CAD의 추가 시간이 약 9초 줄었다(C×S, p&lt;0.001).</a:t>
             </a:r>
           </a:p>
         </p:txBody>
@@ -18880,7 +18857,7 @@
           <p:cNvPr id="64" name="">
             <a:extLst xmlns:a="http://schemas.openxmlformats.org/drawingml/2006/main">
               <a:ext uri="{FF2B5EF4-FFF2-40B4-BE49-F238E27FC236}">
-                <a16:creationId xmlns:a16="http://schemas.microsoft.com/office/drawing/2014/main" id="{0DDFB009-280C-4D25-8BD8-EC906DF8121E}"/>
+                <a16:creationId xmlns:a16="http://schemas.microsoft.com/office/drawing/2014/main" id="{44667C4C-20ED-40C2-AE18-B74E0F151612}"/>
               </a:ext>
             </a:extLst>
           </p:cNvPr>
@@ -18891,7 +18868,7 @@
         </p:nvSpPr>
         <p:spPr>
           <a:xfrm xmlns:a="http://schemas.openxmlformats.org/drawingml/2006/main">
-            <a:off x="10949175" y="24688800"/>
+            <a:off x="10949175" y="24593550"/>
             <a:ext cx="9729975" cy="438150"/>
           </a:xfrm>
           <a:prstGeom xmlns:a="http://schemas.openxmlformats.org/drawingml/2006/main" prst="rect">
@@ -18911,7 +18888,7 @@
           <p:cNvPr id="65" name="07 결론">
             <a:extLst xmlns:a="http://schemas.openxmlformats.org/drawingml/2006/main">
               <a:ext uri="{FF2B5EF4-FFF2-40B4-BE49-F238E27FC236}">
-                <a16:creationId xmlns:a16="http://schemas.microsoft.com/office/drawing/2014/main" id="{BEF4C6BB-82A6-46F7-B90D-D803172EA2E4}"/>
+                <a16:creationId xmlns:a16="http://schemas.microsoft.com/office/drawing/2014/main" id="{A4CAB35E-3269-4A25-88BC-74FA9811A45A}"/>
               </a:ext>
             </a:extLst>
           </p:cNvPr>
@@ -18922,7 +18899,7 @@
         </p:nvSpPr>
         <p:spPr>
           <a:xfrm xmlns:a="http://schemas.openxmlformats.org/drawingml/2006/main">
-            <a:off x="11044425" y="24717375"/>
+            <a:off x="11044425" y="24622125"/>
             <a:ext cx="9539475" cy="381000"/>
           </a:xfrm>
           <a:prstGeom xmlns:a="http://schemas.openxmlformats.org/drawingml/2006/main" prst="rect">
@@ -19066,10 +19043,10 @@
       </p:sp>
       <p:sp>
         <p:nvSpPr>
-          <p:cNvPr id="66" name="HyDE는 C0S0에서 관련성을 높였고(p=0.029), CAD 충실도 차이는 p=0.393이었다. SCD는 같은 영">
+          <p:cNvPr id="66" name="한국어 답변이 필요하면 SCD가 비용이 작은 선택이었다. HyDE의 관련성 향상은 기본 조건(C0S0)에서 관측되었고">
             <a:extLst xmlns:a="http://schemas.openxmlformats.org/drawingml/2006/main">
               <a:ext uri="{FF2B5EF4-FFF2-40B4-BE49-F238E27FC236}">
-                <a16:creationId xmlns:a16="http://schemas.microsoft.com/office/drawing/2014/main" id="{86590124-E2D6-4D2C-BCE9-2DA0B098CE85}"/>
+                <a16:creationId xmlns:a16="http://schemas.microsoft.com/office/drawing/2014/main" id="{447BEAE4-82FB-4924-86F1-7483C3E94D3D}"/>
               </a:ext>
             </a:extLst>
           </p:cNvPr>
@@ -19080,8 +19057,8 @@
         </p:nvSpPr>
         <p:spPr>
           <a:xfrm xmlns:a="http://schemas.openxmlformats.org/drawingml/2006/main">
-            <a:off x="10949175" y="25288875"/>
-            <a:ext cx="9729975" cy="1524000"/>
+            <a:off x="10949175" y="25193625"/>
+            <a:ext cx="9729975" cy="1733550"/>
           </a:xfrm>
           <a:prstGeom xmlns:a="http://schemas.openxmlformats.org/drawingml/2006/main" prst="rect">
             <a:avLst/>
@@ -19217,7 +19194,7 @@
                 <a:ea typeface="Malgun Gothic"/>
                 <a:cs typeface="Malgun Gothic"/>
               </a:rPr>
-              <a:t>HyDE는 C0S0에서 관련성을 높였고(p=0.029), CAD 충실도 차이는 p=0.393이었다.</a:t>
+              <a:t>한국어 답변이 필요하면 SCD가 비용이 작은 선택이었다.</a:t>
             </a:r>
           </a:p>
           <a:p xmlns:a="http://schemas.openxmlformats.org/drawingml/2006/main">
@@ -19240,7 +19217,7 @@
                 <a:ea typeface="Malgun Gothic"/>
                 <a:cs typeface="Malgun Gothic"/>
               </a:rPr>
-              <a:t>SCD는 같은 영어 근거에서 한국어 사용 비중을 높였다.</a:t>
+              <a:t>HyDE의 관련성 향상은 기본 조건(C0S0)에서 관측되었고,</a:t>
             </a:r>
           </a:p>
           <a:p xmlns:a="http://schemas.openxmlformats.org/drawingml/2006/main">
@@ -19263,7 +19240,7 @@
                 <a:ea typeface="Malgun Gothic"/>
                 <a:cs typeface="Malgun Gothic"/>
               </a:rPr>
-              <a:t>CAD는 실행 시간을 SCD 미적용 3.1배, 적용 2.7배로 늘렸다.</a:t>
+              <a:t>이 차이에는 질의 번역과 가상 문서 생성이 함께 포함되었다.</a:t>
             </a:r>
           </a:p>
           <a:p xmlns:a="http://schemas.openxmlformats.org/drawingml/2006/main">
@@ -19286,7 +19263,30 @@
                 <a:ea typeface="Malgun Gothic"/>
                 <a:cs typeface="Malgun Gothic"/>
               </a:rPr>
-              <a:t>HyDE 비교에는 질의 번역과 가상 문서 생성이 함께 포함됐다.</a:t>
+              <a:t>CAD는 충실도 차이가 작고 실행 시간이 약 2.9배로 늘었다</a:t>
+            </a:r>
+          </a:p>
+          <a:p xmlns:a="http://schemas.openxmlformats.org/drawingml/2006/main">
+            <a:pPr algn="l">
+              <a:defRPr sz="1800" b="0">
+                <a:solidFill>
+                  <a:srgbClr val="24324A"/>
+                </a:solidFill>
+                <a:latin typeface="Malgun Gothic"/>
+                <a:ea typeface="Malgun Gothic"/>
+                <a:cs typeface="Malgun Gothic"/>
+              </a:defRPr>
+            </a:pPr>
+            <a:r>
+              <a:rPr sz="1800" b="0">
+                <a:solidFill>
+                  <a:srgbClr val="24324A"/>
+                </a:solidFill>
+                <a:latin typeface="Malgun Gothic"/>
+                <a:ea typeface="Malgun Gothic"/>
+                <a:cs typeface="Malgun Gothic"/>
+              </a:rPr>
+              <a:t>(SCD 미적용 3.1배, 적용 2.7배).</a:t>
             </a:r>
           </a:p>
           <a:p xmlns:a="http://schemas.openxmlformats.org/drawingml/2006/main">
@@ -19319,7 +19319,7 @@
           <p:cNvPr id="67" name="">
             <a:extLst xmlns:a="http://schemas.openxmlformats.org/drawingml/2006/main">
               <a:ext uri="{FF2B5EF4-FFF2-40B4-BE49-F238E27FC236}">
-                <a16:creationId xmlns:a16="http://schemas.microsoft.com/office/drawing/2014/main" id="{836ABA67-7A8C-4E2E-91E6-A3D6200818D8}"/>
+                <a16:creationId xmlns:a16="http://schemas.microsoft.com/office/drawing/2014/main" id="{5334702A-A4A6-4632-B109-0EFB9FBCAD15}"/>
               </a:ext>
             </a:extLst>
           </p:cNvPr>
@@ -19350,7 +19350,7 @@
           <p:cNvPr id="68" name="08 주요 참고문헌">
             <a:extLst xmlns:a="http://schemas.openxmlformats.org/drawingml/2006/main">
               <a:ext uri="{FF2B5EF4-FFF2-40B4-BE49-F238E27FC236}">
-                <a16:creationId xmlns:a16="http://schemas.microsoft.com/office/drawing/2014/main" id="{4D6854E6-000C-459A-B5ED-65287A85E009}"/>
+                <a16:creationId xmlns:a16="http://schemas.microsoft.com/office/drawing/2014/main" id="{7AD350D8-D56A-41AC-BE65-3A82EAD8741D}"/>
               </a:ext>
             </a:extLst>
           </p:cNvPr>
@@ -19508,7 +19508,7 @@
           <p:cNvPr id="69" name="[1] Lewis et al. RAG. NeurIPS, 2020. [2] Gao et al. HyDE. ACL, 20">
             <a:extLst xmlns:a="http://schemas.openxmlformats.org/drawingml/2006/main">
               <a:ext uri="{FF2B5EF4-FFF2-40B4-BE49-F238E27FC236}">
-                <a16:creationId xmlns:a16="http://schemas.microsoft.com/office/drawing/2014/main" id="{825D5A2E-31B9-4494-A2A9-4E4FF8352A4F}"/>
+                <a16:creationId xmlns:a16="http://schemas.microsoft.com/office/drawing/2014/main" id="{29529266-6377-4562-A347-B87CFDA23584}"/>
               </a:ext>
             </a:extLst>
           </p:cNvPr>
@@ -19712,7 +19712,7 @@
           <p:cNvPr id="70" name="[4] Li et al. Language Drift and SCD. AAAI, 2026. [5] Chen et al.">
             <a:extLst xmlns:a="http://schemas.openxmlformats.org/drawingml/2006/main">
               <a:ext uri="{FF2B5EF4-FFF2-40B4-BE49-F238E27FC236}">
-                <a16:creationId xmlns:a16="http://schemas.microsoft.com/office/drawing/2014/main" id="{DE9E04A5-62CE-4805-8CFA-37769019A343}"/>
+                <a16:creationId xmlns:a16="http://schemas.microsoft.com/office/drawing/2014/main" id="{9A30954B-F151-4485-8628-382F33608EFD}"/>
               </a:ext>
             </a:extLst>
           </p:cNvPr>
@@ -19916,7 +19916,7 @@
           <p:cNvPr id="71" name="[6] Robertson et al. Okapi at TREC-3. NIST, 1995. [7] Cormack et ">
             <a:extLst xmlns:a="http://schemas.openxmlformats.org/drawingml/2006/main">
               <a:ext uri="{FF2B5EF4-FFF2-40B4-BE49-F238E27FC236}">
-                <a16:creationId xmlns:a16="http://schemas.microsoft.com/office/drawing/2014/main" id="{78204908-7C94-46F5-ABDD-4B5AEE8C319D}"/>
+                <a16:creationId xmlns:a16="http://schemas.microsoft.com/office/drawing/2014/main" id="{C9F590B0-C100-4C48-85BE-55FDD7C2D31A}"/>
               </a:ext>
             </a:extLst>
           </p:cNvPr>
@@ -20097,7 +20097,7 @@
           <p:cNvPr id="72" name="[8] MacAvaney et al. CEDR. SIGIR, 2019. 공식 모델  [M1] KT Mi:dm 2.0 ">
             <a:extLst xmlns:a="http://schemas.openxmlformats.org/drawingml/2006/main">
               <a:ext uri="{FF2B5EF4-FFF2-40B4-BE49-F238E27FC236}">
-                <a16:creationId xmlns:a16="http://schemas.microsoft.com/office/drawing/2014/main" id="{A19F4303-8579-495D-AFDA-452DB00C7124}"/>
+                <a16:creationId xmlns:a16="http://schemas.microsoft.com/office/drawing/2014/main" id="{AAD2C696-6DD4-491F-A93F-85698066FBBE}"/>
               </a:ext>
             </a:extLst>
           </p:cNvPr>
@@ -20278,7 +20278,7 @@
           <p:cNvPr id="73" name="전체 참고문헌 22편과 모델·자료 출처는 논문의 참고문헌에 수록">
             <a:extLst xmlns:a="http://schemas.openxmlformats.org/drawingml/2006/main">
               <a:ext uri="{FF2B5EF4-FFF2-40B4-BE49-F238E27FC236}">
-                <a16:creationId xmlns:a16="http://schemas.microsoft.com/office/drawing/2014/main" id="{C324540F-2DBC-4D8F-9B96-472E99434986}"/>
+                <a16:creationId xmlns:a16="http://schemas.microsoft.com/office/drawing/2014/main" id="{3AA73015-D3F4-44C7-BF92-76B9825D5D40}"/>
               </a:ext>
             </a:extLst>
           </p:cNvPr>
@@ -20436,7 +20436,7 @@
           <p:cNvPr id="74" name="영어 문서 4종 · 질의 60개 · 생성 모델 1종 · 질의별 반복측정">
             <a:extLst xmlns:a="http://schemas.openxmlformats.org/drawingml/2006/main">
               <a:ext uri="{FF2B5EF4-FFF2-40B4-BE49-F238E27FC236}">
-                <a16:creationId xmlns:a16="http://schemas.microsoft.com/office/drawing/2014/main" id="{D495E1C2-3AAE-4CF5-9BE2-746AF70B155E}"/>
+                <a16:creationId xmlns:a16="http://schemas.microsoft.com/office/drawing/2014/main" id="{94E4FC76-3D47-4121-ACC0-C18495B148AD}"/>
               </a:ext>
             </a:extLst>
           </p:cNvPr>
@@ -20594,7 +20594,7 @@
           <p:cNvPr id="75" name="A1 594 × 841 mm">
             <a:extLst xmlns:a="http://schemas.openxmlformats.org/drawingml/2006/main">
               <a:ext uri="{FF2B5EF4-FFF2-40B4-BE49-F238E27FC236}">
-                <a16:creationId xmlns:a16="http://schemas.microsoft.com/office/drawing/2014/main" id="{7AD36D54-2D25-403B-9A86-DCF8076F882E}"/>
+                <a16:creationId xmlns:a16="http://schemas.microsoft.com/office/drawing/2014/main" id="{8B4ECA7C-6541-497A-A2C4-30B1B838A3C5}"/>
               </a:ext>
             </a:extLst>
           </p:cNvPr>
@@ -20750,7 +20750,7 @@
     </p:spTree>
     <p:extLst>
       <p:ext uri="{BB962C8B-B14F-4D97-AF65-F5344CB8AC3E}">
-        <p14:creationId xmlns:p14="http://schemas.microsoft.com/office/powerpoint/2010/main" val="2047551306"/>
+        <p14:creationId xmlns:p14="http://schemas.microsoft.com/office/powerpoint/2010/main" val="1649542771"/>
       </p:ext>
     </p:extLst>
   </p:cSld>

</xml_diff>

<commit_message>
Apply the independent re-review and author-confirmed query procedure
- Thesis: "보정 없이" for the multiple-comparison note, link the 5.9
  sampling sentence to follow-up measurement, fix particle and parallel
  structure; 5.1 now states the 3 initial questions are part of the 15
  and that gpt-4o produced the summaries; LLM defined at first use (2.6)
- Poster: contrastive connective in 06, tense and CAD takeaway in 07,
  remove two tautologies
- Regenerate HWPX/PDF (51 pages, positions unchanged), refresh manifests;
  re-review section appended to the independent review report

Co-Authored-By: Claude Opus 5.5 <noreply@anthropic.com>
</commit_message>
<xml_diff>
--- a/FINALDOCS/POSTER/FINAL/M_RAG_A1_FINAL_EDITABLE.pptx
+++ b/FINALDOCS/POSTER/FINAL/M_RAG_A1_FINAL_EDITABLE.pptx
@@ -2,13 +2,13 @@
 <file path=ppt/presentation.xml><?xml version="1.0" encoding="utf-8"?>
 <p:presentation xmlns:p="http://schemas.openxmlformats.org/presentationml/2006/main">
   <p:sldMasterIdLst>
-    <p:sldMasterId xmlns:r="http://schemas.openxmlformats.org/officeDocument/2006/relationships" id="2147483648" r:id="R78afd8e3b6eb4d84"/>
+    <p:sldMasterId xmlns:r="http://schemas.openxmlformats.org/officeDocument/2006/relationships" id="2147483648" r:id="R384b91cfcdea4d7a"/>
   </p:sldMasterIdLst>
   <p:notesMasterIdLst>
-    <p:notesMasterId xmlns:r="http://schemas.openxmlformats.org/officeDocument/2006/relationships" r:id="R53f3c389fc704493"/>
+    <p:notesMasterId xmlns:r="http://schemas.openxmlformats.org/officeDocument/2006/relationships" r:id="Rc4ca206ce9304477"/>
   </p:notesMasterIdLst>
   <p:sldIdLst>
-    <p:sldId xmlns:r="http://schemas.openxmlformats.org/officeDocument/2006/relationships" id="256" r:id="Rc702f5a0ec6c4574"/>
+    <p:sldId xmlns:r="http://schemas.openxmlformats.org/officeDocument/2006/relationships" id="256" r:id="R21b8fa34b89d4f48"/>
   </p:sldIdLst>
   <p:sldSz cx="21384000" cy="30276000"/>
   <p:notesSz cx="6858000" cy="9144000"/>
@@ -489,7 +489,7 @@
           <p:cNvPr id="3" name="Title">
             <a:extLst xmlns:a="http://schemas.openxmlformats.org/drawingml/2006/main">
               <a:ext uri="{FF2B5EF4-FFF2-40B4-BE49-F238E27FC236}">
-                <a16:creationId xmlns:a16="http://schemas.microsoft.com/office/drawing/2014/main" id="{2289664F-4BAD-455F-A843-FE758703F648}"/>
+                <a16:creationId xmlns:a16="http://schemas.microsoft.com/office/drawing/2014/main" id="{DC96F6B4-55E3-4274-B911-18FE359FA562}"/>
               </a:ext>
             </a:extLst>
           </p:cNvPr>
@@ -718,7 +718,7 @@
           <p:cNvPr id="2" name="Subtitle">
             <a:extLst xmlns:a="http://schemas.openxmlformats.org/drawingml/2006/main">
               <a:ext uri="{FF2B5EF4-FFF2-40B4-BE49-F238E27FC236}">
-                <a16:creationId xmlns:a16="http://schemas.microsoft.com/office/drawing/2014/main" id="{6806BBF0-0EB0-4FA4-AD43-B7CB5FC00D4D}"/>
+                <a16:creationId xmlns:a16="http://schemas.microsoft.com/office/drawing/2014/main" id="{6AACB9B9-6BD2-42D9-865C-653991384C5A}"/>
               </a:ext>
             </a:extLst>
           </p:cNvPr>
@@ -964,7 +964,7 @@
           <p:cNvPr id="2" name="Section title">
             <a:extLst xmlns:a="http://schemas.openxmlformats.org/drawingml/2006/main">
               <a:ext uri="{FF2B5EF4-FFF2-40B4-BE49-F238E27FC236}">
-                <a16:creationId xmlns:a16="http://schemas.microsoft.com/office/drawing/2014/main" id="{AA42F1BD-BB3A-45EA-BEF4-E97982B6E594}"/>
+                <a16:creationId xmlns:a16="http://schemas.microsoft.com/office/drawing/2014/main" id="{7CE9E248-4CCC-46B3-AA09-977E62B8E6B3}"/>
               </a:ext>
             </a:extLst>
           </p:cNvPr>
@@ -1210,7 +1210,7 @@
           <p:cNvPr id="3" name="Title">
             <a:extLst xmlns:a="http://schemas.openxmlformats.org/drawingml/2006/main">
               <a:ext uri="{FF2B5EF4-FFF2-40B4-BE49-F238E27FC236}">
-                <a16:creationId xmlns:a16="http://schemas.microsoft.com/office/drawing/2014/main" id="{CFD9C104-D843-4298-BC0A-9262CD460E44}"/>
+                <a16:creationId xmlns:a16="http://schemas.microsoft.com/office/drawing/2014/main" id="{4CE874D7-964A-4D82-B6D2-CD6E74797A0C}"/>
               </a:ext>
             </a:extLst>
           </p:cNvPr>
@@ -1439,7 +1439,7 @@
           <p:cNvPr id="2" name="Body">
             <a:extLst xmlns:a="http://schemas.openxmlformats.org/drawingml/2006/main">
               <a:ext uri="{FF2B5EF4-FFF2-40B4-BE49-F238E27FC236}">
-                <a16:creationId xmlns:a16="http://schemas.microsoft.com/office/drawing/2014/main" id="{FC452112-BDC6-47DD-9B0E-F20F3C12DCD0}"/>
+                <a16:creationId xmlns:a16="http://schemas.microsoft.com/office/drawing/2014/main" id="{6CA17C00-DE63-4334-B9A8-872D67E92E3B}"/>
               </a:ext>
             </a:extLst>
           </p:cNvPr>
@@ -1685,7 +1685,7 @@
           <p:cNvPr id="4" name="Title">
             <a:extLst xmlns:a="http://schemas.openxmlformats.org/drawingml/2006/main">
               <a:ext uri="{FF2B5EF4-FFF2-40B4-BE49-F238E27FC236}">
-                <a16:creationId xmlns:a16="http://schemas.microsoft.com/office/drawing/2014/main" id="{DE7D7297-F64C-4758-B596-BED90235E8BC}"/>
+                <a16:creationId xmlns:a16="http://schemas.microsoft.com/office/drawing/2014/main" id="{6AA15563-599B-4919-AF0A-846C84CD29A8}"/>
               </a:ext>
             </a:extLst>
           </p:cNvPr>
@@ -1914,7 +1914,7 @@
           <p:cNvPr id="2" name="Left column">
             <a:extLst xmlns:a="http://schemas.openxmlformats.org/drawingml/2006/main">
               <a:ext uri="{FF2B5EF4-FFF2-40B4-BE49-F238E27FC236}">
-                <a16:creationId xmlns:a16="http://schemas.microsoft.com/office/drawing/2014/main" id="{4F2C80AE-DFF1-4F27-9F1B-EC6749770F90}"/>
+                <a16:creationId xmlns:a16="http://schemas.microsoft.com/office/drawing/2014/main" id="{8706D22C-BDD9-44B4-9293-D499F43FD834}"/>
               </a:ext>
             </a:extLst>
           </p:cNvPr>
@@ -2143,7 +2143,7 @@
           <p:cNvPr id="3" name="Right column">
             <a:extLst xmlns:a="http://schemas.openxmlformats.org/drawingml/2006/main">
               <a:ext uri="{FF2B5EF4-FFF2-40B4-BE49-F238E27FC236}">
-                <a16:creationId xmlns:a16="http://schemas.microsoft.com/office/drawing/2014/main" id="{AD4B81D9-AF12-44CA-9E56-164D7F24E64B}"/>
+                <a16:creationId xmlns:a16="http://schemas.microsoft.com/office/drawing/2014/main" id="{FB510E8B-B468-44F0-B60A-97B7EFE4C19D}"/>
               </a:ext>
             </a:extLst>
           </p:cNvPr>
@@ -2389,7 +2389,7 @@
           <p:cNvPr id="3" name="Title">
             <a:extLst xmlns:a="http://schemas.openxmlformats.org/drawingml/2006/main">
               <a:ext uri="{FF2B5EF4-FFF2-40B4-BE49-F238E27FC236}">
-                <a16:creationId xmlns:a16="http://schemas.microsoft.com/office/drawing/2014/main" id="{ACB77181-AB22-4E4B-B333-D0272E4A1C6F}"/>
+                <a16:creationId xmlns:a16="http://schemas.microsoft.com/office/drawing/2014/main" id="{2B1F5638-DFBC-4C9B-8EE0-BD3EDEC5D71F}"/>
               </a:ext>
             </a:extLst>
           </p:cNvPr>
@@ -2618,7 +2618,7 @@
           <p:cNvPr id="2" name="Left column">
             <a:extLst xmlns:a="http://schemas.openxmlformats.org/drawingml/2006/main">
               <a:ext uri="{FF2B5EF4-FFF2-40B4-BE49-F238E27FC236}">
-                <a16:creationId xmlns:a16="http://schemas.microsoft.com/office/drawing/2014/main" id="{2DE6CFAD-8C85-43A2-968E-62AAB1A15F7E}"/>
+                <a16:creationId xmlns:a16="http://schemas.microsoft.com/office/drawing/2014/main" id="{C8D7D895-8EE3-4269-BD22-61C8E6BAFDC0}"/>
               </a:ext>
             </a:extLst>
           </p:cNvPr>
@@ -2885,12 +2885,12 @@
   </p:cSld>
   <p:clrMap bg1="lt1" tx1="dk1" bg2="lt2" tx2="dk2" accent1="accent1" accent2="accent2" accent3="accent3" accent4="accent4" accent5="accent5" accent6="accent6" hlink="hlink" folHlink="folHlink"/>
   <p:sldLayoutIdLst>
-    <p:sldLayoutId xmlns:r="http://schemas.openxmlformats.org/officeDocument/2006/relationships" id="2147483649" r:id="R1f60f0ded9034f6b"/>
-    <p:sldLayoutId xmlns:r="http://schemas.openxmlformats.org/officeDocument/2006/relationships" id="2147483650" r:id="Rb54d3af20ef84be9"/>
-    <p:sldLayoutId xmlns:r="http://schemas.openxmlformats.org/officeDocument/2006/relationships" id="2147483651" r:id="R05087f3bbfb347a5"/>
-    <p:sldLayoutId xmlns:r="http://schemas.openxmlformats.org/officeDocument/2006/relationships" id="2147483652" r:id="Ra9f3dc87f8584bb7"/>
-    <p:sldLayoutId xmlns:r="http://schemas.openxmlformats.org/officeDocument/2006/relationships" id="2147483653" r:id="Rc9f11f8eca024695"/>
-    <p:sldLayoutId xmlns:r="http://schemas.openxmlformats.org/officeDocument/2006/relationships" id="2147483654" r:id="Rf5144ccf0c2f4f2a"/>
+    <p:sldLayoutId xmlns:r="http://schemas.openxmlformats.org/officeDocument/2006/relationships" id="2147483649" r:id="R6543d032034d4c8f"/>
+    <p:sldLayoutId xmlns:r="http://schemas.openxmlformats.org/officeDocument/2006/relationships" id="2147483650" r:id="R5cd30cb2624d4a8c"/>
+    <p:sldLayoutId xmlns:r="http://schemas.openxmlformats.org/officeDocument/2006/relationships" id="2147483651" r:id="R37d4214cf38d4ece"/>
+    <p:sldLayoutId xmlns:r="http://schemas.openxmlformats.org/officeDocument/2006/relationships" id="2147483652" r:id="R55f31ccb64f847b2"/>
+    <p:sldLayoutId xmlns:r="http://schemas.openxmlformats.org/officeDocument/2006/relationships" id="2147483653" r:id="R9a85a067869f41d5"/>
+    <p:sldLayoutId xmlns:r="http://schemas.openxmlformats.org/officeDocument/2006/relationships" id="2147483654" r:id="Rf8db2a51d3ba4cae"/>
   </p:sldLayoutIdLst>
   <p:txStyles>
     <p:titleStyle>
@@ -3441,7 +3441,7 @@
           <p:cNvPr id="76" name="">
             <a:extLst xmlns:a="http://schemas.openxmlformats.org/drawingml/2006/main">
               <a:ext uri="{FF2B5EF4-FFF2-40B4-BE49-F238E27FC236}">
-                <a16:creationId xmlns:a16="http://schemas.microsoft.com/office/drawing/2014/main" id="{7DDBC1E5-11EC-4264-86F0-4D73BE6C60EE}"/>
+                <a16:creationId xmlns:a16="http://schemas.microsoft.com/office/drawing/2014/main" id="{2FFCBA37-F8D8-413A-A9E5-1B2FBDFA9B5A}"/>
               </a:ext>
             </a:extLst>
           </p:cNvPr>
@@ -3472,7 +3472,7 @@
           <p:cNvPr id="2" name="한국어 질의로 영어 학술·기술 문서를 검색하는">
             <a:extLst xmlns:a="http://schemas.openxmlformats.org/drawingml/2006/main">
               <a:ext uri="{FF2B5EF4-FFF2-40B4-BE49-F238E27FC236}">
-                <a16:creationId xmlns:a16="http://schemas.microsoft.com/office/drawing/2014/main" id="{2CF6C21B-E085-4FBC-8B30-21AF6DC6BE00}"/>
+                <a16:creationId xmlns:a16="http://schemas.microsoft.com/office/drawing/2014/main" id="{CF6A9EFE-9309-41D9-B0E6-08CBC2A0CEB4}"/>
               </a:ext>
             </a:extLst>
           </p:cNvPr>
@@ -3630,7 +3630,7 @@
           <p:cNvPr id="3" name="RAG에서의 HyDE·CAD·SCD 조합 실험">
             <a:extLst xmlns:a="http://schemas.openxmlformats.org/drawingml/2006/main">
               <a:ext uri="{FF2B5EF4-FFF2-40B4-BE49-F238E27FC236}">
-                <a16:creationId xmlns:a16="http://schemas.microsoft.com/office/drawing/2014/main" id="{8BBF0810-01B4-4D75-8ACB-8A99638F984C}"/>
+                <a16:creationId xmlns:a16="http://schemas.microsoft.com/office/drawing/2014/main" id="{8229CE57-BF15-49C3-80FE-4CA3BBE844CB}"/>
               </a:ext>
             </a:extLst>
           </p:cNvPr>
@@ -3788,7 +3788,7 @@
           <p:cNvPr id="4" name="문종건 · 동국대학교 WISE캠퍼스 컴퓨터공학과 · 지도교수 김진석 · 2026.10.15">
             <a:extLst xmlns:a="http://schemas.openxmlformats.org/drawingml/2006/main">
               <a:ext uri="{FF2B5EF4-FFF2-40B4-BE49-F238E27FC236}">
-                <a16:creationId xmlns:a16="http://schemas.microsoft.com/office/drawing/2014/main" id="{2313F6F6-C728-497B-889B-8CE8987F9CBC}"/>
+                <a16:creationId xmlns:a16="http://schemas.microsoft.com/office/drawing/2014/main" id="{8121914F-3FC7-47FC-B553-17AF615186E2}"/>
               </a:ext>
             </a:extLst>
           </p:cNvPr>
@@ -3946,7 +3946,7 @@
           <p:cNvPr id="5" name="">
             <a:extLst xmlns:a="http://schemas.openxmlformats.org/drawingml/2006/main">
               <a:ext uri="{FF2B5EF4-FFF2-40B4-BE49-F238E27FC236}">
-                <a16:creationId xmlns:a16="http://schemas.microsoft.com/office/drawing/2014/main" id="{F23FD162-E6FE-45F4-A9CB-5EDCAE044FE1}"/>
+                <a16:creationId xmlns:a16="http://schemas.microsoft.com/office/drawing/2014/main" id="{98B09A36-D7BA-420F-B178-6486DBFE3C85}"/>
               </a:ext>
             </a:extLst>
           </p:cNvPr>
@@ -3977,7 +3977,7 @@
           <p:cNvPr id="6" name="01 연구 배경과 목적">
             <a:extLst xmlns:a="http://schemas.openxmlformats.org/drawingml/2006/main">
               <a:ext uri="{FF2B5EF4-FFF2-40B4-BE49-F238E27FC236}">
-                <a16:creationId xmlns:a16="http://schemas.microsoft.com/office/drawing/2014/main" id="{C2CAA2EF-A643-4DC9-8684-E5B981AAE592}"/>
+                <a16:creationId xmlns:a16="http://schemas.microsoft.com/office/drawing/2014/main" id="{A82D139F-A585-4C95-8778-0CA0C6DFB7BF}"/>
               </a:ext>
             </a:extLst>
           </p:cNvPr>
@@ -4135,7 +4135,7 @@
           <p:cNvPr id="7" name="검색 증강 생성(Retrieval-Augmented Generation, RAG)은 관련 문서 구간을 검색하고 그 텍">
             <a:extLst xmlns:a="http://schemas.openxmlformats.org/drawingml/2006/main">
               <a:ext uri="{FF2B5EF4-FFF2-40B4-BE49-F238E27FC236}">
-                <a16:creationId xmlns:a16="http://schemas.microsoft.com/office/drawing/2014/main" id="{5F147FA8-2BDD-4566-AB38-91B67205580D}"/>
+                <a16:creationId xmlns:a16="http://schemas.microsoft.com/office/drawing/2014/main" id="{EB6A7530-B94A-4EF1-90B3-61CB5257263A}"/>
               </a:ext>
             </a:extLst>
           </p:cNvPr>
@@ -4316,7 +4316,7 @@
           <p:cNvPr id="8" name="HyDE: 가상 문서 임베딩(Hypothetical Document Embeddings) 가상 문서 검색 입력 구성[">
             <a:extLst xmlns:a="http://schemas.openxmlformats.org/drawingml/2006/main">
               <a:ext uri="{FF2B5EF4-FFF2-40B4-BE49-F238E27FC236}">
-                <a16:creationId xmlns:a16="http://schemas.microsoft.com/office/drawing/2014/main" id="{A45F7719-E4B1-4D0E-9E1B-C09BE6212C7E}"/>
+                <a16:creationId xmlns:a16="http://schemas.microsoft.com/office/drawing/2014/main" id="{9AF43210-6670-4D94-A512-60E4E6B87B58}"/>
               </a:ext>
             </a:extLst>
           </p:cNvPr>
@@ -4589,7 +4589,7 @@
           <p:cNvPr id="9" name="한국어 질의–영어 문서 RAG는 검색 어휘 차이, 근거 반영, 영어 출력(언어 이탈)의 문제를 함께 겪는다. 세 기법">
             <a:extLst xmlns:a="http://schemas.openxmlformats.org/drawingml/2006/main">
               <a:ext uri="{FF2B5EF4-FFF2-40B4-BE49-F238E27FC236}">
-                <a16:creationId xmlns:a16="http://schemas.microsoft.com/office/drawing/2014/main" id="{EB97F40D-DBF6-42FC-9C01-A4BCF26C2E96}"/>
+                <a16:creationId xmlns:a16="http://schemas.microsoft.com/office/drawing/2014/main" id="{05CB1B7C-BA96-4FBE-9C4D-C6B3BC628399}"/>
               </a:ext>
             </a:extLst>
           </p:cNvPr>
@@ -4793,7 +4793,7 @@
           <p:cNvPr id="10" name="">
             <a:extLst xmlns:a="http://schemas.openxmlformats.org/drawingml/2006/main">
               <a:ext uri="{FF2B5EF4-FFF2-40B4-BE49-F238E27FC236}">
-                <a16:creationId xmlns:a16="http://schemas.microsoft.com/office/drawing/2014/main" id="{A2CDC6DC-5954-4C46-A4EE-365ED29BE15E}"/>
+                <a16:creationId xmlns:a16="http://schemas.microsoft.com/office/drawing/2014/main" id="{3029337B-1C3E-4E8A-A20B-25BCA4D2E4F0}"/>
               </a:ext>
             </a:extLst>
           </p:cNvPr>
@@ -4824,7 +4824,7 @@
           <p:cNvPr id="11" name="02 Paper-RAG 구조와 기법 적용 위치">
             <a:extLst xmlns:a="http://schemas.openxmlformats.org/drawingml/2006/main">
               <a:ext uri="{FF2B5EF4-FFF2-40B4-BE49-F238E27FC236}">
-                <a16:creationId xmlns:a16="http://schemas.microsoft.com/office/drawing/2014/main" id="{62C38AF6-1253-4D6A-AC7B-1307FF33F75D}"/>
+                <a16:creationId xmlns:a16="http://schemas.microsoft.com/office/drawing/2014/main" id="{2892CED4-99A6-4385-BD92-D7FDD0883291}"/>
               </a:ext>
             </a:extLst>
           </p:cNvPr>
@@ -4982,7 +4982,7 @@
           <p:cNvPr id="12" name="Paper-RAG는 실험에 사용한 고정 검색·생성 파이프라인이다.">
             <a:extLst xmlns:a="http://schemas.openxmlformats.org/drawingml/2006/main">
               <a:ext uri="{FF2B5EF4-FFF2-40B4-BE49-F238E27FC236}">
-                <a16:creationId xmlns:a16="http://schemas.microsoft.com/office/drawing/2014/main" id="{2946413C-2FBF-44EE-B3D8-2DA83DE7EE62}"/>
+                <a16:creationId xmlns:a16="http://schemas.microsoft.com/office/drawing/2014/main" id="{13A10CF4-65B0-49FC-A74D-8937610525C9}"/>
               </a:ext>
             </a:extLst>
           </p:cNvPr>
@@ -5140,7 +5140,7 @@
           <p:cNvPr id="13" name="">
             <a:extLst xmlns:a="http://schemas.openxmlformats.org/drawingml/2006/main">
               <a:ext uri="{FF2B5EF4-FFF2-40B4-BE49-F238E27FC236}">
-                <a16:creationId xmlns:a16="http://schemas.microsoft.com/office/drawing/2014/main" id="{19B9C244-15B9-4843-9945-97BDAA6CF0C1}"/>
+                <a16:creationId xmlns:a16="http://schemas.microsoft.com/office/drawing/2014/main" id="{BAE41FC7-0000-4C3C-BEB4-DCE88E033285}"/>
               </a:ext>
             </a:extLst>
           </p:cNvPr>
@@ -5173,7 +5173,7 @@
           <p:cNvPr id="14" name="한국어 질의 HyDE OFF: 원질의 HyDE ON: 영어 번역·가상 문서">
             <a:extLst xmlns:a="http://schemas.openxmlformats.org/drawingml/2006/main">
               <a:ext uri="{FF2B5EF4-FFF2-40B4-BE49-F238E27FC236}">
-                <a16:creationId xmlns:a16="http://schemas.microsoft.com/office/drawing/2014/main" id="{F622BCE3-CDE8-40A1-AC25-2AEC832302E1}"/>
+                <a16:creationId xmlns:a16="http://schemas.microsoft.com/office/drawing/2014/main" id="{795980B4-227C-42FB-A623-F1056DA6DD85}"/>
               </a:ext>
             </a:extLst>
           </p:cNvPr>
@@ -5377,7 +5377,7 @@
           <p:cNvPr id="15" name="">
             <a:extLst xmlns:a="http://schemas.openxmlformats.org/drawingml/2006/main">
               <a:ext uri="{FF2B5EF4-FFF2-40B4-BE49-F238E27FC236}">
-                <a16:creationId xmlns:a16="http://schemas.microsoft.com/office/drawing/2014/main" id="{053DFD87-1233-4A3F-9594-BEC167988E3F}"/>
+                <a16:creationId xmlns:a16="http://schemas.microsoft.com/office/drawing/2014/main" id="{7DC758B2-E228-43FE-BA10-AECD8326B48E}"/>
               </a:ext>
             </a:extLst>
           </p:cNvPr>
@@ -5410,7 +5410,7 @@
           <p:cNvPr id="16" name="BM25 희소 검색[6] 한국어 원질의 사용">
             <a:extLst xmlns:a="http://schemas.openxmlformats.org/drawingml/2006/main">
               <a:ext uri="{FF2B5EF4-FFF2-40B4-BE49-F238E27FC236}">
-                <a16:creationId xmlns:a16="http://schemas.microsoft.com/office/drawing/2014/main" id="{ABBB11B8-CF77-48B6-96FF-90880EBACDA9}"/>
+                <a16:creationId xmlns:a16="http://schemas.microsoft.com/office/drawing/2014/main" id="{980EF8C8-B2E1-4568-AB51-E366E17BB52E}"/>
               </a:ext>
             </a:extLst>
           </p:cNvPr>
@@ -5591,7 +5591,7 @@
           <p:cNvPr id="17" name="">
             <a:extLst xmlns:a="http://schemas.openxmlformats.org/drawingml/2006/main">
               <a:ext uri="{FF2B5EF4-FFF2-40B4-BE49-F238E27FC236}">
-                <a16:creationId xmlns:a16="http://schemas.microsoft.com/office/drawing/2014/main" id="{0BFDC7CE-CCBF-4F05-B39D-4A43C8FF08CB}"/>
+                <a16:creationId xmlns:a16="http://schemas.microsoft.com/office/drawing/2014/main" id="{92C85F8A-1885-4837-A756-64BAF5E68915}"/>
               </a:ext>
             </a:extLst>
           </p:cNvPr>
@@ -5624,7 +5624,7 @@
           <p:cNvPr id="18" name="BGE-M3 밀집 검색[5]">
             <a:extLst xmlns:a="http://schemas.openxmlformats.org/drawingml/2006/main">
               <a:ext uri="{FF2B5EF4-FFF2-40B4-BE49-F238E27FC236}">
-                <a16:creationId xmlns:a16="http://schemas.microsoft.com/office/drawing/2014/main" id="{BC311CD6-D28F-4F1D-908C-16A33A7E1928}"/>
+                <a16:creationId xmlns:a16="http://schemas.microsoft.com/office/drawing/2014/main" id="{E79DB14E-7872-48D6-836E-2E6B3595167E}"/>
               </a:ext>
             </a:extLst>
           </p:cNvPr>
@@ -5782,7 +5782,7 @@
           <p:cNvPr id="19" name="">
             <a:extLst xmlns:a="http://schemas.openxmlformats.org/drawingml/2006/main">
               <a:ext uri="{FF2B5EF4-FFF2-40B4-BE49-F238E27FC236}">
-                <a16:creationId xmlns:a16="http://schemas.microsoft.com/office/drawing/2014/main" id="{C7223DBD-C1D5-463B-8F95-07D5239E345B}"/>
+                <a16:creationId xmlns:a16="http://schemas.microsoft.com/office/drawing/2014/main" id="{3379877C-BC1F-48A9-A684-457C75D642FE}"/>
               </a:ext>
             </a:extLst>
           </p:cNvPr>
@@ -5815,7 +5815,7 @@
           <p:cNvPr id="20" name="가중 RRF[7] 0.6 / 0.4, k=60">
             <a:extLst xmlns:a="http://schemas.openxmlformats.org/drawingml/2006/main">
               <a:ext uri="{FF2B5EF4-FFF2-40B4-BE49-F238E27FC236}">
-                <a16:creationId xmlns:a16="http://schemas.microsoft.com/office/drawing/2014/main" id="{42E02A47-9235-410F-BC20-EBE6725FA5C7}"/>
+                <a16:creationId xmlns:a16="http://schemas.microsoft.com/office/drawing/2014/main" id="{5F4E13D4-09F5-4FF5-9ED4-D1107D7FD10C}"/>
               </a:ext>
             </a:extLst>
           </p:cNvPr>
@@ -5996,7 +5996,7 @@
           <p:cNvPr id="21" name="">
             <a:extLst xmlns:a="http://schemas.openxmlformats.org/drawingml/2006/main">
               <a:ext uri="{FF2B5EF4-FFF2-40B4-BE49-F238E27FC236}">
-                <a16:creationId xmlns:a16="http://schemas.microsoft.com/office/drawing/2014/main" id="{8B8EBC5E-9FCC-476F-8D0A-DD4335116A84}"/>
+                <a16:creationId xmlns:a16="http://schemas.microsoft.com/office/drawing/2014/main" id="{4D0EA997-5400-4A4F-A43A-AF16996CC915}"/>
               </a:ext>
             </a:extLst>
           </p:cNvPr>
@@ -6028,7 +6028,7 @@
           <p:cNvPr id="22" name="">
             <a:extLst xmlns:a="http://schemas.openxmlformats.org/drawingml/2006/main">
               <a:ext uri="{FF2B5EF4-FFF2-40B4-BE49-F238E27FC236}">
-                <a16:creationId xmlns:a16="http://schemas.microsoft.com/office/drawing/2014/main" id="{3FD3FE97-E9E5-4DFD-8317-2CE1D8FFF96F}"/>
+                <a16:creationId xmlns:a16="http://schemas.microsoft.com/office/drawing/2014/main" id="{26E4E3E8-67ED-45D4-8ED4-C5B5FE70B124}"/>
               </a:ext>
             </a:extLst>
           </p:cNvPr>
@@ -6060,7 +6060,7 @@
           <p:cNvPr id="23" name="">
             <a:extLst xmlns:a="http://schemas.openxmlformats.org/drawingml/2006/main">
               <a:ext uri="{FF2B5EF4-FFF2-40B4-BE49-F238E27FC236}">
-                <a16:creationId xmlns:a16="http://schemas.microsoft.com/office/drawing/2014/main" id="{FD7C67A9-3A28-4A2D-981B-70A9497B5CE3}"/>
+                <a16:creationId xmlns:a16="http://schemas.microsoft.com/office/drawing/2014/main" id="{00541AF2-3412-49F4-93F8-9AE4EFE18C72}"/>
               </a:ext>
             </a:extLst>
           </p:cNvPr>
@@ -6092,7 +6092,7 @@
           <p:cNvPr id="24" name="">
             <a:extLst xmlns:a="http://schemas.openxmlformats.org/drawingml/2006/main">
               <a:ext uri="{FF2B5EF4-FFF2-40B4-BE49-F238E27FC236}">
-                <a16:creationId xmlns:a16="http://schemas.microsoft.com/office/drawing/2014/main" id="{A036E9F2-9F1D-4611-BFC3-41DE23A07634}"/>
+                <a16:creationId xmlns:a16="http://schemas.microsoft.com/office/drawing/2014/main" id="{0336B8BC-4E9A-4C21-9FEB-09AE5EC69971}"/>
               </a:ext>
             </a:extLst>
           </p:cNvPr>
@@ -6125,7 +6125,7 @@
           <p:cNvPr id="25" name="원질의·구간 쌍 CrossEncoder 재정렬[8][M2] 상위 5개 구간 선택·입력 길이 관리">
             <a:extLst xmlns:a="http://schemas.openxmlformats.org/drawingml/2006/main">
               <a:ext uri="{FF2B5EF4-FFF2-40B4-BE49-F238E27FC236}">
-                <a16:creationId xmlns:a16="http://schemas.microsoft.com/office/drawing/2014/main" id="{A0ED452E-C2A3-4CF9-B091-1CBC6DF62573}"/>
+                <a16:creationId xmlns:a16="http://schemas.microsoft.com/office/drawing/2014/main" id="{9C29ECE3-36F5-48C7-8DBD-F64944535806}"/>
               </a:ext>
             </a:extLst>
           </p:cNvPr>
@@ -6306,7 +6306,7 @@
           <p:cNvPr id="26" name="">
             <a:extLst xmlns:a="http://schemas.openxmlformats.org/drawingml/2006/main">
               <a:ext uri="{FF2B5EF4-FFF2-40B4-BE49-F238E27FC236}">
-                <a16:creationId xmlns:a16="http://schemas.microsoft.com/office/drawing/2014/main" id="{052BDE01-5338-4F1D-9563-CC39949503D2}"/>
+                <a16:creationId xmlns:a16="http://schemas.microsoft.com/office/drawing/2014/main" id="{368EC72F-991D-4D8A-8AC6-AB92F94E3C9B}"/>
               </a:ext>
             </a:extLst>
           </p:cNvPr>
@@ -6339,7 +6339,7 @@
           <p:cNvPr id="27" name="Mi:dm 2.0 Base Instruct[M1] CAD 로짓 결합 후 SCD 언어별 조정, 최종 답변 생성">
             <a:extLst xmlns:a="http://schemas.openxmlformats.org/drawingml/2006/main">
               <a:ext uri="{FF2B5EF4-FFF2-40B4-BE49-F238E27FC236}">
-                <a16:creationId xmlns:a16="http://schemas.microsoft.com/office/drawing/2014/main" id="{BA8A9FC7-6D6C-41A5-8243-80100D13252E}"/>
+                <a16:creationId xmlns:a16="http://schemas.microsoft.com/office/drawing/2014/main" id="{386CB12E-7775-4250-8935-730C1362D5A1}"/>
               </a:ext>
             </a:extLst>
           </p:cNvPr>
@@ -6520,7 +6520,7 @@
           <p:cNvPr id="28" name="">
             <a:extLst xmlns:a="http://schemas.openxmlformats.org/drawingml/2006/main">
               <a:ext uri="{FF2B5EF4-FFF2-40B4-BE49-F238E27FC236}">
-                <a16:creationId xmlns:a16="http://schemas.microsoft.com/office/drawing/2014/main" id="{14354F1F-4B89-4781-AC78-F19B65F36CB0}"/>
+                <a16:creationId xmlns:a16="http://schemas.microsoft.com/office/drawing/2014/main" id="{D4213171-B882-4476-BE6E-85A35C5523B7}"/>
               </a:ext>
             </a:extLst>
           </p:cNvPr>
@@ -6552,7 +6552,7 @@
           <p:cNvPr id="29" name="">
             <a:extLst xmlns:a="http://schemas.openxmlformats.org/drawingml/2006/main">
               <a:ext uri="{FF2B5EF4-FFF2-40B4-BE49-F238E27FC236}">
-                <a16:creationId xmlns:a16="http://schemas.microsoft.com/office/drawing/2014/main" id="{7AC54586-7A9D-4D76-909D-1212D2BBC287}"/>
+                <a16:creationId xmlns:a16="http://schemas.microsoft.com/office/drawing/2014/main" id="{5ACECB89-D444-434C-A688-9DEDEF258D10}"/>
               </a:ext>
             </a:extLst>
           </p:cNvPr>
@@ -6584,7 +6584,7 @@
           <p:cNvPr id="30" name="">
             <a:extLst xmlns:a="http://schemas.openxmlformats.org/drawingml/2006/main">
               <a:ext uri="{FF2B5EF4-FFF2-40B4-BE49-F238E27FC236}">
-                <a16:creationId xmlns:a16="http://schemas.microsoft.com/office/drawing/2014/main" id="{72222C0E-2B02-44C9-B807-5B6BE468252C}"/>
+                <a16:creationId xmlns:a16="http://schemas.microsoft.com/office/drawing/2014/main" id="{3423C963-8242-4C34-BFA3-ED8F9DB78FAB}"/>
               </a:ext>
             </a:extLst>
           </p:cNvPr>
@@ -6615,7 +6615,7 @@
           <p:cNvPr id="31" name="03 3요인 완전요인 실험 설계">
             <a:extLst xmlns:a="http://schemas.openxmlformats.org/drawingml/2006/main">
               <a:ext uri="{FF2B5EF4-FFF2-40B4-BE49-F238E27FC236}">
-                <a16:creationId xmlns:a16="http://schemas.microsoft.com/office/drawing/2014/main" id="{94AE48EC-342C-4BA7-ADDB-A47541147896}"/>
+                <a16:creationId xmlns:a16="http://schemas.microsoft.com/office/drawing/2014/main" id="{4B0C7AC3-600C-46B2-AC18-8E09B2772B53}"/>
               </a:ext>
             </a:extLst>
           </p:cNvPr>
@@ -6773,7 +6773,7 @@
           <p:cNvPr id="32" name="H=HyDE, C=CAD, S=SCD   0=미적용, 1=적용">
             <a:extLst xmlns:a="http://schemas.openxmlformats.org/drawingml/2006/main">
               <a:ext uri="{FF2B5EF4-FFF2-40B4-BE49-F238E27FC236}">
-                <a16:creationId xmlns:a16="http://schemas.microsoft.com/office/drawing/2014/main" id="{5EC852D3-B192-4764-9CA6-BEAA9E8068E9}"/>
+                <a16:creationId xmlns:a16="http://schemas.microsoft.com/office/drawing/2014/main" id="{F7296614-64AC-4133-8F1B-7C78554DF43F}"/>
               </a:ext>
             </a:extLst>
           </p:cNvPr>
@@ -6931,7 +6931,7 @@
           <p:cNvPr id="33" name="">
             <a:extLst xmlns:a="http://schemas.openxmlformats.org/drawingml/2006/main">
               <a:ext uri="{FF2B5EF4-FFF2-40B4-BE49-F238E27FC236}">
-                <a16:creationId xmlns:a16="http://schemas.microsoft.com/office/drawing/2014/main" id="{4A773E95-A37F-41D7-8DDC-AB5530DE49B7}"/>
+                <a16:creationId xmlns:a16="http://schemas.microsoft.com/office/drawing/2014/main" id="{CB38EC8E-C0DE-4102-B6A4-FE68EF3AB2AE}"/>
               </a:ext>
             </a:extLst>
           </p:cNvPr>
@@ -8461,7 +8461,7 @@
           <p:cNvPr id="34" name="같은 질의 60개 × 8조건 반복측정 = 480개 생성 기록">
             <a:extLst xmlns:a="http://schemas.openxmlformats.org/drawingml/2006/main">
               <a:ext uri="{FF2B5EF4-FFF2-40B4-BE49-F238E27FC236}">
-                <a16:creationId xmlns:a16="http://schemas.microsoft.com/office/drawing/2014/main" id="{D4F54AAC-AA7C-4AA8-B9B5-055A817CF194}"/>
+                <a16:creationId xmlns:a16="http://schemas.microsoft.com/office/drawing/2014/main" id="{C00A9B81-3677-4337-8A34-32E9D8DB4C37}"/>
               </a:ext>
             </a:extLst>
           </p:cNvPr>
@@ -8619,7 +8619,7 @@
           <p:cNvPr id="35" name="생성 512토큰, CAD α=0.5, SCD α=1.1·β=0.9·Tstart=5">
             <a:extLst xmlns:a="http://schemas.openxmlformats.org/drawingml/2006/main">
               <a:ext uri="{FF2B5EF4-FFF2-40B4-BE49-F238E27FC236}">
-                <a16:creationId xmlns:a16="http://schemas.microsoft.com/office/drawing/2014/main" id="{1F4A2435-F7C6-40F0-A5A3-6EC49D072E29}"/>
+                <a16:creationId xmlns:a16="http://schemas.microsoft.com/office/drawing/2014/main" id="{31E06A9F-EFAD-4722-A4AA-B2664CBC8179}"/>
               </a:ext>
             </a:extLst>
           </p:cNvPr>
@@ -8777,7 +8777,7 @@
           <p:cNvPr id="36" name="문서마다 주요 내용을 15개 단위로 요약해 단위별 질의를 작성하고, 총 60개 질의의 원문 페이지·정답 근거·답변 가">
             <a:extLst xmlns:a="http://schemas.openxmlformats.org/drawingml/2006/main">
               <a:ext uri="{FF2B5EF4-FFF2-40B4-BE49-F238E27FC236}">
-                <a16:creationId xmlns:a16="http://schemas.microsoft.com/office/drawing/2014/main" id="{C4F2748D-DCA3-4DAC-9007-CEEB1963C77A}"/>
+                <a16:creationId xmlns:a16="http://schemas.microsoft.com/office/drawing/2014/main" id="{8A5A6229-6977-4288-90AB-2022F9442D7A}"/>
               </a:ext>
             </a:extLst>
           </p:cNvPr>
@@ -8958,7 +8958,7 @@
           <p:cNvPr id="37" name="">
             <a:extLst xmlns:a="http://schemas.openxmlformats.org/drawingml/2006/main">
               <a:ext uri="{FF2B5EF4-FFF2-40B4-BE49-F238E27FC236}">
-                <a16:creationId xmlns:a16="http://schemas.microsoft.com/office/drawing/2014/main" id="{260B7A32-207C-4841-ABD0-2E7D29AE0DCF}"/>
+                <a16:creationId xmlns:a16="http://schemas.microsoft.com/office/drawing/2014/main" id="{6538A734-E8FC-45E0-B051-76F6BE12F661}"/>
               </a:ext>
             </a:extLst>
           </p:cNvPr>
@@ -8989,7 +8989,7 @@
           <p:cNvPr id="38" name="04 평가 지표 및 실험·통계 방법">
             <a:extLst xmlns:a="http://schemas.openxmlformats.org/drawingml/2006/main">
               <a:ext uri="{FF2B5EF4-FFF2-40B4-BE49-F238E27FC236}">
-                <a16:creationId xmlns:a16="http://schemas.microsoft.com/office/drawing/2014/main" id="{1BEFB309-50C9-4879-B124-470919C6FDAC}"/>
+                <a16:creationId xmlns:a16="http://schemas.microsoft.com/office/drawing/2014/main" id="{42350E51-28E2-4290-87E7-5CCC12CF1398}"/>
               </a:ext>
             </a:extLst>
           </p:cNvPr>
@@ -9147,7 +9147,7 @@
           <p:cNvPr id="39" name="근거 충실도: 높을수록 검색 결과가 뒷받침하는 답변 주장 비율이 크다. 답변 관련성: 높을수록 답변 기반 질문과 원질">
             <a:extLst xmlns:a="http://schemas.openxmlformats.org/drawingml/2006/main">
               <a:ext uri="{FF2B5EF4-FFF2-40B4-BE49-F238E27FC236}">
-                <a16:creationId xmlns:a16="http://schemas.microsoft.com/office/drawing/2014/main" id="{E72B5B61-6ED9-4961-9089-E50F16E0BE15}"/>
+                <a16:creationId xmlns:a16="http://schemas.microsoft.com/office/drawing/2014/main" id="{0FC12234-BB8E-42E8-BDD8-10CCFAE0CF46}"/>
               </a:ext>
             </a:extLst>
           </p:cNvPr>
@@ -9394,10 +9394,10 @@
       </p:sp>
       <p:sp>
         <p:nvSpPr>
-          <p:cNvPr id="40" name="품질 관측값은 0~1이다. 차이는 ON−OFF 평균 차이다. 한국어 비율 0.700은 70.0%, 차이 +0.218은">
+          <p:cNvPr id="40" name="품질 관측값은 0~1이다. 차이 = ON − OFF 평균. 한국어 비율 0.700은 70.0%, 차이 +0.218은 ">
             <a:extLst xmlns:a="http://schemas.openxmlformats.org/drawingml/2006/main">
               <a:ext uri="{FF2B5EF4-FFF2-40B4-BE49-F238E27FC236}">
-                <a16:creationId xmlns:a16="http://schemas.microsoft.com/office/drawing/2014/main" id="{978329CF-3F40-4C48-AD4D-46276CB81490}"/>
+                <a16:creationId xmlns:a16="http://schemas.microsoft.com/office/drawing/2014/main" id="{052DBE33-B6D7-4FF5-BC2E-FE9919F45C6A}"/>
               </a:ext>
             </a:extLst>
           </p:cNvPr>
@@ -9545,7 +9545,7 @@
                 <a:ea typeface="Malgun Gothic"/>
                 <a:cs typeface="Malgun Gothic"/>
               </a:rPr>
-              <a:t>품질 관측값은 0~1이다. 차이는 ON−OFF 평균 차이다.</a:t>
+              <a:t>품질 관측값은 0~1이다. 차이 = ON − OFF 평균.</a:t>
             </a:r>
           </a:p>
           <a:p xmlns:a="http://schemas.openxmlformats.org/drawingml/2006/main">
@@ -9578,7 +9578,7 @@
           <p:cNvPr id="41" name="평가 예시  ext_raptor_011, H0C0S0">
             <a:extLst xmlns:a="http://schemas.openxmlformats.org/drawingml/2006/main">
               <a:ext uri="{FF2B5EF4-FFF2-40B4-BE49-F238E27FC236}">
-                <a16:creationId xmlns:a16="http://schemas.microsoft.com/office/drawing/2014/main" id="{70F0298E-F1E8-4DE7-8BA6-DA9947DA23FE}"/>
+                <a16:creationId xmlns:a16="http://schemas.microsoft.com/office/drawing/2014/main" id="{42463BC7-C840-4FFE-9853-E1E98292BC87}"/>
               </a:ext>
             </a:extLst>
           </p:cNvPr>
@@ -9736,7 +9736,7 @@
           <p:cNvPr id="42" name="질문: Cinderella 사례의 정성 분석에서 RAPTOR의 tree-based retrieval이 DPR보다 주제">
             <a:extLst xmlns:a="http://schemas.openxmlformats.org/drawingml/2006/main">
               <a:ext uri="{FF2B5EF4-FFF2-40B4-BE49-F238E27FC236}">
-                <a16:creationId xmlns:a16="http://schemas.microsoft.com/office/drawing/2014/main" id="{9BD9AA2A-426D-4049-92BF-EDF6FC27791E}"/>
+                <a16:creationId xmlns:a16="http://schemas.microsoft.com/office/drawing/2014/main" id="{D3195CCF-9D16-4A11-8D07-41D841788435}"/>
               </a:ext>
             </a:extLst>
           </p:cNvPr>
@@ -9917,7 +9917,7 @@
           <p:cNvPr id="43" name="검색 근거(PDF p.9): “By providing both the original text and higher-l">
             <a:extLst xmlns:a="http://schemas.openxmlformats.org/drawingml/2006/main">
               <a:ext uri="{FF2B5EF4-FFF2-40B4-BE49-F238E27FC236}">
-                <a16:creationId xmlns:a16="http://schemas.microsoft.com/office/drawing/2014/main" id="{3CAB2510-DC34-47A4-84ED-982C9A1BE75D}"/>
+                <a16:creationId xmlns:a16="http://schemas.microsoft.com/office/drawing/2014/main" id="{8759FD28-866F-42A1-A29E-61ED7741BF01}"/>
               </a:ext>
             </a:extLst>
           </p:cNvPr>
@@ -10121,7 +10121,7 @@
           <p:cNvPr id="44" name="참조 답변 요지(PDF p.20): RAPTOR는 이야기의 주요 부분을, DPR은 이야기의 좁은 일부를 자세히 검색한">
             <a:extLst xmlns:a="http://schemas.openxmlformats.org/drawingml/2006/main">
               <a:ext uri="{FF2B5EF4-FFF2-40B4-BE49-F238E27FC236}">
-                <a16:creationId xmlns:a16="http://schemas.microsoft.com/office/drawing/2014/main" id="{0C264AC3-4781-4E1C-B119-BF5365E8F10D}"/>
+                <a16:creationId xmlns:a16="http://schemas.microsoft.com/office/drawing/2014/main" id="{154FEC9A-6A38-417F-9D52-30F629604C78}"/>
               </a:ext>
             </a:extLst>
           </p:cNvPr>
@@ -10302,7 +10302,7 @@
           <p:cNvPr id="45" name="생성 답변 발췌: “질문의 요구사항에 따라 서로 다른 층위(layer)에서 노드를 선택할 수 있습니다.”">
             <a:extLst xmlns:a="http://schemas.openxmlformats.org/drawingml/2006/main">
               <a:ext uri="{FF2B5EF4-FFF2-40B4-BE49-F238E27FC236}">
-                <a16:creationId xmlns:a16="http://schemas.microsoft.com/office/drawing/2014/main" id="{C5270960-255F-481D-811B-69FC61A2DC0E}"/>
+                <a16:creationId xmlns:a16="http://schemas.microsoft.com/office/drawing/2014/main" id="{A5843330-FCC8-473E-B9C8-72232576A19E}"/>
               </a:ext>
             </a:extLst>
           </p:cNvPr>
@@ -10483,7 +10483,7 @@
           <p:cNvPr id="46" name="충실도 1.000: 추출된 답변 주장을 검색 결과가 모두 지지 관련성 0.937: 답변 기반 질문과 원질문의 평균 의">
             <a:extLst xmlns:a="http://schemas.openxmlformats.org/drawingml/2006/main">
               <a:ext uri="{FF2B5EF4-FFF2-40B4-BE49-F238E27FC236}">
-                <a16:creationId xmlns:a16="http://schemas.microsoft.com/office/drawing/2014/main" id="{71F80C61-FDA2-4789-9E3B-DA0A9D988ABF}"/>
+                <a16:creationId xmlns:a16="http://schemas.microsoft.com/office/drawing/2014/main" id="{C7D6F98D-F8B2-4BCD-8DB6-5D8BD9C181FC}"/>
               </a:ext>
             </a:extLst>
           </p:cNvPr>
@@ -10664,7 +10664,7 @@
           <p:cNvPr id="47" name="평가: RAGAS 0.2.15[10]·gpt-4o·BGE-M3, 저장 답변 평가 평가 언어: S0 영어 / S1 한국">
             <a:extLst xmlns:a="http://schemas.openxmlformats.org/drawingml/2006/main">
               <a:ext uri="{FF2B5EF4-FFF2-40B4-BE49-F238E27FC236}">
-                <a16:creationId xmlns:a16="http://schemas.microsoft.com/office/drawing/2014/main" id="{B33B7512-F3AE-486E-9A70-327951CCBA2B}"/>
+                <a16:creationId xmlns:a16="http://schemas.microsoft.com/office/drawing/2014/main" id="{5071E758-DA13-4CB7-8950-D2EC90A992D2}"/>
               </a:ext>
             </a:extLst>
           </p:cNvPr>
@@ -10845,7 +10845,7 @@
           <p:cNvPr id="48" name="반복측정 분산분석(ANOVA)·대응 t-검정, 양측 α=0.05 품질: SCD 상태별 H×C / 한국어 비율·시간: ">
             <a:extLst xmlns:a="http://schemas.openxmlformats.org/drawingml/2006/main">
               <a:ext uri="{FF2B5EF4-FFF2-40B4-BE49-F238E27FC236}">
-                <a16:creationId xmlns:a16="http://schemas.microsoft.com/office/drawing/2014/main" id="{BDB5008C-77D3-4DB9-A45E-CC1D81C8AC41}"/>
+                <a16:creationId xmlns:a16="http://schemas.microsoft.com/office/drawing/2014/main" id="{5E57602E-2261-42A2-9DB3-1EFC285C0C68}"/>
               </a:ext>
             </a:extLst>
           </p:cNvPr>
@@ -11026,7 +11026,7 @@
           <p:cNvPr id="49" name="">
             <a:extLst xmlns:a="http://schemas.openxmlformats.org/drawingml/2006/main">
               <a:ext uri="{FF2B5EF4-FFF2-40B4-BE49-F238E27FC236}">
-                <a16:creationId xmlns:a16="http://schemas.microsoft.com/office/drawing/2014/main" id="{1974C881-D403-4C6B-B4A3-0D8881F39C10}"/>
+                <a16:creationId xmlns:a16="http://schemas.microsoft.com/office/drawing/2014/main" id="{EAD37014-39C4-4F6D-BAE7-0DECC6DEBAB1}"/>
               </a:ext>
             </a:extLst>
           </p:cNvPr>
@@ -11057,7 +11057,7 @@
           <p:cNvPr id="50" name="05 조합별 결과와 통계 검정">
             <a:extLst xmlns:a="http://schemas.openxmlformats.org/drawingml/2006/main">
               <a:ext uri="{FF2B5EF4-FFF2-40B4-BE49-F238E27FC236}">
-                <a16:creationId xmlns:a16="http://schemas.microsoft.com/office/drawing/2014/main" id="{95B6A686-9609-465C-8912-84C9284509A6}"/>
+                <a16:creationId xmlns:a16="http://schemas.microsoft.com/office/drawing/2014/main" id="{17283022-CED4-43EC-A4A4-3DCE02B09C3D}"/>
               </a:ext>
             </a:extLst>
           </p:cNvPr>
@@ -11215,7 +11215,7 @@
           <p:cNvPr id="51" name="HyDE·CAD·SCD 8조합의 품질·한국어 비율·시간 평균(SD)">
             <a:extLst xmlns:a="http://schemas.openxmlformats.org/drawingml/2006/main">
               <a:ext uri="{FF2B5EF4-FFF2-40B4-BE49-F238E27FC236}">
-                <a16:creationId xmlns:a16="http://schemas.microsoft.com/office/drawing/2014/main" id="{EA0DD159-F5DF-4613-80C8-6FFF91606DBA}"/>
+                <a16:creationId xmlns:a16="http://schemas.microsoft.com/office/drawing/2014/main" id="{F1BBD6C3-D66C-4D86-B241-5F385271F9FE}"/>
               </a:ext>
             </a:extLst>
           </p:cNvPr>
@@ -11373,7 +11373,7 @@
           <p:cNvPr id="52" name="">
             <a:extLst xmlns:a="http://schemas.openxmlformats.org/drawingml/2006/main">
               <a:ext uri="{FF2B5EF4-FFF2-40B4-BE49-F238E27FC236}">
-                <a16:creationId xmlns:a16="http://schemas.microsoft.com/office/drawing/2014/main" id="{6EE18D62-9C4C-4FD0-89A9-57CB2E134EB6}"/>
+                <a16:creationId xmlns:a16="http://schemas.microsoft.com/office/drawing/2014/main" id="{94A0EB5B-A82B-45D7-AF25-903592368B34}"/>
               </a:ext>
             </a:extLst>
           </p:cNvPr>
@@ -14733,7 +14733,7 @@
           <p:cNvPr id="53" name="">
             <a:extLst xmlns:a="http://schemas.openxmlformats.org/drawingml/2006/main">
               <a:ext uri="{FF2B5EF4-FFF2-40B4-BE49-F238E27FC236}">
-                <a16:creationId xmlns:a16="http://schemas.microsoft.com/office/drawing/2014/main" id="{0785FE23-E967-47BF-8A00-A526ED56788B}"/>
+                <a16:creationId xmlns:a16="http://schemas.microsoft.com/office/drawing/2014/main" id="{AA4F8771-8813-4F9F-A387-3EE67CBB3B7F}"/>
               </a:ext>
             </a:extLst>
           </p:cNvPr>
@@ -14764,7 +14764,7 @@
           <p:cNvPr id="54" name="S0: 영어로 평가 / S1: 한국어 번역으로 평가 충실도 H0C1S0 n=58, H0C0S1 n=57, 나머지 n=">
             <a:extLst xmlns:a="http://schemas.openxmlformats.org/drawingml/2006/main">
               <a:ext uri="{FF2B5EF4-FFF2-40B4-BE49-F238E27FC236}">
-                <a16:creationId xmlns:a16="http://schemas.microsoft.com/office/drawing/2014/main" id="{819B5E03-2B43-4114-A3FF-9B3CF9AFE6FE}"/>
+                <a16:creationId xmlns:a16="http://schemas.microsoft.com/office/drawing/2014/main" id="{314DD4E3-DD82-4F16-9D78-EC57094DE293}"/>
               </a:ext>
             </a:extLst>
           </p:cNvPr>
@@ -14958,7 +14958,7 @@
                 <a:ea typeface="Malgun Gothic"/>
                 <a:cs typeface="Malgun Gothic"/>
               </a:rPr>
-              <a:t>한국어 비율·시간(초)은 답변과 실행 시간에서 직접 계산</a:t>
+              <a:t>한국어 비율·시간(초)은 RAGAS를 거치지 않고 직접 계산</a:t>
             </a:r>
           </a:p>
         </p:txBody>
@@ -14968,7 +14968,7 @@
           <p:cNvPr id="55" name="3요인 반복측정 ANOVA  ·  각 효과 df=(1,59)">
             <a:extLst xmlns:a="http://schemas.openxmlformats.org/drawingml/2006/main">
               <a:ext uri="{FF2B5EF4-FFF2-40B4-BE49-F238E27FC236}">
-                <a16:creationId xmlns:a16="http://schemas.microsoft.com/office/drawing/2014/main" id="{8E0281FD-F93A-4A7F-BEE8-E2E954B41BDA}"/>
+                <a16:creationId xmlns:a16="http://schemas.microsoft.com/office/drawing/2014/main" id="{6BF9FBDC-A32F-4789-AACC-54C2D48499A7}"/>
               </a:ext>
             </a:extLst>
           </p:cNvPr>
@@ -15126,7 +15126,7 @@
           <p:cNvPr id="56" name="">
             <a:extLst xmlns:a="http://schemas.openxmlformats.org/drawingml/2006/main">
               <a:ext uri="{FF2B5EF4-FFF2-40B4-BE49-F238E27FC236}">
-                <a16:creationId xmlns:a16="http://schemas.microsoft.com/office/drawing/2014/main" id="{C473657E-1C4E-499D-AE6C-13E525359B5B}"/>
+                <a16:creationId xmlns:a16="http://schemas.microsoft.com/office/drawing/2014/main" id="{9DDDF60B-3C9A-47EA-83CD-A6842FECA7C9}"/>
               </a:ext>
             </a:extLst>
           </p:cNvPr>
@@ -16839,7 +16839,7 @@
           <p:cNvPr id="57" name="p&lt;0.05: 한국어 비율 S·H×C* / 실행 시간 H·C·S*·C×S (*유의수준 근처의 탐색적 결과) RAGAS">
             <a:extLst xmlns:a="http://schemas.openxmlformats.org/drawingml/2006/main">
               <a:ext uri="{FF2B5EF4-FFF2-40B4-BE49-F238E27FC236}">
-                <a16:creationId xmlns:a16="http://schemas.microsoft.com/office/drawing/2014/main" id="{C469F927-E94D-4D5C-99DD-6D6DE9271A04}"/>
+                <a16:creationId xmlns:a16="http://schemas.microsoft.com/office/drawing/2014/main" id="{2C380E27-FBC0-4C2D-90F9-B53370C8244B}"/>
               </a:ext>
             </a:extLst>
           </p:cNvPr>
@@ -17043,7 +17043,7 @@
           <p:cNvPr id="58" name="기법별 대응 비교  ·  질의별 평균 차이, 양측 검정">
             <a:extLst xmlns:a="http://schemas.openxmlformats.org/drawingml/2006/main">
               <a:ext uri="{FF2B5EF4-FFF2-40B4-BE49-F238E27FC236}">
-                <a16:creationId xmlns:a16="http://schemas.microsoft.com/office/drawing/2014/main" id="{59D98C1E-67BB-4DB0-B2F8-F458F43D239A}"/>
+                <a16:creationId xmlns:a16="http://schemas.microsoft.com/office/drawing/2014/main" id="{A9FDAFE2-6273-4DDF-8593-E035E82398A3}"/>
               </a:ext>
             </a:extLst>
           </p:cNvPr>
@@ -17201,7 +17201,7 @@
           <p:cNvPr id="59" name="">
             <a:extLst xmlns:a="http://schemas.openxmlformats.org/drawingml/2006/main">
               <a:ext uri="{FF2B5EF4-FFF2-40B4-BE49-F238E27FC236}">
-                <a16:creationId xmlns:a16="http://schemas.microsoft.com/office/drawing/2014/main" id="{A214632D-95AD-4F5B-A7E1-55689EC16105}"/>
+                <a16:creationId xmlns:a16="http://schemas.microsoft.com/office/drawing/2014/main" id="{9F6A9977-4B0B-4527-B348-A389D9023DE4}"/>
               </a:ext>
             </a:extLst>
           </p:cNvPr>
@@ -18214,7 +18214,7 @@
           <p:cNvPr id="60" name="HyDE: C0S0, CAD: H0S0, SCD: H0의 CAD 상태 평균 p: 다중비교 보정 없는 양측 p, dz:">
             <a:extLst xmlns:a="http://schemas.openxmlformats.org/drawingml/2006/main">
               <a:ext uri="{FF2B5EF4-FFF2-40B4-BE49-F238E27FC236}">
-                <a16:creationId xmlns:a16="http://schemas.microsoft.com/office/drawing/2014/main" id="{8213D86D-36C6-43AC-8A5A-8CE473BC1062}"/>
+                <a16:creationId xmlns:a16="http://schemas.microsoft.com/office/drawing/2014/main" id="{1E2E695C-A79C-4009-B989-D09346E70F7A}"/>
               </a:ext>
             </a:extLst>
           </p:cNvPr>
@@ -18418,7 +18418,7 @@
           <p:cNvPr id="61" name="">
             <a:extLst xmlns:a="http://schemas.openxmlformats.org/drawingml/2006/main">
               <a:ext uri="{FF2B5EF4-FFF2-40B4-BE49-F238E27FC236}">
-                <a16:creationId xmlns:a16="http://schemas.microsoft.com/office/drawing/2014/main" id="{178A86DF-D64B-4ACF-A40F-B761E7FC4CBE}"/>
+                <a16:creationId xmlns:a16="http://schemas.microsoft.com/office/drawing/2014/main" id="{175C7A03-AEDB-454E-B226-0987C1C27142}"/>
               </a:ext>
             </a:extLst>
           </p:cNvPr>
@@ -18449,7 +18449,7 @@
           <p:cNvPr id="62" name="06 결과 해석">
             <a:extLst xmlns:a="http://schemas.openxmlformats.org/drawingml/2006/main">
               <a:ext uri="{FF2B5EF4-FFF2-40B4-BE49-F238E27FC236}">
-                <a16:creationId xmlns:a16="http://schemas.microsoft.com/office/drawing/2014/main" id="{EB7F33E0-937C-455E-B3B4-99C1ABF60FF2}"/>
+                <a16:creationId xmlns:a16="http://schemas.microsoft.com/office/drawing/2014/main" id="{7E6AD3EF-65F1-4B1C-9845-DB45F2C9C7B6}"/>
               </a:ext>
             </a:extLst>
           </p:cNvPr>
@@ -18604,10 +18604,10 @@
       </p:sp>
       <p:sp>
         <p:nvSpPr>
-          <p:cNvPr id="63" name="HyDE: 기본 조건에서 관련성이 유의하게 높았고(p=0.029), SCD 적용 조건의 추가 비교에서는 p=0.114">
+          <p:cNvPr id="63" name="HyDE: 기본 조건에서 관련성이 유의하게 높았으나(p=0.029), SCD 적용 조건의 추가 비교에서는 p=0.11">
             <a:extLst xmlns:a="http://schemas.openxmlformats.org/drawingml/2006/main">
               <a:ext uri="{FF2B5EF4-FFF2-40B4-BE49-F238E27FC236}">
-                <a16:creationId xmlns:a16="http://schemas.microsoft.com/office/drawing/2014/main" id="{3251FDC8-A947-417F-8BEA-38BAD53D0BCC}"/>
+                <a16:creationId xmlns:a16="http://schemas.microsoft.com/office/drawing/2014/main" id="{391FEC8D-D043-4DE0-90DC-C32E507BC223}"/>
               </a:ext>
             </a:extLst>
           </p:cNvPr>
@@ -18755,7 +18755,7 @@
                 <a:ea typeface="Malgun Gothic"/>
                 <a:cs typeface="Malgun Gothic"/>
               </a:rPr>
-              <a:t>HyDE: 기본 조건에서 관련성이 유의하게 높았고(p=0.029),</a:t>
+              <a:t>HyDE: 기본 조건에서 관련성이 유의하게 높았으나(p=0.029),</a:t>
             </a:r>
           </a:p>
           <a:p xmlns:a="http://schemas.openxmlformats.org/drawingml/2006/main">
@@ -18857,7 +18857,7 @@
           <p:cNvPr id="64" name="">
             <a:extLst xmlns:a="http://schemas.openxmlformats.org/drawingml/2006/main">
               <a:ext uri="{FF2B5EF4-FFF2-40B4-BE49-F238E27FC236}">
-                <a16:creationId xmlns:a16="http://schemas.microsoft.com/office/drawing/2014/main" id="{44667C4C-20ED-40C2-AE18-B74E0F151612}"/>
+                <a16:creationId xmlns:a16="http://schemas.microsoft.com/office/drawing/2014/main" id="{1E4E6D9F-FF64-426C-9282-B1292F0EABA8}"/>
               </a:ext>
             </a:extLst>
           </p:cNvPr>
@@ -18888,7 +18888,7 @@
           <p:cNvPr id="65" name="07 결론">
             <a:extLst xmlns:a="http://schemas.openxmlformats.org/drawingml/2006/main">
               <a:ext uri="{FF2B5EF4-FFF2-40B4-BE49-F238E27FC236}">
-                <a16:creationId xmlns:a16="http://schemas.microsoft.com/office/drawing/2014/main" id="{A4CAB35E-3269-4A25-88BC-74FA9811A45A}"/>
+                <a16:creationId xmlns:a16="http://schemas.microsoft.com/office/drawing/2014/main" id="{2FC9ABC9-3D15-44CE-81B0-0F678545E477}"/>
               </a:ext>
             </a:extLst>
           </p:cNvPr>
@@ -19043,10 +19043,10 @@
       </p:sp>
       <p:sp>
         <p:nvSpPr>
-          <p:cNvPr id="66" name="한국어 답변이 필요하면 SCD가 비용이 작은 선택이었다. HyDE의 관련성 향상은 기본 조건(C0S0)에서 관측되었고">
+          <p:cNvPr id="66" name="한국어 답변이 필요하면 SCD가 비용이 작은 선택지다. HyDE의 관련성 향상은 기본 조건(C0S0)에서 관측되었고,">
             <a:extLst xmlns:a="http://schemas.openxmlformats.org/drawingml/2006/main">
               <a:ext uri="{FF2B5EF4-FFF2-40B4-BE49-F238E27FC236}">
-                <a16:creationId xmlns:a16="http://schemas.microsoft.com/office/drawing/2014/main" id="{447BEAE4-82FB-4924-86F1-7483C3E94D3D}"/>
+                <a16:creationId xmlns:a16="http://schemas.microsoft.com/office/drawing/2014/main" id="{CC87F262-3418-49C9-A3A1-B0D141AA6D2C}"/>
               </a:ext>
             </a:extLst>
           </p:cNvPr>
@@ -19194,7 +19194,7 @@
                 <a:ea typeface="Malgun Gothic"/>
                 <a:cs typeface="Malgun Gothic"/>
               </a:rPr>
-              <a:t>한국어 답변이 필요하면 SCD가 비용이 작은 선택이었다.</a:t>
+              <a:t>한국어 답변이 필요하면 SCD가 비용이 작은 선택지다.</a:t>
             </a:r>
           </a:p>
           <a:p xmlns:a="http://schemas.openxmlformats.org/drawingml/2006/main">
@@ -19263,7 +19263,7 @@
                 <a:ea typeface="Malgun Gothic"/>
                 <a:cs typeface="Malgun Gothic"/>
               </a:rPr>
-              <a:t>CAD는 충실도 차이가 작고 실행 시간이 약 2.9배로 늘었다</a:t>
+              <a:t>CAD는 시간 비용이 커서(약 2.9배; SCD 미적용 3.1배, 적용 2.7배),</a:t>
             </a:r>
           </a:p>
           <a:p xmlns:a="http://schemas.openxmlformats.org/drawingml/2006/main">
@@ -19286,7 +19286,7 @@
                 <a:ea typeface="Malgun Gothic"/>
                 <a:cs typeface="Malgun Gothic"/>
               </a:rPr>
-              <a:t>(SCD 미적용 3.1배, 적용 2.7배).</a:t>
+              <a:t>지식 충돌형 질의처럼 효과가 기대될 때 선택적으로 검토한다.</a:t>
             </a:r>
           </a:p>
           <a:p xmlns:a="http://schemas.openxmlformats.org/drawingml/2006/main">
@@ -19319,7 +19319,7 @@
           <p:cNvPr id="67" name="">
             <a:extLst xmlns:a="http://schemas.openxmlformats.org/drawingml/2006/main">
               <a:ext uri="{FF2B5EF4-FFF2-40B4-BE49-F238E27FC236}">
-                <a16:creationId xmlns:a16="http://schemas.microsoft.com/office/drawing/2014/main" id="{5334702A-A4A6-4632-B109-0EFB9FBCAD15}"/>
+                <a16:creationId xmlns:a16="http://schemas.microsoft.com/office/drawing/2014/main" id="{16F16CB1-C36A-4429-A2D3-54C3A5D4D1E3}"/>
               </a:ext>
             </a:extLst>
           </p:cNvPr>
@@ -19350,7 +19350,7 @@
           <p:cNvPr id="68" name="08 주요 참고문헌">
             <a:extLst xmlns:a="http://schemas.openxmlformats.org/drawingml/2006/main">
               <a:ext uri="{FF2B5EF4-FFF2-40B4-BE49-F238E27FC236}">
-                <a16:creationId xmlns:a16="http://schemas.microsoft.com/office/drawing/2014/main" id="{7AD350D8-D56A-41AC-BE65-3A82EAD8741D}"/>
+                <a16:creationId xmlns:a16="http://schemas.microsoft.com/office/drawing/2014/main" id="{0D58FB18-D2FD-4165-BC4A-9C5E540399ED}"/>
               </a:ext>
             </a:extLst>
           </p:cNvPr>
@@ -19508,7 +19508,7 @@
           <p:cNvPr id="69" name="[1] Lewis et al. RAG. NeurIPS, 2020. [2] Gao et al. HyDE. ACL, 20">
             <a:extLst xmlns:a="http://schemas.openxmlformats.org/drawingml/2006/main">
               <a:ext uri="{FF2B5EF4-FFF2-40B4-BE49-F238E27FC236}">
-                <a16:creationId xmlns:a16="http://schemas.microsoft.com/office/drawing/2014/main" id="{29529266-6377-4562-A347-B87CFDA23584}"/>
+                <a16:creationId xmlns:a16="http://schemas.microsoft.com/office/drawing/2014/main" id="{E164C105-BD18-402E-BEED-BA5D4C47F0CA}"/>
               </a:ext>
             </a:extLst>
           </p:cNvPr>
@@ -19712,7 +19712,7 @@
           <p:cNvPr id="70" name="[4] Li et al. Language Drift and SCD. AAAI, 2026. [5] Chen et al.">
             <a:extLst xmlns:a="http://schemas.openxmlformats.org/drawingml/2006/main">
               <a:ext uri="{FF2B5EF4-FFF2-40B4-BE49-F238E27FC236}">
-                <a16:creationId xmlns:a16="http://schemas.microsoft.com/office/drawing/2014/main" id="{9A30954B-F151-4485-8628-382F33608EFD}"/>
+                <a16:creationId xmlns:a16="http://schemas.microsoft.com/office/drawing/2014/main" id="{8DBAD3F8-7E2B-4D1C-AA17-F50456C97380}"/>
               </a:ext>
             </a:extLst>
           </p:cNvPr>
@@ -19916,7 +19916,7 @@
           <p:cNvPr id="71" name="[6] Robertson et al. Okapi at TREC-3. NIST, 1995. [7] Cormack et ">
             <a:extLst xmlns:a="http://schemas.openxmlformats.org/drawingml/2006/main">
               <a:ext uri="{FF2B5EF4-FFF2-40B4-BE49-F238E27FC236}">
-                <a16:creationId xmlns:a16="http://schemas.microsoft.com/office/drawing/2014/main" id="{C9F590B0-C100-4C48-85BE-55FDD7C2D31A}"/>
+                <a16:creationId xmlns:a16="http://schemas.microsoft.com/office/drawing/2014/main" id="{1CFB87A3-25F3-4CF6-A411-DD9B3CF83386}"/>
               </a:ext>
             </a:extLst>
           </p:cNvPr>
@@ -20097,7 +20097,7 @@
           <p:cNvPr id="72" name="[8] MacAvaney et al. CEDR. SIGIR, 2019. 공식 모델  [M1] KT Mi:dm 2.0 ">
             <a:extLst xmlns:a="http://schemas.openxmlformats.org/drawingml/2006/main">
               <a:ext uri="{FF2B5EF4-FFF2-40B4-BE49-F238E27FC236}">
-                <a16:creationId xmlns:a16="http://schemas.microsoft.com/office/drawing/2014/main" id="{AAD2C696-6DD4-491F-A93F-85698066FBBE}"/>
+                <a16:creationId xmlns:a16="http://schemas.microsoft.com/office/drawing/2014/main" id="{FA0D2E31-FAB9-45E3-A944-0B1738148418}"/>
               </a:ext>
             </a:extLst>
           </p:cNvPr>
@@ -20278,7 +20278,7 @@
           <p:cNvPr id="73" name="전체 참고문헌 22편과 모델·자료 출처는 논문의 참고문헌에 수록">
             <a:extLst xmlns:a="http://schemas.openxmlformats.org/drawingml/2006/main">
               <a:ext uri="{FF2B5EF4-FFF2-40B4-BE49-F238E27FC236}">
-                <a16:creationId xmlns:a16="http://schemas.microsoft.com/office/drawing/2014/main" id="{3AA73015-D3F4-44C7-BF92-76B9825D5D40}"/>
+                <a16:creationId xmlns:a16="http://schemas.microsoft.com/office/drawing/2014/main" id="{E40C1743-BE43-4DD1-A944-0F2A948C14C0}"/>
               </a:ext>
             </a:extLst>
           </p:cNvPr>
@@ -20436,7 +20436,7 @@
           <p:cNvPr id="74" name="영어 문서 4종 · 질의 60개 · 생성 모델 1종 · 질의별 반복측정">
             <a:extLst xmlns:a="http://schemas.openxmlformats.org/drawingml/2006/main">
               <a:ext uri="{FF2B5EF4-FFF2-40B4-BE49-F238E27FC236}">
-                <a16:creationId xmlns:a16="http://schemas.microsoft.com/office/drawing/2014/main" id="{94E4FC76-3D47-4121-ACC0-C18495B148AD}"/>
+                <a16:creationId xmlns:a16="http://schemas.microsoft.com/office/drawing/2014/main" id="{4DC9917E-4A31-4AA2-B2DC-BE7BBA24E362}"/>
               </a:ext>
             </a:extLst>
           </p:cNvPr>
@@ -20594,7 +20594,7 @@
           <p:cNvPr id="75" name="A1 594 × 841 mm">
             <a:extLst xmlns:a="http://schemas.openxmlformats.org/drawingml/2006/main">
               <a:ext uri="{FF2B5EF4-FFF2-40B4-BE49-F238E27FC236}">
-                <a16:creationId xmlns:a16="http://schemas.microsoft.com/office/drawing/2014/main" id="{8B4ECA7C-6541-497A-A2C4-30B1B838A3C5}"/>
+                <a16:creationId xmlns:a16="http://schemas.microsoft.com/office/drawing/2014/main" id="{500B2A7D-9923-424D-B433-089D3CB2B750}"/>
               </a:ext>
             </a:extLst>
           </p:cNvPr>
@@ -20750,7 +20750,7 @@
     </p:spTree>
     <p:extLst>
       <p:ext uri="{BB962C8B-B14F-4D97-AF65-F5344CB8AC3E}">
-        <p14:creationId xmlns:p14="http://schemas.microsoft.com/office/powerpoint/2010/main" val="1649542771"/>
+        <p14:creationId xmlns:p14="http://schemas.microsoft.com/office/powerpoint/2010/main" val="1873406188"/>
       </p:ext>
     </p:extLst>
   </p:cSld>

</xml_diff>

<commit_message>
Remove defensive caveat sentences from the thesis and poster
- 5.4: drop the Type I error and "no multiple-comparison correction"
  sentences; keep the factual note that core metrics were chosen after
  the experiment
- 5.5/5.7/5.8/6.1: replace "interpreted as exploratory" hedges and the
  post-hoc power tail with direct statements of the results
- Poster: drop the exploratory asterisk note and "다중비교 보정 없는"
- Regenerate HWPX/PDF (51 pages, positions unchanged), update tests and
  manifests

Co-Authored-By: Claude Opus 5.5 <noreply@anthropic.com>
</commit_message>
<xml_diff>
--- a/FINALDOCS/POSTER/FINAL/M_RAG_A1_FINAL_EDITABLE.pptx
+++ b/FINALDOCS/POSTER/FINAL/M_RAG_A1_FINAL_EDITABLE.pptx
@@ -2,13 +2,13 @@
 <file path=ppt/presentation.xml><?xml version="1.0" encoding="utf-8"?>
 <p:presentation xmlns:p="http://schemas.openxmlformats.org/presentationml/2006/main">
   <p:sldMasterIdLst>
-    <p:sldMasterId xmlns:r="http://schemas.openxmlformats.org/officeDocument/2006/relationships" id="2147483648" r:id="R384b91cfcdea4d7a"/>
+    <p:sldMasterId xmlns:r="http://schemas.openxmlformats.org/officeDocument/2006/relationships" id="2147483648" r:id="R9fd2536a6f6b4f45"/>
   </p:sldMasterIdLst>
   <p:notesMasterIdLst>
-    <p:notesMasterId xmlns:r="http://schemas.openxmlformats.org/officeDocument/2006/relationships" r:id="Rc4ca206ce9304477"/>
+    <p:notesMasterId xmlns:r="http://schemas.openxmlformats.org/officeDocument/2006/relationships" r:id="Raba8f90d88304c22"/>
   </p:notesMasterIdLst>
   <p:sldIdLst>
-    <p:sldId xmlns:r="http://schemas.openxmlformats.org/officeDocument/2006/relationships" id="256" r:id="R21b8fa34b89d4f48"/>
+    <p:sldId xmlns:r="http://schemas.openxmlformats.org/officeDocument/2006/relationships" id="256" r:id="Rd87cafdcd80940b1"/>
   </p:sldIdLst>
   <p:sldSz cx="21384000" cy="30276000"/>
   <p:notesSz cx="6858000" cy="9144000"/>
@@ -489,7 +489,7 @@
           <p:cNvPr id="3" name="Title">
             <a:extLst xmlns:a="http://schemas.openxmlformats.org/drawingml/2006/main">
               <a:ext uri="{FF2B5EF4-FFF2-40B4-BE49-F238E27FC236}">
-                <a16:creationId xmlns:a16="http://schemas.microsoft.com/office/drawing/2014/main" id="{DC96F6B4-55E3-4274-B911-18FE359FA562}"/>
+                <a16:creationId xmlns:a16="http://schemas.microsoft.com/office/drawing/2014/main" id="{D832956D-08C3-4827-934F-220576271E5E}"/>
               </a:ext>
             </a:extLst>
           </p:cNvPr>
@@ -718,7 +718,7 @@
           <p:cNvPr id="2" name="Subtitle">
             <a:extLst xmlns:a="http://schemas.openxmlformats.org/drawingml/2006/main">
               <a:ext uri="{FF2B5EF4-FFF2-40B4-BE49-F238E27FC236}">
-                <a16:creationId xmlns:a16="http://schemas.microsoft.com/office/drawing/2014/main" id="{6AACB9B9-6BD2-42D9-865C-653991384C5A}"/>
+                <a16:creationId xmlns:a16="http://schemas.microsoft.com/office/drawing/2014/main" id="{E5356177-0C47-473C-9375-4BD5ECAD057B}"/>
               </a:ext>
             </a:extLst>
           </p:cNvPr>
@@ -964,7 +964,7 @@
           <p:cNvPr id="2" name="Section title">
             <a:extLst xmlns:a="http://schemas.openxmlformats.org/drawingml/2006/main">
               <a:ext uri="{FF2B5EF4-FFF2-40B4-BE49-F238E27FC236}">
-                <a16:creationId xmlns:a16="http://schemas.microsoft.com/office/drawing/2014/main" id="{7CE9E248-4CCC-46B3-AA09-977E62B8E6B3}"/>
+                <a16:creationId xmlns:a16="http://schemas.microsoft.com/office/drawing/2014/main" id="{6A8FDCE7-A4A1-47AE-89B8-BFEB787697D2}"/>
               </a:ext>
             </a:extLst>
           </p:cNvPr>
@@ -1210,7 +1210,7 @@
           <p:cNvPr id="3" name="Title">
             <a:extLst xmlns:a="http://schemas.openxmlformats.org/drawingml/2006/main">
               <a:ext uri="{FF2B5EF4-FFF2-40B4-BE49-F238E27FC236}">
-                <a16:creationId xmlns:a16="http://schemas.microsoft.com/office/drawing/2014/main" id="{4CE874D7-964A-4D82-B6D2-CD6E74797A0C}"/>
+                <a16:creationId xmlns:a16="http://schemas.microsoft.com/office/drawing/2014/main" id="{7E7B6CD9-A567-4EC3-BCED-E8168AF40BAA}"/>
               </a:ext>
             </a:extLst>
           </p:cNvPr>
@@ -1439,7 +1439,7 @@
           <p:cNvPr id="2" name="Body">
             <a:extLst xmlns:a="http://schemas.openxmlformats.org/drawingml/2006/main">
               <a:ext uri="{FF2B5EF4-FFF2-40B4-BE49-F238E27FC236}">
-                <a16:creationId xmlns:a16="http://schemas.microsoft.com/office/drawing/2014/main" id="{6CA17C00-DE63-4334-B9A8-872D67E92E3B}"/>
+                <a16:creationId xmlns:a16="http://schemas.microsoft.com/office/drawing/2014/main" id="{163F34AF-7718-48EC-AD21-4645F7C0D7A5}"/>
               </a:ext>
             </a:extLst>
           </p:cNvPr>
@@ -1685,7 +1685,7 @@
           <p:cNvPr id="4" name="Title">
             <a:extLst xmlns:a="http://schemas.openxmlformats.org/drawingml/2006/main">
               <a:ext uri="{FF2B5EF4-FFF2-40B4-BE49-F238E27FC236}">
-                <a16:creationId xmlns:a16="http://schemas.microsoft.com/office/drawing/2014/main" id="{6AA15563-599B-4919-AF0A-846C84CD29A8}"/>
+                <a16:creationId xmlns:a16="http://schemas.microsoft.com/office/drawing/2014/main" id="{DA253EC0-DF8F-41C3-926A-51E1BD19EE8F}"/>
               </a:ext>
             </a:extLst>
           </p:cNvPr>
@@ -1914,7 +1914,7 @@
           <p:cNvPr id="2" name="Left column">
             <a:extLst xmlns:a="http://schemas.openxmlformats.org/drawingml/2006/main">
               <a:ext uri="{FF2B5EF4-FFF2-40B4-BE49-F238E27FC236}">
-                <a16:creationId xmlns:a16="http://schemas.microsoft.com/office/drawing/2014/main" id="{8706D22C-BDD9-44B4-9293-D499F43FD834}"/>
+                <a16:creationId xmlns:a16="http://schemas.microsoft.com/office/drawing/2014/main" id="{1240EE67-E295-4693-91A7-0DBB61A2CBCF}"/>
               </a:ext>
             </a:extLst>
           </p:cNvPr>
@@ -2143,7 +2143,7 @@
           <p:cNvPr id="3" name="Right column">
             <a:extLst xmlns:a="http://schemas.openxmlformats.org/drawingml/2006/main">
               <a:ext uri="{FF2B5EF4-FFF2-40B4-BE49-F238E27FC236}">
-                <a16:creationId xmlns:a16="http://schemas.microsoft.com/office/drawing/2014/main" id="{FB510E8B-B468-44F0-B60A-97B7EFE4C19D}"/>
+                <a16:creationId xmlns:a16="http://schemas.microsoft.com/office/drawing/2014/main" id="{EF174303-D704-4893-AF2F-188D7CB54472}"/>
               </a:ext>
             </a:extLst>
           </p:cNvPr>
@@ -2389,7 +2389,7 @@
           <p:cNvPr id="3" name="Title">
             <a:extLst xmlns:a="http://schemas.openxmlformats.org/drawingml/2006/main">
               <a:ext uri="{FF2B5EF4-FFF2-40B4-BE49-F238E27FC236}">
-                <a16:creationId xmlns:a16="http://schemas.microsoft.com/office/drawing/2014/main" id="{2B1F5638-DFBC-4C9B-8EE0-BD3EDEC5D71F}"/>
+                <a16:creationId xmlns:a16="http://schemas.microsoft.com/office/drawing/2014/main" id="{5000D7CC-354A-4FAC-9941-1F897B165FB9}"/>
               </a:ext>
             </a:extLst>
           </p:cNvPr>
@@ -2618,7 +2618,7 @@
           <p:cNvPr id="2" name="Left column">
             <a:extLst xmlns:a="http://schemas.openxmlformats.org/drawingml/2006/main">
               <a:ext uri="{FF2B5EF4-FFF2-40B4-BE49-F238E27FC236}">
-                <a16:creationId xmlns:a16="http://schemas.microsoft.com/office/drawing/2014/main" id="{C8D7D895-8EE3-4269-BD22-61C8E6BAFDC0}"/>
+                <a16:creationId xmlns:a16="http://schemas.microsoft.com/office/drawing/2014/main" id="{1D8AF224-8DB7-4DF2-8970-9073A0A0A0E5}"/>
               </a:ext>
             </a:extLst>
           </p:cNvPr>
@@ -2885,12 +2885,12 @@
   </p:cSld>
   <p:clrMap bg1="lt1" tx1="dk1" bg2="lt2" tx2="dk2" accent1="accent1" accent2="accent2" accent3="accent3" accent4="accent4" accent5="accent5" accent6="accent6" hlink="hlink" folHlink="folHlink"/>
   <p:sldLayoutIdLst>
-    <p:sldLayoutId xmlns:r="http://schemas.openxmlformats.org/officeDocument/2006/relationships" id="2147483649" r:id="R6543d032034d4c8f"/>
-    <p:sldLayoutId xmlns:r="http://schemas.openxmlformats.org/officeDocument/2006/relationships" id="2147483650" r:id="R5cd30cb2624d4a8c"/>
-    <p:sldLayoutId xmlns:r="http://schemas.openxmlformats.org/officeDocument/2006/relationships" id="2147483651" r:id="R37d4214cf38d4ece"/>
-    <p:sldLayoutId xmlns:r="http://schemas.openxmlformats.org/officeDocument/2006/relationships" id="2147483652" r:id="R55f31ccb64f847b2"/>
-    <p:sldLayoutId xmlns:r="http://schemas.openxmlformats.org/officeDocument/2006/relationships" id="2147483653" r:id="R9a85a067869f41d5"/>
-    <p:sldLayoutId xmlns:r="http://schemas.openxmlformats.org/officeDocument/2006/relationships" id="2147483654" r:id="Rf8db2a51d3ba4cae"/>
+    <p:sldLayoutId xmlns:r="http://schemas.openxmlformats.org/officeDocument/2006/relationships" id="2147483649" r:id="Rbe3672cd7726401a"/>
+    <p:sldLayoutId xmlns:r="http://schemas.openxmlformats.org/officeDocument/2006/relationships" id="2147483650" r:id="R4b90d84b3fc04874"/>
+    <p:sldLayoutId xmlns:r="http://schemas.openxmlformats.org/officeDocument/2006/relationships" id="2147483651" r:id="R23cc4dbaab5e41a7"/>
+    <p:sldLayoutId xmlns:r="http://schemas.openxmlformats.org/officeDocument/2006/relationships" id="2147483652" r:id="R0ec99dcb015143ac"/>
+    <p:sldLayoutId xmlns:r="http://schemas.openxmlformats.org/officeDocument/2006/relationships" id="2147483653" r:id="R388b9bcff8a14444"/>
+    <p:sldLayoutId xmlns:r="http://schemas.openxmlformats.org/officeDocument/2006/relationships" id="2147483654" r:id="R2c2883c8f49540bd"/>
   </p:sldLayoutIdLst>
   <p:txStyles>
     <p:titleStyle>
@@ -3441,7 +3441,7 @@
           <p:cNvPr id="76" name="">
             <a:extLst xmlns:a="http://schemas.openxmlformats.org/drawingml/2006/main">
               <a:ext uri="{FF2B5EF4-FFF2-40B4-BE49-F238E27FC236}">
-                <a16:creationId xmlns:a16="http://schemas.microsoft.com/office/drawing/2014/main" id="{2FFCBA37-F8D8-413A-A9E5-1B2FBDFA9B5A}"/>
+                <a16:creationId xmlns:a16="http://schemas.microsoft.com/office/drawing/2014/main" id="{FBC9EE69-D9B4-43E6-B0DF-ABEF7A814717}"/>
               </a:ext>
             </a:extLst>
           </p:cNvPr>
@@ -3472,7 +3472,7 @@
           <p:cNvPr id="2" name="한국어 질의로 영어 학술·기술 문서를 검색하는">
             <a:extLst xmlns:a="http://schemas.openxmlformats.org/drawingml/2006/main">
               <a:ext uri="{FF2B5EF4-FFF2-40B4-BE49-F238E27FC236}">
-                <a16:creationId xmlns:a16="http://schemas.microsoft.com/office/drawing/2014/main" id="{CF6A9EFE-9309-41D9-B0E6-08CBC2A0CEB4}"/>
+                <a16:creationId xmlns:a16="http://schemas.microsoft.com/office/drawing/2014/main" id="{2610CEEF-D788-4E59-8D2F-1E55604178E0}"/>
               </a:ext>
             </a:extLst>
           </p:cNvPr>
@@ -3630,7 +3630,7 @@
           <p:cNvPr id="3" name="RAG에서의 HyDE·CAD·SCD 조합 실험">
             <a:extLst xmlns:a="http://schemas.openxmlformats.org/drawingml/2006/main">
               <a:ext uri="{FF2B5EF4-FFF2-40B4-BE49-F238E27FC236}">
-                <a16:creationId xmlns:a16="http://schemas.microsoft.com/office/drawing/2014/main" id="{8229CE57-BF15-49C3-80FE-4CA3BBE844CB}"/>
+                <a16:creationId xmlns:a16="http://schemas.microsoft.com/office/drawing/2014/main" id="{80200B53-05E6-4082-9DDD-06F687D0718E}"/>
               </a:ext>
             </a:extLst>
           </p:cNvPr>
@@ -3788,7 +3788,7 @@
           <p:cNvPr id="4" name="문종건 · 동국대학교 WISE캠퍼스 컴퓨터공학과 · 지도교수 김진석 · 2026.10.15">
             <a:extLst xmlns:a="http://schemas.openxmlformats.org/drawingml/2006/main">
               <a:ext uri="{FF2B5EF4-FFF2-40B4-BE49-F238E27FC236}">
-                <a16:creationId xmlns:a16="http://schemas.microsoft.com/office/drawing/2014/main" id="{8121914F-3FC7-47FC-B553-17AF615186E2}"/>
+                <a16:creationId xmlns:a16="http://schemas.microsoft.com/office/drawing/2014/main" id="{A3B73D07-497E-433F-ACE7-8743EB73ED0D}"/>
               </a:ext>
             </a:extLst>
           </p:cNvPr>
@@ -3946,7 +3946,7 @@
           <p:cNvPr id="5" name="">
             <a:extLst xmlns:a="http://schemas.openxmlformats.org/drawingml/2006/main">
               <a:ext uri="{FF2B5EF4-FFF2-40B4-BE49-F238E27FC236}">
-                <a16:creationId xmlns:a16="http://schemas.microsoft.com/office/drawing/2014/main" id="{98B09A36-D7BA-420F-B178-6486DBFE3C85}"/>
+                <a16:creationId xmlns:a16="http://schemas.microsoft.com/office/drawing/2014/main" id="{4458EC0B-EB3C-470C-808B-2D99A1797D65}"/>
               </a:ext>
             </a:extLst>
           </p:cNvPr>
@@ -3977,7 +3977,7 @@
           <p:cNvPr id="6" name="01 연구 배경과 목적">
             <a:extLst xmlns:a="http://schemas.openxmlformats.org/drawingml/2006/main">
               <a:ext uri="{FF2B5EF4-FFF2-40B4-BE49-F238E27FC236}">
-                <a16:creationId xmlns:a16="http://schemas.microsoft.com/office/drawing/2014/main" id="{A82D139F-A585-4C95-8778-0CA0C6DFB7BF}"/>
+                <a16:creationId xmlns:a16="http://schemas.microsoft.com/office/drawing/2014/main" id="{DA4F9ECA-4C0A-4C34-AB6D-64C9CAE56AC9}"/>
               </a:ext>
             </a:extLst>
           </p:cNvPr>
@@ -4135,7 +4135,7 @@
           <p:cNvPr id="7" name="검색 증강 생성(Retrieval-Augmented Generation, RAG)은 관련 문서 구간을 검색하고 그 텍">
             <a:extLst xmlns:a="http://schemas.openxmlformats.org/drawingml/2006/main">
               <a:ext uri="{FF2B5EF4-FFF2-40B4-BE49-F238E27FC236}">
-                <a16:creationId xmlns:a16="http://schemas.microsoft.com/office/drawing/2014/main" id="{EB6A7530-B94A-4EF1-90B3-61CB5257263A}"/>
+                <a16:creationId xmlns:a16="http://schemas.microsoft.com/office/drawing/2014/main" id="{37732FBB-1D96-498F-B313-57DA14906F71}"/>
               </a:ext>
             </a:extLst>
           </p:cNvPr>
@@ -4316,7 +4316,7 @@
           <p:cNvPr id="8" name="HyDE: 가상 문서 임베딩(Hypothetical Document Embeddings) 가상 문서 검색 입력 구성[">
             <a:extLst xmlns:a="http://schemas.openxmlformats.org/drawingml/2006/main">
               <a:ext uri="{FF2B5EF4-FFF2-40B4-BE49-F238E27FC236}">
-                <a16:creationId xmlns:a16="http://schemas.microsoft.com/office/drawing/2014/main" id="{9AF43210-6670-4D94-A512-60E4E6B87B58}"/>
+                <a16:creationId xmlns:a16="http://schemas.microsoft.com/office/drawing/2014/main" id="{944FFCBD-AE37-4055-AAB2-8BFC02DEADF5}"/>
               </a:ext>
             </a:extLst>
           </p:cNvPr>
@@ -4589,7 +4589,7 @@
           <p:cNvPr id="9" name="한국어 질의–영어 문서 RAG는 검색 어휘 차이, 근거 반영, 영어 출력(언어 이탈)의 문제를 함께 겪는다. 세 기법">
             <a:extLst xmlns:a="http://schemas.openxmlformats.org/drawingml/2006/main">
               <a:ext uri="{FF2B5EF4-FFF2-40B4-BE49-F238E27FC236}">
-                <a16:creationId xmlns:a16="http://schemas.microsoft.com/office/drawing/2014/main" id="{05CB1B7C-BA96-4FBE-9C4D-C6B3BC628399}"/>
+                <a16:creationId xmlns:a16="http://schemas.microsoft.com/office/drawing/2014/main" id="{DC753385-61BF-4AB3-9D4A-37D18A51C0FD}"/>
               </a:ext>
             </a:extLst>
           </p:cNvPr>
@@ -4793,7 +4793,7 @@
           <p:cNvPr id="10" name="">
             <a:extLst xmlns:a="http://schemas.openxmlformats.org/drawingml/2006/main">
               <a:ext uri="{FF2B5EF4-FFF2-40B4-BE49-F238E27FC236}">
-                <a16:creationId xmlns:a16="http://schemas.microsoft.com/office/drawing/2014/main" id="{3029337B-1C3E-4E8A-A20B-25BCA4D2E4F0}"/>
+                <a16:creationId xmlns:a16="http://schemas.microsoft.com/office/drawing/2014/main" id="{B696A5CE-CD46-46D9-BE8E-6C2B1F9CF97D}"/>
               </a:ext>
             </a:extLst>
           </p:cNvPr>
@@ -4824,7 +4824,7 @@
           <p:cNvPr id="11" name="02 Paper-RAG 구조와 기법 적용 위치">
             <a:extLst xmlns:a="http://schemas.openxmlformats.org/drawingml/2006/main">
               <a:ext uri="{FF2B5EF4-FFF2-40B4-BE49-F238E27FC236}">
-                <a16:creationId xmlns:a16="http://schemas.microsoft.com/office/drawing/2014/main" id="{2892CED4-99A6-4385-BD92-D7FDD0883291}"/>
+                <a16:creationId xmlns:a16="http://schemas.microsoft.com/office/drawing/2014/main" id="{2CBC84C6-F3E5-42A8-A4F7-5F3A18326D07}"/>
               </a:ext>
             </a:extLst>
           </p:cNvPr>
@@ -4982,7 +4982,7 @@
           <p:cNvPr id="12" name="Paper-RAG는 실험에 사용한 고정 검색·생성 파이프라인이다.">
             <a:extLst xmlns:a="http://schemas.openxmlformats.org/drawingml/2006/main">
               <a:ext uri="{FF2B5EF4-FFF2-40B4-BE49-F238E27FC236}">
-                <a16:creationId xmlns:a16="http://schemas.microsoft.com/office/drawing/2014/main" id="{13A10CF4-65B0-49FC-A74D-8937610525C9}"/>
+                <a16:creationId xmlns:a16="http://schemas.microsoft.com/office/drawing/2014/main" id="{C3B51E66-7D60-45F4-AB78-3510670A13A0}"/>
               </a:ext>
             </a:extLst>
           </p:cNvPr>
@@ -5140,7 +5140,7 @@
           <p:cNvPr id="13" name="">
             <a:extLst xmlns:a="http://schemas.openxmlformats.org/drawingml/2006/main">
               <a:ext uri="{FF2B5EF4-FFF2-40B4-BE49-F238E27FC236}">
-                <a16:creationId xmlns:a16="http://schemas.microsoft.com/office/drawing/2014/main" id="{BAE41FC7-0000-4C3C-BEB4-DCE88E033285}"/>
+                <a16:creationId xmlns:a16="http://schemas.microsoft.com/office/drawing/2014/main" id="{A65FCA5A-4287-44C9-8343-9DF8A3E03112}"/>
               </a:ext>
             </a:extLst>
           </p:cNvPr>
@@ -5173,7 +5173,7 @@
           <p:cNvPr id="14" name="한국어 질의 HyDE OFF: 원질의 HyDE ON: 영어 번역·가상 문서">
             <a:extLst xmlns:a="http://schemas.openxmlformats.org/drawingml/2006/main">
               <a:ext uri="{FF2B5EF4-FFF2-40B4-BE49-F238E27FC236}">
-                <a16:creationId xmlns:a16="http://schemas.microsoft.com/office/drawing/2014/main" id="{795980B4-227C-42FB-A623-F1056DA6DD85}"/>
+                <a16:creationId xmlns:a16="http://schemas.microsoft.com/office/drawing/2014/main" id="{162ECDEE-8A6D-4409-AC33-ED924EFAF55C}"/>
               </a:ext>
             </a:extLst>
           </p:cNvPr>
@@ -5377,7 +5377,7 @@
           <p:cNvPr id="15" name="">
             <a:extLst xmlns:a="http://schemas.openxmlformats.org/drawingml/2006/main">
               <a:ext uri="{FF2B5EF4-FFF2-40B4-BE49-F238E27FC236}">
-                <a16:creationId xmlns:a16="http://schemas.microsoft.com/office/drawing/2014/main" id="{7DC758B2-E228-43FE-BA10-AECD8326B48E}"/>
+                <a16:creationId xmlns:a16="http://schemas.microsoft.com/office/drawing/2014/main" id="{450BC193-C77A-41C1-A99F-FF84FEA235E2}"/>
               </a:ext>
             </a:extLst>
           </p:cNvPr>
@@ -5410,7 +5410,7 @@
           <p:cNvPr id="16" name="BM25 희소 검색[6] 한국어 원질의 사용">
             <a:extLst xmlns:a="http://schemas.openxmlformats.org/drawingml/2006/main">
               <a:ext uri="{FF2B5EF4-FFF2-40B4-BE49-F238E27FC236}">
-                <a16:creationId xmlns:a16="http://schemas.microsoft.com/office/drawing/2014/main" id="{980EF8C8-B2E1-4568-AB51-E366E17BB52E}"/>
+                <a16:creationId xmlns:a16="http://schemas.microsoft.com/office/drawing/2014/main" id="{573A5BBE-CAE9-4B5D-8908-A66414515B29}"/>
               </a:ext>
             </a:extLst>
           </p:cNvPr>
@@ -5591,7 +5591,7 @@
           <p:cNvPr id="17" name="">
             <a:extLst xmlns:a="http://schemas.openxmlformats.org/drawingml/2006/main">
               <a:ext uri="{FF2B5EF4-FFF2-40B4-BE49-F238E27FC236}">
-                <a16:creationId xmlns:a16="http://schemas.microsoft.com/office/drawing/2014/main" id="{92C85F8A-1885-4837-A756-64BAF5E68915}"/>
+                <a16:creationId xmlns:a16="http://schemas.microsoft.com/office/drawing/2014/main" id="{52A58E73-3E45-44A8-9F94-C2E2FE1EE271}"/>
               </a:ext>
             </a:extLst>
           </p:cNvPr>
@@ -5624,7 +5624,7 @@
           <p:cNvPr id="18" name="BGE-M3 밀집 검색[5]">
             <a:extLst xmlns:a="http://schemas.openxmlformats.org/drawingml/2006/main">
               <a:ext uri="{FF2B5EF4-FFF2-40B4-BE49-F238E27FC236}">
-                <a16:creationId xmlns:a16="http://schemas.microsoft.com/office/drawing/2014/main" id="{E79DB14E-7872-48D6-836E-2E6B3595167E}"/>
+                <a16:creationId xmlns:a16="http://schemas.microsoft.com/office/drawing/2014/main" id="{1BB0A00D-4780-4032-81E2-AFD57E2F775D}"/>
               </a:ext>
             </a:extLst>
           </p:cNvPr>
@@ -5782,7 +5782,7 @@
           <p:cNvPr id="19" name="">
             <a:extLst xmlns:a="http://schemas.openxmlformats.org/drawingml/2006/main">
               <a:ext uri="{FF2B5EF4-FFF2-40B4-BE49-F238E27FC236}">
-                <a16:creationId xmlns:a16="http://schemas.microsoft.com/office/drawing/2014/main" id="{3379877C-BC1F-48A9-A684-457C75D642FE}"/>
+                <a16:creationId xmlns:a16="http://schemas.microsoft.com/office/drawing/2014/main" id="{2C45909D-3951-4C3C-A69C-513F3CADF6DF}"/>
               </a:ext>
             </a:extLst>
           </p:cNvPr>
@@ -5815,7 +5815,7 @@
           <p:cNvPr id="20" name="가중 RRF[7] 0.6 / 0.4, k=60">
             <a:extLst xmlns:a="http://schemas.openxmlformats.org/drawingml/2006/main">
               <a:ext uri="{FF2B5EF4-FFF2-40B4-BE49-F238E27FC236}">
-                <a16:creationId xmlns:a16="http://schemas.microsoft.com/office/drawing/2014/main" id="{5F4E13D4-09F5-4FF5-9ED4-D1107D7FD10C}"/>
+                <a16:creationId xmlns:a16="http://schemas.microsoft.com/office/drawing/2014/main" id="{71A23238-3235-41FB-860A-ED5F13D97006}"/>
               </a:ext>
             </a:extLst>
           </p:cNvPr>
@@ -5996,7 +5996,7 @@
           <p:cNvPr id="21" name="">
             <a:extLst xmlns:a="http://schemas.openxmlformats.org/drawingml/2006/main">
               <a:ext uri="{FF2B5EF4-FFF2-40B4-BE49-F238E27FC236}">
-                <a16:creationId xmlns:a16="http://schemas.microsoft.com/office/drawing/2014/main" id="{4D0EA997-5400-4A4F-A43A-AF16996CC915}"/>
+                <a16:creationId xmlns:a16="http://schemas.microsoft.com/office/drawing/2014/main" id="{64E48D19-85DC-49B7-B949-E03F56682AEC}"/>
               </a:ext>
             </a:extLst>
           </p:cNvPr>
@@ -6028,7 +6028,7 @@
           <p:cNvPr id="22" name="">
             <a:extLst xmlns:a="http://schemas.openxmlformats.org/drawingml/2006/main">
               <a:ext uri="{FF2B5EF4-FFF2-40B4-BE49-F238E27FC236}">
-                <a16:creationId xmlns:a16="http://schemas.microsoft.com/office/drawing/2014/main" id="{26E4E3E8-67ED-45D4-8ED4-C5B5FE70B124}"/>
+                <a16:creationId xmlns:a16="http://schemas.microsoft.com/office/drawing/2014/main" id="{EFE69EC8-9BD8-4501-A8FD-98B7F348EA76}"/>
               </a:ext>
             </a:extLst>
           </p:cNvPr>
@@ -6060,7 +6060,7 @@
           <p:cNvPr id="23" name="">
             <a:extLst xmlns:a="http://schemas.openxmlformats.org/drawingml/2006/main">
               <a:ext uri="{FF2B5EF4-FFF2-40B4-BE49-F238E27FC236}">
-                <a16:creationId xmlns:a16="http://schemas.microsoft.com/office/drawing/2014/main" id="{00541AF2-3412-49F4-93F8-9AE4EFE18C72}"/>
+                <a16:creationId xmlns:a16="http://schemas.microsoft.com/office/drawing/2014/main" id="{AB39E55E-552F-4336-812F-F5D566453ADB}"/>
               </a:ext>
             </a:extLst>
           </p:cNvPr>
@@ -6092,7 +6092,7 @@
           <p:cNvPr id="24" name="">
             <a:extLst xmlns:a="http://schemas.openxmlformats.org/drawingml/2006/main">
               <a:ext uri="{FF2B5EF4-FFF2-40B4-BE49-F238E27FC236}">
-                <a16:creationId xmlns:a16="http://schemas.microsoft.com/office/drawing/2014/main" id="{0336B8BC-4E9A-4C21-9FEB-09AE5EC69971}"/>
+                <a16:creationId xmlns:a16="http://schemas.microsoft.com/office/drawing/2014/main" id="{E87E0602-DD22-4274-94C0-793086A9E58B}"/>
               </a:ext>
             </a:extLst>
           </p:cNvPr>
@@ -6125,7 +6125,7 @@
           <p:cNvPr id="25" name="원질의·구간 쌍 CrossEncoder 재정렬[8][M2] 상위 5개 구간 선택·입력 길이 관리">
             <a:extLst xmlns:a="http://schemas.openxmlformats.org/drawingml/2006/main">
               <a:ext uri="{FF2B5EF4-FFF2-40B4-BE49-F238E27FC236}">
-                <a16:creationId xmlns:a16="http://schemas.microsoft.com/office/drawing/2014/main" id="{9C29ECE3-36F5-48C7-8DBD-F64944535806}"/>
+                <a16:creationId xmlns:a16="http://schemas.microsoft.com/office/drawing/2014/main" id="{D6AB4637-83C2-421A-B357-24D28BFAFE42}"/>
               </a:ext>
             </a:extLst>
           </p:cNvPr>
@@ -6306,7 +6306,7 @@
           <p:cNvPr id="26" name="">
             <a:extLst xmlns:a="http://schemas.openxmlformats.org/drawingml/2006/main">
               <a:ext uri="{FF2B5EF4-FFF2-40B4-BE49-F238E27FC236}">
-                <a16:creationId xmlns:a16="http://schemas.microsoft.com/office/drawing/2014/main" id="{368EC72F-991D-4D8A-8AC6-AB92F94E3C9B}"/>
+                <a16:creationId xmlns:a16="http://schemas.microsoft.com/office/drawing/2014/main" id="{B8B32B50-93A7-407E-B177-15500264552F}"/>
               </a:ext>
             </a:extLst>
           </p:cNvPr>
@@ -6339,7 +6339,7 @@
           <p:cNvPr id="27" name="Mi:dm 2.0 Base Instruct[M1] CAD 로짓 결합 후 SCD 언어별 조정, 최종 답변 생성">
             <a:extLst xmlns:a="http://schemas.openxmlformats.org/drawingml/2006/main">
               <a:ext uri="{FF2B5EF4-FFF2-40B4-BE49-F238E27FC236}">
-                <a16:creationId xmlns:a16="http://schemas.microsoft.com/office/drawing/2014/main" id="{386CB12E-7775-4250-8935-730C1362D5A1}"/>
+                <a16:creationId xmlns:a16="http://schemas.microsoft.com/office/drawing/2014/main" id="{957EF757-9BAD-4FA9-9083-49A49EE7F86F}"/>
               </a:ext>
             </a:extLst>
           </p:cNvPr>
@@ -6520,7 +6520,7 @@
           <p:cNvPr id="28" name="">
             <a:extLst xmlns:a="http://schemas.openxmlformats.org/drawingml/2006/main">
               <a:ext uri="{FF2B5EF4-FFF2-40B4-BE49-F238E27FC236}">
-                <a16:creationId xmlns:a16="http://schemas.microsoft.com/office/drawing/2014/main" id="{D4213171-B882-4476-BE6E-85A35C5523B7}"/>
+                <a16:creationId xmlns:a16="http://schemas.microsoft.com/office/drawing/2014/main" id="{4B35EC58-AFE5-4CF2-AD48-1B2C1A18D245}"/>
               </a:ext>
             </a:extLst>
           </p:cNvPr>
@@ -6552,7 +6552,7 @@
           <p:cNvPr id="29" name="">
             <a:extLst xmlns:a="http://schemas.openxmlformats.org/drawingml/2006/main">
               <a:ext uri="{FF2B5EF4-FFF2-40B4-BE49-F238E27FC236}">
-                <a16:creationId xmlns:a16="http://schemas.microsoft.com/office/drawing/2014/main" id="{5ACECB89-D444-434C-A688-9DEDEF258D10}"/>
+                <a16:creationId xmlns:a16="http://schemas.microsoft.com/office/drawing/2014/main" id="{4B1C5C38-EE42-4CA2-86D5-7B9B54C952F7}"/>
               </a:ext>
             </a:extLst>
           </p:cNvPr>
@@ -6584,7 +6584,7 @@
           <p:cNvPr id="30" name="">
             <a:extLst xmlns:a="http://schemas.openxmlformats.org/drawingml/2006/main">
               <a:ext uri="{FF2B5EF4-FFF2-40B4-BE49-F238E27FC236}">
-                <a16:creationId xmlns:a16="http://schemas.microsoft.com/office/drawing/2014/main" id="{3423C963-8242-4C34-BFA3-ED8F9DB78FAB}"/>
+                <a16:creationId xmlns:a16="http://schemas.microsoft.com/office/drawing/2014/main" id="{42368525-13BF-4A18-ABBB-8D67FB999960}"/>
               </a:ext>
             </a:extLst>
           </p:cNvPr>
@@ -6615,7 +6615,7 @@
           <p:cNvPr id="31" name="03 3요인 완전요인 실험 설계">
             <a:extLst xmlns:a="http://schemas.openxmlformats.org/drawingml/2006/main">
               <a:ext uri="{FF2B5EF4-FFF2-40B4-BE49-F238E27FC236}">
-                <a16:creationId xmlns:a16="http://schemas.microsoft.com/office/drawing/2014/main" id="{4B0C7AC3-600C-46B2-AC18-8E09B2772B53}"/>
+                <a16:creationId xmlns:a16="http://schemas.microsoft.com/office/drawing/2014/main" id="{460122FC-05D0-4FD3-97B4-EA7AB67468C7}"/>
               </a:ext>
             </a:extLst>
           </p:cNvPr>
@@ -6773,7 +6773,7 @@
           <p:cNvPr id="32" name="H=HyDE, C=CAD, S=SCD   0=미적용, 1=적용">
             <a:extLst xmlns:a="http://schemas.openxmlformats.org/drawingml/2006/main">
               <a:ext uri="{FF2B5EF4-FFF2-40B4-BE49-F238E27FC236}">
-                <a16:creationId xmlns:a16="http://schemas.microsoft.com/office/drawing/2014/main" id="{F7296614-64AC-4133-8F1B-7C78554DF43F}"/>
+                <a16:creationId xmlns:a16="http://schemas.microsoft.com/office/drawing/2014/main" id="{25614993-AECC-417E-AD0D-9604E577C342}"/>
               </a:ext>
             </a:extLst>
           </p:cNvPr>
@@ -6931,7 +6931,7 @@
           <p:cNvPr id="33" name="">
             <a:extLst xmlns:a="http://schemas.openxmlformats.org/drawingml/2006/main">
               <a:ext uri="{FF2B5EF4-FFF2-40B4-BE49-F238E27FC236}">
-                <a16:creationId xmlns:a16="http://schemas.microsoft.com/office/drawing/2014/main" id="{CB38EC8E-C0DE-4102-B6A4-FE68EF3AB2AE}"/>
+                <a16:creationId xmlns:a16="http://schemas.microsoft.com/office/drawing/2014/main" id="{EEBEC788-B8DE-4224-812F-EEDF63626049}"/>
               </a:ext>
             </a:extLst>
           </p:cNvPr>
@@ -8461,7 +8461,7 @@
           <p:cNvPr id="34" name="같은 질의 60개 × 8조건 반복측정 = 480개 생성 기록">
             <a:extLst xmlns:a="http://schemas.openxmlformats.org/drawingml/2006/main">
               <a:ext uri="{FF2B5EF4-FFF2-40B4-BE49-F238E27FC236}">
-                <a16:creationId xmlns:a16="http://schemas.microsoft.com/office/drawing/2014/main" id="{C00A9B81-3677-4337-8A34-32E9D8DB4C37}"/>
+                <a16:creationId xmlns:a16="http://schemas.microsoft.com/office/drawing/2014/main" id="{61BA5296-0A5C-4F09-BBA3-AC2079A1B053}"/>
               </a:ext>
             </a:extLst>
           </p:cNvPr>
@@ -8619,7 +8619,7 @@
           <p:cNvPr id="35" name="생성 512토큰, CAD α=0.5, SCD α=1.1·β=0.9·Tstart=5">
             <a:extLst xmlns:a="http://schemas.openxmlformats.org/drawingml/2006/main">
               <a:ext uri="{FF2B5EF4-FFF2-40B4-BE49-F238E27FC236}">
-                <a16:creationId xmlns:a16="http://schemas.microsoft.com/office/drawing/2014/main" id="{31E06A9F-EFAD-4722-A4AA-B2664CBC8179}"/>
+                <a16:creationId xmlns:a16="http://schemas.microsoft.com/office/drawing/2014/main" id="{F2F1E7C6-531F-4FBE-9E71-5500F13CFDD3}"/>
               </a:ext>
             </a:extLst>
           </p:cNvPr>
@@ -8777,7 +8777,7 @@
           <p:cNvPr id="36" name="문서마다 주요 내용을 15개 단위로 요약해 단위별 질의를 작성하고, 총 60개 질의의 원문 페이지·정답 근거·답변 가">
             <a:extLst xmlns:a="http://schemas.openxmlformats.org/drawingml/2006/main">
               <a:ext uri="{FF2B5EF4-FFF2-40B4-BE49-F238E27FC236}">
-                <a16:creationId xmlns:a16="http://schemas.microsoft.com/office/drawing/2014/main" id="{8A5A6229-6977-4288-90AB-2022F9442D7A}"/>
+                <a16:creationId xmlns:a16="http://schemas.microsoft.com/office/drawing/2014/main" id="{F396F52A-1F1D-46A7-821E-61FB3659203C}"/>
               </a:ext>
             </a:extLst>
           </p:cNvPr>
@@ -8958,7 +8958,7 @@
           <p:cNvPr id="37" name="">
             <a:extLst xmlns:a="http://schemas.openxmlformats.org/drawingml/2006/main">
               <a:ext uri="{FF2B5EF4-FFF2-40B4-BE49-F238E27FC236}">
-                <a16:creationId xmlns:a16="http://schemas.microsoft.com/office/drawing/2014/main" id="{6538A734-E8FC-45E0-B051-76F6BE12F661}"/>
+                <a16:creationId xmlns:a16="http://schemas.microsoft.com/office/drawing/2014/main" id="{39B81B0F-A61B-4D01-BAB4-AE13A11613FF}"/>
               </a:ext>
             </a:extLst>
           </p:cNvPr>
@@ -8989,7 +8989,7 @@
           <p:cNvPr id="38" name="04 평가 지표 및 실험·통계 방법">
             <a:extLst xmlns:a="http://schemas.openxmlformats.org/drawingml/2006/main">
               <a:ext uri="{FF2B5EF4-FFF2-40B4-BE49-F238E27FC236}">
-                <a16:creationId xmlns:a16="http://schemas.microsoft.com/office/drawing/2014/main" id="{42350E51-28E2-4290-87E7-5CCC12CF1398}"/>
+                <a16:creationId xmlns:a16="http://schemas.microsoft.com/office/drawing/2014/main" id="{F13765E4-696C-4A33-A059-CF055D095393}"/>
               </a:ext>
             </a:extLst>
           </p:cNvPr>
@@ -9147,7 +9147,7 @@
           <p:cNvPr id="39" name="근거 충실도: 높을수록 검색 결과가 뒷받침하는 답변 주장 비율이 크다. 답변 관련성: 높을수록 답변 기반 질문과 원질">
             <a:extLst xmlns:a="http://schemas.openxmlformats.org/drawingml/2006/main">
               <a:ext uri="{FF2B5EF4-FFF2-40B4-BE49-F238E27FC236}">
-                <a16:creationId xmlns:a16="http://schemas.microsoft.com/office/drawing/2014/main" id="{0FC12234-BB8E-42E8-BDD8-10CCFAE0CF46}"/>
+                <a16:creationId xmlns:a16="http://schemas.microsoft.com/office/drawing/2014/main" id="{636E831F-D874-44D6-BEF6-CE3717F6F7EA}"/>
               </a:ext>
             </a:extLst>
           </p:cNvPr>
@@ -9397,7 +9397,7 @@
           <p:cNvPr id="40" name="품질 관측값은 0~1이다. 차이 = ON − OFF 평균. 한국어 비율 0.700은 70.0%, 차이 +0.218은 ">
             <a:extLst xmlns:a="http://schemas.openxmlformats.org/drawingml/2006/main">
               <a:ext uri="{FF2B5EF4-FFF2-40B4-BE49-F238E27FC236}">
-                <a16:creationId xmlns:a16="http://schemas.microsoft.com/office/drawing/2014/main" id="{052DBE33-B6D7-4FF5-BC2E-FE9919F45C6A}"/>
+                <a16:creationId xmlns:a16="http://schemas.microsoft.com/office/drawing/2014/main" id="{CCA67F45-C41A-4AF0-8CA0-51DC5FFFAA27}"/>
               </a:ext>
             </a:extLst>
           </p:cNvPr>
@@ -9578,7 +9578,7 @@
           <p:cNvPr id="41" name="평가 예시  ext_raptor_011, H0C0S0">
             <a:extLst xmlns:a="http://schemas.openxmlformats.org/drawingml/2006/main">
               <a:ext uri="{FF2B5EF4-FFF2-40B4-BE49-F238E27FC236}">
-                <a16:creationId xmlns:a16="http://schemas.microsoft.com/office/drawing/2014/main" id="{42463BC7-C840-4FFE-9853-E1E98292BC87}"/>
+                <a16:creationId xmlns:a16="http://schemas.microsoft.com/office/drawing/2014/main" id="{264E39CA-EF38-456A-A6CE-17FE94B06767}"/>
               </a:ext>
             </a:extLst>
           </p:cNvPr>
@@ -9736,7 +9736,7 @@
           <p:cNvPr id="42" name="질문: Cinderella 사례의 정성 분석에서 RAPTOR의 tree-based retrieval이 DPR보다 주제">
             <a:extLst xmlns:a="http://schemas.openxmlformats.org/drawingml/2006/main">
               <a:ext uri="{FF2B5EF4-FFF2-40B4-BE49-F238E27FC236}">
-                <a16:creationId xmlns:a16="http://schemas.microsoft.com/office/drawing/2014/main" id="{D3195CCF-9D16-4A11-8D07-41D841788435}"/>
+                <a16:creationId xmlns:a16="http://schemas.microsoft.com/office/drawing/2014/main" id="{F529F920-6248-453D-A5B1-BA94AB1E0F15}"/>
               </a:ext>
             </a:extLst>
           </p:cNvPr>
@@ -9917,7 +9917,7 @@
           <p:cNvPr id="43" name="검색 근거(PDF p.9): “By providing both the original text and higher-l">
             <a:extLst xmlns:a="http://schemas.openxmlformats.org/drawingml/2006/main">
               <a:ext uri="{FF2B5EF4-FFF2-40B4-BE49-F238E27FC236}">
-                <a16:creationId xmlns:a16="http://schemas.microsoft.com/office/drawing/2014/main" id="{8759FD28-866F-42A1-A29E-61ED7741BF01}"/>
+                <a16:creationId xmlns:a16="http://schemas.microsoft.com/office/drawing/2014/main" id="{E7B08066-6E5D-43E1-AE37-CDFFF208AC0F}"/>
               </a:ext>
             </a:extLst>
           </p:cNvPr>
@@ -10121,7 +10121,7 @@
           <p:cNvPr id="44" name="참조 답변 요지(PDF p.20): RAPTOR는 이야기의 주요 부분을, DPR은 이야기의 좁은 일부를 자세히 검색한">
             <a:extLst xmlns:a="http://schemas.openxmlformats.org/drawingml/2006/main">
               <a:ext uri="{FF2B5EF4-FFF2-40B4-BE49-F238E27FC236}">
-                <a16:creationId xmlns:a16="http://schemas.microsoft.com/office/drawing/2014/main" id="{154FEC9A-6A38-417F-9D52-30F629604C78}"/>
+                <a16:creationId xmlns:a16="http://schemas.microsoft.com/office/drawing/2014/main" id="{18964C21-A579-461E-85C4-78CD196A48E4}"/>
               </a:ext>
             </a:extLst>
           </p:cNvPr>
@@ -10302,7 +10302,7 @@
           <p:cNvPr id="45" name="생성 답변 발췌: “질문의 요구사항에 따라 서로 다른 층위(layer)에서 노드를 선택할 수 있습니다.”">
             <a:extLst xmlns:a="http://schemas.openxmlformats.org/drawingml/2006/main">
               <a:ext uri="{FF2B5EF4-FFF2-40B4-BE49-F238E27FC236}">
-                <a16:creationId xmlns:a16="http://schemas.microsoft.com/office/drawing/2014/main" id="{A5843330-FCC8-473E-B9C8-72232576A19E}"/>
+                <a16:creationId xmlns:a16="http://schemas.microsoft.com/office/drawing/2014/main" id="{F4FF1B30-905E-41E8-9D35-86BFC1AE8126}"/>
               </a:ext>
             </a:extLst>
           </p:cNvPr>
@@ -10483,7 +10483,7 @@
           <p:cNvPr id="46" name="충실도 1.000: 추출된 답변 주장을 검색 결과가 모두 지지 관련성 0.937: 답변 기반 질문과 원질문의 평균 의">
             <a:extLst xmlns:a="http://schemas.openxmlformats.org/drawingml/2006/main">
               <a:ext uri="{FF2B5EF4-FFF2-40B4-BE49-F238E27FC236}">
-                <a16:creationId xmlns:a16="http://schemas.microsoft.com/office/drawing/2014/main" id="{C7D6F98D-F8B2-4BCD-8DB6-5D8BD9C181FC}"/>
+                <a16:creationId xmlns:a16="http://schemas.microsoft.com/office/drawing/2014/main" id="{D9557E79-36C3-45EE-9035-27088B2DCE4F}"/>
               </a:ext>
             </a:extLst>
           </p:cNvPr>
@@ -10664,7 +10664,7 @@
           <p:cNvPr id="47" name="평가: RAGAS 0.2.15[10]·gpt-4o·BGE-M3, 저장 답변 평가 평가 언어: S0 영어 / S1 한국">
             <a:extLst xmlns:a="http://schemas.openxmlformats.org/drawingml/2006/main">
               <a:ext uri="{FF2B5EF4-FFF2-40B4-BE49-F238E27FC236}">
-                <a16:creationId xmlns:a16="http://schemas.microsoft.com/office/drawing/2014/main" id="{5071E758-DA13-4CB7-8950-D2EC90A992D2}"/>
+                <a16:creationId xmlns:a16="http://schemas.microsoft.com/office/drawing/2014/main" id="{566075CC-5BCA-4C4A-A538-DD990DCCB5A8}"/>
               </a:ext>
             </a:extLst>
           </p:cNvPr>
@@ -10845,7 +10845,7 @@
           <p:cNvPr id="48" name="반복측정 분산분석(ANOVA)·대응 t-검정, 양측 α=0.05 품질: SCD 상태별 H×C / 한국어 비율·시간: ">
             <a:extLst xmlns:a="http://schemas.openxmlformats.org/drawingml/2006/main">
               <a:ext uri="{FF2B5EF4-FFF2-40B4-BE49-F238E27FC236}">
-                <a16:creationId xmlns:a16="http://schemas.microsoft.com/office/drawing/2014/main" id="{5E57602E-2261-42A2-9DB3-1EFC285C0C68}"/>
+                <a16:creationId xmlns:a16="http://schemas.microsoft.com/office/drawing/2014/main" id="{78EC1220-8A54-4432-877F-E45B099FBD4B}"/>
               </a:ext>
             </a:extLst>
           </p:cNvPr>
@@ -11026,7 +11026,7 @@
           <p:cNvPr id="49" name="">
             <a:extLst xmlns:a="http://schemas.openxmlformats.org/drawingml/2006/main">
               <a:ext uri="{FF2B5EF4-FFF2-40B4-BE49-F238E27FC236}">
-                <a16:creationId xmlns:a16="http://schemas.microsoft.com/office/drawing/2014/main" id="{EAD37014-39C4-4F6D-BAE7-0DECC6DEBAB1}"/>
+                <a16:creationId xmlns:a16="http://schemas.microsoft.com/office/drawing/2014/main" id="{4BC480BD-DCDF-4524-A11F-C9A5BDE99DF8}"/>
               </a:ext>
             </a:extLst>
           </p:cNvPr>
@@ -11057,7 +11057,7 @@
           <p:cNvPr id="50" name="05 조합별 결과와 통계 검정">
             <a:extLst xmlns:a="http://schemas.openxmlformats.org/drawingml/2006/main">
               <a:ext uri="{FF2B5EF4-FFF2-40B4-BE49-F238E27FC236}">
-                <a16:creationId xmlns:a16="http://schemas.microsoft.com/office/drawing/2014/main" id="{17283022-CED4-43EC-A4A4-3DCE02B09C3D}"/>
+                <a16:creationId xmlns:a16="http://schemas.microsoft.com/office/drawing/2014/main" id="{F714C7E8-6361-4130-8482-93B0F4A77427}"/>
               </a:ext>
             </a:extLst>
           </p:cNvPr>
@@ -11215,7 +11215,7 @@
           <p:cNvPr id="51" name="HyDE·CAD·SCD 8조합의 품질·한국어 비율·시간 평균(SD)">
             <a:extLst xmlns:a="http://schemas.openxmlformats.org/drawingml/2006/main">
               <a:ext uri="{FF2B5EF4-FFF2-40B4-BE49-F238E27FC236}">
-                <a16:creationId xmlns:a16="http://schemas.microsoft.com/office/drawing/2014/main" id="{F1BBD6C3-D66C-4D86-B241-5F385271F9FE}"/>
+                <a16:creationId xmlns:a16="http://schemas.microsoft.com/office/drawing/2014/main" id="{EB38499C-7E90-416C-BF49-66DECC10B7F7}"/>
               </a:ext>
             </a:extLst>
           </p:cNvPr>
@@ -11373,7 +11373,7 @@
           <p:cNvPr id="52" name="">
             <a:extLst xmlns:a="http://schemas.openxmlformats.org/drawingml/2006/main">
               <a:ext uri="{FF2B5EF4-FFF2-40B4-BE49-F238E27FC236}">
-                <a16:creationId xmlns:a16="http://schemas.microsoft.com/office/drawing/2014/main" id="{94A0EB5B-A82B-45D7-AF25-903592368B34}"/>
+                <a16:creationId xmlns:a16="http://schemas.microsoft.com/office/drawing/2014/main" id="{1D106931-8371-43A6-93A2-E1402F194973}"/>
               </a:ext>
             </a:extLst>
           </p:cNvPr>
@@ -14733,7 +14733,7 @@
           <p:cNvPr id="53" name="">
             <a:extLst xmlns:a="http://schemas.openxmlformats.org/drawingml/2006/main">
               <a:ext uri="{FF2B5EF4-FFF2-40B4-BE49-F238E27FC236}">
-                <a16:creationId xmlns:a16="http://schemas.microsoft.com/office/drawing/2014/main" id="{AA4F8771-8813-4F9F-A387-3EE67CBB3B7F}"/>
+                <a16:creationId xmlns:a16="http://schemas.microsoft.com/office/drawing/2014/main" id="{45DC1508-9867-417C-BF3C-99A22EBCA065}"/>
               </a:ext>
             </a:extLst>
           </p:cNvPr>
@@ -14764,7 +14764,7 @@
           <p:cNvPr id="54" name="S0: 영어로 평가 / S1: 한국어 번역으로 평가 충실도 H0C1S0 n=58, H0C0S1 n=57, 나머지 n=">
             <a:extLst xmlns:a="http://schemas.openxmlformats.org/drawingml/2006/main">
               <a:ext uri="{FF2B5EF4-FFF2-40B4-BE49-F238E27FC236}">
-                <a16:creationId xmlns:a16="http://schemas.microsoft.com/office/drawing/2014/main" id="{314DD4E3-DD82-4F16-9D78-EC57094DE293}"/>
+                <a16:creationId xmlns:a16="http://schemas.microsoft.com/office/drawing/2014/main" id="{8814ADC1-2079-4018-812F-DFA8344F8042}"/>
               </a:ext>
             </a:extLst>
           </p:cNvPr>
@@ -14968,7 +14968,7 @@
           <p:cNvPr id="55" name="3요인 반복측정 ANOVA  ·  각 효과 df=(1,59)">
             <a:extLst xmlns:a="http://schemas.openxmlformats.org/drawingml/2006/main">
               <a:ext uri="{FF2B5EF4-FFF2-40B4-BE49-F238E27FC236}">
-                <a16:creationId xmlns:a16="http://schemas.microsoft.com/office/drawing/2014/main" id="{6BF9FBDC-A32F-4789-AACC-54C2D48499A7}"/>
+                <a16:creationId xmlns:a16="http://schemas.microsoft.com/office/drawing/2014/main" id="{523B2149-6F87-4389-BFDA-6E964593E23C}"/>
               </a:ext>
             </a:extLst>
           </p:cNvPr>
@@ -15126,7 +15126,7 @@
           <p:cNvPr id="56" name="">
             <a:extLst xmlns:a="http://schemas.openxmlformats.org/drawingml/2006/main">
               <a:ext uri="{FF2B5EF4-FFF2-40B4-BE49-F238E27FC236}">
-                <a16:creationId xmlns:a16="http://schemas.microsoft.com/office/drawing/2014/main" id="{9DDDF60B-3C9A-47EA-83CD-A6842FECA7C9}"/>
+                <a16:creationId xmlns:a16="http://schemas.microsoft.com/office/drawing/2014/main" id="{5CAEBC21-F0E0-4D6A-A3D5-BA19EA533133}"/>
               </a:ext>
             </a:extLst>
           </p:cNvPr>
@@ -16836,10 +16836,10 @@
       </p:graphicFrame>
       <p:sp>
         <p:nvSpPr>
-          <p:cNvPr id="57" name="p&lt;0.05: 한국어 비율 S·H×C* / 실행 시간 H·C·S*·C×S (*유의수준 근처의 탐색적 결과) RAGAS">
+          <p:cNvPr id="57" name="p&lt;0.05: 한국어 비율 S·H×C / 실행 시간 H·C·S·C×S RAGAS H×C 검정은 평가 언어별로 수행했으">
             <a:extLst xmlns:a="http://schemas.openxmlformats.org/drawingml/2006/main">
               <a:ext uri="{FF2B5EF4-FFF2-40B4-BE49-F238E27FC236}">
-                <a16:creationId xmlns:a16="http://schemas.microsoft.com/office/drawing/2014/main" id="{2C380E27-FBC0-4C2D-90F9-B53370C8244B}"/>
+                <a16:creationId xmlns:a16="http://schemas.microsoft.com/office/drawing/2014/main" id="{68415212-689D-4787-B9BC-D11576F36264}"/>
               </a:ext>
             </a:extLst>
           </p:cNvPr>
@@ -16987,7 +16987,7 @@
                 <a:ea typeface="Malgun Gothic"/>
                 <a:cs typeface="Malgun Gothic"/>
               </a:rPr>
-              <a:t>p&lt;0.05: 한국어 비율 S·H×C* / 실행 시간 H·C·S*·C×S (*유의수준 근처의 탐색적 결과)</a:t>
+              <a:t>p&lt;0.05: 한국어 비율 S·H×C / 실행 시간 H·C·S·C×S</a:t>
             </a:r>
           </a:p>
           <a:p xmlns:a="http://schemas.openxmlformats.org/drawingml/2006/main">
@@ -17043,7 +17043,7 @@
           <p:cNvPr id="58" name="기법별 대응 비교  ·  질의별 평균 차이, 양측 검정">
             <a:extLst xmlns:a="http://schemas.openxmlformats.org/drawingml/2006/main">
               <a:ext uri="{FF2B5EF4-FFF2-40B4-BE49-F238E27FC236}">
-                <a16:creationId xmlns:a16="http://schemas.microsoft.com/office/drawing/2014/main" id="{A9FDAFE2-6273-4DDF-8593-E035E82398A3}"/>
+                <a16:creationId xmlns:a16="http://schemas.microsoft.com/office/drawing/2014/main" id="{0A708DCF-AF52-4F8E-A661-5A4B290E7142}"/>
               </a:ext>
             </a:extLst>
           </p:cNvPr>
@@ -17201,7 +17201,7 @@
           <p:cNvPr id="59" name="">
             <a:extLst xmlns:a="http://schemas.openxmlformats.org/drawingml/2006/main">
               <a:ext uri="{FF2B5EF4-FFF2-40B4-BE49-F238E27FC236}">
-                <a16:creationId xmlns:a16="http://schemas.microsoft.com/office/drawing/2014/main" id="{9F6A9977-4B0B-4527-B348-A389D9023DE4}"/>
+                <a16:creationId xmlns:a16="http://schemas.microsoft.com/office/drawing/2014/main" id="{4DAB576C-0F1A-4DFF-A6F6-BA8547566394}"/>
               </a:ext>
             </a:extLst>
           </p:cNvPr>
@@ -18211,10 +18211,10 @@
       </p:graphicFrame>
       <p:sp>
         <p:nvSpPr>
-          <p:cNvPr id="60" name="HyDE: C0S0, CAD: H0S0, SCD: H0의 CAD 상태 평균 p: 다중비교 보정 없는 양측 p, dz:">
+          <p:cNvPr id="60" name="HyDE: C0S0, CAD: H0S0, SCD: H0의 CAD 상태 평균 p: 양측 p, dz: 차이 평균/차이 S">
             <a:extLst xmlns:a="http://schemas.openxmlformats.org/drawingml/2006/main">
               <a:ext uri="{FF2B5EF4-FFF2-40B4-BE49-F238E27FC236}">
-                <a16:creationId xmlns:a16="http://schemas.microsoft.com/office/drawing/2014/main" id="{1E2E695C-A79C-4009-B989-D09346E70F7A}"/>
+                <a16:creationId xmlns:a16="http://schemas.microsoft.com/office/drawing/2014/main" id="{5D6F7B2C-923C-4712-A536-E8560C5EF4F3}"/>
               </a:ext>
             </a:extLst>
           </p:cNvPr>
@@ -18385,7 +18385,7 @@
                 <a:ea typeface="Malgun Gothic"/>
                 <a:cs typeface="Malgun Gothic"/>
               </a:rPr>
-              <a:t>p: 다중비교 보정 없는 양측 p, dz: 차이 평균/차이 SD</a:t>
+              <a:t>p: 양측 p, dz: 차이 평균/차이 SD</a:t>
             </a:r>
           </a:p>
           <a:p xmlns:a="http://schemas.openxmlformats.org/drawingml/2006/main">
@@ -18418,7 +18418,7 @@
           <p:cNvPr id="61" name="">
             <a:extLst xmlns:a="http://schemas.openxmlformats.org/drawingml/2006/main">
               <a:ext uri="{FF2B5EF4-FFF2-40B4-BE49-F238E27FC236}">
-                <a16:creationId xmlns:a16="http://schemas.microsoft.com/office/drawing/2014/main" id="{175C7A03-AEDB-454E-B226-0987C1C27142}"/>
+                <a16:creationId xmlns:a16="http://schemas.microsoft.com/office/drawing/2014/main" id="{C06B35C2-3140-4DE0-ACD6-74441CC8A288}"/>
               </a:ext>
             </a:extLst>
           </p:cNvPr>
@@ -18449,7 +18449,7 @@
           <p:cNvPr id="62" name="06 결과 해석">
             <a:extLst xmlns:a="http://schemas.openxmlformats.org/drawingml/2006/main">
               <a:ext uri="{FF2B5EF4-FFF2-40B4-BE49-F238E27FC236}">
-                <a16:creationId xmlns:a16="http://schemas.microsoft.com/office/drawing/2014/main" id="{7E6AD3EF-65F1-4B1C-9845-DB45F2C9C7B6}"/>
+                <a16:creationId xmlns:a16="http://schemas.microsoft.com/office/drawing/2014/main" id="{96D7BF30-D1F8-4E35-8AE0-48B7ECE309EC}"/>
               </a:ext>
             </a:extLst>
           </p:cNvPr>
@@ -18607,7 +18607,7 @@
           <p:cNvPr id="63" name="HyDE: 기본 조건에서 관련성이 유의하게 높았으나(p=0.029), SCD 적용 조건의 추가 비교에서는 p=0.11">
             <a:extLst xmlns:a="http://schemas.openxmlformats.org/drawingml/2006/main">
               <a:ext uri="{FF2B5EF4-FFF2-40B4-BE49-F238E27FC236}">
-                <a16:creationId xmlns:a16="http://schemas.microsoft.com/office/drawing/2014/main" id="{391FEC8D-D043-4DE0-90DC-C32E507BC223}"/>
+                <a16:creationId xmlns:a16="http://schemas.microsoft.com/office/drawing/2014/main" id="{76584C04-50B2-44D3-89EF-107EA2449487}"/>
               </a:ext>
             </a:extLst>
           </p:cNvPr>
@@ -18857,7 +18857,7 @@
           <p:cNvPr id="64" name="">
             <a:extLst xmlns:a="http://schemas.openxmlformats.org/drawingml/2006/main">
               <a:ext uri="{FF2B5EF4-FFF2-40B4-BE49-F238E27FC236}">
-                <a16:creationId xmlns:a16="http://schemas.microsoft.com/office/drawing/2014/main" id="{1E4E6D9F-FF64-426C-9282-B1292F0EABA8}"/>
+                <a16:creationId xmlns:a16="http://schemas.microsoft.com/office/drawing/2014/main" id="{F7955013-B764-46DF-BDD7-5B0F9107001A}"/>
               </a:ext>
             </a:extLst>
           </p:cNvPr>
@@ -18888,7 +18888,7 @@
           <p:cNvPr id="65" name="07 결론">
             <a:extLst xmlns:a="http://schemas.openxmlformats.org/drawingml/2006/main">
               <a:ext uri="{FF2B5EF4-FFF2-40B4-BE49-F238E27FC236}">
-                <a16:creationId xmlns:a16="http://schemas.microsoft.com/office/drawing/2014/main" id="{2FC9ABC9-3D15-44CE-81B0-0F678545E477}"/>
+                <a16:creationId xmlns:a16="http://schemas.microsoft.com/office/drawing/2014/main" id="{8F9D01A6-2187-443F-BF7A-F7777E08CB39}"/>
               </a:ext>
             </a:extLst>
           </p:cNvPr>
@@ -19046,7 +19046,7 @@
           <p:cNvPr id="66" name="한국어 답변이 필요하면 SCD가 비용이 작은 선택지다. HyDE의 관련성 향상은 기본 조건(C0S0)에서 관측되었고,">
             <a:extLst xmlns:a="http://schemas.openxmlformats.org/drawingml/2006/main">
               <a:ext uri="{FF2B5EF4-FFF2-40B4-BE49-F238E27FC236}">
-                <a16:creationId xmlns:a16="http://schemas.microsoft.com/office/drawing/2014/main" id="{CC87F262-3418-49C9-A3A1-B0D141AA6D2C}"/>
+                <a16:creationId xmlns:a16="http://schemas.microsoft.com/office/drawing/2014/main" id="{D3A283A5-8665-4E04-94AC-FD2237E9D670}"/>
               </a:ext>
             </a:extLst>
           </p:cNvPr>
@@ -19319,7 +19319,7 @@
           <p:cNvPr id="67" name="">
             <a:extLst xmlns:a="http://schemas.openxmlformats.org/drawingml/2006/main">
               <a:ext uri="{FF2B5EF4-FFF2-40B4-BE49-F238E27FC236}">
-                <a16:creationId xmlns:a16="http://schemas.microsoft.com/office/drawing/2014/main" id="{16F16CB1-C36A-4429-A2D3-54C3A5D4D1E3}"/>
+                <a16:creationId xmlns:a16="http://schemas.microsoft.com/office/drawing/2014/main" id="{3E8E2E6C-A17C-4D4E-8C12-704584686269}"/>
               </a:ext>
             </a:extLst>
           </p:cNvPr>
@@ -19350,7 +19350,7 @@
           <p:cNvPr id="68" name="08 주요 참고문헌">
             <a:extLst xmlns:a="http://schemas.openxmlformats.org/drawingml/2006/main">
               <a:ext uri="{FF2B5EF4-FFF2-40B4-BE49-F238E27FC236}">
-                <a16:creationId xmlns:a16="http://schemas.microsoft.com/office/drawing/2014/main" id="{0D58FB18-D2FD-4165-BC4A-9C5E540399ED}"/>
+                <a16:creationId xmlns:a16="http://schemas.microsoft.com/office/drawing/2014/main" id="{B2D6977F-DA73-46B9-9F88-5B217A6B79E3}"/>
               </a:ext>
             </a:extLst>
           </p:cNvPr>
@@ -19508,7 +19508,7 @@
           <p:cNvPr id="69" name="[1] Lewis et al. RAG. NeurIPS, 2020. [2] Gao et al. HyDE. ACL, 20">
             <a:extLst xmlns:a="http://schemas.openxmlformats.org/drawingml/2006/main">
               <a:ext uri="{FF2B5EF4-FFF2-40B4-BE49-F238E27FC236}">
-                <a16:creationId xmlns:a16="http://schemas.microsoft.com/office/drawing/2014/main" id="{E164C105-BD18-402E-BEED-BA5D4C47F0CA}"/>
+                <a16:creationId xmlns:a16="http://schemas.microsoft.com/office/drawing/2014/main" id="{421CF83B-D3B0-4688-A147-F9F4AB5053F9}"/>
               </a:ext>
             </a:extLst>
           </p:cNvPr>
@@ -19712,7 +19712,7 @@
           <p:cNvPr id="70" name="[4] Li et al. Language Drift and SCD. AAAI, 2026. [5] Chen et al.">
             <a:extLst xmlns:a="http://schemas.openxmlformats.org/drawingml/2006/main">
               <a:ext uri="{FF2B5EF4-FFF2-40B4-BE49-F238E27FC236}">
-                <a16:creationId xmlns:a16="http://schemas.microsoft.com/office/drawing/2014/main" id="{8DBAD3F8-7E2B-4D1C-AA17-F50456C97380}"/>
+                <a16:creationId xmlns:a16="http://schemas.microsoft.com/office/drawing/2014/main" id="{996F7F1B-2882-4A97-8C29-6D444B3AA2A9}"/>
               </a:ext>
             </a:extLst>
           </p:cNvPr>
@@ -19916,7 +19916,7 @@
           <p:cNvPr id="71" name="[6] Robertson et al. Okapi at TREC-3. NIST, 1995. [7] Cormack et ">
             <a:extLst xmlns:a="http://schemas.openxmlformats.org/drawingml/2006/main">
               <a:ext uri="{FF2B5EF4-FFF2-40B4-BE49-F238E27FC236}">
-                <a16:creationId xmlns:a16="http://schemas.microsoft.com/office/drawing/2014/main" id="{1CFB87A3-25F3-4CF6-A411-DD9B3CF83386}"/>
+                <a16:creationId xmlns:a16="http://schemas.microsoft.com/office/drawing/2014/main" id="{2A15DEEB-666F-4975-8143-3A35A69A1E3F}"/>
               </a:ext>
             </a:extLst>
           </p:cNvPr>
@@ -20097,7 +20097,7 @@
           <p:cNvPr id="72" name="[8] MacAvaney et al. CEDR. SIGIR, 2019. 공식 모델  [M1] KT Mi:dm 2.0 ">
             <a:extLst xmlns:a="http://schemas.openxmlformats.org/drawingml/2006/main">
               <a:ext uri="{FF2B5EF4-FFF2-40B4-BE49-F238E27FC236}">
-                <a16:creationId xmlns:a16="http://schemas.microsoft.com/office/drawing/2014/main" id="{FA0D2E31-FAB9-45E3-A944-0B1738148418}"/>
+                <a16:creationId xmlns:a16="http://schemas.microsoft.com/office/drawing/2014/main" id="{B45BAEF3-0C63-4BC4-BA2D-6B806FF7615A}"/>
               </a:ext>
             </a:extLst>
           </p:cNvPr>
@@ -20278,7 +20278,7 @@
           <p:cNvPr id="73" name="전체 참고문헌 22편과 모델·자료 출처는 논문의 참고문헌에 수록">
             <a:extLst xmlns:a="http://schemas.openxmlformats.org/drawingml/2006/main">
               <a:ext uri="{FF2B5EF4-FFF2-40B4-BE49-F238E27FC236}">
-                <a16:creationId xmlns:a16="http://schemas.microsoft.com/office/drawing/2014/main" id="{E40C1743-BE43-4DD1-A944-0F2A948C14C0}"/>
+                <a16:creationId xmlns:a16="http://schemas.microsoft.com/office/drawing/2014/main" id="{6DC40DE2-6A21-4D73-B1A0-FF336936B3CE}"/>
               </a:ext>
             </a:extLst>
           </p:cNvPr>
@@ -20436,7 +20436,7 @@
           <p:cNvPr id="74" name="영어 문서 4종 · 질의 60개 · 생성 모델 1종 · 질의별 반복측정">
             <a:extLst xmlns:a="http://schemas.openxmlformats.org/drawingml/2006/main">
               <a:ext uri="{FF2B5EF4-FFF2-40B4-BE49-F238E27FC236}">
-                <a16:creationId xmlns:a16="http://schemas.microsoft.com/office/drawing/2014/main" id="{4DC9917E-4A31-4AA2-B2DC-BE7BBA24E362}"/>
+                <a16:creationId xmlns:a16="http://schemas.microsoft.com/office/drawing/2014/main" id="{43690470-C233-4BA5-9A1C-14A7894D9F04}"/>
               </a:ext>
             </a:extLst>
           </p:cNvPr>
@@ -20594,7 +20594,7 @@
           <p:cNvPr id="75" name="A1 594 × 841 mm">
             <a:extLst xmlns:a="http://schemas.openxmlformats.org/drawingml/2006/main">
               <a:ext uri="{FF2B5EF4-FFF2-40B4-BE49-F238E27FC236}">
-                <a16:creationId xmlns:a16="http://schemas.microsoft.com/office/drawing/2014/main" id="{500B2A7D-9923-424D-B433-089D3CB2B750}"/>
+                <a16:creationId xmlns:a16="http://schemas.microsoft.com/office/drawing/2014/main" id="{449DAA75-75FB-4026-8E11-AB907B4F01C2}"/>
               </a:ext>
             </a:extLst>
           </p:cNvPr>
@@ -20750,7 +20750,7 @@
     </p:spTree>
     <p:extLst>
       <p:ext uri="{BB962C8B-B14F-4D97-AF65-F5344CB8AC3E}">
-        <p14:creationId xmlns:p14="http://schemas.microsoft.com/office/powerpoint/2010/main" val="1873406188"/>
+        <p14:creationId xmlns:p14="http://schemas.microsoft.com/office/powerpoint/2010/main" val="45596023"/>
       </p:ext>
     </p:extLst>
   </p:cSld>

</xml_diff>

<commit_message>
Apply the final sentence-level copyedit across the thesis
- Join short sentences that describe one procedure; remove deictic and
  explanatory frames ("이 분석은", "이 설계에서는 … 가능하다", "즉",
  "이 결과는 … 근거가 된다", section-pointer sentences)
- 2.7 opens with the concrete DPR/FiD contributions; 5.8 drops the
  first/second/third enumeration; 4.3 lone sentence merged into 4.2
- Align the C×S CAD time difference to 8.8 s in 5.7, 6.1 and the poster
- Analysis-contract marker updated to "실험 종료 후 선정"
- Add the R3 A-to-B table; regenerate HWPX/PDF (50 pages, positions
  unchanged) and refresh manifests

Co-Authored-By: Claude Opus 5.5 <noreply@anthropic.com>
</commit_message>
<xml_diff>
--- a/FINALDOCS/POSTER/FINAL/M_RAG_A1_FINAL_EDITABLE.pptx
+++ b/FINALDOCS/POSTER/FINAL/M_RAG_A1_FINAL_EDITABLE.pptx
@@ -2,13 +2,13 @@
 <file path=ppt/presentation.xml><?xml version="1.0" encoding="utf-8"?>
 <p:presentation xmlns:p="http://schemas.openxmlformats.org/presentationml/2006/main">
   <p:sldMasterIdLst>
-    <p:sldMasterId xmlns:r="http://schemas.openxmlformats.org/officeDocument/2006/relationships" id="2147483648" r:id="R9fd2536a6f6b4f45"/>
+    <p:sldMasterId xmlns:r="http://schemas.openxmlformats.org/officeDocument/2006/relationships" id="2147483648" r:id="Ra2c36bcd48a9477e"/>
   </p:sldMasterIdLst>
   <p:notesMasterIdLst>
-    <p:notesMasterId xmlns:r="http://schemas.openxmlformats.org/officeDocument/2006/relationships" r:id="Raba8f90d88304c22"/>
+    <p:notesMasterId xmlns:r="http://schemas.openxmlformats.org/officeDocument/2006/relationships" r:id="R06343fae3fb64c23"/>
   </p:notesMasterIdLst>
   <p:sldIdLst>
-    <p:sldId xmlns:r="http://schemas.openxmlformats.org/officeDocument/2006/relationships" id="256" r:id="Rd87cafdcd80940b1"/>
+    <p:sldId xmlns:r="http://schemas.openxmlformats.org/officeDocument/2006/relationships" id="256" r:id="R1781b0e238cd45a8"/>
   </p:sldIdLst>
   <p:sldSz cx="21384000" cy="30276000"/>
   <p:notesSz cx="6858000" cy="9144000"/>
@@ -489,7 +489,7 @@
           <p:cNvPr id="3" name="Title">
             <a:extLst xmlns:a="http://schemas.openxmlformats.org/drawingml/2006/main">
               <a:ext uri="{FF2B5EF4-FFF2-40B4-BE49-F238E27FC236}">
-                <a16:creationId xmlns:a16="http://schemas.microsoft.com/office/drawing/2014/main" id="{D832956D-08C3-4827-934F-220576271E5E}"/>
+                <a16:creationId xmlns:a16="http://schemas.microsoft.com/office/drawing/2014/main" id="{75F0FC80-33EF-4042-BD27-217C47BB66FC}"/>
               </a:ext>
             </a:extLst>
           </p:cNvPr>
@@ -718,7 +718,7 @@
           <p:cNvPr id="2" name="Subtitle">
             <a:extLst xmlns:a="http://schemas.openxmlformats.org/drawingml/2006/main">
               <a:ext uri="{FF2B5EF4-FFF2-40B4-BE49-F238E27FC236}">
-                <a16:creationId xmlns:a16="http://schemas.microsoft.com/office/drawing/2014/main" id="{E5356177-0C47-473C-9375-4BD5ECAD057B}"/>
+                <a16:creationId xmlns:a16="http://schemas.microsoft.com/office/drawing/2014/main" id="{5879261E-DE5F-490E-8673-8206B58A1724}"/>
               </a:ext>
             </a:extLst>
           </p:cNvPr>
@@ -964,7 +964,7 @@
           <p:cNvPr id="2" name="Section title">
             <a:extLst xmlns:a="http://schemas.openxmlformats.org/drawingml/2006/main">
               <a:ext uri="{FF2B5EF4-FFF2-40B4-BE49-F238E27FC236}">
-                <a16:creationId xmlns:a16="http://schemas.microsoft.com/office/drawing/2014/main" id="{6A8FDCE7-A4A1-47AE-89B8-BFEB787697D2}"/>
+                <a16:creationId xmlns:a16="http://schemas.microsoft.com/office/drawing/2014/main" id="{6044AF0A-1A94-429A-9D80-F6D58E867412}"/>
               </a:ext>
             </a:extLst>
           </p:cNvPr>
@@ -1210,7 +1210,7 @@
           <p:cNvPr id="3" name="Title">
             <a:extLst xmlns:a="http://schemas.openxmlformats.org/drawingml/2006/main">
               <a:ext uri="{FF2B5EF4-FFF2-40B4-BE49-F238E27FC236}">
-                <a16:creationId xmlns:a16="http://schemas.microsoft.com/office/drawing/2014/main" id="{7E7B6CD9-A567-4EC3-BCED-E8168AF40BAA}"/>
+                <a16:creationId xmlns:a16="http://schemas.microsoft.com/office/drawing/2014/main" id="{3C62F454-E1ED-4642-9A86-050B066F47A7}"/>
               </a:ext>
             </a:extLst>
           </p:cNvPr>
@@ -1439,7 +1439,7 @@
           <p:cNvPr id="2" name="Body">
             <a:extLst xmlns:a="http://schemas.openxmlformats.org/drawingml/2006/main">
               <a:ext uri="{FF2B5EF4-FFF2-40B4-BE49-F238E27FC236}">
-                <a16:creationId xmlns:a16="http://schemas.microsoft.com/office/drawing/2014/main" id="{163F34AF-7718-48EC-AD21-4645F7C0D7A5}"/>
+                <a16:creationId xmlns:a16="http://schemas.microsoft.com/office/drawing/2014/main" id="{BE2662AB-790A-4212-969F-F6A246AE1509}"/>
               </a:ext>
             </a:extLst>
           </p:cNvPr>
@@ -1685,7 +1685,7 @@
           <p:cNvPr id="4" name="Title">
             <a:extLst xmlns:a="http://schemas.openxmlformats.org/drawingml/2006/main">
               <a:ext uri="{FF2B5EF4-FFF2-40B4-BE49-F238E27FC236}">
-                <a16:creationId xmlns:a16="http://schemas.microsoft.com/office/drawing/2014/main" id="{DA253EC0-DF8F-41C3-926A-51E1BD19EE8F}"/>
+                <a16:creationId xmlns:a16="http://schemas.microsoft.com/office/drawing/2014/main" id="{5F9CD04D-6A29-4CCF-B3E1-B345337DCAF3}"/>
               </a:ext>
             </a:extLst>
           </p:cNvPr>
@@ -1914,7 +1914,7 @@
           <p:cNvPr id="2" name="Left column">
             <a:extLst xmlns:a="http://schemas.openxmlformats.org/drawingml/2006/main">
               <a:ext uri="{FF2B5EF4-FFF2-40B4-BE49-F238E27FC236}">
-                <a16:creationId xmlns:a16="http://schemas.microsoft.com/office/drawing/2014/main" id="{1240EE67-E295-4693-91A7-0DBB61A2CBCF}"/>
+                <a16:creationId xmlns:a16="http://schemas.microsoft.com/office/drawing/2014/main" id="{3811E2B2-623A-402D-A036-EA8AF17C4645}"/>
               </a:ext>
             </a:extLst>
           </p:cNvPr>
@@ -2143,7 +2143,7 @@
           <p:cNvPr id="3" name="Right column">
             <a:extLst xmlns:a="http://schemas.openxmlformats.org/drawingml/2006/main">
               <a:ext uri="{FF2B5EF4-FFF2-40B4-BE49-F238E27FC236}">
-                <a16:creationId xmlns:a16="http://schemas.microsoft.com/office/drawing/2014/main" id="{EF174303-D704-4893-AF2F-188D7CB54472}"/>
+                <a16:creationId xmlns:a16="http://schemas.microsoft.com/office/drawing/2014/main" id="{1F2B4204-233D-496B-82C2-FCEEC07520F7}"/>
               </a:ext>
             </a:extLst>
           </p:cNvPr>
@@ -2389,7 +2389,7 @@
           <p:cNvPr id="3" name="Title">
             <a:extLst xmlns:a="http://schemas.openxmlformats.org/drawingml/2006/main">
               <a:ext uri="{FF2B5EF4-FFF2-40B4-BE49-F238E27FC236}">
-                <a16:creationId xmlns:a16="http://schemas.microsoft.com/office/drawing/2014/main" id="{5000D7CC-354A-4FAC-9941-1F897B165FB9}"/>
+                <a16:creationId xmlns:a16="http://schemas.microsoft.com/office/drawing/2014/main" id="{A5697E72-E511-4986-BA80-805A34F6C371}"/>
               </a:ext>
             </a:extLst>
           </p:cNvPr>
@@ -2618,7 +2618,7 @@
           <p:cNvPr id="2" name="Left column">
             <a:extLst xmlns:a="http://schemas.openxmlformats.org/drawingml/2006/main">
               <a:ext uri="{FF2B5EF4-FFF2-40B4-BE49-F238E27FC236}">
-                <a16:creationId xmlns:a16="http://schemas.microsoft.com/office/drawing/2014/main" id="{1D8AF224-8DB7-4DF2-8970-9073A0A0A0E5}"/>
+                <a16:creationId xmlns:a16="http://schemas.microsoft.com/office/drawing/2014/main" id="{3D43CEBD-C7FA-44F0-9F0A-7186832BBF9D}"/>
               </a:ext>
             </a:extLst>
           </p:cNvPr>
@@ -2885,12 +2885,12 @@
   </p:cSld>
   <p:clrMap bg1="lt1" tx1="dk1" bg2="lt2" tx2="dk2" accent1="accent1" accent2="accent2" accent3="accent3" accent4="accent4" accent5="accent5" accent6="accent6" hlink="hlink" folHlink="folHlink"/>
   <p:sldLayoutIdLst>
-    <p:sldLayoutId xmlns:r="http://schemas.openxmlformats.org/officeDocument/2006/relationships" id="2147483649" r:id="Rbe3672cd7726401a"/>
-    <p:sldLayoutId xmlns:r="http://schemas.openxmlformats.org/officeDocument/2006/relationships" id="2147483650" r:id="R4b90d84b3fc04874"/>
-    <p:sldLayoutId xmlns:r="http://schemas.openxmlformats.org/officeDocument/2006/relationships" id="2147483651" r:id="R23cc4dbaab5e41a7"/>
-    <p:sldLayoutId xmlns:r="http://schemas.openxmlformats.org/officeDocument/2006/relationships" id="2147483652" r:id="R0ec99dcb015143ac"/>
-    <p:sldLayoutId xmlns:r="http://schemas.openxmlformats.org/officeDocument/2006/relationships" id="2147483653" r:id="R388b9bcff8a14444"/>
-    <p:sldLayoutId xmlns:r="http://schemas.openxmlformats.org/officeDocument/2006/relationships" id="2147483654" r:id="R2c2883c8f49540bd"/>
+    <p:sldLayoutId xmlns:r="http://schemas.openxmlformats.org/officeDocument/2006/relationships" id="2147483649" r:id="Red1039956fa94ce6"/>
+    <p:sldLayoutId xmlns:r="http://schemas.openxmlformats.org/officeDocument/2006/relationships" id="2147483650" r:id="Re1811be2820c4590"/>
+    <p:sldLayoutId xmlns:r="http://schemas.openxmlformats.org/officeDocument/2006/relationships" id="2147483651" r:id="Ra72ff968aa954554"/>
+    <p:sldLayoutId xmlns:r="http://schemas.openxmlformats.org/officeDocument/2006/relationships" id="2147483652" r:id="R61735ee285bc4135"/>
+    <p:sldLayoutId xmlns:r="http://schemas.openxmlformats.org/officeDocument/2006/relationships" id="2147483653" r:id="Rf484aaf6ff5145fc"/>
+    <p:sldLayoutId xmlns:r="http://schemas.openxmlformats.org/officeDocument/2006/relationships" id="2147483654" r:id="R8ed2df2b2041493f"/>
   </p:sldLayoutIdLst>
   <p:txStyles>
     <p:titleStyle>
@@ -3441,7 +3441,7 @@
           <p:cNvPr id="76" name="">
             <a:extLst xmlns:a="http://schemas.openxmlformats.org/drawingml/2006/main">
               <a:ext uri="{FF2B5EF4-FFF2-40B4-BE49-F238E27FC236}">
-                <a16:creationId xmlns:a16="http://schemas.microsoft.com/office/drawing/2014/main" id="{FBC9EE69-D9B4-43E6-B0DF-ABEF7A814717}"/>
+                <a16:creationId xmlns:a16="http://schemas.microsoft.com/office/drawing/2014/main" id="{E395722E-0320-4928-8250-988BC7EA8D83}"/>
               </a:ext>
             </a:extLst>
           </p:cNvPr>
@@ -3472,7 +3472,7 @@
           <p:cNvPr id="2" name="한국어 질의로 영어 학술·기술 문서를 검색하는">
             <a:extLst xmlns:a="http://schemas.openxmlformats.org/drawingml/2006/main">
               <a:ext uri="{FF2B5EF4-FFF2-40B4-BE49-F238E27FC236}">
-                <a16:creationId xmlns:a16="http://schemas.microsoft.com/office/drawing/2014/main" id="{2610CEEF-D788-4E59-8D2F-1E55604178E0}"/>
+                <a16:creationId xmlns:a16="http://schemas.microsoft.com/office/drawing/2014/main" id="{AB9618D4-BFA7-4F4D-8076-D0E1D2C7611C}"/>
               </a:ext>
             </a:extLst>
           </p:cNvPr>
@@ -3630,7 +3630,7 @@
           <p:cNvPr id="3" name="RAG에서의 HyDE·CAD·SCD 조합 실험">
             <a:extLst xmlns:a="http://schemas.openxmlformats.org/drawingml/2006/main">
               <a:ext uri="{FF2B5EF4-FFF2-40B4-BE49-F238E27FC236}">
-                <a16:creationId xmlns:a16="http://schemas.microsoft.com/office/drawing/2014/main" id="{80200B53-05E6-4082-9DDD-06F687D0718E}"/>
+                <a16:creationId xmlns:a16="http://schemas.microsoft.com/office/drawing/2014/main" id="{ECDAF47B-5C67-44D7-BE8A-84F59BDB4676}"/>
               </a:ext>
             </a:extLst>
           </p:cNvPr>
@@ -3788,7 +3788,7 @@
           <p:cNvPr id="4" name="문종건 · 동국대학교 WISE캠퍼스 컴퓨터공학과 · 지도교수 김진석 · 2026.10.15">
             <a:extLst xmlns:a="http://schemas.openxmlformats.org/drawingml/2006/main">
               <a:ext uri="{FF2B5EF4-FFF2-40B4-BE49-F238E27FC236}">
-                <a16:creationId xmlns:a16="http://schemas.microsoft.com/office/drawing/2014/main" id="{A3B73D07-497E-433F-ACE7-8743EB73ED0D}"/>
+                <a16:creationId xmlns:a16="http://schemas.microsoft.com/office/drawing/2014/main" id="{4297F5BD-F081-4226-8199-39790737565D}"/>
               </a:ext>
             </a:extLst>
           </p:cNvPr>
@@ -3946,7 +3946,7 @@
           <p:cNvPr id="5" name="">
             <a:extLst xmlns:a="http://schemas.openxmlformats.org/drawingml/2006/main">
               <a:ext uri="{FF2B5EF4-FFF2-40B4-BE49-F238E27FC236}">
-                <a16:creationId xmlns:a16="http://schemas.microsoft.com/office/drawing/2014/main" id="{4458EC0B-EB3C-470C-808B-2D99A1797D65}"/>
+                <a16:creationId xmlns:a16="http://schemas.microsoft.com/office/drawing/2014/main" id="{14C471D1-4109-42E2-BBCF-714202F853A4}"/>
               </a:ext>
             </a:extLst>
           </p:cNvPr>
@@ -3977,7 +3977,7 @@
           <p:cNvPr id="6" name="01 연구 배경과 목적">
             <a:extLst xmlns:a="http://schemas.openxmlformats.org/drawingml/2006/main">
               <a:ext uri="{FF2B5EF4-FFF2-40B4-BE49-F238E27FC236}">
-                <a16:creationId xmlns:a16="http://schemas.microsoft.com/office/drawing/2014/main" id="{DA4F9ECA-4C0A-4C34-AB6D-64C9CAE56AC9}"/>
+                <a16:creationId xmlns:a16="http://schemas.microsoft.com/office/drawing/2014/main" id="{E2DA5D83-0888-4563-944F-F26D139B051C}"/>
               </a:ext>
             </a:extLst>
           </p:cNvPr>
@@ -4135,7 +4135,7 @@
           <p:cNvPr id="7" name="검색 증강 생성(Retrieval-Augmented Generation, RAG)은 관련 문서 구간을 검색하고 그 텍">
             <a:extLst xmlns:a="http://schemas.openxmlformats.org/drawingml/2006/main">
               <a:ext uri="{FF2B5EF4-FFF2-40B4-BE49-F238E27FC236}">
-                <a16:creationId xmlns:a16="http://schemas.microsoft.com/office/drawing/2014/main" id="{37732FBB-1D96-498F-B313-57DA14906F71}"/>
+                <a16:creationId xmlns:a16="http://schemas.microsoft.com/office/drawing/2014/main" id="{AC9E3F68-78AB-4EF4-A307-EFE9528A6943}"/>
               </a:ext>
             </a:extLst>
           </p:cNvPr>
@@ -4316,7 +4316,7 @@
           <p:cNvPr id="8" name="HyDE: 가상 문서 임베딩(Hypothetical Document Embeddings) 가상 문서 검색 입력 구성[">
             <a:extLst xmlns:a="http://schemas.openxmlformats.org/drawingml/2006/main">
               <a:ext uri="{FF2B5EF4-FFF2-40B4-BE49-F238E27FC236}">
-                <a16:creationId xmlns:a16="http://schemas.microsoft.com/office/drawing/2014/main" id="{944FFCBD-AE37-4055-AAB2-8BFC02DEADF5}"/>
+                <a16:creationId xmlns:a16="http://schemas.microsoft.com/office/drawing/2014/main" id="{FA53EF0D-05F1-48BE-8ED6-1A5D975CF0CE}"/>
               </a:ext>
             </a:extLst>
           </p:cNvPr>
@@ -4589,7 +4589,7 @@
           <p:cNvPr id="9" name="한국어 질의–영어 문서 RAG는 검색 어휘 차이, 근거 반영, 영어 출력(언어 이탈)의 문제를 함께 겪는다. 세 기법">
             <a:extLst xmlns:a="http://schemas.openxmlformats.org/drawingml/2006/main">
               <a:ext uri="{FF2B5EF4-FFF2-40B4-BE49-F238E27FC236}">
-                <a16:creationId xmlns:a16="http://schemas.microsoft.com/office/drawing/2014/main" id="{DC753385-61BF-4AB3-9D4A-37D18A51C0FD}"/>
+                <a16:creationId xmlns:a16="http://schemas.microsoft.com/office/drawing/2014/main" id="{0ECA771E-89F8-4C64-90F6-8CBAF4EBA409}"/>
               </a:ext>
             </a:extLst>
           </p:cNvPr>
@@ -4793,7 +4793,7 @@
           <p:cNvPr id="10" name="">
             <a:extLst xmlns:a="http://schemas.openxmlformats.org/drawingml/2006/main">
               <a:ext uri="{FF2B5EF4-FFF2-40B4-BE49-F238E27FC236}">
-                <a16:creationId xmlns:a16="http://schemas.microsoft.com/office/drawing/2014/main" id="{B696A5CE-CD46-46D9-BE8E-6C2B1F9CF97D}"/>
+                <a16:creationId xmlns:a16="http://schemas.microsoft.com/office/drawing/2014/main" id="{54279545-A96C-4FC4-97D7-F0D2D431C51B}"/>
               </a:ext>
             </a:extLst>
           </p:cNvPr>
@@ -4824,7 +4824,7 @@
           <p:cNvPr id="11" name="02 Paper-RAG 구조와 기법 적용 위치">
             <a:extLst xmlns:a="http://schemas.openxmlformats.org/drawingml/2006/main">
               <a:ext uri="{FF2B5EF4-FFF2-40B4-BE49-F238E27FC236}">
-                <a16:creationId xmlns:a16="http://schemas.microsoft.com/office/drawing/2014/main" id="{2CBC84C6-F3E5-42A8-A4F7-5F3A18326D07}"/>
+                <a16:creationId xmlns:a16="http://schemas.microsoft.com/office/drawing/2014/main" id="{7A248187-DE65-46BD-A6AC-2BE83F3380C8}"/>
               </a:ext>
             </a:extLst>
           </p:cNvPr>
@@ -4982,7 +4982,7 @@
           <p:cNvPr id="12" name="Paper-RAG는 실험에 사용한 고정 검색·생성 파이프라인이다.">
             <a:extLst xmlns:a="http://schemas.openxmlformats.org/drawingml/2006/main">
               <a:ext uri="{FF2B5EF4-FFF2-40B4-BE49-F238E27FC236}">
-                <a16:creationId xmlns:a16="http://schemas.microsoft.com/office/drawing/2014/main" id="{C3B51E66-7D60-45F4-AB78-3510670A13A0}"/>
+                <a16:creationId xmlns:a16="http://schemas.microsoft.com/office/drawing/2014/main" id="{CEB0B2CA-8A61-4FBE-B1BC-2EB891E55ACA}"/>
               </a:ext>
             </a:extLst>
           </p:cNvPr>
@@ -5140,7 +5140,7 @@
           <p:cNvPr id="13" name="">
             <a:extLst xmlns:a="http://schemas.openxmlformats.org/drawingml/2006/main">
               <a:ext uri="{FF2B5EF4-FFF2-40B4-BE49-F238E27FC236}">
-                <a16:creationId xmlns:a16="http://schemas.microsoft.com/office/drawing/2014/main" id="{A65FCA5A-4287-44C9-8343-9DF8A3E03112}"/>
+                <a16:creationId xmlns:a16="http://schemas.microsoft.com/office/drawing/2014/main" id="{336A3D45-18C9-4C90-BC40-E4CF50E9F6B4}"/>
               </a:ext>
             </a:extLst>
           </p:cNvPr>
@@ -5173,7 +5173,7 @@
           <p:cNvPr id="14" name="한국어 질의 HyDE OFF: 원질의 HyDE ON: 영어 번역·가상 문서">
             <a:extLst xmlns:a="http://schemas.openxmlformats.org/drawingml/2006/main">
               <a:ext uri="{FF2B5EF4-FFF2-40B4-BE49-F238E27FC236}">
-                <a16:creationId xmlns:a16="http://schemas.microsoft.com/office/drawing/2014/main" id="{162ECDEE-8A6D-4409-AC33-ED924EFAF55C}"/>
+                <a16:creationId xmlns:a16="http://schemas.microsoft.com/office/drawing/2014/main" id="{08A5248D-BB03-4DC2-8E7C-2F925D9F8CE1}"/>
               </a:ext>
             </a:extLst>
           </p:cNvPr>
@@ -5377,7 +5377,7 @@
           <p:cNvPr id="15" name="">
             <a:extLst xmlns:a="http://schemas.openxmlformats.org/drawingml/2006/main">
               <a:ext uri="{FF2B5EF4-FFF2-40B4-BE49-F238E27FC236}">
-                <a16:creationId xmlns:a16="http://schemas.microsoft.com/office/drawing/2014/main" id="{450BC193-C77A-41C1-A99F-FF84FEA235E2}"/>
+                <a16:creationId xmlns:a16="http://schemas.microsoft.com/office/drawing/2014/main" id="{EF9178C6-C1DD-4AFA-830B-2335478E0B74}"/>
               </a:ext>
             </a:extLst>
           </p:cNvPr>
@@ -5410,7 +5410,7 @@
           <p:cNvPr id="16" name="BM25 희소 검색[6] 한국어 원질의 사용">
             <a:extLst xmlns:a="http://schemas.openxmlformats.org/drawingml/2006/main">
               <a:ext uri="{FF2B5EF4-FFF2-40B4-BE49-F238E27FC236}">
-                <a16:creationId xmlns:a16="http://schemas.microsoft.com/office/drawing/2014/main" id="{573A5BBE-CAE9-4B5D-8908-A66414515B29}"/>
+                <a16:creationId xmlns:a16="http://schemas.microsoft.com/office/drawing/2014/main" id="{4AB568C2-B6FB-4971-9D7D-1DBEC816F117}"/>
               </a:ext>
             </a:extLst>
           </p:cNvPr>
@@ -5591,7 +5591,7 @@
           <p:cNvPr id="17" name="">
             <a:extLst xmlns:a="http://schemas.openxmlformats.org/drawingml/2006/main">
               <a:ext uri="{FF2B5EF4-FFF2-40B4-BE49-F238E27FC236}">
-                <a16:creationId xmlns:a16="http://schemas.microsoft.com/office/drawing/2014/main" id="{52A58E73-3E45-44A8-9F94-C2E2FE1EE271}"/>
+                <a16:creationId xmlns:a16="http://schemas.microsoft.com/office/drawing/2014/main" id="{4149C74A-5070-4157-BAF7-EC83A59A990F}"/>
               </a:ext>
             </a:extLst>
           </p:cNvPr>
@@ -5624,7 +5624,7 @@
           <p:cNvPr id="18" name="BGE-M3 밀집 검색[5]">
             <a:extLst xmlns:a="http://schemas.openxmlformats.org/drawingml/2006/main">
               <a:ext uri="{FF2B5EF4-FFF2-40B4-BE49-F238E27FC236}">
-                <a16:creationId xmlns:a16="http://schemas.microsoft.com/office/drawing/2014/main" id="{1BB0A00D-4780-4032-81E2-AFD57E2F775D}"/>
+                <a16:creationId xmlns:a16="http://schemas.microsoft.com/office/drawing/2014/main" id="{A9D96583-7E4D-4DBB-AE35-7C8C822516A0}"/>
               </a:ext>
             </a:extLst>
           </p:cNvPr>
@@ -5782,7 +5782,7 @@
           <p:cNvPr id="19" name="">
             <a:extLst xmlns:a="http://schemas.openxmlformats.org/drawingml/2006/main">
               <a:ext uri="{FF2B5EF4-FFF2-40B4-BE49-F238E27FC236}">
-                <a16:creationId xmlns:a16="http://schemas.microsoft.com/office/drawing/2014/main" id="{2C45909D-3951-4C3C-A69C-513F3CADF6DF}"/>
+                <a16:creationId xmlns:a16="http://schemas.microsoft.com/office/drawing/2014/main" id="{CC42528C-4725-435B-AB16-536A67103A58}"/>
               </a:ext>
             </a:extLst>
           </p:cNvPr>
@@ -5815,7 +5815,7 @@
           <p:cNvPr id="20" name="가중 RRF[7] 0.6 / 0.4, k=60">
             <a:extLst xmlns:a="http://schemas.openxmlformats.org/drawingml/2006/main">
               <a:ext uri="{FF2B5EF4-FFF2-40B4-BE49-F238E27FC236}">
-                <a16:creationId xmlns:a16="http://schemas.microsoft.com/office/drawing/2014/main" id="{71A23238-3235-41FB-860A-ED5F13D97006}"/>
+                <a16:creationId xmlns:a16="http://schemas.microsoft.com/office/drawing/2014/main" id="{1679DDD9-8C86-47C7-85C6-84E80F1506E9}"/>
               </a:ext>
             </a:extLst>
           </p:cNvPr>
@@ -5996,7 +5996,7 @@
           <p:cNvPr id="21" name="">
             <a:extLst xmlns:a="http://schemas.openxmlformats.org/drawingml/2006/main">
               <a:ext uri="{FF2B5EF4-FFF2-40B4-BE49-F238E27FC236}">
-                <a16:creationId xmlns:a16="http://schemas.microsoft.com/office/drawing/2014/main" id="{64E48D19-85DC-49B7-B949-E03F56682AEC}"/>
+                <a16:creationId xmlns:a16="http://schemas.microsoft.com/office/drawing/2014/main" id="{3A00CBE0-38EE-455A-A7C9-AE5369A07D28}"/>
               </a:ext>
             </a:extLst>
           </p:cNvPr>
@@ -6028,7 +6028,7 @@
           <p:cNvPr id="22" name="">
             <a:extLst xmlns:a="http://schemas.openxmlformats.org/drawingml/2006/main">
               <a:ext uri="{FF2B5EF4-FFF2-40B4-BE49-F238E27FC236}">
-                <a16:creationId xmlns:a16="http://schemas.microsoft.com/office/drawing/2014/main" id="{EFE69EC8-9BD8-4501-A8FD-98B7F348EA76}"/>
+                <a16:creationId xmlns:a16="http://schemas.microsoft.com/office/drawing/2014/main" id="{14C75861-DBC2-4E0D-B5AE-F74E5A1C27D1}"/>
               </a:ext>
             </a:extLst>
           </p:cNvPr>
@@ -6060,7 +6060,7 @@
           <p:cNvPr id="23" name="">
             <a:extLst xmlns:a="http://schemas.openxmlformats.org/drawingml/2006/main">
               <a:ext uri="{FF2B5EF4-FFF2-40B4-BE49-F238E27FC236}">
-                <a16:creationId xmlns:a16="http://schemas.microsoft.com/office/drawing/2014/main" id="{AB39E55E-552F-4336-812F-F5D566453ADB}"/>
+                <a16:creationId xmlns:a16="http://schemas.microsoft.com/office/drawing/2014/main" id="{2608E98F-1AF5-42D5-910B-0F37B4140B9B}"/>
               </a:ext>
             </a:extLst>
           </p:cNvPr>
@@ -6092,7 +6092,7 @@
           <p:cNvPr id="24" name="">
             <a:extLst xmlns:a="http://schemas.openxmlformats.org/drawingml/2006/main">
               <a:ext uri="{FF2B5EF4-FFF2-40B4-BE49-F238E27FC236}">
-                <a16:creationId xmlns:a16="http://schemas.microsoft.com/office/drawing/2014/main" id="{E87E0602-DD22-4274-94C0-793086A9E58B}"/>
+                <a16:creationId xmlns:a16="http://schemas.microsoft.com/office/drawing/2014/main" id="{B4E5DB06-D7AF-4EA4-AD52-BC72E37608C6}"/>
               </a:ext>
             </a:extLst>
           </p:cNvPr>
@@ -6125,7 +6125,7 @@
           <p:cNvPr id="25" name="원질의·구간 쌍 CrossEncoder 재정렬[8][M2] 상위 5개 구간 선택·입력 길이 관리">
             <a:extLst xmlns:a="http://schemas.openxmlformats.org/drawingml/2006/main">
               <a:ext uri="{FF2B5EF4-FFF2-40B4-BE49-F238E27FC236}">
-                <a16:creationId xmlns:a16="http://schemas.microsoft.com/office/drawing/2014/main" id="{D6AB4637-83C2-421A-B357-24D28BFAFE42}"/>
+                <a16:creationId xmlns:a16="http://schemas.microsoft.com/office/drawing/2014/main" id="{E0C29DD9-3988-4BC3-85A2-FBAFD7EE4E97}"/>
               </a:ext>
             </a:extLst>
           </p:cNvPr>
@@ -6306,7 +6306,7 @@
           <p:cNvPr id="26" name="">
             <a:extLst xmlns:a="http://schemas.openxmlformats.org/drawingml/2006/main">
               <a:ext uri="{FF2B5EF4-FFF2-40B4-BE49-F238E27FC236}">
-                <a16:creationId xmlns:a16="http://schemas.microsoft.com/office/drawing/2014/main" id="{B8B32B50-93A7-407E-B177-15500264552F}"/>
+                <a16:creationId xmlns:a16="http://schemas.microsoft.com/office/drawing/2014/main" id="{F6193B95-3A6C-4CC6-BA9B-D3BE41E109DD}"/>
               </a:ext>
             </a:extLst>
           </p:cNvPr>
@@ -6339,7 +6339,7 @@
           <p:cNvPr id="27" name="Mi:dm 2.0 Base Instruct[M1] CAD 로짓 결합 후 SCD 언어별 조정, 최종 답변 생성">
             <a:extLst xmlns:a="http://schemas.openxmlformats.org/drawingml/2006/main">
               <a:ext uri="{FF2B5EF4-FFF2-40B4-BE49-F238E27FC236}">
-                <a16:creationId xmlns:a16="http://schemas.microsoft.com/office/drawing/2014/main" id="{957EF757-9BAD-4FA9-9083-49A49EE7F86F}"/>
+                <a16:creationId xmlns:a16="http://schemas.microsoft.com/office/drawing/2014/main" id="{74CEE050-1D7B-4011-BFEF-88462673056E}"/>
               </a:ext>
             </a:extLst>
           </p:cNvPr>
@@ -6520,7 +6520,7 @@
           <p:cNvPr id="28" name="">
             <a:extLst xmlns:a="http://schemas.openxmlformats.org/drawingml/2006/main">
               <a:ext uri="{FF2B5EF4-FFF2-40B4-BE49-F238E27FC236}">
-                <a16:creationId xmlns:a16="http://schemas.microsoft.com/office/drawing/2014/main" id="{4B35EC58-AFE5-4CF2-AD48-1B2C1A18D245}"/>
+                <a16:creationId xmlns:a16="http://schemas.microsoft.com/office/drawing/2014/main" id="{925D53B2-A524-4425-8BF7-C7BC158989EE}"/>
               </a:ext>
             </a:extLst>
           </p:cNvPr>
@@ -6552,7 +6552,7 @@
           <p:cNvPr id="29" name="">
             <a:extLst xmlns:a="http://schemas.openxmlformats.org/drawingml/2006/main">
               <a:ext uri="{FF2B5EF4-FFF2-40B4-BE49-F238E27FC236}">
-                <a16:creationId xmlns:a16="http://schemas.microsoft.com/office/drawing/2014/main" id="{4B1C5C38-EE42-4CA2-86D5-7B9B54C952F7}"/>
+                <a16:creationId xmlns:a16="http://schemas.microsoft.com/office/drawing/2014/main" id="{BBD6EE17-7979-41B2-875D-17A8110C23ED}"/>
               </a:ext>
             </a:extLst>
           </p:cNvPr>
@@ -6584,7 +6584,7 @@
           <p:cNvPr id="30" name="">
             <a:extLst xmlns:a="http://schemas.openxmlformats.org/drawingml/2006/main">
               <a:ext uri="{FF2B5EF4-FFF2-40B4-BE49-F238E27FC236}">
-                <a16:creationId xmlns:a16="http://schemas.microsoft.com/office/drawing/2014/main" id="{42368525-13BF-4A18-ABBB-8D67FB999960}"/>
+                <a16:creationId xmlns:a16="http://schemas.microsoft.com/office/drawing/2014/main" id="{324B9920-4910-4CDA-954E-F2EE24659288}"/>
               </a:ext>
             </a:extLst>
           </p:cNvPr>
@@ -6615,7 +6615,7 @@
           <p:cNvPr id="31" name="03 3요인 완전요인 실험 설계">
             <a:extLst xmlns:a="http://schemas.openxmlformats.org/drawingml/2006/main">
               <a:ext uri="{FF2B5EF4-FFF2-40B4-BE49-F238E27FC236}">
-                <a16:creationId xmlns:a16="http://schemas.microsoft.com/office/drawing/2014/main" id="{460122FC-05D0-4FD3-97B4-EA7AB67468C7}"/>
+                <a16:creationId xmlns:a16="http://schemas.microsoft.com/office/drawing/2014/main" id="{7CD99925-E4FC-4C66-BFB2-679BEA53432E}"/>
               </a:ext>
             </a:extLst>
           </p:cNvPr>
@@ -6773,7 +6773,7 @@
           <p:cNvPr id="32" name="H=HyDE, C=CAD, S=SCD   0=미적용, 1=적용">
             <a:extLst xmlns:a="http://schemas.openxmlformats.org/drawingml/2006/main">
               <a:ext uri="{FF2B5EF4-FFF2-40B4-BE49-F238E27FC236}">
-                <a16:creationId xmlns:a16="http://schemas.microsoft.com/office/drawing/2014/main" id="{25614993-AECC-417E-AD0D-9604E577C342}"/>
+                <a16:creationId xmlns:a16="http://schemas.microsoft.com/office/drawing/2014/main" id="{DAC40030-95F2-4374-B49F-F07E1783567E}"/>
               </a:ext>
             </a:extLst>
           </p:cNvPr>
@@ -6931,7 +6931,7 @@
           <p:cNvPr id="33" name="">
             <a:extLst xmlns:a="http://schemas.openxmlformats.org/drawingml/2006/main">
               <a:ext uri="{FF2B5EF4-FFF2-40B4-BE49-F238E27FC236}">
-                <a16:creationId xmlns:a16="http://schemas.microsoft.com/office/drawing/2014/main" id="{EEBEC788-B8DE-4224-812F-EEDF63626049}"/>
+                <a16:creationId xmlns:a16="http://schemas.microsoft.com/office/drawing/2014/main" id="{EDBA6536-99F7-48BA-AD4B-1B7D2FA2ADB7}"/>
               </a:ext>
             </a:extLst>
           </p:cNvPr>
@@ -8461,7 +8461,7 @@
           <p:cNvPr id="34" name="같은 질의 60개 × 8조건 반복측정 = 480개 생성 기록">
             <a:extLst xmlns:a="http://schemas.openxmlformats.org/drawingml/2006/main">
               <a:ext uri="{FF2B5EF4-FFF2-40B4-BE49-F238E27FC236}">
-                <a16:creationId xmlns:a16="http://schemas.microsoft.com/office/drawing/2014/main" id="{61BA5296-0A5C-4F09-BBA3-AC2079A1B053}"/>
+                <a16:creationId xmlns:a16="http://schemas.microsoft.com/office/drawing/2014/main" id="{D1307836-4D2E-497C-9E8F-CFCF5CDB237C}"/>
               </a:ext>
             </a:extLst>
           </p:cNvPr>
@@ -8619,7 +8619,7 @@
           <p:cNvPr id="35" name="생성 512토큰, CAD α=0.5, SCD α=1.1·β=0.9·Tstart=5">
             <a:extLst xmlns:a="http://schemas.openxmlformats.org/drawingml/2006/main">
               <a:ext uri="{FF2B5EF4-FFF2-40B4-BE49-F238E27FC236}">
-                <a16:creationId xmlns:a16="http://schemas.microsoft.com/office/drawing/2014/main" id="{F2F1E7C6-531F-4FBE-9E71-5500F13CFDD3}"/>
+                <a16:creationId xmlns:a16="http://schemas.microsoft.com/office/drawing/2014/main" id="{7367A58D-DB4E-469D-A8B4-92717C3C0EE6}"/>
               </a:ext>
             </a:extLst>
           </p:cNvPr>
@@ -8777,7 +8777,7 @@
           <p:cNvPr id="36" name="문서마다 주요 내용을 15개 단위로 요약해 단위별 질의를 작성하고, 총 60개 질의의 원문 페이지·정답 근거·답변 가">
             <a:extLst xmlns:a="http://schemas.openxmlformats.org/drawingml/2006/main">
               <a:ext uri="{FF2B5EF4-FFF2-40B4-BE49-F238E27FC236}">
-                <a16:creationId xmlns:a16="http://schemas.microsoft.com/office/drawing/2014/main" id="{F396F52A-1F1D-46A7-821E-61FB3659203C}"/>
+                <a16:creationId xmlns:a16="http://schemas.microsoft.com/office/drawing/2014/main" id="{7FF39FDF-F991-41D3-8CAA-0977B3DCD24C}"/>
               </a:ext>
             </a:extLst>
           </p:cNvPr>
@@ -8958,7 +8958,7 @@
           <p:cNvPr id="37" name="">
             <a:extLst xmlns:a="http://schemas.openxmlformats.org/drawingml/2006/main">
               <a:ext uri="{FF2B5EF4-FFF2-40B4-BE49-F238E27FC236}">
-                <a16:creationId xmlns:a16="http://schemas.microsoft.com/office/drawing/2014/main" id="{39B81B0F-A61B-4D01-BAB4-AE13A11613FF}"/>
+                <a16:creationId xmlns:a16="http://schemas.microsoft.com/office/drawing/2014/main" id="{E055367C-74E7-4EFE-AB67-BDC63436E62F}"/>
               </a:ext>
             </a:extLst>
           </p:cNvPr>
@@ -8989,7 +8989,7 @@
           <p:cNvPr id="38" name="04 평가 지표 및 실험·통계 방법">
             <a:extLst xmlns:a="http://schemas.openxmlformats.org/drawingml/2006/main">
               <a:ext uri="{FF2B5EF4-FFF2-40B4-BE49-F238E27FC236}">
-                <a16:creationId xmlns:a16="http://schemas.microsoft.com/office/drawing/2014/main" id="{F13765E4-696C-4A33-A059-CF055D095393}"/>
+                <a16:creationId xmlns:a16="http://schemas.microsoft.com/office/drawing/2014/main" id="{2483ABE8-8E6C-429E-84D9-93D779E4D9D7}"/>
               </a:ext>
             </a:extLst>
           </p:cNvPr>
@@ -9147,7 +9147,7 @@
           <p:cNvPr id="39" name="근거 충실도: 높을수록 검색 결과가 뒷받침하는 답변 주장 비율이 크다. 답변 관련성: 높을수록 답변 기반 질문과 원질">
             <a:extLst xmlns:a="http://schemas.openxmlformats.org/drawingml/2006/main">
               <a:ext uri="{FF2B5EF4-FFF2-40B4-BE49-F238E27FC236}">
-                <a16:creationId xmlns:a16="http://schemas.microsoft.com/office/drawing/2014/main" id="{636E831F-D874-44D6-BEF6-CE3717F6F7EA}"/>
+                <a16:creationId xmlns:a16="http://schemas.microsoft.com/office/drawing/2014/main" id="{9827BE99-BE23-418E-97A9-EE205D0C5A2C}"/>
               </a:ext>
             </a:extLst>
           </p:cNvPr>
@@ -9397,7 +9397,7 @@
           <p:cNvPr id="40" name="품질 관측값은 0~1이다. 차이 = ON − OFF 평균. 한국어 비율 0.700은 70.0%, 차이 +0.218은 ">
             <a:extLst xmlns:a="http://schemas.openxmlformats.org/drawingml/2006/main">
               <a:ext uri="{FF2B5EF4-FFF2-40B4-BE49-F238E27FC236}">
-                <a16:creationId xmlns:a16="http://schemas.microsoft.com/office/drawing/2014/main" id="{CCA67F45-C41A-4AF0-8CA0-51DC5FFFAA27}"/>
+                <a16:creationId xmlns:a16="http://schemas.microsoft.com/office/drawing/2014/main" id="{C99A31BB-4C98-4AA8-8688-6153E15A3411}"/>
               </a:ext>
             </a:extLst>
           </p:cNvPr>
@@ -9578,7 +9578,7 @@
           <p:cNvPr id="41" name="평가 예시  ext_raptor_011, H0C0S0">
             <a:extLst xmlns:a="http://schemas.openxmlformats.org/drawingml/2006/main">
               <a:ext uri="{FF2B5EF4-FFF2-40B4-BE49-F238E27FC236}">
-                <a16:creationId xmlns:a16="http://schemas.microsoft.com/office/drawing/2014/main" id="{264E39CA-EF38-456A-A6CE-17FE94B06767}"/>
+                <a16:creationId xmlns:a16="http://schemas.microsoft.com/office/drawing/2014/main" id="{8DE8B263-2B27-46B0-B574-4E238802A01B}"/>
               </a:ext>
             </a:extLst>
           </p:cNvPr>
@@ -9736,7 +9736,7 @@
           <p:cNvPr id="42" name="질문: Cinderella 사례의 정성 분석에서 RAPTOR의 tree-based retrieval이 DPR보다 주제">
             <a:extLst xmlns:a="http://schemas.openxmlformats.org/drawingml/2006/main">
               <a:ext uri="{FF2B5EF4-FFF2-40B4-BE49-F238E27FC236}">
-                <a16:creationId xmlns:a16="http://schemas.microsoft.com/office/drawing/2014/main" id="{F529F920-6248-453D-A5B1-BA94AB1E0F15}"/>
+                <a16:creationId xmlns:a16="http://schemas.microsoft.com/office/drawing/2014/main" id="{D5B67245-DB24-43E6-AAED-83F0CC6E1173}"/>
               </a:ext>
             </a:extLst>
           </p:cNvPr>
@@ -9917,7 +9917,7 @@
           <p:cNvPr id="43" name="검색 근거(PDF p.9): “By providing both the original text and higher-l">
             <a:extLst xmlns:a="http://schemas.openxmlformats.org/drawingml/2006/main">
               <a:ext uri="{FF2B5EF4-FFF2-40B4-BE49-F238E27FC236}">
-                <a16:creationId xmlns:a16="http://schemas.microsoft.com/office/drawing/2014/main" id="{E7B08066-6E5D-43E1-AE37-CDFFF208AC0F}"/>
+                <a16:creationId xmlns:a16="http://schemas.microsoft.com/office/drawing/2014/main" id="{16E6D16C-43E6-43BC-BA40-FA2D3F7137FD}"/>
               </a:ext>
             </a:extLst>
           </p:cNvPr>
@@ -10121,7 +10121,7 @@
           <p:cNvPr id="44" name="참조 답변 요지(PDF p.20): RAPTOR는 이야기의 주요 부분을, DPR은 이야기의 좁은 일부를 자세히 검색한">
             <a:extLst xmlns:a="http://schemas.openxmlformats.org/drawingml/2006/main">
               <a:ext uri="{FF2B5EF4-FFF2-40B4-BE49-F238E27FC236}">
-                <a16:creationId xmlns:a16="http://schemas.microsoft.com/office/drawing/2014/main" id="{18964C21-A579-461E-85C4-78CD196A48E4}"/>
+                <a16:creationId xmlns:a16="http://schemas.microsoft.com/office/drawing/2014/main" id="{C984E1B1-06F0-4546-AB26-D56DFE55119F}"/>
               </a:ext>
             </a:extLst>
           </p:cNvPr>
@@ -10302,7 +10302,7 @@
           <p:cNvPr id="45" name="생성 답변 발췌: “질문의 요구사항에 따라 서로 다른 층위(layer)에서 노드를 선택할 수 있습니다.”">
             <a:extLst xmlns:a="http://schemas.openxmlformats.org/drawingml/2006/main">
               <a:ext uri="{FF2B5EF4-FFF2-40B4-BE49-F238E27FC236}">
-                <a16:creationId xmlns:a16="http://schemas.microsoft.com/office/drawing/2014/main" id="{F4FF1B30-905E-41E8-9D35-86BFC1AE8126}"/>
+                <a16:creationId xmlns:a16="http://schemas.microsoft.com/office/drawing/2014/main" id="{31FA4CAA-1322-4492-9885-FC87E83A0360}"/>
               </a:ext>
             </a:extLst>
           </p:cNvPr>
@@ -10483,7 +10483,7 @@
           <p:cNvPr id="46" name="충실도 1.000: 추출된 답변 주장을 검색 결과가 모두 지지 관련성 0.937: 답변 기반 질문과 원질문의 평균 의">
             <a:extLst xmlns:a="http://schemas.openxmlformats.org/drawingml/2006/main">
               <a:ext uri="{FF2B5EF4-FFF2-40B4-BE49-F238E27FC236}">
-                <a16:creationId xmlns:a16="http://schemas.microsoft.com/office/drawing/2014/main" id="{D9557E79-36C3-45EE-9035-27088B2DCE4F}"/>
+                <a16:creationId xmlns:a16="http://schemas.microsoft.com/office/drawing/2014/main" id="{8B152D4F-8DF7-4E42-AE91-AE86C32DF585}"/>
               </a:ext>
             </a:extLst>
           </p:cNvPr>
@@ -10664,7 +10664,7 @@
           <p:cNvPr id="47" name="평가: RAGAS 0.2.15[10]·gpt-4o·BGE-M3, 저장 답변 평가 평가 언어: S0 영어 / S1 한국">
             <a:extLst xmlns:a="http://schemas.openxmlformats.org/drawingml/2006/main">
               <a:ext uri="{FF2B5EF4-FFF2-40B4-BE49-F238E27FC236}">
-                <a16:creationId xmlns:a16="http://schemas.microsoft.com/office/drawing/2014/main" id="{566075CC-5BCA-4C4A-A538-DD990DCCB5A8}"/>
+                <a16:creationId xmlns:a16="http://schemas.microsoft.com/office/drawing/2014/main" id="{1CED883F-9B88-4197-8F87-EC16A612D522}"/>
               </a:ext>
             </a:extLst>
           </p:cNvPr>
@@ -10845,7 +10845,7 @@
           <p:cNvPr id="48" name="반복측정 분산분석(ANOVA)·대응 t-검정, 양측 α=0.05 품질: SCD 상태별 H×C / 한국어 비율·시간: ">
             <a:extLst xmlns:a="http://schemas.openxmlformats.org/drawingml/2006/main">
               <a:ext uri="{FF2B5EF4-FFF2-40B4-BE49-F238E27FC236}">
-                <a16:creationId xmlns:a16="http://schemas.microsoft.com/office/drawing/2014/main" id="{78EC1220-8A54-4432-877F-E45B099FBD4B}"/>
+                <a16:creationId xmlns:a16="http://schemas.microsoft.com/office/drawing/2014/main" id="{3CBAC86F-EA9F-4B6E-A065-3779A1B11406}"/>
               </a:ext>
             </a:extLst>
           </p:cNvPr>
@@ -11026,7 +11026,7 @@
           <p:cNvPr id="49" name="">
             <a:extLst xmlns:a="http://schemas.openxmlformats.org/drawingml/2006/main">
               <a:ext uri="{FF2B5EF4-FFF2-40B4-BE49-F238E27FC236}">
-                <a16:creationId xmlns:a16="http://schemas.microsoft.com/office/drawing/2014/main" id="{4BC480BD-DCDF-4524-A11F-C9A5BDE99DF8}"/>
+                <a16:creationId xmlns:a16="http://schemas.microsoft.com/office/drawing/2014/main" id="{F841973D-C4C2-4654-8747-3902723A5438}"/>
               </a:ext>
             </a:extLst>
           </p:cNvPr>
@@ -11057,7 +11057,7 @@
           <p:cNvPr id="50" name="05 조합별 결과와 통계 검정">
             <a:extLst xmlns:a="http://schemas.openxmlformats.org/drawingml/2006/main">
               <a:ext uri="{FF2B5EF4-FFF2-40B4-BE49-F238E27FC236}">
-                <a16:creationId xmlns:a16="http://schemas.microsoft.com/office/drawing/2014/main" id="{F714C7E8-6361-4130-8482-93B0F4A77427}"/>
+                <a16:creationId xmlns:a16="http://schemas.microsoft.com/office/drawing/2014/main" id="{EEB64929-40A4-4038-A628-40DEE23F4DBD}"/>
               </a:ext>
             </a:extLst>
           </p:cNvPr>
@@ -11215,7 +11215,7 @@
           <p:cNvPr id="51" name="HyDE·CAD·SCD 8조합의 품질·한국어 비율·시간 평균(SD)">
             <a:extLst xmlns:a="http://schemas.openxmlformats.org/drawingml/2006/main">
               <a:ext uri="{FF2B5EF4-FFF2-40B4-BE49-F238E27FC236}">
-                <a16:creationId xmlns:a16="http://schemas.microsoft.com/office/drawing/2014/main" id="{EB38499C-7E90-416C-BF49-66DECC10B7F7}"/>
+                <a16:creationId xmlns:a16="http://schemas.microsoft.com/office/drawing/2014/main" id="{18C0E817-91B0-42EA-A32F-DA2D009E1C8B}"/>
               </a:ext>
             </a:extLst>
           </p:cNvPr>
@@ -11373,7 +11373,7 @@
           <p:cNvPr id="52" name="">
             <a:extLst xmlns:a="http://schemas.openxmlformats.org/drawingml/2006/main">
               <a:ext uri="{FF2B5EF4-FFF2-40B4-BE49-F238E27FC236}">
-                <a16:creationId xmlns:a16="http://schemas.microsoft.com/office/drawing/2014/main" id="{1D106931-8371-43A6-93A2-E1402F194973}"/>
+                <a16:creationId xmlns:a16="http://schemas.microsoft.com/office/drawing/2014/main" id="{D4900C09-C005-4EA1-BF88-11EA0CD1433C}"/>
               </a:ext>
             </a:extLst>
           </p:cNvPr>
@@ -14733,7 +14733,7 @@
           <p:cNvPr id="53" name="">
             <a:extLst xmlns:a="http://schemas.openxmlformats.org/drawingml/2006/main">
               <a:ext uri="{FF2B5EF4-FFF2-40B4-BE49-F238E27FC236}">
-                <a16:creationId xmlns:a16="http://schemas.microsoft.com/office/drawing/2014/main" id="{45DC1508-9867-417C-BF3C-99A22EBCA065}"/>
+                <a16:creationId xmlns:a16="http://schemas.microsoft.com/office/drawing/2014/main" id="{3BD22C05-26C4-4437-B932-1A5A5A3EA66F}"/>
               </a:ext>
             </a:extLst>
           </p:cNvPr>
@@ -14764,7 +14764,7 @@
           <p:cNvPr id="54" name="S0: 영어로 평가 / S1: 한국어 번역으로 평가 충실도 H0C1S0 n=58, H0C0S1 n=57, 나머지 n=">
             <a:extLst xmlns:a="http://schemas.openxmlformats.org/drawingml/2006/main">
               <a:ext uri="{FF2B5EF4-FFF2-40B4-BE49-F238E27FC236}">
-                <a16:creationId xmlns:a16="http://schemas.microsoft.com/office/drawing/2014/main" id="{8814ADC1-2079-4018-812F-DFA8344F8042}"/>
+                <a16:creationId xmlns:a16="http://schemas.microsoft.com/office/drawing/2014/main" id="{EBC22191-FA2C-4FD2-A327-A0ABEAEF3868}"/>
               </a:ext>
             </a:extLst>
           </p:cNvPr>
@@ -14968,7 +14968,7 @@
           <p:cNvPr id="55" name="3요인 반복측정 ANOVA  ·  각 효과 df=(1,59)">
             <a:extLst xmlns:a="http://schemas.openxmlformats.org/drawingml/2006/main">
               <a:ext uri="{FF2B5EF4-FFF2-40B4-BE49-F238E27FC236}">
-                <a16:creationId xmlns:a16="http://schemas.microsoft.com/office/drawing/2014/main" id="{523B2149-6F87-4389-BFDA-6E964593E23C}"/>
+                <a16:creationId xmlns:a16="http://schemas.microsoft.com/office/drawing/2014/main" id="{BB6D5BF9-D43F-4F36-B547-2FC61036FBDC}"/>
               </a:ext>
             </a:extLst>
           </p:cNvPr>
@@ -15126,7 +15126,7 @@
           <p:cNvPr id="56" name="">
             <a:extLst xmlns:a="http://schemas.openxmlformats.org/drawingml/2006/main">
               <a:ext uri="{FF2B5EF4-FFF2-40B4-BE49-F238E27FC236}">
-                <a16:creationId xmlns:a16="http://schemas.microsoft.com/office/drawing/2014/main" id="{5CAEBC21-F0E0-4D6A-A3D5-BA19EA533133}"/>
+                <a16:creationId xmlns:a16="http://schemas.microsoft.com/office/drawing/2014/main" id="{ABF09564-B404-4305-868A-67FD2D737F64}"/>
               </a:ext>
             </a:extLst>
           </p:cNvPr>
@@ -16839,7 +16839,7 @@
           <p:cNvPr id="57" name="p&lt;0.05: 한국어 비율 S·H×C / 실행 시간 H·C·S·C×S RAGAS H×C 검정은 평가 언어별로 수행했으">
             <a:extLst xmlns:a="http://schemas.openxmlformats.org/drawingml/2006/main">
               <a:ext uri="{FF2B5EF4-FFF2-40B4-BE49-F238E27FC236}">
-                <a16:creationId xmlns:a16="http://schemas.microsoft.com/office/drawing/2014/main" id="{68415212-689D-4787-B9BC-D11576F36264}"/>
+                <a16:creationId xmlns:a16="http://schemas.microsoft.com/office/drawing/2014/main" id="{38EB2C80-A5C2-40AF-AD3A-E18885C07E41}"/>
               </a:ext>
             </a:extLst>
           </p:cNvPr>
@@ -17043,7 +17043,7 @@
           <p:cNvPr id="58" name="기법별 대응 비교  ·  질의별 평균 차이, 양측 검정">
             <a:extLst xmlns:a="http://schemas.openxmlformats.org/drawingml/2006/main">
               <a:ext uri="{FF2B5EF4-FFF2-40B4-BE49-F238E27FC236}">
-                <a16:creationId xmlns:a16="http://schemas.microsoft.com/office/drawing/2014/main" id="{0A708DCF-AF52-4F8E-A661-5A4B290E7142}"/>
+                <a16:creationId xmlns:a16="http://schemas.microsoft.com/office/drawing/2014/main" id="{9C452A79-733D-446C-93A6-120085116DDA}"/>
               </a:ext>
             </a:extLst>
           </p:cNvPr>
@@ -17201,7 +17201,7 @@
           <p:cNvPr id="59" name="">
             <a:extLst xmlns:a="http://schemas.openxmlformats.org/drawingml/2006/main">
               <a:ext uri="{FF2B5EF4-FFF2-40B4-BE49-F238E27FC236}">
-                <a16:creationId xmlns:a16="http://schemas.microsoft.com/office/drawing/2014/main" id="{4DAB576C-0F1A-4DFF-A6F6-BA8547566394}"/>
+                <a16:creationId xmlns:a16="http://schemas.microsoft.com/office/drawing/2014/main" id="{619E716F-F5B9-48A3-8899-DB884D51EE30}"/>
               </a:ext>
             </a:extLst>
           </p:cNvPr>
@@ -18214,7 +18214,7 @@
           <p:cNvPr id="60" name="HyDE: C0S0, CAD: H0S0, SCD: H0의 CAD 상태 평균 p: 양측 p, dz: 차이 평균/차이 S">
             <a:extLst xmlns:a="http://schemas.openxmlformats.org/drawingml/2006/main">
               <a:ext uri="{FF2B5EF4-FFF2-40B4-BE49-F238E27FC236}">
-                <a16:creationId xmlns:a16="http://schemas.microsoft.com/office/drawing/2014/main" id="{5D6F7B2C-923C-4712-A536-E8560C5EF4F3}"/>
+                <a16:creationId xmlns:a16="http://schemas.microsoft.com/office/drawing/2014/main" id="{D187388D-E0E5-4EB8-95C8-05E889484D8B}"/>
               </a:ext>
             </a:extLst>
           </p:cNvPr>
@@ -18418,7 +18418,7 @@
           <p:cNvPr id="61" name="">
             <a:extLst xmlns:a="http://schemas.openxmlformats.org/drawingml/2006/main">
               <a:ext uri="{FF2B5EF4-FFF2-40B4-BE49-F238E27FC236}">
-                <a16:creationId xmlns:a16="http://schemas.microsoft.com/office/drawing/2014/main" id="{C06B35C2-3140-4DE0-ACD6-74441CC8A288}"/>
+                <a16:creationId xmlns:a16="http://schemas.microsoft.com/office/drawing/2014/main" id="{EA2F5F60-D6C2-4A1F-B4FA-FDEFF5B71B1B}"/>
               </a:ext>
             </a:extLst>
           </p:cNvPr>
@@ -18449,7 +18449,7 @@
           <p:cNvPr id="62" name="06 결과 해석">
             <a:extLst xmlns:a="http://schemas.openxmlformats.org/drawingml/2006/main">
               <a:ext uri="{FF2B5EF4-FFF2-40B4-BE49-F238E27FC236}">
-                <a16:creationId xmlns:a16="http://schemas.microsoft.com/office/drawing/2014/main" id="{96D7BF30-D1F8-4E35-8AE0-48B7ECE309EC}"/>
+                <a16:creationId xmlns:a16="http://schemas.microsoft.com/office/drawing/2014/main" id="{9AAFB2FD-863F-41F1-85F1-E1BCDDCE870F}"/>
               </a:ext>
             </a:extLst>
           </p:cNvPr>
@@ -18607,7 +18607,7 @@
           <p:cNvPr id="63" name="HyDE: 기본 조건에서 관련성이 유의하게 높았으나(p=0.029), SCD 적용 조건의 추가 비교에서는 p=0.11">
             <a:extLst xmlns:a="http://schemas.openxmlformats.org/drawingml/2006/main">
               <a:ext uri="{FF2B5EF4-FFF2-40B4-BE49-F238E27FC236}">
-                <a16:creationId xmlns:a16="http://schemas.microsoft.com/office/drawing/2014/main" id="{76584C04-50B2-44D3-89EF-107EA2449487}"/>
+                <a16:creationId xmlns:a16="http://schemas.microsoft.com/office/drawing/2014/main" id="{2241DB9C-967A-4B2B-AFF2-9703313253E4}"/>
               </a:ext>
             </a:extLst>
           </p:cNvPr>
@@ -18847,7 +18847,7 @@
                 <a:ea typeface="Malgun Gothic"/>
                 <a:cs typeface="Malgun Gothic"/>
               </a:rPr>
-              <a:t>쓰면 CAD의 추가 시간이 약 9초 줄었다(C×S, p&lt;0.001).</a:t>
+              <a:t>쓰면 CAD의 추가 시간이 약 8.8초 줄었다(C×S, p&lt;0.001).</a:t>
             </a:r>
           </a:p>
         </p:txBody>
@@ -18857,7 +18857,7 @@
           <p:cNvPr id="64" name="">
             <a:extLst xmlns:a="http://schemas.openxmlformats.org/drawingml/2006/main">
               <a:ext uri="{FF2B5EF4-FFF2-40B4-BE49-F238E27FC236}">
-                <a16:creationId xmlns:a16="http://schemas.microsoft.com/office/drawing/2014/main" id="{F7955013-B764-46DF-BDD7-5B0F9107001A}"/>
+                <a16:creationId xmlns:a16="http://schemas.microsoft.com/office/drawing/2014/main" id="{6838B24F-5971-45CA-9C51-E7160AB52D8C}"/>
               </a:ext>
             </a:extLst>
           </p:cNvPr>
@@ -18888,7 +18888,7 @@
           <p:cNvPr id="65" name="07 결론">
             <a:extLst xmlns:a="http://schemas.openxmlformats.org/drawingml/2006/main">
               <a:ext uri="{FF2B5EF4-FFF2-40B4-BE49-F238E27FC236}">
-                <a16:creationId xmlns:a16="http://schemas.microsoft.com/office/drawing/2014/main" id="{8F9D01A6-2187-443F-BF7A-F7777E08CB39}"/>
+                <a16:creationId xmlns:a16="http://schemas.microsoft.com/office/drawing/2014/main" id="{718314C9-D4D0-49DA-96CE-635BAF3A5B97}"/>
               </a:ext>
             </a:extLst>
           </p:cNvPr>
@@ -19046,7 +19046,7 @@
           <p:cNvPr id="66" name="한국어 답변이 필요하면 SCD가 비용이 작은 선택지다. HyDE의 관련성 향상은 기본 조건(C0S0)에서 관측되었고,">
             <a:extLst xmlns:a="http://schemas.openxmlformats.org/drawingml/2006/main">
               <a:ext uri="{FF2B5EF4-FFF2-40B4-BE49-F238E27FC236}">
-                <a16:creationId xmlns:a16="http://schemas.microsoft.com/office/drawing/2014/main" id="{D3A283A5-8665-4E04-94AC-FD2237E9D670}"/>
+                <a16:creationId xmlns:a16="http://schemas.microsoft.com/office/drawing/2014/main" id="{8CE915E6-69C5-4058-ADF7-9302F18B843C}"/>
               </a:ext>
             </a:extLst>
           </p:cNvPr>
@@ -19319,7 +19319,7 @@
           <p:cNvPr id="67" name="">
             <a:extLst xmlns:a="http://schemas.openxmlformats.org/drawingml/2006/main">
               <a:ext uri="{FF2B5EF4-FFF2-40B4-BE49-F238E27FC236}">
-                <a16:creationId xmlns:a16="http://schemas.microsoft.com/office/drawing/2014/main" id="{3E8E2E6C-A17C-4D4E-8C12-704584686269}"/>
+                <a16:creationId xmlns:a16="http://schemas.microsoft.com/office/drawing/2014/main" id="{932BC51D-0505-4A2A-BE46-381816F72841}"/>
               </a:ext>
             </a:extLst>
           </p:cNvPr>
@@ -19350,7 +19350,7 @@
           <p:cNvPr id="68" name="08 주요 참고문헌">
             <a:extLst xmlns:a="http://schemas.openxmlformats.org/drawingml/2006/main">
               <a:ext uri="{FF2B5EF4-FFF2-40B4-BE49-F238E27FC236}">
-                <a16:creationId xmlns:a16="http://schemas.microsoft.com/office/drawing/2014/main" id="{B2D6977F-DA73-46B9-9F88-5B217A6B79E3}"/>
+                <a16:creationId xmlns:a16="http://schemas.microsoft.com/office/drawing/2014/main" id="{B9884EFE-C170-45C5-AA20-4229AD5F6467}"/>
               </a:ext>
             </a:extLst>
           </p:cNvPr>
@@ -19508,7 +19508,7 @@
           <p:cNvPr id="69" name="[1] Lewis et al. RAG. NeurIPS, 2020. [2] Gao et al. HyDE. ACL, 20">
             <a:extLst xmlns:a="http://schemas.openxmlformats.org/drawingml/2006/main">
               <a:ext uri="{FF2B5EF4-FFF2-40B4-BE49-F238E27FC236}">
-                <a16:creationId xmlns:a16="http://schemas.microsoft.com/office/drawing/2014/main" id="{421CF83B-D3B0-4688-A147-F9F4AB5053F9}"/>
+                <a16:creationId xmlns:a16="http://schemas.microsoft.com/office/drawing/2014/main" id="{74580B26-B021-426B-98D4-64380D755D33}"/>
               </a:ext>
             </a:extLst>
           </p:cNvPr>
@@ -19712,7 +19712,7 @@
           <p:cNvPr id="70" name="[4] Li et al. Language Drift and SCD. AAAI, 2026. [5] Chen et al.">
             <a:extLst xmlns:a="http://schemas.openxmlformats.org/drawingml/2006/main">
               <a:ext uri="{FF2B5EF4-FFF2-40B4-BE49-F238E27FC236}">
-                <a16:creationId xmlns:a16="http://schemas.microsoft.com/office/drawing/2014/main" id="{996F7F1B-2882-4A97-8C29-6D444B3AA2A9}"/>
+                <a16:creationId xmlns:a16="http://schemas.microsoft.com/office/drawing/2014/main" id="{EC5EEF81-0438-4142-9FD1-6DE96EDA6EAC}"/>
               </a:ext>
             </a:extLst>
           </p:cNvPr>
@@ -19916,7 +19916,7 @@
           <p:cNvPr id="71" name="[6] Robertson et al. Okapi at TREC-3. NIST, 1995. [7] Cormack et ">
             <a:extLst xmlns:a="http://schemas.openxmlformats.org/drawingml/2006/main">
               <a:ext uri="{FF2B5EF4-FFF2-40B4-BE49-F238E27FC236}">
-                <a16:creationId xmlns:a16="http://schemas.microsoft.com/office/drawing/2014/main" id="{2A15DEEB-666F-4975-8143-3A35A69A1E3F}"/>
+                <a16:creationId xmlns:a16="http://schemas.microsoft.com/office/drawing/2014/main" id="{F608A2BD-623A-46AC-AFD5-16A72F73A009}"/>
               </a:ext>
             </a:extLst>
           </p:cNvPr>
@@ -20097,7 +20097,7 @@
           <p:cNvPr id="72" name="[8] MacAvaney et al. CEDR. SIGIR, 2019. 공식 모델  [M1] KT Mi:dm 2.0 ">
             <a:extLst xmlns:a="http://schemas.openxmlformats.org/drawingml/2006/main">
               <a:ext uri="{FF2B5EF4-FFF2-40B4-BE49-F238E27FC236}">
-                <a16:creationId xmlns:a16="http://schemas.microsoft.com/office/drawing/2014/main" id="{B45BAEF3-0C63-4BC4-BA2D-6B806FF7615A}"/>
+                <a16:creationId xmlns:a16="http://schemas.microsoft.com/office/drawing/2014/main" id="{E5D7AFA4-F9A2-4852-9C77-163A96011D22}"/>
               </a:ext>
             </a:extLst>
           </p:cNvPr>
@@ -20278,7 +20278,7 @@
           <p:cNvPr id="73" name="전체 참고문헌 22편과 모델·자료 출처는 논문의 참고문헌에 수록">
             <a:extLst xmlns:a="http://schemas.openxmlformats.org/drawingml/2006/main">
               <a:ext uri="{FF2B5EF4-FFF2-40B4-BE49-F238E27FC236}">
-                <a16:creationId xmlns:a16="http://schemas.microsoft.com/office/drawing/2014/main" id="{6DC40DE2-6A21-4D73-B1A0-FF336936B3CE}"/>
+                <a16:creationId xmlns:a16="http://schemas.microsoft.com/office/drawing/2014/main" id="{2E8E43B5-0B52-4F3C-BE48-BA26BD728596}"/>
               </a:ext>
             </a:extLst>
           </p:cNvPr>
@@ -20436,7 +20436,7 @@
           <p:cNvPr id="74" name="영어 문서 4종 · 질의 60개 · 생성 모델 1종 · 질의별 반복측정">
             <a:extLst xmlns:a="http://schemas.openxmlformats.org/drawingml/2006/main">
               <a:ext uri="{FF2B5EF4-FFF2-40B4-BE49-F238E27FC236}">
-                <a16:creationId xmlns:a16="http://schemas.microsoft.com/office/drawing/2014/main" id="{43690470-C233-4BA5-9A1C-14A7894D9F04}"/>
+                <a16:creationId xmlns:a16="http://schemas.microsoft.com/office/drawing/2014/main" id="{423A4DE1-5A3A-44FC-9820-6DD679F40F64}"/>
               </a:ext>
             </a:extLst>
           </p:cNvPr>
@@ -20594,7 +20594,7 @@
           <p:cNvPr id="75" name="A1 594 × 841 mm">
             <a:extLst xmlns:a="http://schemas.openxmlformats.org/drawingml/2006/main">
               <a:ext uri="{FF2B5EF4-FFF2-40B4-BE49-F238E27FC236}">
-                <a16:creationId xmlns:a16="http://schemas.microsoft.com/office/drawing/2014/main" id="{449DAA75-75FB-4026-8E11-AB907B4F01C2}"/>
+                <a16:creationId xmlns:a16="http://schemas.microsoft.com/office/drawing/2014/main" id="{3906BF05-F89B-453D-ABE6-D29A74124344}"/>
               </a:ext>
             </a:extLst>
           </p:cNvPr>
@@ -20750,7 +20750,7 @@
     </p:spTree>
     <p:extLst>
       <p:ext uri="{BB962C8B-B14F-4D97-AF65-F5344CB8AC3E}">
-        <p14:creationId xmlns:p14="http://schemas.microsoft.com/office/powerpoint/2010/main" val="45596023"/>
+        <p14:creationId xmlns:p14="http://schemas.microsoft.com/office/powerpoint/2010/main" val="920580845"/>
       </p:ext>
     </p:extLst>
   </p:cSld>

</xml_diff>

<commit_message>
Revise thesis and poster around individual question profiles
</commit_message>
<xml_diff>
--- a/FINALDOCS/POSTER/FINAL/M_RAG_A1_FINAL_EDITABLE.pptx
+++ b/FINALDOCS/POSTER/FINAL/M_RAG_A1_FINAL_EDITABLE.pptx
@@ -5558,8 +5558,8 @@
                 <a:latin typeface="Malgun Gothic"/>
                 <a:ea typeface="Malgun Gothic"/>
               </a:rPr>
-              <a:t>- HyDE: Hypothetical Document Embeddings
-  CAD: Context-Aware Decoding · SCD: Soft Constrained Decoding</a:t>
+              <a:t>- HyDE(Hypothetical Document Embeddings) · CAD(Context-Aware Decoding)
+  SCD(Soft Constrained Decoding)</a:t>
             </a:r>
           </a:p>
         </p:txBody>
@@ -5599,7 +5599,7 @@
                 <a:latin typeface="Malgun Gothic"/>
                 <a:ea typeface="Malgun Gothic"/>
               </a:rPr>
-              <a:t>- 품질 평가 근거: 조건 1~4 영어, 조건 5~8 한국어 번역</a:t>
+              <a:t>- 품질 평가는 조건 1~4는 영어 근거, 조건 5~8은 한국어 번역 근거로 수행</a:t>
             </a:r>
           </a:p>
         </p:txBody>
@@ -6843,92 +6843,22 @@
                 <a:latin typeface="Malgun Gothic"/>
                 <a:ea typeface="Malgun Gothic"/>
               </a:rPr>
-              <a:t>04 질문 유형별 HyDE의 답변 관련성</a:t>
-            </a:r>
-          </a:p>
-        </p:txBody>
-      </p:sp>
-      <p:sp>
-        <p:nvSpPr>
-          <p:cNvPr id="24" name="TextBox 23"/>
-          <p:cNvSpPr txBox="1"/>
-          <p:nvPr/>
-        </p:nvSpPr>
-        <p:spPr>
-          <a:xfrm>
-            <a:off x="10980000" y="4248000"/>
-            <a:ext cx="9612000" cy="288000"/>
-          </a:xfrm>
-          <a:prstGeom prst="rect">
-            <a:avLst/>
-          </a:prstGeom>
-          <a:noFill/>
-        </p:spPr>
-        <p:txBody>
-          <a:bodyPr wrap="square" lIns="0" rIns="0" tIns="0" bIns="0">
-            <a:spAutoFit/>
-          </a:bodyPr>
-          <a:lstStyle/>
-          <a:p>
-            <a:pPr algn="l">
-              <a:lnSpc>
-                <a:spcPct val="115000"/>
-              </a:lnSpc>
-            </a:pPr>
-            <a:r>
-              <a:rPr sz="1700" b="1">
-                <a:solidFill>
-                  <a:srgbClr val="263044"/>
-                </a:solidFill>
-                <a:latin typeface="Malgun Gothic"/>
-                <a:ea typeface="Malgun Gothic"/>
-              </a:rPr>
-              <a:t>영어 근거 평가</a:t>
-            </a:r>
-            <a:r>
-              <a:rPr sz="1700" b="0">
-                <a:solidFill>
-                  <a:srgbClr val="263044"/>
-                </a:solidFill>
-                <a:latin typeface="Malgun Gothic"/>
-                <a:ea typeface="Malgun Gothic"/>
-              </a:rPr>
-              <a:t>(미적용 → HyDE)  ·  </a:t>
-            </a:r>
-            <a:r>
-              <a:rPr sz="1700" b="1">
-                <a:solidFill>
-                  <a:srgbClr val="263044"/>
-                </a:solidFill>
-                <a:latin typeface="Malgun Gothic"/>
-                <a:ea typeface="Malgun Gothic"/>
-              </a:rPr>
-              <a:t>한국어 번역 근거 평가</a:t>
-            </a:r>
-            <a:r>
-              <a:rPr sz="1700" b="0">
-                <a:solidFill>
-                  <a:srgbClr val="263044"/>
-                </a:solidFill>
-                <a:latin typeface="Malgun Gothic"/>
-                <a:ea typeface="Malgun Gothic"/>
-              </a:rPr>
-              <a:t>(SCD → HyDE+SCD)</a:t>
+              <a:t>04 질문 유형별 단일 기법의 변화</a:t>
             </a:r>
           </a:p>
         </p:txBody>
       </p:sp>
       <p:graphicFrame>
         <p:nvGraphicFramePr>
-          <p:cNvPr id="25" name="Table 24"/>
+          <p:cNvPr id="24" name="Table 23"/>
           <p:cNvGraphicFramePr>
             <a:graphicFrameLocks noGrp="1"/>
           </p:cNvGraphicFramePr>
           <p:nvPr/>
         </p:nvGraphicFramePr>
         <p:xfrm>
-          <a:off x="10980000" y="4536000"/>
-          <a:ext cx="9611998" cy="2470764"/>
+          <a:off x="10980000" y="4284000"/>
+          <a:ext cx="9611997" cy="2470764"/>
         </p:xfrm>
         <a:graphic>
           <a:graphicData uri="http://schemas.openxmlformats.org/drawingml/2006/table">
@@ -6937,14 +6867,13 @@
                 <a:tableStyleId>{5940675A-B579-460E-94D1-54222C63F5DA}</a:tableStyleId>
               </a:tblPr>
               <a:tblGrid>
-                <a:gridCol w="1875512"/>
-                <a:gridCol w="937756"/>
-                <a:gridCol w="1172195"/>
-                <a:gridCol w="1125307"/>
-                <a:gridCol w="1125307"/>
-                <a:gridCol w="1078419"/>
-                <a:gridCol w="1172195"/>
-                <a:gridCol w="1125307"/>
+                <a:gridCol w="2017988"/>
+                <a:gridCol w="1274519"/>
+                <a:gridCol w="1168309"/>
+                <a:gridCol w="1274519"/>
+                <a:gridCol w="1168309"/>
+                <a:gridCol w="1540044"/>
+                <a:gridCol w="1168309"/>
               </a:tblGrid>
               <a:tr h="644219">
                 <a:tc>
@@ -7003,7 +6932,7 @@
                           </a:solidFill>
                           <a:latin typeface="Malgun Gothic"/>
                         </a:rPr>
-                        <a:t>질문</a:t>
+                        <a:t>HyDE</a:t>
                       </a:r>
                     </a:p>
                     <a:p>
@@ -7015,7 +6944,7 @@
                           </a:solidFill>
                           <a:latin typeface="Malgun Gothic"/>
                         </a:rPr>
-                        <a:t>수</a:t>
+                        <a:t>관련성</a:t>
                       </a:r>
                     </a:p>
                   </a:txBody>
@@ -7058,40 +6987,9 @@
                           </a:solidFill>
                           <a:latin typeface="Malgun Gothic"/>
                         </a:rPr>
-                        <a:t>미적용</a:t>
-                      </a:r>
-                    </a:p>
-                  </a:txBody>
-                  <a:tcPr marL="57600" marR="57600" marT="21600" marB="21600" anchor="ctr">
-                    <a:solidFill>
-                      <a:srgbClr val="FFFFFF"/>
-                    </a:solidFill>
-                    <a:lnL w="9525">
-                      <a:solidFill>
-                        <a:srgbClr val="777777"/>
-                      </a:solidFill>
-                    </a:lnL>
-                    <a:lnR w="9525">
-                      <a:solidFill>
-                        <a:srgbClr val="777777"/>
-                      </a:solidFill>
-                    </a:lnR>
-                    <a:lnT w="9525">
-                      <a:solidFill>
-                        <a:srgbClr val="777777"/>
-                      </a:solidFill>
-                    </a:lnT>
-                    <a:lnB w="9525">
-                      <a:solidFill>
-                        <a:srgbClr val="777777"/>
-                      </a:solidFill>
-                    </a:lnB>
-                  </a:tcPr>
-                </a:tc>
-                <a:tc>
-                  <a:txBody>
-                    <a:bodyPr wrap="square"/>
-                    <a:lstStyle/>
+                        <a:t>개선</a:t>
+                      </a:r>
+                    </a:p>
                     <a:p>
                       <a:pPr algn="ctr"/>
                       <a:r>
@@ -7101,7 +6999,7 @@
                           </a:solidFill>
                           <a:latin typeface="Malgun Gothic"/>
                         </a:rPr>
-                        <a:t>HyDE</a:t>
+                        <a:t>/악화</a:t>
                       </a:r>
                     </a:p>
                   </a:txBody>
@@ -7144,40 +7042,9 @@
                           </a:solidFill>
                           <a:latin typeface="Malgun Gothic"/>
                         </a:rPr>
-                        <a:t>변화</a:t>
-                      </a:r>
-                    </a:p>
-                  </a:txBody>
-                  <a:tcPr marL="57600" marR="57600" marT="21600" marB="21600" anchor="ctr">
-                    <a:solidFill>
-                      <a:srgbClr val="FFFFFF"/>
-                    </a:solidFill>
-                    <a:lnL w="9525">
-                      <a:solidFill>
-                        <a:srgbClr val="777777"/>
-                      </a:solidFill>
-                    </a:lnL>
-                    <a:lnR w="9525">
-                      <a:solidFill>
-                        <a:srgbClr val="777777"/>
-                      </a:solidFill>
-                    </a:lnR>
-                    <a:lnT w="9525">
-                      <a:solidFill>
-                        <a:srgbClr val="777777"/>
-                      </a:solidFill>
-                    </a:lnT>
-                    <a:lnB w="9525">
-                      <a:solidFill>
-                        <a:srgbClr val="777777"/>
-                      </a:solidFill>
-                    </a:lnB>
-                  </a:tcPr>
-                </a:tc>
-                <a:tc>
-                  <a:txBody>
-                    <a:bodyPr wrap="square"/>
-                    <a:lstStyle/>
+                        <a:t>CAD</a:t>
+                      </a:r>
+                    </a:p>
                     <a:p>
                       <a:pPr algn="ctr"/>
                       <a:r>
@@ -7187,40 +7054,107 @@
                           </a:solidFill>
                           <a:latin typeface="Malgun Gothic"/>
                         </a:rPr>
+                        <a:t>충실도</a:t>
+                      </a:r>
+                    </a:p>
+                  </a:txBody>
+                  <a:tcPr marL="57600" marR="57600" marT="21600" marB="21600" anchor="ctr">
+                    <a:solidFill>
+                      <a:srgbClr val="FFFFFF"/>
+                    </a:solidFill>
+                    <a:lnL w="9525">
+                      <a:solidFill>
+                        <a:srgbClr val="777777"/>
+                      </a:solidFill>
+                    </a:lnL>
+                    <a:lnR w="9525">
+                      <a:solidFill>
+                        <a:srgbClr val="777777"/>
+                      </a:solidFill>
+                    </a:lnR>
+                    <a:lnT w="9525">
+                      <a:solidFill>
+                        <a:srgbClr val="777777"/>
+                      </a:solidFill>
+                    </a:lnT>
+                    <a:lnB w="9525">
+                      <a:solidFill>
+                        <a:srgbClr val="777777"/>
+                      </a:solidFill>
+                    </a:lnB>
+                  </a:tcPr>
+                </a:tc>
+                <a:tc>
+                  <a:txBody>
+                    <a:bodyPr wrap="square"/>
+                    <a:lstStyle/>
+                    <a:p>
+                      <a:pPr algn="ctr"/>
+                      <a:r>
+                        <a:rPr sz="1800" b="1">
+                          <a:solidFill>
+                            <a:srgbClr val="263044"/>
+                          </a:solidFill>
+                          <a:latin typeface="Malgun Gothic"/>
+                        </a:rPr>
+                        <a:t>개선</a:t>
+                      </a:r>
+                    </a:p>
+                    <a:p>
+                      <a:pPr algn="ctr"/>
+                      <a:r>
+                        <a:rPr sz="1800" b="1">
+                          <a:solidFill>
+                            <a:srgbClr val="263044"/>
+                          </a:solidFill>
+                          <a:latin typeface="Malgun Gothic"/>
+                        </a:rPr>
+                        <a:t>/악화</a:t>
+                      </a:r>
+                    </a:p>
+                  </a:txBody>
+                  <a:tcPr marL="57600" marR="57600" marT="21600" marB="21600" anchor="ctr">
+                    <a:solidFill>
+                      <a:srgbClr val="FFFFFF"/>
+                    </a:solidFill>
+                    <a:lnL w="9525">
+                      <a:solidFill>
+                        <a:srgbClr val="777777"/>
+                      </a:solidFill>
+                    </a:lnL>
+                    <a:lnR w="9525">
+                      <a:solidFill>
+                        <a:srgbClr val="777777"/>
+                      </a:solidFill>
+                    </a:lnR>
+                    <a:lnT w="9525">
+                      <a:solidFill>
+                        <a:srgbClr val="777777"/>
+                      </a:solidFill>
+                    </a:lnT>
+                    <a:lnB w="9525">
+                      <a:solidFill>
+                        <a:srgbClr val="777777"/>
+                      </a:solidFill>
+                    </a:lnB>
+                  </a:tcPr>
+                </a:tc>
+                <a:tc>
+                  <a:txBody>
+                    <a:bodyPr wrap="square"/>
+                    <a:lstStyle/>
+                    <a:p>
+                      <a:pPr algn="ctr"/>
+                      <a:r>
+                        <a:rPr sz="1800" b="1">
+                          <a:solidFill>
+                            <a:srgbClr val="263044"/>
+                          </a:solidFill>
+                          <a:latin typeface="Malgun Gothic"/>
+                        </a:rPr>
                         <a:t>SCD</a:t>
                       </a:r>
                     </a:p>
-                  </a:txBody>
-                  <a:tcPr marL="57600" marR="57600" marT="21600" marB="21600" anchor="ctr">
-                    <a:solidFill>
-                      <a:srgbClr val="FFFFFF"/>
-                    </a:solidFill>
-                    <a:lnL w="9525">
-                      <a:solidFill>
-                        <a:srgbClr val="777777"/>
-                      </a:solidFill>
-                    </a:lnL>
-                    <a:lnR w="9525">
-                      <a:solidFill>
-                        <a:srgbClr val="777777"/>
-                      </a:solidFill>
-                    </a:lnR>
-                    <a:lnT w="9525">
-                      <a:solidFill>
-                        <a:srgbClr val="777777"/>
-                      </a:solidFill>
-                    </a:lnT>
-                    <a:lnB w="9525">
-                      <a:solidFill>
-                        <a:srgbClr val="777777"/>
-                      </a:solidFill>
-                    </a:lnB>
-                  </a:tcPr>
-                </a:tc>
-                <a:tc>
-                  <a:txBody>
-                    <a:bodyPr wrap="square"/>
-                    <a:lstStyle/>
                     <a:p>
                       <a:pPr algn="ctr"/>
                       <a:r>
@@ -7230,9 +7164,40 @@
                           </a:solidFill>
                           <a:latin typeface="Malgun Gothic"/>
                         </a:rPr>
-                        <a:t>HyDE</a:t>
-                      </a:r>
-                    </a:p>
+                        <a:t>한국어 비율</a:t>
+                      </a:r>
+                    </a:p>
+                  </a:txBody>
+                  <a:tcPr marL="57600" marR="57600" marT="21600" marB="21600" anchor="ctr">
+                    <a:solidFill>
+                      <a:srgbClr val="FFFFFF"/>
+                    </a:solidFill>
+                    <a:lnL w="9525">
+                      <a:solidFill>
+                        <a:srgbClr val="777777"/>
+                      </a:solidFill>
+                    </a:lnL>
+                    <a:lnR w="9525">
+                      <a:solidFill>
+                        <a:srgbClr val="777777"/>
+                      </a:solidFill>
+                    </a:lnR>
+                    <a:lnT w="9525">
+                      <a:solidFill>
+                        <a:srgbClr val="777777"/>
+                      </a:solidFill>
+                    </a:lnT>
+                    <a:lnB w="9525">
+                      <a:solidFill>
+                        <a:srgbClr val="777777"/>
+                      </a:solidFill>
+                    </a:lnB>
+                  </a:tcPr>
+                </a:tc>
+                <a:tc>
+                  <a:txBody>
+                    <a:bodyPr wrap="square"/>
+                    <a:lstStyle/>
                     <a:p>
                       <a:pPr algn="ctr"/>
                       <a:r>
@@ -7242,40 +7207,9 @@
                           </a:solidFill>
                           <a:latin typeface="Malgun Gothic"/>
                         </a:rPr>
-                        <a:t>+SCD</a:t>
-                      </a:r>
-                    </a:p>
-                  </a:txBody>
-                  <a:tcPr marL="57600" marR="57600" marT="21600" marB="21600" anchor="ctr">
-                    <a:solidFill>
-                      <a:srgbClr val="FFFFFF"/>
-                    </a:solidFill>
-                    <a:lnL w="9525">
-                      <a:solidFill>
-                        <a:srgbClr val="777777"/>
-                      </a:solidFill>
-                    </a:lnL>
-                    <a:lnR w="9525">
-                      <a:solidFill>
-                        <a:srgbClr val="777777"/>
-                      </a:solidFill>
-                    </a:lnR>
-                    <a:lnT w="9525">
-                      <a:solidFill>
-                        <a:srgbClr val="777777"/>
-                      </a:solidFill>
-                    </a:lnT>
-                    <a:lnB w="9525">
-                      <a:solidFill>
-                        <a:srgbClr val="777777"/>
-                      </a:solidFill>
-                    </a:lnB>
-                  </a:tcPr>
-                </a:tc>
-                <a:tc>
-                  <a:txBody>
-                    <a:bodyPr wrap="square"/>
-                    <a:lstStyle/>
+                        <a:t>증가</a:t>
+                      </a:r>
+                    </a:p>
                     <a:p>
                       <a:pPr algn="ctr"/>
                       <a:r>
@@ -7285,7 +7219,7 @@
                           </a:solidFill>
                           <a:latin typeface="Malgun Gothic"/>
                         </a:rPr>
-                        <a:t>변화</a:t>
+                        <a:t>/감소</a:t>
                       </a:r>
                     </a:p>
                   </a:txBody>
@@ -7373,7 +7307,7 @@
                           </a:solidFill>
                           <a:latin typeface="Malgun Gothic"/>
                         </a:rPr>
-                        <a:t>8</a:t>
+                        <a:t>+0.05</a:t>
                       </a:r>
                     </a:p>
                   </a:txBody>
@@ -7416,7 +7350,7 @@
                           </a:solidFill>
                           <a:latin typeface="Malgun Gothic"/>
                         </a:rPr>
-                        <a:t>0.78</a:t>
+                        <a:t>4/1</a:t>
                       </a:r>
                     </a:p>
                   </a:txBody>
@@ -7453,13 +7387,99 @@
                     <a:p>
                       <a:pPr algn="r"/>
                       <a:r>
+                        <a:rPr sz="1800" b="0">
+                          <a:solidFill>
+                            <a:srgbClr val="263044"/>
+                          </a:solidFill>
+                          <a:latin typeface="Malgun Gothic"/>
+                        </a:rPr>
+                        <a:t>0.00</a:t>
+                      </a:r>
+                    </a:p>
+                  </a:txBody>
+                  <a:tcPr marL="57600" marR="57600" marT="21600" marB="21600" anchor="ctr">
+                    <a:solidFill>
+                      <a:srgbClr val="FFFFFF"/>
+                    </a:solidFill>
+                    <a:lnL w="9525">
+                      <a:solidFill>
+                        <a:srgbClr val="777777"/>
+                      </a:solidFill>
+                    </a:lnL>
+                    <a:lnR w="9525">
+                      <a:solidFill>
+                        <a:srgbClr val="777777"/>
+                      </a:solidFill>
+                    </a:lnR>
+                    <a:lnT w="9525">
+                      <a:solidFill>
+                        <a:srgbClr val="777777"/>
+                      </a:solidFill>
+                    </a:lnT>
+                    <a:lnB w="9525">
+                      <a:solidFill>
+                        <a:srgbClr val="777777"/>
+                      </a:solidFill>
+                    </a:lnB>
+                  </a:tcPr>
+                </a:tc>
+                <a:tc>
+                  <a:txBody>
+                    <a:bodyPr wrap="square"/>
+                    <a:lstStyle/>
+                    <a:p>
+                      <a:pPr algn="r"/>
+                      <a:r>
+                        <a:rPr sz="1800" b="0">
+                          <a:solidFill>
+                            <a:srgbClr val="263044"/>
+                          </a:solidFill>
+                          <a:latin typeface="Malgun Gothic"/>
+                        </a:rPr>
+                        <a:t>2/4</a:t>
+                      </a:r>
+                    </a:p>
+                  </a:txBody>
+                  <a:tcPr marL="57600" marR="57600" marT="21600" marB="21600" anchor="ctr">
+                    <a:solidFill>
+                      <a:srgbClr val="FFFFFF"/>
+                    </a:solidFill>
+                    <a:lnL w="9525">
+                      <a:solidFill>
+                        <a:srgbClr val="777777"/>
+                      </a:solidFill>
+                    </a:lnL>
+                    <a:lnR w="9525">
+                      <a:solidFill>
+                        <a:srgbClr val="777777"/>
+                      </a:solidFill>
+                    </a:lnR>
+                    <a:lnT w="9525">
+                      <a:solidFill>
+                        <a:srgbClr val="777777"/>
+                      </a:solidFill>
+                    </a:lnT>
+                    <a:lnB w="9525">
+                      <a:solidFill>
+                        <a:srgbClr val="777777"/>
+                      </a:solidFill>
+                    </a:lnB>
+                  </a:tcPr>
+                </a:tc>
+                <a:tc>
+                  <a:txBody>
+                    <a:bodyPr wrap="square"/>
+                    <a:lstStyle/>
+                    <a:p>
+                      <a:pPr algn="r"/>
+                      <a:r>
                         <a:rPr sz="1800" b="1">
                           <a:solidFill>
                             <a:srgbClr val="263044"/>
                           </a:solidFill>
                           <a:latin typeface="Malgun Gothic"/>
                         </a:rPr>
-                        <a:t>0.82</a:t>
+                        <a:t>+0.28</a:t>
                       </a:r>
                     </a:p>
                   </a:txBody>
@@ -7502,136 +7522,7 @@
                           </a:solidFill>
                           <a:latin typeface="Malgun Gothic"/>
                         </a:rPr>
-                        <a:t>+0.05</a:t>
-                      </a:r>
-                    </a:p>
-                  </a:txBody>
-                  <a:tcPr marL="57600" marR="57600" marT="21600" marB="21600" anchor="ctr">
-                    <a:solidFill>
-                      <a:srgbClr val="FFFFFF"/>
-                    </a:solidFill>
-                    <a:lnL w="9525">
-                      <a:solidFill>
-                        <a:srgbClr val="777777"/>
-                      </a:solidFill>
-                    </a:lnL>
-                    <a:lnR w="9525">
-                      <a:solidFill>
-                        <a:srgbClr val="777777"/>
-                      </a:solidFill>
-                    </a:lnR>
-                    <a:lnT w="9525">
-                      <a:solidFill>
-                        <a:srgbClr val="777777"/>
-                      </a:solidFill>
-                    </a:lnT>
-                    <a:lnB w="9525">
-                      <a:solidFill>
-                        <a:srgbClr val="777777"/>
-                      </a:solidFill>
-                    </a:lnB>
-                  </a:tcPr>
-                </a:tc>
-                <a:tc>
-                  <a:txBody>
-                    <a:bodyPr wrap="square"/>
-                    <a:lstStyle/>
-                    <a:p>
-                      <a:pPr algn="r"/>
-                      <a:r>
-                        <a:rPr sz="1800" b="0">
-                          <a:solidFill>
-                            <a:srgbClr val="263044"/>
-                          </a:solidFill>
-                          <a:latin typeface="Malgun Gothic"/>
-                        </a:rPr>
-                        <a:t>0.70</a:t>
-                      </a:r>
-                    </a:p>
-                  </a:txBody>
-                  <a:tcPr marL="57600" marR="57600" marT="21600" marB="21600" anchor="ctr">
-                    <a:solidFill>
-                      <a:srgbClr val="FFFFFF"/>
-                    </a:solidFill>
-                    <a:lnL w="9525">
-                      <a:solidFill>
-                        <a:srgbClr val="777777"/>
-                      </a:solidFill>
-                    </a:lnL>
-                    <a:lnR w="9525">
-                      <a:solidFill>
-                        <a:srgbClr val="777777"/>
-                      </a:solidFill>
-                    </a:lnR>
-                    <a:lnT w="9525">
-                      <a:solidFill>
-                        <a:srgbClr val="777777"/>
-                      </a:solidFill>
-                    </a:lnT>
-                    <a:lnB w="9525">
-                      <a:solidFill>
-                        <a:srgbClr val="777777"/>
-                      </a:solidFill>
-                    </a:lnB>
-                  </a:tcPr>
-                </a:tc>
-                <a:tc>
-                  <a:txBody>
-                    <a:bodyPr wrap="square"/>
-                    <a:lstStyle/>
-                    <a:p>
-                      <a:pPr algn="r"/>
-                      <a:r>
-                        <a:rPr sz="1800" b="1">
-                          <a:solidFill>
-                            <a:srgbClr val="263044"/>
-                          </a:solidFill>
-                          <a:latin typeface="Malgun Gothic"/>
-                        </a:rPr>
-                        <a:t>0.79</a:t>
-                      </a:r>
-                    </a:p>
-                  </a:txBody>
-                  <a:tcPr marL="57600" marR="57600" marT="21600" marB="21600" anchor="ctr">
-                    <a:solidFill>
-                      <a:srgbClr val="FFFFFF"/>
-                    </a:solidFill>
-                    <a:lnL w="9525">
-                      <a:solidFill>
-                        <a:srgbClr val="777777"/>
-                      </a:solidFill>
-                    </a:lnL>
-                    <a:lnR w="9525">
-                      <a:solidFill>
-                        <a:srgbClr val="777777"/>
-                      </a:solidFill>
-                    </a:lnR>
-                    <a:lnT w="9525">
-                      <a:solidFill>
-                        <a:srgbClr val="777777"/>
-                      </a:solidFill>
-                    </a:lnT>
-                    <a:lnB w="9525">
-                      <a:solidFill>
-                        <a:srgbClr val="777777"/>
-                      </a:solidFill>
-                    </a:lnB>
-                  </a:tcPr>
-                </a:tc>
-                <a:tc>
-                  <a:txBody>
-                    <a:bodyPr wrap="square"/>
-                    <a:lstStyle/>
-                    <a:p>
-                      <a:pPr algn="r"/>
-                      <a:r>
-                        <a:rPr sz="1800" b="0">
-                          <a:solidFill>
-                            <a:srgbClr val="263044"/>
-                          </a:solidFill>
-                          <a:latin typeface="Malgun Gothic"/>
-                        </a:rPr>
-                        <a:t>+0.09</a:t>
+                        <a:t>8/0</a:t>
                       </a:r>
                     </a:p>
                   </a:txBody>
@@ -7713,13 +7604,56 @@
                     <a:p>
                       <a:pPr algn="r"/>
                       <a:r>
+                        <a:rPr sz="1800" b="1">
+                          <a:solidFill>
+                            <a:srgbClr val="263044"/>
+                          </a:solidFill>
+                          <a:latin typeface="Malgun Gothic"/>
+                        </a:rPr>
+                        <a:t>+0.07</a:t>
+                      </a:r>
+                    </a:p>
+                  </a:txBody>
+                  <a:tcPr marL="57600" marR="57600" marT="21600" marB="21600" anchor="ctr">
+                    <a:solidFill>
+                      <a:srgbClr val="FFFFFF"/>
+                    </a:solidFill>
+                    <a:lnL w="9525">
+                      <a:solidFill>
+                        <a:srgbClr val="777777"/>
+                      </a:solidFill>
+                    </a:lnL>
+                    <a:lnR w="9525">
+                      <a:solidFill>
+                        <a:srgbClr val="777777"/>
+                      </a:solidFill>
+                    </a:lnR>
+                    <a:lnT w="9525">
+                      <a:solidFill>
+                        <a:srgbClr val="777777"/>
+                      </a:solidFill>
+                    </a:lnT>
+                    <a:lnB w="9525">
+                      <a:solidFill>
+                        <a:srgbClr val="777777"/>
+                      </a:solidFill>
+                    </a:lnB>
+                  </a:tcPr>
+                </a:tc>
+                <a:tc>
+                  <a:txBody>
+                    <a:bodyPr wrap="square"/>
+                    <a:lstStyle/>
+                    <a:p>
+                      <a:pPr algn="r"/>
+                      <a:r>
                         <a:rPr sz="1800" b="0">
                           <a:solidFill>
                             <a:srgbClr val="263044"/>
                           </a:solidFill>
                           <a:latin typeface="Malgun Gothic"/>
                         </a:rPr>
-                        <a:t>29</a:t>
+                        <a:t>8/2</a:t>
                       </a:r>
                     </a:p>
                   </a:txBody>
@@ -7756,13 +7690,56 @@
                     <a:p>
                       <a:pPr algn="r"/>
                       <a:r>
+                        <a:rPr sz="1800" b="1">
+                          <a:solidFill>
+                            <a:srgbClr val="263044"/>
+                          </a:solidFill>
+                          <a:latin typeface="Malgun Gothic"/>
+                        </a:rPr>
+                        <a:t>+0.08</a:t>
+                      </a:r>
+                    </a:p>
+                  </a:txBody>
+                  <a:tcPr marL="57600" marR="57600" marT="21600" marB="21600" anchor="ctr">
+                    <a:solidFill>
+                      <a:srgbClr val="FFFFFF"/>
+                    </a:solidFill>
+                    <a:lnL w="9525">
+                      <a:solidFill>
+                        <a:srgbClr val="777777"/>
+                      </a:solidFill>
+                    </a:lnL>
+                    <a:lnR w="9525">
+                      <a:solidFill>
+                        <a:srgbClr val="777777"/>
+                      </a:solidFill>
+                    </a:lnR>
+                    <a:lnT w="9525">
+                      <a:solidFill>
+                        <a:srgbClr val="777777"/>
+                      </a:solidFill>
+                    </a:lnT>
+                    <a:lnB w="9525">
+                      <a:solidFill>
+                        <a:srgbClr val="777777"/>
+                      </a:solidFill>
+                    </a:lnB>
+                  </a:tcPr>
+                </a:tc>
+                <a:tc>
+                  <a:txBody>
+                    <a:bodyPr wrap="square"/>
+                    <a:lstStyle/>
+                    <a:p>
+                      <a:pPr algn="r"/>
+                      <a:r>
                         <a:rPr sz="1800" b="0">
                           <a:solidFill>
                             <a:srgbClr val="263044"/>
                           </a:solidFill>
                           <a:latin typeface="Malgun Gothic"/>
                         </a:rPr>
-                        <a:t>0.58</a:t>
+                        <a:t>10/7</a:t>
                       </a:r>
                     </a:p>
                   </a:txBody>
@@ -7805,7 +7782,7 @@
                           </a:solidFill>
                           <a:latin typeface="Malgun Gothic"/>
                         </a:rPr>
-                        <a:t>0.75</a:t>
+                        <a:t>+0.16</a:t>
                       </a:r>
                     </a:p>
                   </a:txBody>
@@ -7842,142 +7819,13 @@
                     <a:p>
                       <a:pPr algn="r"/>
                       <a:r>
-                        <a:rPr sz="1800" b="1">
-                          <a:solidFill>
-                            <a:srgbClr val="263044"/>
-                          </a:solidFill>
-                          <a:latin typeface="Malgun Gothic"/>
-                        </a:rPr>
-                        <a:t>+0.17</a:t>
-                      </a:r>
-                    </a:p>
-                  </a:txBody>
-                  <a:tcPr marL="57600" marR="57600" marT="21600" marB="21600" anchor="ctr">
-                    <a:solidFill>
-                      <a:srgbClr val="FFFFFF"/>
-                    </a:solidFill>
-                    <a:lnL w="9525">
-                      <a:solidFill>
-                        <a:srgbClr val="777777"/>
-                      </a:solidFill>
-                    </a:lnL>
-                    <a:lnR w="9525">
-                      <a:solidFill>
-                        <a:srgbClr val="777777"/>
-                      </a:solidFill>
-                    </a:lnR>
-                    <a:lnT w="9525">
-                      <a:solidFill>
-                        <a:srgbClr val="777777"/>
-                      </a:solidFill>
-                    </a:lnT>
-                    <a:lnB w="9525">
-                      <a:solidFill>
-                        <a:srgbClr val="777777"/>
-                      </a:solidFill>
-                    </a:lnB>
-                  </a:tcPr>
-                </a:tc>
-                <a:tc>
-                  <a:txBody>
-                    <a:bodyPr wrap="square"/>
-                    <a:lstStyle/>
-                    <a:p>
-                      <a:pPr algn="r"/>
-                      <a:r>
                         <a:rPr sz="1800" b="0">
                           <a:solidFill>
                             <a:srgbClr val="263044"/>
                           </a:solidFill>
                           <a:latin typeface="Malgun Gothic"/>
                         </a:rPr>
-                        <a:t>0.53</a:t>
-                      </a:r>
-                    </a:p>
-                  </a:txBody>
-                  <a:tcPr marL="57600" marR="57600" marT="21600" marB="21600" anchor="ctr">
-                    <a:solidFill>
-                      <a:srgbClr val="FFFFFF"/>
-                    </a:solidFill>
-                    <a:lnL w="9525">
-                      <a:solidFill>
-                        <a:srgbClr val="777777"/>
-                      </a:solidFill>
-                    </a:lnL>
-                    <a:lnR w="9525">
-                      <a:solidFill>
-                        <a:srgbClr val="777777"/>
-                      </a:solidFill>
-                    </a:lnR>
-                    <a:lnT w="9525">
-                      <a:solidFill>
-                        <a:srgbClr val="777777"/>
-                      </a:solidFill>
-                    </a:lnT>
-                    <a:lnB w="9525">
-                      <a:solidFill>
-                        <a:srgbClr val="777777"/>
-                      </a:solidFill>
-                    </a:lnB>
-                  </a:tcPr>
-                </a:tc>
-                <a:tc>
-                  <a:txBody>
-                    <a:bodyPr wrap="square"/>
-                    <a:lstStyle/>
-                    <a:p>
-                      <a:pPr algn="r"/>
-                      <a:r>
-                        <a:rPr sz="1800" b="0">
-                          <a:solidFill>
-                            <a:srgbClr val="263044"/>
-                          </a:solidFill>
-                          <a:latin typeface="Malgun Gothic"/>
-                        </a:rPr>
-                        <a:t>0.69</a:t>
-                      </a:r>
-                    </a:p>
-                  </a:txBody>
-                  <a:tcPr marL="57600" marR="57600" marT="21600" marB="21600" anchor="ctr">
-                    <a:solidFill>
-                      <a:srgbClr val="FFFFFF"/>
-                    </a:solidFill>
-                    <a:lnL w="9525">
-                      <a:solidFill>
-                        <a:srgbClr val="777777"/>
-                      </a:solidFill>
-                    </a:lnL>
-                    <a:lnR w="9525">
-                      <a:solidFill>
-                        <a:srgbClr val="777777"/>
-                      </a:solidFill>
-                    </a:lnR>
-                    <a:lnT w="9525">
-                      <a:solidFill>
-                        <a:srgbClr val="777777"/>
-                      </a:solidFill>
-                    </a:lnT>
-                    <a:lnB w="9525">
-                      <a:solidFill>
-                        <a:srgbClr val="777777"/>
-                      </a:solidFill>
-                    </a:lnB>
-                  </a:tcPr>
-                </a:tc>
-                <a:tc>
-                  <a:txBody>
-                    <a:bodyPr wrap="square"/>
-                    <a:lstStyle/>
-                    <a:p>
-                      <a:pPr algn="r"/>
-                      <a:r>
-                        <a:rPr sz="1800" b="1">
-                          <a:solidFill>
-                            <a:srgbClr val="263044"/>
-                          </a:solidFill>
-                          <a:latin typeface="Malgun Gothic"/>
-                        </a:rPr>
-                        <a:t>+0.16</a:t>
+                        <a:t>22/2</a:t>
                       </a:r>
                     </a:p>
                   </a:txBody>
@@ -8065,7 +7913,7 @@
                           </a:solidFill>
                           <a:latin typeface="Malgun Gothic"/>
                         </a:rPr>
-                        <a:t>20</a:t>
+                        <a:t>+0.02</a:t>
                       </a:r>
                     </a:p>
                   </a:txBody>
@@ -8108,7 +7956,7 @@
                           </a:solidFill>
                           <a:latin typeface="Malgun Gothic"/>
                         </a:rPr>
-                        <a:t>0.78</a:t>
+                        <a:t>4/1</a:t>
                       </a:r>
                     </a:p>
                   </a:txBody>
@@ -8151,7 +7999,7 @@
                           </a:solidFill>
                           <a:latin typeface="Malgun Gothic"/>
                         </a:rPr>
-                        <a:t>0.76</a:t>
+                        <a:t>0.00</a:t>
                       </a:r>
                     </a:p>
                   </a:txBody>
@@ -8194,7 +8042,7 @@
                           </a:solidFill>
                           <a:latin typeface="Malgun Gothic"/>
                         </a:rPr>
-                        <a:t>-0.02</a:t>
+                        <a:t>4/7</a:t>
                       </a:r>
                     </a:p>
                   </a:txBody>
@@ -8237,7 +8085,7 @@
                           </a:solidFill>
                           <a:latin typeface="Malgun Gothic"/>
                         </a:rPr>
-                        <a:t>0.74</a:t>
+                        <a:t>+0.25</a:t>
                       </a:r>
                     </a:p>
                   </a:txBody>
@@ -8280,50 +8128,7 @@
                           </a:solidFill>
                           <a:latin typeface="Malgun Gothic"/>
                         </a:rPr>
-                        <a:t>0.73</a:t>
-                      </a:r>
-                    </a:p>
-                  </a:txBody>
-                  <a:tcPr marL="57600" marR="57600" marT="21600" marB="21600" anchor="ctr">
-                    <a:solidFill>
-                      <a:srgbClr val="FFFFFF"/>
-                    </a:solidFill>
-                    <a:lnL w="9525">
-                      <a:solidFill>
-                        <a:srgbClr val="777777"/>
-                      </a:solidFill>
-                    </a:lnL>
-                    <a:lnR w="9525">
-                      <a:solidFill>
-                        <a:srgbClr val="777777"/>
-                      </a:solidFill>
-                    </a:lnR>
-                    <a:lnT w="9525">
-                      <a:solidFill>
-                        <a:srgbClr val="777777"/>
-                      </a:solidFill>
-                    </a:lnT>
-                    <a:lnB w="9525">
-                      <a:solidFill>
-                        <a:srgbClr val="777777"/>
-                      </a:solidFill>
-                    </a:lnB>
-                  </a:tcPr>
-                </a:tc>
-                <a:tc>
-                  <a:txBody>
-                    <a:bodyPr wrap="square"/>
-                    <a:lstStyle/>
-                    <a:p>
-                      <a:pPr algn="r"/>
-                      <a:r>
-                        <a:rPr sz="1800" b="0">
-                          <a:solidFill>
-                            <a:srgbClr val="263044"/>
-                          </a:solidFill>
-                          <a:latin typeface="Malgun Gothic"/>
-                        </a:rPr>
-                        <a:t>-0.01</a:t>
+                        <a:t>18/0</a:t>
                       </a:r>
                     </a:p>
                   </a:txBody>
@@ -8411,7 +8216,7 @@
                           </a:solidFill>
                           <a:latin typeface="Malgun Gothic"/>
                         </a:rPr>
-                        <a:t>3</a:t>
+                        <a:t>-0.03</a:t>
                       </a:r>
                     </a:p>
                   </a:txBody>
@@ -8454,7 +8259,7 @@
                           </a:solidFill>
                           <a:latin typeface="Malgun Gothic"/>
                         </a:rPr>
-                        <a:t>0.82</a:t>
+                        <a:t>0/1</a:t>
                       </a:r>
                     </a:p>
                   </a:txBody>
@@ -8497,7 +8302,7 @@
                           </a:solidFill>
                           <a:latin typeface="Malgun Gothic"/>
                         </a:rPr>
-                        <a:t>0.79</a:t>
+                        <a:t>-0.16</a:t>
                       </a:r>
                     </a:p>
                   </a:txBody>
@@ -8540,7 +8345,7 @@
                           </a:solidFill>
                           <a:latin typeface="Malgun Gothic"/>
                         </a:rPr>
-                        <a:t>-0.03</a:t>
+                        <a:t>0/1</a:t>
                       </a:r>
                     </a:p>
                   </a:txBody>
@@ -8583,7 +8388,7 @@
                           </a:solidFill>
                           <a:latin typeface="Malgun Gothic"/>
                         </a:rPr>
-                        <a:t>0.81</a:t>
+                        <a:t>+0.15</a:t>
                       </a:r>
                     </a:p>
                   </a:txBody>
@@ -8626,50 +8431,7 @@
                           </a:solidFill>
                           <a:latin typeface="Malgun Gothic"/>
                         </a:rPr>
-                        <a:t>0.59</a:t>
-                      </a:r>
-                    </a:p>
-                  </a:txBody>
-                  <a:tcPr marL="57600" marR="57600" marT="21600" marB="21600" anchor="ctr">
-                    <a:solidFill>
-                      <a:srgbClr val="FFFFFF"/>
-                    </a:solidFill>
-                    <a:lnL w="9525">
-                      <a:solidFill>
-                        <a:srgbClr val="777777"/>
-                      </a:solidFill>
-                    </a:lnL>
-                    <a:lnR w="9525">
-                      <a:solidFill>
-                        <a:srgbClr val="777777"/>
-                      </a:solidFill>
-                    </a:lnR>
-                    <a:lnT w="9525">
-                      <a:solidFill>
-                        <a:srgbClr val="777777"/>
-                      </a:solidFill>
-                    </a:lnT>
-                    <a:lnB w="9525">
-                      <a:solidFill>
-                        <a:srgbClr val="777777"/>
-                      </a:solidFill>
-                    </a:lnB>
-                  </a:tcPr>
-                </a:tc>
-                <a:tc>
-                  <a:txBody>
-                    <a:bodyPr wrap="square"/>
-                    <a:lstStyle/>
-                    <a:p>
-                      <a:pPr algn="r"/>
-                      <a:r>
-                        <a:rPr sz="1800" b="0">
-                          <a:solidFill>
-                            <a:srgbClr val="263044"/>
-                          </a:solidFill>
-                          <a:latin typeface="Malgun Gothic"/>
-                        </a:rPr>
-                        <a:t>-0.21</a:t>
+                        <a:t>2/1</a:t>
                       </a:r>
                     </a:p>
                   </a:txBody>
@@ -8714,7 +8476,7 @@
                           </a:solidFill>
                           <a:latin typeface="Malgun Gothic"/>
                         </a:rPr>
-                        <a:t>전체</a:t>
+                        <a:t>전체 60개</a:t>
                       </a:r>
                     </a:p>
                   </a:txBody>
@@ -8757,7 +8519,7 @@
                           </a:solidFill>
                           <a:latin typeface="Malgun Gothic"/>
                         </a:rPr>
-                        <a:t>60</a:t>
+                        <a:t>+0.04</a:t>
                       </a:r>
                     </a:p>
                   </a:txBody>
@@ -8800,7 +8562,7 @@
                           </a:solidFill>
                           <a:latin typeface="Malgun Gothic"/>
                         </a:rPr>
-                        <a:t>0.68</a:t>
+                        <a:t>16/5</a:t>
                       </a:r>
                     </a:p>
                   </a:txBody>
@@ -8843,7 +8605,7 @@
                           </a:solidFill>
                           <a:latin typeface="Malgun Gothic"/>
                         </a:rPr>
-                        <a:t>0.76</a:t>
+                        <a:t>+0.03</a:t>
                       </a:r>
                     </a:p>
                   </a:txBody>
@@ -8886,7 +8648,7 @@
                           </a:solidFill>
                           <a:latin typeface="Malgun Gothic"/>
                         </a:rPr>
-                        <a:t>+0.08</a:t>
+                        <a:t>16/19</a:t>
                       </a:r>
                     </a:p>
                   </a:txBody>
@@ -8929,7 +8691,7 @@
                           </a:solidFill>
                           <a:latin typeface="Malgun Gothic"/>
                         </a:rPr>
-                        <a:t>0.64</a:t>
+                        <a:t>+0.20</a:t>
                       </a:r>
                     </a:p>
                   </a:txBody>
@@ -8972,50 +8734,7 @@
                           </a:solidFill>
                           <a:latin typeface="Malgun Gothic"/>
                         </a:rPr>
-                        <a:t>0.71</a:t>
-                      </a:r>
-                    </a:p>
-                  </a:txBody>
-                  <a:tcPr marL="57600" marR="57600" marT="21600" marB="21600" anchor="ctr">
-                    <a:solidFill>
-                      <a:srgbClr val="FFFFFF"/>
-                    </a:solidFill>
-                    <a:lnL w="9525">
-                      <a:solidFill>
-                        <a:srgbClr val="777777"/>
-                      </a:solidFill>
-                    </a:lnL>
-                    <a:lnR w="9525">
-                      <a:solidFill>
-                        <a:srgbClr val="777777"/>
-                      </a:solidFill>
-                    </a:lnR>
-                    <a:lnT w="9525">
-                      <a:solidFill>
-                        <a:srgbClr val="777777"/>
-                      </a:solidFill>
-                    </a:lnT>
-                    <a:lnB w="9525">
-                      <a:solidFill>
-                        <a:srgbClr val="777777"/>
-                      </a:solidFill>
-                    </a:lnB>
-                  </a:tcPr>
-                </a:tc>
-                <a:tc>
-                  <a:txBody>
-                    <a:bodyPr wrap="square"/>
-                    <a:lstStyle/>
-                    <a:p>
-                      <a:pPr algn="r"/>
-                      <a:r>
-                        <a:rPr sz="1800" b="0">
-                          <a:solidFill>
-                            <a:srgbClr val="263044"/>
-                          </a:solidFill>
-                          <a:latin typeface="Malgun Gothic"/>
-                        </a:rPr>
-                        <a:t>+0.07</a:t>
+                        <a:t>50/3</a:t>
                       </a:r>
                     </a:p>
                   </a:txBody>
@@ -9052,13 +8771,13 @@
       </p:graphicFrame>
       <p:sp>
         <p:nvSpPr>
-          <p:cNvPr id="26" name="TextBox 25"/>
+          <p:cNvPr id="25" name="TextBox 24"/>
           <p:cNvSpPr txBox="1"/>
           <p:nvPr/>
         </p:nvSpPr>
         <p:spPr>
           <a:xfrm>
-            <a:off x="10980000" y="7114766"/>
+            <a:off x="10980000" y="6862766"/>
             <a:ext cx="9612000" cy="318536"/>
           </a:xfrm>
           <a:prstGeom prst="rect">
@@ -9085,20 +8804,20 @@
                 <a:latin typeface="Malgun Gothic"/>
                 <a:ea typeface="Malgun Gothic"/>
               </a:rPr>
-              <a:t>- 방법·절차: 두 평가 언어 모두 가장 크게 상승(+0.17, +0.16), 개선 14 · 악화 3</a:t>
+              <a:t>- 미적용 대비 평균 변화 · 관련성 비교는 0점 답변이 있는 질문 제외(이 표 9개)</a:t>
             </a:r>
           </a:p>
         </p:txBody>
       </p:sp>
       <p:sp>
         <p:nvSpPr>
-          <p:cNvPr id="27" name="TextBox 26"/>
+          <p:cNvPr id="26" name="TextBox 25"/>
           <p:cNvSpPr txBox="1"/>
           <p:nvPr/>
         </p:nvSpPr>
         <p:spPr>
           <a:xfrm>
-            <a:off x="10980000" y="7523303"/>
+            <a:off x="10980000" y="7271303"/>
             <a:ext cx="9612000" cy="318536"/>
           </a:xfrm>
           <a:prstGeom prst="rect">
@@ -9125,20 +8844,20 @@
                 <a:latin typeface="Malgun Gothic"/>
                 <a:ea typeface="Malgun Gothic"/>
               </a:rPr>
-              <a:t>- 방법·절차 6개는 회피 응답(0점)에서 답변으로 바뀜 · 결과·비교는 −0.02</a:t>
+              <a:t>- HyDE는 방법·절차 질문의 관련성을 가장 크게 높임(+0.07, 개선 8 · 악화 2)</a:t>
             </a:r>
           </a:p>
         </p:txBody>
       </p:sp>
       <p:sp>
         <p:nvSpPr>
-          <p:cNvPr id="28" name="Rectangle 27"/>
+          <p:cNvPr id="27" name="Rectangle 26"/>
           <p:cNvSpPr/>
           <p:nvPr/>
         </p:nvSpPr>
         <p:spPr>
           <a:xfrm>
-            <a:off x="10980000" y="8075839"/>
+            <a:off x="10980000" y="7823839"/>
             <a:ext cx="9612000" cy="468000"/>
           </a:xfrm>
           <a:prstGeom prst="rect">
@@ -9176,13 +8895,13 @@
       </p:sp>
       <p:sp>
         <p:nvSpPr>
-          <p:cNvPr id="29" name="TextBox 28"/>
+          <p:cNvPr id="28" name="TextBox 27"/>
           <p:cNvSpPr txBox="1"/>
           <p:nvPr/>
         </p:nvSpPr>
         <p:spPr>
           <a:xfrm>
-            <a:off x="11124000" y="8101039"/>
+            <a:off x="11124000" y="7849039"/>
             <a:ext cx="9324000" cy="360000"/>
           </a:xfrm>
           <a:prstGeom prst="rect">
@@ -9209,21 +8928,21 @@
                 <a:latin typeface="Malgun Gothic"/>
                 <a:ea typeface="Malgun Gothic"/>
               </a:rPr>
-              <a:t>05 기법을 더했을 때의 변화 (60개)</a:t>
+              <a:t>05 기법을 더했을 때의 관련성 변화</a:t>
             </a:r>
           </a:p>
         </p:txBody>
       </p:sp>
       <p:graphicFrame>
         <p:nvGraphicFramePr>
-          <p:cNvPr id="30" name="Table 29"/>
+          <p:cNvPr id="29" name="Table 28"/>
           <p:cNvGraphicFramePr>
             <a:graphicFrameLocks noGrp="1"/>
           </p:cNvGraphicFramePr>
           <p:nvPr/>
         </p:nvGraphicFramePr>
         <p:xfrm>
-          <a:off x="10980000" y="8687839"/>
+          <a:off x="10980000" y="8435839"/>
           <a:ext cx="9611999" cy="3566691"/>
         </p:xfrm>
         <a:graphic>
@@ -9295,7 +9014,7 @@
                           </a:solidFill>
                           <a:latin typeface="Malgun Gothic"/>
                         </a:rPr>
-                        <a:t>기준 → 적용 조건</a:t>
+                        <a:t>기법 적용 방법</a:t>
                       </a:r>
                     </a:p>
                   </a:txBody>
@@ -9493,7 +9212,7 @@
                           </a:solidFill>
                           <a:latin typeface="Malgun Gothic"/>
                         </a:rPr>
-                        <a:t>미적용 → HyDE</a:t>
+                        <a:t>미적용 상태에서 HyDE 적용</a:t>
                       </a:r>
                     </a:p>
                   </a:txBody>
@@ -9536,7 +9255,7 @@
                           </a:solidFill>
                           <a:latin typeface="Malgun Gothic"/>
                         </a:rPr>
-                        <a:t>+0.08</a:t>
+                        <a:t>+0.04</a:t>
                       </a:r>
                     </a:p>
                   </a:txBody>
@@ -9579,7 +9298,7 @@
                           </a:solidFill>
                           <a:latin typeface="Malgun Gothic"/>
                         </a:rPr>
-                        <a:t>22/7/31</a:t>
+                        <a:t>16/5/30</a:t>
                       </a:r>
                     </a:p>
                   </a:txBody>
@@ -9667,7 +9386,7 @@
                           </a:solidFill>
                           <a:latin typeface="Malgun Gothic"/>
                         </a:rPr>
-                        <a:t>CAD → HyDE+CAD</a:t>
+                        <a:t>CAD에 HyDE 추가</a:t>
                       </a:r>
                     </a:p>
                   </a:txBody>
@@ -9710,7 +9429,7 @@
                           </a:solidFill>
                           <a:latin typeface="Malgun Gothic"/>
                         </a:rPr>
-                        <a:t>+0.03</a:t>
+                        <a:t>+0.01</a:t>
                       </a:r>
                     </a:p>
                   </a:txBody>
@@ -9753,7 +9472,7 @@
                           </a:solidFill>
                           <a:latin typeface="Malgun Gothic"/>
                         </a:rPr>
-                        <a:t>15/13/32</a:t>
+                        <a:t>9/8/32</a:t>
                       </a:r>
                     </a:p>
                   </a:txBody>
@@ -9841,7 +9560,7 @@
                           </a:solidFill>
                           <a:latin typeface="Malgun Gothic"/>
                         </a:rPr>
-                        <a:t>SCD → HyDE+SCD</a:t>
+                        <a:t>SCD에 HyDE 추가</a:t>
                       </a:r>
                     </a:p>
                   </a:txBody>
@@ -9878,56 +9597,56 @@
                     <a:p>
                       <a:pPr algn="r"/>
                       <a:r>
+                        <a:rPr sz="1800" b="1">
+                          <a:solidFill>
+                            <a:srgbClr val="263044"/>
+                          </a:solidFill>
+                          <a:latin typeface="Malgun Gothic"/>
+                        </a:rPr>
+                        <a:t>+0.04</a:t>
+                      </a:r>
+                    </a:p>
+                  </a:txBody>
+                  <a:tcPr marL="57600" marR="57600" marT="21600" marB="21600" anchor="ctr">
+                    <a:solidFill>
+                      <a:srgbClr val="FFFFFF"/>
+                    </a:solidFill>
+                    <a:lnL w="9525">
+                      <a:solidFill>
+                        <a:srgbClr val="777777"/>
+                      </a:solidFill>
+                    </a:lnL>
+                    <a:lnR w="9525">
+                      <a:solidFill>
+                        <a:srgbClr val="777777"/>
+                      </a:solidFill>
+                    </a:lnR>
+                    <a:lnT w="9525">
+                      <a:solidFill>
+                        <a:srgbClr val="777777"/>
+                      </a:solidFill>
+                    </a:lnT>
+                    <a:lnB w="9525">
+                      <a:solidFill>
+                        <a:srgbClr val="777777"/>
+                      </a:solidFill>
+                    </a:lnB>
+                  </a:tcPr>
+                </a:tc>
+                <a:tc>
+                  <a:txBody>
+                    <a:bodyPr wrap="square"/>
+                    <a:lstStyle/>
+                    <a:p>
+                      <a:pPr algn="r"/>
+                      <a:r>
                         <a:rPr sz="1800" b="0">
                           <a:solidFill>
                             <a:srgbClr val="263044"/>
                           </a:solidFill>
                           <a:latin typeface="Malgun Gothic"/>
                         </a:rPr>
-                        <a:t>+0.07</a:t>
-                      </a:r>
-                    </a:p>
-                  </a:txBody>
-                  <a:tcPr marL="57600" marR="57600" marT="21600" marB="21600" anchor="ctr">
-                    <a:solidFill>
-                      <a:srgbClr val="FFFFFF"/>
-                    </a:solidFill>
-                    <a:lnL w="9525">
-                      <a:solidFill>
-                        <a:srgbClr val="777777"/>
-                      </a:solidFill>
-                    </a:lnL>
-                    <a:lnR w="9525">
-                      <a:solidFill>
-                        <a:srgbClr val="777777"/>
-                      </a:solidFill>
-                    </a:lnR>
-                    <a:lnT w="9525">
-                      <a:solidFill>
-                        <a:srgbClr val="777777"/>
-                      </a:solidFill>
-                    </a:lnT>
-                    <a:lnB w="9525">
-                      <a:solidFill>
-                        <a:srgbClr val="777777"/>
-                      </a:solidFill>
-                    </a:lnB>
-                  </a:tcPr>
-                </a:tc>
-                <a:tc>
-                  <a:txBody>
-                    <a:bodyPr wrap="square"/>
-                    <a:lstStyle/>
-                    <a:p>
-                      <a:pPr algn="r"/>
-                      <a:r>
-                        <a:rPr sz="1800" b="0">
-                          <a:solidFill>
-                            <a:srgbClr val="263044"/>
-                          </a:solidFill>
-                          <a:latin typeface="Malgun Gothic"/>
-                        </a:rPr>
-                        <a:t>20/14/26</a:t>
+                        <a:t>13/9/25</a:t>
                       </a:r>
                     </a:p>
                   </a:txBody>
@@ -10015,7 +9734,7 @@
                           </a:solidFill>
                           <a:latin typeface="Malgun Gothic"/>
                         </a:rPr>
-                        <a:t>CAD+SCD → HyDE+CAD+SCD</a:t>
+                        <a:t>CAD와 SCD에 HyDE 추가</a:t>
                       </a:r>
                     </a:p>
                   </a:txBody>
@@ -10058,7 +9777,7 @@
                           </a:solidFill>
                           <a:latin typeface="Malgun Gothic"/>
                         </a:rPr>
-                        <a:t>+0.07</a:t>
+                        <a:t>+0.01</a:t>
                       </a:r>
                     </a:p>
                   </a:txBody>
@@ -10101,7 +9820,7 @@
                           </a:solidFill>
                           <a:latin typeface="Malgun Gothic"/>
                         </a:rPr>
-                        <a:t>21/14/25</a:t>
+                        <a:t>12/8/23</a:t>
                       </a:r>
                     </a:p>
                   </a:txBody>
@@ -10189,7 +9908,7 @@
                           </a:solidFill>
                           <a:latin typeface="Malgun Gothic"/>
                         </a:rPr>
-                        <a:t>미적용 → CAD</a:t>
+                        <a:t>미적용 상태에서 CAD 적용</a:t>
                       </a:r>
                     </a:p>
                   </a:txBody>
@@ -10232,7 +9951,7 @@
                           </a:solidFill>
                           <a:latin typeface="Malgun Gothic"/>
                         </a:rPr>
-                        <a:t>-0.01</a:t>
+                        <a:t>-0.02</a:t>
                       </a:r>
                     </a:p>
                   </a:txBody>
@@ -10275,7 +9994,7 @@
                           </a:solidFill>
                           <a:latin typeface="Malgun Gothic"/>
                         </a:rPr>
-                        <a:t>14/19/27</a:t>
+                        <a:t>8/14/26</a:t>
                       </a:r>
                     </a:p>
                   </a:txBody>
@@ -10363,7 +10082,7 @@
                           </a:solidFill>
                           <a:latin typeface="Malgun Gothic"/>
                         </a:rPr>
-                        <a:t>HyDE → HyDE+CAD</a:t>
+                        <a:t>HyDE에 CAD 추가</a:t>
                       </a:r>
                     </a:p>
                   </a:txBody>
@@ -10406,7 +10125,7 @@
                           </a:solidFill>
                           <a:latin typeface="Malgun Gothic"/>
                         </a:rPr>
-                        <a:t>-0.06</a:t>
+                        <a:t>-0.03</a:t>
                       </a:r>
                     </a:p>
                   </a:txBody>
@@ -10449,7 +10168,7 @@
                           </a:solidFill>
                           <a:latin typeface="Malgun Gothic"/>
                         </a:rPr>
-                        <a:t>7/22/31</a:t>
+                        <a:t>5/18/30</a:t>
                       </a:r>
                     </a:p>
                   </a:txBody>
@@ -10537,7 +10256,7 @@
                           </a:solidFill>
                           <a:latin typeface="Malgun Gothic"/>
                         </a:rPr>
-                        <a:t>SCD → CAD+SCD</a:t>
+                        <a:t>SCD에 CAD 추가</a:t>
                       </a:r>
                     </a:p>
                   </a:txBody>
@@ -10580,7 +10299,7 @@
                           </a:solidFill>
                           <a:latin typeface="Malgun Gothic"/>
                         </a:rPr>
-                        <a:t>-0.04</a:t>
+                        <a:t>-0.02</a:t>
                       </a:r>
                     </a:p>
                   </a:txBody>
@@ -10623,7 +10342,7 @@
                           </a:solidFill>
                           <a:latin typeface="Malgun Gothic"/>
                         </a:rPr>
-                        <a:t>12/20/28</a:t>
+                        <a:t>8/13/24</a:t>
                       </a:r>
                     </a:p>
                   </a:txBody>
@@ -10711,7 +10430,7 @@
                           </a:solidFill>
                           <a:latin typeface="Malgun Gothic"/>
                         </a:rPr>
-                        <a:t>HyDE+SCD → HyDE+CAD+SCD</a:t>
+                        <a:t>HyDE와 SCD에 CAD 추가</a:t>
                       </a:r>
                     </a:p>
                   </a:txBody>
@@ -10754,7 +10473,7 @@
                           </a:solidFill>
                           <a:latin typeface="Malgun Gothic"/>
                         </a:rPr>
-                        <a:t>-0.04</a:t>
+                        <a:t>-0.03</a:t>
                       </a:r>
                     </a:p>
                   </a:txBody>
@@ -10797,7 +10516,7 @@
                           </a:solidFill>
                           <a:latin typeface="Malgun Gothic"/>
                         </a:rPr>
-                        <a:t>7/18/35</a:t>
+                        <a:t>5/14/31</a:t>
                       </a:r>
                     </a:p>
                   </a:txBody>
@@ -10834,13 +10553,13 @@
       </p:graphicFrame>
       <p:sp>
         <p:nvSpPr>
-          <p:cNvPr id="31" name="TextBox 30"/>
+          <p:cNvPr id="30" name="TextBox 29"/>
           <p:cNvSpPr txBox="1"/>
           <p:nvPr/>
         </p:nvSpPr>
         <p:spPr>
           <a:xfrm>
-            <a:off x="10980000" y="12362534"/>
+            <a:off x="10980000" y="12110534"/>
             <a:ext cx="9612000" cy="318536"/>
           </a:xfrm>
           <a:prstGeom prst="rect">
@@ -10874,13 +10593,13 @@
       </p:sp>
       <p:sp>
         <p:nvSpPr>
-          <p:cNvPr id="32" name="TextBox 31"/>
+          <p:cNvPr id="31" name="TextBox 30"/>
           <p:cNvSpPr txBox="1"/>
           <p:nvPr/>
         </p:nvSpPr>
         <p:spPr>
           <a:xfrm>
-            <a:off x="10980000" y="12771070"/>
+            <a:off x="10980000" y="12519070"/>
             <a:ext cx="9612000" cy="318536"/>
           </a:xfrm>
           <a:prstGeom prst="rect">
@@ -10907,20 +10626,20 @@
                 <a:latin typeface="Malgun Gothic"/>
                 <a:ea typeface="Malgun Gothic"/>
               </a:rPr>
-              <a:t>- CAD를 더한 네 비교는 모두 악화가 더 많음(예: HyDE → HyDE+CAD 7/22)</a:t>
+              <a:t>- CAD를 더한 네 비교는 모두 악화가 더 많음(HyDE에 CAD 추가 시 개선 5 · 악화 18)</a:t>
             </a:r>
           </a:p>
         </p:txBody>
       </p:sp>
       <p:sp>
         <p:nvSpPr>
-          <p:cNvPr id="33" name="Rectangle 32"/>
+          <p:cNvPr id="32" name="Rectangle 31"/>
           <p:cNvSpPr/>
           <p:nvPr/>
         </p:nvSpPr>
         <p:spPr>
           <a:xfrm>
-            <a:off x="10980000" y="13323606"/>
+            <a:off x="10980000" y="13071606"/>
             <a:ext cx="9612000" cy="468000"/>
           </a:xfrm>
           <a:prstGeom prst="rect">
@@ -10958,13 +10677,13 @@
       </p:sp>
       <p:sp>
         <p:nvSpPr>
-          <p:cNvPr id="34" name="TextBox 33"/>
+          <p:cNvPr id="33" name="TextBox 32"/>
           <p:cNvSpPr txBox="1"/>
           <p:nvPr/>
         </p:nvSpPr>
         <p:spPr>
           <a:xfrm>
-            <a:off x="11124000" y="13348806"/>
+            <a:off x="11124000" y="13096806"/>
             <a:ext cx="9324000" cy="360000"/>
           </a:xfrm>
           <a:prstGeom prst="rect">
@@ -10998,14 +10717,14 @@
       </p:sp>
       <p:graphicFrame>
         <p:nvGraphicFramePr>
-          <p:cNvPr id="35" name="Table 34"/>
+          <p:cNvPr id="34" name="Table 33"/>
           <p:cNvGraphicFramePr>
             <a:graphicFrameLocks noGrp="1"/>
           </p:cNvGraphicFramePr>
           <p:nvPr/>
         </p:nvGraphicFramePr>
         <p:xfrm>
-          <a:off x="10980000" y="13935606"/>
+          <a:off x="10980000" y="13683606"/>
           <a:ext cx="9612000" cy="1826545"/>
         </p:xfrm>
         <a:graphic>
@@ -12112,13 +11831,13 @@
       </p:graphicFrame>
       <p:sp>
         <p:nvSpPr>
-          <p:cNvPr id="36" name="TextBox 35"/>
+          <p:cNvPr id="35" name="TextBox 34"/>
           <p:cNvSpPr txBox="1"/>
           <p:nvPr/>
         </p:nvSpPr>
         <p:spPr>
           <a:xfrm>
-            <a:off x="10980000" y="15870154"/>
+            <a:off x="10980000" y="15618154"/>
             <a:ext cx="9612000" cy="318536"/>
           </a:xfrm>
           <a:prstGeom prst="rect">
@@ -12152,13 +11871,13 @@
       </p:sp>
       <p:sp>
         <p:nvSpPr>
-          <p:cNvPr id="37" name="TextBox 36"/>
+          <p:cNvPr id="36" name="TextBox 35"/>
           <p:cNvSpPr txBox="1"/>
           <p:nvPr/>
         </p:nvSpPr>
         <p:spPr>
           <a:xfrm>
-            <a:off x="10980000" y="16278690"/>
+            <a:off x="10980000" y="16026690"/>
             <a:ext cx="9612000" cy="318536"/>
           </a:xfrm>
           <a:prstGeom prst="rect">
@@ -12192,13 +11911,13 @@
       </p:sp>
       <p:sp>
         <p:nvSpPr>
-          <p:cNvPr id="38" name="Rectangle 37"/>
+          <p:cNvPr id="37" name="Rectangle 36"/>
           <p:cNvSpPr/>
           <p:nvPr/>
         </p:nvSpPr>
         <p:spPr>
           <a:xfrm>
-            <a:off x="10980000" y="16831226"/>
+            <a:off x="10980000" y="16579226"/>
             <a:ext cx="9612000" cy="468000"/>
           </a:xfrm>
           <a:prstGeom prst="rect">
@@ -12236,13 +11955,13 @@
       </p:sp>
       <p:sp>
         <p:nvSpPr>
-          <p:cNvPr id="39" name="TextBox 38"/>
+          <p:cNvPr id="38" name="TextBox 37"/>
           <p:cNvSpPr txBox="1"/>
           <p:nvPr/>
         </p:nvSpPr>
         <p:spPr>
           <a:xfrm>
-            <a:off x="11124000" y="16856426"/>
+            <a:off x="11124000" y="16604426"/>
             <a:ext cx="9324000" cy="360000"/>
           </a:xfrm>
           <a:prstGeom prst="rect">
@@ -12276,14 +11995,14 @@
       </p:sp>
       <p:graphicFrame>
         <p:nvGraphicFramePr>
-          <p:cNvPr id="40" name="Table 39"/>
+          <p:cNvPr id="39" name="Table 38"/>
           <p:cNvGraphicFramePr>
             <a:graphicFrameLocks noGrp="1"/>
           </p:cNvGraphicFramePr>
           <p:nvPr/>
         </p:nvGraphicFramePr>
         <p:xfrm>
-          <a:off x="10980000" y="17443226"/>
+          <a:off x="10980000" y="17191226"/>
           <a:ext cx="9611998" cy="1461236"/>
         </p:xfrm>
         <a:graphic>
@@ -13173,13 +12892,13 @@
       </p:graphicFrame>
       <p:sp>
         <p:nvSpPr>
-          <p:cNvPr id="41" name="TextBox 40"/>
+          <p:cNvPr id="40" name="TextBox 39"/>
           <p:cNvSpPr txBox="1"/>
           <p:nvPr/>
         </p:nvSpPr>
         <p:spPr>
           <a:xfrm>
-            <a:off x="10980000" y="19012465"/>
+            <a:off x="10980000" y="18760465"/>
             <a:ext cx="9612000" cy="318536"/>
           </a:xfrm>
           <a:prstGeom prst="rect">
@@ -13213,13 +12932,13 @@
       </p:sp>
       <p:sp>
         <p:nvSpPr>
-          <p:cNvPr id="42" name="Rectangle 41"/>
+          <p:cNvPr id="41" name="Rectangle 40"/>
           <p:cNvSpPr/>
           <p:nvPr/>
         </p:nvSpPr>
         <p:spPr>
           <a:xfrm>
-            <a:off x="792000" y="19565001"/>
+            <a:off x="792000" y="19312958"/>
             <a:ext cx="19800000" cy="468000"/>
           </a:xfrm>
           <a:prstGeom prst="rect">
@@ -13257,13 +12976,13 @@
       </p:sp>
       <p:sp>
         <p:nvSpPr>
-          <p:cNvPr id="43" name="TextBox 42"/>
+          <p:cNvPr id="42" name="TextBox 41"/>
           <p:cNvSpPr txBox="1"/>
           <p:nvPr/>
         </p:nvSpPr>
         <p:spPr>
           <a:xfrm>
-            <a:off x="936000" y="19590201"/>
+            <a:off x="936000" y="19338158"/>
             <a:ext cx="19512000" cy="360000"/>
           </a:xfrm>
           <a:prstGeom prst="rect">
@@ -13290,14 +13009,14 @@
                 <a:latin typeface="Malgun Gothic"/>
                 <a:ea typeface="Malgun Gothic"/>
               </a:rPr>
-              <a:t>08 질문 60개의 원점수 평행좌표: 미적용과 HyDE</a:t>
+              <a:t>08 HyDE 적용 후 질문 유형별 개별 점수</a:t>
             </a:r>
           </a:p>
         </p:txBody>
       </p:sp>
       <p:pic>
         <p:nvPicPr>
-          <p:cNvPr id="44" name="Picture 43" descr="poster_parallel.png"/>
+          <p:cNvPr id="43" name="Picture 42" descr="poster_parallel.png"/>
           <p:cNvPicPr>
             <a:picLocks noChangeAspect="1"/>
           </p:cNvPicPr>
@@ -13311,8 +13030,8 @@
         </p:blipFill>
         <p:spPr>
           <a:xfrm>
-            <a:off x="792000" y="20177001"/>
-            <a:ext cx="19800000" cy="6022120"/>
+            <a:off x="792000" y="19924958"/>
+            <a:ext cx="19800000" cy="6660829"/>
           </a:xfrm>
           <a:prstGeom prst="rect">
             <a:avLst/>
@@ -13321,13 +13040,13 @@
       </p:pic>
       <p:sp>
         <p:nvSpPr>
-          <p:cNvPr id="45" name="TextBox 44"/>
+          <p:cNvPr id="44" name="TextBox 43"/>
           <p:cNvSpPr txBox="1"/>
           <p:nvPr/>
         </p:nvSpPr>
         <p:spPr>
           <a:xfrm>
-            <a:off x="792000" y="26271121"/>
+            <a:off x="792000" y="26621787"/>
             <a:ext cx="19800000" cy="318536"/>
           </a:xfrm>
           <a:prstGeom prst="rect">
@@ -13354,20 +13073,20 @@
                 <a:latin typeface="Malgun Gothic"/>
                 <a:ea typeface="Malgun Gothic"/>
               </a:rPr>
-              <a:t>- 선 하나가 질문 하나 · 미적용에서 답변 관련성 0에 모인 방법·절차 질문이 HyDE 적용 후 위로 이동</a:t>
+              <a:t>- 선 하나는 질문 하나이며, 0점과 결측값에서는 선을 끊음. 처리 시간은 위쪽일수록 짧음. 굵은 선은 BIC 질문</a:t>
             </a:r>
           </a:p>
         </p:txBody>
       </p:sp>
       <p:sp>
         <p:nvSpPr>
-          <p:cNvPr id="46" name="Rectangle 45"/>
+          <p:cNvPr id="45" name="Rectangle 44"/>
           <p:cNvSpPr/>
           <p:nvPr/>
         </p:nvSpPr>
         <p:spPr>
           <a:xfrm>
-            <a:off x="792000" y="26787657"/>
+            <a:off x="792000" y="27102323"/>
             <a:ext cx="9612000" cy="468000"/>
           </a:xfrm>
           <a:prstGeom prst="rect">
@@ -13405,13 +13124,13 @@
       </p:sp>
       <p:sp>
         <p:nvSpPr>
-          <p:cNvPr id="47" name="TextBox 46"/>
+          <p:cNvPr id="46" name="TextBox 45"/>
           <p:cNvSpPr txBox="1"/>
           <p:nvPr/>
         </p:nvSpPr>
         <p:spPr>
           <a:xfrm>
-            <a:off x="936000" y="26812857"/>
+            <a:off x="936000" y="27127523"/>
             <a:ext cx="9324000" cy="360000"/>
           </a:xfrm>
           <a:prstGeom prst="rect">
@@ -13445,13 +13164,13 @@
       </p:sp>
       <p:sp>
         <p:nvSpPr>
-          <p:cNvPr id="48" name="TextBox 47"/>
+          <p:cNvPr id="47" name="TextBox 46"/>
           <p:cNvSpPr txBox="1"/>
           <p:nvPr/>
         </p:nvSpPr>
         <p:spPr>
           <a:xfrm>
-            <a:off x="792000" y="27399657"/>
+            <a:off x="792000" y="27714323"/>
             <a:ext cx="9612000" cy="335301"/>
           </a:xfrm>
           <a:prstGeom prst="rect">
@@ -13478,20 +13197,20 @@
                 <a:latin typeface="Malgun Gothic"/>
                 <a:ea typeface="Malgun Gothic"/>
               </a:rPr>
-              <a:t>- 방법·절차 질문: HyDE 적용</a:t>
+              <a:t>- 방법·절차 질문에는 HyDE 적용</a:t>
             </a:r>
           </a:p>
         </p:txBody>
       </p:sp>
       <p:sp>
         <p:nvSpPr>
-          <p:cNvPr id="49" name="TextBox 48"/>
+          <p:cNvPr id="48" name="TextBox 47"/>
           <p:cNvSpPr txBox="1"/>
           <p:nvPr/>
         </p:nvSpPr>
         <p:spPr>
           <a:xfrm>
-            <a:off x="792000" y="27824958"/>
+            <a:off x="792000" y="28139624"/>
             <a:ext cx="9612000" cy="335301"/>
           </a:xfrm>
           <a:prstGeom prst="rect">
@@ -13518,20 +13237,20 @@
                 <a:latin typeface="Malgun Gothic"/>
                 <a:ea typeface="Malgun Gothic"/>
               </a:rPr>
-              <a:t>- 한국어 답변이 필요할 때: SCD 추가</a:t>
+              <a:t>- 한국어 답변이 필요하면 SCD 추가</a:t>
             </a:r>
           </a:p>
         </p:txBody>
       </p:sp>
       <p:sp>
         <p:nvSpPr>
-          <p:cNvPr id="50" name="TextBox 49"/>
+          <p:cNvPr id="49" name="TextBox 48"/>
           <p:cNvSpPr txBox="1"/>
           <p:nvPr/>
         </p:nvSpPr>
         <p:spPr>
           <a:xfrm>
-            <a:off x="792000" y="28250259"/>
+            <a:off x="792000" y="28564926"/>
             <a:ext cx="9612000" cy="335301"/>
           </a:xfrm>
           <a:prstGeom prst="rect">
@@ -13558,20 +13277,20 @@
                 <a:latin typeface="Malgun Gothic"/>
                 <a:ea typeface="Malgun Gothic"/>
               </a:rPr>
-              <a:t>- 수치 질문: 정답 수치가 담긴 구간이 입력됐는지 확인</a:t>
+              <a:t>- 수치 질문은 정답 수치가 담긴 구간의 입력 여부를 먼저 확인</a:t>
             </a:r>
           </a:p>
         </p:txBody>
       </p:sp>
       <p:sp>
         <p:nvSpPr>
-          <p:cNvPr id="51" name="TextBox 50"/>
+          <p:cNvPr id="50" name="TextBox 49"/>
           <p:cNvSpPr txBox="1"/>
           <p:nvPr/>
         </p:nvSpPr>
         <p:spPr>
           <a:xfrm>
-            <a:off x="792000" y="28675560"/>
+            <a:off x="792000" y="28990227"/>
             <a:ext cx="9612000" cy="335301"/>
           </a:xfrm>
           <a:prstGeom prst="rect">
@@ -13598,20 +13317,20 @@
                 <a:latin typeface="Malgun Gothic"/>
                 <a:ea typeface="Malgun Gothic"/>
               </a:rPr>
-              <a:t>- CAD: 시간 3.1배, 관련성 변화 −0.01 → 지식 충돌 질문에서 별도 검토</a:t>
+              <a:t>- CAD는 시간 3.1배에 관련성 -0.02, 지식 충돌 질문에서 별도 검토</a:t>
             </a:r>
           </a:p>
         </p:txBody>
       </p:sp>
       <p:sp>
         <p:nvSpPr>
-          <p:cNvPr id="52" name="Rectangle 51"/>
+          <p:cNvPr id="51" name="Rectangle 50"/>
           <p:cNvSpPr/>
           <p:nvPr/>
         </p:nvSpPr>
         <p:spPr>
           <a:xfrm>
-            <a:off x="10980000" y="26787657"/>
+            <a:off x="10980000" y="27102323"/>
             <a:ext cx="9612000" cy="468000"/>
           </a:xfrm>
           <a:prstGeom prst="rect">
@@ -13649,13 +13368,13 @@
       </p:sp>
       <p:sp>
         <p:nvSpPr>
-          <p:cNvPr id="53" name="TextBox 52"/>
+          <p:cNvPr id="52" name="TextBox 51"/>
           <p:cNvSpPr txBox="1"/>
           <p:nvPr/>
         </p:nvSpPr>
         <p:spPr>
           <a:xfrm>
-            <a:off x="11124000" y="26812857"/>
+            <a:off x="11124000" y="27127523"/>
             <a:ext cx="9324000" cy="360000"/>
           </a:xfrm>
           <a:prstGeom prst="rect">
@@ -13689,13 +13408,13 @@
       </p:sp>
       <p:sp>
         <p:nvSpPr>
-          <p:cNvPr id="54" name="TextBox 53"/>
+          <p:cNvPr id="53" name="TextBox 52"/>
           <p:cNvSpPr txBox="1"/>
           <p:nvPr/>
         </p:nvSpPr>
         <p:spPr>
           <a:xfrm>
-            <a:off x="10980000" y="27399657"/>
+            <a:off x="10980000" y="27714323"/>
             <a:ext cx="9612000" cy="335301"/>
           </a:xfrm>
           <a:prstGeom prst="rect">
@@ -13722,20 +13441,20 @@
                 <a:latin typeface="Malgun Gothic"/>
                 <a:ea typeface="Malgun Gothic"/>
               </a:rPr>
-              <a:t>- BIC 질문: HyDE가 근거 구간을 찾아 관련성 0.00→0.89</a:t>
+              <a:t>- BIC 질문은 HyDE가 근거 구간을 찾아 관련성 0.00→0.89</a:t>
             </a:r>
           </a:p>
         </p:txBody>
       </p:sp>
       <p:sp>
         <p:nvSpPr>
-          <p:cNvPr id="55" name="TextBox 54"/>
+          <p:cNvPr id="54" name="TextBox 53"/>
           <p:cNvSpPr txBox="1"/>
           <p:nvPr/>
         </p:nvSpPr>
         <p:spPr>
           <a:xfrm>
-            <a:off x="10980000" y="27824958"/>
+            <a:off x="10980000" y="28139624"/>
             <a:ext cx="9612000" cy="335301"/>
           </a:xfrm>
           <a:prstGeom prst="rect">
@@ -13762,20 +13481,20 @@
                 <a:latin typeface="Malgun Gothic"/>
                 <a:ea typeface="Malgun Gothic"/>
               </a:rPr>
-              <a:t>- QuALITY 질문: 73.68이 빠져 관련성 0.87→0.00</a:t>
+              <a:t>- QuALITY 질문은 73.68이 빠져 관련성 0.87→0.00</a:t>
             </a:r>
           </a:p>
         </p:txBody>
       </p:sp>
       <p:sp>
         <p:nvSpPr>
-          <p:cNvPr id="56" name="TextBox 55"/>
+          <p:cNvPr id="55" name="TextBox 54"/>
           <p:cNvSpPr txBox="1"/>
           <p:nvPr/>
         </p:nvSpPr>
         <p:spPr>
           <a:xfrm>
-            <a:off x="10980000" y="28250259"/>
+            <a:off x="10980000" y="28564926"/>
             <a:ext cx="9612000" cy="335301"/>
           </a:xfrm>
           <a:prstGeom prst="rect">
@@ -13802,20 +13521,20 @@
                 <a:latin typeface="Malgun Gothic"/>
                 <a:ea typeface="Malgun Gothic"/>
               </a:rPr>
-              <a:t>- XSUM 질문: 다른 행 수치를 옮겼는데 충실도 0.53→0.87</a:t>
+              <a:t>- XSUM 질문은 다른 행 수치를 옮겼는데 충실도 0.53→0.87</a:t>
             </a:r>
           </a:p>
         </p:txBody>
       </p:sp>
       <p:sp>
         <p:nvSpPr>
-          <p:cNvPr id="57" name="TextBox 56"/>
+          <p:cNvPr id="56" name="TextBox 55"/>
           <p:cNvSpPr txBox="1"/>
           <p:nvPr/>
         </p:nvSpPr>
         <p:spPr>
           <a:xfrm>
-            <a:off x="792000" y="29208861"/>
+            <a:off x="792000" y="29523528"/>
             <a:ext cx="19800000" cy="504000"/>
           </a:xfrm>
           <a:prstGeom prst="rect">

</xml_diff>

<commit_message>
Add the technique-count trade-off to the conclusion
State when one technique is enough and when all three are worth the
cost: HyDE alone for relevancy and concept questions, HyDE+CAD for
numeric faithfulness, and HyDE+CAD+SCD when Korean answers must keep
every quality metric (the only condition with all four metrics above
baseline on method questions; smallest quality drop among SCD
conditions overall). Updated 5.4, 5.5, 5.8, chapter 6 and the poster
conclusion; thesis v15 re-exported from Hancom at 47 pages.

Co-Authored-By: Claude Opus 5.5 <noreply@anthropic.com>
</commit_message>
<xml_diff>
--- a/FINALDOCS/POSTER/FINAL/M_RAG_A1_FINAL_EDITABLE.pptx
+++ b/FINALDOCS/POSTER/FINAL/M_RAG_A1_FINAL_EDITABLE.pptx
@@ -13550,7 +13550,7 @@
                 <a:latin typeface="Malgun Gothic"/>
                 <a:ea typeface="Malgun Gothic"/>
               </a:rPr>
-              <a:t>- 방법 질문에는 HyDE, 한국어 답변이 필요하면 HyDE+SCD</a:t>
+              <a:t>- 한 지표가 중요하면 기법 하나(관련성, 개념과 결과 질문은 HyDE)</a:t>
             </a:r>
           </a:p>
         </p:txBody>
@@ -13590,7 +13590,7 @@
                 <a:latin typeface="Malgun Gothic"/>
                 <a:ea typeface="Malgun Gothic"/>
               </a:rPr>
-              <a:t>- 수치 질문은 정답 수치가 담긴 구간의 검색을 먼저 확인</a:t>
+              <a:t>- 수치 질문은 정답 구간의 검색을 확인하고 충실도는 HyDE+CAD</a:t>
             </a:r>
           </a:p>
         </p:txBody>
@@ -13630,7 +13630,7 @@
                 <a:latin typeface="Malgun Gothic"/>
                 <a:ea typeface="Malgun Gothic"/>
               </a:rPr>
-              <a:t>- 개념과 결과 질문에는 미적용이나 HyDE</a:t>
+              <a:t>- 고루 지키려면 세 기법, 방법 질문에서 네 품질 지표가 모두 상승</a:t>
             </a:r>
           </a:p>
         </p:txBody>
@@ -13670,7 +13670,7 @@
                 <a:latin typeface="Malgun Gothic"/>
                 <a:ea typeface="Malgun Gothic"/>
               </a:rPr>
-              <a:t>- 조합의 일관된 이득은 한국어 비율이므로 유형에 맞는 기법 하나에 SCD 추가</a:t>
+              <a:t>- 세 기법은 최고값 없이 한국어 비율 0.73, 처리 시간은 약 세 배</a:t>
             </a:r>
           </a:p>
         </p:txBody>

</xml_diff>

<commit_message>
Restore the submitter line on the poster and make references legible
Add the department, student ID, name and advisor line under the poster
title as placeholders in the public master; a local personal_fields.json
passed with --personal-fields fills it in an output kept outside the
repository. Set the references in dark 17 pt over three lines under 08,
and give the 2 x 2 parallel chart room so its legend no longer touches
the panel titles.

Co-Authored-By: Claude Opus 5.5 <noreply@anthropic.com>
</commit_message>
<xml_diff>
--- a/FINALDOCS/POSTER/FINAL/M_RAG_A1_FINAL_EDITABLE.pptx
+++ b/FINALDOCS/POSTER/FINAL/M_RAG_A1_FINAL_EDITABLE.pptx
@@ -3140,7 +3140,7 @@
         </p:nvSpPr>
         <p:spPr>
           <a:xfrm>
-            <a:off x="792000" y="468000"/>
+            <a:off x="792000" y="324000"/>
             <a:ext cx="19800000" cy="1800000"/>
           </a:xfrm>
           <a:prstGeom prst="rect">
@@ -3197,7 +3197,7 @@
         </p:nvSpPr>
         <p:spPr>
           <a:xfrm>
-            <a:off x="792000" y="2520000"/>
+            <a:off x="792000" y="2340000"/>
             <a:ext cx="19800000" cy="432000"/>
           </a:xfrm>
           <a:prstGeom prst="rect">
@@ -3231,7 +3231,47 @@
       </p:sp>
       <p:sp>
         <p:nvSpPr>
-          <p:cNvPr id="5" name="Rectangle 4"/>
+          <p:cNvPr id="5" name="TextBox 4"/>
+          <p:cNvSpPr txBox="1"/>
+          <p:nvPr/>
+        </p:nvSpPr>
+        <p:spPr>
+          <a:xfrm>
+            <a:off x="792000" y="2862000"/>
+            <a:ext cx="19800000" cy="288000"/>
+          </a:xfrm>
+          <a:prstGeom prst="rect">
+            <a:avLst/>
+          </a:prstGeom>
+          <a:noFill/>
+        </p:spPr>
+        <p:txBody>
+          <a:bodyPr wrap="square" lIns="0" rIns="0" tIns="0" bIns="0">
+            <a:spAutoFit/>
+          </a:bodyPr>
+          <a:lstStyle/>
+          <a:p>
+            <a:pPr algn="ctr">
+              <a:lnSpc>
+                <a:spcPct val="115000"/>
+              </a:lnSpc>
+            </a:pPr>
+            <a:r>
+              <a:rPr sz="2000" b="0">
+                <a:solidFill>
+                  <a:srgbClr val="FFFFFF"/>
+                </a:solidFill>
+                <a:latin typeface="Malgun Gothic"/>
+                <a:ea typeface="Malgun Gothic"/>
+              </a:rPr>
+              <a:t>[학과] [학번] [이름], 지도교수 [지도교수]</a:t>
+            </a:r>
+          </a:p>
+        </p:txBody>
+      </p:sp>
+      <p:sp>
+        <p:nvSpPr>
+          <p:cNvPr id="6" name="Rectangle 5"/>
           <p:cNvSpPr/>
           <p:nvPr/>
         </p:nvSpPr>
@@ -3275,7 +3315,7 @@
       </p:sp>
       <p:sp>
         <p:nvSpPr>
-          <p:cNvPr id="6" name="TextBox 5"/>
+          <p:cNvPr id="7" name="TextBox 6"/>
           <p:cNvSpPr txBox="1"/>
           <p:nvPr/>
         </p:nvSpPr>
@@ -3315,7 +3355,7 @@
       </p:sp>
       <p:sp>
         <p:nvSpPr>
-          <p:cNvPr id="7" name="TextBox 6"/>
+          <p:cNvPr id="8" name="TextBox 7"/>
           <p:cNvSpPr txBox="1"/>
           <p:nvPr/>
         </p:nvSpPr>
@@ -3355,7 +3395,7 @@
       </p:sp>
       <p:sp>
         <p:nvSpPr>
-          <p:cNvPr id="8" name="TextBox 7"/>
+          <p:cNvPr id="9" name="TextBox 8"/>
           <p:cNvSpPr txBox="1"/>
           <p:nvPr/>
         </p:nvSpPr>
@@ -3395,7 +3435,7 @@
       </p:sp>
       <p:sp>
         <p:nvSpPr>
-          <p:cNvPr id="9" name="TextBox 8"/>
+          <p:cNvPr id="10" name="TextBox 9"/>
           <p:cNvSpPr txBox="1"/>
           <p:nvPr/>
         </p:nvSpPr>
@@ -3435,7 +3475,7 @@
       </p:sp>
       <p:sp>
         <p:nvSpPr>
-          <p:cNvPr id="10" name="Rectangle 9"/>
+          <p:cNvPr id="11" name="Rectangle 10"/>
           <p:cNvSpPr/>
           <p:nvPr/>
         </p:nvSpPr>
@@ -3479,7 +3519,7 @@
       </p:sp>
       <p:sp>
         <p:nvSpPr>
-          <p:cNvPr id="11" name="TextBox 10"/>
+          <p:cNvPr id="12" name="TextBox 11"/>
           <p:cNvSpPr txBox="1"/>
           <p:nvPr/>
         </p:nvSpPr>
@@ -3519,7 +3559,7 @@
       </p:sp>
       <p:pic>
         <p:nvPicPr>
-          <p:cNvPr id="12" name="Picture 11" descr="poster_pipeline.png"/>
+          <p:cNvPr id="13" name="Picture 12" descr="poster_pipeline.png"/>
           <p:cNvPicPr>
             <a:picLocks noChangeAspect="1"/>
           </p:cNvPicPr>
@@ -3543,7 +3583,7 @@
       </p:pic>
       <p:graphicFrame>
         <p:nvGraphicFramePr>
-          <p:cNvPr id="13" name="Table 12"/>
+          <p:cNvPr id="14" name="Table 13"/>
           <p:cNvGraphicFramePr>
             <a:graphicFrameLocks noGrp="1"/>
           </p:cNvGraphicFramePr>
@@ -5525,7 +5565,7 @@
       </p:graphicFrame>
       <p:sp>
         <p:nvSpPr>
-          <p:cNvPr id="14" name="TextBox 13"/>
+          <p:cNvPr id="15" name="TextBox 14"/>
           <p:cNvSpPr txBox="1"/>
           <p:nvPr/>
         </p:nvSpPr>
@@ -5567,7 +5607,7 @@
       </p:sp>
       <p:sp>
         <p:nvSpPr>
-          <p:cNvPr id="15" name="Rectangle 14"/>
+          <p:cNvPr id="16" name="Rectangle 15"/>
           <p:cNvSpPr/>
           <p:nvPr/>
         </p:nvSpPr>
@@ -5611,7 +5651,7 @@
       </p:sp>
       <p:sp>
         <p:nvSpPr>
-          <p:cNvPr id="16" name="TextBox 15"/>
+          <p:cNvPr id="17" name="TextBox 16"/>
           <p:cNvSpPr txBox="1"/>
           <p:nvPr/>
         </p:nvSpPr>
@@ -5651,7 +5691,7 @@
       </p:sp>
       <p:sp>
         <p:nvSpPr>
-          <p:cNvPr id="17" name="TextBox 16"/>
+          <p:cNvPr id="18" name="TextBox 17"/>
           <p:cNvSpPr txBox="1"/>
           <p:nvPr/>
         </p:nvSpPr>
@@ -5691,7 +5731,7 @@
       </p:sp>
       <p:sp>
         <p:nvSpPr>
-          <p:cNvPr id="18" name="TextBox 17"/>
+          <p:cNvPr id="19" name="TextBox 18"/>
           <p:cNvSpPr txBox="1"/>
           <p:nvPr/>
         </p:nvSpPr>
@@ -5731,7 +5771,7 @@
       </p:sp>
       <p:graphicFrame>
         <p:nvGraphicFramePr>
-          <p:cNvPr id="19" name="Table 18"/>
+          <p:cNvPr id="20" name="Table 19"/>
           <p:cNvGraphicFramePr>
             <a:graphicFrameLocks noGrp="1"/>
           </p:cNvGraphicFramePr>
@@ -6687,7 +6727,7 @@
       </p:graphicFrame>
       <p:sp>
         <p:nvSpPr>
-          <p:cNvPr id="20" name="TextBox 19"/>
+          <p:cNvPr id="21" name="TextBox 20"/>
           <p:cNvSpPr txBox="1"/>
           <p:nvPr/>
         </p:nvSpPr>
@@ -6727,7 +6767,7 @@
       </p:sp>
       <p:sp>
         <p:nvSpPr>
-          <p:cNvPr id="21" name="Rectangle 20"/>
+          <p:cNvPr id="22" name="Rectangle 21"/>
           <p:cNvSpPr/>
           <p:nvPr/>
         </p:nvSpPr>
@@ -6771,7 +6811,7 @@
       </p:sp>
       <p:sp>
         <p:nvSpPr>
-          <p:cNvPr id="22" name="TextBox 21"/>
+          <p:cNvPr id="23" name="TextBox 22"/>
           <p:cNvSpPr txBox="1"/>
           <p:nvPr/>
         </p:nvSpPr>
@@ -6811,7 +6851,7 @@
       </p:sp>
       <p:graphicFrame>
         <p:nvGraphicFramePr>
-          <p:cNvPr id="23" name="Table 22"/>
+          <p:cNvPr id="24" name="Table 23"/>
           <p:cNvGraphicFramePr>
             <a:graphicFrameLocks noGrp="1"/>
           </p:cNvGraphicFramePr>
@@ -7535,7 +7575,7 @@
       </p:graphicFrame>
       <p:sp>
         <p:nvSpPr>
-          <p:cNvPr id="24" name="TextBox 23"/>
+          <p:cNvPr id="25" name="TextBox 24"/>
           <p:cNvSpPr txBox="1"/>
           <p:nvPr/>
         </p:nvSpPr>
@@ -7575,7 +7615,7 @@
       </p:sp>
       <p:sp>
         <p:nvSpPr>
-          <p:cNvPr id="25" name="Rectangle 24"/>
+          <p:cNvPr id="26" name="Rectangle 25"/>
           <p:cNvSpPr/>
           <p:nvPr/>
         </p:nvSpPr>
@@ -7619,7 +7659,7 @@
       </p:sp>
       <p:sp>
         <p:nvSpPr>
-          <p:cNvPr id="26" name="TextBox 25"/>
+          <p:cNvPr id="27" name="TextBox 26"/>
           <p:cNvSpPr txBox="1"/>
           <p:nvPr/>
         </p:nvSpPr>
@@ -7659,7 +7699,7 @@
       </p:sp>
       <p:graphicFrame>
         <p:nvGraphicFramePr>
-          <p:cNvPr id="27" name="Table 26"/>
+          <p:cNvPr id="28" name="Table 27"/>
           <p:cNvGraphicFramePr>
             <a:graphicFrameLocks noGrp="1"/>
           </p:cNvGraphicFramePr>
@@ -10089,7 +10129,7 @@
       </p:graphicFrame>
       <p:sp>
         <p:nvSpPr>
-          <p:cNvPr id="28" name="TextBox 27"/>
+          <p:cNvPr id="29" name="TextBox 28"/>
           <p:cNvSpPr txBox="1"/>
           <p:nvPr/>
         </p:nvSpPr>
@@ -10129,7 +10169,7 @@
       </p:sp>
       <p:sp>
         <p:nvSpPr>
-          <p:cNvPr id="29" name="Rectangle 28"/>
+          <p:cNvPr id="30" name="Rectangle 29"/>
           <p:cNvSpPr/>
           <p:nvPr/>
         </p:nvSpPr>
@@ -10173,7 +10213,7 @@
       </p:sp>
       <p:sp>
         <p:nvSpPr>
-          <p:cNvPr id="30" name="TextBox 29"/>
+          <p:cNvPr id="31" name="TextBox 30"/>
           <p:cNvSpPr txBox="1"/>
           <p:nvPr/>
         </p:nvSpPr>
@@ -10213,7 +10253,7 @@
       </p:sp>
       <p:graphicFrame>
         <p:nvGraphicFramePr>
-          <p:cNvPr id="31" name="Table 30"/>
+          <p:cNvPr id="32" name="Table 31"/>
           <p:cNvGraphicFramePr>
             <a:graphicFrameLocks noGrp="1"/>
           </p:cNvGraphicFramePr>
@@ -17213,7 +17253,7 @@
       </p:graphicFrame>
       <p:sp>
         <p:nvSpPr>
-          <p:cNvPr id="32" name="TextBox 31"/>
+          <p:cNvPr id="33" name="TextBox 32"/>
           <p:cNvSpPr txBox="1"/>
           <p:nvPr/>
         </p:nvSpPr>
@@ -17253,7 +17293,7 @@
       </p:sp>
       <p:sp>
         <p:nvSpPr>
-          <p:cNvPr id="33" name="Rectangle 32"/>
+          <p:cNvPr id="34" name="Rectangle 33"/>
           <p:cNvSpPr/>
           <p:nvPr/>
         </p:nvSpPr>
@@ -17297,7 +17337,7 @@
       </p:sp>
       <p:sp>
         <p:nvSpPr>
-          <p:cNvPr id="34" name="TextBox 33"/>
+          <p:cNvPr id="35" name="TextBox 34"/>
           <p:cNvSpPr txBox="1"/>
           <p:nvPr/>
         </p:nvSpPr>
@@ -17337,7 +17377,7 @@
       </p:sp>
       <p:pic>
         <p:nvPicPr>
-          <p:cNvPr id="35" name="Picture 34" descr="poster_parallel.png"/>
+          <p:cNvPr id="36" name="Picture 35" descr="poster_parallel.png"/>
           <p:cNvPicPr>
             <a:picLocks noChangeAspect="1"/>
           </p:cNvPicPr>
@@ -17352,7 +17392,7 @@
         <p:spPr>
           <a:xfrm>
             <a:off x="792000" y="21531351"/>
-            <a:ext cx="19800000" cy="5200922"/>
+            <a:ext cx="19800000" cy="4744700"/>
           </a:xfrm>
           <a:prstGeom prst="rect">
             <a:avLst/>
@@ -17361,13 +17401,13 @@
       </p:pic>
       <p:sp>
         <p:nvSpPr>
-          <p:cNvPr id="36" name="TextBox 35"/>
+          <p:cNvPr id="37" name="TextBox 36"/>
           <p:cNvSpPr txBox="1"/>
           <p:nvPr/>
         </p:nvSpPr>
         <p:spPr>
           <a:xfrm>
-            <a:off x="792000" y="26768273"/>
+            <a:off x="792000" y="26312051"/>
             <a:ext cx="19800000" cy="318536"/>
           </a:xfrm>
           <a:prstGeom prst="rect">
@@ -17401,13 +17441,13 @@
       </p:sp>
       <p:sp>
         <p:nvSpPr>
-          <p:cNvPr id="37" name="Rectangle 36"/>
+          <p:cNvPr id="38" name="Rectangle 37"/>
           <p:cNvSpPr/>
           <p:nvPr/>
         </p:nvSpPr>
         <p:spPr>
           <a:xfrm>
-            <a:off x="792000" y="27248809"/>
+            <a:off x="792000" y="26792587"/>
             <a:ext cx="9612000" cy="468000"/>
           </a:xfrm>
           <a:prstGeom prst="rect">
@@ -17445,13 +17485,13 @@
       </p:sp>
       <p:sp>
         <p:nvSpPr>
-          <p:cNvPr id="38" name="TextBox 37"/>
+          <p:cNvPr id="39" name="TextBox 38"/>
           <p:cNvSpPr txBox="1"/>
           <p:nvPr/>
         </p:nvSpPr>
         <p:spPr>
           <a:xfrm>
-            <a:off x="936000" y="27274009"/>
+            <a:off x="936000" y="26817787"/>
             <a:ext cx="9324000" cy="360000"/>
           </a:xfrm>
           <a:prstGeom prst="rect">
@@ -17485,13 +17525,13 @@
       </p:sp>
       <p:sp>
         <p:nvSpPr>
-          <p:cNvPr id="39" name="TextBox 38"/>
+          <p:cNvPr id="40" name="TextBox 39"/>
           <p:cNvSpPr txBox="1"/>
           <p:nvPr/>
         </p:nvSpPr>
         <p:spPr>
           <a:xfrm>
-            <a:off x="792000" y="27860809"/>
+            <a:off x="792000" y="27404587"/>
             <a:ext cx="9612000" cy="335301"/>
           </a:xfrm>
           <a:prstGeom prst="rect">
@@ -17525,13 +17565,13 @@
       </p:sp>
       <p:sp>
         <p:nvSpPr>
-          <p:cNvPr id="40" name="TextBox 39"/>
+          <p:cNvPr id="41" name="TextBox 40"/>
           <p:cNvSpPr txBox="1"/>
           <p:nvPr/>
         </p:nvSpPr>
         <p:spPr>
           <a:xfrm>
-            <a:off x="792000" y="28286110"/>
+            <a:off x="792000" y="27829888"/>
             <a:ext cx="9612000" cy="335301"/>
           </a:xfrm>
           <a:prstGeom prst="rect">
@@ -17565,13 +17605,13 @@
       </p:sp>
       <p:sp>
         <p:nvSpPr>
-          <p:cNvPr id="41" name="TextBox 40"/>
+          <p:cNvPr id="42" name="TextBox 41"/>
           <p:cNvSpPr txBox="1"/>
           <p:nvPr/>
         </p:nvSpPr>
         <p:spPr>
           <a:xfrm>
-            <a:off x="792000" y="28711412"/>
+            <a:off x="792000" y="28255190"/>
             <a:ext cx="9612000" cy="335301"/>
           </a:xfrm>
           <a:prstGeom prst="rect">
@@ -17605,13 +17645,13 @@
       </p:sp>
       <p:sp>
         <p:nvSpPr>
-          <p:cNvPr id="42" name="TextBox 41"/>
+          <p:cNvPr id="43" name="TextBox 42"/>
           <p:cNvSpPr txBox="1"/>
           <p:nvPr/>
         </p:nvSpPr>
         <p:spPr>
           <a:xfrm>
-            <a:off x="792000" y="29136713"/>
+            <a:off x="792000" y="28680491"/>
             <a:ext cx="9612000" cy="335301"/>
           </a:xfrm>
           <a:prstGeom prst="rect">
@@ -17645,13 +17685,13 @@
       </p:sp>
       <p:sp>
         <p:nvSpPr>
-          <p:cNvPr id="43" name="Rectangle 42"/>
+          <p:cNvPr id="44" name="Rectangle 43"/>
           <p:cNvSpPr/>
           <p:nvPr/>
         </p:nvSpPr>
         <p:spPr>
           <a:xfrm>
-            <a:off x="10980000" y="27248809"/>
+            <a:off x="10980000" y="26792587"/>
             <a:ext cx="9612000" cy="468000"/>
           </a:xfrm>
           <a:prstGeom prst="rect">
@@ -17689,13 +17729,13 @@
       </p:sp>
       <p:sp>
         <p:nvSpPr>
-          <p:cNvPr id="44" name="TextBox 43"/>
+          <p:cNvPr id="45" name="TextBox 44"/>
           <p:cNvSpPr txBox="1"/>
           <p:nvPr/>
         </p:nvSpPr>
         <p:spPr>
           <a:xfrm>
-            <a:off x="11124000" y="27274009"/>
+            <a:off x="11124000" y="26817787"/>
             <a:ext cx="9324000" cy="360000"/>
           </a:xfrm>
           <a:prstGeom prst="rect">
@@ -17729,13 +17769,13 @@
       </p:sp>
       <p:sp>
         <p:nvSpPr>
-          <p:cNvPr id="45" name="TextBox 44"/>
+          <p:cNvPr id="46" name="TextBox 45"/>
           <p:cNvSpPr txBox="1"/>
           <p:nvPr/>
         </p:nvSpPr>
         <p:spPr>
           <a:xfrm>
-            <a:off x="10980000" y="27860809"/>
+            <a:off x="10980000" y="27404587"/>
             <a:ext cx="9612000" cy="335301"/>
           </a:xfrm>
           <a:prstGeom prst="rect">
@@ -17769,13 +17809,13 @@
       </p:sp>
       <p:sp>
         <p:nvSpPr>
-          <p:cNvPr id="46" name="TextBox 45"/>
+          <p:cNvPr id="47" name="TextBox 46"/>
           <p:cNvSpPr txBox="1"/>
           <p:nvPr/>
         </p:nvSpPr>
         <p:spPr>
           <a:xfrm>
-            <a:off x="10980000" y="28286110"/>
+            <a:off x="10980000" y="27829888"/>
             <a:ext cx="9612000" cy="335301"/>
           </a:xfrm>
           <a:prstGeom prst="rect">
@@ -17809,13 +17849,13 @@
       </p:sp>
       <p:sp>
         <p:nvSpPr>
-          <p:cNvPr id="47" name="TextBox 46"/>
+          <p:cNvPr id="48" name="TextBox 47"/>
           <p:cNvSpPr txBox="1"/>
           <p:nvPr/>
         </p:nvSpPr>
         <p:spPr>
           <a:xfrm>
-            <a:off x="10980000" y="28711412"/>
+            <a:off x="10980000" y="28255190"/>
             <a:ext cx="9612000" cy="335301"/>
           </a:xfrm>
           <a:prstGeom prst="rect">
@@ -17849,13 +17889,13 @@
       </p:sp>
       <p:sp>
         <p:nvSpPr>
-          <p:cNvPr id="48" name="TextBox 47"/>
+          <p:cNvPr id="49" name="TextBox 48"/>
           <p:cNvSpPr txBox="1"/>
           <p:nvPr/>
         </p:nvSpPr>
         <p:spPr>
           <a:xfrm>
-            <a:off x="10980000" y="29136713"/>
+            <a:off x="10980000" y="28680491"/>
             <a:ext cx="9612000" cy="335301"/>
           </a:xfrm>
           <a:prstGeom prst="rect">
@@ -17889,14 +17929,14 @@
       </p:sp>
       <p:sp>
         <p:nvSpPr>
-          <p:cNvPr id="49" name="TextBox 48"/>
+          <p:cNvPr id="50" name="TextBox 49"/>
           <p:cNvSpPr txBox="1"/>
           <p:nvPr/>
         </p:nvSpPr>
         <p:spPr>
           <a:xfrm>
-            <a:off x="792000" y="29634014"/>
-            <a:ext cx="9612000" cy="396000"/>
+            <a:off x="792000" y="29177792"/>
+            <a:ext cx="9612000" cy="792000"/>
           </a:xfrm>
           <a:prstGeom prst="rect">
             <a:avLst/>
@@ -17915,14 +17955,14 @@
               </a:lnSpc>
             </a:pPr>
             <a:r>
-              <a:rPr sz="1500" b="0">
+              <a:rPr sz="1700" b="0">
                 <a:solidFill>
-                  <a:srgbClr val="777777"/>
+                  <a:srgbClr val="263044"/>
                 </a:solidFill>
                 <a:latin typeface="Malgun Gothic"/>
                 <a:ea typeface="Malgun Gothic"/>
               </a:rPr>
-              <a:t>[1] Lewis et al., RAG, NeurIPS 2020  [2] Gao et al., HyDE, ACL 2023  [3] Shi et al., CAD, NAACL 2024</a:t>
+              <a:t>[1] Lewis et al., RAG, NeurIPS 2020  [2] Gao et al., HyDE, ACL 2023</a:t>
             </a:r>
           </a:p>
           <a:p>
@@ -17932,14 +17972,31 @@
               </a:lnSpc>
             </a:pPr>
             <a:r>
-              <a:rPr sz="1500" b="0">
+              <a:rPr sz="1700" b="0">
                 <a:solidFill>
-                  <a:srgbClr val="777777"/>
+                  <a:srgbClr val="263044"/>
                 </a:solidFill>
                 <a:latin typeface="Malgun Gothic"/>
                 <a:ea typeface="Malgun Gothic"/>
               </a:rPr>
-              <a:t>[4] Li et al., SCD, AAAI 2026  [5] Es et al., RAGAs, EACL 2024</a:t>
+              <a:t>[3] Shi et al., CAD, NAACL 2024  [4] Li et al., SCD, AAAI 2026</a:t>
+            </a:r>
+          </a:p>
+          <a:p>
+            <a:pPr algn="l">
+              <a:lnSpc>
+                <a:spcPct val="115000"/>
+              </a:lnSpc>
+            </a:pPr>
+            <a:r>
+              <a:rPr sz="1700" b="0">
+                <a:solidFill>
+                  <a:srgbClr val="263044"/>
+                </a:solidFill>
+                <a:latin typeface="Malgun Gothic"/>
+                <a:ea typeface="Malgun Gothic"/>
+              </a:rPr>
+              <a:t>[5] Es et al., RAGAs, EACL 2024</a:t>
             </a:r>
           </a:p>
         </p:txBody>

</xml_diff>

<commit_message>
Final copy-edit pass on the thesis and poster
Thesis: correct the numeric-question faithfulness claim in 5.8 (CAD+SCD
is 0.77), name the two compared conditions in the Fusion SFT case and
fix its subject, tighten the XSUM case sentence, align the tense of the
6.2 recommendation, unify count wording, and drop colon labels from
reference notes. Thesis v21 re-exported from Hancom at 47 pages with no
page movement.

Poster: state the key combination finding in 08 and give the 09 case
bullets complete endings.

Co-Authored-By: Claude Opus 5.5 <noreply@anthropic.com>
</commit_message>
<xml_diff>
--- a/FINALDOCS/POSTER/FINAL/M_RAG_A1_FINAL_EDITABLE.pptx
+++ b/FINALDOCS/POSTER/FINAL/M_RAG_A1_FINAL_EDITABLE.pptx
@@ -17638,7 +17638,7 @@
                 <a:latin typeface="Malgun Gothic"/>
                 <a:ea typeface="Malgun Gothic"/>
               </a:rPr>
-              <a:t>- 고루 지키려면 세 기법, 방법 질문에서 네 품질 지표가 모두 상승</a:t>
+              <a:t>- 고루 지키려면 세 기법(방법 질문의 네 품질 지표 모두 상승)</a:t>
             </a:r>
           </a:p>
         </p:txBody>
@@ -17678,7 +17678,7 @@
                 <a:latin typeface="Malgun Gothic"/>
                 <a:ea typeface="Malgun Gothic"/>
               </a:rPr>
-              <a:t>- 세 기법은 최고값 없이 한국어 비율 0.73, 처리 시간은 약 세 배</a:t>
+              <a:t>- 조합은 HyDE 단독보다 관련성이 낮고 일관된 이득은 SCD의 한국어 비율</a:t>
             </a:r>
           </a:p>
         </p:txBody>
@@ -17802,7 +17802,7 @@
                 <a:latin typeface="Malgun Gothic"/>
                 <a:ea typeface="Malgun Gothic"/>
               </a:rPr>
-              <a:t>- BIC 질문은 HyDE가 근거 구간을 찾아 관련성이 0.00에서 0.89로</a:t>
+              <a:t>- BIC 질문은 HyDE가 근거 구간을 찾아 관련성이 0.00에서 0.89로 오름</a:t>
             </a:r>
           </a:p>
         </p:txBody>
@@ -17842,7 +17842,7 @@
                 <a:latin typeface="Malgun Gothic"/>
                 <a:ea typeface="Malgun Gothic"/>
               </a:rPr>
-              <a:t>- QuALITY 질문은 HyDE 후 73.68이 빠져 관련성이 0.87에서 0.00으로</a:t>
+              <a:t>- QuALITY 질문은 HyDE 후 73.68이 빠져 관련성이 0.87에서 0.00으로 내림</a:t>
             </a:r>
           </a:p>
         </p:txBody>
@@ -17882,7 +17882,7 @@
                 <a:latin typeface="Malgun Gothic"/>
                 <a:ea typeface="Malgun Gothic"/>
               </a:rPr>
-              <a:t>- XSUM 질문은 CAD가 다른 행 수치를 옮겼는데 충실도가 0.53에서 0.87로</a:t>
+              <a:t>- XSUM 질문은 CAD가 다른 행 수치를 옮겼는데 충실도가 0.53에서 0.87로 오름</a:t>
             </a:r>
           </a:p>
         </p:txBody>
@@ -17922,7 +17922,7 @@
                 <a:latin typeface="Malgun Gothic"/>
                 <a:ea typeface="Malgun Gothic"/>
               </a:rPr>
-              <a:t>- RAG 이점 질문은 CAD 후 지시문만 남아 관련성이 0.90에서 0.00으로</a:t>
+              <a:t>- RAG 이점 질문은 CAD 후 지시문만 남아 관련성이 0.90에서 0.00으로 내림</a:t>
             </a:r>
           </a:p>
         </p:txBody>

</xml_diff>

<commit_message>
Drop the poster subtitle and list references one per line
Remove the subtitle so the submitter line sits directly under the title,
shrink the title band, and set the five references on separate lines so
[2] and [4] are no longer hidden behind [1] and [3].

Co-Authored-By: Claude Opus 5.5 <noreply@anthropic.com>
</commit_message>
<xml_diff>
--- a/FINALDOCS/POSTER/FINAL/M_RAG_A1_FINAL_EDITABLE.pptx
+++ b/FINALDOCS/POSTER/FINAL/M_RAG_A1_FINAL_EDITABLE.pptx
@@ -3097,7 +3097,7 @@
         <p:spPr>
           <a:xfrm>
             <a:off x="0" y="0"/>
-            <a:ext cx="21384000" cy="3312000"/>
+            <a:ext cx="21384000" cy="2880000"/>
           </a:xfrm>
           <a:prstGeom prst="rect">
             <a:avLst/>
@@ -3197,8 +3197,8 @@
         </p:nvSpPr>
         <p:spPr>
           <a:xfrm>
-            <a:off x="792000" y="2340000"/>
-            <a:ext cx="19800000" cy="432000"/>
+            <a:off x="792000" y="2376000"/>
+            <a:ext cx="19800000" cy="360000"/>
           </a:xfrm>
           <a:prstGeom prst="rect">
             <a:avLst/>
@@ -3217,47 +3217,7 @@
               </a:lnSpc>
             </a:pPr>
             <a:r>
-              <a:rPr sz="3000" b="0">
-                <a:solidFill>
-                  <a:srgbClr val="FFFFFF"/>
-                </a:solidFill>
-                <a:latin typeface="Malgun Gothic"/>
-                <a:ea typeface="Malgun Gothic"/>
-              </a:rPr>
-              <a:t>질문 유형별 원점수와 실제 답변 분석</a:t>
-            </a:r>
-          </a:p>
-        </p:txBody>
-      </p:sp>
-      <p:sp>
-        <p:nvSpPr>
-          <p:cNvPr id="5" name="TextBox 4"/>
-          <p:cNvSpPr txBox="1"/>
-          <p:nvPr/>
-        </p:nvSpPr>
-        <p:spPr>
-          <a:xfrm>
-            <a:off x="792000" y="2862000"/>
-            <a:ext cx="19800000" cy="288000"/>
-          </a:xfrm>
-          <a:prstGeom prst="rect">
-            <a:avLst/>
-          </a:prstGeom>
-          <a:noFill/>
-        </p:spPr>
-        <p:txBody>
-          <a:bodyPr wrap="square" lIns="0" rIns="0" tIns="0" bIns="0">
-            <a:spAutoFit/>
-          </a:bodyPr>
-          <a:lstStyle/>
-          <a:p>
-            <a:pPr algn="ctr">
-              <a:lnSpc>
-                <a:spcPct val="115000"/>
-              </a:lnSpc>
-            </a:pPr>
-            <a:r>
-              <a:rPr sz="2000" b="0">
+              <a:rPr sz="2400" b="0">
                 <a:solidFill>
                   <a:srgbClr val="FFFFFF"/>
                 </a:solidFill>
@@ -3271,13 +3231,13 @@
       </p:sp>
       <p:sp>
         <p:nvSpPr>
-          <p:cNvPr id="6" name="Rectangle 5"/>
+          <p:cNvPr id="5" name="Rectangle 4"/>
           <p:cNvSpPr/>
           <p:nvPr/>
         </p:nvSpPr>
         <p:spPr>
           <a:xfrm>
-            <a:off x="792000" y="3672000"/>
+            <a:off x="792000" y="3240000"/>
             <a:ext cx="9612000" cy="468000"/>
           </a:xfrm>
           <a:prstGeom prst="rect">
@@ -3315,13 +3275,13 @@
       </p:sp>
       <p:sp>
         <p:nvSpPr>
-          <p:cNvPr id="7" name="TextBox 6"/>
+          <p:cNvPr id="6" name="TextBox 5"/>
           <p:cNvSpPr txBox="1"/>
           <p:nvPr/>
         </p:nvSpPr>
         <p:spPr>
           <a:xfrm>
-            <a:off x="936000" y="3697200"/>
+            <a:off x="936000" y="3265200"/>
             <a:ext cx="9324000" cy="360000"/>
           </a:xfrm>
           <a:prstGeom prst="rect">
@@ -3355,13 +3315,13 @@
       </p:sp>
       <p:sp>
         <p:nvSpPr>
-          <p:cNvPr id="8" name="TextBox 7"/>
+          <p:cNvPr id="7" name="TextBox 6"/>
           <p:cNvSpPr txBox="1"/>
           <p:nvPr/>
         </p:nvSpPr>
         <p:spPr>
           <a:xfrm>
-            <a:off x="792000" y="4284000"/>
+            <a:off x="792000" y="3852000"/>
             <a:ext cx="9612000" cy="352066"/>
           </a:xfrm>
           <a:prstGeom prst="rect">
@@ -3395,13 +3355,13 @@
       </p:sp>
       <p:sp>
         <p:nvSpPr>
-          <p:cNvPr id="9" name="TextBox 8"/>
+          <p:cNvPr id="8" name="TextBox 7"/>
           <p:cNvSpPr txBox="1"/>
           <p:nvPr/>
         </p:nvSpPr>
         <p:spPr>
           <a:xfrm>
-            <a:off x="792000" y="4726066"/>
+            <a:off x="792000" y="4294066"/>
             <a:ext cx="9612000" cy="352066"/>
           </a:xfrm>
           <a:prstGeom prst="rect">
@@ -3435,13 +3395,13 @@
       </p:sp>
       <p:sp>
         <p:nvSpPr>
-          <p:cNvPr id="10" name="TextBox 9"/>
+          <p:cNvPr id="9" name="TextBox 8"/>
           <p:cNvSpPr txBox="1"/>
           <p:nvPr/>
         </p:nvSpPr>
         <p:spPr>
           <a:xfrm>
-            <a:off x="792000" y="5168132"/>
+            <a:off x="792000" y="4736132"/>
             <a:ext cx="9612000" cy="352066"/>
           </a:xfrm>
           <a:prstGeom prst="rect">
@@ -3475,13 +3435,13 @@
       </p:sp>
       <p:sp>
         <p:nvSpPr>
-          <p:cNvPr id="11" name="Rectangle 10"/>
+          <p:cNvPr id="10" name="Rectangle 9"/>
           <p:cNvSpPr/>
           <p:nvPr/>
         </p:nvSpPr>
         <p:spPr>
           <a:xfrm>
-            <a:off x="792000" y="6042198"/>
+            <a:off x="792000" y="5610198"/>
             <a:ext cx="9612000" cy="468000"/>
           </a:xfrm>
           <a:prstGeom prst="rect">
@@ -3519,13 +3479,13 @@
       </p:sp>
       <p:sp>
         <p:nvSpPr>
-          <p:cNvPr id="12" name="TextBox 11"/>
+          <p:cNvPr id="11" name="TextBox 10"/>
           <p:cNvSpPr txBox="1"/>
           <p:nvPr/>
         </p:nvSpPr>
         <p:spPr>
           <a:xfrm>
-            <a:off x="936000" y="6067398"/>
+            <a:off x="936000" y="5635398"/>
             <a:ext cx="9324000" cy="360000"/>
           </a:xfrm>
           <a:prstGeom prst="rect">
@@ -3559,7 +3519,7 @@
       </p:sp>
       <p:pic>
         <p:nvPicPr>
-          <p:cNvPr id="13" name="Picture 12" descr="poster_pipeline.png"/>
+          <p:cNvPr id="12" name="Picture 11" descr="poster_pipeline.png"/>
           <p:cNvPicPr>
             <a:picLocks noChangeAspect="1"/>
           </p:cNvPicPr>
@@ -3573,7 +3533,7 @@
         </p:blipFill>
         <p:spPr>
           <a:xfrm>
-            <a:off x="792000" y="6798198"/>
+            <a:off x="792000" y="6366198"/>
             <a:ext cx="9612000" cy="3661714"/>
           </a:xfrm>
           <a:prstGeom prst="rect">
@@ -3583,14 +3543,14 @@
       </p:pic>
       <p:graphicFrame>
         <p:nvGraphicFramePr>
-          <p:cNvPr id="14" name="Table 13"/>
+          <p:cNvPr id="13" name="Table 12"/>
           <p:cNvGraphicFramePr>
             <a:graphicFrameLocks noGrp="1"/>
           </p:cNvGraphicFramePr>
           <p:nvPr/>
         </p:nvGraphicFramePr>
         <p:xfrm>
-          <a:off x="792000" y="10819912"/>
+          <a:off x="792000" y="10387912"/>
           <a:ext cx="9612000" cy="3287781"/>
         </p:xfrm>
         <a:graphic>
@@ -5565,13 +5525,13 @@
       </p:graphicFrame>
       <p:sp>
         <p:nvSpPr>
-          <p:cNvPr id="15" name="TextBox 14"/>
+          <p:cNvPr id="14" name="TextBox 13"/>
           <p:cNvSpPr txBox="1"/>
           <p:nvPr/>
         </p:nvSpPr>
         <p:spPr>
           <a:xfrm>
-            <a:off x="792000" y="14215698"/>
+            <a:off x="792000" y="13783698"/>
             <a:ext cx="9612000" cy="905313"/>
           </a:xfrm>
           <a:prstGeom prst="rect">
@@ -5607,13 +5567,13 @@
       </p:sp>
       <p:sp>
         <p:nvSpPr>
-          <p:cNvPr id="16" name="Rectangle 15"/>
+          <p:cNvPr id="15" name="Rectangle 14"/>
           <p:cNvSpPr/>
           <p:nvPr/>
         </p:nvSpPr>
         <p:spPr>
           <a:xfrm>
-            <a:off x="10980000" y="3672000"/>
+            <a:off x="10980000" y="3240000"/>
             <a:ext cx="9612000" cy="468000"/>
           </a:xfrm>
           <a:prstGeom prst="rect">
@@ -5651,13 +5611,13 @@
       </p:sp>
       <p:sp>
         <p:nvSpPr>
-          <p:cNvPr id="17" name="TextBox 16"/>
+          <p:cNvPr id="16" name="TextBox 15"/>
           <p:cNvSpPr txBox="1"/>
           <p:nvPr/>
         </p:nvSpPr>
         <p:spPr>
           <a:xfrm>
-            <a:off x="11124000" y="3697200"/>
+            <a:off x="11124000" y="3265200"/>
             <a:ext cx="9324000" cy="360000"/>
           </a:xfrm>
           <a:prstGeom prst="rect">
@@ -5691,13 +5651,13 @@
       </p:sp>
       <p:sp>
         <p:nvSpPr>
-          <p:cNvPr id="18" name="TextBox 17"/>
+          <p:cNvPr id="17" name="TextBox 16"/>
           <p:cNvSpPr txBox="1"/>
           <p:nvPr/>
         </p:nvSpPr>
         <p:spPr>
           <a:xfrm>
-            <a:off x="10980000" y="4284000"/>
+            <a:off x="10980000" y="3852000"/>
             <a:ext cx="9612000" cy="352066"/>
           </a:xfrm>
           <a:prstGeom prst="rect">
@@ -5731,13 +5691,13 @@
       </p:sp>
       <p:sp>
         <p:nvSpPr>
-          <p:cNvPr id="19" name="TextBox 18"/>
+          <p:cNvPr id="18" name="TextBox 17"/>
           <p:cNvSpPr txBox="1"/>
           <p:nvPr/>
         </p:nvSpPr>
         <p:spPr>
           <a:xfrm>
-            <a:off x="10980000" y="4726066"/>
+            <a:off x="10980000" y="4294066"/>
             <a:ext cx="9612000" cy="352066"/>
           </a:xfrm>
           <a:prstGeom prst="rect">
@@ -5771,14 +5731,14 @@
       </p:sp>
       <p:graphicFrame>
         <p:nvGraphicFramePr>
-          <p:cNvPr id="20" name="Table 19"/>
+          <p:cNvPr id="19" name="Table 18"/>
           <p:cNvGraphicFramePr>
             <a:graphicFrameLocks noGrp="1"/>
           </p:cNvGraphicFramePr>
           <p:nvPr/>
         </p:nvGraphicFramePr>
         <p:xfrm>
-          <a:off x="10980000" y="5204132"/>
+          <a:off x="10980000" y="4772132"/>
           <a:ext cx="9611999" cy="2712113"/>
         </p:xfrm>
         <a:graphic>
@@ -6727,13 +6687,13 @@
       </p:graphicFrame>
       <p:sp>
         <p:nvSpPr>
-          <p:cNvPr id="21" name="TextBox 20"/>
+          <p:cNvPr id="20" name="TextBox 19"/>
           <p:cNvSpPr txBox="1"/>
           <p:nvPr/>
         </p:nvSpPr>
         <p:spPr>
           <a:xfrm>
-            <a:off x="10980000" y="7988249"/>
+            <a:off x="10980000" y="7556249"/>
             <a:ext cx="9612000" cy="288000"/>
           </a:xfrm>
           <a:prstGeom prst="rect">
@@ -6767,13 +6727,13 @@
       </p:sp>
       <p:sp>
         <p:nvSpPr>
-          <p:cNvPr id="22" name="Rectangle 21"/>
+          <p:cNvPr id="21" name="Rectangle 20"/>
           <p:cNvSpPr/>
           <p:nvPr/>
         </p:nvSpPr>
         <p:spPr>
           <a:xfrm>
-            <a:off x="10980000" y="8384249"/>
+            <a:off x="10980000" y="7952249"/>
             <a:ext cx="9612000" cy="468000"/>
           </a:xfrm>
           <a:prstGeom prst="rect">
@@ -6811,13 +6771,13 @@
       </p:sp>
       <p:sp>
         <p:nvSpPr>
-          <p:cNvPr id="23" name="TextBox 22"/>
+          <p:cNvPr id="22" name="TextBox 21"/>
           <p:cNvSpPr txBox="1"/>
           <p:nvPr/>
         </p:nvSpPr>
         <p:spPr>
           <a:xfrm>
-            <a:off x="11124000" y="8409449"/>
+            <a:off x="11124000" y="7977449"/>
             <a:ext cx="9324000" cy="360000"/>
           </a:xfrm>
           <a:prstGeom prst="rect">
@@ -6851,14 +6811,14 @@
       </p:sp>
       <p:graphicFrame>
         <p:nvGraphicFramePr>
-          <p:cNvPr id="24" name="Table 23"/>
+          <p:cNvPr id="23" name="Table 22"/>
           <p:cNvGraphicFramePr>
             <a:graphicFrameLocks noGrp="1"/>
           </p:cNvGraphicFramePr>
           <p:nvPr/>
         </p:nvGraphicFramePr>
         <p:xfrm>
-          <a:off x="10980000" y="8996249"/>
+          <a:off x="10980000" y="8564249"/>
           <a:ext cx="9611998" cy="1461236"/>
         </p:xfrm>
         <a:graphic>
@@ -7575,13 +7535,13 @@
       </p:graphicFrame>
       <p:sp>
         <p:nvSpPr>
-          <p:cNvPr id="25" name="TextBox 24"/>
+          <p:cNvPr id="24" name="TextBox 23"/>
           <p:cNvSpPr txBox="1"/>
           <p:nvPr/>
         </p:nvSpPr>
         <p:spPr>
           <a:xfrm>
-            <a:off x="10980000" y="10565487"/>
+            <a:off x="10980000" y="10133487"/>
             <a:ext cx="9612000" cy="318536"/>
           </a:xfrm>
           <a:prstGeom prst="rect">
@@ -7615,13 +7575,13 @@
       </p:sp>
       <p:sp>
         <p:nvSpPr>
-          <p:cNvPr id="26" name="Rectangle 25"/>
+          <p:cNvPr id="25" name="Rectangle 24"/>
           <p:cNvSpPr/>
           <p:nvPr/>
         </p:nvSpPr>
         <p:spPr>
           <a:xfrm>
-            <a:off x="10980000" y="11046023"/>
+            <a:off x="10980000" y="10614023"/>
             <a:ext cx="9612000" cy="468000"/>
           </a:xfrm>
           <a:prstGeom prst="rect">
@@ -7659,13 +7619,13 @@
       </p:sp>
       <p:sp>
         <p:nvSpPr>
-          <p:cNvPr id="27" name="TextBox 26"/>
+          <p:cNvPr id="26" name="TextBox 25"/>
           <p:cNvSpPr txBox="1"/>
           <p:nvPr/>
         </p:nvSpPr>
         <p:spPr>
           <a:xfrm>
-            <a:off x="11124000" y="11071223"/>
+            <a:off x="11124000" y="10639223"/>
             <a:ext cx="9324000" cy="360000"/>
           </a:xfrm>
           <a:prstGeom prst="rect">
@@ -7699,14 +7659,14 @@
       </p:sp>
       <p:graphicFrame>
         <p:nvGraphicFramePr>
-          <p:cNvPr id="28" name="Table 27"/>
+          <p:cNvPr id="27" name="Table 26"/>
           <p:cNvGraphicFramePr>
             <a:graphicFrameLocks noGrp="1"/>
           </p:cNvGraphicFramePr>
           <p:nvPr/>
         </p:nvGraphicFramePr>
         <p:xfrm>
-          <a:off x="10980000" y="11658023"/>
+          <a:off x="10980000" y="11226023"/>
           <a:ext cx="9611996" cy="3566691"/>
         </p:xfrm>
         <a:graphic>
@@ -10129,13 +10089,13 @@
       </p:graphicFrame>
       <p:sp>
         <p:nvSpPr>
-          <p:cNvPr id="29" name="TextBox 28"/>
+          <p:cNvPr id="28" name="TextBox 27"/>
           <p:cNvSpPr txBox="1"/>
           <p:nvPr/>
         </p:nvSpPr>
         <p:spPr>
           <a:xfrm>
-            <a:off x="10980000" y="15332719"/>
+            <a:off x="10980000" y="14900719"/>
             <a:ext cx="9612000" cy="318536"/>
           </a:xfrm>
           <a:prstGeom prst="rect">
@@ -10169,13 +10129,13 @@
       </p:sp>
       <p:sp>
         <p:nvSpPr>
-          <p:cNvPr id="30" name="Rectangle 29"/>
+          <p:cNvPr id="29" name="Rectangle 28"/>
           <p:cNvSpPr/>
           <p:nvPr/>
         </p:nvSpPr>
         <p:spPr>
           <a:xfrm>
-            <a:off x="792000" y="15885255"/>
+            <a:off x="792000" y="15453255"/>
             <a:ext cx="19800000" cy="468000"/>
           </a:xfrm>
           <a:prstGeom prst="rect">
@@ -10213,13 +10173,13 @@
       </p:sp>
       <p:sp>
         <p:nvSpPr>
-          <p:cNvPr id="31" name="TextBox 30"/>
+          <p:cNvPr id="30" name="TextBox 29"/>
           <p:cNvSpPr txBox="1"/>
           <p:nvPr/>
         </p:nvSpPr>
         <p:spPr>
           <a:xfrm>
-            <a:off x="936000" y="15910455"/>
+            <a:off x="936000" y="15478455"/>
             <a:ext cx="19512000" cy="360000"/>
           </a:xfrm>
           <a:prstGeom prst="rect">
@@ -10253,14 +10213,14 @@
       </p:sp>
       <p:graphicFrame>
         <p:nvGraphicFramePr>
-          <p:cNvPr id="32" name="Table 31"/>
+          <p:cNvPr id="31" name="Table 30"/>
           <p:cNvGraphicFramePr>
             <a:graphicFrameLocks noGrp="1"/>
           </p:cNvGraphicFramePr>
           <p:nvPr/>
         </p:nvGraphicFramePr>
         <p:xfrm>
-          <a:off x="792000" y="16497255"/>
+          <a:off x="792000" y="16065255"/>
           <a:ext cx="19799991" cy="3761555"/>
         </p:xfrm>
         <a:graphic>
@@ -17253,13 +17213,13 @@
       </p:graphicFrame>
       <p:sp>
         <p:nvSpPr>
-          <p:cNvPr id="33" name="TextBox 32"/>
+          <p:cNvPr id="32" name="TextBox 31"/>
           <p:cNvSpPr txBox="1"/>
           <p:nvPr/>
         </p:nvSpPr>
         <p:spPr>
           <a:xfrm>
-            <a:off x="792000" y="20366815"/>
+            <a:off x="792000" y="19934815"/>
             <a:ext cx="19800000" cy="318536"/>
           </a:xfrm>
           <a:prstGeom prst="rect">
@@ -17293,13 +17253,13 @@
       </p:sp>
       <p:sp>
         <p:nvSpPr>
-          <p:cNvPr id="34" name="Rectangle 33"/>
+          <p:cNvPr id="33" name="Rectangle 32"/>
           <p:cNvSpPr/>
           <p:nvPr/>
         </p:nvSpPr>
         <p:spPr>
           <a:xfrm>
-            <a:off x="792000" y="20919351"/>
+            <a:off x="792000" y="20487351"/>
             <a:ext cx="19800000" cy="468000"/>
           </a:xfrm>
           <a:prstGeom prst="rect">
@@ -17337,13 +17297,13 @@
       </p:sp>
       <p:sp>
         <p:nvSpPr>
-          <p:cNvPr id="35" name="TextBox 34"/>
+          <p:cNvPr id="34" name="TextBox 33"/>
           <p:cNvSpPr txBox="1"/>
           <p:nvPr/>
         </p:nvSpPr>
         <p:spPr>
           <a:xfrm>
-            <a:off x="936000" y="20944551"/>
+            <a:off x="936000" y="20512551"/>
             <a:ext cx="19512000" cy="360000"/>
           </a:xfrm>
           <a:prstGeom prst="rect">
@@ -17377,7 +17337,7 @@
       </p:sp>
       <p:pic>
         <p:nvPicPr>
-          <p:cNvPr id="36" name="Picture 35" descr="poster_parallel.png"/>
+          <p:cNvPr id="35" name="Picture 34" descr="poster_parallel.png"/>
           <p:cNvPicPr>
             <a:picLocks noChangeAspect="1"/>
           </p:cNvPicPr>
@@ -17391,8 +17351,8 @@
         </p:blipFill>
         <p:spPr>
           <a:xfrm>
-            <a:off x="792000" y="21531351"/>
-            <a:ext cx="19800000" cy="4744700"/>
+            <a:off x="792000" y="21099351"/>
+            <a:ext cx="19800000" cy="4470968"/>
           </a:xfrm>
           <a:prstGeom prst="rect">
             <a:avLst/>
@@ -17401,13 +17361,13 @@
       </p:pic>
       <p:sp>
         <p:nvSpPr>
-          <p:cNvPr id="37" name="TextBox 36"/>
+          <p:cNvPr id="36" name="TextBox 35"/>
           <p:cNvSpPr txBox="1"/>
           <p:nvPr/>
         </p:nvSpPr>
         <p:spPr>
           <a:xfrm>
-            <a:off x="792000" y="26312051"/>
+            <a:off x="792000" y="25606319"/>
             <a:ext cx="19800000" cy="318536"/>
           </a:xfrm>
           <a:prstGeom prst="rect">
@@ -17441,13 +17401,13 @@
       </p:sp>
       <p:sp>
         <p:nvSpPr>
-          <p:cNvPr id="38" name="Rectangle 37"/>
+          <p:cNvPr id="37" name="Rectangle 36"/>
           <p:cNvSpPr/>
           <p:nvPr/>
         </p:nvSpPr>
         <p:spPr>
           <a:xfrm>
-            <a:off x="792000" y="26792587"/>
+            <a:off x="792000" y="26086855"/>
             <a:ext cx="9612000" cy="468000"/>
           </a:xfrm>
           <a:prstGeom prst="rect">
@@ -17485,13 +17445,13 @@
       </p:sp>
       <p:sp>
         <p:nvSpPr>
-          <p:cNvPr id="39" name="TextBox 38"/>
+          <p:cNvPr id="38" name="TextBox 37"/>
           <p:cNvSpPr txBox="1"/>
           <p:nvPr/>
         </p:nvSpPr>
         <p:spPr>
           <a:xfrm>
-            <a:off x="936000" y="26817787"/>
+            <a:off x="936000" y="26112055"/>
             <a:ext cx="9324000" cy="360000"/>
           </a:xfrm>
           <a:prstGeom prst="rect">
@@ -17525,13 +17485,13 @@
       </p:sp>
       <p:sp>
         <p:nvSpPr>
-          <p:cNvPr id="40" name="TextBox 39"/>
+          <p:cNvPr id="39" name="TextBox 38"/>
           <p:cNvSpPr txBox="1"/>
           <p:nvPr/>
         </p:nvSpPr>
         <p:spPr>
           <a:xfrm>
-            <a:off x="792000" y="27404587"/>
+            <a:off x="792000" y="26698855"/>
             <a:ext cx="9612000" cy="335301"/>
           </a:xfrm>
           <a:prstGeom prst="rect">
@@ -17565,13 +17525,13 @@
       </p:sp>
       <p:sp>
         <p:nvSpPr>
-          <p:cNvPr id="41" name="TextBox 40"/>
+          <p:cNvPr id="40" name="TextBox 39"/>
           <p:cNvSpPr txBox="1"/>
           <p:nvPr/>
         </p:nvSpPr>
         <p:spPr>
           <a:xfrm>
-            <a:off x="792000" y="27829888"/>
+            <a:off x="792000" y="27124156"/>
             <a:ext cx="9612000" cy="335301"/>
           </a:xfrm>
           <a:prstGeom prst="rect">
@@ -17605,13 +17565,13 @@
       </p:sp>
       <p:sp>
         <p:nvSpPr>
-          <p:cNvPr id="42" name="TextBox 41"/>
+          <p:cNvPr id="41" name="TextBox 40"/>
           <p:cNvSpPr txBox="1"/>
           <p:nvPr/>
         </p:nvSpPr>
         <p:spPr>
           <a:xfrm>
-            <a:off x="792000" y="28255190"/>
+            <a:off x="792000" y="27549458"/>
             <a:ext cx="9612000" cy="335301"/>
           </a:xfrm>
           <a:prstGeom prst="rect">
@@ -17645,13 +17605,13 @@
       </p:sp>
       <p:sp>
         <p:nvSpPr>
-          <p:cNvPr id="43" name="TextBox 42"/>
+          <p:cNvPr id="42" name="TextBox 41"/>
           <p:cNvSpPr txBox="1"/>
           <p:nvPr/>
         </p:nvSpPr>
         <p:spPr>
           <a:xfrm>
-            <a:off x="792000" y="28680491"/>
+            <a:off x="792000" y="27974759"/>
             <a:ext cx="9612000" cy="335301"/>
           </a:xfrm>
           <a:prstGeom prst="rect">
@@ -17685,13 +17645,13 @@
       </p:sp>
       <p:sp>
         <p:nvSpPr>
-          <p:cNvPr id="44" name="Rectangle 43"/>
+          <p:cNvPr id="43" name="Rectangle 42"/>
           <p:cNvSpPr/>
           <p:nvPr/>
         </p:nvSpPr>
         <p:spPr>
           <a:xfrm>
-            <a:off x="10980000" y="26792587"/>
+            <a:off x="10980000" y="26086855"/>
             <a:ext cx="9612000" cy="468000"/>
           </a:xfrm>
           <a:prstGeom prst="rect">
@@ -17729,13 +17689,13 @@
       </p:sp>
       <p:sp>
         <p:nvSpPr>
-          <p:cNvPr id="45" name="TextBox 44"/>
+          <p:cNvPr id="44" name="TextBox 43"/>
           <p:cNvSpPr txBox="1"/>
           <p:nvPr/>
         </p:nvSpPr>
         <p:spPr>
           <a:xfrm>
-            <a:off x="11124000" y="26817787"/>
+            <a:off x="11124000" y="26112055"/>
             <a:ext cx="9324000" cy="360000"/>
           </a:xfrm>
           <a:prstGeom prst="rect">
@@ -17769,13 +17729,13 @@
       </p:sp>
       <p:sp>
         <p:nvSpPr>
-          <p:cNvPr id="46" name="TextBox 45"/>
+          <p:cNvPr id="45" name="TextBox 44"/>
           <p:cNvSpPr txBox="1"/>
           <p:nvPr/>
         </p:nvSpPr>
         <p:spPr>
           <a:xfrm>
-            <a:off x="10980000" y="27404587"/>
+            <a:off x="10980000" y="26698855"/>
             <a:ext cx="9612000" cy="335301"/>
           </a:xfrm>
           <a:prstGeom prst="rect">
@@ -17809,13 +17769,13 @@
       </p:sp>
       <p:sp>
         <p:nvSpPr>
-          <p:cNvPr id="47" name="TextBox 46"/>
+          <p:cNvPr id="46" name="TextBox 45"/>
           <p:cNvSpPr txBox="1"/>
           <p:nvPr/>
         </p:nvSpPr>
         <p:spPr>
           <a:xfrm>
-            <a:off x="10980000" y="27829888"/>
+            <a:off x="10980000" y="27124156"/>
             <a:ext cx="9612000" cy="335301"/>
           </a:xfrm>
           <a:prstGeom prst="rect">
@@ -17849,13 +17809,13 @@
       </p:sp>
       <p:sp>
         <p:nvSpPr>
-          <p:cNvPr id="48" name="TextBox 47"/>
+          <p:cNvPr id="47" name="TextBox 46"/>
           <p:cNvSpPr txBox="1"/>
           <p:nvPr/>
         </p:nvSpPr>
         <p:spPr>
           <a:xfrm>
-            <a:off x="10980000" y="28255190"/>
+            <a:off x="10980000" y="27549458"/>
             <a:ext cx="9612000" cy="335301"/>
           </a:xfrm>
           <a:prstGeom prst="rect">
@@ -17889,13 +17849,13 @@
       </p:sp>
       <p:sp>
         <p:nvSpPr>
-          <p:cNvPr id="49" name="TextBox 48"/>
+          <p:cNvPr id="48" name="TextBox 47"/>
           <p:cNvSpPr txBox="1"/>
           <p:nvPr/>
         </p:nvSpPr>
         <p:spPr>
           <a:xfrm>
-            <a:off x="10980000" y="28680491"/>
+            <a:off x="10980000" y="27974759"/>
             <a:ext cx="9612000" cy="335301"/>
           </a:xfrm>
           <a:prstGeom prst="rect">
@@ -17929,14 +17889,14 @@
       </p:sp>
       <p:sp>
         <p:nvSpPr>
-          <p:cNvPr id="50" name="TextBox 49"/>
+          <p:cNvPr id="49" name="TextBox 48"/>
           <p:cNvSpPr txBox="1"/>
           <p:nvPr/>
         </p:nvSpPr>
         <p:spPr>
           <a:xfrm>
-            <a:off x="792000" y="29177792"/>
-            <a:ext cx="9612000" cy="792000"/>
+            <a:off x="792000" y="28472060"/>
+            <a:ext cx="9612000" cy="1368000"/>
           </a:xfrm>
           <a:prstGeom prst="rect">
             <a:avLst/>
@@ -17962,7 +17922,7 @@
                 <a:latin typeface="Malgun Gothic"/>
                 <a:ea typeface="Malgun Gothic"/>
               </a:rPr>
-              <a:t>[1] Lewis et al., RAG, NeurIPS 2020  [2] Gao et al., HyDE, ACL 2023</a:t>
+              <a:t>[1] Lewis et al., RAG, NeurIPS 2020</a:t>
             </a:r>
           </a:p>
           <a:p>
@@ -17979,7 +17939,41 @@
                 <a:latin typeface="Malgun Gothic"/>
                 <a:ea typeface="Malgun Gothic"/>
               </a:rPr>
-              <a:t>[3] Shi et al., CAD, NAACL 2024  [4] Li et al., SCD, AAAI 2026</a:t>
+              <a:t>[2] Gao et al., HyDE, ACL 2023</a:t>
+            </a:r>
+          </a:p>
+          <a:p>
+            <a:pPr algn="l">
+              <a:lnSpc>
+                <a:spcPct val="115000"/>
+              </a:lnSpc>
+            </a:pPr>
+            <a:r>
+              <a:rPr sz="1700" b="0">
+                <a:solidFill>
+                  <a:srgbClr val="263044"/>
+                </a:solidFill>
+                <a:latin typeface="Malgun Gothic"/>
+                <a:ea typeface="Malgun Gothic"/>
+              </a:rPr>
+              <a:t>[3] Shi et al., CAD, NAACL 2024</a:t>
+            </a:r>
+          </a:p>
+          <a:p>
+            <a:pPr algn="l">
+              <a:lnSpc>
+                <a:spcPct val="115000"/>
+              </a:lnSpc>
+            </a:pPr>
+            <a:r>
+              <a:rPr sz="1700" b="0">
+                <a:solidFill>
+                  <a:srgbClr val="263044"/>
+                </a:solidFill>
+                <a:latin typeface="Malgun Gothic"/>
+                <a:ea typeface="Malgun Gothic"/>
+              </a:rPr>
+              <a:t>[4] Li et al., SCD, AAAI 2026</a:t>
             </a:r>
           </a:p>
           <a:p>

</xml_diff>

<commit_message>
Set poster references as two full-width lines at the bottom
Move the five references from a five-line block under 08 to two
full-width lines below 08 and 09, and give the freed space back to the
parallel chart.

Co-Authored-By: Claude Opus 5.5 <noreply@anthropic.com>
</commit_message>
<xml_diff>
--- a/FINALDOCS/POSTER/FINAL/M_RAG_A1_FINAL_EDITABLE.pptx
+++ b/FINALDOCS/POSTER/FINAL/M_RAG_A1_FINAL_EDITABLE.pptx
@@ -17352,7 +17352,7 @@
         <p:spPr>
           <a:xfrm>
             <a:off x="792000" y="21099351"/>
-            <a:ext cx="19800000" cy="4470968"/>
+            <a:ext cx="19800000" cy="5292166"/>
           </a:xfrm>
           <a:prstGeom prst="rect">
             <a:avLst/>
@@ -17367,7 +17367,7 @@
         </p:nvSpPr>
         <p:spPr>
           <a:xfrm>
-            <a:off x="792000" y="25606319"/>
+            <a:off x="792000" y="26427517"/>
             <a:ext cx="19800000" cy="318536"/>
           </a:xfrm>
           <a:prstGeom prst="rect">
@@ -17407,7 +17407,7 @@
         </p:nvSpPr>
         <p:spPr>
           <a:xfrm>
-            <a:off x="792000" y="26086855"/>
+            <a:off x="792000" y="26908053"/>
             <a:ext cx="9612000" cy="468000"/>
           </a:xfrm>
           <a:prstGeom prst="rect">
@@ -17451,7 +17451,7 @@
         </p:nvSpPr>
         <p:spPr>
           <a:xfrm>
-            <a:off x="936000" y="26112055"/>
+            <a:off x="936000" y="26933253"/>
             <a:ext cx="9324000" cy="360000"/>
           </a:xfrm>
           <a:prstGeom prst="rect">
@@ -17491,7 +17491,7 @@
         </p:nvSpPr>
         <p:spPr>
           <a:xfrm>
-            <a:off x="792000" y="26698855"/>
+            <a:off x="792000" y="27520053"/>
             <a:ext cx="9612000" cy="335301"/>
           </a:xfrm>
           <a:prstGeom prst="rect">
@@ -17531,7 +17531,7 @@
         </p:nvSpPr>
         <p:spPr>
           <a:xfrm>
-            <a:off x="792000" y="27124156"/>
+            <a:off x="792000" y="27945354"/>
             <a:ext cx="9612000" cy="335301"/>
           </a:xfrm>
           <a:prstGeom prst="rect">
@@ -17571,7 +17571,7 @@
         </p:nvSpPr>
         <p:spPr>
           <a:xfrm>
-            <a:off x="792000" y="27549458"/>
+            <a:off x="792000" y="28370656"/>
             <a:ext cx="9612000" cy="335301"/>
           </a:xfrm>
           <a:prstGeom prst="rect">
@@ -17611,7 +17611,7 @@
         </p:nvSpPr>
         <p:spPr>
           <a:xfrm>
-            <a:off x="792000" y="27974759"/>
+            <a:off x="792000" y="28795957"/>
             <a:ext cx="9612000" cy="335301"/>
           </a:xfrm>
           <a:prstGeom prst="rect">
@@ -17651,7 +17651,7 @@
         </p:nvSpPr>
         <p:spPr>
           <a:xfrm>
-            <a:off x="10980000" y="26086855"/>
+            <a:off x="10980000" y="26908053"/>
             <a:ext cx="9612000" cy="468000"/>
           </a:xfrm>
           <a:prstGeom prst="rect">
@@ -17695,7 +17695,7 @@
         </p:nvSpPr>
         <p:spPr>
           <a:xfrm>
-            <a:off x="11124000" y="26112055"/>
+            <a:off x="11124000" y="26933253"/>
             <a:ext cx="9324000" cy="360000"/>
           </a:xfrm>
           <a:prstGeom prst="rect">
@@ -17735,7 +17735,7 @@
         </p:nvSpPr>
         <p:spPr>
           <a:xfrm>
-            <a:off x="10980000" y="26698855"/>
+            <a:off x="10980000" y="27520053"/>
             <a:ext cx="9612000" cy="335301"/>
           </a:xfrm>
           <a:prstGeom prst="rect">
@@ -17775,7 +17775,7 @@
         </p:nvSpPr>
         <p:spPr>
           <a:xfrm>
-            <a:off x="10980000" y="27124156"/>
+            <a:off x="10980000" y="27945354"/>
             <a:ext cx="9612000" cy="335301"/>
           </a:xfrm>
           <a:prstGeom prst="rect">
@@ -17815,7 +17815,7 @@
         </p:nvSpPr>
         <p:spPr>
           <a:xfrm>
-            <a:off x="10980000" y="27549458"/>
+            <a:off x="10980000" y="28370656"/>
             <a:ext cx="9612000" cy="335301"/>
           </a:xfrm>
           <a:prstGeom prst="rect">
@@ -17855,7 +17855,7 @@
         </p:nvSpPr>
         <p:spPr>
           <a:xfrm>
-            <a:off x="10980000" y="27974759"/>
+            <a:off x="10980000" y="28795957"/>
             <a:ext cx="9612000" cy="335301"/>
           </a:xfrm>
           <a:prstGeom prst="rect">
@@ -17895,8 +17895,8 @@
         </p:nvSpPr>
         <p:spPr>
           <a:xfrm>
-            <a:off x="792000" y="28472060"/>
-            <a:ext cx="9612000" cy="1368000"/>
+            <a:off x="792000" y="29329258"/>
+            <a:ext cx="19800000" cy="576000"/>
           </a:xfrm>
           <a:prstGeom prst="rect">
             <a:avLst/>
@@ -17922,7 +17922,7 @@
                 <a:latin typeface="Malgun Gothic"/>
                 <a:ea typeface="Malgun Gothic"/>
               </a:rPr>
-              <a:t>[1] Lewis et al., RAG, NeurIPS 2020</a:t>
+              <a:t>[1] Lewis et al., RAG, NeurIPS 2020      [2] Gao et al., HyDE, ACL 2023      [3] Shi et al., CAD, NAACL 2024</a:t>
             </a:r>
           </a:p>
           <a:p>
@@ -17939,58 +17939,7 @@
                 <a:latin typeface="Malgun Gothic"/>
                 <a:ea typeface="Malgun Gothic"/>
               </a:rPr>
-              <a:t>[2] Gao et al., HyDE, ACL 2023</a:t>
-            </a:r>
-          </a:p>
-          <a:p>
-            <a:pPr algn="l">
-              <a:lnSpc>
-                <a:spcPct val="115000"/>
-              </a:lnSpc>
-            </a:pPr>
-            <a:r>
-              <a:rPr sz="1700" b="0">
-                <a:solidFill>
-                  <a:srgbClr val="263044"/>
-                </a:solidFill>
-                <a:latin typeface="Malgun Gothic"/>
-                <a:ea typeface="Malgun Gothic"/>
-              </a:rPr>
-              <a:t>[3] Shi et al., CAD, NAACL 2024</a:t>
-            </a:r>
-          </a:p>
-          <a:p>
-            <a:pPr algn="l">
-              <a:lnSpc>
-                <a:spcPct val="115000"/>
-              </a:lnSpc>
-            </a:pPr>
-            <a:r>
-              <a:rPr sz="1700" b="0">
-                <a:solidFill>
-                  <a:srgbClr val="263044"/>
-                </a:solidFill>
-                <a:latin typeface="Malgun Gothic"/>
-                <a:ea typeface="Malgun Gothic"/>
-              </a:rPr>
-              <a:t>[4] Li et al., SCD, AAAI 2026</a:t>
-            </a:r>
-          </a:p>
-          <a:p>
-            <a:pPr algn="l">
-              <a:lnSpc>
-                <a:spcPct val="115000"/>
-              </a:lnSpc>
-            </a:pPr>
-            <a:r>
-              <a:rPr sz="1700" b="0">
-                <a:solidFill>
-                  <a:srgbClr val="263044"/>
-                </a:solidFill>
-                <a:latin typeface="Malgun Gothic"/>
-                <a:ea typeface="Malgun Gothic"/>
-              </a:rPr>
-              <a:t>[5] Es et al., RAGAs, EACL 2024</a:t>
+              <a:t>[4] Li et al., SCD, AAAI 2026      [5] Es et al., RAGAs, EACL 2024</a:t>
             </a:r>
           </a:p>
         </p:txBody>

</xml_diff>

<commit_message>
Put the poster references on one full-width line
Co-Authored-By: Claude Opus 5.5 <noreply@anthropic.com>
</commit_message>
<xml_diff>
--- a/FINALDOCS/POSTER/FINAL/M_RAG_A1_FINAL_EDITABLE.pptx
+++ b/FINALDOCS/POSTER/FINAL/M_RAG_A1_FINAL_EDITABLE.pptx
@@ -17352,7 +17352,7 @@
         <p:spPr>
           <a:xfrm>
             <a:off x="792000" y="21099351"/>
-            <a:ext cx="19800000" cy="5292166"/>
+            <a:ext cx="19800000" cy="5565899"/>
           </a:xfrm>
           <a:prstGeom prst="rect">
             <a:avLst/>
@@ -17367,7 +17367,7 @@
         </p:nvSpPr>
         <p:spPr>
           <a:xfrm>
-            <a:off x="792000" y="26427517"/>
+            <a:off x="792000" y="26701250"/>
             <a:ext cx="19800000" cy="318536"/>
           </a:xfrm>
           <a:prstGeom prst="rect">
@@ -17407,7 +17407,7 @@
         </p:nvSpPr>
         <p:spPr>
           <a:xfrm>
-            <a:off x="792000" y="26908053"/>
+            <a:off x="792000" y="27181786"/>
             <a:ext cx="9612000" cy="468000"/>
           </a:xfrm>
           <a:prstGeom prst="rect">
@@ -17451,7 +17451,7 @@
         </p:nvSpPr>
         <p:spPr>
           <a:xfrm>
-            <a:off x="936000" y="26933253"/>
+            <a:off x="936000" y="27206986"/>
             <a:ext cx="9324000" cy="360000"/>
           </a:xfrm>
           <a:prstGeom prst="rect">
@@ -17491,7 +17491,7 @@
         </p:nvSpPr>
         <p:spPr>
           <a:xfrm>
-            <a:off x="792000" y="27520053"/>
+            <a:off x="792000" y="27793786"/>
             <a:ext cx="9612000" cy="335301"/>
           </a:xfrm>
           <a:prstGeom prst="rect">
@@ -17531,7 +17531,7 @@
         </p:nvSpPr>
         <p:spPr>
           <a:xfrm>
-            <a:off x="792000" y="27945354"/>
+            <a:off x="792000" y="28219087"/>
             <a:ext cx="9612000" cy="335301"/>
           </a:xfrm>
           <a:prstGeom prst="rect">
@@ -17571,7 +17571,7 @@
         </p:nvSpPr>
         <p:spPr>
           <a:xfrm>
-            <a:off x="792000" y="28370656"/>
+            <a:off x="792000" y="28644389"/>
             <a:ext cx="9612000" cy="335301"/>
           </a:xfrm>
           <a:prstGeom prst="rect">
@@ -17611,7 +17611,7 @@
         </p:nvSpPr>
         <p:spPr>
           <a:xfrm>
-            <a:off x="792000" y="28795957"/>
+            <a:off x="792000" y="29069690"/>
             <a:ext cx="9612000" cy="335301"/>
           </a:xfrm>
           <a:prstGeom prst="rect">
@@ -17651,7 +17651,7 @@
         </p:nvSpPr>
         <p:spPr>
           <a:xfrm>
-            <a:off x="10980000" y="26908053"/>
+            <a:off x="10980000" y="27181786"/>
             <a:ext cx="9612000" cy="468000"/>
           </a:xfrm>
           <a:prstGeom prst="rect">
@@ -17695,7 +17695,7 @@
         </p:nvSpPr>
         <p:spPr>
           <a:xfrm>
-            <a:off x="11124000" y="26933253"/>
+            <a:off x="11124000" y="27206986"/>
             <a:ext cx="9324000" cy="360000"/>
           </a:xfrm>
           <a:prstGeom prst="rect">
@@ -17735,7 +17735,7 @@
         </p:nvSpPr>
         <p:spPr>
           <a:xfrm>
-            <a:off x="10980000" y="27520053"/>
+            <a:off x="10980000" y="27793786"/>
             <a:ext cx="9612000" cy="335301"/>
           </a:xfrm>
           <a:prstGeom prst="rect">
@@ -17775,7 +17775,7 @@
         </p:nvSpPr>
         <p:spPr>
           <a:xfrm>
-            <a:off x="10980000" y="27945354"/>
+            <a:off x="10980000" y="28219087"/>
             <a:ext cx="9612000" cy="335301"/>
           </a:xfrm>
           <a:prstGeom prst="rect">
@@ -17815,7 +17815,7 @@
         </p:nvSpPr>
         <p:spPr>
           <a:xfrm>
-            <a:off x="10980000" y="28370656"/>
+            <a:off x="10980000" y="28644389"/>
             <a:ext cx="9612000" cy="335301"/>
           </a:xfrm>
           <a:prstGeom prst="rect">
@@ -17855,7 +17855,7 @@
         </p:nvSpPr>
         <p:spPr>
           <a:xfrm>
-            <a:off x="10980000" y="28795957"/>
+            <a:off x="10980000" y="29069690"/>
             <a:ext cx="9612000" cy="335301"/>
           </a:xfrm>
           <a:prstGeom prst="rect">
@@ -17895,8 +17895,8 @@
         </p:nvSpPr>
         <p:spPr>
           <a:xfrm>
-            <a:off x="792000" y="29329258"/>
-            <a:ext cx="19800000" cy="576000"/>
+            <a:off x="792000" y="29602991"/>
+            <a:ext cx="19800000" cy="324000"/>
           </a:xfrm>
           <a:prstGeom prst="rect">
             <a:avLst/>
@@ -17922,24 +17922,7 @@
                 <a:latin typeface="Malgun Gothic"/>
                 <a:ea typeface="Malgun Gothic"/>
               </a:rPr>
-              <a:t>[1] Lewis et al., RAG, NeurIPS 2020      [2] Gao et al., HyDE, ACL 2023      [3] Shi et al., CAD, NAACL 2024</a:t>
-            </a:r>
-          </a:p>
-          <a:p>
-            <a:pPr algn="l">
-              <a:lnSpc>
-                <a:spcPct val="115000"/>
-              </a:lnSpc>
-            </a:pPr>
-            <a:r>
-              <a:rPr sz="1700" b="0">
-                <a:solidFill>
-                  <a:srgbClr val="263044"/>
-                </a:solidFill>
-                <a:latin typeface="Malgun Gothic"/>
-                <a:ea typeface="Malgun Gothic"/>
-              </a:rPr>
-              <a:t>[4] Li et al., SCD, AAAI 2026      [5] Es et al., RAGAs, EACL 2024</a:t>
+              <a:t>[1] Lewis et al., RAG, NeurIPS 2020   [2] Gao et al., HyDE, ACL 2023   [3] Shi et al., CAD, NAACL 2024   [4] Li et al., SCD, AAAI 2026   [5] Es et al., RAGAs, EACL 2024</a:t>
             </a:r>
           </a:p>
         </p:txBody>

</xml_diff>

<commit_message>
Restore poster metric definitions and drop the answer-case section
Professor feedback (2026-10-27): the poster must say what each metric
measures and whether higher is better, and the answer-case bullets were
hard to read. Section 04 now pairs the question and evaluation notes
with a definition table (thesis 5.2) whose five metrics match the 05
result table in name and order, each with "높을수록" direction. Section
08 is removed and the conclusions take the right column beside the
parallel chart. The pipeline and example figures are unchanged, the 05
table keeps its 120 two-decimal values and bold rules, and the poster
checks now validate both tables.

Co-Authored-By: Claude Opus 5.5 <noreply@anthropic.com>
</commit_message>
<xml_diff>
--- a/FINALDOCS/POSTER/FINAL/M_RAG_A1_FINAL_EDITABLE.pptx
+++ b/FINALDOCS/POSTER/FINAL/M_RAG_A1_FINAL_EDITABLE.pptx
@@ -3941,7 +3941,7 @@
         </p:nvSpPr>
         <p:spPr>
           <a:xfrm>
-            <a:off x="792000" y="16545513"/>
+            <a:off x="792000" y="16527513"/>
             <a:ext cx="9612000" cy="335301"/>
           </a:xfrm>
           <a:prstGeom prst="rect">
@@ -3981,7 +3981,7 @@
         </p:nvSpPr>
         <p:spPr>
           <a:xfrm>
-            <a:off x="792000" y="16970814"/>
+            <a:off x="792000" y="16934814"/>
             <a:ext cx="9612000" cy="335301"/>
           </a:xfrm>
           <a:prstGeom prst="rect">
@@ -4021,8 +4021,8 @@
         </p:nvSpPr>
         <p:spPr>
           <a:xfrm>
-            <a:off x="10980000" y="16120212"/>
-            <a:ext cx="9612000" cy="670602"/>
+            <a:off x="792000" y="17342115"/>
+            <a:ext cx="9612000" cy="335301"/>
           </a:xfrm>
           <a:prstGeom prst="rect">
             <a:avLst/>
@@ -4048,8 +4048,7 @@
                 <a:latin typeface="Malgun Gothic"/>
                 <a:ea typeface="Malgun Gothic"/>
               </a:rPr>
-              <a:t>- 답변 품질은 RAGAS의 근거 충실도, 답변 관련성,
-  문맥 정밀도, 문맥 재현율(0에서 1)</a:t>
+              <a:t>- 관측값은 모두 0에서 1, 앞의 네 지표는 RAGAS로 계산</a:t>
             </a:r>
           </a:p>
         </p:txBody>
@@ -4062,47 +4061,7 @@
         </p:nvSpPr>
         <p:spPr>
           <a:xfrm>
-            <a:off x="10980000" y="16880814"/>
-            <a:ext cx="9612000" cy="335301"/>
-          </a:xfrm>
-          <a:prstGeom prst="rect">
-            <a:avLst/>
-          </a:prstGeom>
-          <a:noFill/>
-        </p:spPr>
-        <p:txBody>
-          <a:bodyPr wrap="square" lIns="0" rIns="0" tIns="0" bIns="0">
-            <a:spAutoFit/>
-          </a:bodyPr>
-          <a:lstStyle/>
-          <a:p>
-            <a:pPr algn="l">
-              <a:lnSpc>
-                <a:spcPct val="115000"/>
-              </a:lnSpc>
-            </a:pPr>
-            <a:r>
-              <a:rPr sz="2000" b="0">
-                <a:solidFill>
-                  <a:srgbClr val="263044"/>
-                </a:solidFill>
-                <a:latin typeface="Malgun Gothic"/>
-                <a:ea typeface="Malgun Gothic"/>
-              </a:rPr>
-              <a:t>- 출력 언어는 한국어 문자 비율</a:t>
-            </a:r>
-          </a:p>
-        </p:txBody>
-      </p:sp>
-      <p:sp>
-        <p:nvSpPr>
-          <p:cNvPr id="27" name="TextBox 26"/>
-          <p:cNvSpPr txBox="1"/>
-          <p:nvPr/>
-        </p:nvSpPr>
-        <p:spPr>
-          <a:xfrm>
-            <a:off x="10980000" y="17306115"/>
+            <a:off x="792000" y="17749416"/>
             <a:ext cx="9612000" cy="670602"/>
           </a:xfrm>
           <a:prstGeom prst="rect">
@@ -4135,6 +4094,831 @@
           </a:p>
         </p:txBody>
       </p:sp>
+      <p:graphicFrame>
+        <p:nvGraphicFramePr>
+          <p:cNvPr id="27" name="Table 26"/>
+          <p:cNvGraphicFramePr>
+            <a:graphicFrameLocks noGrp="1"/>
+          </p:cNvGraphicFramePr>
+          <p:nvPr/>
+        </p:nvGraphicFramePr>
+        <p:xfrm>
+          <a:off x="10980000" y="16120212"/>
+          <a:ext cx="9611999" cy="2362299"/>
+        </p:xfrm>
+        <a:graphic>
+          <a:graphicData uri="http://schemas.openxmlformats.org/drawingml/2006/table">
+            <a:tbl>
+              <a:tblPr firstRow="0" bandRow="0">
+                <a:tableStyleId>{5940675A-B579-460E-94D1-54222C63F5DA}</a:tableStyleId>
+              </a:tblPr>
+              <a:tblGrid>
+                <a:gridCol w="1848461"/>
+                <a:gridCol w="5083269"/>
+                <a:gridCol w="2680269"/>
+              </a:tblGrid>
+              <a:tr h="349814">
+                <a:tc>
+                  <a:txBody>
+                    <a:bodyPr wrap="square"/>
+                    <a:lstStyle/>
+                    <a:p>
+                      <a:pPr algn="ctr"/>
+                      <a:r>
+                        <a:rPr sz="1700" b="1">
+                          <a:solidFill>
+                            <a:srgbClr val="263044"/>
+                          </a:solidFill>
+                          <a:latin typeface="Malgun Gothic"/>
+                        </a:rPr>
+                        <a:t>지표</a:t>
+                      </a:r>
+                    </a:p>
+                  </a:txBody>
+                  <a:tcPr marL="57600" marR="57600" marT="21600" marB="21600" anchor="ctr">
+                    <a:solidFill>
+                      <a:srgbClr val="FFFFFF"/>
+                    </a:solidFill>
+                    <a:lnL w="9525">
+                      <a:solidFill>
+                        <a:srgbClr val="777777"/>
+                      </a:solidFill>
+                    </a:lnL>
+                    <a:lnR w="9525">
+                      <a:solidFill>
+                        <a:srgbClr val="777777"/>
+                      </a:solidFill>
+                    </a:lnR>
+                    <a:lnT w="9525">
+                      <a:solidFill>
+                        <a:srgbClr val="777777"/>
+                      </a:solidFill>
+                    </a:lnT>
+                    <a:lnB w="9525">
+                      <a:solidFill>
+                        <a:srgbClr val="777777"/>
+                      </a:solidFill>
+                    </a:lnB>
+                  </a:tcPr>
+                </a:tc>
+                <a:tc>
+                  <a:txBody>
+                    <a:bodyPr wrap="square"/>
+                    <a:lstStyle/>
+                    <a:p>
+                      <a:pPr algn="ctr"/>
+                      <a:r>
+                        <a:rPr sz="1700" b="1">
+                          <a:solidFill>
+                            <a:srgbClr val="263044"/>
+                          </a:solidFill>
+                          <a:latin typeface="Malgun Gothic"/>
+                        </a:rPr>
+                        <a:t>측정 내용</a:t>
+                      </a:r>
+                    </a:p>
+                  </a:txBody>
+                  <a:tcPr marL="57600" marR="57600" marT="21600" marB="21600" anchor="ctr">
+                    <a:solidFill>
+                      <a:srgbClr val="FFFFFF"/>
+                    </a:solidFill>
+                    <a:lnL w="9525">
+                      <a:solidFill>
+                        <a:srgbClr val="777777"/>
+                      </a:solidFill>
+                    </a:lnL>
+                    <a:lnR w="9525">
+                      <a:solidFill>
+                        <a:srgbClr val="777777"/>
+                      </a:solidFill>
+                    </a:lnR>
+                    <a:lnT w="9525">
+                      <a:solidFill>
+                        <a:srgbClr val="777777"/>
+                      </a:solidFill>
+                    </a:lnT>
+                    <a:lnB w="9525">
+                      <a:solidFill>
+                        <a:srgbClr val="777777"/>
+                      </a:solidFill>
+                    </a:lnB>
+                  </a:tcPr>
+                </a:tc>
+                <a:tc>
+                  <a:txBody>
+                    <a:bodyPr wrap="square"/>
+                    <a:lstStyle/>
+                    <a:p>
+                      <a:pPr algn="ctr"/>
+                      <a:r>
+                        <a:rPr sz="1700" b="1">
+                          <a:solidFill>
+                            <a:srgbClr val="263044"/>
+                          </a:solidFill>
+                          <a:latin typeface="Malgun Gothic"/>
+                        </a:rPr>
+                        <a:t>값의 방향</a:t>
+                      </a:r>
+                    </a:p>
+                  </a:txBody>
+                  <a:tcPr marL="57600" marR="57600" marT="21600" marB="21600" anchor="ctr">
+                    <a:solidFill>
+                      <a:srgbClr val="FFFFFF"/>
+                    </a:solidFill>
+                    <a:lnL w="9525">
+                      <a:solidFill>
+                        <a:srgbClr val="777777"/>
+                      </a:solidFill>
+                    </a:lnL>
+                    <a:lnR w="9525">
+                      <a:solidFill>
+                        <a:srgbClr val="777777"/>
+                      </a:solidFill>
+                    </a:lnR>
+                    <a:lnT w="9525">
+                      <a:solidFill>
+                        <a:srgbClr val="777777"/>
+                      </a:solidFill>
+                    </a:lnT>
+                    <a:lnB w="9525">
+                      <a:solidFill>
+                        <a:srgbClr val="777777"/>
+                      </a:solidFill>
+                    </a:lnB>
+                  </a:tcPr>
+                </a:tc>
+              </a:tr>
+              <a:tr h="349814">
+                <a:tc>
+                  <a:txBody>
+                    <a:bodyPr wrap="square"/>
+                    <a:lstStyle/>
+                    <a:p>
+                      <a:pPr algn="l"/>
+                      <a:r>
+                        <a:rPr sz="1700" b="0">
+                          <a:solidFill>
+                            <a:srgbClr val="263044"/>
+                          </a:solidFill>
+                          <a:latin typeface="Malgun Gothic"/>
+                        </a:rPr>
+                        <a:t>근거 충실도</a:t>
+                      </a:r>
+                    </a:p>
+                  </a:txBody>
+                  <a:tcPr marL="57600" marR="57600" marT="21600" marB="21600" anchor="ctr">
+                    <a:solidFill>
+                      <a:srgbClr val="FFFFFF"/>
+                    </a:solidFill>
+                    <a:lnL w="9525">
+                      <a:solidFill>
+                        <a:srgbClr val="777777"/>
+                      </a:solidFill>
+                    </a:lnL>
+                    <a:lnR w="9525">
+                      <a:solidFill>
+                        <a:srgbClr val="777777"/>
+                      </a:solidFill>
+                    </a:lnR>
+                    <a:lnT w="9525">
+                      <a:solidFill>
+                        <a:srgbClr val="777777"/>
+                      </a:solidFill>
+                    </a:lnT>
+                    <a:lnB w="9525">
+                      <a:solidFill>
+                        <a:srgbClr val="777777"/>
+                      </a:solidFill>
+                    </a:lnB>
+                  </a:tcPr>
+                </a:tc>
+                <a:tc>
+                  <a:txBody>
+                    <a:bodyPr wrap="square"/>
+                    <a:lstStyle/>
+                    <a:p>
+                      <a:pPr algn="l"/>
+                      <a:r>
+                        <a:rPr sz="1700" b="0">
+                          <a:solidFill>
+                            <a:srgbClr val="263044"/>
+                          </a:solidFill>
+                          <a:latin typeface="Malgun Gothic"/>
+                        </a:rPr>
+                        <a:t>답변의 주장 중 검색 구간이 뒷받침하는 비율</a:t>
+                      </a:r>
+                    </a:p>
+                  </a:txBody>
+                  <a:tcPr marL="57600" marR="57600" marT="21600" marB="21600" anchor="ctr">
+                    <a:solidFill>
+                      <a:srgbClr val="FFFFFF"/>
+                    </a:solidFill>
+                    <a:lnL w="9525">
+                      <a:solidFill>
+                        <a:srgbClr val="777777"/>
+                      </a:solidFill>
+                    </a:lnL>
+                    <a:lnR w="9525">
+                      <a:solidFill>
+                        <a:srgbClr val="777777"/>
+                      </a:solidFill>
+                    </a:lnR>
+                    <a:lnT w="9525">
+                      <a:solidFill>
+                        <a:srgbClr val="777777"/>
+                      </a:solidFill>
+                    </a:lnT>
+                    <a:lnB w="9525">
+                      <a:solidFill>
+                        <a:srgbClr val="777777"/>
+                      </a:solidFill>
+                    </a:lnB>
+                  </a:tcPr>
+                </a:tc>
+                <a:tc>
+                  <a:txBody>
+                    <a:bodyPr wrap="square"/>
+                    <a:lstStyle/>
+                    <a:p>
+                      <a:pPr algn="l"/>
+                      <a:r>
+                        <a:rPr sz="1700" b="0">
+                          <a:solidFill>
+                            <a:srgbClr val="263044"/>
+                          </a:solidFill>
+                          <a:latin typeface="Malgun Gothic"/>
+                        </a:rPr>
+                        <a:t>높을수록 근거에 충실</a:t>
+                      </a:r>
+                    </a:p>
+                  </a:txBody>
+                  <a:tcPr marL="57600" marR="57600" marT="21600" marB="21600" anchor="ctr">
+                    <a:solidFill>
+                      <a:srgbClr val="FFFFFF"/>
+                    </a:solidFill>
+                    <a:lnL w="9525">
+                      <a:solidFill>
+                        <a:srgbClr val="777777"/>
+                      </a:solidFill>
+                    </a:lnL>
+                    <a:lnR w="9525">
+                      <a:solidFill>
+                        <a:srgbClr val="777777"/>
+                      </a:solidFill>
+                    </a:lnR>
+                    <a:lnT w="9525">
+                      <a:solidFill>
+                        <a:srgbClr val="777777"/>
+                      </a:solidFill>
+                    </a:lnT>
+                    <a:lnB w="9525">
+                      <a:solidFill>
+                        <a:srgbClr val="777777"/>
+                      </a:solidFill>
+                    </a:lnB>
+                  </a:tcPr>
+                </a:tc>
+              </a:tr>
+              <a:tr h="613229">
+                <a:tc>
+                  <a:txBody>
+                    <a:bodyPr wrap="square"/>
+                    <a:lstStyle/>
+                    <a:p>
+                      <a:pPr algn="l"/>
+                      <a:r>
+                        <a:rPr sz="1700" b="0">
+                          <a:solidFill>
+                            <a:srgbClr val="263044"/>
+                          </a:solidFill>
+                          <a:latin typeface="Malgun Gothic"/>
+                        </a:rPr>
+                        <a:t>답변 관련성</a:t>
+                      </a:r>
+                    </a:p>
+                  </a:txBody>
+                  <a:tcPr marL="57600" marR="57600" marT="21600" marB="21600" anchor="ctr">
+                    <a:solidFill>
+                      <a:srgbClr val="FFFFFF"/>
+                    </a:solidFill>
+                    <a:lnL w="9525">
+                      <a:solidFill>
+                        <a:srgbClr val="777777"/>
+                      </a:solidFill>
+                    </a:lnL>
+                    <a:lnR w="9525">
+                      <a:solidFill>
+                        <a:srgbClr val="777777"/>
+                      </a:solidFill>
+                    </a:lnR>
+                    <a:lnT w="9525">
+                      <a:solidFill>
+                        <a:srgbClr val="777777"/>
+                      </a:solidFill>
+                    </a:lnT>
+                    <a:lnB w="9525">
+                      <a:solidFill>
+                        <a:srgbClr val="777777"/>
+                      </a:solidFill>
+                    </a:lnB>
+                  </a:tcPr>
+                </a:tc>
+                <a:tc>
+                  <a:txBody>
+                    <a:bodyPr wrap="square"/>
+                    <a:lstStyle/>
+                    <a:p>
+                      <a:pPr algn="l"/>
+                      <a:r>
+                        <a:rPr sz="1700" b="0">
+                          <a:solidFill>
+                            <a:srgbClr val="263044"/>
+                          </a:solidFill>
+                          <a:latin typeface="Malgun Gothic"/>
+                        </a:rPr>
+                        <a:t>답변에서 역으로 만든 질문과 원래 질문의 유사도</a:t>
+                      </a:r>
+                    </a:p>
+                    <a:p>
+                      <a:pPr algn="l"/>
+                      <a:r>
+                        <a:rPr sz="1700" b="0">
+                          <a:solidFill>
+                            <a:srgbClr val="263044"/>
+                          </a:solidFill>
+                          <a:latin typeface="Malgun Gothic"/>
+                        </a:rPr>
+                        <a:t>모호하거나 회피하는 답변은 0</a:t>
+                      </a:r>
+                    </a:p>
+                  </a:txBody>
+                  <a:tcPr marL="57600" marR="57600" marT="21600" marB="21600" anchor="ctr">
+                    <a:solidFill>
+                      <a:srgbClr val="FFFFFF"/>
+                    </a:solidFill>
+                    <a:lnL w="9525">
+                      <a:solidFill>
+                        <a:srgbClr val="777777"/>
+                      </a:solidFill>
+                    </a:lnL>
+                    <a:lnR w="9525">
+                      <a:solidFill>
+                        <a:srgbClr val="777777"/>
+                      </a:solidFill>
+                    </a:lnR>
+                    <a:lnT w="9525">
+                      <a:solidFill>
+                        <a:srgbClr val="777777"/>
+                      </a:solidFill>
+                    </a:lnT>
+                    <a:lnB w="9525">
+                      <a:solidFill>
+                        <a:srgbClr val="777777"/>
+                      </a:solidFill>
+                    </a:lnB>
+                  </a:tcPr>
+                </a:tc>
+                <a:tc>
+                  <a:txBody>
+                    <a:bodyPr wrap="square"/>
+                    <a:lstStyle/>
+                    <a:p>
+                      <a:pPr algn="l"/>
+                      <a:r>
+                        <a:rPr sz="1700" b="0">
+                          <a:solidFill>
+                            <a:srgbClr val="263044"/>
+                          </a:solidFill>
+                          <a:latin typeface="Malgun Gothic"/>
+                        </a:rPr>
+                        <a:t>높을수록 질문에 부합</a:t>
+                      </a:r>
+                    </a:p>
+                  </a:txBody>
+                  <a:tcPr marL="57600" marR="57600" marT="21600" marB="21600" anchor="ctr">
+                    <a:solidFill>
+                      <a:srgbClr val="FFFFFF"/>
+                    </a:solidFill>
+                    <a:lnL w="9525">
+                      <a:solidFill>
+                        <a:srgbClr val="777777"/>
+                      </a:solidFill>
+                    </a:lnL>
+                    <a:lnR w="9525">
+                      <a:solidFill>
+                        <a:srgbClr val="777777"/>
+                      </a:solidFill>
+                    </a:lnR>
+                    <a:lnT w="9525">
+                      <a:solidFill>
+                        <a:srgbClr val="777777"/>
+                      </a:solidFill>
+                    </a:lnT>
+                    <a:lnB w="9525">
+                      <a:solidFill>
+                        <a:srgbClr val="777777"/>
+                      </a:solidFill>
+                    </a:lnB>
+                  </a:tcPr>
+                </a:tc>
+              </a:tr>
+              <a:tr h="349814">
+                <a:tc>
+                  <a:txBody>
+                    <a:bodyPr wrap="square"/>
+                    <a:lstStyle/>
+                    <a:p>
+                      <a:pPr algn="l"/>
+                      <a:r>
+                        <a:rPr sz="1700" b="0">
+                          <a:solidFill>
+                            <a:srgbClr val="263044"/>
+                          </a:solidFill>
+                          <a:latin typeface="Malgun Gothic"/>
+                        </a:rPr>
+                        <a:t>문맥 정밀도</a:t>
+                      </a:r>
+                    </a:p>
+                  </a:txBody>
+                  <a:tcPr marL="57600" marR="57600" marT="21600" marB="21600" anchor="ctr">
+                    <a:solidFill>
+                      <a:srgbClr val="FFFFFF"/>
+                    </a:solidFill>
+                    <a:lnL w="9525">
+                      <a:solidFill>
+                        <a:srgbClr val="777777"/>
+                      </a:solidFill>
+                    </a:lnL>
+                    <a:lnR w="9525">
+                      <a:solidFill>
+                        <a:srgbClr val="777777"/>
+                      </a:solidFill>
+                    </a:lnR>
+                    <a:lnT w="9525">
+                      <a:solidFill>
+                        <a:srgbClr val="777777"/>
+                      </a:solidFill>
+                    </a:lnT>
+                    <a:lnB w="9525">
+                      <a:solidFill>
+                        <a:srgbClr val="777777"/>
+                      </a:solidFill>
+                    </a:lnB>
+                  </a:tcPr>
+                </a:tc>
+                <a:tc>
+                  <a:txBody>
+                    <a:bodyPr wrap="square"/>
+                    <a:lstStyle/>
+                    <a:p>
+                      <a:pPr algn="l"/>
+                      <a:r>
+                        <a:rPr sz="1700" b="0">
+                          <a:solidFill>
+                            <a:srgbClr val="263044"/>
+                          </a:solidFill>
+                          <a:latin typeface="Malgun Gothic"/>
+                        </a:rPr>
+                        <a:t>참조 답변에 유용한 구간의 순위가 높은 정도</a:t>
+                      </a:r>
+                    </a:p>
+                  </a:txBody>
+                  <a:tcPr marL="57600" marR="57600" marT="21600" marB="21600" anchor="ctr">
+                    <a:solidFill>
+                      <a:srgbClr val="FFFFFF"/>
+                    </a:solidFill>
+                    <a:lnL w="9525">
+                      <a:solidFill>
+                        <a:srgbClr val="777777"/>
+                      </a:solidFill>
+                    </a:lnL>
+                    <a:lnR w="9525">
+                      <a:solidFill>
+                        <a:srgbClr val="777777"/>
+                      </a:solidFill>
+                    </a:lnR>
+                    <a:lnT w="9525">
+                      <a:solidFill>
+                        <a:srgbClr val="777777"/>
+                      </a:solidFill>
+                    </a:lnT>
+                    <a:lnB w="9525">
+                      <a:solidFill>
+                        <a:srgbClr val="777777"/>
+                      </a:solidFill>
+                    </a:lnB>
+                  </a:tcPr>
+                </a:tc>
+                <a:tc>
+                  <a:txBody>
+                    <a:bodyPr wrap="square"/>
+                    <a:lstStyle/>
+                    <a:p>
+                      <a:pPr algn="l"/>
+                      <a:r>
+                        <a:rPr sz="1700" b="0">
+                          <a:solidFill>
+                            <a:srgbClr val="263044"/>
+                          </a:solidFill>
+                          <a:latin typeface="Malgun Gothic"/>
+                        </a:rPr>
+                        <a:t>높을수록 순위가 적절</a:t>
+                      </a:r>
+                    </a:p>
+                  </a:txBody>
+                  <a:tcPr marL="57600" marR="57600" marT="21600" marB="21600" anchor="ctr">
+                    <a:solidFill>
+                      <a:srgbClr val="FFFFFF"/>
+                    </a:solidFill>
+                    <a:lnL w="9525">
+                      <a:solidFill>
+                        <a:srgbClr val="777777"/>
+                      </a:solidFill>
+                    </a:lnL>
+                    <a:lnR w="9525">
+                      <a:solidFill>
+                        <a:srgbClr val="777777"/>
+                      </a:solidFill>
+                    </a:lnR>
+                    <a:lnT w="9525">
+                      <a:solidFill>
+                        <a:srgbClr val="777777"/>
+                      </a:solidFill>
+                    </a:lnT>
+                    <a:lnB w="9525">
+                      <a:solidFill>
+                        <a:srgbClr val="777777"/>
+                      </a:solidFill>
+                    </a:lnB>
+                  </a:tcPr>
+                </a:tc>
+              </a:tr>
+              <a:tr h="349814">
+                <a:tc>
+                  <a:txBody>
+                    <a:bodyPr wrap="square"/>
+                    <a:lstStyle/>
+                    <a:p>
+                      <a:pPr algn="l"/>
+                      <a:r>
+                        <a:rPr sz="1700" b="0">
+                          <a:solidFill>
+                            <a:srgbClr val="263044"/>
+                          </a:solidFill>
+                          <a:latin typeface="Malgun Gothic"/>
+                        </a:rPr>
+                        <a:t>문맥 재현율</a:t>
+                      </a:r>
+                    </a:p>
+                  </a:txBody>
+                  <a:tcPr marL="57600" marR="57600" marT="21600" marB="21600" anchor="ctr">
+                    <a:solidFill>
+                      <a:srgbClr val="FFFFFF"/>
+                    </a:solidFill>
+                    <a:lnL w="9525">
+                      <a:solidFill>
+                        <a:srgbClr val="777777"/>
+                      </a:solidFill>
+                    </a:lnL>
+                    <a:lnR w="9525">
+                      <a:solidFill>
+                        <a:srgbClr val="777777"/>
+                      </a:solidFill>
+                    </a:lnR>
+                    <a:lnT w="9525">
+                      <a:solidFill>
+                        <a:srgbClr val="777777"/>
+                      </a:solidFill>
+                    </a:lnT>
+                    <a:lnB w="9525">
+                      <a:solidFill>
+                        <a:srgbClr val="777777"/>
+                      </a:solidFill>
+                    </a:lnB>
+                  </a:tcPr>
+                </a:tc>
+                <a:tc>
+                  <a:txBody>
+                    <a:bodyPr wrap="square"/>
+                    <a:lstStyle/>
+                    <a:p>
+                      <a:pPr algn="l"/>
+                      <a:r>
+                        <a:rPr sz="1700" b="0">
+                          <a:solidFill>
+                            <a:srgbClr val="263044"/>
+                          </a:solidFill>
+                          <a:latin typeface="Malgun Gothic"/>
+                        </a:rPr>
+                        <a:t>참조 답변의 주장을 검색 구간이 뒷받침하는 비율</a:t>
+                      </a:r>
+                    </a:p>
+                  </a:txBody>
+                  <a:tcPr marL="57600" marR="57600" marT="21600" marB="21600" anchor="ctr">
+                    <a:solidFill>
+                      <a:srgbClr val="FFFFFF"/>
+                    </a:solidFill>
+                    <a:lnL w="9525">
+                      <a:solidFill>
+                        <a:srgbClr val="777777"/>
+                      </a:solidFill>
+                    </a:lnL>
+                    <a:lnR w="9525">
+                      <a:solidFill>
+                        <a:srgbClr val="777777"/>
+                      </a:solidFill>
+                    </a:lnR>
+                    <a:lnT w="9525">
+                      <a:solidFill>
+                        <a:srgbClr val="777777"/>
+                      </a:solidFill>
+                    </a:lnT>
+                    <a:lnB w="9525">
+                      <a:solidFill>
+                        <a:srgbClr val="777777"/>
+                      </a:solidFill>
+                    </a:lnB>
+                  </a:tcPr>
+                </a:tc>
+                <a:tc>
+                  <a:txBody>
+                    <a:bodyPr wrap="square"/>
+                    <a:lstStyle/>
+                    <a:p>
+                      <a:pPr algn="l"/>
+                      <a:r>
+                        <a:rPr sz="1700" b="0">
+                          <a:solidFill>
+                            <a:srgbClr val="263044"/>
+                          </a:solidFill>
+                          <a:latin typeface="Malgun Gothic"/>
+                        </a:rPr>
+                        <a:t>높을수록 정답 근거 확보</a:t>
+                      </a:r>
+                    </a:p>
+                  </a:txBody>
+                  <a:tcPr marL="57600" marR="57600" marT="21600" marB="21600" anchor="ctr">
+                    <a:solidFill>
+                      <a:srgbClr val="FFFFFF"/>
+                    </a:solidFill>
+                    <a:lnL w="9525">
+                      <a:solidFill>
+                        <a:srgbClr val="777777"/>
+                      </a:solidFill>
+                    </a:lnL>
+                    <a:lnR w="9525">
+                      <a:solidFill>
+                        <a:srgbClr val="777777"/>
+                      </a:solidFill>
+                    </a:lnR>
+                    <a:lnT w="9525">
+                      <a:solidFill>
+                        <a:srgbClr val="777777"/>
+                      </a:solidFill>
+                    </a:lnT>
+                    <a:lnB w="9525">
+                      <a:solidFill>
+                        <a:srgbClr val="777777"/>
+                      </a:solidFill>
+                    </a:lnB>
+                  </a:tcPr>
+                </a:tc>
+              </a:tr>
+              <a:tr h="349814">
+                <a:tc>
+                  <a:txBody>
+                    <a:bodyPr wrap="square"/>
+                    <a:lstStyle/>
+                    <a:p>
+                      <a:pPr algn="l"/>
+                      <a:r>
+                        <a:rPr sz="1700" b="0">
+                          <a:solidFill>
+                            <a:srgbClr val="263044"/>
+                          </a:solidFill>
+                          <a:latin typeface="Malgun Gothic"/>
+                        </a:rPr>
+                        <a:t>한국어 문자 비율</a:t>
+                      </a:r>
+                    </a:p>
+                  </a:txBody>
+                  <a:tcPr marL="57600" marR="57600" marT="21600" marB="21600" anchor="ctr">
+                    <a:solidFill>
+                      <a:srgbClr val="FFFFFF"/>
+                    </a:solidFill>
+                    <a:lnL w="9525">
+                      <a:solidFill>
+                        <a:srgbClr val="777777"/>
+                      </a:solidFill>
+                    </a:lnL>
+                    <a:lnR w="9525">
+                      <a:solidFill>
+                        <a:srgbClr val="777777"/>
+                      </a:solidFill>
+                    </a:lnR>
+                    <a:lnT w="9525">
+                      <a:solidFill>
+                        <a:srgbClr val="777777"/>
+                      </a:solidFill>
+                    </a:lnT>
+                    <a:lnB w="9525">
+                      <a:solidFill>
+                        <a:srgbClr val="777777"/>
+                      </a:solidFill>
+                    </a:lnB>
+                  </a:tcPr>
+                </a:tc>
+                <a:tc>
+                  <a:txBody>
+                    <a:bodyPr wrap="square"/>
+                    <a:lstStyle/>
+                    <a:p>
+                      <a:pPr algn="l"/>
+                      <a:r>
+                        <a:rPr sz="1700" b="0">
+                          <a:solidFill>
+                            <a:srgbClr val="263044"/>
+                          </a:solidFill>
+                          <a:latin typeface="Malgun Gothic"/>
+                        </a:rPr>
+                        <a:t>출력 언어, 한글 ÷ (한글 + ASCII 영문자)</a:t>
+                      </a:r>
+                    </a:p>
+                  </a:txBody>
+                  <a:tcPr marL="57600" marR="57600" marT="21600" marB="21600" anchor="ctr">
+                    <a:solidFill>
+                      <a:srgbClr val="FFFFFF"/>
+                    </a:solidFill>
+                    <a:lnL w="9525">
+                      <a:solidFill>
+                        <a:srgbClr val="777777"/>
+                      </a:solidFill>
+                    </a:lnL>
+                    <a:lnR w="9525">
+                      <a:solidFill>
+                        <a:srgbClr val="777777"/>
+                      </a:solidFill>
+                    </a:lnR>
+                    <a:lnT w="9525">
+                      <a:solidFill>
+                        <a:srgbClr val="777777"/>
+                      </a:solidFill>
+                    </a:lnT>
+                    <a:lnB w="9525">
+                      <a:solidFill>
+                        <a:srgbClr val="777777"/>
+                      </a:solidFill>
+                    </a:lnB>
+                  </a:tcPr>
+                </a:tc>
+                <a:tc>
+                  <a:txBody>
+                    <a:bodyPr wrap="square"/>
+                    <a:lstStyle/>
+                    <a:p>
+                      <a:pPr algn="l"/>
+                      <a:r>
+                        <a:rPr sz="1700" b="0">
+                          <a:solidFill>
+                            <a:srgbClr val="263044"/>
+                          </a:solidFill>
+                          <a:latin typeface="Malgun Gothic"/>
+                        </a:rPr>
+                        <a:t>높을수록 한국어 출력</a:t>
+                      </a:r>
+                    </a:p>
+                  </a:txBody>
+                  <a:tcPr marL="57600" marR="57600" marT="21600" marB="21600" anchor="ctr">
+                    <a:solidFill>
+                      <a:srgbClr val="FFFFFF"/>
+                    </a:solidFill>
+                    <a:lnL w="9525">
+                      <a:solidFill>
+                        <a:srgbClr val="777777"/>
+                      </a:solidFill>
+                    </a:lnL>
+                    <a:lnR w="9525">
+                      <a:solidFill>
+                        <a:srgbClr val="777777"/>
+                      </a:solidFill>
+                    </a:lnR>
+                    <a:lnT w="9525">
+                      <a:solidFill>
+                        <a:srgbClr val="777777"/>
+                      </a:solidFill>
+                    </a:lnT>
+                    <a:lnB w="9525">
+                      <a:solidFill>
+                        <a:srgbClr val="777777"/>
+                      </a:solidFill>
+                    </a:lnB>
+                  </a:tcPr>
+                </a:tc>
+              </a:tr>
+            </a:tbl>
+          </a:graphicData>
+        </a:graphic>
+      </p:graphicFrame>
       <p:sp>
         <p:nvSpPr>
           <p:cNvPr id="28" name="Rectangle 27"/>
@@ -4143,7 +4927,7 @@
         </p:nvSpPr>
         <p:spPr>
           <a:xfrm>
-            <a:off x="792000" y="18210717"/>
+            <a:off x="792000" y="18636018"/>
             <a:ext cx="19800000" cy="468000"/>
           </a:xfrm>
           <a:prstGeom prst="rect">
@@ -4187,7 +4971,7 @@
         </p:nvSpPr>
         <p:spPr>
           <a:xfrm>
-            <a:off x="936000" y="18235917"/>
+            <a:off x="936000" y="18661218"/>
             <a:ext cx="19512000" cy="360000"/>
           </a:xfrm>
           <a:prstGeom prst="rect">
@@ -4228,7 +5012,7 @@
           <p:nvPr/>
         </p:nvGraphicFramePr>
         <p:xfrm>
-          <a:off x="792000" y="18822717"/>
+          <a:off x="792000" y="19248018"/>
           <a:ext cx="19799991" cy="3761555"/>
         </p:xfrm>
         <a:graphic>
@@ -11227,7 +12011,7 @@
         </p:nvSpPr>
         <p:spPr>
           <a:xfrm>
-            <a:off x="792000" y="22692278"/>
+            <a:off x="792000" y="23117579"/>
             <a:ext cx="19800000" cy="318536"/>
           </a:xfrm>
           <a:prstGeom prst="rect">
@@ -11267,7 +12051,7 @@
         </p:nvSpPr>
         <p:spPr>
           <a:xfrm>
-            <a:off x="792000" y="23100814"/>
+            <a:off x="792000" y="23526115"/>
             <a:ext cx="19800000" cy="318536"/>
           </a:xfrm>
           <a:prstGeom prst="rect">
@@ -11307,7 +12091,7 @@
         </p:nvSpPr>
         <p:spPr>
           <a:xfrm>
-            <a:off x="10980000" y="23653350"/>
+            <a:off x="10980000" y="24078651"/>
             <a:ext cx="9612000" cy="468000"/>
           </a:xfrm>
           <a:prstGeom prst="rect">
@@ -11351,7 +12135,7 @@
         </p:nvSpPr>
         <p:spPr>
           <a:xfrm>
-            <a:off x="11124000" y="23678550"/>
+            <a:off x="11124000" y="24103851"/>
             <a:ext cx="9324000" cy="360000"/>
           </a:xfrm>
           <a:prstGeom prst="rect">
@@ -11391,8 +12175,8 @@
         </p:nvSpPr>
         <p:spPr>
           <a:xfrm>
-            <a:off x="10980000" y="24265350"/>
-            <a:ext cx="9612000" cy="352066"/>
+            <a:off x="10980000" y="24762651"/>
+            <a:ext cx="9612000" cy="804722"/>
           </a:xfrm>
           <a:prstGeom prst="rect">
             <a:avLst/>
@@ -11411,14 +12195,15 @@
               </a:lnSpc>
             </a:pPr>
             <a:r>
-              <a:rPr sz="2100" b="0">
+              <a:rPr sz="2400" b="0">
                 <a:solidFill>
                   <a:srgbClr val="263044"/>
                 </a:solidFill>
                 <a:latin typeface="Malgun Gothic"/>
                 <a:ea typeface="Malgun Gothic"/>
               </a:rPr>
-              <a:t>- 관련성과 응답 시간이 중요하면 HyDE 하나(개념과 결과 질문 포함)</a:t>
+              <a:t>- 관련성과 응답 시간이 중요하면 HyDE 하나
+  (개념과 결과 질문 포함)</a:t>
             </a:r>
           </a:p>
         </p:txBody>
@@ -11431,8 +12216,8 @@
         </p:nvSpPr>
         <p:spPr>
           <a:xfrm>
-            <a:off x="10980000" y="24828318"/>
-            <a:ext cx="9612000" cy="352066"/>
+            <a:off x="10980000" y="26071374"/>
+            <a:ext cx="9612000" cy="402361"/>
           </a:xfrm>
           <a:prstGeom prst="rect">
             <a:avLst/>
@@ -11451,7 +12236,7 @@
               </a:lnSpc>
             </a:pPr>
             <a:r>
-              <a:rPr sz="2100" b="0">
+              <a:rPr sz="2400" b="0">
                 <a:solidFill>
                   <a:srgbClr val="263044"/>
                 </a:solidFill>
@@ -11471,8 +12256,8 @@
         </p:nvSpPr>
         <p:spPr>
           <a:xfrm>
-            <a:off x="10980000" y="25391287"/>
-            <a:ext cx="9612000" cy="352066"/>
+            <a:off x="10980000" y="26977735"/>
+            <a:ext cx="9612000" cy="402361"/>
           </a:xfrm>
           <a:prstGeom prst="rect">
             <a:avLst/>
@@ -11491,7 +12276,7 @@
               </a:lnSpc>
             </a:pPr>
             <a:r>
-              <a:rPr sz="2100" b="0">
+              <a:rPr sz="2400" b="0">
                 <a:solidFill>
                   <a:srgbClr val="263044"/>
                 </a:solidFill>
@@ -11511,8 +12296,8 @@
         </p:nvSpPr>
         <p:spPr>
           <a:xfrm>
-            <a:off x="10980000" y="25954255"/>
-            <a:ext cx="9612000" cy="352066"/>
+            <a:off x="10980000" y="27884096"/>
+            <a:ext cx="9612000" cy="804722"/>
           </a:xfrm>
           <a:prstGeom prst="rect">
             <a:avLst/>
@@ -11531,14 +12316,15 @@
               </a:lnSpc>
             </a:pPr>
             <a:r>
-              <a:rPr sz="2100" b="0">
+              <a:rPr sz="2400" b="0">
                 <a:solidFill>
                   <a:srgbClr val="263044"/>
                 </a:solidFill>
                 <a:latin typeface="Malgun Gothic"/>
                 <a:ea typeface="Malgun Gothic"/>
               </a:rPr>
-              <a:t>- 조합은 HyDE 단독보다 관련성이 낮고 일관된 이득은 SCD의 한국어 비율</a:t>
+              <a:t>- 조합은 HyDE 단독보다 관련성이 낮고
+  일관된 이득은 SCD의 한국어 비율</a:t>
             </a:r>
           </a:p>
         </p:txBody>
@@ -11551,7 +12337,7 @@
         </p:nvSpPr>
         <p:spPr>
           <a:xfrm>
-            <a:off x="10980000" y="26728126"/>
+            <a:off x="792000" y="24078651"/>
             <a:ext cx="9612000" cy="468000"/>
           </a:xfrm>
           <a:prstGeom prst="rect">
@@ -11595,251 +12381,7 @@
         </p:nvSpPr>
         <p:spPr>
           <a:xfrm>
-            <a:off x="11124000" y="26753326"/>
-            <a:ext cx="9324000" cy="360000"/>
-          </a:xfrm>
-          <a:prstGeom prst="rect">
-            <a:avLst/>
-          </a:prstGeom>
-          <a:noFill/>
-        </p:spPr>
-        <p:txBody>
-          <a:bodyPr wrap="square" lIns="0" rIns="0" tIns="0" bIns="0">
-            <a:spAutoFit/>
-          </a:bodyPr>
-          <a:lstStyle/>
-          <a:p>
-            <a:pPr algn="l">
-              <a:lnSpc>
-                <a:spcPct val="115000"/>
-              </a:lnSpc>
-            </a:pPr>
-            <a:r>
-              <a:rPr sz="2700" b="1">
-                <a:solidFill>
-                  <a:srgbClr val="FFFFFF"/>
-                </a:solidFill>
-                <a:latin typeface="Malgun Gothic"/>
-                <a:ea typeface="Malgun Gothic"/>
-              </a:rPr>
-              <a:t>08 실제 답변에서 확인한 점</a:t>
-            </a:r>
-          </a:p>
-        </p:txBody>
-      </p:sp>
-      <p:sp>
-        <p:nvSpPr>
-          <p:cNvPr id="41" name="TextBox 40"/>
-          <p:cNvSpPr txBox="1"/>
-          <p:nvPr/>
-        </p:nvSpPr>
-        <p:spPr>
-          <a:xfrm>
-            <a:off x="10980000" y="27340126"/>
-            <a:ext cx="9612000" cy="352066"/>
-          </a:xfrm>
-          <a:prstGeom prst="rect">
-            <a:avLst/>
-          </a:prstGeom>
-          <a:noFill/>
-        </p:spPr>
-        <p:txBody>
-          <a:bodyPr wrap="square" lIns="0" rIns="0" tIns="0" bIns="0">
-            <a:spAutoFit/>
-          </a:bodyPr>
-          <a:lstStyle/>
-          <a:p>
-            <a:pPr algn="l">
-              <a:lnSpc>
-                <a:spcPct val="115000"/>
-              </a:lnSpc>
-            </a:pPr>
-            <a:r>
-              <a:rPr sz="2100" b="0">
-                <a:solidFill>
-                  <a:srgbClr val="263044"/>
-                </a:solidFill>
-                <a:latin typeface="Malgun Gothic"/>
-                <a:ea typeface="Malgun Gothic"/>
-              </a:rPr>
-              <a:t>- BIC 질문은 HyDE가 근거 구간을 찾아 관련성이 0.00에서 0.89로 오름</a:t>
-            </a:r>
-          </a:p>
-        </p:txBody>
-      </p:sp>
-      <p:sp>
-        <p:nvSpPr>
-          <p:cNvPr id="42" name="TextBox 41"/>
-          <p:cNvSpPr txBox="1"/>
-          <p:nvPr/>
-        </p:nvSpPr>
-        <p:spPr>
-          <a:xfrm>
-            <a:off x="10980000" y="27903094"/>
-            <a:ext cx="9612000" cy="352066"/>
-          </a:xfrm>
-          <a:prstGeom prst="rect">
-            <a:avLst/>
-          </a:prstGeom>
-          <a:noFill/>
-        </p:spPr>
-        <p:txBody>
-          <a:bodyPr wrap="square" lIns="0" rIns="0" tIns="0" bIns="0">
-            <a:spAutoFit/>
-          </a:bodyPr>
-          <a:lstStyle/>
-          <a:p>
-            <a:pPr algn="l">
-              <a:lnSpc>
-                <a:spcPct val="115000"/>
-              </a:lnSpc>
-            </a:pPr>
-            <a:r>
-              <a:rPr sz="2100" b="0">
-                <a:solidFill>
-                  <a:srgbClr val="263044"/>
-                </a:solidFill>
-                <a:latin typeface="Malgun Gothic"/>
-                <a:ea typeface="Malgun Gothic"/>
-              </a:rPr>
-              <a:t>- QuALITY 질문은 HyDE 후 73.68이 빠져 관련성이 0.87에서 0.00으로 내림</a:t>
-            </a:r>
-          </a:p>
-        </p:txBody>
-      </p:sp>
-      <p:sp>
-        <p:nvSpPr>
-          <p:cNvPr id="43" name="TextBox 42"/>
-          <p:cNvSpPr txBox="1"/>
-          <p:nvPr/>
-        </p:nvSpPr>
-        <p:spPr>
-          <a:xfrm>
-            <a:off x="10980000" y="28466063"/>
-            <a:ext cx="9612000" cy="352066"/>
-          </a:xfrm>
-          <a:prstGeom prst="rect">
-            <a:avLst/>
-          </a:prstGeom>
-          <a:noFill/>
-        </p:spPr>
-        <p:txBody>
-          <a:bodyPr wrap="square" lIns="0" rIns="0" tIns="0" bIns="0">
-            <a:spAutoFit/>
-          </a:bodyPr>
-          <a:lstStyle/>
-          <a:p>
-            <a:pPr algn="l">
-              <a:lnSpc>
-                <a:spcPct val="115000"/>
-              </a:lnSpc>
-            </a:pPr>
-            <a:r>
-              <a:rPr sz="2100" b="0">
-                <a:solidFill>
-                  <a:srgbClr val="263044"/>
-                </a:solidFill>
-                <a:latin typeface="Malgun Gothic"/>
-                <a:ea typeface="Malgun Gothic"/>
-              </a:rPr>
-              <a:t>- XSUM 질문은 CAD가 다른 행 수치를 옮겼는데 충실도가 0.53에서 0.87로 오름</a:t>
-            </a:r>
-          </a:p>
-        </p:txBody>
-      </p:sp>
-      <p:sp>
-        <p:nvSpPr>
-          <p:cNvPr id="44" name="TextBox 43"/>
-          <p:cNvSpPr txBox="1"/>
-          <p:nvPr/>
-        </p:nvSpPr>
-        <p:spPr>
-          <a:xfrm>
-            <a:off x="10980000" y="29029031"/>
-            <a:ext cx="9612000" cy="352066"/>
-          </a:xfrm>
-          <a:prstGeom prst="rect">
-            <a:avLst/>
-          </a:prstGeom>
-          <a:noFill/>
-        </p:spPr>
-        <p:txBody>
-          <a:bodyPr wrap="square" lIns="0" rIns="0" tIns="0" bIns="0">
-            <a:spAutoFit/>
-          </a:bodyPr>
-          <a:lstStyle/>
-          <a:p>
-            <a:pPr algn="l">
-              <a:lnSpc>
-                <a:spcPct val="115000"/>
-              </a:lnSpc>
-            </a:pPr>
-            <a:r>
-              <a:rPr sz="2100" b="0">
-                <a:solidFill>
-                  <a:srgbClr val="263044"/>
-                </a:solidFill>
-                <a:latin typeface="Malgun Gothic"/>
-                <a:ea typeface="Malgun Gothic"/>
-              </a:rPr>
-              <a:t>- RAG 이점 질문은 CAD 후 지시문만 남아 관련성이 0.90에서 0.00으로 내림</a:t>
-            </a:r>
-          </a:p>
-        </p:txBody>
-      </p:sp>
-      <p:sp>
-        <p:nvSpPr>
-          <p:cNvPr id="45" name="Rectangle 44"/>
-          <p:cNvSpPr/>
-          <p:nvPr/>
-        </p:nvSpPr>
-        <p:spPr>
-          <a:xfrm>
-            <a:off x="792000" y="23653350"/>
-            <a:ext cx="9612000" cy="468000"/>
-          </a:xfrm>
-          <a:prstGeom prst="rect">
-            <a:avLst/>
-          </a:prstGeom>
-          <a:solidFill>
-            <a:srgbClr val="695184"/>
-          </a:solidFill>
-          <a:ln>
-            <a:noFill/>
-          </a:ln>
-          <a:effectLst/>
-        </p:spPr>
-        <p:style>
-          <a:lnRef idx="1">
-            <a:schemeClr val="accent1"/>
-          </a:lnRef>
-          <a:fillRef idx="3">
-            <a:schemeClr val="accent1"/>
-          </a:fillRef>
-          <a:effectRef idx="2">
-            <a:schemeClr val="accent1"/>
-          </a:effectRef>
-          <a:fontRef idx="minor">
-            <a:schemeClr val="lt1"/>
-          </a:fontRef>
-        </p:style>
-        <p:txBody>
-          <a:bodyPr rtlCol="0" anchor="ctr"/>
-          <a:lstStyle/>
-          <a:p>
-            <a:pPr algn="ctr"/>
-          </a:p>
-        </p:txBody>
-      </p:sp>
-      <p:sp>
-        <p:nvSpPr>
-          <p:cNvPr id="46" name="TextBox 45"/>
-          <p:cNvSpPr txBox="1"/>
-          <p:nvPr/>
-        </p:nvSpPr>
-        <p:spPr>
-          <a:xfrm>
-            <a:off x="936000" y="23678550"/>
+            <a:off x="936000" y="24103851"/>
             <a:ext cx="9324000" cy="360000"/>
           </a:xfrm>
           <a:prstGeom prst="rect">
@@ -11873,7 +12415,7 @@
       </p:sp>
       <p:pic>
         <p:nvPicPr>
-          <p:cNvPr id="47" name="Picture 46" descr="poster_parallel.png"/>
+          <p:cNvPr id="41" name="Picture 40" descr="poster_parallel.png"/>
           <p:cNvPicPr>
             <a:picLocks noChangeAspect="1"/>
           </p:cNvPicPr>
@@ -11887,8 +12429,8 @@
         </p:blipFill>
         <p:spPr>
           <a:xfrm>
-            <a:off x="792000" y="24265350"/>
-            <a:ext cx="9612000" cy="4568215"/>
+            <a:off x="792000" y="24690651"/>
+            <a:ext cx="9612000" cy="4142946"/>
           </a:xfrm>
           <a:prstGeom prst="rect">
             <a:avLst/>
@@ -11897,13 +12439,13 @@
       </p:pic>
       <p:sp>
         <p:nvSpPr>
-          <p:cNvPr id="48" name="TextBox 47"/>
+          <p:cNvPr id="42" name="TextBox 41"/>
           <p:cNvSpPr txBox="1"/>
           <p:nvPr/>
         </p:nvSpPr>
         <p:spPr>
           <a:xfrm>
-            <a:off x="792000" y="28869565"/>
+            <a:off x="792000" y="28869597"/>
             <a:ext cx="9612000" cy="637072"/>
           </a:xfrm>
           <a:prstGeom prst="rect">
@@ -11938,13 +12480,13 @@
       </p:sp>
       <p:sp>
         <p:nvSpPr>
-          <p:cNvPr id="49" name="TextBox 48"/>
+          <p:cNvPr id="43" name="TextBox 42"/>
           <p:cNvSpPr txBox="1"/>
           <p:nvPr/>
         </p:nvSpPr>
         <p:spPr>
           <a:xfrm>
-            <a:off x="792000" y="29704637"/>
+            <a:off x="792000" y="29704669"/>
             <a:ext cx="19800000" cy="324000"/>
           </a:xfrm>
           <a:prstGeom prst="rect">

</xml_diff>

<commit_message>
Spread poster sections 06 and 07 across the full width
The parallel chart now shows the four condition panels in one full-width
row, roughly doubling their height, and the conclusions follow in two
columns at the full width. The chart note about zero and missing values
is removed from the poster figure. Thesis figures 5-3 to 5-5 render
pixel-identical.

Co-Authored-By: Claude Opus 5.5 <noreply@anthropic.com>
</commit_message>
<xml_diff>
--- a/FINALDOCS/POSTER/FINAL/M_RAG_A1_FINAL_EDITABLE.pptx
+++ b/FINALDOCS/POSTER/FINAL/M_RAG_A1_FINAL_EDITABLE.pptx
@@ -12091,8 +12091,8 @@
         </p:nvSpPr>
         <p:spPr>
           <a:xfrm>
-            <a:off x="10980000" y="24078651"/>
-            <a:ext cx="9612000" cy="468000"/>
+            <a:off x="792000" y="24078651"/>
+            <a:ext cx="19800000" cy="468000"/>
           </a:xfrm>
           <a:prstGeom prst="rect">
             <a:avLst/>
@@ -12135,8 +12135,8 @@
         </p:nvSpPr>
         <p:spPr>
           <a:xfrm>
-            <a:off x="11124000" y="24103851"/>
-            <a:ext cx="9324000" cy="360000"/>
+            <a:off x="936000" y="24103851"/>
+            <a:ext cx="19512000" cy="360000"/>
           </a:xfrm>
           <a:prstGeom prst="rect">
             <a:avLst/>
@@ -12162,21 +12162,45 @@
                 <a:latin typeface="Malgun Gothic"/>
                 <a:ea typeface="Malgun Gothic"/>
               </a:rPr>
-              <a:t>07 결론</a:t>
+              <a:t>06 방법 질문 25개의 원점수 평행좌표</a:t>
             </a:r>
           </a:p>
         </p:txBody>
       </p:sp>
+      <p:pic>
+        <p:nvPicPr>
+          <p:cNvPr id="35" name="Picture 34" descr="poster_parallel.png"/>
+          <p:cNvPicPr>
+            <a:picLocks noChangeAspect="1"/>
+          </p:cNvPicPr>
+          <p:nvPr/>
+        </p:nvPicPr>
+        <p:blipFill>
+          <a:blip r:embed="rId4"/>
+          <a:stretch>
+            <a:fillRect/>
+          </a:stretch>
+        </p:blipFill>
+        <p:spPr>
+          <a:xfrm>
+            <a:off x="792000" y="24690651"/>
+            <a:ext cx="19800000" cy="2816813"/>
+          </a:xfrm>
+          <a:prstGeom prst="rect">
+            <a:avLst/>
+          </a:prstGeom>
+        </p:spPr>
+      </p:pic>
       <p:sp>
         <p:nvSpPr>
-          <p:cNvPr id="35" name="TextBox 34"/>
+          <p:cNvPr id="36" name="TextBox 35"/>
           <p:cNvSpPr txBox="1"/>
           <p:nvPr/>
         </p:nvSpPr>
         <p:spPr>
           <a:xfrm>
-            <a:off x="10980000" y="24762651"/>
-            <a:ext cx="9612000" cy="804722"/>
+            <a:off x="792000" y="27543464"/>
+            <a:ext cx="19800000" cy="318536"/>
           </a:xfrm>
           <a:prstGeom prst="rect">
             <a:avLst/>
@@ -12195,150 +12219,28 @@
               </a:lnSpc>
             </a:pPr>
             <a:r>
-              <a:rPr sz="2400" b="0">
+              <a:rPr sz="1900" b="0">
                 <a:solidFill>
                   <a:srgbClr val="263044"/>
                 </a:solidFill>
                 <a:latin typeface="Malgun Gothic"/>
                 <a:ea typeface="Malgun Gothic"/>
               </a:rPr>
-              <a:t>- 관련성과 응답 시간이 중요하면 HyDE 하나
-  (개념과 결과 질문 포함)</a:t>
+              <a:t>- HyDE 적용 후 관련성 축의 선이 위로 모이고 관련성 0점 답변이 5개에서 1개로 줄어듦</a:t>
             </a:r>
           </a:p>
         </p:txBody>
       </p:sp>
       <p:sp>
         <p:nvSpPr>
-          <p:cNvPr id="36" name="TextBox 35"/>
-          <p:cNvSpPr txBox="1"/>
-          <p:nvPr/>
-        </p:nvSpPr>
-        <p:spPr>
-          <a:xfrm>
-            <a:off x="10980000" y="26071374"/>
-            <a:ext cx="9612000" cy="402361"/>
-          </a:xfrm>
-          <a:prstGeom prst="rect">
-            <a:avLst/>
-          </a:prstGeom>
-          <a:noFill/>
-        </p:spPr>
-        <p:txBody>
-          <a:bodyPr wrap="square" lIns="0" rIns="0" tIns="0" bIns="0">
-            <a:spAutoFit/>
-          </a:bodyPr>
-          <a:lstStyle/>
-          <a:p>
-            <a:pPr algn="l">
-              <a:lnSpc>
-                <a:spcPct val="115000"/>
-              </a:lnSpc>
-            </a:pPr>
-            <a:r>
-              <a:rPr sz="2400" b="0">
-                <a:solidFill>
-                  <a:srgbClr val="263044"/>
-                </a:solidFill>
-                <a:latin typeface="Malgun Gothic"/>
-                <a:ea typeface="Malgun Gothic"/>
-              </a:rPr>
-              <a:t>- 수치 질문은 정답 구간의 검색을 확인하고 충실도는 HyDE+CAD</a:t>
-            </a:r>
-          </a:p>
-        </p:txBody>
-      </p:sp>
-      <p:sp>
-        <p:nvSpPr>
-          <p:cNvPr id="37" name="TextBox 36"/>
-          <p:cNvSpPr txBox="1"/>
-          <p:nvPr/>
-        </p:nvSpPr>
-        <p:spPr>
-          <a:xfrm>
-            <a:off x="10980000" y="26977735"/>
-            <a:ext cx="9612000" cy="402361"/>
-          </a:xfrm>
-          <a:prstGeom prst="rect">
-            <a:avLst/>
-          </a:prstGeom>
-          <a:noFill/>
-        </p:spPr>
-        <p:txBody>
-          <a:bodyPr wrap="square" lIns="0" rIns="0" tIns="0" bIns="0">
-            <a:spAutoFit/>
-          </a:bodyPr>
-          <a:lstStyle/>
-          <a:p>
-            <a:pPr algn="l">
-              <a:lnSpc>
-                <a:spcPct val="115000"/>
-              </a:lnSpc>
-            </a:pPr>
-            <a:r>
-              <a:rPr sz="2400" b="0">
-                <a:solidFill>
-                  <a:srgbClr val="263044"/>
-                </a:solidFill>
-                <a:latin typeface="Malgun Gothic"/>
-                <a:ea typeface="Malgun Gothic"/>
-              </a:rPr>
-              <a:t>- 한국어 답변은 세 기법(방법 질문 세 지표가 SCD 단독보다 높음)</a:t>
-            </a:r>
-          </a:p>
-        </p:txBody>
-      </p:sp>
-      <p:sp>
-        <p:nvSpPr>
-          <p:cNvPr id="38" name="TextBox 37"/>
-          <p:cNvSpPr txBox="1"/>
-          <p:nvPr/>
-        </p:nvSpPr>
-        <p:spPr>
-          <a:xfrm>
-            <a:off x="10980000" y="27884096"/>
-            <a:ext cx="9612000" cy="804722"/>
-          </a:xfrm>
-          <a:prstGeom prst="rect">
-            <a:avLst/>
-          </a:prstGeom>
-          <a:noFill/>
-        </p:spPr>
-        <p:txBody>
-          <a:bodyPr wrap="square" lIns="0" rIns="0" tIns="0" bIns="0">
-            <a:spAutoFit/>
-          </a:bodyPr>
-          <a:lstStyle/>
-          <a:p>
-            <a:pPr algn="l">
-              <a:lnSpc>
-                <a:spcPct val="115000"/>
-              </a:lnSpc>
-            </a:pPr>
-            <a:r>
-              <a:rPr sz="2400" b="0">
-                <a:solidFill>
-                  <a:srgbClr val="263044"/>
-                </a:solidFill>
-                <a:latin typeface="Malgun Gothic"/>
-                <a:ea typeface="Malgun Gothic"/>
-              </a:rPr>
-              <a:t>- 조합은 HyDE 단독보다 관련성이 낮고
-  일관된 이득은 SCD의 한국어 비율</a:t>
-            </a:r>
-          </a:p>
-        </p:txBody>
-      </p:sp>
-      <p:sp>
-        <p:nvSpPr>
-          <p:cNvPr id="39" name="Rectangle 38"/>
+          <p:cNvPr id="37" name="Rectangle 36"/>
           <p:cNvSpPr/>
           <p:nvPr/>
         </p:nvSpPr>
         <p:spPr>
           <a:xfrm>
-            <a:off x="792000" y="24078651"/>
-            <a:ext cx="9612000" cy="468000"/>
+            <a:off x="792000" y="28096000"/>
+            <a:ext cx="19800000" cy="468000"/>
           </a:xfrm>
           <a:prstGeom prst="rect">
             <a:avLst/>
@@ -12375,14 +12277,14 @@
       </p:sp>
       <p:sp>
         <p:nvSpPr>
-          <p:cNvPr id="40" name="TextBox 39"/>
+          <p:cNvPr id="38" name="TextBox 37"/>
           <p:cNvSpPr txBox="1"/>
           <p:nvPr/>
         </p:nvSpPr>
         <p:spPr>
           <a:xfrm>
-            <a:off x="936000" y="24103851"/>
-            <a:ext cx="9324000" cy="360000"/>
+            <a:off x="936000" y="28121200"/>
+            <a:ext cx="19512000" cy="360000"/>
           </a:xfrm>
           <a:prstGeom prst="rect">
             <a:avLst/>
@@ -12408,45 +12310,21 @@
                 <a:latin typeface="Malgun Gothic"/>
                 <a:ea typeface="Malgun Gothic"/>
               </a:rPr>
-              <a:t>06 방법 질문 25개의 원점수 평행좌표</a:t>
+              <a:t>07 결론</a:t>
             </a:r>
           </a:p>
         </p:txBody>
       </p:sp>
-      <p:pic>
-        <p:nvPicPr>
-          <p:cNvPr id="41" name="Picture 40" descr="poster_parallel.png"/>
-          <p:cNvPicPr>
-            <a:picLocks noChangeAspect="1"/>
-          </p:cNvPicPr>
-          <p:nvPr/>
-        </p:nvPicPr>
-        <p:blipFill>
-          <a:blip r:embed="rId4"/>
-          <a:stretch>
-            <a:fillRect/>
-          </a:stretch>
-        </p:blipFill>
-        <p:spPr>
-          <a:xfrm>
-            <a:off x="792000" y="24690651"/>
-            <a:ext cx="9612000" cy="4142946"/>
-          </a:xfrm>
-          <a:prstGeom prst="rect">
-            <a:avLst/>
-          </a:prstGeom>
-        </p:spPr>
-      </p:pic>
       <p:sp>
         <p:nvSpPr>
-          <p:cNvPr id="42" name="TextBox 41"/>
+          <p:cNvPr id="39" name="TextBox 38"/>
           <p:cNvSpPr txBox="1"/>
           <p:nvPr/>
         </p:nvSpPr>
         <p:spPr>
           <a:xfrm>
-            <a:off x="792000" y="28869597"/>
-            <a:ext cx="9612000" cy="637072"/>
+            <a:off x="792000" y="28708000"/>
+            <a:ext cx="9612000" cy="368831"/>
           </a:xfrm>
           <a:prstGeom prst="rect">
             <a:avLst/>
@@ -12465,15 +12343,134 @@
               </a:lnSpc>
             </a:pPr>
             <a:r>
-              <a:rPr sz="1900" b="0">
+              <a:rPr sz="2200" b="0">
                 <a:solidFill>
                   <a:srgbClr val="263044"/>
                 </a:solidFill>
                 <a:latin typeface="Malgun Gothic"/>
                 <a:ea typeface="Malgun Gothic"/>
               </a:rPr>
-              <a:t>- HyDE 적용 후 관련성 축의 선이 위로 모이고
-  관련성 0점 답변이 5개에서 1개로 줄어듦</a:t>
+              <a:t>- 관련성과 응답 시간이 중요하면 HyDE 하나(개념과 결과 질문 포함)</a:t>
+            </a:r>
+          </a:p>
+        </p:txBody>
+      </p:sp>
+      <p:sp>
+        <p:nvSpPr>
+          <p:cNvPr id="40" name="TextBox 39"/>
+          <p:cNvSpPr txBox="1"/>
+          <p:nvPr/>
+        </p:nvSpPr>
+        <p:spPr>
+          <a:xfrm>
+            <a:off x="792000" y="29148831"/>
+            <a:ext cx="9612000" cy="368831"/>
+          </a:xfrm>
+          <a:prstGeom prst="rect">
+            <a:avLst/>
+          </a:prstGeom>
+          <a:noFill/>
+        </p:spPr>
+        <p:txBody>
+          <a:bodyPr wrap="square" lIns="0" rIns="0" tIns="0" bIns="0">
+            <a:spAutoFit/>
+          </a:bodyPr>
+          <a:lstStyle/>
+          <a:p>
+            <a:pPr algn="l">
+              <a:lnSpc>
+                <a:spcPct val="115000"/>
+              </a:lnSpc>
+            </a:pPr>
+            <a:r>
+              <a:rPr sz="2200" b="0">
+                <a:solidFill>
+                  <a:srgbClr val="263044"/>
+                </a:solidFill>
+                <a:latin typeface="Malgun Gothic"/>
+                <a:ea typeface="Malgun Gothic"/>
+              </a:rPr>
+              <a:t>- 수치 질문은 정답 구간의 검색을 확인하고 충실도는 HyDE+CAD</a:t>
+            </a:r>
+          </a:p>
+        </p:txBody>
+      </p:sp>
+      <p:sp>
+        <p:nvSpPr>
+          <p:cNvPr id="41" name="TextBox 40"/>
+          <p:cNvSpPr txBox="1"/>
+          <p:nvPr/>
+        </p:nvSpPr>
+        <p:spPr>
+          <a:xfrm>
+            <a:off x="10980000" y="28708000"/>
+            <a:ext cx="9612000" cy="368831"/>
+          </a:xfrm>
+          <a:prstGeom prst="rect">
+            <a:avLst/>
+          </a:prstGeom>
+          <a:noFill/>
+        </p:spPr>
+        <p:txBody>
+          <a:bodyPr wrap="square" lIns="0" rIns="0" tIns="0" bIns="0">
+            <a:spAutoFit/>
+          </a:bodyPr>
+          <a:lstStyle/>
+          <a:p>
+            <a:pPr algn="l">
+              <a:lnSpc>
+                <a:spcPct val="115000"/>
+              </a:lnSpc>
+            </a:pPr>
+            <a:r>
+              <a:rPr sz="2200" b="0">
+                <a:solidFill>
+                  <a:srgbClr val="263044"/>
+                </a:solidFill>
+                <a:latin typeface="Malgun Gothic"/>
+                <a:ea typeface="Malgun Gothic"/>
+              </a:rPr>
+              <a:t>- 한국어 답변은 세 기법(방법 질문 세 지표가 SCD 단독보다 높음)</a:t>
+            </a:r>
+          </a:p>
+        </p:txBody>
+      </p:sp>
+      <p:sp>
+        <p:nvSpPr>
+          <p:cNvPr id="42" name="TextBox 41"/>
+          <p:cNvSpPr txBox="1"/>
+          <p:nvPr/>
+        </p:nvSpPr>
+        <p:spPr>
+          <a:xfrm>
+            <a:off x="10980000" y="29148831"/>
+            <a:ext cx="9612000" cy="368831"/>
+          </a:xfrm>
+          <a:prstGeom prst="rect">
+            <a:avLst/>
+          </a:prstGeom>
+          <a:noFill/>
+        </p:spPr>
+        <p:txBody>
+          <a:bodyPr wrap="square" lIns="0" rIns="0" tIns="0" bIns="0">
+            <a:spAutoFit/>
+          </a:bodyPr>
+          <a:lstStyle/>
+          <a:p>
+            <a:pPr algn="l">
+              <a:lnSpc>
+                <a:spcPct val="115000"/>
+              </a:lnSpc>
+            </a:pPr>
+            <a:r>
+              <a:rPr sz="2200" b="0">
+                <a:solidFill>
+                  <a:srgbClr val="263044"/>
+                </a:solidFill>
+                <a:latin typeface="Malgun Gothic"/>
+                <a:ea typeface="Malgun Gothic"/>
+              </a:rPr>
+              <a:t>- 조합은 HyDE 단독보다 관련성이 낮고 일관된 이득은 SCD의 한국어 비율</a:t>
             </a:r>
           </a:p>
         </p:txBody>
@@ -12486,7 +12483,7 @@
         </p:nvSpPr>
         <p:spPr>
           <a:xfrm>
-            <a:off x="792000" y="29704669"/>
+            <a:off x="792000" y="29661662"/>
             <a:ext cx="19800000" cy="324000"/>
           </a:xfrm>
           <a:prstGeom prst="rect">

</xml_diff>